<commit_message>
Normalize bridge deck PowerPoint metadata
</commit_message>
<xml_diff>
--- a/bridge/docs/dev/spec.pptx
+++ b/bridge/docs/dev/spec.pptx
@@ -1741,7 +1741,7 @@
       </p:grpSpPr>
       <p:sp>
         <p:nvSpPr>
-          <p:cNvPr id="1" name="Title 1">
+          <p:cNvPr id="2" name="Title 1">
             <a:extLst xmlns:a="http://schemas.openxmlformats.org/drawingml/2006/main">
               <a:ext uri="{FF2B5EF4-FFF2-40B4-BE49-F238E27FC236}">
                 <a16:creationId xmlns:a16="http://schemas.microsoft.com/office/drawing/2014/main" id="{5A44F919-0DA3-4C7E-AFB8-B2C6476A1BD6}"/>
@@ -1772,7 +1772,7 @@
       </p:sp>
       <p:sp>
         <p:nvSpPr>
-          <p:cNvPr id="2" name="Subtitle 2">
+          <p:cNvPr id="3" name="Subtitle 2">
             <a:extLst xmlns:a="http://schemas.openxmlformats.org/drawingml/2006/main">
               <a:ext uri="{FF2B5EF4-FFF2-40B4-BE49-F238E27FC236}">
                 <a16:creationId xmlns:a16="http://schemas.microsoft.com/office/drawing/2014/main" id="{C1B176C2-7756-43FD-A16C-A63422F031B3}"/>
@@ -1835,7 +1835,7 @@
       </p:sp>
       <p:sp>
         <p:nvSpPr>
-          <p:cNvPr id="3" name="Date Placeholder 3">
+          <p:cNvPr id="4" name="Date Placeholder 3">
             <a:extLst xmlns:a="http://schemas.openxmlformats.org/drawingml/2006/main">
               <a:ext uri="{FF2B5EF4-FFF2-40B4-BE49-F238E27FC236}">
                 <a16:creationId xmlns:a16="http://schemas.microsoft.com/office/drawing/2014/main" id="{4D27C514-A63F-43DA-BE24-F9FF89CB75C9}"/>
@@ -1856,7 +1856,7 @@
       </p:sp>
       <p:sp>
         <p:nvSpPr>
-          <p:cNvPr id="4" name="Footer Placeholder 4">
+          <p:cNvPr id="5" name="Footer Placeholder 4">
             <a:extLst xmlns:a="http://schemas.openxmlformats.org/drawingml/2006/main">
               <a:ext uri="{FF2B5EF4-FFF2-40B4-BE49-F238E27FC236}">
                 <a16:creationId xmlns:a16="http://schemas.microsoft.com/office/drawing/2014/main" id="{6BB22E9F-03BC-4DEB-A389-00C9A4D8A8A2}"/>
@@ -1877,7 +1877,7 @@
       </p:sp>
       <p:sp>
         <p:nvSpPr>
-          <p:cNvPr id="5" name="Slide Number Placeholder 5">
+          <p:cNvPr id="6" name="Slide Number Placeholder 5">
             <a:extLst xmlns:a="http://schemas.openxmlformats.org/drawingml/2006/main">
               <a:ext uri="{FF2B5EF4-FFF2-40B4-BE49-F238E27FC236}">
                 <a16:creationId xmlns:a16="http://schemas.microsoft.com/office/drawing/2014/main" id="{70659316-B4BB-42AA-9EDF-4B27092320CB}"/>
@@ -1920,7 +1920,7 @@
       </p:grpSpPr>
       <p:sp>
         <p:nvSpPr>
-          <p:cNvPr id="1" name="Slide Number Placeholder 5">
+          <p:cNvPr id="2" name="Slide Number Placeholder 5">
             <a:extLst xmlns:a="http://schemas.openxmlformats.org/drawingml/2006/main">
               <a:ext uri="{FF2B5EF4-FFF2-40B4-BE49-F238E27FC236}">
                 <a16:creationId xmlns:a16="http://schemas.microsoft.com/office/drawing/2014/main" id="{FDF153FB-6104-4793-A817-7214F6D99D48}"/>
@@ -2258,7 +2258,7 @@
       </p:grpSpPr>
       <p:sp>
         <p:nvSpPr>
-          <p:cNvPr id="1" name="Slide Number Placeholder 5">
+          <p:cNvPr id="2" name="Slide Number Placeholder 5">
             <a:extLst xmlns:a="http://schemas.openxmlformats.org/drawingml/2006/main">
               <a:ext uri="{FF2B5EF4-FFF2-40B4-BE49-F238E27FC236}">
                 <a16:creationId xmlns:a16="http://schemas.microsoft.com/office/drawing/2014/main" id="{70659316-B4BB-42AA-9EDF-4B27092320CB}"/>
@@ -2290,7 +2290,7 @@
       </p:sp>
       <p:sp>
         <p:nvSpPr>
-          <p:cNvPr id="2" name="">
+          <p:cNvPr id="3" name="">
             <a:extLst xmlns:a="http://schemas.openxmlformats.org/drawingml/2006/main">
               <a:ext uri="{FF2B5EF4-FFF2-40B4-BE49-F238E27FC236}">
                 <a16:creationId xmlns:a16="http://schemas.microsoft.com/office/drawing/2014/main" id="{B69A51EC-2871-4CB6-9B3C-9B17C0ABA553}"/>
@@ -2322,7 +2322,7 @@
       </p:sp>
       <p:sp>
         <p:nvSpPr>
-          <p:cNvPr id="3" name="">
+          <p:cNvPr id="4" name="">
             <a:extLst xmlns:a="http://schemas.openxmlformats.org/drawingml/2006/main">
               <a:ext uri="{FF2B5EF4-FFF2-40B4-BE49-F238E27FC236}">
                 <a16:creationId xmlns:a16="http://schemas.microsoft.com/office/drawing/2014/main" id="{ECA02D13-783A-4172-AFB3-51D692CD3F32}"/>
@@ -2354,7 +2354,7 @@
       </p:sp>
       <p:sp>
         <p:nvSpPr>
-          <p:cNvPr id="4" name="">
+          <p:cNvPr id="5" name="">
             <a:extLst xmlns:a="http://schemas.openxmlformats.org/drawingml/2006/main">
               <a:ext uri="{FF2B5EF4-FFF2-40B4-BE49-F238E27FC236}">
                 <a16:creationId xmlns:a16="http://schemas.microsoft.com/office/drawing/2014/main" id="{A0256D18-801F-4F59-9240-3E811D4FBECD}"/>
@@ -2386,7 +2386,7 @@
       </p:sp>
       <p:sp>
         <p:nvSpPr>
-          <p:cNvPr id="5" name="">
+          <p:cNvPr id="6" name="">
             <a:extLst xmlns:a="http://schemas.openxmlformats.org/drawingml/2006/main">
               <a:ext uri="{FF2B5EF4-FFF2-40B4-BE49-F238E27FC236}">
                 <a16:creationId xmlns:a16="http://schemas.microsoft.com/office/drawing/2014/main" id="{F61EDE21-B325-46E9-A2CA-5491CF432B36}"/>
@@ -2418,7 +2418,7 @@
       </p:sp>
       <p:sp>
         <p:nvSpPr>
-          <p:cNvPr id="6" name="">
+          <p:cNvPr id="7" name="">
             <a:extLst xmlns:a="http://schemas.openxmlformats.org/drawingml/2006/main">
               <a:ext uri="{FF2B5EF4-FFF2-40B4-BE49-F238E27FC236}">
                 <a16:creationId xmlns:a16="http://schemas.microsoft.com/office/drawing/2014/main" id="{38320591-9722-4247-A170-8158A224FC9A}"/>
@@ -2450,7 +2450,7 @@
       </p:sp>
       <p:sp>
         <p:nvSpPr>
-          <p:cNvPr id="7" name="">
+          <p:cNvPr id="8" name="">
             <a:extLst xmlns:a="http://schemas.openxmlformats.org/drawingml/2006/main">
               <a:ext uri="{FF2B5EF4-FFF2-40B4-BE49-F238E27FC236}">
                 <a16:creationId xmlns:a16="http://schemas.microsoft.com/office/drawing/2014/main" id="{9368C19E-E283-4EA6-88D3-3AE7D3709C8D}"/>
@@ -2482,7 +2482,7 @@
       </p:sp>
       <p:sp>
         <p:nvSpPr>
-          <p:cNvPr id="8" name="">
+          <p:cNvPr id="9" name="">
             <a:extLst xmlns:a="http://schemas.openxmlformats.org/drawingml/2006/main">
               <a:ext uri="{FF2B5EF4-FFF2-40B4-BE49-F238E27FC236}">
                 <a16:creationId xmlns:a16="http://schemas.microsoft.com/office/drawing/2014/main" id="{5985A839-D8B5-4094-9951-31D268089FC4}"/>
@@ -2514,7 +2514,7 @@
       </p:sp>
       <p:sp>
         <p:nvSpPr>
-          <p:cNvPr id="9" name="">
+          <p:cNvPr id="10" name="">
             <a:extLst xmlns:a="http://schemas.openxmlformats.org/drawingml/2006/main">
               <a:ext uri="{FF2B5EF4-FFF2-40B4-BE49-F238E27FC236}">
                 <a16:creationId xmlns:a16="http://schemas.microsoft.com/office/drawing/2014/main" id="{1BFD377C-5D5C-483B-A768-2B95261E0E05}"/>
@@ -2560,7 +2560,7 @@
       </p:sp>
       <p:sp>
         <p:nvSpPr>
-          <p:cNvPr id="10" name="">
+          <p:cNvPr id="11" name="">
             <a:extLst xmlns:a="http://schemas.openxmlformats.org/drawingml/2006/main">
               <a:ext uri="{FF2B5EF4-FFF2-40B4-BE49-F238E27FC236}">
                 <a16:creationId xmlns:a16="http://schemas.microsoft.com/office/drawing/2014/main" id="{32B939C4-73ED-412E-A768-21356591C093}"/>
@@ -2606,7 +2606,7 @@
       </p:sp>
       <p:sp>
         <p:nvSpPr>
-          <p:cNvPr id="11" name="">
+          <p:cNvPr id="12" name="">
             <a:extLst xmlns:a="http://schemas.openxmlformats.org/drawingml/2006/main">
               <a:ext uri="{FF2B5EF4-FFF2-40B4-BE49-F238E27FC236}">
                 <a16:creationId xmlns:a16="http://schemas.microsoft.com/office/drawing/2014/main" id="{208DBC58-4E34-49B3-8ADF-18FC71B20C32}"/>
@@ -2653,7 +2653,7 @@
       </p:sp>
       <p:sp>
         <p:nvSpPr>
-          <p:cNvPr id="12" name="">
+          <p:cNvPr id="13" name="">
             <a:extLst xmlns:a="http://schemas.openxmlformats.org/drawingml/2006/main">
               <a:ext uri="{FF2B5EF4-FFF2-40B4-BE49-F238E27FC236}">
                 <a16:creationId xmlns:a16="http://schemas.microsoft.com/office/drawing/2014/main" id="{E5B87C48-7BE6-4174-A624-17D6C0A01B51}"/>
@@ -2700,7 +2700,7 @@
       </p:sp>
       <p:sp>
         <p:nvSpPr>
-          <p:cNvPr id="13" name="">
+          <p:cNvPr id="14" name="">
             <a:extLst xmlns:a="http://schemas.openxmlformats.org/drawingml/2006/main">
               <a:ext uri="{FF2B5EF4-FFF2-40B4-BE49-F238E27FC236}">
                 <a16:creationId xmlns:a16="http://schemas.microsoft.com/office/drawing/2014/main" id="{22D03480-E7B3-40A1-B7A2-A81D6CEF6758}"/>
@@ -2747,7 +2747,7 @@
       </p:sp>
       <p:sp>
         <p:nvSpPr>
-          <p:cNvPr id="14" name="">
+          <p:cNvPr id="15" name="">
             <a:extLst xmlns:a="http://schemas.openxmlformats.org/drawingml/2006/main">
               <a:ext uri="{FF2B5EF4-FFF2-40B4-BE49-F238E27FC236}">
                 <a16:creationId xmlns:a16="http://schemas.microsoft.com/office/drawing/2014/main" id="{A42120B9-91BF-4F4C-BA71-298FFCE882C7}"/>
@@ -2791,7 +2791,7 @@
       </p:sp>
       <p:sp>
         <p:nvSpPr>
-          <p:cNvPr id="15" name="">
+          <p:cNvPr id="16" name="">
             <a:extLst xmlns:a="http://schemas.openxmlformats.org/drawingml/2006/main">
               <a:ext uri="{FF2B5EF4-FFF2-40B4-BE49-F238E27FC236}">
                 <a16:creationId xmlns:a16="http://schemas.microsoft.com/office/drawing/2014/main" id="{25B7FEAE-7F3F-472F-973A-7DB3C46ED052}"/>
@@ -2836,7 +2836,7 @@
       </p:sp>
       <p:sp>
         <p:nvSpPr>
-          <p:cNvPr id="16" name="">
+          <p:cNvPr id="17" name="">
             <a:extLst xmlns:a="http://schemas.openxmlformats.org/drawingml/2006/main">
               <a:ext uri="{FF2B5EF4-FFF2-40B4-BE49-F238E27FC236}">
                 <a16:creationId xmlns:a16="http://schemas.microsoft.com/office/drawing/2014/main" id="{460A631D-D813-4822-B381-68F98FC174F8}"/>
@@ -2881,7 +2881,7 @@
       </p:sp>
       <p:sp>
         <p:nvSpPr>
-          <p:cNvPr id="17" name="">
+          <p:cNvPr id="18" name="">
             <a:extLst xmlns:a="http://schemas.openxmlformats.org/drawingml/2006/main">
               <a:ext uri="{FF2B5EF4-FFF2-40B4-BE49-F238E27FC236}">
                 <a16:creationId xmlns:a16="http://schemas.microsoft.com/office/drawing/2014/main" id="{1CC9343D-F413-416F-8A64-63CF62A7922D}"/>
@@ -2948,7 +2948,7 @@
       </p:grpSpPr>
       <p:sp>
         <p:nvSpPr>
-          <p:cNvPr id="1" name="Slide Number Placeholder 5">
+          <p:cNvPr id="2" name="Slide Number Placeholder 5">
             <a:extLst xmlns:a="http://schemas.openxmlformats.org/drawingml/2006/main">
               <a:ext uri="{FF2B5EF4-FFF2-40B4-BE49-F238E27FC236}">
                 <a16:creationId xmlns:a16="http://schemas.microsoft.com/office/drawing/2014/main" id="{70659316-B4BB-42AA-9EDF-4B27092320CB}"/>
@@ -2980,7 +2980,7 @@
       </p:sp>
       <p:sp>
         <p:nvSpPr>
-          <p:cNvPr id="2" name="">
+          <p:cNvPr id="3" name="">
             <a:extLst xmlns:a="http://schemas.openxmlformats.org/drawingml/2006/main">
               <a:ext uri="{FF2B5EF4-FFF2-40B4-BE49-F238E27FC236}">
                 <a16:creationId xmlns:a16="http://schemas.microsoft.com/office/drawing/2014/main" id="{2964F39B-C934-4922-A905-E4562E38F97E}"/>
@@ -3012,7 +3012,7 @@
       </p:sp>
       <p:sp>
         <p:nvSpPr>
-          <p:cNvPr id="3" name="">
+          <p:cNvPr id="4" name="">
             <a:extLst xmlns:a="http://schemas.openxmlformats.org/drawingml/2006/main">
               <a:ext uri="{FF2B5EF4-FFF2-40B4-BE49-F238E27FC236}">
                 <a16:creationId xmlns:a16="http://schemas.microsoft.com/office/drawing/2014/main" id="{D808787B-9866-4AF1-BF9C-F6F6E018C25F}"/>
@@ -3044,7 +3044,7 @@
       </p:sp>
       <p:sp>
         <p:nvSpPr>
-          <p:cNvPr id="4" name="">
+          <p:cNvPr id="5" name="">
             <a:extLst xmlns:a="http://schemas.openxmlformats.org/drawingml/2006/main">
               <a:ext uri="{FF2B5EF4-FFF2-40B4-BE49-F238E27FC236}">
                 <a16:creationId xmlns:a16="http://schemas.microsoft.com/office/drawing/2014/main" id="{80ADCF05-D80C-44EF-BC4F-6EBE8CEAFBAC}"/>
@@ -3088,7 +3088,7 @@
       </p:sp>
       <p:sp>
         <p:nvSpPr>
-          <p:cNvPr id="5" name="">
+          <p:cNvPr id="6" name="">
             <a:extLst xmlns:a="http://schemas.openxmlformats.org/drawingml/2006/main">
               <a:ext uri="{FF2B5EF4-FFF2-40B4-BE49-F238E27FC236}">
                 <a16:creationId xmlns:a16="http://schemas.microsoft.com/office/drawing/2014/main" id="{4A3BC836-E1DC-4C5E-AF9B-6184485C377C}"/>
@@ -3134,7 +3134,7 @@
       </p:sp>
       <p:sp>
         <p:nvSpPr>
-          <p:cNvPr id="6" name="">
+          <p:cNvPr id="7" name="">
             <a:extLst xmlns:a="http://schemas.openxmlformats.org/drawingml/2006/main">
               <a:ext uri="{FF2B5EF4-FFF2-40B4-BE49-F238E27FC236}">
                 <a16:creationId xmlns:a16="http://schemas.microsoft.com/office/drawing/2014/main" id="{58AD92BD-E643-4647-A7FB-513AF7D2AD3C}"/>
@@ -3180,7 +3180,7 @@
       </p:sp>
       <p:sp>
         <p:nvSpPr>
-          <p:cNvPr id="7" name="">
+          <p:cNvPr id="8" name="">
             <a:extLst xmlns:a="http://schemas.openxmlformats.org/drawingml/2006/main">
               <a:ext uri="{FF2B5EF4-FFF2-40B4-BE49-F238E27FC236}">
                 <a16:creationId xmlns:a16="http://schemas.microsoft.com/office/drawing/2014/main" id="{8B43D4F4-3E77-4008-8247-6296CAD3C8DC}"/>
@@ -3212,7 +3212,7 @@
       </p:sp>
       <p:sp>
         <p:nvSpPr>
-          <p:cNvPr id="8" name="">
+          <p:cNvPr id="9" name="">
             <a:extLst xmlns:a="http://schemas.openxmlformats.org/drawingml/2006/main">
               <a:ext uri="{FF2B5EF4-FFF2-40B4-BE49-F238E27FC236}">
                 <a16:creationId xmlns:a16="http://schemas.microsoft.com/office/drawing/2014/main" id="{EFCB419E-C54B-4056-8962-AE41A9A6D33D}"/>
@@ -3256,7 +3256,7 @@
       </p:sp>
       <p:sp>
         <p:nvSpPr>
-          <p:cNvPr id="9" name="">
+          <p:cNvPr id="10" name="">
             <a:extLst xmlns:a="http://schemas.openxmlformats.org/drawingml/2006/main">
               <a:ext uri="{FF2B5EF4-FFF2-40B4-BE49-F238E27FC236}">
                 <a16:creationId xmlns:a16="http://schemas.microsoft.com/office/drawing/2014/main" id="{B294AD79-DCD0-4DC4-9327-E8F661B98907}"/>
@@ -3301,7 +3301,7 @@
       </p:sp>
       <p:sp>
         <p:nvSpPr>
-          <p:cNvPr id="10" name="">
+          <p:cNvPr id="11" name="">
             <a:extLst xmlns:a="http://schemas.openxmlformats.org/drawingml/2006/main">
               <a:ext uri="{FF2B5EF4-FFF2-40B4-BE49-F238E27FC236}">
                 <a16:creationId xmlns:a16="http://schemas.microsoft.com/office/drawing/2014/main" id="{3F880295-8E71-4FEA-ADFB-DE5BB78511D5}"/>
@@ -3348,7 +3348,7 @@
       </p:sp>
       <p:sp>
         <p:nvSpPr>
-          <p:cNvPr id="11" name="">
+          <p:cNvPr id="12" name="">
             <a:extLst xmlns:a="http://schemas.openxmlformats.org/drawingml/2006/main">
               <a:ext uri="{FF2B5EF4-FFF2-40B4-BE49-F238E27FC236}">
                 <a16:creationId xmlns:a16="http://schemas.microsoft.com/office/drawing/2014/main" id="{F9C5762B-B8DB-4993-A843-CF6FD50859D4}"/>
@@ -3380,7 +3380,7 @@
       </p:sp>
       <p:sp>
         <p:nvSpPr>
-          <p:cNvPr id="12" name="">
+          <p:cNvPr id="13" name="">
             <a:extLst xmlns:a="http://schemas.openxmlformats.org/drawingml/2006/main">
               <a:ext uri="{FF2B5EF4-FFF2-40B4-BE49-F238E27FC236}">
                 <a16:creationId xmlns:a16="http://schemas.microsoft.com/office/drawing/2014/main" id="{FB98EECF-76DC-4FB6-87FD-A263D584A715}"/>
@@ -3427,7 +3427,7 @@
       </p:sp>
       <p:sp>
         <p:nvSpPr>
-          <p:cNvPr id="13" name="">
+          <p:cNvPr id="14" name="">
             <a:extLst xmlns:a="http://schemas.openxmlformats.org/drawingml/2006/main">
               <a:ext uri="{FF2B5EF4-FFF2-40B4-BE49-F238E27FC236}">
                 <a16:creationId xmlns:a16="http://schemas.microsoft.com/office/drawing/2014/main" id="{C1FE060F-09B9-46E4-8E13-735B01B055EA}"/>
@@ -3459,7 +3459,7 @@
       </p:sp>
       <p:sp>
         <p:nvSpPr>
-          <p:cNvPr id="14" name="">
+          <p:cNvPr id="15" name="">
             <a:extLst xmlns:a="http://schemas.openxmlformats.org/drawingml/2006/main">
               <a:ext uri="{FF2B5EF4-FFF2-40B4-BE49-F238E27FC236}">
                 <a16:creationId xmlns:a16="http://schemas.microsoft.com/office/drawing/2014/main" id="{A04F56A5-FC1B-4F86-ACF3-8B01E5588D4C}"/>
@@ -3506,7 +3506,7 @@
       </p:sp>
       <p:sp>
         <p:nvSpPr>
-          <p:cNvPr id="15" name="">
+          <p:cNvPr id="16" name="">
             <a:extLst xmlns:a="http://schemas.openxmlformats.org/drawingml/2006/main">
               <a:ext uri="{FF2B5EF4-FFF2-40B4-BE49-F238E27FC236}">
                 <a16:creationId xmlns:a16="http://schemas.microsoft.com/office/drawing/2014/main" id="{C40CF443-8D7C-4759-A71B-F2A124488A46}"/>
@@ -3538,7 +3538,7 @@
       </p:sp>
       <p:sp>
         <p:nvSpPr>
-          <p:cNvPr id="16" name="">
+          <p:cNvPr id="17" name="">
             <a:extLst xmlns:a="http://schemas.openxmlformats.org/drawingml/2006/main">
               <a:ext uri="{FF2B5EF4-FFF2-40B4-BE49-F238E27FC236}">
                 <a16:creationId xmlns:a16="http://schemas.microsoft.com/office/drawing/2014/main" id="{580A00EB-E304-4DE3-BDA7-FCE82BD98D34}"/>
@@ -3585,7 +3585,7 @@
       </p:sp>
       <p:sp>
         <p:nvSpPr>
-          <p:cNvPr id="17" name="">
+          <p:cNvPr id="18" name="">
             <a:extLst xmlns:a="http://schemas.openxmlformats.org/drawingml/2006/main">
               <a:ext uri="{FF2B5EF4-FFF2-40B4-BE49-F238E27FC236}">
                 <a16:creationId xmlns:a16="http://schemas.microsoft.com/office/drawing/2014/main" id="{E5597619-343F-48B5-9E86-10DA0A76617E}"/>
@@ -3617,7 +3617,7 @@
       </p:sp>
       <p:sp>
         <p:nvSpPr>
-          <p:cNvPr id="18" name="">
+          <p:cNvPr id="19" name="">
             <a:extLst xmlns:a="http://schemas.openxmlformats.org/drawingml/2006/main">
               <a:ext uri="{FF2B5EF4-FFF2-40B4-BE49-F238E27FC236}">
                 <a16:creationId xmlns:a16="http://schemas.microsoft.com/office/drawing/2014/main" id="{701D4D29-F470-4475-9876-E73D0CBF5621}"/>
@@ -3664,7 +3664,7 @@
       </p:sp>
       <p:sp>
         <p:nvSpPr>
-          <p:cNvPr id="19" name="">
+          <p:cNvPr id="20" name="">
             <a:extLst xmlns:a="http://schemas.openxmlformats.org/drawingml/2006/main">
               <a:ext uri="{FF2B5EF4-FFF2-40B4-BE49-F238E27FC236}">
                 <a16:creationId xmlns:a16="http://schemas.microsoft.com/office/drawing/2014/main" id="{45BEB5E4-8C73-4B45-87D7-1434B566FB3F}"/>
@@ -3696,7 +3696,7 @@
       </p:sp>
       <p:sp>
         <p:nvSpPr>
-          <p:cNvPr id="20" name="">
+          <p:cNvPr id="21" name="">
             <a:extLst xmlns:a="http://schemas.openxmlformats.org/drawingml/2006/main">
               <a:ext uri="{FF2B5EF4-FFF2-40B4-BE49-F238E27FC236}">
                 <a16:creationId xmlns:a16="http://schemas.microsoft.com/office/drawing/2014/main" id="{B7EBC064-8945-46BF-BC94-4F387096779D}"/>
@@ -3741,7 +3741,7 @@
       </p:sp>
       <p:sp>
         <p:nvSpPr>
-          <p:cNvPr id="21" name="">
+          <p:cNvPr id="22" name="">
             <a:extLst xmlns:a="http://schemas.openxmlformats.org/drawingml/2006/main">
               <a:ext uri="{FF2B5EF4-FFF2-40B4-BE49-F238E27FC236}">
                 <a16:creationId xmlns:a16="http://schemas.microsoft.com/office/drawing/2014/main" id="{67B8BCAA-8CC4-4624-881F-C8BF4166A6E6}"/>
@@ -3788,7 +3788,7 @@
       </p:sp>
       <p:sp>
         <p:nvSpPr>
-          <p:cNvPr id="22" name="">
+          <p:cNvPr id="23" name="">
             <a:extLst xmlns:a="http://schemas.openxmlformats.org/drawingml/2006/main">
               <a:ext uri="{FF2B5EF4-FFF2-40B4-BE49-F238E27FC236}">
                 <a16:creationId xmlns:a16="http://schemas.microsoft.com/office/drawing/2014/main" id="{0CA1613B-A56A-4DF5-8385-F94B926A9D0F}"/>
@@ -3833,7 +3833,7 @@
       </p:sp>
       <p:sp>
         <p:nvSpPr>
-          <p:cNvPr id="23" name="">
+          <p:cNvPr id="24" name="">
             <a:extLst xmlns:a="http://schemas.openxmlformats.org/drawingml/2006/main">
               <a:ext uri="{FF2B5EF4-FFF2-40B4-BE49-F238E27FC236}">
                 <a16:creationId xmlns:a16="http://schemas.microsoft.com/office/drawing/2014/main" id="{0FED54B0-DE99-4C5B-9A6C-CA5D35ABEC6D}"/>
@@ -3880,7 +3880,7 @@
       </p:sp>
       <p:sp>
         <p:nvSpPr>
-          <p:cNvPr id="24" name="">
+          <p:cNvPr id="25" name="">
             <a:extLst xmlns:a="http://schemas.openxmlformats.org/drawingml/2006/main">
               <a:ext uri="{FF2B5EF4-FFF2-40B4-BE49-F238E27FC236}">
                 <a16:creationId xmlns:a16="http://schemas.microsoft.com/office/drawing/2014/main" id="{DE56D32B-62EC-4C84-8939-C4623137B9BE}"/>
@@ -3912,7 +3912,7 @@
       </p:sp>
       <p:sp>
         <p:nvSpPr>
-          <p:cNvPr id="25" name="">
+          <p:cNvPr id="26" name="">
             <a:extLst xmlns:a="http://schemas.openxmlformats.org/drawingml/2006/main">
               <a:ext uri="{FF2B5EF4-FFF2-40B4-BE49-F238E27FC236}">
                 <a16:creationId xmlns:a16="http://schemas.microsoft.com/office/drawing/2014/main" id="{DC59394E-1FA8-4120-8A10-4E1B4E59C4A4}"/>
@@ -3957,7 +3957,7 @@
       </p:sp>
       <p:sp>
         <p:nvSpPr>
-          <p:cNvPr id="26" name="">
+          <p:cNvPr id="27" name="">
             <a:extLst xmlns:a="http://schemas.openxmlformats.org/drawingml/2006/main">
               <a:ext uri="{FF2B5EF4-FFF2-40B4-BE49-F238E27FC236}">
                 <a16:creationId xmlns:a16="http://schemas.microsoft.com/office/drawing/2014/main" id="{9E1A6B05-37C8-4186-944A-6B05FF55A0D3}"/>
@@ -4004,7 +4004,7 @@
       </p:sp>
       <p:sp>
         <p:nvSpPr>
-          <p:cNvPr id="27" name="">
+          <p:cNvPr id="28" name="">
             <a:extLst xmlns:a="http://schemas.openxmlformats.org/drawingml/2006/main">
               <a:ext uri="{FF2B5EF4-FFF2-40B4-BE49-F238E27FC236}">
                 <a16:creationId xmlns:a16="http://schemas.microsoft.com/office/drawing/2014/main" id="{31091260-C7F5-42AF-9BDF-DDA1CE250D53}"/>
@@ -4058,7 +4058,7 @@
       </p:grpSpPr>
       <p:sp>
         <p:nvSpPr>
-          <p:cNvPr id="1" name="Slide Number Placeholder 5">
+          <p:cNvPr id="2" name="Slide Number Placeholder 5">
             <a:extLst xmlns:a="http://schemas.openxmlformats.org/drawingml/2006/main">
               <a:ext uri="{FF2B5EF4-FFF2-40B4-BE49-F238E27FC236}">
                 <a16:creationId xmlns:a16="http://schemas.microsoft.com/office/drawing/2014/main" id="{70659316-B4BB-42AA-9EDF-4B27092320CB}"/>
@@ -4090,7 +4090,7 @@
       </p:sp>
       <p:sp>
         <p:nvSpPr>
-          <p:cNvPr id="2" name="">
+          <p:cNvPr id="3" name="">
             <a:extLst xmlns:a="http://schemas.openxmlformats.org/drawingml/2006/main">
               <a:ext uri="{FF2B5EF4-FFF2-40B4-BE49-F238E27FC236}">
                 <a16:creationId xmlns:a16="http://schemas.microsoft.com/office/drawing/2014/main" id="{C7347597-E704-40E4-85A3-C0EEED3E8E6E}"/>
@@ -4122,7 +4122,7 @@
       </p:sp>
       <p:sp>
         <p:nvSpPr>
-          <p:cNvPr id="3" name="">
+          <p:cNvPr id="4" name="">
             <a:extLst xmlns:a="http://schemas.openxmlformats.org/drawingml/2006/main">
               <a:ext uri="{FF2B5EF4-FFF2-40B4-BE49-F238E27FC236}">
                 <a16:creationId xmlns:a16="http://schemas.microsoft.com/office/drawing/2014/main" id="{B6538743-05C7-4C2B-BCC7-3A82D9AF8E04}"/>
@@ -4154,7 +4154,7 @@
       </p:sp>
       <p:sp>
         <p:nvSpPr>
-          <p:cNvPr id="4" name="">
+          <p:cNvPr id="5" name="">
             <a:extLst xmlns:a="http://schemas.openxmlformats.org/drawingml/2006/main">
               <a:ext uri="{FF2B5EF4-FFF2-40B4-BE49-F238E27FC236}">
                 <a16:creationId xmlns:a16="http://schemas.microsoft.com/office/drawing/2014/main" id="{FA303344-430E-4D75-885A-9ACEF49196F2}"/>
@@ -4198,7 +4198,7 @@
       </p:sp>
       <p:sp>
         <p:nvSpPr>
-          <p:cNvPr id="5" name="">
+          <p:cNvPr id="6" name="">
             <a:extLst xmlns:a="http://schemas.openxmlformats.org/drawingml/2006/main">
               <a:ext uri="{FF2B5EF4-FFF2-40B4-BE49-F238E27FC236}">
                 <a16:creationId xmlns:a16="http://schemas.microsoft.com/office/drawing/2014/main" id="{82B678A4-CC57-432D-8E31-FE9E0B6EA7F4}"/>
@@ -4244,7 +4244,7 @@
       </p:sp>
       <p:sp>
         <p:nvSpPr>
-          <p:cNvPr id="6" name="">
+          <p:cNvPr id="7" name="">
             <a:extLst xmlns:a="http://schemas.openxmlformats.org/drawingml/2006/main">
               <a:ext uri="{FF2B5EF4-FFF2-40B4-BE49-F238E27FC236}">
                 <a16:creationId xmlns:a16="http://schemas.microsoft.com/office/drawing/2014/main" id="{28D47209-DA96-4506-B6EB-E044553D997B}"/>
@@ -4290,7 +4290,7 @@
       </p:sp>
       <p:sp>
         <p:nvSpPr>
-          <p:cNvPr id="7" name="">
+          <p:cNvPr id="8" name="">
             <a:extLst xmlns:a="http://schemas.openxmlformats.org/drawingml/2006/main">
               <a:ext uri="{FF2B5EF4-FFF2-40B4-BE49-F238E27FC236}">
                 <a16:creationId xmlns:a16="http://schemas.microsoft.com/office/drawing/2014/main" id="{01ECEED4-FDF9-4DE6-9AB4-C1FF6AED38A9}"/>
@@ -4322,7 +4322,7 @@
       </p:sp>
       <p:sp>
         <p:nvSpPr>
-          <p:cNvPr id="8" name="">
+          <p:cNvPr id="9" name="">
             <a:extLst xmlns:a="http://schemas.openxmlformats.org/drawingml/2006/main">
               <a:ext uri="{FF2B5EF4-FFF2-40B4-BE49-F238E27FC236}">
                 <a16:creationId xmlns:a16="http://schemas.microsoft.com/office/drawing/2014/main" id="{7B2A47B3-8F8D-4143-9562-7E292EEFFBC3}"/>
@@ -4366,7 +4366,7 @@
       </p:sp>
       <p:sp>
         <p:nvSpPr>
-          <p:cNvPr id="9" name="">
+          <p:cNvPr id="10" name="">
             <a:extLst xmlns:a="http://schemas.openxmlformats.org/drawingml/2006/main">
               <a:ext uri="{FF2B5EF4-FFF2-40B4-BE49-F238E27FC236}">
                 <a16:creationId xmlns:a16="http://schemas.microsoft.com/office/drawing/2014/main" id="{79F76C93-0DB0-44F7-800C-F5493FB7E758}"/>
@@ -4411,7 +4411,7 @@
       </p:sp>
       <p:sp>
         <p:nvSpPr>
-          <p:cNvPr id="10" name="">
+          <p:cNvPr id="11" name="">
             <a:extLst xmlns:a="http://schemas.openxmlformats.org/drawingml/2006/main">
               <a:ext uri="{FF2B5EF4-FFF2-40B4-BE49-F238E27FC236}">
                 <a16:creationId xmlns:a16="http://schemas.microsoft.com/office/drawing/2014/main" id="{D05624B3-FD0C-43E1-A793-61BFC1D3D03F}"/>
@@ -4458,7 +4458,7 @@
       </p:sp>
       <p:sp>
         <p:nvSpPr>
-          <p:cNvPr id="11" name="">
+          <p:cNvPr id="12" name="">
             <a:extLst xmlns:a="http://schemas.openxmlformats.org/drawingml/2006/main">
               <a:ext uri="{FF2B5EF4-FFF2-40B4-BE49-F238E27FC236}">
                 <a16:creationId xmlns:a16="http://schemas.microsoft.com/office/drawing/2014/main" id="{1B55AD0D-9CB0-49DF-AC2E-8132540201F9}"/>
@@ -4506,7 +4506,7 @@
       </p:sp>
       <p:sp>
         <p:nvSpPr>
-          <p:cNvPr id="12" name="">
+          <p:cNvPr id="13" name="">
             <a:extLst xmlns:a="http://schemas.openxmlformats.org/drawingml/2006/main">
               <a:ext uri="{FF2B5EF4-FFF2-40B4-BE49-F238E27FC236}">
                 <a16:creationId xmlns:a16="http://schemas.microsoft.com/office/drawing/2014/main" id="{7A46739D-6B42-49A2-B086-9836DAF0734B}"/>
@@ -4554,7 +4554,7 @@
       </p:sp>
       <p:sp>
         <p:nvSpPr>
-          <p:cNvPr id="13" name="">
+          <p:cNvPr id="14" name="">
             <a:extLst xmlns:a="http://schemas.openxmlformats.org/drawingml/2006/main">
               <a:ext uri="{FF2B5EF4-FFF2-40B4-BE49-F238E27FC236}">
                 <a16:creationId xmlns:a16="http://schemas.microsoft.com/office/drawing/2014/main" id="{03EB8163-9559-4478-9B9B-17D931EA4146}"/>
@@ -4602,7 +4602,7 @@
       </p:sp>
       <p:sp>
         <p:nvSpPr>
-          <p:cNvPr id="14" name="">
+          <p:cNvPr id="15" name="">
             <a:extLst xmlns:a="http://schemas.openxmlformats.org/drawingml/2006/main">
               <a:ext uri="{FF2B5EF4-FFF2-40B4-BE49-F238E27FC236}">
                 <a16:creationId xmlns:a16="http://schemas.microsoft.com/office/drawing/2014/main" id="{FFF80A0A-A9DE-4C2B-9D2F-44E25A01F57D}"/>
@@ -4634,7 +4634,7 @@
       </p:sp>
       <p:sp>
         <p:nvSpPr>
-          <p:cNvPr id="15" name="">
+          <p:cNvPr id="16" name="">
             <a:extLst xmlns:a="http://schemas.openxmlformats.org/drawingml/2006/main">
               <a:ext uri="{FF2B5EF4-FFF2-40B4-BE49-F238E27FC236}">
                 <a16:creationId xmlns:a16="http://schemas.microsoft.com/office/drawing/2014/main" id="{6DAE6466-6D5A-4297-A0F1-94D17773FC4D}"/>
@@ -4666,7 +4666,7 @@
       </p:sp>
       <p:sp>
         <p:nvSpPr>
-          <p:cNvPr id="16" name="">
+          <p:cNvPr id="17" name="">
             <a:extLst xmlns:a="http://schemas.openxmlformats.org/drawingml/2006/main">
               <a:ext uri="{FF2B5EF4-FFF2-40B4-BE49-F238E27FC236}">
                 <a16:creationId xmlns:a16="http://schemas.microsoft.com/office/drawing/2014/main" id="{B0A20E1A-66E2-43D2-BC46-71772C7B464D}"/>
@@ -4698,7 +4698,7 @@
       </p:sp>
       <p:sp>
         <p:nvSpPr>
-          <p:cNvPr id="17" name="">
+          <p:cNvPr id="18" name="">
             <a:extLst xmlns:a="http://schemas.openxmlformats.org/drawingml/2006/main">
               <a:ext uri="{FF2B5EF4-FFF2-40B4-BE49-F238E27FC236}">
                 <a16:creationId xmlns:a16="http://schemas.microsoft.com/office/drawing/2014/main" id="{CCEF142F-4C77-486F-93A5-4CBA58B9A5E9}"/>
@@ -4767,7 +4767,7 @@
       </p:grpSpPr>
       <p:sp>
         <p:nvSpPr>
-          <p:cNvPr id="1" name="Slide Number Placeholder 5">
+          <p:cNvPr id="2" name="Slide Number Placeholder 5">
             <a:extLst xmlns:a="http://schemas.openxmlformats.org/drawingml/2006/main">
               <a:ext uri="{FF2B5EF4-FFF2-40B4-BE49-F238E27FC236}">
                 <a16:creationId xmlns:a16="http://schemas.microsoft.com/office/drawing/2014/main" id="{70659316-B4BB-42AA-9EDF-4B27092320CB}"/>
@@ -4799,7 +4799,7 @@
       </p:sp>
       <p:sp>
         <p:nvSpPr>
-          <p:cNvPr id="2" name="">
+          <p:cNvPr id="3" name="">
             <a:extLst xmlns:a="http://schemas.openxmlformats.org/drawingml/2006/main">
               <a:ext uri="{FF2B5EF4-FFF2-40B4-BE49-F238E27FC236}">
                 <a16:creationId xmlns:a16="http://schemas.microsoft.com/office/drawing/2014/main" id="{C46A3FD3-EDE3-4070-9B6B-1A1313DB91D9}"/>
@@ -4831,7 +4831,7 @@
       </p:sp>
       <p:sp>
         <p:nvSpPr>
-          <p:cNvPr id="3" name="">
+          <p:cNvPr id="4" name="">
             <a:extLst xmlns:a="http://schemas.openxmlformats.org/drawingml/2006/main">
               <a:ext uri="{FF2B5EF4-FFF2-40B4-BE49-F238E27FC236}">
                 <a16:creationId xmlns:a16="http://schemas.microsoft.com/office/drawing/2014/main" id="{695965E7-C89E-4476-A38A-8420F3474DE2}"/>
@@ -4863,7 +4863,7 @@
       </p:sp>
       <p:sp>
         <p:nvSpPr>
-          <p:cNvPr id="4" name="">
+          <p:cNvPr id="5" name="">
             <a:extLst xmlns:a="http://schemas.openxmlformats.org/drawingml/2006/main">
               <a:ext uri="{FF2B5EF4-FFF2-40B4-BE49-F238E27FC236}">
                 <a16:creationId xmlns:a16="http://schemas.microsoft.com/office/drawing/2014/main" id="{F59311C2-C9EC-40F5-9C1C-4F766C315162}"/>
@@ -4907,7 +4907,7 @@
       </p:sp>
       <p:sp>
         <p:nvSpPr>
-          <p:cNvPr id="5" name="">
+          <p:cNvPr id="6" name="">
             <a:extLst xmlns:a="http://schemas.openxmlformats.org/drawingml/2006/main">
               <a:ext uri="{FF2B5EF4-FFF2-40B4-BE49-F238E27FC236}">
                 <a16:creationId xmlns:a16="http://schemas.microsoft.com/office/drawing/2014/main" id="{5AFE2577-AA9C-4DED-A83E-654D1496D6E6}"/>
@@ -4953,7 +4953,7 @@
       </p:sp>
       <p:sp>
         <p:nvSpPr>
-          <p:cNvPr id="6" name="">
+          <p:cNvPr id="7" name="">
             <a:extLst xmlns:a="http://schemas.openxmlformats.org/drawingml/2006/main">
               <a:ext uri="{FF2B5EF4-FFF2-40B4-BE49-F238E27FC236}">
                 <a16:creationId xmlns:a16="http://schemas.microsoft.com/office/drawing/2014/main" id="{9EC1D04E-BC5B-41C5-B98B-EE2CCD222800}"/>
@@ -4999,7 +4999,7 @@
       </p:sp>
       <p:sp>
         <p:nvSpPr>
-          <p:cNvPr id="7" name="">
+          <p:cNvPr id="8" name="">
             <a:extLst xmlns:a="http://schemas.openxmlformats.org/drawingml/2006/main">
               <a:ext uri="{FF2B5EF4-FFF2-40B4-BE49-F238E27FC236}">
                 <a16:creationId xmlns:a16="http://schemas.microsoft.com/office/drawing/2014/main" id="{372FA45D-A4C1-4060-A807-A5099EFE39E8}"/>
@@ -5031,7 +5031,7 @@
       </p:sp>
       <p:sp>
         <p:nvSpPr>
-          <p:cNvPr id="8" name="">
+          <p:cNvPr id="9" name="">
             <a:extLst xmlns:a="http://schemas.openxmlformats.org/drawingml/2006/main">
               <a:ext uri="{FF2B5EF4-FFF2-40B4-BE49-F238E27FC236}">
                 <a16:creationId xmlns:a16="http://schemas.microsoft.com/office/drawing/2014/main" id="{19C436F2-5375-40FE-9E0D-68B145F89442}"/>
@@ -5075,7 +5075,7 @@
       </p:sp>
       <p:sp>
         <p:nvSpPr>
-          <p:cNvPr id="9" name="">
+          <p:cNvPr id="10" name="">
             <a:extLst xmlns:a="http://schemas.openxmlformats.org/drawingml/2006/main">
               <a:ext uri="{FF2B5EF4-FFF2-40B4-BE49-F238E27FC236}">
                 <a16:creationId xmlns:a16="http://schemas.microsoft.com/office/drawing/2014/main" id="{4A9C56FF-EFCF-47D9-A782-B105B0D21AF7}"/>
@@ -5120,7 +5120,7 @@
       </p:sp>
       <p:sp>
         <p:nvSpPr>
-          <p:cNvPr id="10" name="">
+          <p:cNvPr id="11" name="">
             <a:extLst xmlns:a="http://schemas.openxmlformats.org/drawingml/2006/main">
               <a:ext uri="{FF2B5EF4-FFF2-40B4-BE49-F238E27FC236}">
                 <a16:creationId xmlns:a16="http://schemas.microsoft.com/office/drawing/2014/main" id="{BE1A4665-4F58-43D2-8CF6-DD12AC90EA56}"/>
@@ -5152,7 +5152,7 @@
       </p:sp>
       <p:sp>
         <p:nvSpPr>
-          <p:cNvPr id="11" name="">
+          <p:cNvPr id="12" name="">
             <a:extLst xmlns:a="http://schemas.openxmlformats.org/drawingml/2006/main">
               <a:ext uri="{FF2B5EF4-FFF2-40B4-BE49-F238E27FC236}">
                 <a16:creationId xmlns:a16="http://schemas.microsoft.com/office/drawing/2014/main" id="{2BCD5637-DBB0-45FC-914E-B28DE2C7A261}"/>
@@ -5184,7 +5184,7 @@
       </p:sp>
       <p:sp>
         <p:nvSpPr>
-          <p:cNvPr id="12" name="">
+          <p:cNvPr id="13" name="">
             <a:extLst xmlns:a="http://schemas.openxmlformats.org/drawingml/2006/main">
               <a:ext uri="{FF2B5EF4-FFF2-40B4-BE49-F238E27FC236}">
                 <a16:creationId xmlns:a16="http://schemas.microsoft.com/office/drawing/2014/main" id="{A2536D06-E0AD-4EA4-B762-3C711C95346B}"/>
@@ -5230,7 +5230,7 @@
       </p:sp>
       <p:sp>
         <p:nvSpPr>
-          <p:cNvPr id="13" name="">
+          <p:cNvPr id="14" name="">
             <a:extLst xmlns:a="http://schemas.openxmlformats.org/drawingml/2006/main">
               <a:ext uri="{FF2B5EF4-FFF2-40B4-BE49-F238E27FC236}">
                 <a16:creationId xmlns:a16="http://schemas.microsoft.com/office/drawing/2014/main" id="{4BA929EF-85DB-45D8-B944-1BFAFFA6E9DD}"/>
@@ -5276,7 +5276,7 @@
       </p:sp>
       <p:sp>
         <p:nvSpPr>
-          <p:cNvPr id="14" name="">
+          <p:cNvPr id="15" name="">
             <a:extLst xmlns:a="http://schemas.openxmlformats.org/drawingml/2006/main">
               <a:ext uri="{FF2B5EF4-FFF2-40B4-BE49-F238E27FC236}">
                 <a16:creationId xmlns:a16="http://schemas.microsoft.com/office/drawing/2014/main" id="{A1580ED3-DD1C-4B3F-A35D-16A4E613EC56}"/>
@@ -5308,7 +5308,7 @@
       </p:sp>
       <p:sp>
         <p:nvSpPr>
-          <p:cNvPr id="15" name="">
+          <p:cNvPr id="16" name="">
             <a:extLst xmlns:a="http://schemas.openxmlformats.org/drawingml/2006/main">
               <a:ext uri="{FF2B5EF4-FFF2-40B4-BE49-F238E27FC236}">
                 <a16:creationId xmlns:a16="http://schemas.microsoft.com/office/drawing/2014/main" id="{35FF7A75-71CF-4463-88FF-F861F3C81E35}"/>
@@ -5340,7 +5340,7 @@
       </p:sp>
       <p:sp>
         <p:nvSpPr>
-          <p:cNvPr id="16" name="">
+          <p:cNvPr id="17" name="">
             <a:extLst xmlns:a="http://schemas.openxmlformats.org/drawingml/2006/main">
               <a:ext uri="{FF2B5EF4-FFF2-40B4-BE49-F238E27FC236}">
                 <a16:creationId xmlns:a16="http://schemas.microsoft.com/office/drawing/2014/main" id="{8E117F22-C073-40D0-B484-4C883CD584CD}"/>
@@ -5386,7 +5386,7 @@
       </p:sp>
       <p:sp>
         <p:nvSpPr>
-          <p:cNvPr id="17" name="">
+          <p:cNvPr id="18" name="">
             <a:extLst xmlns:a="http://schemas.openxmlformats.org/drawingml/2006/main">
               <a:ext uri="{FF2B5EF4-FFF2-40B4-BE49-F238E27FC236}">
                 <a16:creationId xmlns:a16="http://schemas.microsoft.com/office/drawing/2014/main" id="{C5D0848F-590C-493D-B653-FFE7C1D08CF0}"/>
@@ -5432,7 +5432,7 @@
       </p:sp>
       <p:sp>
         <p:nvSpPr>
-          <p:cNvPr id="18" name="">
+          <p:cNvPr id="19" name="">
             <a:extLst xmlns:a="http://schemas.openxmlformats.org/drawingml/2006/main">
               <a:ext uri="{FF2B5EF4-FFF2-40B4-BE49-F238E27FC236}">
                 <a16:creationId xmlns:a16="http://schemas.microsoft.com/office/drawing/2014/main" id="{B9054AEC-F21C-4F32-B730-8BB65AB20EE4}"/>
@@ -5464,7 +5464,7 @@
       </p:sp>
       <p:sp>
         <p:nvSpPr>
-          <p:cNvPr id="19" name="">
+          <p:cNvPr id="20" name="">
             <a:extLst xmlns:a="http://schemas.openxmlformats.org/drawingml/2006/main">
               <a:ext uri="{FF2B5EF4-FFF2-40B4-BE49-F238E27FC236}">
                 <a16:creationId xmlns:a16="http://schemas.microsoft.com/office/drawing/2014/main" id="{4BE45452-BB72-4FDC-AA3F-31C2A26AC960}"/>
@@ -5533,7 +5533,7 @@
       </p:grpSpPr>
       <p:sp>
         <p:nvSpPr>
-          <p:cNvPr id="1" name="Slide Number Placeholder 5">
+          <p:cNvPr id="2" name="Slide Number Placeholder 5">
             <a:extLst xmlns:a="http://schemas.openxmlformats.org/drawingml/2006/main">
               <a:ext uri="{FF2B5EF4-FFF2-40B4-BE49-F238E27FC236}">
                 <a16:creationId xmlns:a16="http://schemas.microsoft.com/office/drawing/2014/main" id="{70659316-B4BB-42AA-9EDF-4B27092320CB}"/>
@@ -5565,7 +5565,7 @@
       </p:sp>
       <p:sp>
         <p:nvSpPr>
-          <p:cNvPr id="2" name="">
+          <p:cNvPr id="3" name="">
             <a:extLst xmlns:a="http://schemas.openxmlformats.org/drawingml/2006/main">
               <a:ext uri="{FF2B5EF4-FFF2-40B4-BE49-F238E27FC236}">
                 <a16:creationId xmlns:a16="http://schemas.microsoft.com/office/drawing/2014/main" id="{CF3F3AE5-02C5-4EA7-8B47-9BC368E189D1}"/>
@@ -5597,7 +5597,7 @@
       </p:sp>
       <p:sp>
         <p:nvSpPr>
-          <p:cNvPr id="3" name="">
+          <p:cNvPr id="4" name="">
             <a:extLst xmlns:a="http://schemas.openxmlformats.org/drawingml/2006/main">
               <a:ext uri="{FF2B5EF4-FFF2-40B4-BE49-F238E27FC236}">
                 <a16:creationId xmlns:a16="http://schemas.microsoft.com/office/drawing/2014/main" id="{E5E469A0-368A-4BE7-97EB-B42451F4FE4D}"/>
@@ -5629,7 +5629,7 @@
       </p:sp>
       <p:sp>
         <p:nvSpPr>
-          <p:cNvPr id="4" name="">
+          <p:cNvPr id="5" name="">
             <a:extLst xmlns:a="http://schemas.openxmlformats.org/drawingml/2006/main">
               <a:ext uri="{FF2B5EF4-FFF2-40B4-BE49-F238E27FC236}">
                 <a16:creationId xmlns:a16="http://schemas.microsoft.com/office/drawing/2014/main" id="{436CE175-6D94-4AA4-A7C1-D3542C456035}"/>
@@ -5673,7 +5673,7 @@
       </p:sp>
       <p:sp>
         <p:nvSpPr>
-          <p:cNvPr id="5" name="">
+          <p:cNvPr id="6" name="">
             <a:extLst xmlns:a="http://schemas.openxmlformats.org/drawingml/2006/main">
               <a:ext uri="{FF2B5EF4-FFF2-40B4-BE49-F238E27FC236}">
                 <a16:creationId xmlns:a16="http://schemas.microsoft.com/office/drawing/2014/main" id="{641832DD-B2F0-48D1-B8CF-B5DC6B09854F}"/>
@@ -5719,7 +5719,7 @@
       </p:sp>
       <p:sp>
         <p:nvSpPr>
-          <p:cNvPr id="6" name="">
+          <p:cNvPr id="7" name="">
             <a:extLst xmlns:a="http://schemas.openxmlformats.org/drawingml/2006/main">
               <a:ext uri="{FF2B5EF4-FFF2-40B4-BE49-F238E27FC236}">
                 <a16:creationId xmlns:a16="http://schemas.microsoft.com/office/drawing/2014/main" id="{F8380DBE-4DF7-47F5-94A5-BDBD1E2ABF6B}"/>
@@ -5765,7 +5765,7 @@
       </p:sp>
       <p:sp>
         <p:nvSpPr>
-          <p:cNvPr id="7" name="">
+          <p:cNvPr id="8" name="">
             <a:extLst xmlns:a="http://schemas.openxmlformats.org/drawingml/2006/main">
               <a:ext uri="{FF2B5EF4-FFF2-40B4-BE49-F238E27FC236}">
                 <a16:creationId xmlns:a16="http://schemas.microsoft.com/office/drawing/2014/main" id="{7EFE3B3E-27D3-4955-9DB7-61BB5E3BD367}"/>
@@ -5797,7 +5797,7 @@
       </p:sp>
       <p:sp>
         <p:nvSpPr>
-          <p:cNvPr id="8" name="">
+          <p:cNvPr id="9" name="">
             <a:extLst xmlns:a="http://schemas.openxmlformats.org/drawingml/2006/main">
               <a:ext uri="{FF2B5EF4-FFF2-40B4-BE49-F238E27FC236}">
                 <a16:creationId xmlns:a16="http://schemas.microsoft.com/office/drawing/2014/main" id="{1A7507B9-3577-436D-81EF-31F183EF8C18}"/>
@@ -5841,7 +5841,7 @@
       </p:sp>
       <p:sp>
         <p:nvSpPr>
-          <p:cNvPr id="9" name="">
+          <p:cNvPr id="10" name="">
             <a:extLst xmlns:a="http://schemas.openxmlformats.org/drawingml/2006/main">
               <a:ext uri="{FF2B5EF4-FFF2-40B4-BE49-F238E27FC236}">
                 <a16:creationId xmlns:a16="http://schemas.microsoft.com/office/drawing/2014/main" id="{2717AA2F-6183-482F-9AC4-4780AE72B737}"/>
@@ -5886,7 +5886,7 @@
       </p:sp>
       <p:sp>
         <p:nvSpPr>
-          <p:cNvPr id="10" name="">
+          <p:cNvPr id="11" name="">
             <a:extLst xmlns:a="http://schemas.openxmlformats.org/drawingml/2006/main">
               <a:ext uri="{FF2B5EF4-FFF2-40B4-BE49-F238E27FC236}">
                 <a16:creationId xmlns:a16="http://schemas.microsoft.com/office/drawing/2014/main" id="{5C8A1444-6BDF-4027-A10E-EEA0004C6D50}"/>
@@ -5933,7 +5933,7 @@
       </p:sp>
       <p:sp>
         <p:nvSpPr>
-          <p:cNvPr id="11" name="">
+          <p:cNvPr id="12" name="">
             <a:extLst xmlns:a="http://schemas.openxmlformats.org/drawingml/2006/main">
               <a:ext uri="{FF2B5EF4-FFF2-40B4-BE49-F238E27FC236}">
                 <a16:creationId xmlns:a16="http://schemas.microsoft.com/office/drawing/2014/main" id="{7E7429C8-9D06-4844-B65A-C274982AD106}"/>
@@ -5965,7 +5965,7 @@
       </p:sp>
       <p:sp>
         <p:nvSpPr>
-          <p:cNvPr id="12" name="">
+          <p:cNvPr id="13" name="">
             <a:extLst xmlns:a="http://schemas.openxmlformats.org/drawingml/2006/main">
               <a:ext uri="{FF2B5EF4-FFF2-40B4-BE49-F238E27FC236}">
                 <a16:creationId xmlns:a16="http://schemas.microsoft.com/office/drawing/2014/main" id="{039A707F-3559-49D9-9D39-590BBAE44D12}"/>
@@ -6012,7 +6012,7 @@
       </p:sp>
       <p:sp>
         <p:nvSpPr>
-          <p:cNvPr id="13" name="">
+          <p:cNvPr id="14" name="">
             <a:extLst xmlns:a="http://schemas.openxmlformats.org/drawingml/2006/main">
               <a:ext uri="{FF2B5EF4-FFF2-40B4-BE49-F238E27FC236}">
                 <a16:creationId xmlns:a16="http://schemas.microsoft.com/office/drawing/2014/main" id="{8597AA8D-90DD-4B0B-9B9E-E57436FD047A}"/>
@@ -6044,7 +6044,7 @@
       </p:sp>
       <p:sp>
         <p:nvSpPr>
-          <p:cNvPr id="14" name="">
+          <p:cNvPr id="15" name="">
             <a:extLst xmlns:a="http://schemas.openxmlformats.org/drawingml/2006/main">
               <a:ext uri="{FF2B5EF4-FFF2-40B4-BE49-F238E27FC236}">
                 <a16:creationId xmlns:a16="http://schemas.microsoft.com/office/drawing/2014/main" id="{37E96E16-78DC-45A4-A162-F07096A33C20}"/>
@@ -6091,7 +6091,7 @@
       </p:sp>
       <p:sp>
         <p:nvSpPr>
-          <p:cNvPr id="15" name="">
+          <p:cNvPr id="16" name="">
             <a:extLst xmlns:a="http://schemas.openxmlformats.org/drawingml/2006/main">
               <a:ext uri="{FF2B5EF4-FFF2-40B4-BE49-F238E27FC236}">
                 <a16:creationId xmlns:a16="http://schemas.microsoft.com/office/drawing/2014/main" id="{BB2B2798-8587-4848-985D-67FCD36EFCAD}"/>
@@ -6123,7 +6123,7 @@
       </p:sp>
       <p:sp>
         <p:nvSpPr>
-          <p:cNvPr id="16" name="">
+          <p:cNvPr id="17" name="">
             <a:extLst xmlns:a="http://schemas.openxmlformats.org/drawingml/2006/main">
               <a:ext uri="{FF2B5EF4-FFF2-40B4-BE49-F238E27FC236}">
                 <a16:creationId xmlns:a16="http://schemas.microsoft.com/office/drawing/2014/main" id="{255F3721-FF72-4955-A042-B8F13F2CC208}"/>
@@ -6170,7 +6170,7 @@
       </p:sp>
       <p:sp>
         <p:nvSpPr>
-          <p:cNvPr id="17" name="">
+          <p:cNvPr id="18" name="">
             <a:extLst xmlns:a="http://schemas.openxmlformats.org/drawingml/2006/main">
               <a:ext uri="{FF2B5EF4-FFF2-40B4-BE49-F238E27FC236}">
                 <a16:creationId xmlns:a16="http://schemas.microsoft.com/office/drawing/2014/main" id="{A71CCE4E-631B-4C7D-BD8B-BBADC97F9D85}"/>
@@ -6202,7 +6202,7 @@
       </p:sp>
       <p:sp>
         <p:nvSpPr>
-          <p:cNvPr id="18" name="">
+          <p:cNvPr id="19" name="">
             <a:extLst xmlns:a="http://schemas.openxmlformats.org/drawingml/2006/main">
               <a:ext uri="{FF2B5EF4-FFF2-40B4-BE49-F238E27FC236}">
                 <a16:creationId xmlns:a16="http://schemas.microsoft.com/office/drawing/2014/main" id="{A47F62E2-EE37-4447-AFF3-CB86C4EB0C11}"/>
@@ -6249,7 +6249,7 @@
       </p:sp>
       <p:sp>
         <p:nvSpPr>
-          <p:cNvPr id="19" name="">
+          <p:cNvPr id="20" name="">
             <a:extLst xmlns:a="http://schemas.openxmlformats.org/drawingml/2006/main">
               <a:ext uri="{FF2B5EF4-FFF2-40B4-BE49-F238E27FC236}">
                 <a16:creationId xmlns:a16="http://schemas.microsoft.com/office/drawing/2014/main" id="{D2DDF870-F95D-453E-AD75-F6E5CADEB927}"/>
@@ -6281,7 +6281,7 @@
       </p:sp>
       <p:sp>
         <p:nvSpPr>
-          <p:cNvPr id="20" name="">
+          <p:cNvPr id="21" name="">
             <a:extLst xmlns:a="http://schemas.openxmlformats.org/drawingml/2006/main">
               <a:ext uri="{FF2B5EF4-FFF2-40B4-BE49-F238E27FC236}">
                 <a16:creationId xmlns:a16="http://schemas.microsoft.com/office/drawing/2014/main" id="{03EE8F69-8625-4186-8768-4B84A5553429}"/>
@@ -6328,7 +6328,7 @@
       </p:sp>
       <p:sp>
         <p:nvSpPr>
-          <p:cNvPr id="21" name="">
+          <p:cNvPr id="22" name="">
             <a:extLst xmlns:a="http://schemas.openxmlformats.org/drawingml/2006/main">
               <a:ext uri="{FF2B5EF4-FFF2-40B4-BE49-F238E27FC236}">
                 <a16:creationId xmlns:a16="http://schemas.microsoft.com/office/drawing/2014/main" id="{CBB87CD9-05A3-42C5-8F2B-17A3B50B260A}"/>
@@ -6360,7 +6360,7 @@
       </p:sp>
       <p:sp>
         <p:nvSpPr>
-          <p:cNvPr id="22" name="">
+          <p:cNvPr id="23" name="">
             <a:extLst xmlns:a="http://schemas.openxmlformats.org/drawingml/2006/main">
               <a:ext uri="{FF2B5EF4-FFF2-40B4-BE49-F238E27FC236}">
                 <a16:creationId xmlns:a16="http://schemas.microsoft.com/office/drawing/2014/main" id="{9661BBCA-5495-4E26-8EA2-FDA5A8750AB0}"/>
@@ -6407,7 +6407,7 @@
       </p:sp>
       <p:sp>
         <p:nvSpPr>
-          <p:cNvPr id="23" name="">
+          <p:cNvPr id="24" name="">
             <a:extLst xmlns:a="http://schemas.openxmlformats.org/drawingml/2006/main">
               <a:ext uri="{FF2B5EF4-FFF2-40B4-BE49-F238E27FC236}">
                 <a16:creationId xmlns:a16="http://schemas.microsoft.com/office/drawing/2014/main" id="{C1A8BAE4-278E-45B0-8515-43F16F6F4121}"/>
@@ -6439,7 +6439,7 @@
       </p:sp>
       <p:sp>
         <p:nvSpPr>
-          <p:cNvPr id="24" name="">
+          <p:cNvPr id="25" name="">
             <a:extLst xmlns:a="http://schemas.openxmlformats.org/drawingml/2006/main">
               <a:ext uri="{FF2B5EF4-FFF2-40B4-BE49-F238E27FC236}">
                 <a16:creationId xmlns:a16="http://schemas.microsoft.com/office/drawing/2014/main" id="{B28EED4A-F719-419B-9855-BF8C39C6277D}"/>
@@ -6484,7 +6484,7 @@
       </p:sp>
       <p:sp>
         <p:nvSpPr>
-          <p:cNvPr id="25" name="">
+          <p:cNvPr id="26" name="">
             <a:extLst xmlns:a="http://schemas.openxmlformats.org/drawingml/2006/main">
               <a:ext uri="{FF2B5EF4-FFF2-40B4-BE49-F238E27FC236}">
                 <a16:creationId xmlns:a16="http://schemas.microsoft.com/office/drawing/2014/main" id="{0FEDDE43-50B4-47FA-AE32-806BE9A8583F}"/>
@@ -6516,7 +6516,7 @@
       </p:sp>
       <p:sp>
         <p:nvSpPr>
-          <p:cNvPr id="26" name="">
+          <p:cNvPr id="27" name="">
             <a:extLst xmlns:a="http://schemas.openxmlformats.org/drawingml/2006/main">
               <a:ext uri="{FF2B5EF4-FFF2-40B4-BE49-F238E27FC236}">
                 <a16:creationId xmlns:a16="http://schemas.microsoft.com/office/drawing/2014/main" id="{79CE50BC-92E6-4013-8646-9BBD6140903D}"/>
@@ -6561,7 +6561,7 @@
       </p:sp>
       <p:sp>
         <p:nvSpPr>
-          <p:cNvPr id="27" name="">
+          <p:cNvPr id="28" name="">
             <a:extLst xmlns:a="http://schemas.openxmlformats.org/drawingml/2006/main">
               <a:ext uri="{FF2B5EF4-FFF2-40B4-BE49-F238E27FC236}">
                 <a16:creationId xmlns:a16="http://schemas.microsoft.com/office/drawing/2014/main" id="{3DB871D2-B9CB-4095-89C9-3C0CC200F7F0}"/>
@@ -6593,7 +6593,7 @@
       </p:sp>
       <p:sp>
         <p:nvSpPr>
-          <p:cNvPr id="28" name="">
+          <p:cNvPr id="29" name="">
             <a:extLst xmlns:a="http://schemas.openxmlformats.org/drawingml/2006/main">
               <a:ext uri="{FF2B5EF4-FFF2-40B4-BE49-F238E27FC236}">
                 <a16:creationId xmlns:a16="http://schemas.microsoft.com/office/drawing/2014/main" id="{1114F4FD-C0CB-4F6D-9185-ADA49E7E1B43}"/>
@@ -6660,7 +6660,7 @@
       </p:grpSpPr>
       <p:sp>
         <p:nvSpPr>
-          <p:cNvPr id="1" name="Slide Number Placeholder 5">
+          <p:cNvPr id="2" name="Slide Number Placeholder 5">
             <a:extLst xmlns:a="http://schemas.openxmlformats.org/drawingml/2006/main">
               <a:ext uri="{FF2B5EF4-FFF2-40B4-BE49-F238E27FC236}">
                 <a16:creationId xmlns:a16="http://schemas.microsoft.com/office/drawing/2014/main" id="{70659316-B4BB-42AA-9EDF-4B27092320CB}"/>
@@ -6692,7 +6692,7 @@
       </p:sp>
       <p:sp>
         <p:nvSpPr>
-          <p:cNvPr id="2" name="">
+          <p:cNvPr id="3" name="">
             <a:extLst xmlns:a="http://schemas.openxmlformats.org/drawingml/2006/main">
               <a:ext uri="{FF2B5EF4-FFF2-40B4-BE49-F238E27FC236}">
                 <a16:creationId xmlns:a16="http://schemas.microsoft.com/office/drawing/2014/main" id="{911E65B7-866C-4D43-8ECB-414420DEC234}"/>
@@ -6724,7 +6724,7 @@
       </p:sp>
       <p:sp>
         <p:nvSpPr>
-          <p:cNvPr id="3" name="">
+          <p:cNvPr id="4" name="">
             <a:extLst xmlns:a="http://schemas.openxmlformats.org/drawingml/2006/main">
               <a:ext uri="{FF2B5EF4-FFF2-40B4-BE49-F238E27FC236}">
                 <a16:creationId xmlns:a16="http://schemas.microsoft.com/office/drawing/2014/main" id="{3C0E8B28-E0EB-4704-8B7A-6E89F551BC61}"/>
@@ -6756,7 +6756,7 @@
       </p:sp>
       <p:sp>
         <p:nvSpPr>
-          <p:cNvPr id="4" name="">
+          <p:cNvPr id="5" name="">
             <a:extLst xmlns:a="http://schemas.openxmlformats.org/drawingml/2006/main">
               <a:ext uri="{FF2B5EF4-FFF2-40B4-BE49-F238E27FC236}">
                 <a16:creationId xmlns:a16="http://schemas.microsoft.com/office/drawing/2014/main" id="{D4BC4F10-DCD0-4C3B-9CEA-73A2504D4DD0}"/>
@@ -6800,7 +6800,7 @@
       </p:sp>
       <p:sp>
         <p:nvSpPr>
-          <p:cNvPr id="5" name="">
+          <p:cNvPr id="6" name="">
             <a:extLst xmlns:a="http://schemas.openxmlformats.org/drawingml/2006/main">
               <a:ext uri="{FF2B5EF4-FFF2-40B4-BE49-F238E27FC236}">
                 <a16:creationId xmlns:a16="http://schemas.microsoft.com/office/drawing/2014/main" id="{1C41C3BF-7268-45A6-9FFD-1DA728931054}"/>
@@ -6846,7 +6846,7 @@
       </p:sp>
       <p:sp>
         <p:nvSpPr>
-          <p:cNvPr id="6" name="">
+          <p:cNvPr id="7" name="">
             <a:extLst xmlns:a="http://schemas.openxmlformats.org/drawingml/2006/main">
               <a:ext uri="{FF2B5EF4-FFF2-40B4-BE49-F238E27FC236}">
                 <a16:creationId xmlns:a16="http://schemas.microsoft.com/office/drawing/2014/main" id="{5421988F-9CBC-4180-9A19-60D755341F73}"/>
@@ -6892,7 +6892,7 @@
       </p:sp>
       <p:sp>
         <p:nvSpPr>
-          <p:cNvPr id="7" name="">
+          <p:cNvPr id="8" name="">
             <a:extLst xmlns:a="http://schemas.openxmlformats.org/drawingml/2006/main">
               <a:ext uri="{FF2B5EF4-FFF2-40B4-BE49-F238E27FC236}">
                 <a16:creationId xmlns:a16="http://schemas.microsoft.com/office/drawing/2014/main" id="{B89FCA28-26DE-4B99-A5C3-C8ECE6BA82E1}"/>
@@ -6924,7 +6924,7 @@
       </p:sp>
       <p:sp>
         <p:nvSpPr>
-          <p:cNvPr id="8" name="">
+          <p:cNvPr id="9" name="">
             <a:extLst xmlns:a="http://schemas.openxmlformats.org/drawingml/2006/main">
               <a:ext uri="{FF2B5EF4-FFF2-40B4-BE49-F238E27FC236}">
                 <a16:creationId xmlns:a16="http://schemas.microsoft.com/office/drawing/2014/main" id="{228D5F8B-D9DF-49F0-9910-4729105D67CF}"/>
@@ -6968,7 +6968,7 @@
       </p:sp>
       <p:sp>
         <p:nvSpPr>
-          <p:cNvPr id="9" name="">
+          <p:cNvPr id="10" name="">
             <a:extLst xmlns:a="http://schemas.openxmlformats.org/drawingml/2006/main">
               <a:ext uri="{FF2B5EF4-FFF2-40B4-BE49-F238E27FC236}">
                 <a16:creationId xmlns:a16="http://schemas.microsoft.com/office/drawing/2014/main" id="{272D4A9D-BC25-420E-A4EC-80FB2D43E3E0}"/>
@@ -7013,7 +7013,7 @@
       </p:sp>
       <p:sp>
         <p:nvSpPr>
-          <p:cNvPr id="10" name="">
+          <p:cNvPr id="11" name="">
             <a:extLst xmlns:a="http://schemas.openxmlformats.org/drawingml/2006/main">
               <a:ext uri="{FF2B5EF4-FFF2-40B4-BE49-F238E27FC236}">
                 <a16:creationId xmlns:a16="http://schemas.microsoft.com/office/drawing/2014/main" id="{7DCE8172-83D7-4FF0-9D25-7EFEB1B65163}"/>
@@ -7045,7 +7045,7 @@
       </p:sp>
       <p:sp>
         <p:nvSpPr>
-          <p:cNvPr id="11" name="">
+          <p:cNvPr id="12" name="">
             <a:extLst xmlns:a="http://schemas.openxmlformats.org/drawingml/2006/main">
               <a:ext uri="{FF2B5EF4-FFF2-40B4-BE49-F238E27FC236}">
                 <a16:creationId xmlns:a16="http://schemas.microsoft.com/office/drawing/2014/main" id="{A9C28A6C-43D2-414B-B4E0-627542C10194}"/>
@@ -7089,7 +7089,7 @@
       </p:sp>
       <p:sp>
         <p:nvSpPr>
-          <p:cNvPr id="12" name="">
+          <p:cNvPr id="13" name="">
             <a:extLst xmlns:a="http://schemas.openxmlformats.org/drawingml/2006/main">
               <a:ext uri="{FF2B5EF4-FFF2-40B4-BE49-F238E27FC236}">
                 <a16:creationId xmlns:a16="http://schemas.microsoft.com/office/drawing/2014/main" id="{79369DD6-64CC-4BE7-9730-73BF9FF7A7D6}"/>
@@ -7121,7 +7121,7 @@
       </p:sp>
       <p:sp>
         <p:nvSpPr>
-          <p:cNvPr id="13" name="">
+          <p:cNvPr id="14" name="">
             <a:extLst xmlns:a="http://schemas.openxmlformats.org/drawingml/2006/main">
               <a:ext uri="{FF2B5EF4-FFF2-40B4-BE49-F238E27FC236}">
                 <a16:creationId xmlns:a16="http://schemas.microsoft.com/office/drawing/2014/main" id="{BCE552E4-230B-4E12-B5DB-A5EDB938C055}"/>
@@ -7167,7 +7167,7 @@
       </p:sp>
       <p:sp>
         <p:nvSpPr>
-          <p:cNvPr id="14" name="">
+          <p:cNvPr id="15" name="">
             <a:extLst xmlns:a="http://schemas.openxmlformats.org/drawingml/2006/main">
               <a:ext uri="{FF2B5EF4-FFF2-40B4-BE49-F238E27FC236}">
                 <a16:creationId xmlns:a16="http://schemas.microsoft.com/office/drawing/2014/main" id="{0F6C74A6-B2BE-4379-9707-341570B2A811}"/>
@@ -7199,7 +7199,7 @@
       </p:sp>
       <p:sp>
         <p:nvSpPr>
-          <p:cNvPr id="15" name="">
+          <p:cNvPr id="16" name="">
             <a:extLst xmlns:a="http://schemas.openxmlformats.org/drawingml/2006/main">
               <a:ext uri="{FF2B5EF4-FFF2-40B4-BE49-F238E27FC236}">
                 <a16:creationId xmlns:a16="http://schemas.microsoft.com/office/drawing/2014/main" id="{ADFCA090-0D0D-43A3-B7B8-4A118151A2A1}"/>
@@ -7245,7 +7245,7 @@
       </p:sp>
       <p:sp>
         <p:nvSpPr>
-          <p:cNvPr id="16" name="">
+          <p:cNvPr id="17" name="">
             <a:extLst xmlns:a="http://schemas.openxmlformats.org/drawingml/2006/main">
               <a:ext uri="{FF2B5EF4-FFF2-40B4-BE49-F238E27FC236}">
                 <a16:creationId xmlns:a16="http://schemas.microsoft.com/office/drawing/2014/main" id="{AAFE2ABE-F670-45ED-B1D9-23C4A2F2408A}"/>
@@ -7277,7 +7277,7 @@
       </p:sp>
       <p:sp>
         <p:nvSpPr>
-          <p:cNvPr id="17" name="">
+          <p:cNvPr id="18" name="">
             <a:extLst xmlns:a="http://schemas.openxmlformats.org/drawingml/2006/main">
               <a:ext uri="{FF2B5EF4-FFF2-40B4-BE49-F238E27FC236}">
                 <a16:creationId xmlns:a16="http://schemas.microsoft.com/office/drawing/2014/main" id="{45A0BB87-98D1-4BFE-A89C-212ADA1C5A81}"/>
@@ -7323,7 +7323,7 @@
       </p:sp>
       <p:sp>
         <p:nvSpPr>
-          <p:cNvPr id="18" name="">
+          <p:cNvPr id="19" name="">
             <a:extLst xmlns:a="http://schemas.openxmlformats.org/drawingml/2006/main">
               <a:ext uri="{FF2B5EF4-FFF2-40B4-BE49-F238E27FC236}">
                 <a16:creationId xmlns:a16="http://schemas.microsoft.com/office/drawing/2014/main" id="{9DC2A8B2-3FD7-4F3E-86A6-98BE4B2AC6CF}"/>
@@ -7355,7 +7355,7 @@
       </p:sp>
       <p:sp>
         <p:nvSpPr>
-          <p:cNvPr id="19" name="">
+          <p:cNvPr id="20" name="">
             <a:extLst xmlns:a="http://schemas.openxmlformats.org/drawingml/2006/main">
               <a:ext uri="{FF2B5EF4-FFF2-40B4-BE49-F238E27FC236}">
                 <a16:creationId xmlns:a16="http://schemas.microsoft.com/office/drawing/2014/main" id="{85E98059-9DD9-4FD2-BB07-E67FF18CB3E2}"/>
@@ -7401,7 +7401,7 @@
       </p:sp>
       <p:sp>
         <p:nvSpPr>
-          <p:cNvPr id="20" name="">
+          <p:cNvPr id="21" name="">
             <a:extLst xmlns:a="http://schemas.openxmlformats.org/drawingml/2006/main">
               <a:ext uri="{FF2B5EF4-FFF2-40B4-BE49-F238E27FC236}">
                 <a16:creationId xmlns:a16="http://schemas.microsoft.com/office/drawing/2014/main" id="{7DF6A68F-4072-42CD-A228-89BF469C983C}"/>
@@ -7433,7 +7433,7 @@
       </p:sp>
       <p:sp>
         <p:nvSpPr>
-          <p:cNvPr id="21" name="">
+          <p:cNvPr id="22" name="">
             <a:extLst xmlns:a="http://schemas.openxmlformats.org/drawingml/2006/main">
               <a:ext uri="{FF2B5EF4-FFF2-40B4-BE49-F238E27FC236}">
                 <a16:creationId xmlns:a16="http://schemas.microsoft.com/office/drawing/2014/main" id="{5F164FD1-437A-4774-99F0-AEBA19F92A51}"/>
@@ -7477,7 +7477,7 @@
       </p:sp>
       <p:sp>
         <p:nvSpPr>
-          <p:cNvPr id="22" name="">
+          <p:cNvPr id="23" name="">
             <a:extLst xmlns:a="http://schemas.openxmlformats.org/drawingml/2006/main">
               <a:ext uri="{FF2B5EF4-FFF2-40B4-BE49-F238E27FC236}">
                 <a16:creationId xmlns:a16="http://schemas.microsoft.com/office/drawing/2014/main" id="{D6578827-6838-42D4-865B-005410D391BA}"/>
@@ -7509,7 +7509,7 @@
       </p:sp>
       <p:sp>
         <p:nvSpPr>
-          <p:cNvPr id="23" name="">
+          <p:cNvPr id="24" name="">
             <a:extLst xmlns:a="http://schemas.openxmlformats.org/drawingml/2006/main">
               <a:ext uri="{FF2B5EF4-FFF2-40B4-BE49-F238E27FC236}">
                 <a16:creationId xmlns:a16="http://schemas.microsoft.com/office/drawing/2014/main" id="{F07EAAC7-50FA-4C3A-A370-EED9B72DDF9D}"/>
@@ -7555,7 +7555,7 @@
       </p:sp>
       <p:sp>
         <p:nvSpPr>
-          <p:cNvPr id="24" name="">
+          <p:cNvPr id="25" name="">
             <a:extLst xmlns:a="http://schemas.openxmlformats.org/drawingml/2006/main">
               <a:ext uri="{FF2B5EF4-FFF2-40B4-BE49-F238E27FC236}">
                 <a16:creationId xmlns:a16="http://schemas.microsoft.com/office/drawing/2014/main" id="{6BBC7541-339C-4D1F-B4DA-773808D4C1B5}"/>
@@ -7587,7 +7587,7 @@
       </p:sp>
       <p:sp>
         <p:nvSpPr>
-          <p:cNvPr id="25" name="">
+          <p:cNvPr id="26" name="">
             <a:extLst xmlns:a="http://schemas.openxmlformats.org/drawingml/2006/main">
               <a:ext uri="{FF2B5EF4-FFF2-40B4-BE49-F238E27FC236}">
                 <a16:creationId xmlns:a16="http://schemas.microsoft.com/office/drawing/2014/main" id="{AB9A24C1-DABE-4E86-855A-DE00C7BA68DE}"/>
@@ -7633,7 +7633,7 @@
       </p:sp>
       <p:sp>
         <p:nvSpPr>
-          <p:cNvPr id="26" name="">
+          <p:cNvPr id="27" name="">
             <a:extLst xmlns:a="http://schemas.openxmlformats.org/drawingml/2006/main">
               <a:ext uri="{FF2B5EF4-FFF2-40B4-BE49-F238E27FC236}">
                 <a16:creationId xmlns:a16="http://schemas.microsoft.com/office/drawing/2014/main" id="{97C0DA07-82AF-4A21-A9EA-5353BD5CE7A7}"/>
@@ -7665,7 +7665,7 @@
       </p:sp>
       <p:sp>
         <p:nvSpPr>
-          <p:cNvPr id="27" name="">
+          <p:cNvPr id="28" name="">
             <a:extLst xmlns:a="http://schemas.openxmlformats.org/drawingml/2006/main">
               <a:ext uri="{FF2B5EF4-FFF2-40B4-BE49-F238E27FC236}">
                 <a16:creationId xmlns:a16="http://schemas.microsoft.com/office/drawing/2014/main" id="{ED1DCD60-0DD4-4B84-9BF0-4EBC02FE100E}"/>
@@ -7711,7 +7711,7 @@
       </p:sp>
       <p:sp>
         <p:nvSpPr>
-          <p:cNvPr id="28" name="">
+          <p:cNvPr id="29" name="">
             <a:extLst xmlns:a="http://schemas.openxmlformats.org/drawingml/2006/main">
               <a:ext uri="{FF2B5EF4-FFF2-40B4-BE49-F238E27FC236}">
                 <a16:creationId xmlns:a16="http://schemas.microsoft.com/office/drawing/2014/main" id="{754D28B8-8B8B-48BA-9AB4-CB5443F486B4}"/>
@@ -7743,7 +7743,7 @@
       </p:sp>
       <p:sp>
         <p:nvSpPr>
-          <p:cNvPr id="29" name="">
+          <p:cNvPr id="30" name="">
             <a:extLst xmlns:a="http://schemas.openxmlformats.org/drawingml/2006/main">
               <a:ext uri="{FF2B5EF4-FFF2-40B4-BE49-F238E27FC236}">
                 <a16:creationId xmlns:a16="http://schemas.microsoft.com/office/drawing/2014/main" id="{DB722501-18BD-49CB-8749-852858A2D615}"/>
@@ -7811,7 +7811,7 @@
       </p:grpSpPr>
       <p:sp>
         <p:nvSpPr>
-          <p:cNvPr id="1" name="Slide Number Placeholder 5">
+          <p:cNvPr id="2" name="Slide Number Placeholder 5">
             <a:extLst xmlns:a="http://schemas.openxmlformats.org/drawingml/2006/main">
               <a:ext uri="{FF2B5EF4-FFF2-40B4-BE49-F238E27FC236}">
                 <a16:creationId xmlns:a16="http://schemas.microsoft.com/office/drawing/2014/main" id="{70659316-B4BB-42AA-9EDF-4B27092320CB}"/>
@@ -7843,7 +7843,7 @@
       </p:sp>
       <p:sp>
         <p:nvSpPr>
-          <p:cNvPr id="2" name="">
+          <p:cNvPr id="3" name="">
             <a:extLst xmlns:a="http://schemas.openxmlformats.org/drawingml/2006/main">
               <a:ext uri="{FF2B5EF4-FFF2-40B4-BE49-F238E27FC236}">
                 <a16:creationId xmlns:a16="http://schemas.microsoft.com/office/drawing/2014/main" id="{059B4E16-F54C-4816-9F5A-CA4A146232ED}"/>
@@ -7875,7 +7875,7 @@
       </p:sp>
       <p:sp>
         <p:nvSpPr>
-          <p:cNvPr id="3" name="">
+          <p:cNvPr id="4" name="">
             <a:extLst xmlns:a="http://schemas.openxmlformats.org/drawingml/2006/main">
               <a:ext uri="{FF2B5EF4-FFF2-40B4-BE49-F238E27FC236}">
                 <a16:creationId xmlns:a16="http://schemas.microsoft.com/office/drawing/2014/main" id="{062DE88E-A33E-4947-8A25-2EA4955C7328}"/>
@@ -7907,7 +7907,7 @@
       </p:sp>
       <p:sp>
         <p:nvSpPr>
-          <p:cNvPr id="4" name="">
+          <p:cNvPr id="5" name="">
             <a:extLst xmlns:a="http://schemas.openxmlformats.org/drawingml/2006/main">
               <a:ext uri="{FF2B5EF4-FFF2-40B4-BE49-F238E27FC236}">
                 <a16:creationId xmlns:a16="http://schemas.microsoft.com/office/drawing/2014/main" id="{ADA00936-FC43-400E-8A59-7693C479DA2B}"/>
@@ -7951,7 +7951,7 @@
       </p:sp>
       <p:sp>
         <p:nvSpPr>
-          <p:cNvPr id="5" name="">
+          <p:cNvPr id="6" name="">
             <a:extLst xmlns:a="http://schemas.openxmlformats.org/drawingml/2006/main">
               <a:ext uri="{FF2B5EF4-FFF2-40B4-BE49-F238E27FC236}">
                 <a16:creationId xmlns:a16="http://schemas.microsoft.com/office/drawing/2014/main" id="{965CC9CF-F7F3-4325-B6A3-0805FD725395}"/>
@@ -7997,7 +7997,7 @@
       </p:sp>
       <p:sp>
         <p:nvSpPr>
-          <p:cNvPr id="6" name="">
+          <p:cNvPr id="7" name="">
             <a:extLst xmlns:a="http://schemas.openxmlformats.org/drawingml/2006/main">
               <a:ext uri="{FF2B5EF4-FFF2-40B4-BE49-F238E27FC236}">
                 <a16:creationId xmlns:a16="http://schemas.microsoft.com/office/drawing/2014/main" id="{C259E28D-D520-423B-9EC4-D2CC2403076E}"/>
@@ -8043,7 +8043,7 @@
       </p:sp>
       <p:sp>
         <p:nvSpPr>
-          <p:cNvPr id="7" name="">
+          <p:cNvPr id="8" name="">
             <a:extLst xmlns:a="http://schemas.openxmlformats.org/drawingml/2006/main">
               <a:ext uri="{FF2B5EF4-FFF2-40B4-BE49-F238E27FC236}">
                 <a16:creationId xmlns:a16="http://schemas.microsoft.com/office/drawing/2014/main" id="{C0415114-DE78-423A-8277-1C658102EF4C}"/>
@@ -8075,7 +8075,7 @@
       </p:sp>
       <p:sp>
         <p:nvSpPr>
-          <p:cNvPr id="8" name="">
+          <p:cNvPr id="9" name="">
             <a:extLst xmlns:a="http://schemas.openxmlformats.org/drawingml/2006/main">
               <a:ext uri="{FF2B5EF4-FFF2-40B4-BE49-F238E27FC236}">
                 <a16:creationId xmlns:a16="http://schemas.microsoft.com/office/drawing/2014/main" id="{574CB6E2-E714-472B-9CA7-3509EDDF6B35}"/>
@@ -8119,7 +8119,7 @@
       </p:sp>
       <p:sp>
         <p:nvSpPr>
-          <p:cNvPr id="9" name="">
+          <p:cNvPr id="10" name="">
             <a:extLst xmlns:a="http://schemas.openxmlformats.org/drawingml/2006/main">
               <a:ext uri="{FF2B5EF4-FFF2-40B4-BE49-F238E27FC236}">
                 <a16:creationId xmlns:a16="http://schemas.microsoft.com/office/drawing/2014/main" id="{FAA92934-D02F-4EE6-B604-193CF4D9830C}"/>
@@ -8164,7 +8164,7 @@
       </p:sp>
       <p:sp>
         <p:nvSpPr>
-          <p:cNvPr id="10" name="">
+          <p:cNvPr id="11" name="">
             <a:extLst xmlns:a="http://schemas.openxmlformats.org/drawingml/2006/main">
               <a:ext uri="{FF2B5EF4-FFF2-40B4-BE49-F238E27FC236}">
                 <a16:creationId xmlns:a16="http://schemas.microsoft.com/office/drawing/2014/main" id="{E53D713C-0BE7-46A5-8D72-B320F8D6DFBB}"/>
@@ -8196,7 +8196,7 @@
       </p:sp>
       <p:sp>
         <p:nvSpPr>
-          <p:cNvPr id="11" name="">
+          <p:cNvPr id="12" name="">
             <a:extLst xmlns:a="http://schemas.openxmlformats.org/drawingml/2006/main">
               <a:ext uri="{FF2B5EF4-FFF2-40B4-BE49-F238E27FC236}">
                 <a16:creationId xmlns:a16="http://schemas.microsoft.com/office/drawing/2014/main" id="{196F9377-F5D9-4C05-8E47-F840CFFF6E25}"/>
@@ -8241,7 +8241,7 @@
       </p:sp>
       <p:sp>
         <p:nvSpPr>
-          <p:cNvPr id="12" name="">
+          <p:cNvPr id="13" name="">
             <a:extLst xmlns:a="http://schemas.openxmlformats.org/drawingml/2006/main">
               <a:ext uri="{FF2B5EF4-FFF2-40B4-BE49-F238E27FC236}">
                 <a16:creationId xmlns:a16="http://schemas.microsoft.com/office/drawing/2014/main" id="{690AE978-8F8F-4FB7-93FE-02500DDCFEA8}"/>
@@ -8288,7 +8288,7 @@
       </p:sp>
       <p:sp>
         <p:nvSpPr>
-          <p:cNvPr id="13" name="">
+          <p:cNvPr id="14" name="">
             <a:extLst xmlns:a="http://schemas.openxmlformats.org/drawingml/2006/main">
               <a:ext uri="{FF2B5EF4-FFF2-40B4-BE49-F238E27FC236}">
                 <a16:creationId xmlns:a16="http://schemas.microsoft.com/office/drawing/2014/main" id="{E280AA74-7A38-4D96-BC3C-EBFFAE09B1AB}"/>
@@ -8333,7 +8333,7 @@
       </p:sp>
       <p:sp>
         <p:nvSpPr>
-          <p:cNvPr id="14" name="">
+          <p:cNvPr id="15" name="">
             <a:extLst xmlns:a="http://schemas.openxmlformats.org/drawingml/2006/main">
               <a:ext uri="{FF2B5EF4-FFF2-40B4-BE49-F238E27FC236}">
                 <a16:creationId xmlns:a16="http://schemas.microsoft.com/office/drawing/2014/main" id="{F2F1E93C-8874-4115-B739-1730D3E1BEB5}"/>
@@ -8380,7 +8380,7 @@
       </p:sp>
       <p:sp>
         <p:nvSpPr>
-          <p:cNvPr id="15" name="">
+          <p:cNvPr id="16" name="">
             <a:extLst xmlns:a="http://schemas.openxmlformats.org/drawingml/2006/main">
               <a:ext uri="{FF2B5EF4-FFF2-40B4-BE49-F238E27FC236}">
                 <a16:creationId xmlns:a16="http://schemas.microsoft.com/office/drawing/2014/main" id="{6E9D3B2B-81E5-4A5A-8D73-804BE89C7195}"/>
@@ -8412,7 +8412,7 @@
       </p:sp>
       <p:sp>
         <p:nvSpPr>
-          <p:cNvPr id="16" name="">
+          <p:cNvPr id="17" name="">
             <a:extLst xmlns:a="http://schemas.openxmlformats.org/drawingml/2006/main">
               <a:ext uri="{FF2B5EF4-FFF2-40B4-BE49-F238E27FC236}">
                 <a16:creationId xmlns:a16="http://schemas.microsoft.com/office/drawing/2014/main" id="{C7A5F767-4680-485E-B380-77BD684459F6}"/>
@@ -8457,7 +8457,7 @@
       </p:sp>
       <p:sp>
         <p:nvSpPr>
-          <p:cNvPr id="17" name="">
+          <p:cNvPr id="18" name="">
             <a:extLst xmlns:a="http://schemas.openxmlformats.org/drawingml/2006/main">
               <a:ext uri="{FF2B5EF4-FFF2-40B4-BE49-F238E27FC236}">
                 <a16:creationId xmlns:a16="http://schemas.microsoft.com/office/drawing/2014/main" id="{4905CC9A-DEEB-4639-9886-3B71505F5C35}"/>
@@ -8504,7 +8504,7 @@
       </p:sp>
       <p:sp>
         <p:nvSpPr>
-          <p:cNvPr id="18" name="">
+          <p:cNvPr id="19" name="">
             <a:extLst xmlns:a="http://schemas.openxmlformats.org/drawingml/2006/main">
               <a:ext uri="{FF2B5EF4-FFF2-40B4-BE49-F238E27FC236}">
                 <a16:creationId xmlns:a16="http://schemas.microsoft.com/office/drawing/2014/main" id="{424DC742-3D3E-4A8D-80C8-BE2B0EB1B84F}"/>
@@ -8536,7 +8536,7 @@
       </p:sp>
       <p:sp>
         <p:nvSpPr>
-          <p:cNvPr id="19" name="">
+          <p:cNvPr id="20" name="">
             <a:extLst xmlns:a="http://schemas.openxmlformats.org/drawingml/2006/main">
               <a:ext uri="{FF2B5EF4-FFF2-40B4-BE49-F238E27FC236}">
                 <a16:creationId xmlns:a16="http://schemas.microsoft.com/office/drawing/2014/main" id="{1326D078-CC34-465C-8D2F-6D4FB40E9639}"/>
@@ -8581,7 +8581,7 @@
       </p:sp>
       <p:sp>
         <p:nvSpPr>
-          <p:cNvPr id="20" name="">
+          <p:cNvPr id="21" name="">
             <a:extLst xmlns:a="http://schemas.openxmlformats.org/drawingml/2006/main">
               <a:ext uri="{FF2B5EF4-FFF2-40B4-BE49-F238E27FC236}">
                 <a16:creationId xmlns:a16="http://schemas.microsoft.com/office/drawing/2014/main" id="{03EB3947-B4A8-4F33-BF51-419816475F08}"/>
@@ -8628,7 +8628,7 @@
       </p:sp>
       <p:sp>
         <p:nvSpPr>
-          <p:cNvPr id="21" name="">
+          <p:cNvPr id="22" name="">
             <a:extLst xmlns:a="http://schemas.openxmlformats.org/drawingml/2006/main">
               <a:ext uri="{FF2B5EF4-FFF2-40B4-BE49-F238E27FC236}">
                 <a16:creationId xmlns:a16="http://schemas.microsoft.com/office/drawing/2014/main" id="{34948277-495F-4234-B53B-B865B270EBBE}"/>
@@ -8660,7 +8660,7 @@
       </p:sp>
       <p:sp>
         <p:nvSpPr>
-          <p:cNvPr id="22" name="">
+          <p:cNvPr id="23" name="">
             <a:extLst xmlns:a="http://schemas.openxmlformats.org/drawingml/2006/main">
               <a:ext uri="{FF2B5EF4-FFF2-40B4-BE49-F238E27FC236}">
                 <a16:creationId xmlns:a16="http://schemas.microsoft.com/office/drawing/2014/main" id="{67ED9812-76E9-4570-92E0-9466CCB44FD1}"/>
@@ -8692,7 +8692,7 @@
       </p:sp>
       <p:sp>
         <p:nvSpPr>
-          <p:cNvPr id="23" name="">
+          <p:cNvPr id="24" name="">
             <a:extLst xmlns:a="http://schemas.openxmlformats.org/drawingml/2006/main">
               <a:ext uri="{FF2B5EF4-FFF2-40B4-BE49-F238E27FC236}">
                 <a16:creationId xmlns:a16="http://schemas.microsoft.com/office/drawing/2014/main" id="{9C7BA835-9FFC-4EE8-96CA-6C0D0DEB1618}"/>
@@ -8724,7 +8724,7 @@
       </p:sp>
       <p:sp>
         <p:nvSpPr>
-          <p:cNvPr id="24" name="">
+          <p:cNvPr id="25" name="">
             <a:extLst xmlns:a="http://schemas.openxmlformats.org/drawingml/2006/main">
               <a:ext uri="{FF2B5EF4-FFF2-40B4-BE49-F238E27FC236}">
                 <a16:creationId xmlns:a16="http://schemas.microsoft.com/office/drawing/2014/main" id="{1E086080-A26E-478F-9D93-59FF71F6AC39}"/>
@@ -8770,7 +8770,7 @@
       </p:sp>
       <p:sp>
         <p:nvSpPr>
-          <p:cNvPr id="25" name="">
+          <p:cNvPr id="26" name="">
             <a:extLst xmlns:a="http://schemas.openxmlformats.org/drawingml/2006/main">
               <a:ext uri="{FF2B5EF4-FFF2-40B4-BE49-F238E27FC236}">
                 <a16:creationId xmlns:a16="http://schemas.microsoft.com/office/drawing/2014/main" id="{767CA6F4-0395-4002-8CD5-67F8115DDFFA}"/>
@@ -8816,7 +8816,7 @@
       </p:sp>
       <p:sp>
         <p:nvSpPr>
-          <p:cNvPr id="26" name="">
+          <p:cNvPr id="27" name="">
             <a:extLst xmlns:a="http://schemas.openxmlformats.org/drawingml/2006/main">
               <a:ext uri="{FF2B5EF4-FFF2-40B4-BE49-F238E27FC236}">
                 <a16:creationId xmlns:a16="http://schemas.microsoft.com/office/drawing/2014/main" id="{053CE478-2257-4F37-B5B1-D65856EDF707}"/>
@@ -8848,7 +8848,7 @@
       </p:sp>
       <p:sp>
         <p:nvSpPr>
-          <p:cNvPr id="27" name="">
+          <p:cNvPr id="28" name="">
             <a:extLst xmlns:a="http://schemas.openxmlformats.org/drawingml/2006/main">
               <a:ext uri="{FF2B5EF4-FFF2-40B4-BE49-F238E27FC236}">
                 <a16:creationId xmlns:a16="http://schemas.microsoft.com/office/drawing/2014/main" id="{108C0460-09E0-4740-A8E9-07D2AE497D11}"/>
@@ -8880,7 +8880,7 @@
       </p:sp>
       <p:sp>
         <p:nvSpPr>
-          <p:cNvPr id="28" name="">
+          <p:cNvPr id="29" name="">
             <a:extLst xmlns:a="http://schemas.openxmlformats.org/drawingml/2006/main">
               <a:ext uri="{FF2B5EF4-FFF2-40B4-BE49-F238E27FC236}">
                 <a16:creationId xmlns:a16="http://schemas.microsoft.com/office/drawing/2014/main" id="{85A7AC86-DD2A-42E2-8930-5D6C12418C13}"/>
@@ -8926,7 +8926,7 @@
       </p:sp>
       <p:sp>
         <p:nvSpPr>
-          <p:cNvPr id="29" name="">
+          <p:cNvPr id="30" name="">
             <a:extLst xmlns:a="http://schemas.openxmlformats.org/drawingml/2006/main">
               <a:ext uri="{FF2B5EF4-FFF2-40B4-BE49-F238E27FC236}">
                 <a16:creationId xmlns:a16="http://schemas.microsoft.com/office/drawing/2014/main" id="{BEFDDB94-D9D3-4866-9E4E-EB444B7988D9}"/>
@@ -8972,7 +8972,7 @@
       </p:sp>
       <p:sp>
         <p:nvSpPr>
-          <p:cNvPr id="30" name="">
+          <p:cNvPr id="31" name="">
             <a:extLst xmlns:a="http://schemas.openxmlformats.org/drawingml/2006/main">
               <a:ext uri="{FF2B5EF4-FFF2-40B4-BE49-F238E27FC236}">
                 <a16:creationId xmlns:a16="http://schemas.microsoft.com/office/drawing/2014/main" id="{A190BAD2-445E-46D0-91D8-4C80E462C75D}"/>
@@ -9004,7 +9004,7 @@
       </p:sp>
       <p:sp>
         <p:nvSpPr>
-          <p:cNvPr id="31" name="">
+          <p:cNvPr id="32" name="">
             <a:extLst xmlns:a="http://schemas.openxmlformats.org/drawingml/2006/main">
               <a:ext uri="{FF2B5EF4-FFF2-40B4-BE49-F238E27FC236}">
                 <a16:creationId xmlns:a16="http://schemas.microsoft.com/office/drawing/2014/main" id="{B2E4B0FC-C882-4191-8B13-5245296B914E}"/>
@@ -9036,7 +9036,7 @@
       </p:sp>
       <p:sp>
         <p:nvSpPr>
-          <p:cNvPr id="32" name="">
+          <p:cNvPr id="33" name="">
             <a:extLst xmlns:a="http://schemas.openxmlformats.org/drawingml/2006/main">
               <a:ext uri="{FF2B5EF4-FFF2-40B4-BE49-F238E27FC236}">
                 <a16:creationId xmlns:a16="http://schemas.microsoft.com/office/drawing/2014/main" id="{B40B64D2-75A4-464C-9A42-0A019E69AB70}"/>
@@ -9082,7 +9082,7 @@
       </p:sp>
       <p:sp>
         <p:nvSpPr>
-          <p:cNvPr id="33" name="">
+          <p:cNvPr id="34" name="">
             <a:extLst xmlns:a="http://schemas.openxmlformats.org/drawingml/2006/main">
               <a:ext uri="{FF2B5EF4-FFF2-40B4-BE49-F238E27FC236}">
                 <a16:creationId xmlns:a16="http://schemas.microsoft.com/office/drawing/2014/main" id="{3B4794BD-635E-43BD-85EA-981190328A07}"/>
@@ -9150,7 +9150,7 @@
       </p:grpSpPr>
       <p:sp>
         <p:nvSpPr>
-          <p:cNvPr id="1" name="Slide Number Placeholder 5">
+          <p:cNvPr id="2" name="Slide Number Placeholder 5">
             <a:extLst xmlns:a="http://schemas.openxmlformats.org/drawingml/2006/main">
               <a:ext uri="{FF2B5EF4-FFF2-40B4-BE49-F238E27FC236}">
                 <a16:creationId xmlns:a16="http://schemas.microsoft.com/office/drawing/2014/main" id="{70659316-B4BB-42AA-9EDF-4B27092320CB}"/>
@@ -9182,7 +9182,7 @@
       </p:sp>
       <p:sp>
         <p:nvSpPr>
-          <p:cNvPr id="2" name="">
+          <p:cNvPr id="3" name="">
             <a:extLst xmlns:a="http://schemas.openxmlformats.org/drawingml/2006/main">
               <a:ext uri="{FF2B5EF4-FFF2-40B4-BE49-F238E27FC236}">
                 <a16:creationId xmlns:a16="http://schemas.microsoft.com/office/drawing/2014/main" id="{E38CD2D2-B5DC-481D-8D8F-F712F67BBECB}"/>
@@ -9214,7 +9214,7 @@
       </p:sp>
       <p:sp>
         <p:nvSpPr>
-          <p:cNvPr id="3" name="">
+          <p:cNvPr id="4" name="">
             <a:extLst xmlns:a="http://schemas.openxmlformats.org/drawingml/2006/main">
               <a:ext uri="{FF2B5EF4-FFF2-40B4-BE49-F238E27FC236}">
                 <a16:creationId xmlns:a16="http://schemas.microsoft.com/office/drawing/2014/main" id="{2EE3FF8F-D3B8-4D12-A271-0C9E4EA24D66}"/>
@@ -9246,7 +9246,7 @@
       </p:sp>
       <p:sp>
         <p:nvSpPr>
-          <p:cNvPr id="4" name="">
+          <p:cNvPr id="5" name="">
             <a:extLst xmlns:a="http://schemas.openxmlformats.org/drawingml/2006/main">
               <a:ext uri="{FF2B5EF4-FFF2-40B4-BE49-F238E27FC236}">
                 <a16:creationId xmlns:a16="http://schemas.microsoft.com/office/drawing/2014/main" id="{C93540C6-8990-432C-B313-17EBB46E22C3}"/>
@@ -9290,7 +9290,7 @@
       </p:sp>
       <p:sp>
         <p:nvSpPr>
-          <p:cNvPr id="5" name="">
+          <p:cNvPr id="6" name="">
             <a:extLst xmlns:a="http://schemas.openxmlformats.org/drawingml/2006/main">
               <a:ext uri="{FF2B5EF4-FFF2-40B4-BE49-F238E27FC236}">
                 <a16:creationId xmlns:a16="http://schemas.microsoft.com/office/drawing/2014/main" id="{8020B5D1-C521-4330-923A-7B9186C81311}"/>
@@ -9336,7 +9336,7 @@
       </p:sp>
       <p:sp>
         <p:nvSpPr>
-          <p:cNvPr id="6" name="">
+          <p:cNvPr id="7" name="">
             <a:extLst xmlns:a="http://schemas.openxmlformats.org/drawingml/2006/main">
               <a:ext uri="{FF2B5EF4-FFF2-40B4-BE49-F238E27FC236}">
                 <a16:creationId xmlns:a16="http://schemas.microsoft.com/office/drawing/2014/main" id="{9DB59CA3-55ED-41A8-B04C-77F2ABB15D6B}"/>
@@ -9382,7 +9382,7 @@
       </p:sp>
       <p:sp>
         <p:nvSpPr>
-          <p:cNvPr id="7" name="">
+          <p:cNvPr id="8" name="">
             <a:extLst xmlns:a="http://schemas.openxmlformats.org/drawingml/2006/main">
               <a:ext uri="{FF2B5EF4-FFF2-40B4-BE49-F238E27FC236}">
                 <a16:creationId xmlns:a16="http://schemas.microsoft.com/office/drawing/2014/main" id="{D76893A5-04A0-46EE-92C5-59A863642106}"/>
@@ -9414,7 +9414,7 @@
       </p:sp>
       <p:sp>
         <p:nvSpPr>
-          <p:cNvPr id="8" name="">
+          <p:cNvPr id="9" name="">
             <a:extLst xmlns:a="http://schemas.openxmlformats.org/drawingml/2006/main">
               <a:ext uri="{FF2B5EF4-FFF2-40B4-BE49-F238E27FC236}">
                 <a16:creationId xmlns:a16="http://schemas.microsoft.com/office/drawing/2014/main" id="{197C3B7F-1B67-4896-B7B7-41FB4BCB55E1}"/>
@@ -9458,7 +9458,7 @@
       </p:sp>
       <p:sp>
         <p:nvSpPr>
-          <p:cNvPr id="9" name="">
+          <p:cNvPr id="10" name="">
             <a:extLst xmlns:a="http://schemas.openxmlformats.org/drawingml/2006/main">
               <a:ext uri="{FF2B5EF4-FFF2-40B4-BE49-F238E27FC236}">
                 <a16:creationId xmlns:a16="http://schemas.microsoft.com/office/drawing/2014/main" id="{FECBA466-A6AA-4AF3-8696-594C188E92AB}"/>
@@ -9503,7 +9503,7 @@
       </p:sp>
       <p:sp>
         <p:nvSpPr>
-          <p:cNvPr id="10" name="">
+          <p:cNvPr id="11" name="">
             <a:extLst xmlns:a="http://schemas.openxmlformats.org/drawingml/2006/main">
               <a:ext uri="{FF2B5EF4-FFF2-40B4-BE49-F238E27FC236}">
                 <a16:creationId xmlns:a16="http://schemas.microsoft.com/office/drawing/2014/main" id="{9E582314-0DE1-4F4D-AB37-F49F6FB3E300}"/>
@@ -9535,7 +9535,7 @@
       </p:sp>
       <p:sp>
         <p:nvSpPr>
-          <p:cNvPr id="11" name="">
+          <p:cNvPr id="12" name="">
             <a:extLst xmlns:a="http://schemas.openxmlformats.org/drawingml/2006/main">
               <a:ext uri="{FF2B5EF4-FFF2-40B4-BE49-F238E27FC236}">
                 <a16:creationId xmlns:a16="http://schemas.microsoft.com/office/drawing/2014/main" id="{E7E38DFF-1D85-44CF-AC90-3FD5FADB9457}"/>
@@ -9581,7 +9581,7 @@
       </p:sp>
       <p:sp>
         <p:nvSpPr>
-          <p:cNvPr id="12" name="">
+          <p:cNvPr id="13" name="">
             <a:extLst xmlns:a="http://schemas.openxmlformats.org/drawingml/2006/main">
               <a:ext uri="{FF2B5EF4-FFF2-40B4-BE49-F238E27FC236}">
                 <a16:creationId xmlns:a16="http://schemas.microsoft.com/office/drawing/2014/main" id="{E2BC7BE0-2589-42D1-B434-5886B17BAB0C}"/>
@@ -9627,7 +9627,7 @@
       </p:sp>
       <p:sp>
         <p:nvSpPr>
-          <p:cNvPr id="13" name="">
+          <p:cNvPr id="14" name="">
             <a:extLst xmlns:a="http://schemas.openxmlformats.org/drawingml/2006/main">
               <a:ext uri="{FF2B5EF4-FFF2-40B4-BE49-F238E27FC236}">
                 <a16:creationId xmlns:a16="http://schemas.microsoft.com/office/drawing/2014/main" id="{9A7A56C2-891F-484F-AA2B-FACD5E721DEE}"/>
@@ -9659,7 +9659,7 @@
       </p:sp>
       <p:sp>
         <p:nvSpPr>
-          <p:cNvPr id="14" name="">
+          <p:cNvPr id="15" name="">
             <a:extLst xmlns:a="http://schemas.openxmlformats.org/drawingml/2006/main">
               <a:ext uri="{FF2B5EF4-FFF2-40B4-BE49-F238E27FC236}">
                 <a16:creationId xmlns:a16="http://schemas.microsoft.com/office/drawing/2014/main" id="{10BEA6EE-E345-411F-B03F-0A35A5BEF8AC}"/>
@@ -9705,7 +9705,7 @@
       </p:sp>
       <p:sp>
         <p:nvSpPr>
-          <p:cNvPr id="15" name="">
+          <p:cNvPr id="16" name="">
             <a:extLst xmlns:a="http://schemas.openxmlformats.org/drawingml/2006/main">
               <a:ext uri="{FF2B5EF4-FFF2-40B4-BE49-F238E27FC236}">
                 <a16:creationId xmlns:a16="http://schemas.microsoft.com/office/drawing/2014/main" id="{9D19C1DD-BB66-497C-BCB1-F0C3F50CDE4D}"/>
@@ -9751,7 +9751,7 @@
       </p:sp>
       <p:sp>
         <p:nvSpPr>
-          <p:cNvPr id="16" name="">
+          <p:cNvPr id="17" name="">
             <a:extLst xmlns:a="http://schemas.openxmlformats.org/drawingml/2006/main">
               <a:ext uri="{FF2B5EF4-FFF2-40B4-BE49-F238E27FC236}">
                 <a16:creationId xmlns:a16="http://schemas.microsoft.com/office/drawing/2014/main" id="{B4183E30-8A0F-43D4-B0F6-41839B6579A4}"/>
@@ -9783,7 +9783,7 @@
       </p:sp>
       <p:sp>
         <p:nvSpPr>
-          <p:cNvPr id="17" name="">
+          <p:cNvPr id="18" name="">
             <a:extLst xmlns:a="http://schemas.openxmlformats.org/drawingml/2006/main">
               <a:ext uri="{FF2B5EF4-FFF2-40B4-BE49-F238E27FC236}">
                 <a16:creationId xmlns:a16="http://schemas.microsoft.com/office/drawing/2014/main" id="{43349744-AEC6-4968-82A6-07EF30C38EC6}"/>
@@ -9829,7 +9829,7 @@
       </p:sp>
       <p:sp>
         <p:nvSpPr>
-          <p:cNvPr id="18" name="">
+          <p:cNvPr id="19" name="">
             <a:extLst xmlns:a="http://schemas.openxmlformats.org/drawingml/2006/main">
               <a:ext uri="{FF2B5EF4-FFF2-40B4-BE49-F238E27FC236}">
                 <a16:creationId xmlns:a16="http://schemas.microsoft.com/office/drawing/2014/main" id="{E3012001-00E9-4C83-A6D2-C45376B8D66D}"/>
@@ -9875,7 +9875,7 @@
       </p:sp>
       <p:sp>
         <p:nvSpPr>
-          <p:cNvPr id="19" name="">
+          <p:cNvPr id="20" name="">
             <a:extLst xmlns:a="http://schemas.openxmlformats.org/drawingml/2006/main">
               <a:ext uri="{FF2B5EF4-FFF2-40B4-BE49-F238E27FC236}">
                 <a16:creationId xmlns:a16="http://schemas.microsoft.com/office/drawing/2014/main" id="{E95DFBDE-1D00-4F64-BB62-73CDFEF9AFB2}"/>
@@ -9907,7 +9907,7 @@
       </p:sp>
       <p:sp>
         <p:nvSpPr>
-          <p:cNvPr id="20" name="">
+          <p:cNvPr id="21" name="">
             <a:extLst xmlns:a="http://schemas.openxmlformats.org/drawingml/2006/main">
               <a:ext uri="{FF2B5EF4-FFF2-40B4-BE49-F238E27FC236}">
                 <a16:creationId xmlns:a16="http://schemas.microsoft.com/office/drawing/2014/main" id="{CE493463-2908-41F4-858A-28BB0635CF8A}"/>
@@ -9953,7 +9953,7 @@
       </p:sp>
       <p:sp>
         <p:nvSpPr>
-          <p:cNvPr id="21" name="">
+          <p:cNvPr id="22" name="">
             <a:extLst xmlns:a="http://schemas.openxmlformats.org/drawingml/2006/main">
               <a:ext uri="{FF2B5EF4-FFF2-40B4-BE49-F238E27FC236}">
                 <a16:creationId xmlns:a16="http://schemas.microsoft.com/office/drawing/2014/main" id="{A32AF0E8-F9C5-4E8A-A456-05AE696F552F}"/>
@@ -9999,7 +9999,7 @@
       </p:sp>
       <p:sp>
         <p:nvSpPr>
-          <p:cNvPr id="22" name="">
+          <p:cNvPr id="23" name="">
             <a:extLst xmlns:a="http://schemas.openxmlformats.org/drawingml/2006/main">
               <a:ext uri="{FF2B5EF4-FFF2-40B4-BE49-F238E27FC236}">
                 <a16:creationId xmlns:a16="http://schemas.microsoft.com/office/drawing/2014/main" id="{E6F7EDCB-D344-437D-999A-8FA3D63F00AD}"/>
@@ -10031,7 +10031,7 @@
       </p:sp>
       <p:sp>
         <p:nvSpPr>
-          <p:cNvPr id="23" name="">
+          <p:cNvPr id="24" name="">
             <a:extLst xmlns:a="http://schemas.openxmlformats.org/drawingml/2006/main">
               <a:ext uri="{FF2B5EF4-FFF2-40B4-BE49-F238E27FC236}">
                 <a16:creationId xmlns:a16="http://schemas.microsoft.com/office/drawing/2014/main" id="{0344FC26-7BAA-483B-9D47-BB40131D34DC}"/>
@@ -10077,7 +10077,7 @@
       </p:sp>
       <p:sp>
         <p:nvSpPr>
-          <p:cNvPr id="24" name="">
+          <p:cNvPr id="25" name="">
             <a:extLst xmlns:a="http://schemas.openxmlformats.org/drawingml/2006/main">
               <a:ext uri="{FF2B5EF4-FFF2-40B4-BE49-F238E27FC236}">
                 <a16:creationId xmlns:a16="http://schemas.microsoft.com/office/drawing/2014/main" id="{4586902E-70AB-4931-BB02-3085A7A65252}"/>
@@ -10123,7 +10123,7 @@
       </p:sp>
       <p:sp>
         <p:nvSpPr>
-          <p:cNvPr id="25" name="">
+          <p:cNvPr id="26" name="">
             <a:extLst xmlns:a="http://schemas.openxmlformats.org/drawingml/2006/main">
               <a:ext uri="{FF2B5EF4-FFF2-40B4-BE49-F238E27FC236}">
                 <a16:creationId xmlns:a16="http://schemas.microsoft.com/office/drawing/2014/main" id="{2539E539-A968-4EDA-AAC1-375AD145C11D}"/>
@@ -10155,7 +10155,7 @@
       </p:sp>
       <p:sp>
         <p:nvSpPr>
-          <p:cNvPr id="26" name="">
+          <p:cNvPr id="27" name="">
             <a:extLst xmlns:a="http://schemas.openxmlformats.org/drawingml/2006/main">
               <a:ext uri="{FF2B5EF4-FFF2-40B4-BE49-F238E27FC236}">
                 <a16:creationId xmlns:a16="http://schemas.microsoft.com/office/drawing/2014/main" id="{30095419-7B54-4C80-818F-0780F1268A56}"/>
@@ -10201,7 +10201,7 @@
       </p:sp>
       <p:sp>
         <p:nvSpPr>
-          <p:cNvPr id="27" name="">
+          <p:cNvPr id="28" name="">
             <a:extLst xmlns:a="http://schemas.openxmlformats.org/drawingml/2006/main">
               <a:ext uri="{FF2B5EF4-FFF2-40B4-BE49-F238E27FC236}">
                 <a16:creationId xmlns:a16="http://schemas.microsoft.com/office/drawing/2014/main" id="{09E9917D-F8FE-4926-8EE2-2E0B2CA5DAE0}"/>
@@ -10247,7 +10247,7 @@
       </p:sp>
       <p:sp>
         <p:nvSpPr>
-          <p:cNvPr id="28" name="">
+          <p:cNvPr id="29" name="">
             <a:extLst xmlns:a="http://schemas.openxmlformats.org/drawingml/2006/main">
               <a:ext uri="{FF2B5EF4-FFF2-40B4-BE49-F238E27FC236}">
                 <a16:creationId xmlns:a16="http://schemas.microsoft.com/office/drawing/2014/main" id="{8E976CF9-AB91-4D28-91E6-4FAD895B59FF}"/>
@@ -10279,7 +10279,7 @@
       </p:sp>
       <p:sp>
         <p:nvSpPr>
-          <p:cNvPr id="29" name="">
+          <p:cNvPr id="30" name="">
             <a:extLst xmlns:a="http://schemas.openxmlformats.org/drawingml/2006/main">
               <a:ext uri="{FF2B5EF4-FFF2-40B4-BE49-F238E27FC236}">
                 <a16:creationId xmlns:a16="http://schemas.microsoft.com/office/drawing/2014/main" id="{6A63C0E9-3F0C-4115-9411-181E078FB649}"/>
@@ -10325,7 +10325,7 @@
       </p:sp>
       <p:sp>
         <p:nvSpPr>
-          <p:cNvPr id="30" name="">
+          <p:cNvPr id="31" name="">
             <a:extLst xmlns:a="http://schemas.openxmlformats.org/drawingml/2006/main">
               <a:ext uri="{FF2B5EF4-FFF2-40B4-BE49-F238E27FC236}">
                 <a16:creationId xmlns:a16="http://schemas.microsoft.com/office/drawing/2014/main" id="{1398968F-680E-4EE8-9617-B83A8DF31A68}"/>
@@ -10393,7 +10393,7 @@
       </p:grpSpPr>
       <p:sp>
         <p:nvSpPr>
-          <p:cNvPr id="1" name="Slide Number Placeholder 5">
+          <p:cNvPr id="2" name="Slide Number Placeholder 5">
             <a:extLst xmlns:a="http://schemas.openxmlformats.org/drawingml/2006/main">
               <a:ext uri="{FF2B5EF4-FFF2-40B4-BE49-F238E27FC236}">
                 <a16:creationId xmlns:a16="http://schemas.microsoft.com/office/drawing/2014/main" id="{70659316-B4BB-42AA-9EDF-4B27092320CB}"/>
@@ -10425,7 +10425,7 @@
       </p:sp>
       <p:sp>
         <p:nvSpPr>
-          <p:cNvPr id="2" name="">
+          <p:cNvPr id="3" name="">
             <a:extLst xmlns:a="http://schemas.openxmlformats.org/drawingml/2006/main">
               <a:ext uri="{FF2B5EF4-FFF2-40B4-BE49-F238E27FC236}">
                 <a16:creationId xmlns:a16="http://schemas.microsoft.com/office/drawing/2014/main" id="{24C7A573-78FD-40BC-B5F4-C1AC60AF1108}"/>
@@ -10457,7 +10457,7 @@
       </p:sp>
       <p:sp>
         <p:nvSpPr>
-          <p:cNvPr id="3" name="">
+          <p:cNvPr id="4" name="">
             <a:extLst xmlns:a="http://schemas.openxmlformats.org/drawingml/2006/main">
               <a:ext uri="{FF2B5EF4-FFF2-40B4-BE49-F238E27FC236}">
                 <a16:creationId xmlns:a16="http://schemas.microsoft.com/office/drawing/2014/main" id="{4FF3341D-00B7-4735-A554-F6CBB78FB09C}"/>
@@ -10489,7 +10489,7 @@
       </p:sp>
       <p:sp>
         <p:nvSpPr>
-          <p:cNvPr id="4" name="">
+          <p:cNvPr id="5" name="">
             <a:extLst xmlns:a="http://schemas.openxmlformats.org/drawingml/2006/main">
               <a:ext uri="{FF2B5EF4-FFF2-40B4-BE49-F238E27FC236}">
                 <a16:creationId xmlns:a16="http://schemas.microsoft.com/office/drawing/2014/main" id="{7360831C-7AB1-4C80-A8EF-75C6D03E76B6}"/>
@@ -10533,7 +10533,7 @@
       </p:sp>
       <p:sp>
         <p:nvSpPr>
-          <p:cNvPr id="5" name="">
+          <p:cNvPr id="6" name="">
             <a:extLst xmlns:a="http://schemas.openxmlformats.org/drawingml/2006/main">
               <a:ext uri="{FF2B5EF4-FFF2-40B4-BE49-F238E27FC236}">
                 <a16:creationId xmlns:a16="http://schemas.microsoft.com/office/drawing/2014/main" id="{95860B44-E88D-40BA-9B22-FDF9334321D3}"/>
@@ -10579,7 +10579,7 @@
       </p:sp>
       <p:sp>
         <p:nvSpPr>
-          <p:cNvPr id="6" name="">
+          <p:cNvPr id="7" name="">
             <a:extLst xmlns:a="http://schemas.openxmlformats.org/drawingml/2006/main">
               <a:ext uri="{FF2B5EF4-FFF2-40B4-BE49-F238E27FC236}">
                 <a16:creationId xmlns:a16="http://schemas.microsoft.com/office/drawing/2014/main" id="{FD646174-158C-424B-9944-44A931F75B0C}"/>
@@ -10625,7 +10625,7 @@
       </p:sp>
       <p:sp>
         <p:nvSpPr>
-          <p:cNvPr id="7" name="">
+          <p:cNvPr id="8" name="">
             <a:extLst xmlns:a="http://schemas.openxmlformats.org/drawingml/2006/main">
               <a:ext uri="{FF2B5EF4-FFF2-40B4-BE49-F238E27FC236}">
                 <a16:creationId xmlns:a16="http://schemas.microsoft.com/office/drawing/2014/main" id="{C55E878C-11B4-4555-AF1E-EE1F90764FE3}"/>
@@ -10657,7 +10657,7 @@
       </p:sp>
       <p:sp>
         <p:nvSpPr>
-          <p:cNvPr id="8" name="">
+          <p:cNvPr id="9" name="">
             <a:extLst xmlns:a="http://schemas.openxmlformats.org/drawingml/2006/main">
               <a:ext uri="{FF2B5EF4-FFF2-40B4-BE49-F238E27FC236}">
                 <a16:creationId xmlns:a16="http://schemas.microsoft.com/office/drawing/2014/main" id="{652828AE-27CE-4F72-B280-83D6DC0DC00E}"/>
@@ -10701,7 +10701,7 @@
       </p:sp>
       <p:sp>
         <p:nvSpPr>
-          <p:cNvPr id="9" name="">
+          <p:cNvPr id="10" name="">
             <a:extLst xmlns:a="http://schemas.openxmlformats.org/drawingml/2006/main">
               <a:ext uri="{FF2B5EF4-FFF2-40B4-BE49-F238E27FC236}">
                 <a16:creationId xmlns:a16="http://schemas.microsoft.com/office/drawing/2014/main" id="{8A90389F-CA69-4CBE-A9C6-AEFF1A8AB425}"/>
@@ -10746,7 +10746,7 @@
       </p:sp>
       <p:sp>
         <p:nvSpPr>
-          <p:cNvPr id="10" name="">
+          <p:cNvPr id="11" name="">
             <a:extLst xmlns:a="http://schemas.openxmlformats.org/drawingml/2006/main">
               <a:ext uri="{FF2B5EF4-FFF2-40B4-BE49-F238E27FC236}">
                 <a16:creationId xmlns:a16="http://schemas.microsoft.com/office/drawing/2014/main" id="{84987F8A-AF95-4E2E-B7E8-FB89375921AB}"/>
@@ -10778,7 +10778,7 @@
       </p:sp>
       <p:sp>
         <p:nvSpPr>
-          <p:cNvPr id="11" name="">
+          <p:cNvPr id="12" name="">
             <a:extLst xmlns:a="http://schemas.openxmlformats.org/drawingml/2006/main">
               <a:ext uri="{FF2B5EF4-FFF2-40B4-BE49-F238E27FC236}">
                 <a16:creationId xmlns:a16="http://schemas.microsoft.com/office/drawing/2014/main" id="{22F630CC-628B-4626-83D4-A3EBEDD21D1D}"/>
@@ -10810,7 +10810,7 @@
       </p:sp>
       <p:sp>
         <p:nvSpPr>
-          <p:cNvPr id="12" name="">
+          <p:cNvPr id="13" name="">
             <a:extLst xmlns:a="http://schemas.openxmlformats.org/drawingml/2006/main">
               <a:ext uri="{FF2B5EF4-FFF2-40B4-BE49-F238E27FC236}">
                 <a16:creationId xmlns:a16="http://schemas.microsoft.com/office/drawing/2014/main" id="{2EAC4851-6455-4E44-B479-EEB5DD89B007}"/>
@@ -10855,7 +10855,7 @@
       </p:sp>
       <p:sp>
         <p:nvSpPr>
-          <p:cNvPr id="13" name="">
+          <p:cNvPr id="14" name="">
             <a:extLst xmlns:a="http://schemas.openxmlformats.org/drawingml/2006/main">
               <a:ext uri="{FF2B5EF4-FFF2-40B4-BE49-F238E27FC236}">
                 <a16:creationId xmlns:a16="http://schemas.microsoft.com/office/drawing/2014/main" id="{B9E3AAC7-C085-4D2F-A2DE-EAA97DF61C2A}"/>
@@ -10901,7 +10901,7 @@
       </p:sp>
       <p:sp>
         <p:nvSpPr>
-          <p:cNvPr id="14" name="">
+          <p:cNvPr id="15" name="">
             <a:extLst xmlns:a="http://schemas.openxmlformats.org/drawingml/2006/main">
               <a:ext uri="{FF2B5EF4-FFF2-40B4-BE49-F238E27FC236}">
                 <a16:creationId xmlns:a16="http://schemas.microsoft.com/office/drawing/2014/main" id="{C7570872-65E0-4D78-ADCF-EB6EEB98D13D}"/>
@@ -10933,7 +10933,7 @@
       </p:sp>
       <p:sp>
         <p:nvSpPr>
-          <p:cNvPr id="15" name="">
+          <p:cNvPr id="16" name="">
             <a:extLst xmlns:a="http://schemas.openxmlformats.org/drawingml/2006/main">
               <a:ext uri="{FF2B5EF4-FFF2-40B4-BE49-F238E27FC236}">
                 <a16:creationId xmlns:a16="http://schemas.microsoft.com/office/drawing/2014/main" id="{815D2C47-DE26-4D4E-93BE-61FACDAE8CC4}"/>
@@ -10965,7 +10965,7 @@
       </p:sp>
       <p:sp>
         <p:nvSpPr>
-          <p:cNvPr id="16" name="">
+          <p:cNvPr id="17" name="">
             <a:extLst xmlns:a="http://schemas.openxmlformats.org/drawingml/2006/main">
               <a:ext uri="{FF2B5EF4-FFF2-40B4-BE49-F238E27FC236}">
                 <a16:creationId xmlns:a16="http://schemas.microsoft.com/office/drawing/2014/main" id="{A40FD408-9003-4C3B-821A-08436D3BD8BC}"/>
@@ -10997,7 +10997,7 @@
       </p:sp>
       <p:sp>
         <p:nvSpPr>
-          <p:cNvPr id="17" name="">
+          <p:cNvPr id="18" name="">
             <a:extLst xmlns:a="http://schemas.openxmlformats.org/drawingml/2006/main">
               <a:ext uri="{FF2B5EF4-FFF2-40B4-BE49-F238E27FC236}">
                 <a16:creationId xmlns:a16="http://schemas.microsoft.com/office/drawing/2014/main" id="{3B4A2A51-14FD-4C5A-8AA2-282C6725AFC5}"/>
@@ -11042,7 +11042,7 @@
       </p:sp>
       <p:sp>
         <p:nvSpPr>
-          <p:cNvPr id="18" name="">
+          <p:cNvPr id="19" name="">
             <a:extLst xmlns:a="http://schemas.openxmlformats.org/drawingml/2006/main">
               <a:ext uri="{FF2B5EF4-FFF2-40B4-BE49-F238E27FC236}">
                 <a16:creationId xmlns:a16="http://schemas.microsoft.com/office/drawing/2014/main" id="{C5BC62D0-CF9F-46BE-A14A-6C3B203AFF08}"/>
@@ -11088,7 +11088,7 @@
       </p:sp>
       <p:sp>
         <p:nvSpPr>
-          <p:cNvPr id="19" name="">
+          <p:cNvPr id="20" name="">
             <a:extLst xmlns:a="http://schemas.openxmlformats.org/drawingml/2006/main">
               <a:ext uri="{FF2B5EF4-FFF2-40B4-BE49-F238E27FC236}">
                 <a16:creationId xmlns:a16="http://schemas.microsoft.com/office/drawing/2014/main" id="{9DAB98B2-5566-4D80-9BB4-9E206D73CD56}"/>
@@ -11120,7 +11120,7 @@
       </p:sp>
       <p:sp>
         <p:nvSpPr>
-          <p:cNvPr id="20" name="">
+          <p:cNvPr id="21" name="">
             <a:extLst xmlns:a="http://schemas.openxmlformats.org/drawingml/2006/main">
               <a:ext uri="{FF2B5EF4-FFF2-40B4-BE49-F238E27FC236}">
                 <a16:creationId xmlns:a16="http://schemas.microsoft.com/office/drawing/2014/main" id="{25906C40-8DEF-4806-B4EB-0BEFE91D5D49}"/>
@@ -11152,7 +11152,7 @@
       </p:sp>
       <p:sp>
         <p:nvSpPr>
-          <p:cNvPr id="21" name="">
+          <p:cNvPr id="22" name="">
             <a:extLst xmlns:a="http://schemas.openxmlformats.org/drawingml/2006/main">
               <a:ext uri="{FF2B5EF4-FFF2-40B4-BE49-F238E27FC236}">
                 <a16:creationId xmlns:a16="http://schemas.microsoft.com/office/drawing/2014/main" id="{3EDB294D-686D-4169-B86A-9254429CE647}"/>
@@ -11184,7 +11184,7 @@
       </p:sp>
       <p:sp>
         <p:nvSpPr>
-          <p:cNvPr id="22" name="">
+          <p:cNvPr id="23" name="">
             <a:extLst xmlns:a="http://schemas.openxmlformats.org/drawingml/2006/main">
               <a:ext uri="{FF2B5EF4-FFF2-40B4-BE49-F238E27FC236}">
                 <a16:creationId xmlns:a16="http://schemas.microsoft.com/office/drawing/2014/main" id="{6DE1A0C9-AF3D-4483-986B-D85BB8C040EE}"/>
@@ -11229,7 +11229,7 @@
       </p:sp>
       <p:sp>
         <p:nvSpPr>
-          <p:cNvPr id="23" name="">
+          <p:cNvPr id="24" name="">
             <a:extLst xmlns:a="http://schemas.openxmlformats.org/drawingml/2006/main">
               <a:ext uri="{FF2B5EF4-FFF2-40B4-BE49-F238E27FC236}">
                 <a16:creationId xmlns:a16="http://schemas.microsoft.com/office/drawing/2014/main" id="{F85EF030-5CB5-4484-B0EF-532535F655F0}"/>
@@ -11275,7 +11275,7 @@
       </p:sp>
       <p:sp>
         <p:nvSpPr>
-          <p:cNvPr id="24" name="">
+          <p:cNvPr id="25" name="">
             <a:extLst xmlns:a="http://schemas.openxmlformats.org/drawingml/2006/main">
               <a:ext uri="{FF2B5EF4-FFF2-40B4-BE49-F238E27FC236}">
                 <a16:creationId xmlns:a16="http://schemas.microsoft.com/office/drawing/2014/main" id="{B06F4713-A91A-492B-A07F-822CDF71FD23}"/>
@@ -11307,7 +11307,7 @@
       </p:sp>
       <p:sp>
         <p:nvSpPr>
-          <p:cNvPr id="25" name="">
+          <p:cNvPr id="26" name="">
             <a:extLst xmlns:a="http://schemas.openxmlformats.org/drawingml/2006/main">
               <a:ext uri="{FF2B5EF4-FFF2-40B4-BE49-F238E27FC236}">
                 <a16:creationId xmlns:a16="http://schemas.microsoft.com/office/drawing/2014/main" id="{55D9EEDC-412B-49B4-9EFC-5606921CC96A}"/>
@@ -11339,7 +11339,7 @@
       </p:sp>
       <p:sp>
         <p:nvSpPr>
-          <p:cNvPr id="26" name="">
+          <p:cNvPr id="27" name="">
             <a:extLst xmlns:a="http://schemas.openxmlformats.org/drawingml/2006/main">
               <a:ext uri="{FF2B5EF4-FFF2-40B4-BE49-F238E27FC236}">
                 <a16:creationId xmlns:a16="http://schemas.microsoft.com/office/drawing/2014/main" id="{16B23F21-4D2C-4176-A001-E740BFF4240D}"/>
@@ -11371,7 +11371,7 @@
       </p:sp>
       <p:sp>
         <p:nvSpPr>
-          <p:cNvPr id="27" name="">
+          <p:cNvPr id="28" name="">
             <a:extLst xmlns:a="http://schemas.openxmlformats.org/drawingml/2006/main">
               <a:ext uri="{FF2B5EF4-FFF2-40B4-BE49-F238E27FC236}">
                 <a16:creationId xmlns:a16="http://schemas.microsoft.com/office/drawing/2014/main" id="{E07A86DF-7D86-43BC-86DB-006A388B5034}"/>
@@ -11416,7 +11416,7 @@
       </p:sp>
       <p:sp>
         <p:nvSpPr>
-          <p:cNvPr id="28" name="">
+          <p:cNvPr id="29" name="">
             <a:extLst xmlns:a="http://schemas.openxmlformats.org/drawingml/2006/main">
               <a:ext uri="{FF2B5EF4-FFF2-40B4-BE49-F238E27FC236}">
                 <a16:creationId xmlns:a16="http://schemas.microsoft.com/office/drawing/2014/main" id="{C353298F-B13E-4BA9-A9C3-C7D5CE710363}"/>
@@ -11462,7 +11462,7 @@
       </p:sp>
       <p:sp>
         <p:nvSpPr>
-          <p:cNvPr id="29" name="">
+          <p:cNvPr id="30" name="">
             <a:extLst xmlns:a="http://schemas.openxmlformats.org/drawingml/2006/main">
               <a:ext uri="{FF2B5EF4-FFF2-40B4-BE49-F238E27FC236}">
                 <a16:creationId xmlns:a16="http://schemas.microsoft.com/office/drawing/2014/main" id="{B21C5200-F3E1-42F7-A329-CEE598BAFCFA}"/>
@@ -11494,7 +11494,7 @@
       </p:sp>
       <p:sp>
         <p:nvSpPr>
-          <p:cNvPr id="30" name="">
+          <p:cNvPr id="31" name="">
             <a:extLst xmlns:a="http://schemas.openxmlformats.org/drawingml/2006/main">
               <a:ext uri="{FF2B5EF4-FFF2-40B4-BE49-F238E27FC236}">
                 <a16:creationId xmlns:a16="http://schemas.microsoft.com/office/drawing/2014/main" id="{F1B29D8F-5718-4B32-B6A2-80D39B21732D}"/>
@@ -11526,7 +11526,7 @@
       </p:sp>
       <p:sp>
         <p:nvSpPr>
-          <p:cNvPr id="31" name="">
+          <p:cNvPr id="32" name="">
             <a:extLst xmlns:a="http://schemas.openxmlformats.org/drawingml/2006/main">
               <a:ext uri="{FF2B5EF4-FFF2-40B4-BE49-F238E27FC236}">
                 <a16:creationId xmlns:a16="http://schemas.microsoft.com/office/drawing/2014/main" id="{9C4077F8-FB8F-443F-AECF-8F925F48956E}"/>
@@ -11558,7 +11558,7 @@
       </p:sp>
       <p:sp>
         <p:nvSpPr>
-          <p:cNvPr id="32" name="">
+          <p:cNvPr id="33" name="">
             <a:extLst xmlns:a="http://schemas.openxmlformats.org/drawingml/2006/main">
               <a:ext uri="{FF2B5EF4-FFF2-40B4-BE49-F238E27FC236}">
                 <a16:creationId xmlns:a16="http://schemas.microsoft.com/office/drawing/2014/main" id="{4EFD2311-F6E5-43A8-A084-29624A2D09FD}"/>
@@ -11603,7 +11603,7 @@
       </p:sp>
       <p:sp>
         <p:nvSpPr>
-          <p:cNvPr id="33" name="">
+          <p:cNvPr id="34" name="">
             <a:extLst xmlns:a="http://schemas.openxmlformats.org/drawingml/2006/main">
               <a:ext uri="{FF2B5EF4-FFF2-40B4-BE49-F238E27FC236}">
                 <a16:creationId xmlns:a16="http://schemas.microsoft.com/office/drawing/2014/main" id="{9A338CF7-6D5E-4ED6-B4F1-2EC45FC6B72B}"/>
@@ -11649,7 +11649,7 @@
       </p:sp>
       <p:sp>
         <p:nvSpPr>
-          <p:cNvPr id="34" name="">
+          <p:cNvPr id="35" name="">
             <a:extLst xmlns:a="http://schemas.openxmlformats.org/drawingml/2006/main">
               <a:ext uri="{FF2B5EF4-FFF2-40B4-BE49-F238E27FC236}">
                 <a16:creationId xmlns:a16="http://schemas.microsoft.com/office/drawing/2014/main" id="{EA887FBD-1985-4A6F-ACD5-48A6FC9200BD}"/>
@@ -11681,7 +11681,7 @@
       </p:sp>
       <p:sp>
         <p:nvSpPr>
-          <p:cNvPr id="35" name="">
+          <p:cNvPr id="36" name="">
             <a:extLst xmlns:a="http://schemas.openxmlformats.org/drawingml/2006/main">
               <a:ext uri="{FF2B5EF4-FFF2-40B4-BE49-F238E27FC236}">
                 <a16:creationId xmlns:a16="http://schemas.microsoft.com/office/drawing/2014/main" id="{03BDE4EE-4C5C-4A47-B51E-37865A5C6EF3}"/>
@@ -11713,7 +11713,7 @@
       </p:sp>
       <p:sp>
         <p:nvSpPr>
-          <p:cNvPr id="36" name="">
+          <p:cNvPr id="37" name="">
             <a:extLst xmlns:a="http://schemas.openxmlformats.org/drawingml/2006/main">
               <a:ext uri="{FF2B5EF4-FFF2-40B4-BE49-F238E27FC236}">
                 <a16:creationId xmlns:a16="http://schemas.microsoft.com/office/drawing/2014/main" id="{2AFEB79A-0D2D-4914-8366-FF25EA6EA53D}"/>
@@ -11745,7 +11745,7 @@
       </p:sp>
       <p:sp>
         <p:nvSpPr>
-          <p:cNvPr id="37" name="">
+          <p:cNvPr id="38" name="">
             <a:extLst xmlns:a="http://schemas.openxmlformats.org/drawingml/2006/main">
               <a:ext uri="{FF2B5EF4-FFF2-40B4-BE49-F238E27FC236}">
                 <a16:creationId xmlns:a16="http://schemas.microsoft.com/office/drawing/2014/main" id="{00C633E2-7FD0-4C8A-9ABC-D21AE2BD6800}"/>
@@ -11790,7 +11790,7 @@
       </p:sp>
       <p:sp>
         <p:nvSpPr>
-          <p:cNvPr id="38" name="">
+          <p:cNvPr id="39" name="">
             <a:extLst xmlns:a="http://schemas.openxmlformats.org/drawingml/2006/main">
               <a:ext uri="{FF2B5EF4-FFF2-40B4-BE49-F238E27FC236}">
                 <a16:creationId xmlns:a16="http://schemas.microsoft.com/office/drawing/2014/main" id="{B3312A7B-14B9-4FE2-865C-C6B12CDA1A6B}"/>
@@ -11858,7 +11858,7 @@
       </p:grpSpPr>
       <p:sp>
         <p:nvSpPr>
-          <p:cNvPr id="1" name="Slide Number Placeholder 5">
+          <p:cNvPr id="2" name="Slide Number Placeholder 5">
             <a:extLst xmlns:a="http://schemas.openxmlformats.org/drawingml/2006/main">
               <a:ext uri="{FF2B5EF4-FFF2-40B4-BE49-F238E27FC236}">
                 <a16:creationId xmlns:a16="http://schemas.microsoft.com/office/drawing/2014/main" id="{70659316-B4BB-42AA-9EDF-4B27092320CB}"/>
@@ -11890,7 +11890,7 @@
       </p:sp>
       <p:sp>
         <p:nvSpPr>
-          <p:cNvPr id="2" name="">
+          <p:cNvPr id="3" name="">
             <a:extLst xmlns:a="http://schemas.openxmlformats.org/drawingml/2006/main">
               <a:ext uri="{FF2B5EF4-FFF2-40B4-BE49-F238E27FC236}">
                 <a16:creationId xmlns:a16="http://schemas.microsoft.com/office/drawing/2014/main" id="{B43CEEB3-2022-4800-956C-D9DBAFDAA511}"/>
@@ -11922,7 +11922,7 @@
       </p:sp>
       <p:sp>
         <p:nvSpPr>
-          <p:cNvPr id="3" name="">
+          <p:cNvPr id="4" name="">
             <a:extLst xmlns:a="http://schemas.openxmlformats.org/drawingml/2006/main">
               <a:ext uri="{FF2B5EF4-FFF2-40B4-BE49-F238E27FC236}">
                 <a16:creationId xmlns:a16="http://schemas.microsoft.com/office/drawing/2014/main" id="{351D5334-B594-41B7-9D6A-1EF82D0DCAF3}"/>
@@ -11954,7 +11954,7 @@
       </p:sp>
       <p:sp>
         <p:nvSpPr>
-          <p:cNvPr id="4" name="">
+          <p:cNvPr id="5" name="">
             <a:extLst xmlns:a="http://schemas.openxmlformats.org/drawingml/2006/main">
               <a:ext uri="{FF2B5EF4-FFF2-40B4-BE49-F238E27FC236}">
                 <a16:creationId xmlns:a16="http://schemas.microsoft.com/office/drawing/2014/main" id="{B9592A1D-784E-46AE-828E-DD28929C88C9}"/>
@@ -11998,7 +11998,7 @@
       </p:sp>
       <p:sp>
         <p:nvSpPr>
-          <p:cNvPr id="5" name="">
+          <p:cNvPr id="6" name="">
             <a:extLst xmlns:a="http://schemas.openxmlformats.org/drawingml/2006/main">
               <a:ext uri="{FF2B5EF4-FFF2-40B4-BE49-F238E27FC236}">
                 <a16:creationId xmlns:a16="http://schemas.microsoft.com/office/drawing/2014/main" id="{C3B15A80-7969-46E4-96E9-E17F41DA8585}"/>
@@ -12044,7 +12044,7 @@
       </p:sp>
       <p:sp>
         <p:nvSpPr>
-          <p:cNvPr id="6" name="">
+          <p:cNvPr id="7" name="">
             <a:extLst xmlns:a="http://schemas.openxmlformats.org/drawingml/2006/main">
               <a:ext uri="{FF2B5EF4-FFF2-40B4-BE49-F238E27FC236}">
                 <a16:creationId xmlns:a16="http://schemas.microsoft.com/office/drawing/2014/main" id="{D31E771E-DE0C-4701-80C8-8431436C80F0}"/>
@@ -12090,7 +12090,7 @@
       </p:sp>
       <p:sp>
         <p:nvSpPr>
-          <p:cNvPr id="7" name="">
+          <p:cNvPr id="8" name="">
             <a:extLst xmlns:a="http://schemas.openxmlformats.org/drawingml/2006/main">
               <a:ext uri="{FF2B5EF4-FFF2-40B4-BE49-F238E27FC236}">
                 <a16:creationId xmlns:a16="http://schemas.microsoft.com/office/drawing/2014/main" id="{56905DE7-D30E-4363-899F-0D0BB331BE83}"/>
@@ -12122,7 +12122,7 @@
       </p:sp>
       <p:sp>
         <p:nvSpPr>
-          <p:cNvPr id="8" name="">
+          <p:cNvPr id="9" name="">
             <a:extLst xmlns:a="http://schemas.openxmlformats.org/drawingml/2006/main">
               <a:ext uri="{FF2B5EF4-FFF2-40B4-BE49-F238E27FC236}">
                 <a16:creationId xmlns:a16="http://schemas.microsoft.com/office/drawing/2014/main" id="{4453A15F-7CA6-4753-8255-1CEEF714805E}"/>
@@ -12166,7 +12166,7 @@
       </p:sp>
       <p:sp>
         <p:nvSpPr>
-          <p:cNvPr id="9" name="">
+          <p:cNvPr id="10" name="">
             <a:extLst xmlns:a="http://schemas.openxmlformats.org/drawingml/2006/main">
               <a:ext uri="{FF2B5EF4-FFF2-40B4-BE49-F238E27FC236}">
                 <a16:creationId xmlns:a16="http://schemas.microsoft.com/office/drawing/2014/main" id="{01BADA11-E585-4C36-BB15-45A3B471FFD4}"/>
@@ -12211,7 +12211,7 @@
       </p:sp>
       <p:sp>
         <p:nvSpPr>
-          <p:cNvPr id="10" name="">
+          <p:cNvPr id="11" name="">
             <a:extLst xmlns:a="http://schemas.openxmlformats.org/drawingml/2006/main">
               <a:ext uri="{FF2B5EF4-FFF2-40B4-BE49-F238E27FC236}">
                 <a16:creationId xmlns:a16="http://schemas.microsoft.com/office/drawing/2014/main" id="{C53776E1-37B2-40DD-A1DA-A774E86C34FB}"/>
@@ -12243,7 +12243,7 @@
       </p:sp>
       <p:sp>
         <p:nvSpPr>
-          <p:cNvPr id="11" name="">
+          <p:cNvPr id="12" name="">
             <a:extLst xmlns:a="http://schemas.openxmlformats.org/drawingml/2006/main">
               <a:ext uri="{FF2B5EF4-FFF2-40B4-BE49-F238E27FC236}">
                 <a16:creationId xmlns:a16="http://schemas.microsoft.com/office/drawing/2014/main" id="{5CB180F9-C792-4C38-973B-9737D0E9664C}"/>
@@ -12275,7 +12275,7 @@
       </p:sp>
       <p:sp>
         <p:nvSpPr>
-          <p:cNvPr id="12" name="">
+          <p:cNvPr id="13" name="">
             <a:extLst xmlns:a="http://schemas.openxmlformats.org/drawingml/2006/main">
               <a:ext uri="{FF2B5EF4-FFF2-40B4-BE49-F238E27FC236}">
                 <a16:creationId xmlns:a16="http://schemas.microsoft.com/office/drawing/2014/main" id="{0A5E0CEF-D7C2-4EA2-AA50-0704434DEC3B}"/>
@@ -12321,7 +12321,7 @@
       </p:sp>
       <p:sp>
         <p:nvSpPr>
-          <p:cNvPr id="13" name="">
+          <p:cNvPr id="14" name="">
             <a:extLst xmlns:a="http://schemas.openxmlformats.org/drawingml/2006/main">
               <a:ext uri="{FF2B5EF4-FFF2-40B4-BE49-F238E27FC236}">
                 <a16:creationId xmlns:a16="http://schemas.microsoft.com/office/drawing/2014/main" id="{BA5E8B7C-C73B-4F87-8BCB-E51A603FB9C4}"/>
@@ -12367,7 +12367,7 @@
       </p:sp>
       <p:sp>
         <p:nvSpPr>
-          <p:cNvPr id="14" name="">
+          <p:cNvPr id="15" name="">
             <a:extLst xmlns:a="http://schemas.openxmlformats.org/drawingml/2006/main">
               <a:ext uri="{FF2B5EF4-FFF2-40B4-BE49-F238E27FC236}">
                 <a16:creationId xmlns:a16="http://schemas.microsoft.com/office/drawing/2014/main" id="{ECB3CADD-E72C-4B6D-80A7-397A55F21B46}"/>
@@ -12399,7 +12399,7 @@
       </p:sp>
       <p:sp>
         <p:nvSpPr>
-          <p:cNvPr id="15" name="">
+          <p:cNvPr id="16" name="">
             <a:extLst xmlns:a="http://schemas.openxmlformats.org/drawingml/2006/main">
               <a:ext uri="{FF2B5EF4-FFF2-40B4-BE49-F238E27FC236}">
                 <a16:creationId xmlns:a16="http://schemas.microsoft.com/office/drawing/2014/main" id="{7978FD13-5465-4591-82EB-15B8779AB13C}"/>
@@ -12431,7 +12431,7 @@
       </p:sp>
       <p:sp>
         <p:nvSpPr>
-          <p:cNvPr id="16" name="">
+          <p:cNvPr id="17" name="">
             <a:extLst xmlns:a="http://schemas.openxmlformats.org/drawingml/2006/main">
               <a:ext uri="{FF2B5EF4-FFF2-40B4-BE49-F238E27FC236}">
                 <a16:creationId xmlns:a16="http://schemas.microsoft.com/office/drawing/2014/main" id="{6A44369E-2539-43C6-AC59-9C3CD44CD21A}"/>
@@ -12477,7 +12477,7 @@
       </p:sp>
       <p:sp>
         <p:nvSpPr>
-          <p:cNvPr id="17" name="">
+          <p:cNvPr id="18" name="">
             <a:extLst xmlns:a="http://schemas.openxmlformats.org/drawingml/2006/main">
               <a:ext uri="{FF2B5EF4-FFF2-40B4-BE49-F238E27FC236}">
                 <a16:creationId xmlns:a16="http://schemas.microsoft.com/office/drawing/2014/main" id="{7DEA98E5-79B8-44BA-9422-BD0700E747FD}"/>
@@ -12523,7 +12523,7 @@
       </p:sp>
       <p:sp>
         <p:nvSpPr>
-          <p:cNvPr id="18" name="">
+          <p:cNvPr id="19" name="">
             <a:extLst xmlns:a="http://schemas.openxmlformats.org/drawingml/2006/main">
               <a:ext uri="{FF2B5EF4-FFF2-40B4-BE49-F238E27FC236}">
                 <a16:creationId xmlns:a16="http://schemas.microsoft.com/office/drawing/2014/main" id="{CB51C744-3AC6-40A0-A0DD-9162462A019D}"/>
@@ -12555,7 +12555,7 @@
       </p:sp>
       <p:sp>
         <p:nvSpPr>
-          <p:cNvPr id="19" name="">
+          <p:cNvPr id="20" name="">
             <a:extLst xmlns:a="http://schemas.openxmlformats.org/drawingml/2006/main">
               <a:ext uri="{FF2B5EF4-FFF2-40B4-BE49-F238E27FC236}">
                 <a16:creationId xmlns:a16="http://schemas.microsoft.com/office/drawing/2014/main" id="{101CA639-2914-47ED-BCB4-CBC7CAC3A291}"/>
@@ -12587,7 +12587,7 @@
       </p:sp>
       <p:sp>
         <p:nvSpPr>
-          <p:cNvPr id="20" name="">
+          <p:cNvPr id="21" name="">
             <a:extLst xmlns:a="http://schemas.openxmlformats.org/drawingml/2006/main">
               <a:ext uri="{FF2B5EF4-FFF2-40B4-BE49-F238E27FC236}">
                 <a16:creationId xmlns:a16="http://schemas.microsoft.com/office/drawing/2014/main" id="{65B2EDF9-1FCB-4F11-A622-178A73BA916F}"/>
@@ -12633,7 +12633,7 @@
       </p:sp>
       <p:sp>
         <p:nvSpPr>
-          <p:cNvPr id="21" name="">
+          <p:cNvPr id="22" name="">
             <a:extLst xmlns:a="http://schemas.openxmlformats.org/drawingml/2006/main">
               <a:ext uri="{FF2B5EF4-FFF2-40B4-BE49-F238E27FC236}">
                 <a16:creationId xmlns:a16="http://schemas.microsoft.com/office/drawing/2014/main" id="{EAB68F82-A964-4B0D-868D-9EEBE78BE3B2}"/>
@@ -12679,7 +12679,7 @@
       </p:sp>
       <p:sp>
         <p:nvSpPr>
-          <p:cNvPr id="22" name="">
+          <p:cNvPr id="23" name="">
             <a:extLst xmlns:a="http://schemas.openxmlformats.org/drawingml/2006/main">
               <a:ext uri="{FF2B5EF4-FFF2-40B4-BE49-F238E27FC236}">
                 <a16:creationId xmlns:a16="http://schemas.microsoft.com/office/drawing/2014/main" id="{F9E9EC00-6B1D-4831-A5B1-8815508180C0}"/>
@@ -12711,7 +12711,7 @@
       </p:sp>
       <p:sp>
         <p:nvSpPr>
-          <p:cNvPr id="23" name="">
+          <p:cNvPr id="24" name="">
             <a:extLst xmlns:a="http://schemas.openxmlformats.org/drawingml/2006/main">
               <a:ext uri="{FF2B5EF4-FFF2-40B4-BE49-F238E27FC236}">
                 <a16:creationId xmlns:a16="http://schemas.microsoft.com/office/drawing/2014/main" id="{51F443B9-02B4-4151-9BCC-96EF5130D40D}"/>
@@ -12743,7 +12743,7 @@
       </p:sp>
       <p:sp>
         <p:nvSpPr>
-          <p:cNvPr id="24" name="">
+          <p:cNvPr id="25" name="">
             <a:extLst xmlns:a="http://schemas.openxmlformats.org/drawingml/2006/main">
               <a:ext uri="{FF2B5EF4-FFF2-40B4-BE49-F238E27FC236}">
                 <a16:creationId xmlns:a16="http://schemas.microsoft.com/office/drawing/2014/main" id="{C64365FC-727A-4C11-BC4B-860029088C89}"/>
@@ -12789,7 +12789,7 @@
       </p:sp>
       <p:sp>
         <p:nvSpPr>
-          <p:cNvPr id="25" name="">
+          <p:cNvPr id="26" name="">
             <a:extLst xmlns:a="http://schemas.openxmlformats.org/drawingml/2006/main">
               <a:ext uri="{FF2B5EF4-FFF2-40B4-BE49-F238E27FC236}">
                 <a16:creationId xmlns:a16="http://schemas.microsoft.com/office/drawing/2014/main" id="{9DD046B7-DB39-4A81-A583-B32ACC56CE80}"/>
@@ -12857,7 +12857,7 @@
       </p:grpSpPr>
       <p:sp>
         <p:nvSpPr>
-          <p:cNvPr id="1" name="Slide Number Placeholder 5">
+          <p:cNvPr id="2" name="Slide Number Placeholder 5">
             <a:extLst xmlns:a="http://schemas.openxmlformats.org/drawingml/2006/main">
               <a:ext uri="{FF2B5EF4-FFF2-40B4-BE49-F238E27FC236}">
                 <a16:creationId xmlns:a16="http://schemas.microsoft.com/office/drawing/2014/main" id="{70659316-B4BB-42AA-9EDF-4B27092320CB}"/>
@@ -12889,7 +12889,7 @@
       </p:sp>
       <p:sp>
         <p:nvSpPr>
-          <p:cNvPr id="2" name="">
+          <p:cNvPr id="3" name="">
             <a:extLst xmlns:a="http://schemas.openxmlformats.org/drawingml/2006/main">
               <a:ext uri="{FF2B5EF4-FFF2-40B4-BE49-F238E27FC236}">
                 <a16:creationId xmlns:a16="http://schemas.microsoft.com/office/drawing/2014/main" id="{EB598B76-D6AA-40DC-BC26-8E6C85644C5D}"/>
@@ -12921,7 +12921,7 @@
       </p:sp>
       <p:sp>
         <p:nvSpPr>
-          <p:cNvPr id="3" name="">
+          <p:cNvPr id="4" name="">
             <a:extLst xmlns:a="http://schemas.openxmlformats.org/drawingml/2006/main">
               <a:ext uri="{FF2B5EF4-FFF2-40B4-BE49-F238E27FC236}">
                 <a16:creationId xmlns:a16="http://schemas.microsoft.com/office/drawing/2014/main" id="{0D491AED-4182-462A-924F-F99F7911A2A4}"/>
@@ -12953,7 +12953,7 @@
       </p:sp>
       <p:sp>
         <p:nvSpPr>
-          <p:cNvPr id="4" name="">
+          <p:cNvPr id="5" name="">
             <a:extLst xmlns:a="http://schemas.openxmlformats.org/drawingml/2006/main">
               <a:ext uri="{FF2B5EF4-FFF2-40B4-BE49-F238E27FC236}">
                 <a16:creationId xmlns:a16="http://schemas.microsoft.com/office/drawing/2014/main" id="{8C4A9B7D-BA48-4CAE-9EE8-62900753B1EB}"/>
@@ -12997,7 +12997,7 @@
       </p:sp>
       <p:sp>
         <p:nvSpPr>
-          <p:cNvPr id="5" name="">
+          <p:cNvPr id="6" name="">
             <a:extLst xmlns:a="http://schemas.openxmlformats.org/drawingml/2006/main">
               <a:ext uri="{FF2B5EF4-FFF2-40B4-BE49-F238E27FC236}">
                 <a16:creationId xmlns:a16="http://schemas.microsoft.com/office/drawing/2014/main" id="{58315B37-1D3A-467C-8F2F-0695EF49E0E1}"/>
@@ -13043,7 +13043,7 @@
       </p:sp>
       <p:sp>
         <p:nvSpPr>
-          <p:cNvPr id="6" name="">
+          <p:cNvPr id="7" name="">
             <a:extLst xmlns:a="http://schemas.openxmlformats.org/drawingml/2006/main">
               <a:ext uri="{FF2B5EF4-FFF2-40B4-BE49-F238E27FC236}">
                 <a16:creationId xmlns:a16="http://schemas.microsoft.com/office/drawing/2014/main" id="{FB812A1C-082E-478D-AAAE-D853C5A92490}"/>
@@ -13089,7 +13089,7 @@
       </p:sp>
       <p:sp>
         <p:nvSpPr>
-          <p:cNvPr id="7" name="">
+          <p:cNvPr id="8" name="">
             <a:extLst xmlns:a="http://schemas.openxmlformats.org/drawingml/2006/main">
               <a:ext uri="{FF2B5EF4-FFF2-40B4-BE49-F238E27FC236}">
                 <a16:creationId xmlns:a16="http://schemas.microsoft.com/office/drawing/2014/main" id="{9C4C1E08-18A3-49F4-A4F3-1D228648575E}"/>
@@ -13121,7 +13121,7 @@
       </p:sp>
       <p:sp>
         <p:nvSpPr>
-          <p:cNvPr id="8" name="">
+          <p:cNvPr id="9" name="">
             <a:extLst xmlns:a="http://schemas.openxmlformats.org/drawingml/2006/main">
               <a:ext uri="{FF2B5EF4-FFF2-40B4-BE49-F238E27FC236}">
                 <a16:creationId xmlns:a16="http://schemas.microsoft.com/office/drawing/2014/main" id="{DC2A2CB0-6278-42F8-B842-B106F4EC1F27}"/>
@@ -13165,7 +13165,7 @@
       </p:sp>
       <p:sp>
         <p:nvSpPr>
-          <p:cNvPr id="9" name="">
+          <p:cNvPr id="10" name="">
             <a:extLst xmlns:a="http://schemas.openxmlformats.org/drawingml/2006/main">
               <a:ext uri="{FF2B5EF4-FFF2-40B4-BE49-F238E27FC236}">
                 <a16:creationId xmlns:a16="http://schemas.microsoft.com/office/drawing/2014/main" id="{B460D2F7-1954-4364-B995-39F3A539C961}"/>
@@ -13210,7 +13210,7 @@
       </p:sp>
       <p:sp>
         <p:nvSpPr>
-          <p:cNvPr id="10" name="">
+          <p:cNvPr id="11" name="">
             <a:extLst xmlns:a="http://schemas.openxmlformats.org/drawingml/2006/main">
               <a:ext uri="{FF2B5EF4-FFF2-40B4-BE49-F238E27FC236}">
                 <a16:creationId xmlns:a16="http://schemas.microsoft.com/office/drawing/2014/main" id="{F579EEF7-460A-46CF-9295-DE2AA9ED1B5E}"/>
@@ -13242,7 +13242,7 @@
       </p:sp>
       <p:sp>
         <p:nvSpPr>
-          <p:cNvPr id="11" name="">
+          <p:cNvPr id="12" name="">
             <a:extLst xmlns:a="http://schemas.openxmlformats.org/drawingml/2006/main">
               <a:ext uri="{FF2B5EF4-FFF2-40B4-BE49-F238E27FC236}">
                 <a16:creationId xmlns:a16="http://schemas.microsoft.com/office/drawing/2014/main" id="{00179D88-510C-450A-BF7F-F7853E28CBD8}"/>
@@ -13288,7 +13288,7 @@
       </p:sp>
       <p:sp>
         <p:nvSpPr>
-          <p:cNvPr id="12" name="">
+          <p:cNvPr id="13" name="">
             <a:extLst xmlns:a="http://schemas.openxmlformats.org/drawingml/2006/main">
               <a:ext uri="{FF2B5EF4-FFF2-40B4-BE49-F238E27FC236}">
                 <a16:creationId xmlns:a16="http://schemas.microsoft.com/office/drawing/2014/main" id="{6BCC59AC-0566-4CAA-B4D3-1BC5105C1BA4}"/>
@@ -13320,7 +13320,7 @@
       </p:sp>
       <p:sp>
         <p:nvSpPr>
-          <p:cNvPr id="13" name="">
+          <p:cNvPr id="14" name="">
             <a:extLst xmlns:a="http://schemas.openxmlformats.org/drawingml/2006/main">
               <a:ext uri="{FF2B5EF4-FFF2-40B4-BE49-F238E27FC236}">
                 <a16:creationId xmlns:a16="http://schemas.microsoft.com/office/drawing/2014/main" id="{22450E83-D043-4CBD-A895-DF194D9B9741}"/>
@@ -13366,7 +13366,7 @@
       </p:sp>
       <p:sp>
         <p:nvSpPr>
-          <p:cNvPr id="14" name="">
+          <p:cNvPr id="15" name="">
             <a:extLst xmlns:a="http://schemas.openxmlformats.org/drawingml/2006/main">
               <a:ext uri="{FF2B5EF4-FFF2-40B4-BE49-F238E27FC236}">
                 <a16:creationId xmlns:a16="http://schemas.microsoft.com/office/drawing/2014/main" id="{C44ADFB7-F7B7-45DE-9D3A-7BE355ECD8F3}"/>
@@ -13398,7 +13398,7 @@
       </p:sp>
       <p:sp>
         <p:nvSpPr>
-          <p:cNvPr id="15" name="">
+          <p:cNvPr id="16" name="">
             <a:extLst xmlns:a="http://schemas.openxmlformats.org/drawingml/2006/main">
               <a:ext uri="{FF2B5EF4-FFF2-40B4-BE49-F238E27FC236}">
                 <a16:creationId xmlns:a16="http://schemas.microsoft.com/office/drawing/2014/main" id="{2DCF9AF8-97A3-434F-9E2F-4D42C6997689}"/>
@@ -13444,7 +13444,7 @@
       </p:sp>
       <p:sp>
         <p:nvSpPr>
-          <p:cNvPr id="16" name="">
+          <p:cNvPr id="17" name="">
             <a:extLst xmlns:a="http://schemas.openxmlformats.org/drawingml/2006/main">
               <a:ext uri="{FF2B5EF4-FFF2-40B4-BE49-F238E27FC236}">
                 <a16:creationId xmlns:a16="http://schemas.microsoft.com/office/drawing/2014/main" id="{834DB99E-47D7-467C-B648-42051F161095}"/>
@@ -13476,7 +13476,7 @@
       </p:sp>
       <p:sp>
         <p:nvSpPr>
-          <p:cNvPr id="17" name="">
+          <p:cNvPr id="18" name="">
             <a:extLst xmlns:a="http://schemas.openxmlformats.org/drawingml/2006/main">
               <a:ext uri="{FF2B5EF4-FFF2-40B4-BE49-F238E27FC236}">
                 <a16:creationId xmlns:a16="http://schemas.microsoft.com/office/drawing/2014/main" id="{CBA15EF5-3E0C-4A8F-A260-9B09AA6F9B47}"/>
@@ -13522,7 +13522,7 @@
       </p:sp>
       <p:sp>
         <p:nvSpPr>
-          <p:cNvPr id="18" name="">
+          <p:cNvPr id="19" name="">
             <a:extLst xmlns:a="http://schemas.openxmlformats.org/drawingml/2006/main">
               <a:ext uri="{FF2B5EF4-FFF2-40B4-BE49-F238E27FC236}">
                 <a16:creationId xmlns:a16="http://schemas.microsoft.com/office/drawing/2014/main" id="{E3226A70-201A-488A-BBB2-DBD3447A3341}"/>
@@ -13554,7 +13554,7 @@
       </p:sp>
       <p:sp>
         <p:nvSpPr>
-          <p:cNvPr id="19" name="">
+          <p:cNvPr id="20" name="">
             <a:extLst xmlns:a="http://schemas.openxmlformats.org/drawingml/2006/main">
               <a:ext uri="{FF2B5EF4-FFF2-40B4-BE49-F238E27FC236}">
                 <a16:creationId xmlns:a16="http://schemas.microsoft.com/office/drawing/2014/main" id="{C3D4CE7F-6C2F-463F-9524-A6E075E45962}"/>
@@ -13600,7 +13600,7 @@
       </p:sp>
       <p:sp>
         <p:nvSpPr>
-          <p:cNvPr id="20" name="">
+          <p:cNvPr id="21" name="">
             <a:extLst xmlns:a="http://schemas.openxmlformats.org/drawingml/2006/main">
               <a:ext uri="{FF2B5EF4-FFF2-40B4-BE49-F238E27FC236}">
                 <a16:creationId xmlns:a16="http://schemas.microsoft.com/office/drawing/2014/main" id="{578EAF15-94F2-4D0C-8FC0-ACE86E04DA08}"/>
@@ -13632,7 +13632,7 @@
       </p:sp>
       <p:sp>
         <p:nvSpPr>
-          <p:cNvPr id="21" name="">
+          <p:cNvPr id="22" name="">
             <a:extLst xmlns:a="http://schemas.openxmlformats.org/drawingml/2006/main">
               <a:ext uri="{FF2B5EF4-FFF2-40B4-BE49-F238E27FC236}">
                 <a16:creationId xmlns:a16="http://schemas.microsoft.com/office/drawing/2014/main" id="{0EB0218A-8E87-4F68-8DC8-7595001BBDC4}"/>
@@ -13701,7 +13701,7 @@
       </p:grpSpPr>
       <p:sp>
         <p:nvSpPr>
-          <p:cNvPr id="1" name="Slide Number Placeholder 5">
+          <p:cNvPr id="2" name="Slide Number Placeholder 5">
             <a:extLst xmlns:a="http://schemas.openxmlformats.org/drawingml/2006/main">
               <a:ext uri="{FF2B5EF4-FFF2-40B4-BE49-F238E27FC236}">
                 <a16:creationId xmlns:a16="http://schemas.microsoft.com/office/drawing/2014/main" id="{70659316-B4BB-42AA-9EDF-4B27092320CB}"/>
@@ -13733,7 +13733,7 @@
       </p:sp>
       <p:sp>
         <p:nvSpPr>
-          <p:cNvPr id="2" name="">
+          <p:cNvPr id="3" name="">
             <a:extLst xmlns:a="http://schemas.openxmlformats.org/drawingml/2006/main">
               <a:ext uri="{FF2B5EF4-FFF2-40B4-BE49-F238E27FC236}">
                 <a16:creationId xmlns:a16="http://schemas.microsoft.com/office/drawing/2014/main" id="{149AEDD8-F810-4DB6-8477-3D2C59D56F68}"/>
@@ -13765,7 +13765,7 @@
       </p:sp>
       <p:sp>
         <p:nvSpPr>
-          <p:cNvPr id="3" name="">
+          <p:cNvPr id="4" name="">
             <a:extLst xmlns:a="http://schemas.openxmlformats.org/drawingml/2006/main">
               <a:ext uri="{FF2B5EF4-FFF2-40B4-BE49-F238E27FC236}">
                 <a16:creationId xmlns:a16="http://schemas.microsoft.com/office/drawing/2014/main" id="{79287009-FDFB-4D0A-B980-9D4284D1AB8E}"/>
@@ -13797,7 +13797,7 @@
       </p:sp>
       <p:sp>
         <p:nvSpPr>
-          <p:cNvPr id="4" name="">
+          <p:cNvPr id="5" name="">
             <a:extLst xmlns:a="http://schemas.openxmlformats.org/drawingml/2006/main">
               <a:ext uri="{FF2B5EF4-FFF2-40B4-BE49-F238E27FC236}">
                 <a16:creationId xmlns:a16="http://schemas.microsoft.com/office/drawing/2014/main" id="{9C70C04F-05F4-4C93-8FC2-9C95DB22258A}"/>
@@ -13841,7 +13841,7 @@
       </p:sp>
       <p:sp>
         <p:nvSpPr>
-          <p:cNvPr id="5" name="">
+          <p:cNvPr id="6" name="">
             <a:extLst xmlns:a="http://schemas.openxmlformats.org/drawingml/2006/main">
               <a:ext uri="{FF2B5EF4-FFF2-40B4-BE49-F238E27FC236}">
                 <a16:creationId xmlns:a16="http://schemas.microsoft.com/office/drawing/2014/main" id="{576A218F-ABEA-4C2F-9A21-E351A99EB672}"/>
@@ -13887,7 +13887,7 @@
       </p:sp>
       <p:sp>
         <p:nvSpPr>
-          <p:cNvPr id="6" name="">
+          <p:cNvPr id="7" name="">
             <a:extLst xmlns:a="http://schemas.openxmlformats.org/drawingml/2006/main">
               <a:ext uri="{FF2B5EF4-FFF2-40B4-BE49-F238E27FC236}">
                 <a16:creationId xmlns:a16="http://schemas.microsoft.com/office/drawing/2014/main" id="{E9671DE2-A980-4D7E-B300-6B94839452D9}"/>
@@ -13933,7 +13933,7 @@
       </p:sp>
       <p:sp>
         <p:nvSpPr>
-          <p:cNvPr id="7" name="">
+          <p:cNvPr id="8" name="">
             <a:extLst xmlns:a="http://schemas.openxmlformats.org/drawingml/2006/main">
               <a:ext uri="{FF2B5EF4-FFF2-40B4-BE49-F238E27FC236}">
                 <a16:creationId xmlns:a16="http://schemas.microsoft.com/office/drawing/2014/main" id="{FEDAEC3D-7F32-4DBF-844A-7F847F4D517F}"/>
@@ -13965,7 +13965,7 @@
       </p:sp>
       <p:sp>
         <p:nvSpPr>
-          <p:cNvPr id="8" name="">
+          <p:cNvPr id="9" name="">
             <a:extLst xmlns:a="http://schemas.openxmlformats.org/drawingml/2006/main">
               <a:ext uri="{FF2B5EF4-FFF2-40B4-BE49-F238E27FC236}">
                 <a16:creationId xmlns:a16="http://schemas.microsoft.com/office/drawing/2014/main" id="{5C112E25-AA66-4627-A2EA-5D33C68D73AB}"/>
@@ -14009,7 +14009,7 @@
       </p:sp>
       <p:sp>
         <p:nvSpPr>
-          <p:cNvPr id="9" name="">
+          <p:cNvPr id="10" name="">
             <a:extLst xmlns:a="http://schemas.openxmlformats.org/drawingml/2006/main">
               <a:ext uri="{FF2B5EF4-FFF2-40B4-BE49-F238E27FC236}">
                 <a16:creationId xmlns:a16="http://schemas.microsoft.com/office/drawing/2014/main" id="{CCCABE79-C742-4FE5-A98E-BBD645DFA68E}"/>
@@ -14054,7 +14054,7 @@
       </p:sp>
       <p:sp>
         <p:nvSpPr>
-          <p:cNvPr id="10" name="">
+          <p:cNvPr id="11" name="">
             <a:extLst xmlns:a="http://schemas.openxmlformats.org/drawingml/2006/main">
               <a:ext uri="{FF2B5EF4-FFF2-40B4-BE49-F238E27FC236}">
                 <a16:creationId xmlns:a16="http://schemas.microsoft.com/office/drawing/2014/main" id="{001B6364-C0D8-4FAD-8A91-65636419D256}"/>
@@ -14086,7 +14086,7 @@
       </p:sp>
       <p:sp>
         <p:nvSpPr>
-          <p:cNvPr id="11" name="">
+          <p:cNvPr id="12" name="">
             <a:extLst xmlns:a="http://schemas.openxmlformats.org/drawingml/2006/main">
               <a:ext uri="{FF2B5EF4-FFF2-40B4-BE49-F238E27FC236}">
                 <a16:creationId xmlns:a16="http://schemas.microsoft.com/office/drawing/2014/main" id="{EBDEFD7D-7837-490A-B5DE-BBD36379AFAC}"/>
@@ -14118,7 +14118,7 @@
       </p:sp>
       <p:sp>
         <p:nvSpPr>
-          <p:cNvPr id="12" name="">
+          <p:cNvPr id="13" name="">
             <a:extLst xmlns:a="http://schemas.openxmlformats.org/drawingml/2006/main">
               <a:ext uri="{FF2B5EF4-FFF2-40B4-BE49-F238E27FC236}">
                 <a16:creationId xmlns:a16="http://schemas.microsoft.com/office/drawing/2014/main" id="{7EE72AF0-7436-432B-B6E0-6F4C7C31F392}"/>
@@ -14164,7 +14164,7 @@
       </p:sp>
       <p:sp>
         <p:nvSpPr>
-          <p:cNvPr id="13" name="">
+          <p:cNvPr id="14" name="">
             <a:extLst xmlns:a="http://schemas.openxmlformats.org/drawingml/2006/main">
               <a:ext uri="{FF2B5EF4-FFF2-40B4-BE49-F238E27FC236}">
                 <a16:creationId xmlns:a16="http://schemas.microsoft.com/office/drawing/2014/main" id="{03FCDBE5-0F97-4BEF-9A83-C950E286596A}"/>
@@ -14210,7 +14210,7 @@
       </p:sp>
       <p:sp>
         <p:nvSpPr>
-          <p:cNvPr id="14" name="">
+          <p:cNvPr id="15" name="">
             <a:extLst xmlns:a="http://schemas.openxmlformats.org/drawingml/2006/main">
               <a:ext uri="{FF2B5EF4-FFF2-40B4-BE49-F238E27FC236}">
                 <a16:creationId xmlns:a16="http://schemas.microsoft.com/office/drawing/2014/main" id="{B45473AF-C33B-45F7-AF94-B6DF33487BB7}"/>
@@ -14242,7 +14242,7 @@
       </p:sp>
       <p:sp>
         <p:nvSpPr>
-          <p:cNvPr id="15" name="">
+          <p:cNvPr id="16" name="">
             <a:extLst xmlns:a="http://schemas.openxmlformats.org/drawingml/2006/main">
               <a:ext uri="{FF2B5EF4-FFF2-40B4-BE49-F238E27FC236}">
                 <a16:creationId xmlns:a16="http://schemas.microsoft.com/office/drawing/2014/main" id="{0DC451E4-0001-487A-9469-FDFE3E19A22C}"/>
@@ -14274,7 +14274,7 @@
       </p:sp>
       <p:sp>
         <p:nvSpPr>
-          <p:cNvPr id="16" name="">
+          <p:cNvPr id="17" name="">
             <a:extLst xmlns:a="http://schemas.openxmlformats.org/drawingml/2006/main">
               <a:ext uri="{FF2B5EF4-FFF2-40B4-BE49-F238E27FC236}">
                 <a16:creationId xmlns:a16="http://schemas.microsoft.com/office/drawing/2014/main" id="{79F65D95-A474-405D-B14F-6B0F825C92DE}"/>
@@ -14320,7 +14320,7 @@
       </p:sp>
       <p:sp>
         <p:nvSpPr>
-          <p:cNvPr id="17" name="">
+          <p:cNvPr id="18" name="">
             <a:extLst xmlns:a="http://schemas.openxmlformats.org/drawingml/2006/main">
               <a:ext uri="{FF2B5EF4-FFF2-40B4-BE49-F238E27FC236}">
                 <a16:creationId xmlns:a16="http://schemas.microsoft.com/office/drawing/2014/main" id="{0897DD10-6367-48DA-8A84-1C6A649A66FC}"/>
@@ -14366,7 +14366,7 @@
       </p:sp>
       <p:sp>
         <p:nvSpPr>
-          <p:cNvPr id="18" name="">
+          <p:cNvPr id="19" name="">
             <a:extLst xmlns:a="http://schemas.openxmlformats.org/drawingml/2006/main">
               <a:ext uri="{FF2B5EF4-FFF2-40B4-BE49-F238E27FC236}">
                 <a16:creationId xmlns:a16="http://schemas.microsoft.com/office/drawing/2014/main" id="{4E8A9AE1-1F88-4090-8599-9044E928FC09}"/>
@@ -14398,7 +14398,7 @@
       </p:sp>
       <p:sp>
         <p:nvSpPr>
-          <p:cNvPr id="19" name="">
+          <p:cNvPr id="20" name="">
             <a:extLst xmlns:a="http://schemas.openxmlformats.org/drawingml/2006/main">
               <a:ext uri="{FF2B5EF4-FFF2-40B4-BE49-F238E27FC236}">
                 <a16:creationId xmlns:a16="http://schemas.microsoft.com/office/drawing/2014/main" id="{AAAE4164-DEDA-42C3-9D34-24F880C3E081}"/>
@@ -14430,7 +14430,7 @@
       </p:sp>
       <p:sp>
         <p:nvSpPr>
-          <p:cNvPr id="20" name="">
+          <p:cNvPr id="21" name="">
             <a:extLst xmlns:a="http://schemas.openxmlformats.org/drawingml/2006/main">
               <a:ext uri="{FF2B5EF4-FFF2-40B4-BE49-F238E27FC236}">
                 <a16:creationId xmlns:a16="http://schemas.microsoft.com/office/drawing/2014/main" id="{CE012C78-DD04-4CD4-A522-1669954EF5A6}"/>
@@ -14476,7 +14476,7 @@
       </p:sp>
       <p:sp>
         <p:nvSpPr>
-          <p:cNvPr id="21" name="">
+          <p:cNvPr id="22" name="">
             <a:extLst xmlns:a="http://schemas.openxmlformats.org/drawingml/2006/main">
               <a:ext uri="{FF2B5EF4-FFF2-40B4-BE49-F238E27FC236}">
                 <a16:creationId xmlns:a16="http://schemas.microsoft.com/office/drawing/2014/main" id="{9E29994B-8064-40BE-9662-FDC7A2CB8DD4}"/>
@@ -14522,7 +14522,7 @@
       </p:sp>
       <p:sp>
         <p:nvSpPr>
-          <p:cNvPr id="22" name="">
+          <p:cNvPr id="23" name="">
             <a:extLst xmlns:a="http://schemas.openxmlformats.org/drawingml/2006/main">
               <a:ext uri="{FF2B5EF4-FFF2-40B4-BE49-F238E27FC236}">
                 <a16:creationId xmlns:a16="http://schemas.microsoft.com/office/drawing/2014/main" id="{ED369B82-32BA-4ADB-BBA4-DEE6F7DC9D77}"/>
@@ -14566,7 +14566,7 @@
       </p:sp>
       <p:sp>
         <p:nvSpPr>
-          <p:cNvPr id="23" name="">
+          <p:cNvPr id="24" name="">
             <a:extLst xmlns:a="http://schemas.openxmlformats.org/drawingml/2006/main">
               <a:ext uri="{FF2B5EF4-FFF2-40B4-BE49-F238E27FC236}">
                 <a16:creationId xmlns:a16="http://schemas.microsoft.com/office/drawing/2014/main" id="{F806B5C2-E0B6-4D15-AC88-2BB76787B652}"/>
@@ -14598,7 +14598,7 @@
       </p:sp>
       <p:sp>
         <p:nvSpPr>
-          <p:cNvPr id="24" name="">
+          <p:cNvPr id="25" name="">
             <a:extLst xmlns:a="http://schemas.openxmlformats.org/drawingml/2006/main">
               <a:ext uri="{FF2B5EF4-FFF2-40B4-BE49-F238E27FC236}">
                 <a16:creationId xmlns:a16="http://schemas.microsoft.com/office/drawing/2014/main" id="{E143D071-A2B9-4085-8B0A-4135CDE2AD81}"/>
@@ -14644,7 +14644,7 @@
       </p:sp>
       <p:sp>
         <p:nvSpPr>
-          <p:cNvPr id="25" name="">
+          <p:cNvPr id="26" name="">
             <a:extLst xmlns:a="http://schemas.openxmlformats.org/drawingml/2006/main">
               <a:ext uri="{FF2B5EF4-FFF2-40B4-BE49-F238E27FC236}">
                 <a16:creationId xmlns:a16="http://schemas.microsoft.com/office/drawing/2014/main" id="{86C7E719-566E-47CD-8F52-993EBCC394D1}"/>
@@ -14676,7 +14676,7 @@
       </p:sp>
       <p:sp>
         <p:nvSpPr>
-          <p:cNvPr id="26" name="">
+          <p:cNvPr id="27" name="">
             <a:extLst xmlns:a="http://schemas.openxmlformats.org/drawingml/2006/main">
               <a:ext uri="{FF2B5EF4-FFF2-40B4-BE49-F238E27FC236}">
                 <a16:creationId xmlns:a16="http://schemas.microsoft.com/office/drawing/2014/main" id="{D5C3FD7F-D27C-4E84-84E3-BBA295D53D9D}"/>
@@ -14722,7 +14722,7 @@
       </p:sp>
       <p:sp>
         <p:nvSpPr>
-          <p:cNvPr id="27" name="">
+          <p:cNvPr id="28" name="">
             <a:extLst xmlns:a="http://schemas.openxmlformats.org/drawingml/2006/main">
               <a:ext uri="{FF2B5EF4-FFF2-40B4-BE49-F238E27FC236}">
                 <a16:creationId xmlns:a16="http://schemas.microsoft.com/office/drawing/2014/main" id="{DED7DC92-B969-416D-A380-38D3D443D4FD}"/>
@@ -14754,7 +14754,7 @@
       </p:sp>
       <p:sp>
         <p:nvSpPr>
-          <p:cNvPr id="28" name="">
+          <p:cNvPr id="29" name="">
             <a:extLst xmlns:a="http://schemas.openxmlformats.org/drawingml/2006/main">
               <a:ext uri="{FF2B5EF4-FFF2-40B4-BE49-F238E27FC236}">
                 <a16:creationId xmlns:a16="http://schemas.microsoft.com/office/drawing/2014/main" id="{E4867EE7-FC1C-4080-9F0D-98E2B03BF0E8}"/>
@@ -14822,7 +14822,7 @@
       </p:grpSpPr>
       <p:sp>
         <p:nvSpPr>
-          <p:cNvPr id="1" name="Slide Number Placeholder 5">
+          <p:cNvPr id="2" name="Slide Number Placeholder 5">
             <a:extLst xmlns:a="http://schemas.openxmlformats.org/drawingml/2006/main">
               <a:ext uri="{FF2B5EF4-FFF2-40B4-BE49-F238E27FC236}">
                 <a16:creationId xmlns:a16="http://schemas.microsoft.com/office/drawing/2014/main" id="{70659316-B4BB-42AA-9EDF-4B27092320CB}"/>
@@ -14854,7 +14854,7 @@
       </p:sp>
       <p:sp>
         <p:nvSpPr>
-          <p:cNvPr id="2" name="">
+          <p:cNvPr id="3" name="">
             <a:extLst xmlns:a="http://schemas.openxmlformats.org/drawingml/2006/main">
               <a:ext uri="{FF2B5EF4-FFF2-40B4-BE49-F238E27FC236}">
                 <a16:creationId xmlns:a16="http://schemas.microsoft.com/office/drawing/2014/main" id="{7A6FFF54-F960-4E94-8541-37FC8366B419}"/>
@@ -14886,7 +14886,7 @@
       </p:sp>
       <p:sp>
         <p:nvSpPr>
-          <p:cNvPr id="3" name="">
+          <p:cNvPr id="4" name="">
             <a:extLst xmlns:a="http://schemas.openxmlformats.org/drawingml/2006/main">
               <a:ext uri="{FF2B5EF4-FFF2-40B4-BE49-F238E27FC236}">
                 <a16:creationId xmlns:a16="http://schemas.microsoft.com/office/drawing/2014/main" id="{A48A8D02-066E-4303-BE38-EE82A799E9F2}"/>
@@ -14918,7 +14918,7 @@
       </p:sp>
       <p:sp>
         <p:nvSpPr>
-          <p:cNvPr id="4" name="">
+          <p:cNvPr id="5" name="">
             <a:extLst xmlns:a="http://schemas.openxmlformats.org/drawingml/2006/main">
               <a:ext uri="{FF2B5EF4-FFF2-40B4-BE49-F238E27FC236}">
                 <a16:creationId xmlns:a16="http://schemas.microsoft.com/office/drawing/2014/main" id="{145D9C1B-33F6-4465-A5CC-77848EFF80E5}"/>
@@ -14962,7 +14962,7 @@
       </p:sp>
       <p:sp>
         <p:nvSpPr>
-          <p:cNvPr id="5" name="">
+          <p:cNvPr id="6" name="">
             <a:extLst xmlns:a="http://schemas.openxmlformats.org/drawingml/2006/main">
               <a:ext uri="{FF2B5EF4-FFF2-40B4-BE49-F238E27FC236}">
                 <a16:creationId xmlns:a16="http://schemas.microsoft.com/office/drawing/2014/main" id="{BE3B5A75-C763-49B6-B3EA-AAE41B8034B8}"/>
@@ -15008,7 +15008,7 @@
       </p:sp>
       <p:sp>
         <p:nvSpPr>
-          <p:cNvPr id="6" name="">
+          <p:cNvPr id="7" name="">
             <a:extLst xmlns:a="http://schemas.openxmlformats.org/drawingml/2006/main">
               <a:ext uri="{FF2B5EF4-FFF2-40B4-BE49-F238E27FC236}">
                 <a16:creationId xmlns:a16="http://schemas.microsoft.com/office/drawing/2014/main" id="{F0C2F911-2D46-4E5E-8161-663A8888708F}"/>
@@ -15054,7 +15054,7 @@
       </p:sp>
       <p:sp>
         <p:nvSpPr>
-          <p:cNvPr id="7" name="">
+          <p:cNvPr id="8" name="">
             <a:extLst xmlns:a="http://schemas.openxmlformats.org/drawingml/2006/main">
               <a:ext uri="{FF2B5EF4-FFF2-40B4-BE49-F238E27FC236}">
                 <a16:creationId xmlns:a16="http://schemas.microsoft.com/office/drawing/2014/main" id="{C717FE5D-01EA-4B36-929B-09063A1A6731}"/>
@@ -15086,7 +15086,7 @@
       </p:sp>
       <p:sp>
         <p:nvSpPr>
-          <p:cNvPr id="8" name="">
+          <p:cNvPr id="9" name="">
             <a:extLst xmlns:a="http://schemas.openxmlformats.org/drawingml/2006/main">
               <a:ext uri="{FF2B5EF4-FFF2-40B4-BE49-F238E27FC236}">
                 <a16:creationId xmlns:a16="http://schemas.microsoft.com/office/drawing/2014/main" id="{7E8D5CB0-9D5B-4A37-84D7-E91119BB3953}"/>
@@ -15130,7 +15130,7 @@
       </p:sp>
       <p:sp>
         <p:nvSpPr>
-          <p:cNvPr id="9" name="">
+          <p:cNvPr id="10" name="">
             <a:extLst xmlns:a="http://schemas.openxmlformats.org/drawingml/2006/main">
               <a:ext uri="{FF2B5EF4-FFF2-40B4-BE49-F238E27FC236}">
                 <a16:creationId xmlns:a16="http://schemas.microsoft.com/office/drawing/2014/main" id="{64E064A7-7BA1-4CA4-AF36-624B91A8D38E}"/>
@@ -15175,7 +15175,7 @@
       </p:sp>
       <p:sp>
         <p:nvSpPr>
-          <p:cNvPr id="10" name="">
+          <p:cNvPr id="11" name="">
             <a:extLst xmlns:a="http://schemas.openxmlformats.org/drawingml/2006/main">
               <a:ext uri="{FF2B5EF4-FFF2-40B4-BE49-F238E27FC236}">
                 <a16:creationId xmlns:a16="http://schemas.microsoft.com/office/drawing/2014/main" id="{D870D203-A283-4D08-A3A6-CFCFDD34A91B}"/>
@@ -15207,7 +15207,7 @@
       </p:sp>
       <p:sp>
         <p:nvSpPr>
-          <p:cNvPr id="11" name="">
+          <p:cNvPr id="12" name="">
             <a:extLst xmlns:a="http://schemas.openxmlformats.org/drawingml/2006/main">
               <a:ext uri="{FF2B5EF4-FFF2-40B4-BE49-F238E27FC236}">
                 <a16:creationId xmlns:a16="http://schemas.microsoft.com/office/drawing/2014/main" id="{44801DCC-31E8-4DF7-B290-F382FF32C5A4}"/>
@@ -15251,7 +15251,7 @@
       </p:sp>
       <p:sp>
         <p:nvSpPr>
-          <p:cNvPr id="12" name="">
+          <p:cNvPr id="13" name="">
             <a:extLst xmlns:a="http://schemas.openxmlformats.org/drawingml/2006/main">
               <a:ext uri="{FF2B5EF4-FFF2-40B4-BE49-F238E27FC236}">
                 <a16:creationId xmlns:a16="http://schemas.microsoft.com/office/drawing/2014/main" id="{1D3DFE1F-5992-423F-BC1E-1BD5FB99F515}"/>
@@ -15283,7 +15283,7 @@
       </p:sp>
       <p:sp>
         <p:nvSpPr>
-          <p:cNvPr id="13" name="">
+          <p:cNvPr id="14" name="">
             <a:extLst xmlns:a="http://schemas.openxmlformats.org/drawingml/2006/main">
               <a:ext uri="{FF2B5EF4-FFF2-40B4-BE49-F238E27FC236}">
                 <a16:creationId xmlns:a16="http://schemas.microsoft.com/office/drawing/2014/main" id="{28C1474E-F25F-4E47-AB60-5CE26D3BC785}"/>
@@ -15329,7 +15329,7 @@
       </p:sp>
       <p:sp>
         <p:nvSpPr>
-          <p:cNvPr id="14" name="">
+          <p:cNvPr id="15" name="">
             <a:extLst xmlns:a="http://schemas.openxmlformats.org/drawingml/2006/main">
               <a:ext uri="{FF2B5EF4-FFF2-40B4-BE49-F238E27FC236}">
                 <a16:creationId xmlns:a16="http://schemas.microsoft.com/office/drawing/2014/main" id="{50D803EE-E5CC-4E90-A01A-3BA8EA3DEC70}"/>
@@ -15361,7 +15361,7 @@
       </p:sp>
       <p:sp>
         <p:nvSpPr>
-          <p:cNvPr id="15" name="">
+          <p:cNvPr id="16" name="">
             <a:extLst xmlns:a="http://schemas.openxmlformats.org/drawingml/2006/main">
               <a:ext uri="{FF2B5EF4-FFF2-40B4-BE49-F238E27FC236}">
                 <a16:creationId xmlns:a16="http://schemas.microsoft.com/office/drawing/2014/main" id="{A42621A5-C4E9-4A49-A1E5-691D2DCD6381}"/>
@@ -15407,7 +15407,7 @@
       </p:sp>
       <p:sp>
         <p:nvSpPr>
-          <p:cNvPr id="16" name="">
+          <p:cNvPr id="17" name="">
             <a:extLst xmlns:a="http://schemas.openxmlformats.org/drawingml/2006/main">
               <a:ext uri="{FF2B5EF4-FFF2-40B4-BE49-F238E27FC236}">
                 <a16:creationId xmlns:a16="http://schemas.microsoft.com/office/drawing/2014/main" id="{1EC8CD65-B9C7-4FE9-8459-89A540DCF40A}"/>
@@ -15439,7 +15439,7 @@
       </p:sp>
       <p:sp>
         <p:nvSpPr>
-          <p:cNvPr id="17" name="">
+          <p:cNvPr id="18" name="">
             <a:extLst xmlns:a="http://schemas.openxmlformats.org/drawingml/2006/main">
               <a:ext uri="{FF2B5EF4-FFF2-40B4-BE49-F238E27FC236}">
                 <a16:creationId xmlns:a16="http://schemas.microsoft.com/office/drawing/2014/main" id="{87AE1E9E-3263-4AA4-9D6C-30D84B6D95AB}"/>
@@ -15485,7 +15485,7 @@
       </p:sp>
       <p:sp>
         <p:nvSpPr>
-          <p:cNvPr id="18" name="">
+          <p:cNvPr id="19" name="">
             <a:extLst xmlns:a="http://schemas.openxmlformats.org/drawingml/2006/main">
               <a:ext uri="{FF2B5EF4-FFF2-40B4-BE49-F238E27FC236}">
                 <a16:creationId xmlns:a16="http://schemas.microsoft.com/office/drawing/2014/main" id="{35BD25C5-CCCC-4936-914F-251E9D4AC39E}"/>
@@ -15517,7 +15517,7 @@
       </p:sp>
       <p:sp>
         <p:nvSpPr>
-          <p:cNvPr id="19" name="">
+          <p:cNvPr id="20" name="">
             <a:extLst xmlns:a="http://schemas.openxmlformats.org/drawingml/2006/main">
               <a:ext uri="{FF2B5EF4-FFF2-40B4-BE49-F238E27FC236}">
                 <a16:creationId xmlns:a16="http://schemas.microsoft.com/office/drawing/2014/main" id="{36AC2CAB-646A-4870-B480-DB8B394A7749}"/>
@@ -15561,7 +15561,7 @@
       </p:sp>
       <p:sp>
         <p:nvSpPr>
-          <p:cNvPr id="20" name="">
+          <p:cNvPr id="21" name="">
             <a:extLst xmlns:a="http://schemas.openxmlformats.org/drawingml/2006/main">
               <a:ext uri="{FF2B5EF4-FFF2-40B4-BE49-F238E27FC236}">
                 <a16:creationId xmlns:a16="http://schemas.microsoft.com/office/drawing/2014/main" id="{B46163B8-2C9A-46C9-BC91-1E3ABF005296}"/>
@@ -15593,7 +15593,7 @@
       </p:sp>
       <p:sp>
         <p:nvSpPr>
-          <p:cNvPr id="21" name="">
+          <p:cNvPr id="22" name="">
             <a:extLst xmlns:a="http://schemas.openxmlformats.org/drawingml/2006/main">
               <a:ext uri="{FF2B5EF4-FFF2-40B4-BE49-F238E27FC236}">
                 <a16:creationId xmlns:a16="http://schemas.microsoft.com/office/drawing/2014/main" id="{770577E4-D79F-4F0F-B12B-E156465E9340}"/>
@@ -15639,7 +15639,7 @@
       </p:sp>
       <p:sp>
         <p:nvSpPr>
-          <p:cNvPr id="22" name="">
+          <p:cNvPr id="23" name="">
             <a:extLst xmlns:a="http://schemas.openxmlformats.org/drawingml/2006/main">
               <a:ext uri="{FF2B5EF4-FFF2-40B4-BE49-F238E27FC236}">
                 <a16:creationId xmlns:a16="http://schemas.microsoft.com/office/drawing/2014/main" id="{EA2C1234-13A6-43E2-8C62-7A896FA67119}"/>
@@ -15671,7 +15671,7 @@
       </p:sp>
       <p:sp>
         <p:nvSpPr>
-          <p:cNvPr id="23" name="">
+          <p:cNvPr id="24" name="">
             <a:extLst xmlns:a="http://schemas.openxmlformats.org/drawingml/2006/main">
               <a:ext uri="{FF2B5EF4-FFF2-40B4-BE49-F238E27FC236}">
                 <a16:creationId xmlns:a16="http://schemas.microsoft.com/office/drawing/2014/main" id="{72D808CE-5CDA-4CB4-B734-204383FD27AE}"/>
@@ -15717,7 +15717,7 @@
       </p:sp>
       <p:sp>
         <p:nvSpPr>
-          <p:cNvPr id="24" name="">
+          <p:cNvPr id="25" name="">
             <a:extLst xmlns:a="http://schemas.openxmlformats.org/drawingml/2006/main">
               <a:ext uri="{FF2B5EF4-FFF2-40B4-BE49-F238E27FC236}">
                 <a16:creationId xmlns:a16="http://schemas.microsoft.com/office/drawing/2014/main" id="{D0A6D619-2DC6-4D91-9CEA-68B1446BEA4B}"/>
@@ -15749,7 +15749,7 @@
       </p:sp>
       <p:sp>
         <p:nvSpPr>
-          <p:cNvPr id="25" name="">
+          <p:cNvPr id="26" name="">
             <a:extLst xmlns:a="http://schemas.openxmlformats.org/drawingml/2006/main">
               <a:ext uri="{FF2B5EF4-FFF2-40B4-BE49-F238E27FC236}">
                 <a16:creationId xmlns:a16="http://schemas.microsoft.com/office/drawing/2014/main" id="{99650662-F16A-4060-B8A2-9AFE4DA65FD9}"/>
@@ -15795,7 +15795,7 @@
       </p:sp>
       <p:sp>
         <p:nvSpPr>
-          <p:cNvPr id="26" name="">
+          <p:cNvPr id="27" name="">
             <a:extLst xmlns:a="http://schemas.openxmlformats.org/drawingml/2006/main">
               <a:ext uri="{FF2B5EF4-FFF2-40B4-BE49-F238E27FC236}">
                 <a16:creationId xmlns:a16="http://schemas.microsoft.com/office/drawing/2014/main" id="{159C248F-E4DD-4280-B59D-C76C1DA868C6}"/>
@@ -15827,7 +15827,7 @@
       </p:sp>
       <p:sp>
         <p:nvSpPr>
-          <p:cNvPr id="27" name="">
+          <p:cNvPr id="28" name="">
             <a:extLst xmlns:a="http://schemas.openxmlformats.org/drawingml/2006/main">
               <a:ext uri="{FF2B5EF4-FFF2-40B4-BE49-F238E27FC236}">
                 <a16:creationId xmlns:a16="http://schemas.microsoft.com/office/drawing/2014/main" id="{3822F0BF-792D-4813-BF51-0999946D7F56}"/>
@@ -15894,7 +15894,7 @@
       </p:grpSpPr>
       <p:sp>
         <p:nvSpPr>
-          <p:cNvPr id="1" name="Slide Number Placeholder 5">
+          <p:cNvPr id="2" name="Slide Number Placeholder 5">
             <a:extLst xmlns:a="http://schemas.openxmlformats.org/drawingml/2006/main">
               <a:ext uri="{FF2B5EF4-FFF2-40B4-BE49-F238E27FC236}">
                 <a16:creationId xmlns:a16="http://schemas.microsoft.com/office/drawing/2014/main" id="{70659316-B4BB-42AA-9EDF-4B27092320CB}"/>
@@ -15926,7 +15926,7 @@
       </p:sp>
       <p:sp>
         <p:nvSpPr>
-          <p:cNvPr id="2" name="">
+          <p:cNvPr id="3" name="">
             <a:extLst xmlns:a="http://schemas.openxmlformats.org/drawingml/2006/main">
               <a:ext uri="{FF2B5EF4-FFF2-40B4-BE49-F238E27FC236}">
                 <a16:creationId xmlns:a16="http://schemas.microsoft.com/office/drawing/2014/main" id="{C98720A9-2A7A-49B3-85E2-4BF0D1C5C63D}"/>
@@ -15958,7 +15958,7 @@
       </p:sp>
       <p:sp>
         <p:nvSpPr>
-          <p:cNvPr id="3" name="">
+          <p:cNvPr id="4" name="">
             <a:extLst xmlns:a="http://schemas.openxmlformats.org/drawingml/2006/main">
               <a:ext uri="{FF2B5EF4-FFF2-40B4-BE49-F238E27FC236}">
                 <a16:creationId xmlns:a16="http://schemas.microsoft.com/office/drawing/2014/main" id="{F4AEC43D-D016-4874-BEE2-4F6DEC63689A}"/>
@@ -15990,7 +15990,7 @@
       </p:sp>
       <p:sp>
         <p:nvSpPr>
-          <p:cNvPr id="4" name="">
+          <p:cNvPr id="5" name="">
             <a:extLst xmlns:a="http://schemas.openxmlformats.org/drawingml/2006/main">
               <a:ext uri="{FF2B5EF4-FFF2-40B4-BE49-F238E27FC236}">
                 <a16:creationId xmlns:a16="http://schemas.microsoft.com/office/drawing/2014/main" id="{964CDDC8-E652-416C-9033-2A630E5CA6C2}"/>
@@ -16034,7 +16034,7 @@
       </p:sp>
       <p:sp>
         <p:nvSpPr>
-          <p:cNvPr id="5" name="">
+          <p:cNvPr id="6" name="">
             <a:extLst xmlns:a="http://schemas.openxmlformats.org/drawingml/2006/main">
               <a:ext uri="{FF2B5EF4-FFF2-40B4-BE49-F238E27FC236}">
                 <a16:creationId xmlns:a16="http://schemas.microsoft.com/office/drawing/2014/main" id="{1784C90C-84F6-470A-B56B-07390B19885B}"/>
@@ -16080,7 +16080,7 @@
       </p:sp>
       <p:sp>
         <p:nvSpPr>
-          <p:cNvPr id="6" name="">
+          <p:cNvPr id="7" name="">
             <a:extLst xmlns:a="http://schemas.openxmlformats.org/drawingml/2006/main">
               <a:ext uri="{FF2B5EF4-FFF2-40B4-BE49-F238E27FC236}">
                 <a16:creationId xmlns:a16="http://schemas.microsoft.com/office/drawing/2014/main" id="{B382194B-CDED-4D20-9E3A-EF3533CE5B31}"/>
@@ -16126,7 +16126,7 @@
       </p:sp>
       <p:sp>
         <p:nvSpPr>
-          <p:cNvPr id="7" name="">
+          <p:cNvPr id="8" name="">
             <a:extLst xmlns:a="http://schemas.openxmlformats.org/drawingml/2006/main">
               <a:ext uri="{FF2B5EF4-FFF2-40B4-BE49-F238E27FC236}">
                 <a16:creationId xmlns:a16="http://schemas.microsoft.com/office/drawing/2014/main" id="{E9ACB714-B504-4335-9373-CF7894029A7B}"/>
@@ -16158,7 +16158,7 @@
       </p:sp>
       <p:sp>
         <p:nvSpPr>
-          <p:cNvPr id="8" name="">
+          <p:cNvPr id="9" name="">
             <a:extLst xmlns:a="http://schemas.openxmlformats.org/drawingml/2006/main">
               <a:ext uri="{FF2B5EF4-FFF2-40B4-BE49-F238E27FC236}">
                 <a16:creationId xmlns:a16="http://schemas.microsoft.com/office/drawing/2014/main" id="{ED3DA009-2F58-4BEF-8367-AE61F187E98D}"/>
@@ -16202,7 +16202,7 @@
       </p:sp>
       <p:sp>
         <p:nvSpPr>
-          <p:cNvPr id="9" name="">
+          <p:cNvPr id="10" name="">
             <a:extLst xmlns:a="http://schemas.openxmlformats.org/drawingml/2006/main">
               <a:ext uri="{FF2B5EF4-FFF2-40B4-BE49-F238E27FC236}">
                 <a16:creationId xmlns:a16="http://schemas.microsoft.com/office/drawing/2014/main" id="{0BEB0CE2-75D3-46EC-A791-BF2D40D6EE06}"/>
@@ -16247,7 +16247,7 @@
       </p:sp>
       <p:sp>
         <p:nvSpPr>
-          <p:cNvPr id="10" name="">
+          <p:cNvPr id="11" name="">
             <a:extLst xmlns:a="http://schemas.openxmlformats.org/drawingml/2006/main">
               <a:ext uri="{FF2B5EF4-FFF2-40B4-BE49-F238E27FC236}">
                 <a16:creationId xmlns:a16="http://schemas.microsoft.com/office/drawing/2014/main" id="{6F4699F7-A8B9-4ADA-B547-169CF11A58D0}"/>
@@ -16294,7 +16294,7 @@
       </p:sp>
       <p:sp>
         <p:nvSpPr>
-          <p:cNvPr id="11" name="">
+          <p:cNvPr id="12" name="">
             <a:extLst xmlns:a="http://schemas.openxmlformats.org/drawingml/2006/main">
               <a:ext uri="{FF2B5EF4-FFF2-40B4-BE49-F238E27FC236}">
                 <a16:creationId xmlns:a16="http://schemas.microsoft.com/office/drawing/2014/main" id="{4540EA23-9956-415B-AF3F-DACB36CB38CE}"/>
@@ -16341,7 +16341,7 @@
       </p:sp>
       <p:sp>
         <p:nvSpPr>
-          <p:cNvPr id="12" name="">
+          <p:cNvPr id="13" name="">
             <a:extLst xmlns:a="http://schemas.openxmlformats.org/drawingml/2006/main">
               <a:ext uri="{FF2B5EF4-FFF2-40B4-BE49-F238E27FC236}">
                 <a16:creationId xmlns:a16="http://schemas.microsoft.com/office/drawing/2014/main" id="{A85F632E-E161-4CA3-9D36-0DBE695CA5D1}"/>
@@ -16388,7 +16388,7 @@
       </p:sp>
       <p:sp>
         <p:nvSpPr>
-          <p:cNvPr id="13" name="">
+          <p:cNvPr id="14" name="">
             <a:extLst xmlns:a="http://schemas.openxmlformats.org/drawingml/2006/main">
               <a:ext uri="{FF2B5EF4-FFF2-40B4-BE49-F238E27FC236}">
                 <a16:creationId xmlns:a16="http://schemas.microsoft.com/office/drawing/2014/main" id="{F97E0122-3899-4737-8D70-623A57D7F10C}"/>
@@ -16435,7 +16435,7 @@
       </p:sp>
       <p:sp>
         <p:nvSpPr>
-          <p:cNvPr id="14" name="">
+          <p:cNvPr id="15" name="">
             <a:extLst xmlns:a="http://schemas.openxmlformats.org/drawingml/2006/main">
               <a:ext uri="{FF2B5EF4-FFF2-40B4-BE49-F238E27FC236}">
                 <a16:creationId xmlns:a16="http://schemas.microsoft.com/office/drawing/2014/main" id="{D8485ED8-BF35-4EE8-8D89-C602B7050901}"/>
@@ -16482,7 +16482,7 @@
       </p:sp>
       <p:sp>
         <p:nvSpPr>
-          <p:cNvPr id="15" name="">
+          <p:cNvPr id="16" name="">
             <a:extLst xmlns:a="http://schemas.openxmlformats.org/drawingml/2006/main">
               <a:ext uri="{FF2B5EF4-FFF2-40B4-BE49-F238E27FC236}">
                 <a16:creationId xmlns:a16="http://schemas.microsoft.com/office/drawing/2014/main" id="{63808DD9-95AF-4BBF-86C8-77EC6903868B}"/>
@@ -16529,7 +16529,7 @@
       </p:sp>
       <p:sp>
         <p:nvSpPr>
-          <p:cNvPr id="16" name="">
+          <p:cNvPr id="17" name="">
             <a:extLst xmlns:a="http://schemas.openxmlformats.org/drawingml/2006/main">
               <a:ext uri="{FF2B5EF4-FFF2-40B4-BE49-F238E27FC236}">
                 <a16:creationId xmlns:a16="http://schemas.microsoft.com/office/drawing/2014/main" id="{BC2D2B6F-AB96-480E-9326-0B4BF62A524B}"/>
@@ -16576,7 +16576,7 @@
       </p:sp>
       <p:sp>
         <p:nvSpPr>
-          <p:cNvPr id="17" name="">
+          <p:cNvPr id="18" name="">
             <a:extLst xmlns:a="http://schemas.openxmlformats.org/drawingml/2006/main">
               <a:ext uri="{FF2B5EF4-FFF2-40B4-BE49-F238E27FC236}">
                 <a16:creationId xmlns:a16="http://schemas.microsoft.com/office/drawing/2014/main" id="{7AB26839-D97B-4DDF-B2A1-69F99F301692}"/>
@@ -16623,7 +16623,7 @@
       </p:sp>
       <p:sp>
         <p:nvSpPr>
-          <p:cNvPr id="18" name="">
+          <p:cNvPr id="19" name="">
             <a:extLst xmlns:a="http://schemas.openxmlformats.org/drawingml/2006/main">
               <a:ext uri="{FF2B5EF4-FFF2-40B4-BE49-F238E27FC236}">
                 <a16:creationId xmlns:a16="http://schemas.microsoft.com/office/drawing/2014/main" id="{264B33AB-D44A-4B24-8F7E-F906D71AF5F5}"/>
@@ -16655,7 +16655,7 @@
       </p:sp>
       <p:sp>
         <p:nvSpPr>
-          <p:cNvPr id="19" name="">
+          <p:cNvPr id="20" name="">
             <a:extLst xmlns:a="http://schemas.openxmlformats.org/drawingml/2006/main">
               <a:ext uri="{FF2B5EF4-FFF2-40B4-BE49-F238E27FC236}">
                 <a16:creationId xmlns:a16="http://schemas.microsoft.com/office/drawing/2014/main" id="{973222EE-D752-49C1-BB08-4F0FC7F67305}"/>
@@ -16687,7 +16687,7 @@
       </p:sp>
       <p:sp>
         <p:nvSpPr>
-          <p:cNvPr id="20" name="">
+          <p:cNvPr id="21" name="">
             <a:extLst xmlns:a="http://schemas.openxmlformats.org/drawingml/2006/main">
               <a:ext uri="{FF2B5EF4-FFF2-40B4-BE49-F238E27FC236}">
                 <a16:creationId xmlns:a16="http://schemas.microsoft.com/office/drawing/2014/main" id="{0EBEAE97-38FF-4CB5-80ED-CDD410A9B960}"/>
@@ -16719,7 +16719,7 @@
       </p:sp>
       <p:sp>
         <p:nvSpPr>
-          <p:cNvPr id="21" name="">
+          <p:cNvPr id="22" name="">
             <a:extLst xmlns:a="http://schemas.openxmlformats.org/drawingml/2006/main">
               <a:ext uri="{FF2B5EF4-FFF2-40B4-BE49-F238E27FC236}">
                 <a16:creationId xmlns:a16="http://schemas.microsoft.com/office/drawing/2014/main" id="{15B85892-3532-4E26-83B3-EC6651957535}"/>
@@ -16751,7 +16751,7 @@
       </p:sp>
       <p:sp>
         <p:nvSpPr>
-          <p:cNvPr id="22" name="">
+          <p:cNvPr id="23" name="">
             <a:extLst xmlns:a="http://schemas.openxmlformats.org/drawingml/2006/main">
               <a:ext uri="{FF2B5EF4-FFF2-40B4-BE49-F238E27FC236}">
                 <a16:creationId xmlns:a16="http://schemas.microsoft.com/office/drawing/2014/main" id="{C61344C6-010C-4554-B89A-C6A1C6D800D9}"/>
@@ -16783,7 +16783,7 @@
       </p:sp>
       <p:sp>
         <p:nvSpPr>
-          <p:cNvPr id="23" name="">
+          <p:cNvPr id="24" name="">
             <a:extLst xmlns:a="http://schemas.openxmlformats.org/drawingml/2006/main">
               <a:ext uri="{FF2B5EF4-FFF2-40B4-BE49-F238E27FC236}">
                 <a16:creationId xmlns:a16="http://schemas.microsoft.com/office/drawing/2014/main" id="{E636D6BD-CA87-4DA3-BDC3-4E67AD20B47F}"/>
@@ -16815,7 +16815,7 @@
       </p:sp>
       <p:sp>
         <p:nvSpPr>
-          <p:cNvPr id="24" name="">
+          <p:cNvPr id="25" name="">
             <a:extLst xmlns:a="http://schemas.openxmlformats.org/drawingml/2006/main">
               <a:ext uri="{FF2B5EF4-FFF2-40B4-BE49-F238E27FC236}">
                 <a16:creationId xmlns:a16="http://schemas.microsoft.com/office/drawing/2014/main" id="{20726A01-244F-4D29-B400-97F61B14FC6E}"/>
@@ -16847,7 +16847,7 @@
       </p:sp>
       <p:sp>
         <p:nvSpPr>
-          <p:cNvPr id="25" name="">
+          <p:cNvPr id="26" name="">
             <a:extLst xmlns:a="http://schemas.openxmlformats.org/drawingml/2006/main">
               <a:ext uri="{FF2B5EF4-FFF2-40B4-BE49-F238E27FC236}">
                 <a16:creationId xmlns:a16="http://schemas.microsoft.com/office/drawing/2014/main" id="{9830EAF6-1731-4348-818D-8E44F0AB664B}"/>
@@ -16879,7 +16879,7 @@
       </p:sp>
       <p:sp>
         <p:nvSpPr>
-          <p:cNvPr id="26" name="">
+          <p:cNvPr id="27" name="">
             <a:extLst xmlns:a="http://schemas.openxmlformats.org/drawingml/2006/main">
               <a:ext uri="{FF2B5EF4-FFF2-40B4-BE49-F238E27FC236}">
                 <a16:creationId xmlns:a16="http://schemas.microsoft.com/office/drawing/2014/main" id="{AAF090BF-E30E-4249-8ABD-0F5ADC16A5ED}"/>
@@ -16924,7 +16924,7 @@
       </p:sp>
       <p:sp>
         <p:nvSpPr>
-          <p:cNvPr id="27" name="">
+          <p:cNvPr id="28" name="">
             <a:extLst xmlns:a="http://schemas.openxmlformats.org/drawingml/2006/main">
               <a:ext uri="{FF2B5EF4-FFF2-40B4-BE49-F238E27FC236}">
                 <a16:creationId xmlns:a16="http://schemas.microsoft.com/office/drawing/2014/main" id="{60DCB07E-0EF6-456E-870B-F0ED84F4FDDF}"/>
@@ -16991,7 +16991,7 @@
       </p:grpSpPr>
       <p:sp>
         <p:nvSpPr>
-          <p:cNvPr id="1" name="Slide Number Placeholder 5">
+          <p:cNvPr id="2" name="Slide Number Placeholder 5">
             <a:extLst xmlns:a="http://schemas.openxmlformats.org/drawingml/2006/main">
               <a:ext uri="{FF2B5EF4-FFF2-40B4-BE49-F238E27FC236}">
                 <a16:creationId xmlns:a16="http://schemas.microsoft.com/office/drawing/2014/main" id="{70659316-B4BB-42AA-9EDF-4B27092320CB}"/>
@@ -17023,7 +17023,7 @@
       </p:sp>
       <p:sp>
         <p:nvSpPr>
-          <p:cNvPr id="2" name="">
+          <p:cNvPr id="3" name="">
             <a:extLst xmlns:a="http://schemas.openxmlformats.org/drawingml/2006/main">
               <a:ext uri="{FF2B5EF4-FFF2-40B4-BE49-F238E27FC236}">
                 <a16:creationId xmlns:a16="http://schemas.microsoft.com/office/drawing/2014/main" id="{053D2591-4DB0-4D0D-809D-790425CAB30D}"/>
@@ -17055,7 +17055,7 @@
       </p:sp>
       <p:sp>
         <p:nvSpPr>
-          <p:cNvPr id="3" name="">
+          <p:cNvPr id="4" name="">
             <a:extLst xmlns:a="http://schemas.openxmlformats.org/drawingml/2006/main">
               <a:ext uri="{FF2B5EF4-FFF2-40B4-BE49-F238E27FC236}">
                 <a16:creationId xmlns:a16="http://schemas.microsoft.com/office/drawing/2014/main" id="{666AED2E-D638-4115-9B5B-4D12DD6CEC1E}"/>
@@ -17087,7 +17087,7 @@
       </p:sp>
       <p:sp>
         <p:nvSpPr>
-          <p:cNvPr id="4" name="">
+          <p:cNvPr id="5" name="">
             <a:extLst xmlns:a="http://schemas.openxmlformats.org/drawingml/2006/main">
               <a:ext uri="{FF2B5EF4-FFF2-40B4-BE49-F238E27FC236}">
                 <a16:creationId xmlns:a16="http://schemas.microsoft.com/office/drawing/2014/main" id="{CFC27DAD-E4BA-45A5-A8ED-FCDFDC1290E7}"/>
@@ -17131,7 +17131,7 @@
       </p:sp>
       <p:sp>
         <p:nvSpPr>
-          <p:cNvPr id="5" name="">
+          <p:cNvPr id="6" name="">
             <a:extLst xmlns:a="http://schemas.openxmlformats.org/drawingml/2006/main">
               <a:ext uri="{FF2B5EF4-FFF2-40B4-BE49-F238E27FC236}">
                 <a16:creationId xmlns:a16="http://schemas.microsoft.com/office/drawing/2014/main" id="{8504EC7B-2A22-4A69-9F65-7D9F04AB7E4B}"/>
@@ -17177,7 +17177,7 @@
       </p:sp>
       <p:sp>
         <p:nvSpPr>
-          <p:cNvPr id="6" name="">
+          <p:cNvPr id="7" name="">
             <a:extLst xmlns:a="http://schemas.openxmlformats.org/drawingml/2006/main">
               <a:ext uri="{FF2B5EF4-FFF2-40B4-BE49-F238E27FC236}">
                 <a16:creationId xmlns:a16="http://schemas.microsoft.com/office/drawing/2014/main" id="{C8CA031F-DF5B-4D52-A0D9-A5DE3532BFA4}"/>
@@ -17223,7 +17223,7 @@
       </p:sp>
       <p:sp>
         <p:nvSpPr>
-          <p:cNvPr id="7" name="">
+          <p:cNvPr id="8" name="">
             <a:extLst xmlns:a="http://schemas.openxmlformats.org/drawingml/2006/main">
               <a:ext uri="{FF2B5EF4-FFF2-40B4-BE49-F238E27FC236}">
                 <a16:creationId xmlns:a16="http://schemas.microsoft.com/office/drawing/2014/main" id="{4280D98C-1464-4141-8625-065677DDF3C8}"/>
@@ -17255,7 +17255,7 @@
       </p:sp>
       <p:sp>
         <p:nvSpPr>
-          <p:cNvPr id="8" name="">
+          <p:cNvPr id="9" name="">
             <a:extLst xmlns:a="http://schemas.openxmlformats.org/drawingml/2006/main">
               <a:ext uri="{FF2B5EF4-FFF2-40B4-BE49-F238E27FC236}">
                 <a16:creationId xmlns:a16="http://schemas.microsoft.com/office/drawing/2014/main" id="{60D4F31B-68FA-4AA5-966D-0BDDD4D6EDA8}"/>
@@ -17299,7 +17299,7 @@
       </p:sp>
       <p:sp>
         <p:nvSpPr>
-          <p:cNvPr id="9" name="">
+          <p:cNvPr id="10" name="">
             <a:extLst xmlns:a="http://schemas.openxmlformats.org/drawingml/2006/main">
               <a:ext uri="{FF2B5EF4-FFF2-40B4-BE49-F238E27FC236}">
                 <a16:creationId xmlns:a16="http://schemas.microsoft.com/office/drawing/2014/main" id="{33140200-5277-42B7-9177-4F4ED786826E}"/>
@@ -17344,7 +17344,7 @@
       </p:sp>
       <p:sp>
         <p:nvSpPr>
-          <p:cNvPr id="10" name="">
+          <p:cNvPr id="11" name="">
             <a:extLst xmlns:a="http://schemas.openxmlformats.org/drawingml/2006/main">
               <a:ext uri="{FF2B5EF4-FFF2-40B4-BE49-F238E27FC236}">
                 <a16:creationId xmlns:a16="http://schemas.microsoft.com/office/drawing/2014/main" id="{2043A20B-98D9-41E0-9E52-F15C3A002C96}"/>
@@ -17376,7 +17376,7 @@
       </p:sp>
       <p:sp>
         <p:nvSpPr>
-          <p:cNvPr id="11" name="">
+          <p:cNvPr id="12" name="">
             <a:extLst xmlns:a="http://schemas.openxmlformats.org/drawingml/2006/main">
               <a:ext uri="{FF2B5EF4-FFF2-40B4-BE49-F238E27FC236}">
                 <a16:creationId xmlns:a16="http://schemas.microsoft.com/office/drawing/2014/main" id="{28A80E08-1069-4F27-A197-224EA8CEAE36}"/>
@@ -17408,7 +17408,7 @@
       </p:sp>
       <p:sp>
         <p:nvSpPr>
-          <p:cNvPr id="12" name="">
+          <p:cNvPr id="13" name="">
             <a:extLst xmlns:a="http://schemas.openxmlformats.org/drawingml/2006/main">
               <a:ext uri="{FF2B5EF4-FFF2-40B4-BE49-F238E27FC236}">
                 <a16:creationId xmlns:a16="http://schemas.microsoft.com/office/drawing/2014/main" id="{A1C033CD-34ED-4252-93BC-268B4459373F}"/>
@@ -17454,7 +17454,7 @@
       </p:sp>
       <p:sp>
         <p:nvSpPr>
-          <p:cNvPr id="13" name="">
+          <p:cNvPr id="14" name="">
             <a:extLst xmlns:a="http://schemas.openxmlformats.org/drawingml/2006/main">
               <a:ext uri="{FF2B5EF4-FFF2-40B4-BE49-F238E27FC236}">
                 <a16:creationId xmlns:a16="http://schemas.microsoft.com/office/drawing/2014/main" id="{F40E3B02-D39B-4B50-97D4-A5F101FACBD2}"/>
@@ -17500,7 +17500,7 @@
       </p:sp>
       <p:sp>
         <p:nvSpPr>
-          <p:cNvPr id="14" name="">
+          <p:cNvPr id="15" name="">
             <a:extLst xmlns:a="http://schemas.openxmlformats.org/drawingml/2006/main">
               <a:ext uri="{FF2B5EF4-FFF2-40B4-BE49-F238E27FC236}">
                 <a16:creationId xmlns:a16="http://schemas.microsoft.com/office/drawing/2014/main" id="{0E043A82-2DFC-4101-A25D-BF95470013DF}"/>
@@ -17532,7 +17532,7 @@
       </p:sp>
       <p:sp>
         <p:nvSpPr>
-          <p:cNvPr id="15" name="">
+          <p:cNvPr id="16" name="">
             <a:extLst xmlns:a="http://schemas.openxmlformats.org/drawingml/2006/main">
               <a:ext uri="{FF2B5EF4-FFF2-40B4-BE49-F238E27FC236}">
                 <a16:creationId xmlns:a16="http://schemas.microsoft.com/office/drawing/2014/main" id="{12059ADC-9B72-4901-B9AF-DD8EAAE351C2}"/>
@@ -17564,7 +17564,7 @@
       </p:sp>
       <p:sp>
         <p:nvSpPr>
-          <p:cNvPr id="16" name="">
+          <p:cNvPr id="17" name="">
             <a:extLst xmlns:a="http://schemas.openxmlformats.org/drawingml/2006/main">
               <a:ext uri="{FF2B5EF4-FFF2-40B4-BE49-F238E27FC236}">
                 <a16:creationId xmlns:a16="http://schemas.microsoft.com/office/drawing/2014/main" id="{CE0F0F37-46DD-41C5-87F6-C23E496E8566}"/>
@@ -17610,7 +17610,7 @@
       </p:sp>
       <p:sp>
         <p:nvSpPr>
-          <p:cNvPr id="17" name="">
+          <p:cNvPr id="18" name="">
             <a:extLst xmlns:a="http://schemas.openxmlformats.org/drawingml/2006/main">
               <a:ext uri="{FF2B5EF4-FFF2-40B4-BE49-F238E27FC236}">
                 <a16:creationId xmlns:a16="http://schemas.microsoft.com/office/drawing/2014/main" id="{E5798C2A-205F-449E-826B-0E6931F650CC}"/>
@@ -17656,7 +17656,7 @@
       </p:sp>
       <p:sp>
         <p:nvSpPr>
-          <p:cNvPr id="18" name="">
+          <p:cNvPr id="19" name="">
             <a:extLst xmlns:a="http://schemas.openxmlformats.org/drawingml/2006/main">
               <a:ext uri="{FF2B5EF4-FFF2-40B4-BE49-F238E27FC236}">
                 <a16:creationId xmlns:a16="http://schemas.microsoft.com/office/drawing/2014/main" id="{B4365D48-AB29-4AA7-B317-5875F4B615D1}"/>
@@ -17688,7 +17688,7 @@
       </p:sp>
       <p:sp>
         <p:nvSpPr>
-          <p:cNvPr id="19" name="">
+          <p:cNvPr id="20" name="">
             <a:extLst xmlns:a="http://schemas.openxmlformats.org/drawingml/2006/main">
               <a:ext uri="{FF2B5EF4-FFF2-40B4-BE49-F238E27FC236}">
                 <a16:creationId xmlns:a16="http://schemas.microsoft.com/office/drawing/2014/main" id="{1D76F32A-042C-44A5-A006-64C4C1FCA6BC}"/>
@@ -17720,7 +17720,7 @@
       </p:sp>
       <p:sp>
         <p:nvSpPr>
-          <p:cNvPr id="20" name="">
+          <p:cNvPr id="21" name="">
             <a:extLst xmlns:a="http://schemas.openxmlformats.org/drawingml/2006/main">
               <a:ext uri="{FF2B5EF4-FFF2-40B4-BE49-F238E27FC236}">
                 <a16:creationId xmlns:a16="http://schemas.microsoft.com/office/drawing/2014/main" id="{5D64628C-B057-416D-8151-4855E81341D5}"/>
@@ -17766,7 +17766,7 @@
       </p:sp>
       <p:sp>
         <p:nvSpPr>
-          <p:cNvPr id="21" name="">
+          <p:cNvPr id="22" name="">
             <a:extLst xmlns:a="http://schemas.openxmlformats.org/drawingml/2006/main">
               <a:ext uri="{FF2B5EF4-FFF2-40B4-BE49-F238E27FC236}">
                 <a16:creationId xmlns:a16="http://schemas.microsoft.com/office/drawing/2014/main" id="{39C8893D-95C9-423F-B52E-544C818A9C67}"/>
@@ -17812,7 +17812,7 @@
       </p:sp>
       <p:sp>
         <p:nvSpPr>
-          <p:cNvPr id="22" name="">
+          <p:cNvPr id="23" name="">
             <a:extLst xmlns:a="http://schemas.openxmlformats.org/drawingml/2006/main">
               <a:ext uri="{FF2B5EF4-FFF2-40B4-BE49-F238E27FC236}">
                 <a16:creationId xmlns:a16="http://schemas.microsoft.com/office/drawing/2014/main" id="{F80B59AF-0B78-4A3F-889C-5FD074A79FA3}"/>
@@ -17844,7 +17844,7 @@
       </p:sp>
       <p:sp>
         <p:nvSpPr>
-          <p:cNvPr id="23" name="">
+          <p:cNvPr id="24" name="">
             <a:extLst xmlns:a="http://schemas.openxmlformats.org/drawingml/2006/main">
               <a:ext uri="{FF2B5EF4-FFF2-40B4-BE49-F238E27FC236}">
                 <a16:creationId xmlns:a16="http://schemas.microsoft.com/office/drawing/2014/main" id="{B2A0D093-AABF-4E86-A5F6-2C9416E8EAAA}"/>
@@ -17913,7 +17913,7 @@
       </p:grpSpPr>
       <p:sp>
         <p:nvSpPr>
-          <p:cNvPr id="1" name="Slide Number Placeholder 5">
+          <p:cNvPr id="2" name="Slide Number Placeholder 5">
             <a:extLst xmlns:a="http://schemas.openxmlformats.org/drawingml/2006/main">
               <a:ext uri="{FF2B5EF4-FFF2-40B4-BE49-F238E27FC236}">
                 <a16:creationId xmlns:a16="http://schemas.microsoft.com/office/drawing/2014/main" id="{70659316-B4BB-42AA-9EDF-4B27092320CB}"/>
@@ -17945,7 +17945,7 @@
       </p:sp>
       <p:sp>
         <p:nvSpPr>
-          <p:cNvPr id="2" name="">
+          <p:cNvPr id="3" name="">
             <a:extLst xmlns:a="http://schemas.openxmlformats.org/drawingml/2006/main">
               <a:ext uri="{FF2B5EF4-FFF2-40B4-BE49-F238E27FC236}">
                 <a16:creationId xmlns:a16="http://schemas.microsoft.com/office/drawing/2014/main" id="{0EA22CD5-C43F-40A0-87E7-AE055CD4E937}"/>
@@ -17977,7 +17977,7 @@
       </p:sp>
       <p:sp>
         <p:nvSpPr>
-          <p:cNvPr id="3" name="">
+          <p:cNvPr id="4" name="">
             <a:extLst xmlns:a="http://schemas.openxmlformats.org/drawingml/2006/main">
               <a:ext uri="{FF2B5EF4-FFF2-40B4-BE49-F238E27FC236}">
                 <a16:creationId xmlns:a16="http://schemas.microsoft.com/office/drawing/2014/main" id="{5DAC5934-0E8D-40A0-B5D2-842C112ECD21}"/>
@@ -18009,7 +18009,7 @@
       </p:sp>
       <p:sp>
         <p:nvSpPr>
-          <p:cNvPr id="4" name="">
+          <p:cNvPr id="5" name="">
             <a:extLst xmlns:a="http://schemas.openxmlformats.org/drawingml/2006/main">
               <a:ext uri="{FF2B5EF4-FFF2-40B4-BE49-F238E27FC236}">
                 <a16:creationId xmlns:a16="http://schemas.microsoft.com/office/drawing/2014/main" id="{CF9808CA-7717-4FBB-8DE0-2B52A3270CA0}"/>
@@ -18053,7 +18053,7 @@
       </p:sp>
       <p:sp>
         <p:nvSpPr>
-          <p:cNvPr id="5" name="">
+          <p:cNvPr id="6" name="">
             <a:extLst xmlns:a="http://schemas.openxmlformats.org/drawingml/2006/main">
               <a:ext uri="{FF2B5EF4-FFF2-40B4-BE49-F238E27FC236}">
                 <a16:creationId xmlns:a16="http://schemas.microsoft.com/office/drawing/2014/main" id="{CD325A1B-B0DD-436E-B3B8-7067CE01C1BA}"/>
@@ -18099,7 +18099,7 @@
       </p:sp>
       <p:sp>
         <p:nvSpPr>
-          <p:cNvPr id="6" name="">
+          <p:cNvPr id="7" name="">
             <a:extLst xmlns:a="http://schemas.openxmlformats.org/drawingml/2006/main">
               <a:ext uri="{FF2B5EF4-FFF2-40B4-BE49-F238E27FC236}">
                 <a16:creationId xmlns:a16="http://schemas.microsoft.com/office/drawing/2014/main" id="{D5D5688F-A1AF-4E88-8571-524CCE36AAF6}"/>
@@ -18145,7 +18145,7 @@
       </p:sp>
       <p:sp>
         <p:nvSpPr>
-          <p:cNvPr id="7" name="">
+          <p:cNvPr id="8" name="">
             <a:extLst xmlns:a="http://schemas.openxmlformats.org/drawingml/2006/main">
               <a:ext uri="{FF2B5EF4-FFF2-40B4-BE49-F238E27FC236}">
                 <a16:creationId xmlns:a16="http://schemas.microsoft.com/office/drawing/2014/main" id="{58C8D458-8C89-4B47-B92E-20D6BF0F0245}"/>
@@ -18177,7 +18177,7 @@
       </p:sp>
       <p:sp>
         <p:nvSpPr>
-          <p:cNvPr id="8" name="">
+          <p:cNvPr id="9" name="">
             <a:extLst xmlns:a="http://schemas.openxmlformats.org/drawingml/2006/main">
               <a:ext uri="{FF2B5EF4-FFF2-40B4-BE49-F238E27FC236}">
                 <a16:creationId xmlns:a16="http://schemas.microsoft.com/office/drawing/2014/main" id="{F7BCA51F-2F4E-4CB6-9000-837C7E25948F}"/>
@@ -18221,7 +18221,7 @@
       </p:sp>
       <p:sp>
         <p:nvSpPr>
-          <p:cNvPr id="9" name="">
+          <p:cNvPr id="10" name="">
             <a:extLst xmlns:a="http://schemas.openxmlformats.org/drawingml/2006/main">
               <a:ext uri="{FF2B5EF4-FFF2-40B4-BE49-F238E27FC236}">
                 <a16:creationId xmlns:a16="http://schemas.microsoft.com/office/drawing/2014/main" id="{41846AFD-1930-46E1-B793-C2AA8A72BE55}"/>
@@ -18266,7 +18266,7 @@
       </p:sp>
       <p:sp>
         <p:nvSpPr>
-          <p:cNvPr id="10" name="">
+          <p:cNvPr id="11" name="">
             <a:extLst xmlns:a="http://schemas.openxmlformats.org/drawingml/2006/main">
               <a:ext uri="{FF2B5EF4-FFF2-40B4-BE49-F238E27FC236}">
                 <a16:creationId xmlns:a16="http://schemas.microsoft.com/office/drawing/2014/main" id="{2798FD5E-0992-4177-84BF-041C39018C62}"/>
@@ -18298,7 +18298,7 @@
       </p:sp>
       <p:sp>
         <p:nvSpPr>
-          <p:cNvPr id="11" name="">
+          <p:cNvPr id="12" name="">
             <a:extLst xmlns:a="http://schemas.openxmlformats.org/drawingml/2006/main">
               <a:ext uri="{FF2B5EF4-FFF2-40B4-BE49-F238E27FC236}">
                 <a16:creationId xmlns:a16="http://schemas.microsoft.com/office/drawing/2014/main" id="{5C846560-F053-4282-875F-D90D5914E774}"/>
@@ -18330,7 +18330,7 @@
       </p:sp>
       <p:sp>
         <p:nvSpPr>
-          <p:cNvPr id="12" name="">
+          <p:cNvPr id="13" name="">
             <a:extLst xmlns:a="http://schemas.openxmlformats.org/drawingml/2006/main">
               <a:ext uri="{FF2B5EF4-FFF2-40B4-BE49-F238E27FC236}">
                 <a16:creationId xmlns:a16="http://schemas.microsoft.com/office/drawing/2014/main" id="{F17688E4-D7EC-439F-A025-3968F80E1F78}"/>
@@ -18376,7 +18376,7 @@
       </p:sp>
       <p:sp>
         <p:nvSpPr>
-          <p:cNvPr id="13" name="">
+          <p:cNvPr id="14" name="">
             <a:extLst xmlns:a="http://schemas.openxmlformats.org/drawingml/2006/main">
               <a:ext uri="{FF2B5EF4-FFF2-40B4-BE49-F238E27FC236}">
                 <a16:creationId xmlns:a16="http://schemas.microsoft.com/office/drawing/2014/main" id="{0DBCAE8D-3D6E-4A38-9AAA-27AB8C57AEF0}"/>
@@ -18408,7 +18408,7 @@
       </p:sp>
       <p:sp>
         <p:nvSpPr>
-          <p:cNvPr id="14" name="">
+          <p:cNvPr id="15" name="">
             <a:extLst xmlns:a="http://schemas.openxmlformats.org/drawingml/2006/main">
               <a:ext uri="{FF2B5EF4-FFF2-40B4-BE49-F238E27FC236}">
                 <a16:creationId xmlns:a16="http://schemas.microsoft.com/office/drawing/2014/main" id="{DE1E7BDD-42E7-4E4C-881B-7D293AC19C77}"/>
@@ -18440,7 +18440,7 @@
       </p:sp>
       <p:sp>
         <p:nvSpPr>
-          <p:cNvPr id="15" name="">
+          <p:cNvPr id="16" name="">
             <a:extLst xmlns:a="http://schemas.openxmlformats.org/drawingml/2006/main">
               <a:ext uri="{FF2B5EF4-FFF2-40B4-BE49-F238E27FC236}">
                 <a16:creationId xmlns:a16="http://schemas.microsoft.com/office/drawing/2014/main" id="{69F1A857-BFF9-47CE-A85B-5849A2079A1A}"/>
@@ -18486,7 +18486,7 @@
       </p:sp>
       <p:sp>
         <p:nvSpPr>
-          <p:cNvPr id="16" name="">
+          <p:cNvPr id="17" name="">
             <a:extLst xmlns:a="http://schemas.openxmlformats.org/drawingml/2006/main">
               <a:ext uri="{FF2B5EF4-FFF2-40B4-BE49-F238E27FC236}">
                 <a16:creationId xmlns:a16="http://schemas.microsoft.com/office/drawing/2014/main" id="{233D9130-C6ED-478C-978B-B38EC6284BD4}"/>
@@ -18518,7 +18518,7 @@
       </p:sp>
       <p:sp>
         <p:nvSpPr>
-          <p:cNvPr id="17" name="">
+          <p:cNvPr id="18" name="">
             <a:extLst xmlns:a="http://schemas.openxmlformats.org/drawingml/2006/main">
               <a:ext uri="{FF2B5EF4-FFF2-40B4-BE49-F238E27FC236}">
                 <a16:creationId xmlns:a16="http://schemas.microsoft.com/office/drawing/2014/main" id="{6B3B76C3-34B4-4753-9E88-5C4ACB907B1C}"/>
@@ -18550,7 +18550,7 @@
       </p:sp>
       <p:sp>
         <p:nvSpPr>
-          <p:cNvPr id="18" name="">
+          <p:cNvPr id="19" name="">
             <a:extLst xmlns:a="http://schemas.openxmlformats.org/drawingml/2006/main">
               <a:ext uri="{FF2B5EF4-FFF2-40B4-BE49-F238E27FC236}">
                 <a16:creationId xmlns:a16="http://schemas.microsoft.com/office/drawing/2014/main" id="{1944D2E8-B60B-4401-A1BE-DC5072B3E6D2}"/>
@@ -18596,7 +18596,7 @@
       </p:sp>
       <p:sp>
         <p:nvSpPr>
-          <p:cNvPr id="19" name="">
+          <p:cNvPr id="20" name="">
             <a:extLst xmlns:a="http://schemas.openxmlformats.org/drawingml/2006/main">
               <a:ext uri="{FF2B5EF4-FFF2-40B4-BE49-F238E27FC236}">
                 <a16:creationId xmlns:a16="http://schemas.microsoft.com/office/drawing/2014/main" id="{273C5D8D-38E8-4521-A810-F9AB2D900E4F}"/>
@@ -18628,7 +18628,7 @@
       </p:sp>
       <p:sp>
         <p:nvSpPr>
-          <p:cNvPr id="20" name="">
+          <p:cNvPr id="21" name="">
             <a:extLst xmlns:a="http://schemas.openxmlformats.org/drawingml/2006/main">
               <a:ext uri="{FF2B5EF4-FFF2-40B4-BE49-F238E27FC236}">
                 <a16:creationId xmlns:a16="http://schemas.microsoft.com/office/drawing/2014/main" id="{CDAF952B-9F60-4089-A78B-E3AE6CDFCCD7}"/>
@@ -18660,7 +18660,7 @@
       </p:sp>
       <p:sp>
         <p:nvSpPr>
-          <p:cNvPr id="21" name="">
+          <p:cNvPr id="22" name="">
             <a:extLst xmlns:a="http://schemas.openxmlformats.org/drawingml/2006/main">
               <a:ext uri="{FF2B5EF4-FFF2-40B4-BE49-F238E27FC236}">
                 <a16:creationId xmlns:a16="http://schemas.microsoft.com/office/drawing/2014/main" id="{16AC23DE-0537-4339-A5B1-FA8CF0C57522}"/>
@@ -18706,7 +18706,7 @@
       </p:sp>
       <p:sp>
         <p:nvSpPr>
-          <p:cNvPr id="22" name="">
+          <p:cNvPr id="23" name="">
             <a:extLst xmlns:a="http://schemas.openxmlformats.org/drawingml/2006/main">
               <a:ext uri="{FF2B5EF4-FFF2-40B4-BE49-F238E27FC236}">
                 <a16:creationId xmlns:a16="http://schemas.microsoft.com/office/drawing/2014/main" id="{0C8E163B-8D45-44A9-AB19-9ECC00903F29}"/>
@@ -18738,7 +18738,7 @@
       </p:sp>
       <p:sp>
         <p:nvSpPr>
-          <p:cNvPr id="23" name="">
+          <p:cNvPr id="24" name="">
             <a:extLst xmlns:a="http://schemas.openxmlformats.org/drawingml/2006/main">
               <a:ext uri="{FF2B5EF4-FFF2-40B4-BE49-F238E27FC236}">
                 <a16:creationId xmlns:a16="http://schemas.microsoft.com/office/drawing/2014/main" id="{74D38216-B8EB-4CEE-BD55-84587FE1C9C6}"/>
@@ -18770,7 +18770,7 @@
       </p:sp>
       <p:sp>
         <p:nvSpPr>
-          <p:cNvPr id="24" name="">
+          <p:cNvPr id="25" name="">
             <a:extLst xmlns:a="http://schemas.openxmlformats.org/drawingml/2006/main">
               <a:ext uri="{FF2B5EF4-FFF2-40B4-BE49-F238E27FC236}">
                 <a16:creationId xmlns:a16="http://schemas.microsoft.com/office/drawing/2014/main" id="{5B8D8E9E-6BF3-49DF-8938-4F9EA571ABAB}"/>
@@ -18816,7 +18816,7 @@
       </p:sp>
       <p:sp>
         <p:nvSpPr>
-          <p:cNvPr id="25" name="">
+          <p:cNvPr id="26" name="">
             <a:extLst xmlns:a="http://schemas.openxmlformats.org/drawingml/2006/main">
               <a:ext uri="{FF2B5EF4-FFF2-40B4-BE49-F238E27FC236}">
                 <a16:creationId xmlns:a16="http://schemas.microsoft.com/office/drawing/2014/main" id="{B9B5EB38-637D-4B66-8407-6ADF97AE5525}"/>
@@ -18848,7 +18848,7 @@
       </p:sp>
       <p:sp>
         <p:nvSpPr>
-          <p:cNvPr id="26" name="">
+          <p:cNvPr id="27" name="">
             <a:extLst xmlns:a="http://schemas.openxmlformats.org/drawingml/2006/main">
               <a:ext uri="{FF2B5EF4-FFF2-40B4-BE49-F238E27FC236}">
                 <a16:creationId xmlns:a16="http://schemas.microsoft.com/office/drawing/2014/main" id="{BF0364F5-381E-4268-A1E6-DCE408356EE4}"/>
@@ -18880,7 +18880,7 @@
       </p:sp>
       <p:sp>
         <p:nvSpPr>
-          <p:cNvPr id="27" name="">
+          <p:cNvPr id="28" name="">
             <a:extLst xmlns:a="http://schemas.openxmlformats.org/drawingml/2006/main">
               <a:ext uri="{FF2B5EF4-FFF2-40B4-BE49-F238E27FC236}">
                 <a16:creationId xmlns:a16="http://schemas.microsoft.com/office/drawing/2014/main" id="{C88E674B-4ABE-4395-8209-8F9B5DA63DF1}"/>
@@ -18926,7 +18926,7 @@
       </p:sp>
       <p:sp>
         <p:nvSpPr>
-          <p:cNvPr id="28" name="">
+          <p:cNvPr id="29" name="">
             <a:extLst xmlns:a="http://schemas.openxmlformats.org/drawingml/2006/main">
               <a:ext uri="{FF2B5EF4-FFF2-40B4-BE49-F238E27FC236}">
                 <a16:creationId xmlns:a16="http://schemas.microsoft.com/office/drawing/2014/main" id="{0D5E17DE-3299-406A-B83A-E19375AE8C12}"/>
@@ -18958,7 +18958,7 @@
       </p:sp>
       <p:sp>
         <p:nvSpPr>
-          <p:cNvPr id="29" name="">
+          <p:cNvPr id="30" name="">
             <a:extLst xmlns:a="http://schemas.openxmlformats.org/drawingml/2006/main">
               <a:ext uri="{FF2B5EF4-FFF2-40B4-BE49-F238E27FC236}">
                 <a16:creationId xmlns:a16="http://schemas.microsoft.com/office/drawing/2014/main" id="{799BD317-7781-473C-BD1D-5233253AA958}"/>
@@ -18990,7 +18990,7 @@
       </p:sp>
       <p:sp>
         <p:nvSpPr>
-          <p:cNvPr id="30" name="">
+          <p:cNvPr id="31" name="">
             <a:extLst xmlns:a="http://schemas.openxmlformats.org/drawingml/2006/main">
               <a:ext uri="{FF2B5EF4-FFF2-40B4-BE49-F238E27FC236}">
                 <a16:creationId xmlns:a16="http://schemas.microsoft.com/office/drawing/2014/main" id="{629F047E-4723-4DB5-A0E4-8448C18E6082}"/>
@@ -19036,7 +19036,7 @@
       </p:sp>
       <p:sp>
         <p:nvSpPr>
-          <p:cNvPr id="31" name="">
+          <p:cNvPr id="32" name="">
             <a:extLst xmlns:a="http://schemas.openxmlformats.org/drawingml/2006/main">
               <a:ext uri="{FF2B5EF4-FFF2-40B4-BE49-F238E27FC236}">
                 <a16:creationId xmlns:a16="http://schemas.microsoft.com/office/drawing/2014/main" id="{CEED762D-7345-43A6-82BB-22CE60BF2327}"/>
@@ -19105,7 +19105,7 @@
       </p:grpSpPr>
       <p:sp>
         <p:nvSpPr>
-          <p:cNvPr id="1" name="Slide Number Placeholder 5">
+          <p:cNvPr id="2" name="Slide Number Placeholder 5">
             <a:extLst xmlns:a="http://schemas.openxmlformats.org/drawingml/2006/main">
               <a:ext uri="{FF2B5EF4-FFF2-40B4-BE49-F238E27FC236}">
                 <a16:creationId xmlns:a16="http://schemas.microsoft.com/office/drawing/2014/main" id="{70659316-B4BB-42AA-9EDF-4B27092320CB}"/>
@@ -19137,7 +19137,7 @@
       </p:sp>
       <p:sp>
         <p:nvSpPr>
-          <p:cNvPr id="2" name="">
+          <p:cNvPr id="3" name="">
             <a:extLst xmlns:a="http://schemas.openxmlformats.org/drawingml/2006/main">
               <a:ext uri="{FF2B5EF4-FFF2-40B4-BE49-F238E27FC236}">
                 <a16:creationId xmlns:a16="http://schemas.microsoft.com/office/drawing/2014/main" id="{A4ED568F-5C79-4EA6-BDB4-949DEFD4C42B}"/>
@@ -19169,7 +19169,7 @@
       </p:sp>
       <p:sp>
         <p:nvSpPr>
-          <p:cNvPr id="3" name="">
+          <p:cNvPr id="4" name="">
             <a:extLst xmlns:a="http://schemas.openxmlformats.org/drawingml/2006/main">
               <a:ext uri="{FF2B5EF4-FFF2-40B4-BE49-F238E27FC236}">
                 <a16:creationId xmlns:a16="http://schemas.microsoft.com/office/drawing/2014/main" id="{158F1731-A3D7-4D5F-9E93-0FF34D79D7E6}"/>
@@ -19201,7 +19201,7 @@
       </p:sp>
       <p:sp>
         <p:nvSpPr>
-          <p:cNvPr id="4" name="">
+          <p:cNvPr id="5" name="">
             <a:extLst xmlns:a="http://schemas.openxmlformats.org/drawingml/2006/main">
               <a:ext uri="{FF2B5EF4-FFF2-40B4-BE49-F238E27FC236}">
                 <a16:creationId xmlns:a16="http://schemas.microsoft.com/office/drawing/2014/main" id="{EA1150A7-45DE-4999-933C-FE511F6D82FA}"/>
@@ -19245,7 +19245,7 @@
       </p:sp>
       <p:sp>
         <p:nvSpPr>
-          <p:cNvPr id="5" name="">
+          <p:cNvPr id="6" name="">
             <a:extLst xmlns:a="http://schemas.openxmlformats.org/drawingml/2006/main">
               <a:ext uri="{FF2B5EF4-FFF2-40B4-BE49-F238E27FC236}">
                 <a16:creationId xmlns:a16="http://schemas.microsoft.com/office/drawing/2014/main" id="{4435BF1A-3540-4C8C-823B-74B8F8377D46}"/>
@@ -19291,7 +19291,7 @@
       </p:sp>
       <p:sp>
         <p:nvSpPr>
-          <p:cNvPr id="6" name="">
+          <p:cNvPr id="7" name="">
             <a:extLst xmlns:a="http://schemas.openxmlformats.org/drawingml/2006/main">
               <a:ext uri="{FF2B5EF4-FFF2-40B4-BE49-F238E27FC236}">
                 <a16:creationId xmlns:a16="http://schemas.microsoft.com/office/drawing/2014/main" id="{2CF423F9-9789-4077-A25D-12EEEA45F334}"/>
@@ -19337,7 +19337,7 @@
       </p:sp>
       <p:sp>
         <p:nvSpPr>
-          <p:cNvPr id="7" name="">
+          <p:cNvPr id="8" name="">
             <a:extLst xmlns:a="http://schemas.openxmlformats.org/drawingml/2006/main">
               <a:ext uri="{FF2B5EF4-FFF2-40B4-BE49-F238E27FC236}">
                 <a16:creationId xmlns:a16="http://schemas.microsoft.com/office/drawing/2014/main" id="{185C9E01-05F1-4EE6-9BBF-C388E3A817F6}"/>
@@ -19369,7 +19369,7 @@
       </p:sp>
       <p:sp>
         <p:nvSpPr>
-          <p:cNvPr id="8" name="">
+          <p:cNvPr id="9" name="">
             <a:extLst xmlns:a="http://schemas.openxmlformats.org/drawingml/2006/main">
               <a:ext uri="{FF2B5EF4-FFF2-40B4-BE49-F238E27FC236}">
                 <a16:creationId xmlns:a16="http://schemas.microsoft.com/office/drawing/2014/main" id="{1D1512FB-C61E-4397-A542-932141CCA0EC}"/>
@@ -19413,7 +19413,7 @@
       </p:sp>
       <p:sp>
         <p:nvSpPr>
-          <p:cNvPr id="9" name="">
+          <p:cNvPr id="10" name="">
             <a:extLst xmlns:a="http://schemas.openxmlformats.org/drawingml/2006/main">
               <a:ext uri="{FF2B5EF4-FFF2-40B4-BE49-F238E27FC236}">
                 <a16:creationId xmlns:a16="http://schemas.microsoft.com/office/drawing/2014/main" id="{4D97A8FD-BBFC-457C-99BE-75992D76A7DA}"/>
@@ -19458,7 +19458,7 @@
       </p:sp>
       <p:sp>
         <p:nvSpPr>
-          <p:cNvPr id="10" name="">
+          <p:cNvPr id="11" name="">
             <a:extLst xmlns:a="http://schemas.openxmlformats.org/drawingml/2006/main">
               <a:ext uri="{FF2B5EF4-FFF2-40B4-BE49-F238E27FC236}">
                 <a16:creationId xmlns:a16="http://schemas.microsoft.com/office/drawing/2014/main" id="{FD8152FF-86A6-4206-85BF-A62CE6D525D1}"/>
@@ -19490,7 +19490,7 @@
       </p:sp>
       <p:sp>
         <p:nvSpPr>
-          <p:cNvPr id="11" name="">
+          <p:cNvPr id="12" name="">
             <a:extLst xmlns:a="http://schemas.openxmlformats.org/drawingml/2006/main">
               <a:ext uri="{FF2B5EF4-FFF2-40B4-BE49-F238E27FC236}">
                 <a16:creationId xmlns:a16="http://schemas.microsoft.com/office/drawing/2014/main" id="{05919AC9-D25A-4DC0-A068-12E0939AED0E}"/>
@@ -19534,7 +19534,7 @@
       </p:sp>
       <p:sp>
         <p:nvSpPr>
-          <p:cNvPr id="12" name="">
+          <p:cNvPr id="13" name="">
             <a:extLst xmlns:a="http://schemas.openxmlformats.org/drawingml/2006/main">
               <a:ext uri="{FF2B5EF4-FFF2-40B4-BE49-F238E27FC236}">
                 <a16:creationId xmlns:a16="http://schemas.microsoft.com/office/drawing/2014/main" id="{BF7122F8-36B0-49E9-AF88-306B889386E2}"/>
@@ -19581,7 +19581,7 @@
       </p:sp>
       <p:sp>
         <p:nvSpPr>
-          <p:cNvPr id="13" name="">
+          <p:cNvPr id="14" name="">
             <a:extLst xmlns:a="http://schemas.openxmlformats.org/drawingml/2006/main">
               <a:ext uri="{FF2B5EF4-FFF2-40B4-BE49-F238E27FC236}">
                 <a16:creationId xmlns:a16="http://schemas.microsoft.com/office/drawing/2014/main" id="{F3F719B5-9B68-435F-8668-0C1AF6698D2B}"/>
@@ -19628,7 +19628,7 @@
       </p:sp>
       <p:sp>
         <p:nvSpPr>
-          <p:cNvPr id="14" name="">
+          <p:cNvPr id="15" name="">
             <a:extLst xmlns:a="http://schemas.openxmlformats.org/drawingml/2006/main">
               <a:ext uri="{FF2B5EF4-FFF2-40B4-BE49-F238E27FC236}">
                 <a16:creationId xmlns:a16="http://schemas.microsoft.com/office/drawing/2014/main" id="{C85A06ED-E580-4D34-811C-E2618CC42AC4}"/>
@@ -19675,7 +19675,7 @@
       </p:sp>
       <p:sp>
         <p:nvSpPr>
-          <p:cNvPr id="15" name="">
+          <p:cNvPr id="16" name="">
             <a:extLst xmlns:a="http://schemas.openxmlformats.org/drawingml/2006/main">
               <a:ext uri="{FF2B5EF4-FFF2-40B4-BE49-F238E27FC236}">
                 <a16:creationId xmlns:a16="http://schemas.microsoft.com/office/drawing/2014/main" id="{A090AED5-0553-4294-9897-660EFCB0B259}"/>
@@ -19722,7 +19722,7 @@
       </p:sp>
       <p:sp>
         <p:nvSpPr>
-          <p:cNvPr id="16" name="">
+          <p:cNvPr id="17" name="">
             <a:extLst xmlns:a="http://schemas.openxmlformats.org/drawingml/2006/main">
               <a:ext uri="{FF2B5EF4-FFF2-40B4-BE49-F238E27FC236}">
                 <a16:creationId xmlns:a16="http://schemas.microsoft.com/office/drawing/2014/main" id="{53DD7EA0-C53C-44FE-B20B-2CB67869FCDF}"/>
@@ -19754,7 +19754,7 @@
       </p:sp>
       <p:sp>
         <p:nvSpPr>
-          <p:cNvPr id="17" name="">
+          <p:cNvPr id="18" name="">
             <a:extLst xmlns:a="http://schemas.openxmlformats.org/drawingml/2006/main">
               <a:ext uri="{FF2B5EF4-FFF2-40B4-BE49-F238E27FC236}">
                 <a16:creationId xmlns:a16="http://schemas.microsoft.com/office/drawing/2014/main" id="{3BC5742B-D421-43FA-8CA0-F5B97D568197}"/>
@@ -19798,7 +19798,7 @@
       </p:sp>
       <p:sp>
         <p:nvSpPr>
-          <p:cNvPr id="18" name="">
+          <p:cNvPr id="19" name="">
             <a:extLst xmlns:a="http://schemas.openxmlformats.org/drawingml/2006/main">
               <a:ext uri="{FF2B5EF4-FFF2-40B4-BE49-F238E27FC236}">
                 <a16:creationId xmlns:a16="http://schemas.microsoft.com/office/drawing/2014/main" id="{9CA4D7A2-E815-4015-8463-F712B4D27BAB}"/>
@@ -19846,7 +19846,7 @@
       </p:sp>
       <p:sp>
         <p:nvSpPr>
-          <p:cNvPr id="19" name="">
+          <p:cNvPr id="20" name="">
             <a:extLst xmlns:a="http://schemas.openxmlformats.org/drawingml/2006/main">
               <a:ext uri="{FF2B5EF4-FFF2-40B4-BE49-F238E27FC236}">
                 <a16:creationId xmlns:a16="http://schemas.microsoft.com/office/drawing/2014/main" id="{EB5B195E-7EE0-4E3D-9A2B-0C2610A3A2B3}"/>
@@ -19878,7 +19878,7 @@
       </p:sp>
       <p:sp>
         <p:nvSpPr>
-          <p:cNvPr id="20" name="">
+          <p:cNvPr id="21" name="">
             <a:extLst xmlns:a="http://schemas.openxmlformats.org/drawingml/2006/main">
               <a:ext uri="{FF2B5EF4-FFF2-40B4-BE49-F238E27FC236}">
                 <a16:creationId xmlns:a16="http://schemas.microsoft.com/office/drawing/2014/main" id="{10D38723-70DA-46B9-B8F7-3E43FE0B57A8}"/>
@@ -19926,7 +19926,7 @@
       </p:sp>
       <p:sp>
         <p:nvSpPr>
-          <p:cNvPr id="21" name="">
+          <p:cNvPr id="22" name="">
             <a:extLst xmlns:a="http://schemas.openxmlformats.org/drawingml/2006/main">
               <a:ext uri="{FF2B5EF4-FFF2-40B4-BE49-F238E27FC236}">
                 <a16:creationId xmlns:a16="http://schemas.microsoft.com/office/drawing/2014/main" id="{3785FD91-9AAF-4040-9748-D37C0915F5F9}"/>
@@ -19958,7 +19958,7 @@
       </p:sp>
       <p:sp>
         <p:nvSpPr>
-          <p:cNvPr id="22" name="">
+          <p:cNvPr id="23" name="">
             <a:extLst xmlns:a="http://schemas.openxmlformats.org/drawingml/2006/main">
               <a:ext uri="{FF2B5EF4-FFF2-40B4-BE49-F238E27FC236}">
                 <a16:creationId xmlns:a16="http://schemas.microsoft.com/office/drawing/2014/main" id="{95D87787-22CE-46C9-A1DD-C1DD7707E61F}"/>
@@ -20006,7 +20006,7 @@
       </p:sp>
       <p:sp>
         <p:nvSpPr>
-          <p:cNvPr id="23" name="">
+          <p:cNvPr id="24" name="">
             <a:extLst xmlns:a="http://schemas.openxmlformats.org/drawingml/2006/main">
               <a:ext uri="{FF2B5EF4-FFF2-40B4-BE49-F238E27FC236}">
                 <a16:creationId xmlns:a16="http://schemas.microsoft.com/office/drawing/2014/main" id="{3C37F089-863F-4599-81CC-0B3061147D73}"/>
@@ -20038,7 +20038,7 @@
       </p:sp>
       <p:sp>
         <p:nvSpPr>
-          <p:cNvPr id="24" name="">
+          <p:cNvPr id="25" name="">
             <a:extLst xmlns:a="http://schemas.openxmlformats.org/drawingml/2006/main">
               <a:ext uri="{FF2B5EF4-FFF2-40B4-BE49-F238E27FC236}">
                 <a16:creationId xmlns:a16="http://schemas.microsoft.com/office/drawing/2014/main" id="{D62292D5-ED2D-4D56-9808-D1FD81971C3E}"/>
@@ -20107,7 +20107,7 @@
       </p:grpSpPr>
       <p:sp>
         <p:nvSpPr>
-          <p:cNvPr id="1" name="Slide Number Placeholder 5">
+          <p:cNvPr id="2" name="Slide Number Placeholder 5">
             <a:extLst xmlns:a="http://schemas.openxmlformats.org/drawingml/2006/main">
               <a:ext uri="{FF2B5EF4-FFF2-40B4-BE49-F238E27FC236}">
                 <a16:creationId xmlns:a16="http://schemas.microsoft.com/office/drawing/2014/main" id="{70659316-B4BB-42AA-9EDF-4B27092320CB}"/>
@@ -20139,7 +20139,7 @@
       </p:sp>
       <p:sp>
         <p:nvSpPr>
-          <p:cNvPr id="2" name="">
+          <p:cNvPr id="3" name="">
             <a:extLst xmlns:a="http://schemas.openxmlformats.org/drawingml/2006/main">
               <a:ext uri="{FF2B5EF4-FFF2-40B4-BE49-F238E27FC236}">
                 <a16:creationId xmlns:a16="http://schemas.microsoft.com/office/drawing/2014/main" id="{57EB7581-C153-488C-AE29-7C18076C8078}"/>
@@ -20171,7 +20171,7 @@
       </p:sp>
       <p:sp>
         <p:nvSpPr>
-          <p:cNvPr id="3" name="">
+          <p:cNvPr id="4" name="">
             <a:extLst xmlns:a="http://schemas.openxmlformats.org/drawingml/2006/main">
               <a:ext uri="{FF2B5EF4-FFF2-40B4-BE49-F238E27FC236}">
                 <a16:creationId xmlns:a16="http://schemas.microsoft.com/office/drawing/2014/main" id="{299158AE-B39D-421B-9A69-F7948EE21E9C}"/>
@@ -20203,7 +20203,7 @@
       </p:sp>
       <p:sp>
         <p:nvSpPr>
-          <p:cNvPr id="4" name="">
+          <p:cNvPr id="5" name="">
             <a:extLst xmlns:a="http://schemas.openxmlformats.org/drawingml/2006/main">
               <a:ext uri="{FF2B5EF4-FFF2-40B4-BE49-F238E27FC236}">
                 <a16:creationId xmlns:a16="http://schemas.microsoft.com/office/drawing/2014/main" id="{1F9D387C-CDE4-4AFB-AEF1-E50D3CFC6E80}"/>
@@ -20247,7 +20247,7 @@
       </p:sp>
       <p:sp>
         <p:nvSpPr>
-          <p:cNvPr id="5" name="">
+          <p:cNvPr id="6" name="">
             <a:extLst xmlns:a="http://schemas.openxmlformats.org/drawingml/2006/main">
               <a:ext uri="{FF2B5EF4-FFF2-40B4-BE49-F238E27FC236}">
                 <a16:creationId xmlns:a16="http://schemas.microsoft.com/office/drawing/2014/main" id="{03290D5B-4AB2-417F-98EA-8A492838ED46}"/>
@@ -20293,7 +20293,7 @@
       </p:sp>
       <p:sp>
         <p:nvSpPr>
-          <p:cNvPr id="6" name="">
+          <p:cNvPr id="7" name="">
             <a:extLst xmlns:a="http://schemas.openxmlformats.org/drawingml/2006/main">
               <a:ext uri="{FF2B5EF4-FFF2-40B4-BE49-F238E27FC236}">
                 <a16:creationId xmlns:a16="http://schemas.microsoft.com/office/drawing/2014/main" id="{85B80A05-88B5-481C-AB84-79237E35D726}"/>
@@ -20339,7 +20339,7 @@
       </p:sp>
       <p:sp>
         <p:nvSpPr>
-          <p:cNvPr id="7" name="">
+          <p:cNvPr id="8" name="">
             <a:extLst xmlns:a="http://schemas.openxmlformats.org/drawingml/2006/main">
               <a:ext uri="{FF2B5EF4-FFF2-40B4-BE49-F238E27FC236}">
                 <a16:creationId xmlns:a16="http://schemas.microsoft.com/office/drawing/2014/main" id="{0A9A9170-947E-4800-BBE0-466D479212B0}"/>
@@ -20371,7 +20371,7 @@
       </p:sp>
       <p:sp>
         <p:nvSpPr>
-          <p:cNvPr id="8" name="">
+          <p:cNvPr id="9" name="">
             <a:extLst xmlns:a="http://schemas.openxmlformats.org/drawingml/2006/main">
               <a:ext uri="{FF2B5EF4-FFF2-40B4-BE49-F238E27FC236}">
                 <a16:creationId xmlns:a16="http://schemas.microsoft.com/office/drawing/2014/main" id="{AE7202EB-C2FC-4B56-BDFA-8E1414F53DAC}"/>
@@ -20415,7 +20415,7 @@
       </p:sp>
       <p:sp>
         <p:nvSpPr>
-          <p:cNvPr id="9" name="">
+          <p:cNvPr id="10" name="">
             <a:extLst xmlns:a="http://schemas.openxmlformats.org/drawingml/2006/main">
               <a:ext uri="{FF2B5EF4-FFF2-40B4-BE49-F238E27FC236}">
                 <a16:creationId xmlns:a16="http://schemas.microsoft.com/office/drawing/2014/main" id="{BAD1C844-2E59-454F-9E47-327133038174}"/>
@@ -20460,7 +20460,7 @@
       </p:sp>
       <p:sp>
         <p:nvSpPr>
-          <p:cNvPr id="10" name="">
+          <p:cNvPr id="11" name="">
             <a:extLst xmlns:a="http://schemas.openxmlformats.org/drawingml/2006/main">
               <a:ext uri="{FF2B5EF4-FFF2-40B4-BE49-F238E27FC236}">
                 <a16:creationId xmlns:a16="http://schemas.microsoft.com/office/drawing/2014/main" id="{BB6B1D21-B157-4D8A-9823-E2081CBA52AF}"/>
@@ -20492,7 +20492,7 @@
       </p:sp>
       <p:sp>
         <p:nvSpPr>
-          <p:cNvPr id="11" name="">
+          <p:cNvPr id="12" name="">
             <a:extLst xmlns:a="http://schemas.openxmlformats.org/drawingml/2006/main">
               <a:ext uri="{FF2B5EF4-FFF2-40B4-BE49-F238E27FC236}">
                 <a16:creationId xmlns:a16="http://schemas.microsoft.com/office/drawing/2014/main" id="{7A5A7E4D-F390-4BE9-8755-7E02228A5969}"/>
@@ -20536,7 +20536,7 @@
       </p:sp>
       <p:sp>
         <p:nvSpPr>
-          <p:cNvPr id="12" name="">
+          <p:cNvPr id="13" name="">
             <a:extLst xmlns:a="http://schemas.openxmlformats.org/drawingml/2006/main">
               <a:ext uri="{FF2B5EF4-FFF2-40B4-BE49-F238E27FC236}">
                 <a16:creationId xmlns:a16="http://schemas.microsoft.com/office/drawing/2014/main" id="{CFC9F457-3C6A-4571-90A5-262405D8F0AC}"/>
@@ -20568,7 +20568,7 @@
       </p:sp>
       <p:sp>
         <p:nvSpPr>
-          <p:cNvPr id="13" name="">
+          <p:cNvPr id="14" name="">
             <a:extLst xmlns:a="http://schemas.openxmlformats.org/drawingml/2006/main">
               <a:ext uri="{FF2B5EF4-FFF2-40B4-BE49-F238E27FC236}">
                 <a16:creationId xmlns:a16="http://schemas.microsoft.com/office/drawing/2014/main" id="{BC0B976A-D14B-494E-96A5-2AE6B14BBE40}"/>
@@ -20614,7 +20614,7 @@
       </p:sp>
       <p:sp>
         <p:nvSpPr>
-          <p:cNvPr id="14" name="">
+          <p:cNvPr id="15" name="">
             <a:extLst xmlns:a="http://schemas.openxmlformats.org/drawingml/2006/main">
               <a:ext uri="{FF2B5EF4-FFF2-40B4-BE49-F238E27FC236}">
                 <a16:creationId xmlns:a16="http://schemas.microsoft.com/office/drawing/2014/main" id="{F1D542F4-65EA-4572-88B0-1496782CE629}"/>
@@ -20646,7 +20646,7 @@
       </p:sp>
       <p:sp>
         <p:nvSpPr>
-          <p:cNvPr id="15" name="">
+          <p:cNvPr id="16" name="">
             <a:extLst xmlns:a="http://schemas.openxmlformats.org/drawingml/2006/main">
               <a:ext uri="{FF2B5EF4-FFF2-40B4-BE49-F238E27FC236}">
                 <a16:creationId xmlns:a16="http://schemas.microsoft.com/office/drawing/2014/main" id="{22A25BBE-D58E-4F9B-B3E0-EA028EFADF9D}"/>
@@ -20692,7 +20692,7 @@
       </p:sp>
       <p:sp>
         <p:nvSpPr>
-          <p:cNvPr id="16" name="">
+          <p:cNvPr id="17" name="">
             <a:extLst xmlns:a="http://schemas.openxmlformats.org/drawingml/2006/main">
               <a:ext uri="{FF2B5EF4-FFF2-40B4-BE49-F238E27FC236}">
                 <a16:creationId xmlns:a16="http://schemas.microsoft.com/office/drawing/2014/main" id="{AE1CBD0A-3B71-4851-95E0-8CD08A8D0C07}"/>
@@ -20724,7 +20724,7 @@
       </p:sp>
       <p:sp>
         <p:nvSpPr>
-          <p:cNvPr id="17" name="">
+          <p:cNvPr id="18" name="">
             <a:extLst xmlns:a="http://schemas.openxmlformats.org/drawingml/2006/main">
               <a:ext uri="{FF2B5EF4-FFF2-40B4-BE49-F238E27FC236}">
                 <a16:creationId xmlns:a16="http://schemas.microsoft.com/office/drawing/2014/main" id="{6EA3364B-4F83-449E-9AAC-D5682E2A5325}"/>
@@ -20770,7 +20770,7 @@
       </p:sp>
       <p:sp>
         <p:nvSpPr>
-          <p:cNvPr id="18" name="">
+          <p:cNvPr id="19" name="">
             <a:extLst xmlns:a="http://schemas.openxmlformats.org/drawingml/2006/main">
               <a:ext uri="{FF2B5EF4-FFF2-40B4-BE49-F238E27FC236}">
                 <a16:creationId xmlns:a16="http://schemas.microsoft.com/office/drawing/2014/main" id="{CB12556A-FC92-4762-AD3E-E53A1AD98CD5}"/>
@@ -20802,7 +20802,7 @@
       </p:sp>
       <p:sp>
         <p:nvSpPr>
-          <p:cNvPr id="19" name="">
+          <p:cNvPr id="20" name="">
             <a:extLst xmlns:a="http://schemas.openxmlformats.org/drawingml/2006/main">
               <a:ext uri="{FF2B5EF4-FFF2-40B4-BE49-F238E27FC236}">
                 <a16:creationId xmlns:a16="http://schemas.microsoft.com/office/drawing/2014/main" id="{914D6E57-A604-4DC4-9CE3-9E3F36CE8CB5}"/>
@@ -20848,7 +20848,7 @@
       </p:sp>
       <p:sp>
         <p:nvSpPr>
-          <p:cNvPr id="20" name="">
+          <p:cNvPr id="21" name="">
             <a:extLst xmlns:a="http://schemas.openxmlformats.org/drawingml/2006/main">
               <a:ext uri="{FF2B5EF4-FFF2-40B4-BE49-F238E27FC236}">
                 <a16:creationId xmlns:a16="http://schemas.microsoft.com/office/drawing/2014/main" id="{76EFC11A-DB4A-41F1-8397-EA7DDB54B6C5}"/>
@@ -20880,7 +20880,7 @@
       </p:sp>
       <p:sp>
         <p:nvSpPr>
-          <p:cNvPr id="21" name="">
+          <p:cNvPr id="22" name="">
             <a:extLst xmlns:a="http://schemas.openxmlformats.org/drawingml/2006/main">
               <a:ext uri="{FF2B5EF4-FFF2-40B4-BE49-F238E27FC236}">
                 <a16:creationId xmlns:a16="http://schemas.microsoft.com/office/drawing/2014/main" id="{46508A5D-3945-43AA-A97D-787A95DF2F89}"/>
@@ -20926,7 +20926,7 @@
       </p:sp>
       <p:sp>
         <p:nvSpPr>
-          <p:cNvPr id="22" name="">
+          <p:cNvPr id="23" name="">
             <a:extLst xmlns:a="http://schemas.openxmlformats.org/drawingml/2006/main">
               <a:ext uri="{FF2B5EF4-FFF2-40B4-BE49-F238E27FC236}">
                 <a16:creationId xmlns:a16="http://schemas.microsoft.com/office/drawing/2014/main" id="{917DD456-819B-4A11-A70D-6680282B81F9}"/>
@@ -20958,7 +20958,7 @@
       </p:sp>
       <p:sp>
         <p:nvSpPr>
-          <p:cNvPr id="23" name="">
+          <p:cNvPr id="24" name="">
             <a:extLst xmlns:a="http://schemas.openxmlformats.org/drawingml/2006/main">
               <a:ext uri="{FF2B5EF4-FFF2-40B4-BE49-F238E27FC236}">
                 <a16:creationId xmlns:a16="http://schemas.microsoft.com/office/drawing/2014/main" id="{4A7C8A3D-3BF3-4925-B0DF-A64B60BB5EEC}"/>
@@ -21004,7 +21004,7 @@
       </p:sp>
       <p:sp>
         <p:nvSpPr>
-          <p:cNvPr id="24" name="">
+          <p:cNvPr id="25" name="">
             <a:extLst xmlns:a="http://schemas.openxmlformats.org/drawingml/2006/main">
               <a:ext uri="{FF2B5EF4-FFF2-40B4-BE49-F238E27FC236}">
                 <a16:creationId xmlns:a16="http://schemas.microsoft.com/office/drawing/2014/main" id="{9F92669F-5B98-4C7E-9D02-9516CE87396A}"/>
@@ -21036,7 +21036,7 @@
       </p:sp>
       <p:sp>
         <p:nvSpPr>
-          <p:cNvPr id="25" name="">
+          <p:cNvPr id="26" name="">
             <a:extLst xmlns:a="http://schemas.openxmlformats.org/drawingml/2006/main">
               <a:ext uri="{FF2B5EF4-FFF2-40B4-BE49-F238E27FC236}">
                 <a16:creationId xmlns:a16="http://schemas.microsoft.com/office/drawing/2014/main" id="{25D3234A-EDEF-4325-B03B-2423E3509F43}"/>
@@ -21082,7 +21082,7 @@
       </p:sp>
       <p:sp>
         <p:nvSpPr>
-          <p:cNvPr id="26" name="">
+          <p:cNvPr id="27" name="">
             <a:extLst xmlns:a="http://schemas.openxmlformats.org/drawingml/2006/main">
               <a:ext uri="{FF2B5EF4-FFF2-40B4-BE49-F238E27FC236}">
                 <a16:creationId xmlns:a16="http://schemas.microsoft.com/office/drawing/2014/main" id="{6CC7E613-8539-4E21-B626-1768CEDF800A}"/>
@@ -21114,7 +21114,7 @@
       </p:sp>
       <p:sp>
         <p:nvSpPr>
-          <p:cNvPr id="27" name="">
+          <p:cNvPr id="28" name="">
             <a:extLst xmlns:a="http://schemas.openxmlformats.org/drawingml/2006/main">
               <a:ext uri="{FF2B5EF4-FFF2-40B4-BE49-F238E27FC236}">
                 <a16:creationId xmlns:a16="http://schemas.microsoft.com/office/drawing/2014/main" id="{8B32A083-E8D5-4058-97EF-915ECADE9CB8}"/>
@@ -21160,7 +21160,7 @@
       </p:sp>
       <p:sp>
         <p:nvSpPr>
-          <p:cNvPr id="28" name="">
+          <p:cNvPr id="29" name="">
             <a:extLst xmlns:a="http://schemas.openxmlformats.org/drawingml/2006/main">
               <a:ext uri="{FF2B5EF4-FFF2-40B4-BE49-F238E27FC236}">
                 <a16:creationId xmlns:a16="http://schemas.microsoft.com/office/drawing/2014/main" id="{6D4686B8-E19F-4C6B-B10C-0C1A0A7DA4CB}"/>
@@ -21192,7 +21192,7 @@
       </p:sp>
       <p:sp>
         <p:nvSpPr>
-          <p:cNvPr id="29" name="">
+          <p:cNvPr id="30" name="">
             <a:extLst xmlns:a="http://schemas.openxmlformats.org/drawingml/2006/main">
               <a:ext uri="{FF2B5EF4-FFF2-40B4-BE49-F238E27FC236}">
                 <a16:creationId xmlns:a16="http://schemas.microsoft.com/office/drawing/2014/main" id="{79BC01D4-BD01-4963-B3F9-B51FE5E6FE3E}"/>
@@ -21236,7 +21236,7 @@
       </p:sp>
       <p:sp>
         <p:nvSpPr>
-          <p:cNvPr id="30" name="">
+          <p:cNvPr id="31" name="">
             <a:extLst xmlns:a="http://schemas.openxmlformats.org/drawingml/2006/main">
               <a:ext uri="{FF2B5EF4-FFF2-40B4-BE49-F238E27FC236}">
                 <a16:creationId xmlns:a16="http://schemas.microsoft.com/office/drawing/2014/main" id="{C6B262BD-1DBE-485E-8BB6-1B505C76D600}"/>
@@ -21268,7 +21268,7 @@
       </p:sp>
       <p:sp>
         <p:nvSpPr>
-          <p:cNvPr id="31" name="">
+          <p:cNvPr id="32" name="">
             <a:extLst xmlns:a="http://schemas.openxmlformats.org/drawingml/2006/main">
               <a:ext uri="{FF2B5EF4-FFF2-40B4-BE49-F238E27FC236}">
                 <a16:creationId xmlns:a16="http://schemas.microsoft.com/office/drawing/2014/main" id="{EC44B914-9608-441F-B973-99517CAC8E23}"/>
@@ -21314,7 +21314,7 @@
       </p:sp>
       <p:sp>
         <p:nvSpPr>
-          <p:cNvPr id="32" name="">
+          <p:cNvPr id="33" name="">
             <a:extLst xmlns:a="http://schemas.openxmlformats.org/drawingml/2006/main">
               <a:ext uri="{FF2B5EF4-FFF2-40B4-BE49-F238E27FC236}">
                 <a16:creationId xmlns:a16="http://schemas.microsoft.com/office/drawing/2014/main" id="{D7DAF27A-51AF-4037-A2BD-6C44374E048B}"/>
@@ -21346,7 +21346,7 @@
       </p:sp>
       <p:sp>
         <p:nvSpPr>
-          <p:cNvPr id="33" name="">
+          <p:cNvPr id="34" name="">
             <a:extLst xmlns:a="http://schemas.openxmlformats.org/drawingml/2006/main">
               <a:ext uri="{FF2B5EF4-FFF2-40B4-BE49-F238E27FC236}">
                 <a16:creationId xmlns:a16="http://schemas.microsoft.com/office/drawing/2014/main" id="{CDB3B05F-653A-4AB9-AA97-EE5FE6E56744}"/>
@@ -21392,7 +21392,7 @@
       </p:sp>
       <p:sp>
         <p:nvSpPr>
-          <p:cNvPr id="34" name="">
+          <p:cNvPr id="35" name="">
             <a:extLst xmlns:a="http://schemas.openxmlformats.org/drawingml/2006/main">
               <a:ext uri="{FF2B5EF4-FFF2-40B4-BE49-F238E27FC236}">
                 <a16:creationId xmlns:a16="http://schemas.microsoft.com/office/drawing/2014/main" id="{E3D1037D-6EA9-452E-AD2F-E908B5CA8919}"/>
@@ -21424,7 +21424,7 @@
       </p:sp>
       <p:sp>
         <p:nvSpPr>
-          <p:cNvPr id="35" name="">
+          <p:cNvPr id="36" name="">
             <a:extLst xmlns:a="http://schemas.openxmlformats.org/drawingml/2006/main">
               <a:ext uri="{FF2B5EF4-FFF2-40B4-BE49-F238E27FC236}">
                 <a16:creationId xmlns:a16="http://schemas.microsoft.com/office/drawing/2014/main" id="{4C081E08-7D3D-4684-B25E-A03703AB2CD3}"/>
@@ -21470,7 +21470,7 @@
       </p:sp>
       <p:sp>
         <p:nvSpPr>
-          <p:cNvPr id="36" name="">
+          <p:cNvPr id="37" name="">
             <a:extLst xmlns:a="http://schemas.openxmlformats.org/drawingml/2006/main">
               <a:ext uri="{FF2B5EF4-FFF2-40B4-BE49-F238E27FC236}">
                 <a16:creationId xmlns:a16="http://schemas.microsoft.com/office/drawing/2014/main" id="{2A07DA41-89F3-4A43-B586-1426F61B902F}"/>
@@ -21502,7 +21502,7 @@
       </p:sp>
       <p:sp>
         <p:nvSpPr>
-          <p:cNvPr id="37" name="">
+          <p:cNvPr id="38" name="">
             <a:extLst xmlns:a="http://schemas.openxmlformats.org/drawingml/2006/main">
               <a:ext uri="{FF2B5EF4-FFF2-40B4-BE49-F238E27FC236}">
                 <a16:creationId xmlns:a16="http://schemas.microsoft.com/office/drawing/2014/main" id="{98AFCD39-8631-4B27-9E3D-3442CAECFB4F}"/>
@@ -21548,7 +21548,7 @@
       </p:sp>
       <p:sp>
         <p:nvSpPr>
-          <p:cNvPr id="38" name="">
+          <p:cNvPr id="39" name="">
             <a:extLst xmlns:a="http://schemas.openxmlformats.org/drawingml/2006/main">
               <a:ext uri="{FF2B5EF4-FFF2-40B4-BE49-F238E27FC236}">
                 <a16:creationId xmlns:a16="http://schemas.microsoft.com/office/drawing/2014/main" id="{F676646B-6C1E-4465-9073-6697C2442C93}"/>
@@ -21580,7 +21580,7 @@
       </p:sp>
       <p:sp>
         <p:nvSpPr>
-          <p:cNvPr id="39" name="">
+          <p:cNvPr id="40" name="">
             <a:extLst xmlns:a="http://schemas.openxmlformats.org/drawingml/2006/main">
               <a:ext uri="{FF2B5EF4-FFF2-40B4-BE49-F238E27FC236}">
                 <a16:creationId xmlns:a16="http://schemas.microsoft.com/office/drawing/2014/main" id="{8C070E1B-3C31-4CED-BAFF-7999000E3ED9}"/>
@@ -21626,7 +21626,7 @@
       </p:sp>
       <p:sp>
         <p:nvSpPr>
-          <p:cNvPr id="40" name="">
+          <p:cNvPr id="41" name="">
             <a:extLst xmlns:a="http://schemas.openxmlformats.org/drawingml/2006/main">
               <a:ext uri="{FF2B5EF4-FFF2-40B4-BE49-F238E27FC236}">
                 <a16:creationId xmlns:a16="http://schemas.microsoft.com/office/drawing/2014/main" id="{9A1FF643-6C83-4354-A879-121746A0C103}"/>
@@ -21680,7 +21680,7 @@
       </p:grpSpPr>
       <p:sp>
         <p:nvSpPr>
-          <p:cNvPr id="1" name="Slide Number Placeholder 5">
+          <p:cNvPr id="2" name="Slide Number Placeholder 5">
             <a:extLst xmlns:a="http://schemas.openxmlformats.org/drawingml/2006/main">
               <a:ext uri="{FF2B5EF4-FFF2-40B4-BE49-F238E27FC236}">
                 <a16:creationId xmlns:a16="http://schemas.microsoft.com/office/drawing/2014/main" id="{70659316-B4BB-42AA-9EDF-4B27092320CB}"/>
@@ -21712,7 +21712,7 @@
       </p:sp>
       <p:sp>
         <p:nvSpPr>
-          <p:cNvPr id="2" name="">
+          <p:cNvPr id="3" name="">
             <a:extLst xmlns:a="http://schemas.openxmlformats.org/drawingml/2006/main">
               <a:ext uri="{FF2B5EF4-FFF2-40B4-BE49-F238E27FC236}">
                 <a16:creationId xmlns:a16="http://schemas.microsoft.com/office/drawing/2014/main" id="{8ED03103-6DAE-4324-B040-537E9149E0AC}"/>
@@ -21744,7 +21744,7 @@
       </p:sp>
       <p:sp>
         <p:nvSpPr>
-          <p:cNvPr id="3" name="">
+          <p:cNvPr id="4" name="">
             <a:extLst xmlns:a="http://schemas.openxmlformats.org/drawingml/2006/main">
               <a:ext uri="{FF2B5EF4-FFF2-40B4-BE49-F238E27FC236}">
                 <a16:creationId xmlns:a16="http://schemas.microsoft.com/office/drawing/2014/main" id="{C7EDE31A-6EDD-47CA-B1A8-E0DD21B97D3F}"/>
@@ -21776,7 +21776,7 @@
       </p:sp>
       <p:sp>
         <p:nvSpPr>
-          <p:cNvPr id="4" name="">
+          <p:cNvPr id="5" name="">
             <a:extLst xmlns:a="http://schemas.openxmlformats.org/drawingml/2006/main">
               <a:ext uri="{FF2B5EF4-FFF2-40B4-BE49-F238E27FC236}">
                 <a16:creationId xmlns:a16="http://schemas.microsoft.com/office/drawing/2014/main" id="{243C047E-17C4-49DE-8008-7370DBD867AE}"/>
@@ -21820,7 +21820,7 @@
       </p:sp>
       <p:sp>
         <p:nvSpPr>
-          <p:cNvPr id="5" name="">
+          <p:cNvPr id="6" name="">
             <a:extLst xmlns:a="http://schemas.openxmlformats.org/drawingml/2006/main">
               <a:ext uri="{FF2B5EF4-FFF2-40B4-BE49-F238E27FC236}">
                 <a16:creationId xmlns:a16="http://schemas.microsoft.com/office/drawing/2014/main" id="{5EC09905-9BE2-43FC-A2A3-18EDD18C0A93}"/>
@@ -21866,7 +21866,7 @@
       </p:sp>
       <p:sp>
         <p:nvSpPr>
-          <p:cNvPr id="6" name="">
+          <p:cNvPr id="7" name="">
             <a:extLst xmlns:a="http://schemas.openxmlformats.org/drawingml/2006/main">
               <a:ext uri="{FF2B5EF4-FFF2-40B4-BE49-F238E27FC236}">
                 <a16:creationId xmlns:a16="http://schemas.microsoft.com/office/drawing/2014/main" id="{6D72D446-615B-46ED-A889-C4801AEF4882}"/>
@@ -21912,7 +21912,7 @@
       </p:sp>
       <p:sp>
         <p:nvSpPr>
-          <p:cNvPr id="7" name="">
+          <p:cNvPr id="8" name="">
             <a:extLst xmlns:a="http://schemas.openxmlformats.org/drawingml/2006/main">
               <a:ext uri="{FF2B5EF4-FFF2-40B4-BE49-F238E27FC236}">
                 <a16:creationId xmlns:a16="http://schemas.microsoft.com/office/drawing/2014/main" id="{CC94C982-5F50-41FA-B5AC-D3AF26004385}"/>
@@ -21944,7 +21944,7 @@
       </p:sp>
       <p:sp>
         <p:nvSpPr>
-          <p:cNvPr id="8" name="">
+          <p:cNvPr id="9" name="">
             <a:extLst xmlns:a="http://schemas.openxmlformats.org/drawingml/2006/main">
               <a:ext uri="{FF2B5EF4-FFF2-40B4-BE49-F238E27FC236}">
                 <a16:creationId xmlns:a16="http://schemas.microsoft.com/office/drawing/2014/main" id="{1FA578A4-E4AF-433A-85C5-4AEC98A2E771}"/>
@@ -21988,7 +21988,7 @@
       </p:sp>
       <p:sp>
         <p:nvSpPr>
-          <p:cNvPr id="9" name="">
+          <p:cNvPr id="10" name="">
             <a:extLst xmlns:a="http://schemas.openxmlformats.org/drawingml/2006/main">
               <a:ext uri="{FF2B5EF4-FFF2-40B4-BE49-F238E27FC236}">
                 <a16:creationId xmlns:a16="http://schemas.microsoft.com/office/drawing/2014/main" id="{BCF7EEF8-DFC3-459E-9964-A3B04CE9D89A}"/>
@@ -22033,7 +22033,7 @@
       </p:sp>
       <p:sp>
         <p:nvSpPr>
-          <p:cNvPr id="10" name="">
+          <p:cNvPr id="11" name="">
             <a:extLst xmlns:a="http://schemas.openxmlformats.org/drawingml/2006/main">
               <a:ext uri="{FF2B5EF4-FFF2-40B4-BE49-F238E27FC236}">
                 <a16:creationId xmlns:a16="http://schemas.microsoft.com/office/drawing/2014/main" id="{B226DD27-7DD9-43C4-823F-7212897FFF18}"/>
@@ -22065,7 +22065,7 @@
       </p:sp>
       <p:sp>
         <p:nvSpPr>
-          <p:cNvPr id="11" name="">
+          <p:cNvPr id="12" name="">
             <a:extLst xmlns:a="http://schemas.openxmlformats.org/drawingml/2006/main">
               <a:ext uri="{FF2B5EF4-FFF2-40B4-BE49-F238E27FC236}">
                 <a16:creationId xmlns:a16="http://schemas.microsoft.com/office/drawing/2014/main" id="{199B9998-0CD2-4408-BDD0-92CF6D69E630}"/>
@@ -22097,7 +22097,7 @@
       </p:sp>
       <p:sp>
         <p:nvSpPr>
-          <p:cNvPr id="12" name="">
+          <p:cNvPr id="13" name="">
             <a:extLst xmlns:a="http://schemas.openxmlformats.org/drawingml/2006/main">
               <a:ext uri="{FF2B5EF4-FFF2-40B4-BE49-F238E27FC236}">
                 <a16:creationId xmlns:a16="http://schemas.microsoft.com/office/drawing/2014/main" id="{92DC98AF-5CBC-4E18-A3AE-8D43F54DB4E7}"/>
@@ -22142,7 +22142,7 @@
       </p:sp>
       <p:sp>
         <p:nvSpPr>
-          <p:cNvPr id="13" name="">
+          <p:cNvPr id="14" name="">
             <a:extLst xmlns:a="http://schemas.openxmlformats.org/drawingml/2006/main">
               <a:ext uri="{FF2B5EF4-FFF2-40B4-BE49-F238E27FC236}">
                 <a16:creationId xmlns:a16="http://schemas.microsoft.com/office/drawing/2014/main" id="{0C0D5D4C-B9FB-434D-B94F-2C66705EB968}"/>
@@ -22189,7 +22189,7 @@
       </p:sp>
       <p:sp>
         <p:nvSpPr>
-          <p:cNvPr id="14" name="">
+          <p:cNvPr id="15" name="">
             <a:extLst xmlns:a="http://schemas.openxmlformats.org/drawingml/2006/main">
               <a:ext uri="{FF2B5EF4-FFF2-40B4-BE49-F238E27FC236}">
                 <a16:creationId xmlns:a16="http://schemas.microsoft.com/office/drawing/2014/main" id="{EBE0E136-7E6E-4267-8577-60F435F6B1C9}"/>
@@ -22221,7 +22221,7 @@
       </p:sp>
       <p:sp>
         <p:nvSpPr>
-          <p:cNvPr id="15" name="">
+          <p:cNvPr id="16" name="">
             <a:extLst xmlns:a="http://schemas.openxmlformats.org/drawingml/2006/main">
               <a:ext uri="{FF2B5EF4-FFF2-40B4-BE49-F238E27FC236}">
                 <a16:creationId xmlns:a16="http://schemas.microsoft.com/office/drawing/2014/main" id="{3246C8B1-7E1C-4F47-98D5-4B3E9E4C1574}"/>
@@ -22253,7 +22253,7 @@
       </p:sp>
       <p:sp>
         <p:nvSpPr>
-          <p:cNvPr id="16" name="">
+          <p:cNvPr id="17" name="">
             <a:extLst xmlns:a="http://schemas.openxmlformats.org/drawingml/2006/main">
               <a:ext uri="{FF2B5EF4-FFF2-40B4-BE49-F238E27FC236}">
                 <a16:creationId xmlns:a16="http://schemas.microsoft.com/office/drawing/2014/main" id="{C270471E-C2EA-4B28-A4B6-505E0366C48C}"/>
@@ -22285,7 +22285,7 @@
       </p:sp>
       <p:sp>
         <p:nvSpPr>
-          <p:cNvPr id="17" name="">
+          <p:cNvPr id="18" name="">
             <a:extLst xmlns:a="http://schemas.openxmlformats.org/drawingml/2006/main">
               <a:ext uri="{FF2B5EF4-FFF2-40B4-BE49-F238E27FC236}">
                 <a16:creationId xmlns:a16="http://schemas.microsoft.com/office/drawing/2014/main" id="{3E0D695E-539F-45EA-8CD0-9D6C07C72C53}"/>
@@ -22330,7 +22330,7 @@
       </p:sp>
       <p:sp>
         <p:nvSpPr>
-          <p:cNvPr id="18" name="">
+          <p:cNvPr id="19" name="">
             <a:extLst xmlns:a="http://schemas.openxmlformats.org/drawingml/2006/main">
               <a:ext uri="{FF2B5EF4-FFF2-40B4-BE49-F238E27FC236}">
                 <a16:creationId xmlns:a16="http://schemas.microsoft.com/office/drawing/2014/main" id="{62E4F989-3ED5-4DE5-A2BE-67C1DFC7AAF5}"/>
@@ -22377,7 +22377,7 @@
       </p:sp>
       <p:sp>
         <p:nvSpPr>
-          <p:cNvPr id="19" name="">
+          <p:cNvPr id="20" name="">
             <a:extLst xmlns:a="http://schemas.openxmlformats.org/drawingml/2006/main">
               <a:ext uri="{FF2B5EF4-FFF2-40B4-BE49-F238E27FC236}">
                 <a16:creationId xmlns:a16="http://schemas.microsoft.com/office/drawing/2014/main" id="{07FE9B88-8D8E-4978-9C31-0DD9131D9607}"/>
@@ -22409,7 +22409,7 @@
       </p:sp>
       <p:sp>
         <p:nvSpPr>
-          <p:cNvPr id="20" name="">
+          <p:cNvPr id="21" name="">
             <a:extLst xmlns:a="http://schemas.openxmlformats.org/drawingml/2006/main">
               <a:ext uri="{FF2B5EF4-FFF2-40B4-BE49-F238E27FC236}">
                 <a16:creationId xmlns:a16="http://schemas.microsoft.com/office/drawing/2014/main" id="{501BDEA8-FD8E-4A7A-B85A-E2E3C49DF3E1}"/>
@@ -22441,7 +22441,7 @@
       </p:sp>
       <p:sp>
         <p:nvSpPr>
-          <p:cNvPr id="21" name="">
+          <p:cNvPr id="22" name="">
             <a:extLst xmlns:a="http://schemas.openxmlformats.org/drawingml/2006/main">
               <a:ext uri="{FF2B5EF4-FFF2-40B4-BE49-F238E27FC236}">
                 <a16:creationId xmlns:a16="http://schemas.microsoft.com/office/drawing/2014/main" id="{FDFF7A00-BF2D-4AF6-9DD4-1963061780D3}"/>
@@ -22473,7 +22473,7 @@
       </p:sp>
       <p:sp>
         <p:nvSpPr>
-          <p:cNvPr id="22" name="">
+          <p:cNvPr id="23" name="">
             <a:extLst xmlns:a="http://schemas.openxmlformats.org/drawingml/2006/main">
               <a:ext uri="{FF2B5EF4-FFF2-40B4-BE49-F238E27FC236}">
                 <a16:creationId xmlns:a16="http://schemas.microsoft.com/office/drawing/2014/main" id="{F3CA1CDE-7C37-4C07-B093-1B9C28F41823}"/>
@@ -22518,7 +22518,7 @@
       </p:sp>
       <p:sp>
         <p:nvSpPr>
-          <p:cNvPr id="23" name="">
+          <p:cNvPr id="24" name="">
             <a:extLst xmlns:a="http://schemas.openxmlformats.org/drawingml/2006/main">
               <a:ext uri="{FF2B5EF4-FFF2-40B4-BE49-F238E27FC236}">
                 <a16:creationId xmlns:a16="http://schemas.microsoft.com/office/drawing/2014/main" id="{C3FD636E-7715-417D-86D9-C59557851C6A}"/>
@@ -22565,7 +22565,7 @@
       </p:sp>
       <p:sp>
         <p:nvSpPr>
-          <p:cNvPr id="24" name="">
+          <p:cNvPr id="25" name="">
             <a:extLst xmlns:a="http://schemas.openxmlformats.org/drawingml/2006/main">
               <a:ext uri="{FF2B5EF4-FFF2-40B4-BE49-F238E27FC236}">
                 <a16:creationId xmlns:a16="http://schemas.microsoft.com/office/drawing/2014/main" id="{D9052AE2-5AFE-4576-9C33-7928C168F6A3}"/>
@@ -22597,7 +22597,7 @@
       </p:sp>
       <p:sp>
         <p:nvSpPr>
-          <p:cNvPr id="25" name="">
+          <p:cNvPr id="26" name="">
             <a:extLst xmlns:a="http://schemas.openxmlformats.org/drawingml/2006/main">
               <a:ext uri="{FF2B5EF4-FFF2-40B4-BE49-F238E27FC236}">
                 <a16:creationId xmlns:a16="http://schemas.microsoft.com/office/drawing/2014/main" id="{3E33F2D7-59F3-4F0A-82E9-069FC7820665}"/>
@@ -22629,7 +22629,7 @@
       </p:sp>
       <p:sp>
         <p:nvSpPr>
-          <p:cNvPr id="26" name="">
+          <p:cNvPr id="27" name="">
             <a:extLst xmlns:a="http://schemas.openxmlformats.org/drawingml/2006/main">
               <a:ext uri="{FF2B5EF4-FFF2-40B4-BE49-F238E27FC236}">
                 <a16:creationId xmlns:a16="http://schemas.microsoft.com/office/drawing/2014/main" id="{F0231C81-2ABF-43E1-A7F8-E7EC29F74208}"/>
@@ -22661,7 +22661,7 @@
       </p:sp>
       <p:sp>
         <p:nvSpPr>
-          <p:cNvPr id="27" name="">
+          <p:cNvPr id="28" name="">
             <a:extLst xmlns:a="http://schemas.openxmlformats.org/drawingml/2006/main">
               <a:ext uri="{FF2B5EF4-FFF2-40B4-BE49-F238E27FC236}">
                 <a16:creationId xmlns:a16="http://schemas.microsoft.com/office/drawing/2014/main" id="{1411C8B1-A8AD-49CE-9500-92885F495DB6}"/>
@@ -22706,7 +22706,7 @@
       </p:sp>
       <p:sp>
         <p:nvSpPr>
-          <p:cNvPr id="28" name="">
+          <p:cNvPr id="29" name="">
             <a:extLst xmlns:a="http://schemas.openxmlformats.org/drawingml/2006/main">
               <a:ext uri="{FF2B5EF4-FFF2-40B4-BE49-F238E27FC236}">
                 <a16:creationId xmlns:a16="http://schemas.microsoft.com/office/drawing/2014/main" id="{5A1B5575-3075-44B8-97D4-65741A95DF3C}"/>
@@ -22753,7 +22753,7 @@
       </p:sp>
       <p:sp>
         <p:nvSpPr>
-          <p:cNvPr id="29" name="">
+          <p:cNvPr id="30" name="">
             <a:extLst xmlns:a="http://schemas.openxmlformats.org/drawingml/2006/main">
               <a:ext uri="{FF2B5EF4-FFF2-40B4-BE49-F238E27FC236}">
                 <a16:creationId xmlns:a16="http://schemas.microsoft.com/office/drawing/2014/main" id="{8D70415C-D0ED-4322-BA5F-7CC211CA49E3}"/>
@@ -22785,7 +22785,7 @@
       </p:sp>
       <p:sp>
         <p:nvSpPr>
-          <p:cNvPr id="30" name="">
+          <p:cNvPr id="31" name="">
             <a:extLst xmlns:a="http://schemas.openxmlformats.org/drawingml/2006/main">
               <a:ext uri="{FF2B5EF4-FFF2-40B4-BE49-F238E27FC236}">
                 <a16:creationId xmlns:a16="http://schemas.microsoft.com/office/drawing/2014/main" id="{AD663DC2-4256-4D7D-9BE3-A0BCA2D47C52}"/>
@@ -22817,7 +22817,7 @@
       </p:sp>
       <p:sp>
         <p:nvSpPr>
-          <p:cNvPr id="31" name="">
+          <p:cNvPr id="32" name="">
             <a:extLst xmlns:a="http://schemas.openxmlformats.org/drawingml/2006/main">
               <a:ext uri="{FF2B5EF4-FFF2-40B4-BE49-F238E27FC236}">
                 <a16:creationId xmlns:a16="http://schemas.microsoft.com/office/drawing/2014/main" id="{8541397B-1096-438D-83BF-42FDE30AEC05}"/>
@@ -22849,7 +22849,7 @@
       </p:sp>
       <p:sp>
         <p:nvSpPr>
-          <p:cNvPr id="32" name="">
+          <p:cNvPr id="33" name="">
             <a:extLst xmlns:a="http://schemas.openxmlformats.org/drawingml/2006/main">
               <a:ext uri="{FF2B5EF4-FFF2-40B4-BE49-F238E27FC236}">
                 <a16:creationId xmlns:a16="http://schemas.microsoft.com/office/drawing/2014/main" id="{581BC096-9AFC-40DF-8216-13B6BC38AFF5}"/>
@@ -22894,7 +22894,7 @@
       </p:sp>
       <p:sp>
         <p:nvSpPr>
-          <p:cNvPr id="33" name="">
+          <p:cNvPr id="34" name="">
             <a:extLst xmlns:a="http://schemas.openxmlformats.org/drawingml/2006/main">
               <a:ext uri="{FF2B5EF4-FFF2-40B4-BE49-F238E27FC236}">
                 <a16:creationId xmlns:a16="http://schemas.microsoft.com/office/drawing/2014/main" id="{7438396A-0C82-4147-9325-8DBD92DDF439}"/>
@@ -22941,7 +22941,7 @@
       </p:sp>
       <p:sp>
         <p:nvSpPr>
-          <p:cNvPr id="34" name="">
+          <p:cNvPr id="35" name="">
             <a:extLst xmlns:a="http://schemas.openxmlformats.org/drawingml/2006/main">
               <a:ext uri="{FF2B5EF4-FFF2-40B4-BE49-F238E27FC236}">
                 <a16:creationId xmlns:a16="http://schemas.microsoft.com/office/drawing/2014/main" id="{F32A5FAA-F892-438E-ADFE-2B27694862C7}"/>

</xml_diff>

<commit_message>
Make bridge deck PowerPoint compatible
</commit_message>
<xml_diff>
--- a/bridge/docs/dev/spec.pptx
+++ b/bridge/docs/dev/spec.pptx
@@ -4,9 +4,6 @@
   <p:sldMasterIdLst>
     <p:sldMasterId xmlns:r="http://schemas.openxmlformats.org/officeDocument/2006/relationships" id="2147483648" r:id="R3f414ebf478f4f85"/>
   </p:sldMasterIdLst>
-  <p:notesMasterIdLst>
-    <p:notesMasterId xmlns:r="http://schemas.openxmlformats.org/officeDocument/2006/relationships" r:id="R715d07ddb1234548"/>
-  </p:notesMasterIdLst>
   <p:sldIdLst>
     <p:sldId xmlns:r="http://schemas.openxmlformats.org/officeDocument/2006/relationships" id="256" r:id="R200302fe550b4a72"/>
     <p:sldId xmlns:r="http://schemas.openxmlformats.org/officeDocument/2006/relationships" id="257" r:id="R5682b2d16297441b"/>
@@ -128,1605 +125,6 @@
 </p:presentation>
 </file>
 
-<file path=ppt/notesMasters/notesMaster1.xml><?xml version="1.0" encoding="utf-8"?>
-<p:notesMaster xmlns:p="http://schemas.openxmlformats.org/presentationml/2006/main">
-  <p:cSld>
-    <p:bg>
-      <p:bgRef idx="1001">
-        <a:schemeClr xmlns:a="http://schemas.openxmlformats.org/drawingml/2006/main" val="bg1"/>
-      </p:bgRef>
-    </p:bg>
-    <p:spTree>
-      <p:nvGrpSpPr>
-        <p:cNvPr id="1" name=""/>
-        <p:cNvGrpSpPr/>
-        <p:nvPr/>
-      </p:nvGrpSpPr>
-      <p:grpSpPr>
-        <a:xfrm xmlns:a="http://schemas.openxmlformats.org/drawingml/2006/main"/>
-      </p:grpSpPr>
-      <p:sp>
-        <p:nvSpPr>
-          <p:cNvPr id="2" name="Header Placeholder"/>
-          <p:cNvSpPr/>
-          <p:nvPr>
-            <p:ph type="hdr" sz="quarter"/>
-          </p:nvPr>
-        </p:nvSpPr>
-        <p:spPr>
-          <a:prstGeom xmlns:a="http://schemas.openxmlformats.org/drawingml/2006/main" prst="rect">
-            <a:avLst/>
-          </a:prstGeom>
-        </p:spPr>
-        <p:txBody>
-          <a:bodyPr xmlns:a="http://schemas.openxmlformats.org/drawingml/2006/main"/>
-          <a:lstStyle xmlns:a="http://schemas.openxmlformats.org/drawingml/2006/main"/>
-          <a:p xmlns:a="http://schemas.openxmlformats.org/drawingml/2006/main"/>
-        </p:txBody>
-      </p:sp>
-      <p:sp>
-        <p:nvSpPr>
-          <p:cNvPr id="3" name="Date Placeholder"/>
-          <p:cNvSpPr/>
-          <p:nvPr>
-            <p:ph type="dt" sz="quarter" idx="1"/>
-          </p:nvPr>
-        </p:nvSpPr>
-        <p:spPr>
-          <a:prstGeom xmlns:a="http://schemas.openxmlformats.org/drawingml/2006/main" prst="rect">
-            <a:avLst/>
-          </a:prstGeom>
-        </p:spPr>
-        <p:txBody>
-          <a:bodyPr xmlns:a="http://schemas.openxmlformats.org/drawingml/2006/main"/>
-          <a:lstStyle xmlns:a="http://schemas.openxmlformats.org/drawingml/2006/main"/>
-          <a:p xmlns:a="http://schemas.openxmlformats.org/drawingml/2006/main"/>
-        </p:txBody>
-      </p:sp>
-      <p:sp>
-        <p:nvSpPr>
-          <p:cNvPr id="4" name="Slide Image Placeholder"/>
-          <p:cNvSpPr/>
-          <p:nvPr>
-            <p:ph type="sldImg" idx="2"/>
-          </p:nvPr>
-        </p:nvSpPr>
-        <p:spPr>
-          <a:prstGeom xmlns:a="http://schemas.openxmlformats.org/drawingml/2006/main" prst="rect">
-            <a:avLst/>
-          </a:prstGeom>
-        </p:spPr>
-        <p:txBody>
-          <a:bodyPr xmlns:a="http://schemas.openxmlformats.org/drawingml/2006/main"/>
-          <a:lstStyle xmlns:a="http://schemas.openxmlformats.org/drawingml/2006/main"/>
-          <a:p xmlns:a="http://schemas.openxmlformats.org/drawingml/2006/main"/>
-        </p:txBody>
-      </p:sp>
-      <p:sp>
-        <p:nvSpPr>
-          <p:cNvPr id="5" name="Notes Placeholder"/>
-          <p:cNvSpPr/>
-          <p:nvPr>
-            <p:ph type="body" sz="quarter" idx="3"/>
-          </p:nvPr>
-        </p:nvSpPr>
-        <p:spPr>
-          <a:prstGeom xmlns:a="http://schemas.openxmlformats.org/drawingml/2006/main" prst="rect">
-            <a:avLst/>
-          </a:prstGeom>
-        </p:spPr>
-        <p:txBody>
-          <a:bodyPr xmlns:a="http://schemas.openxmlformats.org/drawingml/2006/main"/>
-          <a:lstStyle xmlns:a="http://schemas.openxmlformats.org/drawingml/2006/main"/>
-          <a:p xmlns:a="http://schemas.openxmlformats.org/drawingml/2006/main"/>
-        </p:txBody>
-      </p:sp>
-      <p:sp>
-        <p:nvSpPr>
-          <p:cNvPr id="6" name="Footer Placeholder"/>
-          <p:cNvSpPr/>
-          <p:nvPr>
-            <p:ph type="ftr" sz="quarter" idx="4"/>
-          </p:nvPr>
-        </p:nvSpPr>
-        <p:spPr>
-          <a:prstGeom xmlns:a="http://schemas.openxmlformats.org/drawingml/2006/main" prst="rect">
-            <a:avLst/>
-          </a:prstGeom>
-        </p:spPr>
-        <p:txBody>
-          <a:bodyPr xmlns:a="http://schemas.openxmlformats.org/drawingml/2006/main"/>
-          <a:lstStyle xmlns:a="http://schemas.openxmlformats.org/drawingml/2006/main"/>
-          <a:p xmlns:a="http://schemas.openxmlformats.org/drawingml/2006/main"/>
-        </p:txBody>
-      </p:sp>
-      <p:sp>
-        <p:nvSpPr>
-          <p:cNvPr id="7" name="Slide Number Placeholder"/>
-          <p:cNvSpPr/>
-          <p:nvPr>
-            <p:ph type="sldNum" sz="quarter" idx="5"/>
-          </p:nvPr>
-        </p:nvSpPr>
-        <p:spPr>
-          <a:prstGeom xmlns:a="http://schemas.openxmlformats.org/drawingml/2006/main" prst="rect">
-            <a:avLst/>
-          </a:prstGeom>
-        </p:spPr>
-        <p:txBody>
-          <a:bodyPr xmlns:a="http://schemas.openxmlformats.org/drawingml/2006/main"/>
-          <a:lstStyle xmlns:a="http://schemas.openxmlformats.org/drawingml/2006/main"/>
-          <a:p xmlns:a="http://schemas.openxmlformats.org/drawingml/2006/main"/>
-        </p:txBody>
-      </p:sp>
-    </p:spTree>
-  </p:cSld>
-  <p:clrMap bg1="lt1" tx1="dk1" bg2="lt2" tx2="dk2" accent1="accent1" accent2="accent2" accent3="accent3" accent4="accent4" accent5="accent5" accent6="accent6" hlink="hlink" folHlink="folHlink"/>
-  <p:notesStyle>
-    <a:lvl1pPr xmlns:a="http://schemas.openxmlformats.org/drawingml/2006/main" marL="0" algn="l" defTabSz="914400" rtl="0" eaLnBrk="1" latinLnBrk="0" hangingPunct="1">
-      <a:defRPr sz="1200" kern="1200"/>
-    </a:lvl1pPr>
-  </p:notesStyle>
-</p:notesMaster>
-</file>
-
-<file path=ppt/notesMasters/theme/theme2.xml><?xml version="1.0" encoding="utf-8"?>
-<a:theme xmlns:a="http://schemas.openxmlformats.org/drawingml/2006/main" name="Tokamak Private App Channels">
-  <a:themeElements>
-    <a:clrScheme name="Tokamak Private App Channels">
-      <a:accent1>
-        <a:srgbClr val="2563EB"/>
-      </a:accent1>
-      <a:accent2>
-        <a:srgbClr val="00A6B2"/>
-      </a:accent2>
-      <a:accent3>
-        <a:srgbClr val="21A67A"/>
-      </a:accent3>
-      <a:accent4>
-        <a:srgbClr val="F59E0B"/>
-      </a:accent4>
-      <a:accent5>
-        <a:srgbClr val="6D5BD0"/>
-      </a:accent5>
-      <a:accent6>
-        <a:srgbClr val="D94A4A"/>
-      </a:accent6>
-    </a:clrScheme>
-    <a:fontScheme name="Office">
-      <a:majorFont>
-        <a:latin typeface="Calibri Light"/>
-        <a:ea typeface="Calibri Light"/>
-        <a:cs typeface="Calibri Light"/>
-      </a:majorFont>
-      <a:minorFont>
-        <a:latin typeface="Calibri"/>
-        <a:ea typeface="Calibri"/>
-        <a:cs typeface="Calibri"/>
-      </a:minorFont>
-    </a:fontScheme>
-    <a:fmtScheme name="Tokamak Private App Channels">
-      <a:fillStyleLst>
-        <a:solidFill>
-          <a:schemeClr val="phClr"/>
-        </a:solidFill>
-        <a:solidFill>
-          <a:schemeClr val="dk1"/>
-        </a:solidFill>
-        <a:solidFill>
-          <a:schemeClr val="accent1"/>
-        </a:solidFill>
-      </a:fillStyleLst>
-      <a:lnStyleLst>
-        <a:ln w="12700">
-          <a:solidFill>
-            <a:schemeClr val="phClr"/>
-          </a:solidFill>
-          <a:prstDash val="solid"/>
-        </a:ln>
-        <a:ln w="19050">
-          <a:solidFill>
-            <a:schemeClr val="phClr"/>
-          </a:solidFill>
-          <a:prstDash val="solid"/>
-        </a:ln>
-        <a:ln w="25400">
-          <a:solidFill>
-            <a:schemeClr val="phClr"/>
-          </a:solidFill>
-          <a:prstDash val="solid"/>
-        </a:ln>
-      </a:lnStyleLst>
-      <a:effectStyleLst>
-        <a:effectStyle>
-          <a:effectLst/>
-        </a:effectStyle>
-        <a:effectStyle>
-          <a:effectLst/>
-        </a:effectStyle>
-        <a:effectStyle>
-          <a:effectLst>
-            <a:outerShdw blurRad="57150" dist="19050" dir="5400000">
-              <a:srgbClr val="000000">
-                <a:alpha val="63000"/>
-              </a:srgbClr>
-            </a:outerShdw>
-          </a:effectLst>
-        </a:effectStyle>
-      </a:effectStyleLst>
-      <a:bgFillStyleLst>
-        <a:solidFill>
-          <a:schemeClr val="phClr"/>
-        </a:solidFill>
-        <a:solidFill>
-          <a:schemeClr val="phClr">
-            <a:tint val="95000"/>
-            <a:satMod val="170000"/>
-          </a:schemeClr>
-        </a:solidFill>
-        <a:gradFill>
-          <a:gsLst>
-            <a:gs pos="0">
-              <a:schemeClr val="phClr">
-                <a:tint val="93000"/>
-                <a:shade val="98000"/>
-                <a:lumMod val="102000"/>
-                <a:satMod val="150000"/>
-              </a:schemeClr>
-            </a:gs>
-            <a:gs pos="50000">
-              <a:schemeClr val="phClr">
-                <a:tint val="98000"/>
-                <a:shade val="90000"/>
-                <a:lumMod val="103000"/>
-                <a:satMod val="130000"/>
-              </a:schemeClr>
-            </a:gs>
-            <a:gs pos="100000">
-              <a:schemeClr val="phClr">
-                <a:shade val="63000"/>
-                <a:satMod val="120000"/>
-              </a:schemeClr>
-            </a:gs>
-          </a:gsLst>
-          <a:lin ang="5400000" scaled="0"/>
-        </a:gradFill>
-      </a:bgFillStyleLst>
-    </a:fmtScheme>
-  </a:themeElements>
-</a:theme>
-</file>
-
-<file path=ppt/notesSlides/notesSlide1.xml><?xml version="1.0" encoding="utf-8"?>
-<p:notes xmlns:p="http://schemas.openxmlformats.org/presentationml/2006/main">
-  <p:cSld>
-    <p:spTree>
-      <p:nvGrpSpPr>
-        <p:cNvPr id="1" name=""/>
-        <p:cNvGrpSpPr/>
-        <p:nvPr/>
-      </p:nvGrpSpPr>
-      <p:grpSpPr>
-        <a:xfrm xmlns:a="http://schemas.openxmlformats.org/drawingml/2006/main"/>
-      </p:grpSpPr>
-      <p:sp>
-        <p:nvSpPr>
-          <p:cNvPr id="2" name="Slide Image Placeholder 1"/>
-          <p:cNvSpPr>
-            <a:spLocks xmlns:a="http://schemas.openxmlformats.org/drawingml/2006/main" noGrp="1"/>
-          </p:cNvSpPr>
-          <p:nvPr>
-            <p:ph type="sldImg" idx="0"/>
-          </p:nvPr>
-        </p:nvSpPr>
-        <p:spPr/>
-      </p:sp>
-      <p:sp>
-        <p:nvSpPr>
-          <p:cNvPr id="3" name="Notes Placeholder 2"/>
-          <p:cNvSpPr>
-            <a:spLocks xmlns:a="http://schemas.openxmlformats.org/drawingml/2006/main" noGrp="1"/>
-          </p:cNvSpPr>
-          <p:nvPr>
-            <p:ph type="body" idx="1"/>
-          </p:nvPr>
-        </p:nvSpPr>
-        <p:spPr/>
-        <p:txBody>
-          <a:bodyPr xmlns:a="http://schemas.openxmlformats.org/drawingml/2006/main"/>
-          <a:lstStyle xmlns:a="http://schemas.openxmlformats.org/drawingml/2006/main"/>
-          <a:p xmlns:a="http://schemas.openxmlformats.org/drawingml/2006/main">
-            <a:r>
-              <a:t>Slide 1: Present the visible points and relate them to the repository documents: docs/whitepaper.md, bridge/docs/dev/spec.md, bridge/docs/dev/current-implementation.md, and docs/dapps/private-state.</a:t>
-            </a:r>
-          </a:p>
-        </p:txBody>
-      </p:sp>
-      <p:sp>
-        <p:nvSpPr>
-          <p:cNvPr id="4" name="Slide Number Placeholder 3"/>
-          <p:cNvSpPr>
-            <a:spLocks xmlns:a="http://schemas.openxmlformats.org/drawingml/2006/main" noGrp="1"/>
-          </p:cNvSpPr>
-          <p:nvPr>
-            <p:ph type="sldNum" idx="5"/>
-          </p:nvPr>
-        </p:nvSpPr>
-        <p:spPr/>
-        <p:txBody>
-          <a:bodyPr xmlns:a="http://schemas.openxmlformats.org/drawingml/2006/main"/>
-          <a:lstStyle xmlns:a="http://schemas.openxmlformats.org/drawingml/2006/main"/>
-          <a:p xmlns:a="http://schemas.openxmlformats.org/drawingml/2006/main"/>
-        </p:txBody>
-      </p:sp>
-    </p:spTree>
-  </p:cSld>
-  <p:clrMapOvr>
-    <a:masterClrMapping xmlns:a="http://schemas.openxmlformats.org/drawingml/2006/main"/>
-  </p:clrMapOvr>
-</p:notes>
-</file>
-
-<file path=ppt/notesSlides/notesSlide10.xml><?xml version="1.0" encoding="utf-8"?>
-<p:notes xmlns:p="http://schemas.openxmlformats.org/presentationml/2006/main">
-  <p:cSld>
-    <p:spTree>
-      <p:nvGrpSpPr>
-        <p:cNvPr id="1" name=""/>
-        <p:cNvGrpSpPr/>
-        <p:nvPr/>
-      </p:nvGrpSpPr>
-      <p:grpSpPr>
-        <a:xfrm xmlns:a="http://schemas.openxmlformats.org/drawingml/2006/main"/>
-      </p:grpSpPr>
-      <p:sp>
-        <p:nvSpPr>
-          <p:cNvPr id="2" name="Slide Image Placeholder 1"/>
-          <p:cNvSpPr>
-            <a:spLocks xmlns:a="http://schemas.openxmlformats.org/drawingml/2006/main" noGrp="1"/>
-          </p:cNvSpPr>
-          <p:nvPr>
-            <p:ph type="sldImg" idx="0"/>
-          </p:nvPr>
-        </p:nvSpPr>
-        <p:spPr/>
-      </p:sp>
-      <p:sp>
-        <p:nvSpPr>
-          <p:cNvPr id="3" name="Notes Placeholder 2"/>
-          <p:cNvSpPr>
-            <a:spLocks xmlns:a="http://schemas.openxmlformats.org/drawingml/2006/main" noGrp="1"/>
-          </p:cNvSpPr>
-          <p:nvPr>
-            <p:ph type="body" idx="1"/>
-          </p:nvPr>
-        </p:nvSpPr>
-        <p:spPr/>
-        <p:txBody>
-          <a:bodyPr xmlns:a="http://schemas.openxmlformats.org/drawingml/2006/main"/>
-          <a:lstStyle xmlns:a="http://schemas.openxmlformats.org/drawingml/2006/main"/>
-          <a:p xmlns:a="http://schemas.openxmlformats.org/drawingml/2006/main">
-            <a:r>
-              <a:t>Slide 10: Present the visible points and relate them to the repository documents: docs/whitepaper.md, bridge/docs/dev/spec.md, bridge/docs/dev/current-implementation.md, and docs/dapps/private-state.</a:t>
-            </a:r>
-          </a:p>
-        </p:txBody>
-      </p:sp>
-      <p:sp>
-        <p:nvSpPr>
-          <p:cNvPr id="4" name="Slide Number Placeholder 3"/>
-          <p:cNvSpPr>
-            <a:spLocks xmlns:a="http://schemas.openxmlformats.org/drawingml/2006/main" noGrp="1"/>
-          </p:cNvSpPr>
-          <p:nvPr>
-            <p:ph type="sldNum" idx="5"/>
-          </p:nvPr>
-        </p:nvSpPr>
-        <p:spPr/>
-        <p:txBody>
-          <a:bodyPr xmlns:a="http://schemas.openxmlformats.org/drawingml/2006/main"/>
-          <a:lstStyle xmlns:a="http://schemas.openxmlformats.org/drawingml/2006/main"/>
-          <a:p xmlns:a="http://schemas.openxmlformats.org/drawingml/2006/main"/>
-        </p:txBody>
-      </p:sp>
-    </p:spTree>
-  </p:cSld>
-  <p:clrMapOvr>
-    <a:masterClrMapping xmlns:a="http://schemas.openxmlformats.org/drawingml/2006/main"/>
-  </p:clrMapOvr>
-</p:notes>
-</file>
-
-<file path=ppt/notesSlides/notesSlide11.xml><?xml version="1.0" encoding="utf-8"?>
-<p:notes xmlns:p="http://schemas.openxmlformats.org/presentationml/2006/main">
-  <p:cSld>
-    <p:spTree>
-      <p:nvGrpSpPr>
-        <p:cNvPr id="1" name=""/>
-        <p:cNvGrpSpPr/>
-        <p:nvPr/>
-      </p:nvGrpSpPr>
-      <p:grpSpPr>
-        <a:xfrm xmlns:a="http://schemas.openxmlformats.org/drawingml/2006/main"/>
-      </p:grpSpPr>
-      <p:sp>
-        <p:nvSpPr>
-          <p:cNvPr id="2" name="Slide Image Placeholder 1"/>
-          <p:cNvSpPr>
-            <a:spLocks xmlns:a="http://schemas.openxmlformats.org/drawingml/2006/main" noGrp="1"/>
-          </p:cNvSpPr>
-          <p:nvPr>
-            <p:ph type="sldImg" idx="0"/>
-          </p:nvPr>
-        </p:nvSpPr>
-        <p:spPr/>
-      </p:sp>
-      <p:sp>
-        <p:nvSpPr>
-          <p:cNvPr id="3" name="Notes Placeholder 2"/>
-          <p:cNvSpPr>
-            <a:spLocks xmlns:a="http://schemas.openxmlformats.org/drawingml/2006/main" noGrp="1"/>
-          </p:cNvSpPr>
-          <p:nvPr>
-            <p:ph type="body" idx="1"/>
-          </p:nvPr>
-        </p:nvSpPr>
-        <p:spPr/>
-        <p:txBody>
-          <a:bodyPr xmlns:a="http://schemas.openxmlformats.org/drawingml/2006/main"/>
-          <a:lstStyle xmlns:a="http://schemas.openxmlformats.org/drawingml/2006/main"/>
-          <a:p xmlns:a="http://schemas.openxmlformats.org/drawingml/2006/main">
-            <a:r>
-              <a:t>Slide 11: Present the visible points and relate them to the repository documents: docs/whitepaper.md, bridge/docs/dev/spec.md, bridge/docs/dev/current-implementation.md, and docs/dapps/private-state.</a:t>
-            </a:r>
-          </a:p>
-        </p:txBody>
-      </p:sp>
-      <p:sp>
-        <p:nvSpPr>
-          <p:cNvPr id="4" name="Slide Number Placeholder 3"/>
-          <p:cNvSpPr>
-            <a:spLocks xmlns:a="http://schemas.openxmlformats.org/drawingml/2006/main" noGrp="1"/>
-          </p:cNvSpPr>
-          <p:nvPr>
-            <p:ph type="sldNum" idx="5"/>
-          </p:nvPr>
-        </p:nvSpPr>
-        <p:spPr/>
-        <p:txBody>
-          <a:bodyPr xmlns:a="http://schemas.openxmlformats.org/drawingml/2006/main"/>
-          <a:lstStyle xmlns:a="http://schemas.openxmlformats.org/drawingml/2006/main"/>
-          <a:p xmlns:a="http://schemas.openxmlformats.org/drawingml/2006/main"/>
-        </p:txBody>
-      </p:sp>
-    </p:spTree>
-  </p:cSld>
-  <p:clrMapOvr>
-    <a:masterClrMapping xmlns:a="http://schemas.openxmlformats.org/drawingml/2006/main"/>
-  </p:clrMapOvr>
-</p:notes>
-</file>
-
-<file path=ppt/notesSlides/notesSlide12.xml><?xml version="1.0" encoding="utf-8"?>
-<p:notes xmlns:p="http://schemas.openxmlformats.org/presentationml/2006/main">
-  <p:cSld>
-    <p:spTree>
-      <p:nvGrpSpPr>
-        <p:cNvPr id="1" name=""/>
-        <p:cNvGrpSpPr/>
-        <p:nvPr/>
-      </p:nvGrpSpPr>
-      <p:grpSpPr>
-        <a:xfrm xmlns:a="http://schemas.openxmlformats.org/drawingml/2006/main"/>
-      </p:grpSpPr>
-      <p:sp>
-        <p:nvSpPr>
-          <p:cNvPr id="2" name="Slide Image Placeholder 1"/>
-          <p:cNvSpPr>
-            <a:spLocks xmlns:a="http://schemas.openxmlformats.org/drawingml/2006/main" noGrp="1"/>
-          </p:cNvSpPr>
-          <p:nvPr>
-            <p:ph type="sldImg" idx="0"/>
-          </p:nvPr>
-        </p:nvSpPr>
-        <p:spPr/>
-      </p:sp>
-      <p:sp>
-        <p:nvSpPr>
-          <p:cNvPr id="3" name="Notes Placeholder 2"/>
-          <p:cNvSpPr>
-            <a:spLocks xmlns:a="http://schemas.openxmlformats.org/drawingml/2006/main" noGrp="1"/>
-          </p:cNvSpPr>
-          <p:nvPr>
-            <p:ph type="body" idx="1"/>
-          </p:nvPr>
-        </p:nvSpPr>
-        <p:spPr/>
-        <p:txBody>
-          <a:bodyPr xmlns:a="http://schemas.openxmlformats.org/drawingml/2006/main"/>
-          <a:lstStyle xmlns:a="http://schemas.openxmlformats.org/drawingml/2006/main"/>
-          <a:p xmlns:a="http://schemas.openxmlformats.org/drawingml/2006/main">
-            <a:r>
-              <a:t>Slide 12: Present the visible points and relate them to the repository documents: docs/whitepaper.md, bridge/docs/dev/spec.md, bridge/docs/dev/current-implementation.md, and docs/dapps/private-state.</a:t>
-            </a:r>
-          </a:p>
-        </p:txBody>
-      </p:sp>
-      <p:sp>
-        <p:nvSpPr>
-          <p:cNvPr id="4" name="Slide Number Placeholder 3"/>
-          <p:cNvSpPr>
-            <a:spLocks xmlns:a="http://schemas.openxmlformats.org/drawingml/2006/main" noGrp="1"/>
-          </p:cNvSpPr>
-          <p:nvPr>
-            <p:ph type="sldNum" idx="5"/>
-          </p:nvPr>
-        </p:nvSpPr>
-        <p:spPr/>
-        <p:txBody>
-          <a:bodyPr xmlns:a="http://schemas.openxmlformats.org/drawingml/2006/main"/>
-          <a:lstStyle xmlns:a="http://schemas.openxmlformats.org/drawingml/2006/main"/>
-          <a:p xmlns:a="http://schemas.openxmlformats.org/drawingml/2006/main"/>
-        </p:txBody>
-      </p:sp>
-    </p:spTree>
-  </p:cSld>
-  <p:clrMapOvr>
-    <a:masterClrMapping xmlns:a="http://schemas.openxmlformats.org/drawingml/2006/main"/>
-  </p:clrMapOvr>
-</p:notes>
-</file>
-
-<file path=ppt/notesSlides/notesSlide13.xml><?xml version="1.0" encoding="utf-8"?>
-<p:notes xmlns:p="http://schemas.openxmlformats.org/presentationml/2006/main">
-  <p:cSld>
-    <p:spTree>
-      <p:nvGrpSpPr>
-        <p:cNvPr id="1" name=""/>
-        <p:cNvGrpSpPr/>
-        <p:nvPr/>
-      </p:nvGrpSpPr>
-      <p:grpSpPr>
-        <a:xfrm xmlns:a="http://schemas.openxmlformats.org/drawingml/2006/main"/>
-      </p:grpSpPr>
-      <p:sp>
-        <p:nvSpPr>
-          <p:cNvPr id="2" name="Slide Image Placeholder 1"/>
-          <p:cNvSpPr>
-            <a:spLocks xmlns:a="http://schemas.openxmlformats.org/drawingml/2006/main" noGrp="1"/>
-          </p:cNvSpPr>
-          <p:nvPr>
-            <p:ph type="sldImg" idx="0"/>
-          </p:nvPr>
-        </p:nvSpPr>
-        <p:spPr/>
-      </p:sp>
-      <p:sp>
-        <p:nvSpPr>
-          <p:cNvPr id="3" name="Notes Placeholder 2"/>
-          <p:cNvSpPr>
-            <a:spLocks xmlns:a="http://schemas.openxmlformats.org/drawingml/2006/main" noGrp="1"/>
-          </p:cNvSpPr>
-          <p:nvPr>
-            <p:ph type="body" idx="1"/>
-          </p:nvPr>
-        </p:nvSpPr>
-        <p:spPr/>
-        <p:txBody>
-          <a:bodyPr xmlns:a="http://schemas.openxmlformats.org/drawingml/2006/main"/>
-          <a:lstStyle xmlns:a="http://schemas.openxmlformats.org/drawingml/2006/main"/>
-          <a:p xmlns:a="http://schemas.openxmlformats.org/drawingml/2006/main">
-            <a:r>
-              <a:t>Slide 13: Present the visible points and relate them to the repository documents: docs/whitepaper.md, bridge/docs/dev/spec.md, bridge/docs/dev/current-implementation.md, and docs/dapps/private-state.</a:t>
-            </a:r>
-          </a:p>
-        </p:txBody>
-      </p:sp>
-      <p:sp>
-        <p:nvSpPr>
-          <p:cNvPr id="4" name="Slide Number Placeholder 3"/>
-          <p:cNvSpPr>
-            <a:spLocks xmlns:a="http://schemas.openxmlformats.org/drawingml/2006/main" noGrp="1"/>
-          </p:cNvSpPr>
-          <p:nvPr>
-            <p:ph type="sldNum" idx="5"/>
-          </p:nvPr>
-        </p:nvSpPr>
-        <p:spPr/>
-        <p:txBody>
-          <a:bodyPr xmlns:a="http://schemas.openxmlformats.org/drawingml/2006/main"/>
-          <a:lstStyle xmlns:a="http://schemas.openxmlformats.org/drawingml/2006/main"/>
-          <a:p xmlns:a="http://schemas.openxmlformats.org/drawingml/2006/main"/>
-        </p:txBody>
-      </p:sp>
-    </p:spTree>
-  </p:cSld>
-  <p:clrMapOvr>
-    <a:masterClrMapping xmlns:a="http://schemas.openxmlformats.org/drawingml/2006/main"/>
-  </p:clrMapOvr>
-</p:notes>
-</file>
-
-<file path=ppt/notesSlides/notesSlide14.xml><?xml version="1.0" encoding="utf-8"?>
-<p:notes xmlns:p="http://schemas.openxmlformats.org/presentationml/2006/main">
-  <p:cSld>
-    <p:spTree>
-      <p:nvGrpSpPr>
-        <p:cNvPr id="1" name=""/>
-        <p:cNvGrpSpPr/>
-        <p:nvPr/>
-      </p:nvGrpSpPr>
-      <p:grpSpPr>
-        <a:xfrm xmlns:a="http://schemas.openxmlformats.org/drawingml/2006/main"/>
-      </p:grpSpPr>
-      <p:sp>
-        <p:nvSpPr>
-          <p:cNvPr id="2" name="Slide Image Placeholder 1"/>
-          <p:cNvSpPr>
-            <a:spLocks xmlns:a="http://schemas.openxmlformats.org/drawingml/2006/main" noGrp="1"/>
-          </p:cNvSpPr>
-          <p:nvPr>
-            <p:ph type="sldImg" idx="0"/>
-          </p:nvPr>
-        </p:nvSpPr>
-        <p:spPr/>
-      </p:sp>
-      <p:sp>
-        <p:nvSpPr>
-          <p:cNvPr id="3" name="Notes Placeholder 2"/>
-          <p:cNvSpPr>
-            <a:spLocks xmlns:a="http://schemas.openxmlformats.org/drawingml/2006/main" noGrp="1"/>
-          </p:cNvSpPr>
-          <p:nvPr>
-            <p:ph type="body" idx="1"/>
-          </p:nvPr>
-        </p:nvSpPr>
-        <p:spPr/>
-        <p:txBody>
-          <a:bodyPr xmlns:a="http://schemas.openxmlformats.org/drawingml/2006/main"/>
-          <a:lstStyle xmlns:a="http://schemas.openxmlformats.org/drawingml/2006/main"/>
-          <a:p xmlns:a="http://schemas.openxmlformats.org/drawingml/2006/main">
-            <a:r>
-              <a:t>Slide 14: Present the visible points and relate them to the repository documents: docs/whitepaper.md, bridge/docs/dev/spec.md, bridge/docs/dev/current-implementation.md, and docs/dapps/private-state.</a:t>
-            </a:r>
-          </a:p>
-        </p:txBody>
-      </p:sp>
-      <p:sp>
-        <p:nvSpPr>
-          <p:cNvPr id="4" name="Slide Number Placeholder 3"/>
-          <p:cNvSpPr>
-            <a:spLocks xmlns:a="http://schemas.openxmlformats.org/drawingml/2006/main" noGrp="1"/>
-          </p:cNvSpPr>
-          <p:nvPr>
-            <p:ph type="sldNum" idx="5"/>
-          </p:nvPr>
-        </p:nvSpPr>
-        <p:spPr/>
-        <p:txBody>
-          <a:bodyPr xmlns:a="http://schemas.openxmlformats.org/drawingml/2006/main"/>
-          <a:lstStyle xmlns:a="http://schemas.openxmlformats.org/drawingml/2006/main"/>
-          <a:p xmlns:a="http://schemas.openxmlformats.org/drawingml/2006/main"/>
-        </p:txBody>
-      </p:sp>
-    </p:spTree>
-  </p:cSld>
-  <p:clrMapOvr>
-    <a:masterClrMapping xmlns:a="http://schemas.openxmlformats.org/drawingml/2006/main"/>
-  </p:clrMapOvr>
-</p:notes>
-</file>
-
-<file path=ppt/notesSlides/notesSlide15.xml><?xml version="1.0" encoding="utf-8"?>
-<p:notes xmlns:p="http://schemas.openxmlformats.org/presentationml/2006/main">
-  <p:cSld>
-    <p:spTree>
-      <p:nvGrpSpPr>
-        <p:cNvPr id="1" name=""/>
-        <p:cNvGrpSpPr/>
-        <p:nvPr/>
-      </p:nvGrpSpPr>
-      <p:grpSpPr>
-        <a:xfrm xmlns:a="http://schemas.openxmlformats.org/drawingml/2006/main"/>
-      </p:grpSpPr>
-      <p:sp>
-        <p:nvSpPr>
-          <p:cNvPr id="2" name="Slide Image Placeholder 1"/>
-          <p:cNvSpPr>
-            <a:spLocks xmlns:a="http://schemas.openxmlformats.org/drawingml/2006/main" noGrp="1"/>
-          </p:cNvSpPr>
-          <p:nvPr>
-            <p:ph type="sldImg" idx="0"/>
-          </p:nvPr>
-        </p:nvSpPr>
-        <p:spPr/>
-      </p:sp>
-      <p:sp>
-        <p:nvSpPr>
-          <p:cNvPr id="3" name="Notes Placeholder 2"/>
-          <p:cNvSpPr>
-            <a:spLocks xmlns:a="http://schemas.openxmlformats.org/drawingml/2006/main" noGrp="1"/>
-          </p:cNvSpPr>
-          <p:nvPr>
-            <p:ph type="body" idx="1"/>
-          </p:nvPr>
-        </p:nvSpPr>
-        <p:spPr/>
-        <p:txBody>
-          <a:bodyPr xmlns:a="http://schemas.openxmlformats.org/drawingml/2006/main"/>
-          <a:lstStyle xmlns:a="http://schemas.openxmlformats.org/drawingml/2006/main"/>
-          <a:p xmlns:a="http://schemas.openxmlformats.org/drawingml/2006/main">
-            <a:r>
-              <a:t>Slide 15: Present the visible points and relate them to the repository documents: docs/whitepaper.md, bridge/docs/dev/spec.md, bridge/docs/dev/current-implementation.md, and docs/dapps/private-state.</a:t>
-            </a:r>
-          </a:p>
-        </p:txBody>
-      </p:sp>
-      <p:sp>
-        <p:nvSpPr>
-          <p:cNvPr id="4" name="Slide Number Placeholder 3"/>
-          <p:cNvSpPr>
-            <a:spLocks xmlns:a="http://schemas.openxmlformats.org/drawingml/2006/main" noGrp="1"/>
-          </p:cNvSpPr>
-          <p:nvPr>
-            <p:ph type="sldNum" idx="5"/>
-          </p:nvPr>
-        </p:nvSpPr>
-        <p:spPr/>
-        <p:txBody>
-          <a:bodyPr xmlns:a="http://schemas.openxmlformats.org/drawingml/2006/main"/>
-          <a:lstStyle xmlns:a="http://schemas.openxmlformats.org/drawingml/2006/main"/>
-          <a:p xmlns:a="http://schemas.openxmlformats.org/drawingml/2006/main"/>
-        </p:txBody>
-      </p:sp>
-    </p:spTree>
-  </p:cSld>
-  <p:clrMapOvr>
-    <a:masterClrMapping xmlns:a="http://schemas.openxmlformats.org/drawingml/2006/main"/>
-  </p:clrMapOvr>
-</p:notes>
-</file>
-
-<file path=ppt/notesSlides/notesSlide16.xml><?xml version="1.0" encoding="utf-8"?>
-<p:notes xmlns:p="http://schemas.openxmlformats.org/presentationml/2006/main">
-  <p:cSld>
-    <p:spTree>
-      <p:nvGrpSpPr>
-        <p:cNvPr id="1" name=""/>
-        <p:cNvGrpSpPr/>
-        <p:nvPr/>
-      </p:nvGrpSpPr>
-      <p:grpSpPr>
-        <a:xfrm xmlns:a="http://schemas.openxmlformats.org/drawingml/2006/main"/>
-      </p:grpSpPr>
-      <p:sp>
-        <p:nvSpPr>
-          <p:cNvPr id="2" name="Slide Image Placeholder 1"/>
-          <p:cNvSpPr>
-            <a:spLocks xmlns:a="http://schemas.openxmlformats.org/drawingml/2006/main" noGrp="1"/>
-          </p:cNvSpPr>
-          <p:nvPr>
-            <p:ph type="sldImg" idx="0"/>
-          </p:nvPr>
-        </p:nvSpPr>
-        <p:spPr/>
-      </p:sp>
-      <p:sp>
-        <p:nvSpPr>
-          <p:cNvPr id="3" name="Notes Placeholder 2"/>
-          <p:cNvSpPr>
-            <a:spLocks xmlns:a="http://schemas.openxmlformats.org/drawingml/2006/main" noGrp="1"/>
-          </p:cNvSpPr>
-          <p:nvPr>
-            <p:ph type="body" idx="1"/>
-          </p:nvPr>
-        </p:nvSpPr>
-        <p:spPr/>
-        <p:txBody>
-          <a:bodyPr xmlns:a="http://schemas.openxmlformats.org/drawingml/2006/main"/>
-          <a:lstStyle xmlns:a="http://schemas.openxmlformats.org/drawingml/2006/main"/>
-          <a:p xmlns:a="http://schemas.openxmlformats.org/drawingml/2006/main">
-            <a:r>
-              <a:t>Slide 16: Present the visible points and relate them to the repository documents: docs/whitepaper.md, bridge/docs/dev/spec.md, bridge/docs/dev/current-implementation.md, and docs/dapps/private-state.</a:t>
-            </a:r>
-          </a:p>
-        </p:txBody>
-      </p:sp>
-      <p:sp>
-        <p:nvSpPr>
-          <p:cNvPr id="4" name="Slide Number Placeholder 3"/>
-          <p:cNvSpPr>
-            <a:spLocks xmlns:a="http://schemas.openxmlformats.org/drawingml/2006/main" noGrp="1"/>
-          </p:cNvSpPr>
-          <p:nvPr>
-            <p:ph type="sldNum" idx="5"/>
-          </p:nvPr>
-        </p:nvSpPr>
-        <p:spPr/>
-        <p:txBody>
-          <a:bodyPr xmlns:a="http://schemas.openxmlformats.org/drawingml/2006/main"/>
-          <a:lstStyle xmlns:a="http://schemas.openxmlformats.org/drawingml/2006/main"/>
-          <a:p xmlns:a="http://schemas.openxmlformats.org/drawingml/2006/main"/>
-        </p:txBody>
-      </p:sp>
-    </p:spTree>
-  </p:cSld>
-  <p:clrMapOvr>
-    <a:masterClrMapping xmlns:a="http://schemas.openxmlformats.org/drawingml/2006/main"/>
-  </p:clrMapOvr>
-</p:notes>
-</file>
-
-<file path=ppt/notesSlides/notesSlide17.xml><?xml version="1.0" encoding="utf-8"?>
-<p:notes xmlns:p="http://schemas.openxmlformats.org/presentationml/2006/main">
-  <p:cSld>
-    <p:spTree>
-      <p:nvGrpSpPr>
-        <p:cNvPr id="1" name=""/>
-        <p:cNvGrpSpPr/>
-        <p:nvPr/>
-      </p:nvGrpSpPr>
-      <p:grpSpPr>
-        <a:xfrm xmlns:a="http://schemas.openxmlformats.org/drawingml/2006/main"/>
-      </p:grpSpPr>
-      <p:sp>
-        <p:nvSpPr>
-          <p:cNvPr id="2" name="Slide Image Placeholder 1"/>
-          <p:cNvSpPr>
-            <a:spLocks xmlns:a="http://schemas.openxmlformats.org/drawingml/2006/main" noGrp="1"/>
-          </p:cNvSpPr>
-          <p:nvPr>
-            <p:ph type="sldImg" idx="0"/>
-          </p:nvPr>
-        </p:nvSpPr>
-        <p:spPr/>
-      </p:sp>
-      <p:sp>
-        <p:nvSpPr>
-          <p:cNvPr id="3" name="Notes Placeholder 2"/>
-          <p:cNvSpPr>
-            <a:spLocks xmlns:a="http://schemas.openxmlformats.org/drawingml/2006/main" noGrp="1"/>
-          </p:cNvSpPr>
-          <p:nvPr>
-            <p:ph type="body" idx="1"/>
-          </p:nvPr>
-        </p:nvSpPr>
-        <p:spPr/>
-        <p:txBody>
-          <a:bodyPr xmlns:a="http://schemas.openxmlformats.org/drawingml/2006/main"/>
-          <a:lstStyle xmlns:a="http://schemas.openxmlformats.org/drawingml/2006/main"/>
-          <a:p xmlns:a="http://schemas.openxmlformats.org/drawingml/2006/main">
-            <a:r>
-              <a:t>Slide 17: Present the visible points and relate them to the repository documents: docs/whitepaper.md, bridge/docs/dev/spec.md, bridge/docs/dev/current-implementation.md, and docs/dapps/private-state.</a:t>
-            </a:r>
-          </a:p>
-        </p:txBody>
-      </p:sp>
-      <p:sp>
-        <p:nvSpPr>
-          <p:cNvPr id="4" name="Slide Number Placeholder 3"/>
-          <p:cNvSpPr>
-            <a:spLocks xmlns:a="http://schemas.openxmlformats.org/drawingml/2006/main" noGrp="1"/>
-          </p:cNvSpPr>
-          <p:nvPr>
-            <p:ph type="sldNum" idx="5"/>
-          </p:nvPr>
-        </p:nvSpPr>
-        <p:spPr/>
-        <p:txBody>
-          <a:bodyPr xmlns:a="http://schemas.openxmlformats.org/drawingml/2006/main"/>
-          <a:lstStyle xmlns:a="http://schemas.openxmlformats.org/drawingml/2006/main"/>
-          <a:p xmlns:a="http://schemas.openxmlformats.org/drawingml/2006/main"/>
-        </p:txBody>
-      </p:sp>
-    </p:spTree>
-  </p:cSld>
-  <p:clrMapOvr>
-    <a:masterClrMapping xmlns:a="http://schemas.openxmlformats.org/drawingml/2006/main"/>
-  </p:clrMapOvr>
-</p:notes>
-</file>
-
-<file path=ppt/notesSlides/notesSlide18.xml><?xml version="1.0" encoding="utf-8"?>
-<p:notes xmlns:p="http://schemas.openxmlformats.org/presentationml/2006/main">
-  <p:cSld>
-    <p:spTree>
-      <p:nvGrpSpPr>
-        <p:cNvPr id="1" name=""/>
-        <p:cNvGrpSpPr/>
-        <p:nvPr/>
-      </p:nvGrpSpPr>
-      <p:grpSpPr>
-        <a:xfrm xmlns:a="http://schemas.openxmlformats.org/drawingml/2006/main"/>
-      </p:grpSpPr>
-      <p:sp>
-        <p:nvSpPr>
-          <p:cNvPr id="2" name="Slide Image Placeholder 1"/>
-          <p:cNvSpPr>
-            <a:spLocks xmlns:a="http://schemas.openxmlformats.org/drawingml/2006/main" noGrp="1"/>
-          </p:cNvSpPr>
-          <p:nvPr>
-            <p:ph type="sldImg" idx="0"/>
-          </p:nvPr>
-        </p:nvSpPr>
-        <p:spPr/>
-      </p:sp>
-      <p:sp>
-        <p:nvSpPr>
-          <p:cNvPr id="3" name="Notes Placeholder 2"/>
-          <p:cNvSpPr>
-            <a:spLocks xmlns:a="http://schemas.openxmlformats.org/drawingml/2006/main" noGrp="1"/>
-          </p:cNvSpPr>
-          <p:nvPr>
-            <p:ph type="body" idx="1"/>
-          </p:nvPr>
-        </p:nvSpPr>
-        <p:spPr/>
-        <p:txBody>
-          <a:bodyPr xmlns:a="http://schemas.openxmlformats.org/drawingml/2006/main"/>
-          <a:lstStyle xmlns:a="http://schemas.openxmlformats.org/drawingml/2006/main"/>
-          <a:p xmlns:a="http://schemas.openxmlformats.org/drawingml/2006/main">
-            <a:r>
-              <a:t>Slide 18: Present the visible points and relate them to the repository documents: docs/whitepaper.md, bridge/docs/dev/spec.md, bridge/docs/dev/current-implementation.md, and docs/dapps/private-state.</a:t>
-            </a:r>
-          </a:p>
-        </p:txBody>
-      </p:sp>
-      <p:sp>
-        <p:nvSpPr>
-          <p:cNvPr id="4" name="Slide Number Placeholder 3"/>
-          <p:cNvSpPr>
-            <a:spLocks xmlns:a="http://schemas.openxmlformats.org/drawingml/2006/main" noGrp="1"/>
-          </p:cNvSpPr>
-          <p:nvPr>
-            <p:ph type="sldNum" idx="5"/>
-          </p:nvPr>
-        </p:nvSpPr>
-        <p:spPr/>
-        <p:txBody>
-          <a:bodyPr xmlns:a="http://schemas.openxmlformats.org/drawingml/2006/main"/>
-          <a:lstStyle xmlns:a="http://schemas.openxmlformats.org/drawingml/2006/main"/>
-          <a:p xmlns:a="http://schemas.openxmlformats.org/drawingml/2006/main"/>
-        </p:txBody>
-      </p:sp>
-    </p:spTree>
-  </p:cSld>
-  <p:clrMapOvr>
-    <a:masterClrMapping xmlns:a="http://schemas.openxmlformats.org/drawingml/2006/main"/>
-  </p:clrMapOvr>
-</p:notes>
-</file>
-
-<file path=ppt/notesSlides/notesSlide19.xml><?xml version="1.0" encoding="utf-8"?>
-<p:notes xmlns:p="http://schemas.openxmlformats.org/presentationml/2006/main">
-  <p:cSld>
-    <p:spTree>
-      <p:nvGrpSpPr>
-        <p:cNvPr id="1" name=""/>
-        <p:cNvGrpSpPr/>
-        <p:nvPr/>
-      </p:nvGrpSpPr>
-      <p:grpSpPr>
-        <a:xfrm xmlns:a="http://schemas.openxmlformats.org/drawingml/2006/main"/>
-      </p:grpSpPr>
-      <p:sp>
-        <p:nvSpPr>
-          <p:cNvPr id="2" name="Slide Image Placeholder 1"/>
-          <p:cNvSpPr>
-            <a:spLocks xmlns:a="http://schemas.openxmlformats.org/drawingml/2006/main" noGrp="1"/>
-          </p:cNvSpPr>
-          <p:nvPr>
-            <p:ph type="sldImg" idx="0"/>
-          </p:nvPr>
-        </p:nvSpPr>
-        <p:spPr/>
-      </p:sp>
-      <p:sp>
-        <p:nvSpPr>
-          <p:cNvPr id="3" name="Notes Placeholder 2"/>
-          <p:cNvSpPr>
-            <a:spLocks xmlns:a="http://schemas.openxmlformats.org/drawingml/2006/main" noGrp="1"/>
-          </p:cNvSpPr>
-          <p:nvPr>
-            <p:ph type="body" idx="1"/>
-          </p:nvPr>
-        </p:nvSpPr>
-        <p:spPr/>
-        <p:txBody>
-          <a:bodyPr xmlns:a="http://schemas.openxmlformats.org/drawingml/2006/main"/>
-          <a:lstStyle xmlns:a="http://schemas.openxmlformats.org/drawingml/2006/main"/>
-          <a:p xmlns:a="http://schemas.openxmlformats.org/drawingml/2006/main">
-            <a:r>
-              <a:t>Slide 19: Present the visible points and relate them to the repository documents: docs/whitepaper.md, bridge/docs/dev/spec.md, bridge/docs/dev/current-implementation.md, and docs/dapps/private-state.</a:t>
-            </a:r>
-          </a:p>
-        </p:txBody>
-      </p:sp>
-      <p:sp>
-        <p:nvSpPr>
-          <p:cNvPr id="4" name="Slide Number Placeholder 3"/>
-          <p:cNvSpPr>
-            <a:spLocks xmlns:a="http://schemas.openxmlformats.org/drawingml/2006/main" noGrp="1"/>
-          </p:cNvSpPr>
-          <p:nvPr>
-            <p:ph type="sldNum" idx="5"/>
-          </p:nvPr>
-        </p:nvSpPr>
-        <p:spPr/>
-        <p:txBody>
-          <a:bodyPr xmlns:a="http://schemas.openxmlformats.org/drawingml/2006/main"/>
-          <a:lstStyle xmlns:a="http://schemas.openxmlformats.org/drawingml/2006/main"/>
-          <a:p xmlns:a="http://schemas.openxmlformats.org/drawingml/2006/main"/>
-        </p:txBody>
-      </p:sp>
-    </p:spTree>
-  </p:cSld>
-  <p:clrMapOvr>
-    <a:masterClrMapping xmlns:a="http://schemas.openxmlformats.org/drawingml/2006/main"/>
-  </p:clrMapOvr>
-</p:notes>
-</file>
-
-<file path=ppt/notesSlides/notesSlide2.xml><?xml version="1.0" encoding="utf-8"?>
-<p:notes xmlns:p="http://schemas.openxmlformats.org/presentationml/2006/main">
-  <p:cSld>
-    <p:spTree>
-      <p:nvGrpSpPr>
-        <p:cNvPr id="1" name=""/>
-        <p:cNvGrpSpPr/>
-        <p:nvPr/>
-      </p:nvGrpSpPr>
-      <p:grpSpPr>
-        <a:xfrm xmlns:a="http://schemas.openxmlformats.org/drawingml/2006/main"/>
-      </p:grpSpPr>
-      <p:sp>
-        <p:nvSpPr>
-          <p:cNvPr id="2" name="Slide Image Placeholder 1"/>
-          <p:cNvSpPr>
-            <a:spLocks xmlns:a="http://schemas.openxmlformats.org/drawingml/2006/main" noGrp="1"/>
-          </p:cNvSpPr>
-          <p:nvPr>
-            <p:ph type="sldImg" idx="0"/>
-          </p:nvPr>
-        </p:nvSpPr>
-        <p:spPr/>
-      </p:sp>
-      <p:sp>
-        <p:nvSpPr>
-          <p:cNvPr id="3" name="Notes Placeholder 2"/>
-          <p:cNvSpPr>
-            <a:spLocks xmlns:a="http://schemas.openxmlformats.org/drawingml/2006/main" noGrp="1"/>
-          </p:cNvSpPr>
-          <p:nvPr>
-            <p:ph type="body" idx="1"/>
-          </p:nvPr>
-        </p:nvSpPr>
-        <p:spPr/>
-        <p:txBody>
-          <a:bodyPr xmlns:a="http://schemas.openxmlformats.org/drawingml/2006/main"/>
-          <a:lstStyle xmlns:a="http://schemas.openxmlformats.org/drawingml/2006/main"/>
-          <a:p xmlns:a="http://schemas.openxmlformats.org/drawingml/2006/main">
-            <a:r>
-              <a:t>Slide 2: Present the visible points and relate them to the repository documents: docs/whitepaper.md, bridge/docs/dev/spec.md, bridge/docs/dev/current-implementation.md, and docs/dapps/private-state.</a:t>
-            </a:r>
-          </a:p>
-        </p:txBody>
-      </p:sp>
-      <p:sp>
-        <p:nvSpPr>
-          <p:cNvPr id="4" name="Slide Number Placeholder 3"/>
-          <p:cNvSpPr>
-            <a:spLocks xmlns:a="http://schemas.openxmlformats.org/drawingml/2006/main" noGrp="1"/>
-          </p:cNvSpPr>
-          <p:nvPr>
-            <p:ph type="sldNum" idx="5"/>
-          </p:nvPr>
-        </p:nvSpPr>
-        <p:spPr/>
-        <p:txBody>
-          <a:bodyPr xmlns:a="http://schemas.openxmlformats.org/drawingml/2006/main"/>
-          <a:lstStyle xmlns:a="http://schemas.openxmlformats.org/drawingml/2006/main"/>
-          <a:p xmlns:a="http://schemas.openxmlformats.org/drawingml/2006/main"/>
-        </p:txBody>
-      </p:sp>
-    </p:spTree>
-  </p:cSld>
-  <p:clrMapOvr>
-    <a:masterClrMapping xmlns:a="http://schemas.openxmlformats.org/drawingml/2006/main"/>
-  </p:clrMapOvr>
-</p:notes>
-</file>
-
-<file path=ppt/notesSlides/notesSlide3.xml><?xml version="1.0" encoding="utf-8"?>
-<p:notes xmlns:p="http://schemas.openxmlformats.org/presentationml/2006/main">
-  <p:cSld>
-    <p:spTree>
-      <p:nvGrpSpPr>
-        <p:cNvPr id="1" name=""/>
-        <p:cNvGrpSpPr/>
-        <p:nvPr/>
-      </p:nvGrpSpPr>
-      <p:grpSpPr>
-        <a:xfrm xmlns:a="http://schemas.openxmlformats.org/drawingml/2006/main"/>
-      </p:grpSpPr>
-      <p:sp>
-        <p:nvSpPr>
-          <p:cNvPr id="2" name="Slide Image Placeholder 1"/>
-          <p:cNvSpPr>
-            <a:spLocks xmlns:a="http://schemas.openxmlformats.org/drawingml/2006/main" noGrp="1"/>
-          </p:cNvSpPr>
-          <p:nvPr>
-            <p:ph type="sldImg" idx="0"/>
-          </p:nvPr>
-        </p:nvSpPr>
-        <p:spPr/>
-      </p:sp>
-      <p:sp>
-        <p:nvSpPr>
-          <p:cNvPr id="3" name="Notes Placeholder 2"/>
-          <p:cNvSpPr>
-            <a:spLocks xmlns:a="http://schemas.openxmlformats.org/drawingml/2006/main" noGrp="1"/>
-          </p:cNvSpPr>
-          <p:nvPr>
-            <p:ph type="body" idx="1"/>
-          </p:nvPr>
-        </p:nvSpPr>
-        <p:spPr/>
-        <p:txBody>
-          <a:bodyPr xmlns:a="http://schemas.openxmlformats.org/drawingml/2006/main"/>
-          <a:lstStyle xmlns:a="http://schemas.openxmlformats.org/drawingml/2006/main"/>
-          <a:p xmlns:a="http://schemas.openxmlformats.org/drawingml/2006/main">
-            <a:r>
-              <a:t>Slide 3: Present the visible points and relate them to the repository documents: docs/whitepaper.md, bridge/docs/dev/spec.md, bridge/docs/dev/current-implementation.md, and docs/dapps/private-state.</a:t>
-            </a:r>
-          </a:p>
-        </p:txBody>
-      </p:sp>
-      <p:sp>
-        <p:nvSpPr>
-          <p:cNvPr id="4" name="Slide Number Placeholder 3"/>
-          <p:cNvSpPr>
-            <a:spLocks xmlns:a="http://schemas.openxmlformats.org/drawingml/2006/main" noGrp="1"/>
-          </p:cNvSpPr>
-          <p:nvPr>
-            <p:ph type="sldNum" idx="5"/>
-          </p:nvPr>
-        </p:nvSpPr>
-        <p:spPr/>
-        <p:txBody>
-          <a:bodyPr xmlns:a="http://schemas.openxmlformats.org/drawingml/2006/main"/>
-          <a:lstStyle xmlns:a="http://schemas.openxmlformats.org/drawingml/2006/main"/>
-          <a:p xmlns:a="http://schemas.openxmlformats.org/drawingml/2006/main"/>
-        </p:txBody>
-      </p:sp>
-    </p:spTree>
-  </p:cSld>
-  <p:clrMapOvr>
-    <a:masterClrMapping xmlns:a="http://schemas.openxmlformats.org/drawingml/2006/main"/>
-  </p:clrMapOvr>
-</p:notes>
-</file>
-
-<file path=ppt/notesSlides/notesSlide4.xml><?xml version="1.0" encoding="utf-8"?>
-<p:notes xmlns:p="http://schemas.openxmlformats.org/presentationml/2006/main">
-  <p:cSld>
-    <p:spTree>
-      <p:nvGrpSpPr>
-        <p:cNvPr id="1" name=""/>
-        <p:cNvGrpSpPr/>
-        <p:nvPr/>
-      </p:nvGrpSpPr>
-      <p:grpSpPr>
-        <a:xfrm xmlns:a="http://schemas.openxmlformats.org/drawingml/2006/main"/>
-      </p:grpSpPr>
-      <p:sp>
-        <p:nvSpPr>
-          <p:cNvPr id="2" name="Slide Image Placeholder 1"/>
-          <p:cNvSpPr>
-            <a:spLocks xmlns:a="http://schemas.openxmlformats.org/drawingml/2006/main" noGrp="1"/>
-          </p:cNvSpPr>
-          <p:nvPr>
-            <p:ph type="sldImg" idx="0"/>
-          </p:nvPr>
-        </p:nvSpPr>
-        <p:spPr/>
-      </p:sp>
-      <p:sp>
-        <p:nvSpPr>
-          <p:cNvPr id="3" name="Notes Placeholder 2"/>
-          <p:cNvSpPr>
-            <a:spLocks xmlns:a="http://schemas.openxmlformats.org/drawingml/2006/main" noGrp="1"/>
-          </p:cNvSpPr>
-          <p:nvPr>
-            <p:ph type="body" idx="1"/>
-          </p:nvPr>
-        </p:nvSpPr>
-        <p:spPr/>
-        <p:txBody>
-          <a:bodyPr xmlns:a="http://schemas.openxmlformats.org/drawingml/2006/main"/>
-          <a:lstStyle xmlns:a="http://schemas.openxmlformats.org/drawingml/2006/main"/>
-          <a:p xmlns:a="http://schemas.openxmlformats.org/drawingml/2006/main">
-            <a:r>
-              <a:t>Slide 4: Present the visible points and relate them to the repository documents: docs/whitepaper.md, bridge/docs/dev/spec.md, bridge/docs/dev/current-implementation.md, and docs/dapps/private-state.</a:t>
-            </a:r>
-          </a:p>
-        </p:txBody>
-      </p:sp>
-      <p:sp>
-        <p:nvSpPr>
-          <p:cNvPr id="4" name="Slide Number Placeholder 3"/>
-          <p:cNvSpPr>
-            <a:spLocks xmlns:a="http://schemas.openxmlformats.org/drawingml/2006/main" noGrp="1"/>
-          </p:cNvSpPr>
-          <p:nvPr>
-            <p:ph type="sldNum" idx="5"/>
-          </p:nvPr>
-        </p:nvSpPr>
-        <p:spPr/>
-        <p:txBody>
-          <a:bodyPr xmlns:a="http://schemas.openxmlformats.org/drawingml/2006/main"/>
-          <a:lstStyle xmlns:a="http://schemas.openxmlformats.org/drawingml/2006/main"/>
-          <a:p xmlns:a="http://schemas.openxmlformats.org/drawingml/2006/main"/>
-        </p:txBody>
-      </p:sp>
-    </p:spTree>
-  </p:cSld>
-  <p:clrMapOvr>
-    <a:masterClrMapping xmlns:a="http://schemas.openxmlformats.org/drawingml/2006/main"/>
-  </p:clrMapOvr>
-</p:notes>
-</file>
-
-<file path=ppt/notesSlides/notesSlide5.xml><?xml version="1.0" encoding="utf-8"?>
-<p:notes xmlns:p="http://schemas.openxmlformats.org/presentationml/2006/main">
-  <p:cSld>
-    <p:spTree>
-      <p:nvGrpSpPr>
-        <p:cNvPr id="1" name=""/>
-        <p:cNvGrpSpPr/>
-        <p:nvPr/>
-      </p:nvGrpSpPr>
-      <p:grpSpPr>
-        <a:xfrm xmlns:a="http://schemas.openxmlformats.org/drawingml/2006/main"/>
-      </p:grpSpPr>
-      <p:sp>
-        <p:nvSpPr>
-          <p:cNvPr id="2" name="Slide Image Placeholder 1"/>
-          <p:cNvSpPr>
-            <a:spLocks xmlns:a="http://schemas.openxmlformats.org/drawingml/2006/main" noGrp="1"/>
-          </p:cNvSpPr>
-          <p:nvPr>
-            <p:ph type="sldImg" idx="0"/>
-          </p:nvPr>
-        </p:nvSpPr>
-        <p:spPr/>
-      </p:sp>
-      <p:sp>
-        <p:nvSpPr>
-          <p:cNvPr id="3" name="Notes Placeholder 2"/>
-          <p:cNvSpPr>
-            <a:spLocks xmlns:a="http://schemas.openxmlformats.org/drawingml/2006/main" noGrp="1"/>
-          </p:cNvSpPr>
-          <p:nvPr>
-            <p:ph type="body" idx="1"/>
-          </p:nvPr>
-        </p:nvSpPr>
-        <p:spPr/>
-        <p:txBody>
-          <a:bodyPr xmlns:a="http://schemas.openxmlformats.org/drawingml/2006/main"/>
-          <a:lstStyle xmlns:a="http://schemas.openxmlformats.org/drawingml/2006/main"/>
-          <a:p xmlns:a="http://schemas.openxmlformats.org/drawingml/2006/main">
-            <a:r>
-              <a:t>Slide 5: Present the visible points and relate them to the repository documents: docs/whitepaper.md, bridge/docs/dev/spec.md, bridge/docs/dev/current-implementation.md, and docs/dapps/private-state.</a:t>
-            </a:r>
-          </a:p>
-        </p:txBody>
-      </p:sp>
-      <p:sp>
-        <p:nvSpPr>
-          <p:cNvPr id="4" name="Slide Number Placeholder 3"/>
-          <p:cNvSpPr>
-            <a:spLocks xmlns:a="http://schemas.openxmlformats.org/drawingml/2006/main" noGrp="1"/>
-          </p:cNvSpPr>
-          <p:nvPr>
-            <p:ph type="sldNum" idx="5"/>
-          </p:nvPr>
-        </p:nvSpPr>
-        <p:spPr/>
-        <p:txBody>
-          <a:bodyPr xmlns:a="http://schemas.openxmlformats.org/drawingml/2006/main"/>
-          <a:lstStyle xmlns:a="http://schemas.openxmlformats.org/drawingml/2006/main"/>
-          <a:p xmlns:a="http://schemas.openxmlformats.org/drawingml/2006/main"/>
-        </p:txBody>
-      </p:sp>
-    </p:spTree>
-  </p:cSld>
-  <p:clrMapOvr>
-    <a:masterClrMapping xmlns:a="http://schemas.openxmlformats.org/drawingml/2006/main"/>
-  </p:clrMapOvr>
-</p:notes>
-</file>
-
-<file path=ppt/notesSlides/notesSlide6.xml><?xml version="1.0" encoding="utf-8"?>
-<p:notes xmlns:p="http://schemas.openxmlformats.org/presentationml/2006/main">
-  <p:cSld>
-    <p:spTree>
-      <p:nvGrpSpPr>
-        <p:cNvPr id="1" name=""/>
-        <p:cNvGrpSpPr/>
-        <p:nvPr/>
-      </p:nvGrpSpPr>
-      <p:grpSpPr>
-        <a:xfrm xmlns:a="http://schemas.openxmlformats.org/drawingml/2006/main"/>
-      </p:grpSpPr>
-      <p:sp>
-        <p:nvSpPr>
-          <p:cNvPr id="2" name="Slide Image Placeholder 1"/>
-          <p:cNvSpPr>
-            <a:spLocks xmlns:a="http://schemas.openxmlformats.org/drawingml/2006/main" noGrp="1"/>
-          </p:cNvSpPr>
-          <p:nvPr>
-            <p:ph type="sldImg" idx="0"/>
-          </p:nvPr>
-        </p:nvSpPr>
-        <p:spPr/>
-      </p:sp>
-      <p:sp>
-        <p:nvSpPr>
-          <p:cNvPr id="3" name="Notes Placeholder 2"/>
-          <p:cNvSpPr>
-            <a:spLocks xmlns:a="http://schemas.openxmlformats.org/drawingml/2006/main" noGrp="1"/>
-          </p:cNvSpPr>
-          <p:nvPr>
-            <p:ph type="body" idx="1"/>
-          </p:nvPr>
-        </p:nvSpPr>
-        <p:spPr/>
-        <p:txBody>
-          <a:bodyPr xmlns:a="http://schemas.openxmlformats.org/drawingml/2006/main"/>
-          <a:lstStyle xmlns:a="http://schemas.openxmlformats.org/drawingml/2006/main"/>
-          <a:p xmlns:a="http://schemas.openxmlformats.org/drawingml/2006/main">
-            <a:r>
-              <a:t>Slide 6: Present the visible points and relate them to the repository documents: docs/whitepaper.md, bridge/docs/dev/spec.md, bridge/docs/dev/current-implementation.md, and docs/dapps/private-state.</a:t>
-            </a:r>
-          </a:p>
-        </p:txBody>
-      </p:sp>
-      <p:sp>
-        <p:nvSpPr>
-          <p:cNvPr id="4" name="Slide Number Placeholder 3"/>
-          <p:cNvSpPr>
-            <a:spLocks xmlns:a="http://schemas.openxmlformats.org/drawingml/2006/main" noGrp="1"/>
-          </p:cNvSpPr>
-          <p:nvPr>
-            <p:ph type="sldNum" idx="5"/>
-          </p:nvPr>
-        </p:nvSpPr>
-        <p:spPr/>
-        <p:txBody>
-          <a:bodyPr xmlns:a="http://schemas.openxmlformats.org/drawingml/2006/main"/>
-          <a:lstStyle xmlns:a="http://schemas.openxmlformats.org/drawingml/2006/main"/>
-          <a:p xmlns:a="http://schemas.openxmlformats.org/drawingml/2006/main"/>
-        </p:txBody>
-      </p:sp>
-    </p:spTree>
-  </p:cSld>
-  <p:clrMapOvr>
-    <a:masterClrMapping xmlns:a="http://schemas.openxmlformats.org/drawingml/2006/main"/>
-  </p:clrMapOvr>
-</p:notes>
-</file>
-
-<file path=ppt/notesSlides/notesSlide7.xml><?xml version="1.0" encoding="utf-8"?>
-<p:notes xmlns:p="http://schemas.openxmlformats.org/presentationml/2006/main">
-  <p:cSld>
-    <p:spTree>
-      <p:nvGrpSpPr>
-        <p:cNvPr id="1" name=""/>
-        <p:cNvGrpSpPr/>
-        <p:nvPr/>
-      </p:nvGrpSpPr>
-      <p:grpSpPr>
-        <a:xfrm xmlns:a="http://schemas.openxmlformats.org/drawingml/2006/main"/>
-      </p:grpSpPr>
-      <p:sp>
-        <p:nvSpPr>
-          <p:cNvPr id="2" name="Slide Image Placeholder 1"/>
-          <p:cNvSpPr>
-            <a:spLocks xmlns:a="http://schemas.openxmlformats.org/drawingml/2006/main" noGrp="1"/>
-          </p:cNvSpPr>
-          <p:nvPr>
-            <p:ph type="sldImg" idx="0"/>
-          </p:nvPr>
-        </p:nvSpPr>
-        <p:spPr/>
-      </p:sp>
-      <p:sp>
-        <p:nvSpPr>
-          <p:cNvPr id="3" name="Notes Placeholder 2"/>
-          <p:cNvSpPr>
-            <a:spLocks xmlns:a="http://schemas.openxmlformats.org/drawingml/2006/main" noGrp="1"/>
-          </p:cNvSpPr>
-          <p:nvPr>
-            <p:ph type="body" idx="1"/>
-          </p:nvPr>
-        </p:nvSpPr>
-        <p:spPr/>
-        <p:txBody>
-          <a:bodyPr xmlns:a="http://schemas.openxmlformats.org/drawingml/2006/main"/>
-          <a:lstStyle xmlns:a="http://schemas.openxmlformats.org/drawingml/2006/main"/>
-          <a:p xmlns:a="http://schemas.openxmlformats.org/drawingml/2006/main">
-            <a:r>
-              <a:t>Slide 7: Present the visible points and relate them to the repository documents: docs/whitepaper.md, bridge/docs/dev/spec.md, bridge/docs/dev/current-implementation.md, and docs/dapps/private-state.</a:t>
-            </a:r>
-          </a:p>
-        </p:txBody>
-      </p:sp>
-      <p:sp>
-        <p:nvSpPr>
-          <p:cNvPr id="4" name="Slide Number Placeholder 3"/>
-          <p:cNvSpPr>
-            <a:spLocks xmlns:a="http://schemas.openxmlformats.org/drawingml/2006/main" noGrp="1"/>
-          </p:cNvSpPr>
-          <p:nvPr>
-            <p:ph type="sldNum" idx="5"/>
-          </p:nvPr>
-        </p:nvSpPr>
-        <p:spPr/>
-        <p:txBody>
-          <a:bodyPr xmlns:a="http://schemas.openxmlformats.org/drawingml/2006/main"/>
-          <a:lstStyle xmlns:a="http://schemas.openxmlformats.org/drawingml/2006/main"/>
-          <a:p xmlns:a="http://schemas.openxmlformats.org/drawingml/2006/main"/>
-        </p:txBody>
-      </p:sp>
-    </p:spTree>
-  </p:cSld>
-  <p:clrMapOvr>
-    <a:masterClrMapping xmlns:a="http://schemas.openxmlformats.org/drawingml/2006/main"/>
-  </p:clrMapOvr>
-</p:notes>
-</file>
-
-<file path=ppt/notesSlides/notesSlide8.xml><?xml version="1.0" encoding="utf-8"?>
-<p:notes xmlns:p="http://schemas.openxmlformats.org/presentationml/2006/main">
-  <p:cSld>
-    <p:spTree>
-      <p:nvGrpSpPr>
-        <p:cNvPr id="1" name=""/>
-        <p:cNvGrpSpPr/>
-        <p:nvPr/>
-      </p:nvGrpSpPr>
-      <p:grpSpPr>
-        <a:xfrm xmlns:a="http://schemas.openxmlformats.org/drawingml/2006/main"/>
-      </p:grpSpPr>
-      <p:sp>
-        <p:nvSpPr>
-          <p:cNvPr id="2" name="Slide Image Placeholder 1"/>
-          <p:cNvSpPr>
-            <a:spLocks xmlns:a="http://schemas.openxmlformats.org/drawingml/2006/main" noGrp="1"/>
-          </p:cNvSpPr>
-          <p:nvPr>
-            <p:ph type="sldImg" idx="0"/>
-          </p:nvPr>
-        </p:nvSpPr>
-        <p:spPr/>
-      </p:sp>
-      <p:sp>
-        <p:nvSpPr>
-          <p:cNvPr id="3" name="Notes Placeholder 2"/>
-          <p:cNvSpPr>
-            <a:spLocks xmlns:a="http://schemas.openxmlformats.org/drawingml/2006/main" noGrp="1"/>
-          </p:cNvSpPr>
-          <p:nvPr>
-            <p:ph type="body" idx="1"/>
-          </p:nvPr>
-        </p:nvSpPr>
-        <p:spPr/>
-        <p:txBody>
-          <a:bodyPr xmlns:a="http://schemas.openxmlformats.org/drawingml/2006/main"/>
-          <a:lstStyle xmlns:a="http://schemas.openxmlformats.org/drawingml/2006/main"/>
-          <a:p xmlns:a="http://schemas.openxmlformats.org/drawingml/2006/main">
-            <a:r>
-              <a:t>Slide 8: Present the visible points and relate them to the repository documents: docs/whitepaper.md, bridge/docs/dev/spec.md, bridge/docs/dev/current-implementation.md, and docs/dapps/private-state.</a:t>
-            </a:r>
-          </a:p>
-        </p:txBody>
-      </p:sp>
-      <p:sp>
-        <p:nvSpPr>
-          <p:cNvPr id="4" name="Slide Number Placeholder 3"/>
-          <p:cNvSpPr>
-            <a:spLocks xmlns:a="http://schemas.openxmlformats.org/drawingml/2006/main" noGrp="1"/>
-          </p:cNvSpPr>
-          <p:nvPr>
-            <p:ph type="sldNum" idx="5"/>
-          </p:nvPr>
-        </p:nvSpPr>
-        <p:spPr/>
-        <p:txBody>
-          <a:bodyPr xmlns:a="http://schemas.openxmlformats.org/drawingml/2006/main"/>
-          <a:lstStyle xmlns:a="http://schemas.openxmlformats.org/drawingml/2006/main"/>
-          <a:p xmlns:a="http://schemas.openxmlformats.org/drawingml/2006/main"/>
-        </p:txBody>
-      </p:sp>
-    </p:spTree>
-  </p:cSld>
-  <p:clrMapOvr>
-    <a:masterClrMapping xmlns:a="http://schemas.openxmlformats.org/drawingml/2006/main"/>
-  </p:clrMapOvr>
-</p:notes>
-</file>
-
-<file path=ppt/notesSlides/notesSlide9.xml><?xml version="1.0" encoding="utf-8"?>
-<p:notes xmlns:p="http://schemas.openxmlformats.org/presentationml/2006/main">
-  <p:cSld>
-    <p:spTree>
-      <p:nvGrpSpPr>
-        <p:cNvPr id="1" name=""/>
-        <p:cNvGrpSpPr/>
-        <p:nvPr/>
-      </p:nvGrpSpPr>
-      <p:grpSpPr>
-        <a:xfrm xmlns:a="http://schemas.openxmlformats.org/drawingml/2006/main"/>
-      </p:grpSpPr>
-      <p:sp>
-        <p:nvSpPr>
-          <p:cNvPr id="2" name="Slide Image Placeholder 1"/>
-          <p:cNvSpPr>
-            <a:spLocks xmlns:a="http://schemas.openxmlformats.org/drawingml/2006/main" noGrp="1"/>
-          </p:cNvSpPr>
-          <p:nvPr>
-            <p:ph type="sldImg" idx="0"/>
-          </p:nvPr>
-        </p:nvSpPr>
-        <p:spPr/>
-      </p:sp>
-      <p:sp>
-        <p:nvSpPr>
-          <p:cNvPr id="3" name="Notes Placeholder 2"/>
-          <p:cNvSpPr>
-            <a:spLocks xmlns:a="http://schemas.openxmlformats.org/drawingml/2006/main" noGrp="1"/>
-          </p:cNvSpPr>
-          <p:nvPr>
-            <p:ph type="body" idx="1"/>
-          </p:nvPr>
-        </p:nvSpPr>
-        <p:spPr/>
-        <p:txBody>
-          <a:bodyPr xmlns:a="http://schemas.openxmlformats.org/drawingml/2006/main"/>
-          <a:lstStyle xmlns:a="http://schemas.openxmlformats.org/drawingml/2006/main"/>
-          <a:p xmlns:a="http://schemas.openxmlformats.org/drawingml/2006/main">
-            <a:r>
-              <a:t>Slide 9: Present the visible points and relate them to the repository documents: docs/whitepaper.md, bridge/docs/dev/spec.md, bridge/docs/dev/current-implementation.md, and docs/dapps/private-state.</a:t>
-            </a:r>
-          </a:p>
-        </p:txBody>
-      </p:sp>
-      <p:sp>
-        <p:nvSpPr>
-          <p:cNvPr id="4" name="Slide Number Placeholder 3"/>
-          <p:cNvSpPr>
-            <a:spLocks xmlns:a="http://schemas.openxmlformats.org/drawingml/2006/main" noGrp="1"/>
-          </p:cNvSpPr>
-          <p:nvPr>
-            <p:ph type="sldNum" idx="5"/>
-          </p:nvPr>
-        </p:nvSpPr>
-        <p:spPr/>
-        <p:txBody>
-          <a:bodyPr xmlns:a="http://schemas.openxmlformats.org/drawingml/2006/main"/>
-          <a:lstStyle xmlns:a="http://schemas.openxmlformats.org/drawingml/2006/main"/>
-          <a:p xmlns:a="http://schemas.openxmlformats.org/drawingml/2006/main"/>
-        </p:txBody>
-      </p:sp>
-    </p:spTree>
-  </p:cSld>
-  <p:clrMapOvr>
-    <a:masterClrMapping xmlns:a="http://schemas.openxmlformats.org/drawingml/2006/main"/>
-  </p:clrMapOvr>
-</p:notes>
-</file>
-
 <file path=ppt/slideLayouts/slideLayout2.xml><?xml version="1.0" encoding="utf-8"?>
 <p:sldLayout xmlns:p="http://schemas.openxmlformats.org/presentationml/2006/main" type="title">
   <p:cSld name="Title Slide">

</xml_diff>

<commit_message>
Adjust bridge deck rendered layout
</commit_message>
<xml_diff>
--- a/bridge/docs/dev/spec.pptx
+++ b/bridge/docs/dev/spec.pptx
@@ -3942,7 +3942,7 @@
         <p:spPr>
           <a:xfrm>
             <a:off x="530352" y="804672"/>
-            <a:ext cx="7406640" cy="566928"/>
+            <a:ext cx="8046720" cy="640080"/>
           </a:xfrm>
           <a:prstGeom prst="rect">
             <a:avLst/>
@@ -3978,7 +3978,7 @@
         <p:spPr>
           <a:xfrm>
             <a:off x="548640" y="1444752"/>
-            <a:ext cx="7498079" cy="438912"/>
+            <a:ext cx="7863840" cy="438912"/>
           </a:xfrm>
           <a:prstGeom prst="rect">
             <a:avLst/>
@@ -5189,7 +5189,7 @@
         <p:spPr>
           <a:xfrm>
             <a:off x="530352" y="804672"/>
-            <a:ext cx="7406640" cy="566928"/>
+            <a:ext cx="8046720" cy="932688"/>
           </a:xfrm>
           <a:prstGeom prst="rect">
             <a:avLst/>
@@ -5203,7 +5203,7 @@
           <a:lstStyle/>
           <a:p>
             <a:pPr>
-              <a:defRPr sz="3000" b="1">
+              <a:defRPr sz="2800" b="1">
                 <a:solidFill>
                   <a:srgbClr val="101828"/>
                 </a:solidFill>
@@ -5224,8 +5224,8 @@
         </p:nvSpPr>
         <p:spPr>
           <a:xfrm>
-            <a:off x="548640" y="1444752"/>
-            <a:ext cx="7498079" cy="438912"/>
+            <a:off x="548640" y="1719072"/>
+            <a:ext cx="7863840" cy="438912"/>
           </a:xfrm>
           <a:prstGeom prst="rect">
             <a:avLst/>
@@ -5985,7 +5985,7 @@
         <p:spPr>
           <a:xfrm>
             <a:off x="530352" y="804672"/>
-            <a:ext cx="7406640" cy="566928"/>
+            <a:ext cx="8046720" cy="932688"/>
           </a:xfrm>
           <a:prstGeom prst="rect">
             <a:avLst/>
@@ -5999,7 +5999,7 @@
           <a:lstStyle/>
           <a:p>
             <a:pPr>
-              <a:defRPr sz="3400" b="1">
+              <a:defRPr sz="2800" b="1">
                 <a:solidFill>
                   <a:srgbClr val="101828"/>
                 </a:solidFill>
@@ -6020,8 +6020,8 @@
         </p:nvSpPr>
         <p:spPr>
           <a:xfrm>
-            <a:off x="548640" y="1444752"/>
-            <a:ext cx="7498079" cy="438912"/>
+            <a:off x="548640" y="1719072"/>
+            <a:ext cx="7863840" cy="438912"/>
           </a:xfrm>
           <a:prstGeom prst="rect">
             <a:avLst/>
@@ -6668,7 +6668,7 @@
         <p:spPr>
           <a:xfrm>
             <a:off x="530352" y="804672"/>
-            <a:ext cx="7406640" cy="566928"/>
+            <a:ext cx="8046720" cy="932688"/>
           </a:xfrm>
           <a:prstGeom prst="rect">
             <a:avLst/>
@@ -6682,7 +6682,7 @@
           <a:lstStyle/>
           <a:p>
             <a:pPr>
-              <a:defRPr sz="3400" b="1">
+              <a:defRPr sz="2800" b="1">
                 <a:solidFill>
                   <a:srgbClr val="101828"/>
                 </a:solidFill>
@@ -6703,8 +6703,8 @@
         </p:nvSpPr>
         <p:spPr>
           <a:xfrm>
-            <a:off x="548640" y="1444752"/>
-            <a:ext cx="7498079" cy="438912"/>
+            <a:off x="548640" y="1719072"/>
+            <a:ext cx="7863840" cy="438912"/>
           </a:xfrm>
           <a:prstGeom prst="rect">
             <a:avLst/>
@@ -7980,7 +7980,7 @@
         <p:spPr>
           <a:xfrm>
             <a:off x="530352" y="804672"/>
-            <a:ext cx="7406640" cy="566928"/>
+            <a:ext cx="8046720" cy="932688"/>
           </a:xfrm>
           <a:prstGeom prst="rect">
             <a:avLst/>
@@ -7994,7 +7994,7 @@
           <a:lstStyle/>
           <a:p>
             <a:pPr>
-              <a:defRPr sz="3000" b="1">
+              <a:defRPr sz="2800" b="1">
                 <a:solidFill>
                   <a:srgbClr val="101828"/>
                 </a:solidFill>
@@ -8015,8 +8015,8 @@
         </p:nvSpPr>
         <p:spPr>
           <a:xfrm>
-            <a:off x="548640" y="1444752"/>
-            <a:ext cx="7498079" cy="438912"/>
+            <a:off x="548640" y="1719072"/>
+            <a:ext cx="7863840" cy="438912"/>
           </a:xfrm>
           <a:prstGeom prst="rect">
             <a:avLst/>
@@ -9066,7 +9066,7 @@
         <p:spPr>
           <a:xfrm>
             <a:off x="530352" y="804672"/>
-            <a:ext cx="7406640" cy="566928"/>
+            <a:ext cx="8046720" cy="932688"/>
           </a:xfrm>
           <a:prstGeom prst="rect">
             <a:avLst/>
@@ -9080,7 +9080,7 @@
           <a:lstStyle/>
           <a:p>
             <a:pPr>
-              <a:defRPr sz="3400" b="1">
+              <a:defRPr sz="2800" b="1">
                 <a:solidFill>
                   <a:srgbClr val="101828"/>
                 </a:solidFill>
@@ -9101,8 +9101,8 @@
         </p:nvSpPr>
         <p:spPr>
           <a:xfrm>
-            <a:off x="548640" y="1444752"/>
-            <a:ext cx="7498079" cy="438912"/>
+            <a:off x="548640" y="1719072"/>
+            <a:ext cx="7863840" cy="438912"/>
           </a:xfrm>
           <a:prstGeom prst="rect">
             <a:avLst/>
@@ -10298,7 +10298,7 @@
         <p:spPr>
           <a:xfrm>
             <a:off x="530352" y="804672"/>
-            <a:ext cx="7406640" cy="566928"/>
+            <a:ext cx="8046720" cy="932688"/>
           </a:xfrm>
           <a:prstGeom prst="rect">
             <a:avLst/>
@@ -10312,7 +10312,7 @@
           <a:lstStyle/>
           <a:p>
             <a:pPr>
-              <a:defRPr sz="3400" b="1">
+              <a:defRPr sz="2800" b="1">
                 <a:solidFill>
                   <a:srgbClr val="101828"/>
                 </a:solidFill>
@@ -10333,8 +10333,8 @@
         </p:nvSpPr>
         <p:spPr>
           <a:xfrm>
-            <a:off x="548640" y="1444752"/>
-            <a:ext cx="7498079" cy="438912"/>
+            <a:off x="548640" y="1719072"/>
+            <a:ext cx="7863840" cy="438912"/>
           </a:xfrm>
           <a:prstGeom prst="rect">
             <a:avLst/>
@@ -11397,7 +11397,7 @@
         <p:spPr>
           <a:xfrm>
             <a:off x="530352" y="804672"/>
-            <a:ext cx="7406640" cy="566928"/>
+            <a:ext cx="8046720" cy="932688"/>
           </a:xfrm>
           <a:prstGeom prst="rect">
             <a:avLst/>
@@ -11411,7 +11411,7 @@
           <a:lstStyle/>
           <a:p>
             <a:pPr>
-              <a:defRPr sz="3400" b="1">
+              <a:defRPr sz="2800" b="1">
                 <a:solidFill>
                   <a:srgbClr val="101828"/>
                 </a:solidFill>
@@ -11432,8 +11432,8 @@
         </p:nvSpPr>
         <p:spPr>
           <a:xfrm>
-            <a:off x="548640" y="1444752"/>
-            <a:ext cx="7498079" cy="438912"/>
+            <a:off x="548640" y="1719072"/>
+            <a:ext cx="7863840" cy="438912"/>
           </a:xfrm>
           <a:prstGeom prst="rect">
             <a:avLst/>
@@ -12824,7 +12824,7 @@
         <p:spPr>
           <a:xfrm>
             <a:off x="530352" y="804672"/>
-            <a:ext cx="7406640" cy="566928"/>
+            <a:ext cx="8046720" cy="932688"/>
           </a:xfrm>
           <a:prstGeom prst="rect">
             <a:avLst/>
@@ -12838,7 +12838,7 @@
           <a:lstStyle/>
           <a:p>
             <a:pPr>
-              <a:defRPr sz="3400" b="1">
+              <a:defRPr sz="2800" b="1">
                 <a:solidFill>
                   <a:srgbClr val="101828"/>
                 </a:solidFill>
@@ -12859,8 +12859,8 @@
         </p:nvSpPr>
         <p:spPr>
           <a:xfrm>
-            <a:off x="548640" y="1444752"/>
-            <a:ext cx="7498079" cy="438912"/>
+            <a:off x="548640" y="1719072"/>
+            <a:ext cx="7863840" cy="438912"/>
           </a:xfrm>
           <a:prstGeom prst="rect">
             <a:avLst/>
@@ -13756,7 +13756,7 @@
         <p:spPr>
           <a:xfrm>
             <a:off x="530352" y="804672"/>
-            <a:ext cx="7406640" cy="566928"/>
+            <a:ext cx="8046720" cy="640080"/>
           </a:xfrm>
           <a:prstGeom prst="rect">
             <a:avLst/>
@@ -13792,7 +13792,7 @@
         <p:spPr>
           <a:xfrm>
             <a:off x="548640" y="1444752"/>
-            <a:ext cx="7498079" cy="438912"/>
+            <a:ext cx="7863840" cy="438912"/>
           </a:xfrm>
           <a:prstGeom prst="rect">
             <a:avLst/>
@@ -14522,7 +14522,7 @@
         <p:spPr>
           <a:xfrm>
             <a:off x="530352" y="804672"/>
-            <a:ext cx="7406640" cy="566928"/>
+            <a:ext cx="8046720" cy="640080"/>
           </a:xfrm>
           <a:prstGeom prst="rect">
             <a:avLst/>
@@ -14558,7 +14558,7 @@
         <p:spPr>
           <a:xfrm>
             <a:off x="548640" y="1444752"/>
-            <a:ext cx="7498079" cy="438912"/>
+            <a:ext cx="7863840" cy="438912"/>
           </a:xfrm>
           <a:prstGeom prst="rect">
             <a:avLst/>
@@ -15567,7 +15567,7 @@
         <p:spPr>
           <a:xfrm>
             <a:off x="530352" y="804672"/>
-            <a:ext cx="7406640" cy="566928"/>
+            <a:ext cx="8046720" cy="640080"/>
           </a:xfrm>
           <a:prstGeom prst="rect">
             <a:avLst/>
@@ -15603,7 +15603,7 @@
         <p:spPr>
           <a:xfrm>
             <a:off x="548640" y="1444752"/>
-            <a:ext cx="7498079" cy="438912"/>
+            <a:ext cx="7863840" cy="438912"/>
           </a:xfrm>
           <a:prstGeom prst="rect">
             <a:avLst/>
@@ -16566,7 +16566,7 @@
         <p:spPr>
           <a:xfrm>
             <a:off x="530352" y="804672"/>
-            <a:ext cx="7406640" cy="566928"/>
+            <a:ext cx="8046720" cy="932688"/>
           </a:xfrm>
           <a:prstGeom prst="rect">
             <a:avLst/>
@@ -16580,7 +16580,7 @@
           <a:lstStyle/>
           <a:p>
             <a:pPr>
-              <a:defRPr sz="3400" b="1">
+              <a:defRPr sz="2800" b="1">
                 <a:solidFill>
                   <a:srgbClr val="101828"/>
                 </a:solidFill>
@@ -16601,8 +16601,8 @@
         </p:nvSpPr>
         <p:spPr>
           <a:xfrm>
-            <a:off x="548640" y="1444752"/>
-            <a:ext cx="7498079" cy="438912"/>
+            <a:off x="548640" y="1719072"/>
+            <a:ext cx="7863840" cy="438912"/>
           </a:xfrm>
           <a:prstGeom prst="rect">
             <a:avLst/>
@@ -17858,7 +17858,7 @@
         <p:spPr>
           <a:xfrm>
             <a:off x="530352" y="804672"/>
-            <a:ext cx="7406640" cy="566928"/>
+            <a:ext cx="8046720" cy="640080"/>
           </a:xfrm>
           <a:prstGeom prst="rect">
             <a:avLst/>
@@ -17894,7 +17894,7 @@
         <p:spPr>
           <a:xfrm>
             <a:off x="548640" y="1444752"/>
-            <a:ext cx="7498079" cy="438912"/>
+            <a:ext cx="7863840" cy="438912"/>
           </a:xfrm>
           <a:prstGeom prst="rect">
             <a:avLst/>
@@ -18709,7 +18709,7 @@
         <p:spPr>
           <a:xfrm>
             <a:off x="530352" y="804672"/>
-            <a:ext cx="7406640" cy="566928"/>
+            <a:ext cx="8046720" cy="932688"/>
           </a:xfrm>
           <a:prstGeom prst="rect">
             <a:avLst/>
@@ -18723,7 +18723,7 @@
           <a:lstStyle/>
           <a:p>
             <a:pPr>
-              <a:defRPr sz="3400" b="1">
+              <a:defRPr sz="2800" b="1">
                 <a:solidFill>
                   <a:srgbClr val="101828"/>
                 </a:solidFill>
@@ -18744,8 +18744,8 @@
         </p:nvSpPr>
         <p:spPr>
           <a:xfrm>
-            <a:off x="548640" y="1444752"/>
-            <a:ext cx="7498079" cy="438912"/>
+            <a:off x="548640" y="1719072"/>
+            <a:ext cx="7863840" cy="438912"/>
           </a:xfrm>
           <a:prstGeom prst="rect">
             <a:avLst/>
@@ -19905,7 +19905,7 @@
         <p:spPr>
           <a:xfrm>
             <a:off x="530352" y="804672"/>
-            <a:ext cx="7406640" cy="566928"/>
+            <a:ext cx="8046720" cy="932688"/>
           </a:xfrm>
           <a:prstGeom prst="rect">
             <a:avLst/>
@@ -19919,7 +19919,7 @@
           <a:lstStyle/>
           <a:p>
             <a:pPr>
-              <a:defRPr sz="3400" b="1">
+              <a:defRPr sz="2800" b="1">
                 <a:solidFill>
                   <a:srgbClr val="101828"/>
                 </a:solidFill>
@@ -19940,8 +19940,8 @@
         </p:nvSpPr>
         <p:spPr>
           <a:xfrm>
-            <a:off x="548640" y="1444752"/>
-            <a:ext cx="7498079" cy="438912"/>
+            <a:off x="548640" y="1719072"/>
+            <a:ext cx="7863840" cy="438912"/>
           </a:xfrm>
           <a:prstGeom prst="rect">
             <a:avLst/>
@@ -21106,7 +21106,7 @@
         <p:spPr>
           <a:xfrm>
             <a:off x="530352" y="804672"/>
-            <a:ext cx="7406640" cy="566928"/>
+            <a:ext cx="8046720" cy="932688"/>
           </a:xfrm>
           <a:prstGeom prst="rect">
             <a:avLst/>
@@ -21120,7 +21120,7 @@
           <a:lstStyle/>
           <a:p>
             <a:pPr>
-              <a:defRPr sz="3400" b="1">
+              <a:defRPr sz="2800" b="1">
                 <a:solidFill>
                   <a:srgbClr val="101828"/>
                 </a:solidFill>
@@ -21141,8 +21141,8 @@
         </p:nvSpPr>
         <p:spPr>
           <a:xfrm>
-            <a:off x="548640" y="1444752"/>
-            <a:ext cx="7498079" cy="438912"/>
+            <a:off x="548640" y="1719072"/>
+            <a:ext cx="7863840" cy="438912"/>
           </a:xfrm>
           <a:prstGeom prst="rect">
             <a:avLst/>
@@ -22622,7 +22622,7 @@
         <p:spPr>
           <a:xfrm>
             <a:off x="530352" y="804672"/>
-            <a:ext cx="7406640" cy="566928"/>
+            <a:ext cx="8046720" cy="932688"/>
           </a:xfrm>
           <a:prstGeom prst="rect">
             <a:avLst/>
@@ -22636,7 +22636,7 @@
           <a:lstStyle/>
           <a:p>
             <a:pPr>
-              <a:defRPr sz="3400" b="1">
+              <a:defRPr sz="2800" b="1">
                 <a:solidFill>
                   <a:srgbClr val="101828"/>
                 </a:solidFill>
@@ -22657,8 +22657,8 @@
         </p:nvSpPr>
         <p:spPr>
           <a:xfrm>
-            <a:off x="548640" y="1444752"/>
-            <a:ext cx="7498079" cy="438912"/>
+            <a:off x="548640" y="1719072"/>
+            <a:ext cx="7863840" cy="438912"/>
           </a:xfrm>
           <a:prstGeom prst="rect">
             <a:avLst/>

</xml_diff>

<commit_message>
Localize bridge deck and refresh implementation content
</commit_message>
<xml_diff>
--- a/bridge/docs/dev/spec.pptx
+++ b/bridge/docs/dev/spec.pptx
@@ -3389,7 +3389,7 @@
                 <a:solidFill>
                   <a:srgbClr val="FFFFFF"/>
                 </a:solidFill>
-                <a:latin typeface="Aptos Display"/>
+                <a:latin typeface="Apple SD Gothic Neo"/>
               </a:defRPr>
             </a:pPr>
             <a:r>
@@ -3407,7 +3407,7 @@
         <p:spPr>
           <a:xfrm>
             <a:off x="676656" y="2157984"/>
-            <a:ext cx="6126480" cy="475488"/>
+            <a:ext cx="6217920" cy="566928"/>
           </a:xfrm>
           <a:prstGeom prst="rect">
             <a:avLst/>
@@ -3425,11 +3425,11 @@
                 <a:solidFill>
                   <a:srgbClr val="CFD8E8"/>
                 </a:solidFill>
-                <a:latin typeface="Aptos"/>
-              </a:defRPr>
-            </a:pPr>
-            <a:r>
-              <a:t>Bridge-coupled validity-proven DApp channels for</a:t>
+                <a:latin typeface="Apple SD Gothic Neo"/>
+              </a:defRPr>
+            </a:pPr>
+            <a:r>
+              <a:t>Ethereum에 정산되는 자산을 기준으로</a:t>
             </a:r>
           </a:p>
           <a:p>
@@ -3438,11 +3438,11 @@
                 <a:solidFill>
                   <a:srgbClr val="CFD8E8"/>
                 </a:solidFill>
-                <a:latin typeface="Aptos"/>
-              </a:defRPr>
-            </a:pPr>
-            <a:r>
-              <a:t>Ethereum-settled confidential application state.</a:t>
+                <a:latin typeface="Apple SD Gothic Neo"/>
+              </a:defRPr>
+            </a:pPr>
+            <a:r>
+              <a:t>DApp별 프라이버시 실행 채널을 구성하는 브릿지 모델</a:t>
             </a:r>
           </a:p>
         </p:txBody>
@@ -3456,7 +3456,7 @@
         <p:spPr>
           <a:xfrm>
             <a:off x="685800" y="3227832"/>
-            <a:ext cx="1719072" cy="292608"/>
+            <a:ext cx="1444752" cy="292608"/>
           </a:xfrm>
           <a:prstGeom prst="roundRect">
             <a:avLst/>
@@ -3499,7 +3499,7 @@
         <p:spPr>
           <a:xfrm>
             <a:off x="713232" y="3291839"/>
-            <a:ext cx="1664207" cy="164592"/>
+            <a:ext cx="1389888" cy="164592"/>
           </a:xfrm>
           <a:prstGeom prst="rect">
             <a:avLst/>
@@ -3517,11 +3517,11 @@
                 <a:solidFill>
                   <a:srgbClr val="FFFFFF"/>
                 </a:solidFill>
-                <a:latin typeface="Aptos"/>
-              </a:defRPr>
-            </a:pPr>
-            <a:r>
-              <a:t>Ethereum settlement</a:t>
+                <a:latin typeface="Apple SD Gothic Neo"/>
+              </a:defRPr>
+            </a:pPr>
+            <a:r>
+              <a:t>Ethereum 정산</a:t>
             </a:r>
           </a:p>
         </p:txBody>
@@ -3534,8 +3534,8 @@
         </p:nvSpPr>
         <p:spPr>
           <a:xfrm>
-            <a:off x="2578608" y="3227832"/>
-            <a:ext cx="1847088" cy="292608"/>
+            <a:off x="2304288" y="3227832"/>
+            <a:ext cx="1645920" cy="292608"/>
           </a:xfrm>
           <a:prstGeom prst="roundRect">
             <a:avLst/>
@@ -3577,8 +3577,8 @@
         </p:nvSpPr>
         <p:spPr>
           <a:xfrm>
-            <a:off x="2606039" y="3291839"/>
-            <a:ext cx="1792224" cy="164592"/>
+            <a:off x="2331720" y="3291839"/>
+            <a:ext cx="1591056" cy="164592"/>
           </a:xfrm>
           <a:prstGeom prst="rect">
             <a:avLst/>
@@ -3596,11 +3596,11 @@
                 <a:solidFill>
                   <a:srgbClr val="FFFFFF"/>
                 </a:solidFill>
-                <a:latin typeface="Aptos"/>
-              </a:defRPr>
-            </a:pPr>
-            <a:r>
-              <a:t>DApp policy snapshots</a:t>
+                <a:latin typeface="Apple SD Gothic Neo"/>
+              </a:defRPr>
+            </a:pPr>
+            <a:r>
+              <a:t>DApp 정책 스냅샷</a:t>
             </a:r>
           </a:p>
         </p:txBody>
@@ -3613,8 +3613,8 @@
         </p:nvSpPr>
         <p:spPr>
           <a:xfrm>
-            <a:off x="4590288" y="3227832"/>
-            <a:ext cx="1618488" cy="292608"/>
+            <a:off x="4133087" y="3227832"/>
+            <a:ext cx="1508760" cy="292608"/>
           </a:xfrm>
           <a:prstGeom prst="roundRect">
             <a:avLst/>
@@ -3656,8 +3656,8 @@
         </p:nvSpPr>
         <p:spPr>
           <a:xfrm>
-            <a:off x="4617720" y="3291839"/>
-            <a:ext cx="1563624" cy="164592"/>
+            <a:off x="4160520" y="3291839"/>
+            <a:ext cx="1453895" cy="164592"/>
           </a:xfrm>
           <a:prstGeom prst="rect">
             <a:avLst/>
@@ -3675,11 +3675,11 @@
                 <a:solidFill>
                   <a:srgbClr val="FFFFFF"/>
                 </a:solidFill>
-                <a:latin typeface="Aptos"/>
-              </a:defRPr>
-            </a:pPr>
-            <a:r>
-              <a:t>Proof-backed state</a:t>
+                <a:latin typeface="Apple SD Gothic Neo"/>
+              </a:defRPr>
+            </a:pPr>
+            <a:r>
+              <a:t>증명 기반 상태</a:t>
             </a:r>
           </a:p>
         </p:txBody>
@@ -3711,11 +3711,11 @@
                 <a:solidFill>
                   <a:srgbClr val="AEBAD0"/>
                 </a:solidFill>
-                <a:latin typeface="Aptos"/>
-              </a:defRPr>
-            </a:pPr>
-            <a:r>
-              <a:t>Target audience: graduate researchers and protocol developers</a:t>
+                <a:latin typeface="Apple SD Gothic Neo"/>
+              </a:defRPr>
+            </a:pPr>
+            <a:r>
+              <a:t>대상: 대학원 연구자와 프로토콜 개발자</a:t>
             </a:r>
           </a:p>
         </p:txBody>
@@ -3747,7 +3747,7 @@
                 <a:solidFill>
                   <a:srgbClr val="FFFFFF"/>
                 </a:solidFill>
-                <a:latin typeface="Aptos"/>
+                <a:latin typeface="Apple SD Gothic Neo"/>
               </a:defRPr>
             </a:pPr>
             <a:r>
@@ -3783,7 +3783,7 @@
                 <a:solidFill>
                   <a:srgbClr val="FFFFFF"/>
                 </a:solidFill>
-                <a:latin typeface="Aptos"/>
+                <a:latin typeface="Apple SD Gothic Neo"/>
               </a:defRPr>
             </a:pPr>
             <a:r>
@@ -3819,7 +3819,7 @@
                 <a:solidFill>
                   <a:srgbClr val="FFFFFF"/>
                 </a:solidFill>
-                <a:latin typeface="Aptos"/>
+                <a:latin typeface="Apple SD Gothic Neo"/>
               </a:defRPr>
             </a:pPr>
             <a:r>
@@ -3924,11 +3924,11 @@
                 <a:solidFill>
                   <a:srgbClr val="2563EB"/>
                 </a:solidFill>
-                <a:latin typeface="Aptos"/>
-              </a:defRPr>
-            </a:pPr>
-            <a:r>
-              <a:t>STATE TRANSITIONS</a:t>
+                <a:latin typeface="Apple SD Gothic Neo"/>
+              </a:defRPr>
+            </a:pPr>
+            <a:r>
+              <a:t>상태 전이</a:t>
             </a:r>
           </a:p>
         </p:txBody>
@@ -3960,7 +3960,7 @@
                 <a:solidFill>
                   <a:srgbClr val="101828"/>
                 </a:solidFill>
-                <a:latin typeface="Aptos Display"/>
+                <a:latin typeface="Apple SD Gothic Neo"/>
               </a:defRPr>
             </a:pPr>
             <a:r>
@@ -3996,11 +3996,11 @@
                 <a:solidFill>
                   <a:srgbClr val="5C667A"/>
                 </a:solidFill>
-                <a:latin typeface="Aptos"/>
-              </a:defRPr>
-            </a:pPr>
-            <a:r>
-              <a:t>The L1 bridge verifies proof meaning before accepting a new channel commitment.</a:t>
+                <a:latin typeface="Apple SD Gothic Neo"/>
+              </a:defRPr>
+            </a:pPr>
+            <a:r>
+              <a:t>L1 브릿지는 새 channel commitment를 받아들이기 전에 proof의 의미를 검증한다.</a:t>
             </a:r>
           </a:p>
         </p:txBody>
@@ -4075,7 +4075,7 @@
                 <a:solidFill>
                   <a:srgbClr val="5C667A"/>
                 </a:solidFill>
-                <a:latin typeface="Aptos"/>
+                <a:latin typeface="Apple SD Gothic Neo"/>
               </a:defRPr>
             </a:pPr>
             <a:r>
@@ -4111,7 +4111,7 @@
                 <a:solidFill>
                   <a:srgbClr val="5C667A"/>
                 </a:solidFill>
-                <a:latin typeface="Aptos"/>
+                <a:latin typeface="Apple SD Gothic Neo"/>
               </a:defRPr>
             </a:pPr>
             <a:r>
@@ -4192,11 +4192,11 @@
                 <a:solidFill>
                   <a:srgbClr val="1B1F2A"/>
                 </a:solidFill>
-                <a:latin typeface="Aptos"/>
-              </a:defRPr>
-            </a:pPr>
-            <a:r>
-              <a:t>CLI builds proof</a:t>
+                <a:latin typeface="Apple SD Gothic Neo"/>
+              </a:defRPr>
+            </a:pPr>
+            <a:r>
+              <a:t>CLI가 proof</a:t>
             </a:r>
           </a:p>
           <a:p>
@@ -4205,11 +4205,11 @@
                 <a:solidFill>
                   <a:srgbClr val="1B1F2A"/>
                 </a:solidFill>
-                <a:latin typeface="Aptos"/>
-              </a:defRPr>
-            </a:pPr>
-            <a:r>
-              <a:t>input bundle</a:t>
+                <a:latin typeface="Apple SD Gothic Neo"/>
+              </a:defRPr>
+            </a:pPr>
+            <a:r>
+              <a:t>input bundle 구성</a:t>
             </a:r>
           </a:p>
         </p:txBody>
@@ -4321,7 +4321,7 @@
                 <a:solidFill>
                   <a:srgbClr val="1B1F2A"/>
                 </a:solidFill>
-                <a:latin typeface="Aptos"/>
+                <a:latin typeface="Apple SD Gothic Neo"/>
               </a:defRPr>
             </a:pPr>
             <a:r>
@@ -4334,11 +4334,11 @@
                 <a:solidFill>
                   <a:srgbClr val="1B1F2A"/>
                 </a:solidFill>
-                <a:latin typeface="Aptos"/>
-              </a:defRPr>
-            </a:pPr>
-            <a:r>
-              <a:t>verifies</a:t>
+                <a:latin typeface="Apple SD Gothic Neo"/>
+              </a:defRPr>
+            </a:pPr>
+            <a:r>
+              <a:t>검증</a:t>
             </a:r>
           </a:p>
         </p:txBody>
@@ -4450,11 +4450,11 @@
                 <a:solidFill>
                   <a:srgbClr val="1B1F2A"/>
                 </a:solidFill>
-                <a:latin typeface="Aptos"/>
-              </a:defRPr>
-            </a:pPr>
-            <a:r>
-              <a:t>Metadata checks</a:t>
+                <a:latin typeface="Apple SD Gothic Neo"/>
+              </a:defRPr>
+            </a:pPr>
+            <a:r>
+              <a:t>metadata check가</a:t>
             </a:r>
           </a:p>
           <a:p>
@@ -4463,11 +4463,11 @@
                 <a:solidFill>
                   <a:srgbClr val="1B1F2A"/>
                 </a:solidFill>
-                <a:latin typeface="Aptos"/>
-              </a:defRPr>
-            </a:pPr>
-            <a:r>
-              <a:t>decode public inputs</a:t>
+                <a:latin typeface="Apple SD Gothic Neo"/>
+              </a:defRPr>
+            </a:pPr>
+            <a:r>
+              <a:t>public input 해석</a:t>
             </a:r>
           </a:p>
         </p:txBody>
@@ -4579,7 +4579,7 @@
                 <a:solidFill>
                   <a:srgbClr val="1B1F2A"/>
                 </a:solidFill>
-                <a:latin typeface="Aptos"/>
+                <a:latin typeface="Apple SD Gothic Neo"/>
               </a:defRPr>
             </a:pPr>
             <a:r>
@@ -4592,11 +4592,11 @@
                 <a:solidFill>
                   <a:srgbClr val="1B1F2A"/>
                 </a:solidFill>
-                <a:latin typeface="Aptos"/>
-              </a:defRPr>
-            </a:pPr>
-            <a:r>
-              <a:t>advances</a:t>
+                <a:latin typeface="Apple SD Gothic Neo"/>
+              </a:defRPr>
+            </a:pPr>
+            <a:r>
+              <a:t>갱신</a:t>
             </a:r>
           </a:p>
         </p:txBody>
@@ -4708,11 +4708,11 @@
                 <a:solidFill>
                   <a:srgbClr val="1B1F2A"/>
                 </a:solidFill>
-                <a:latin typeface="Aptos"/>
-              </a:defRPr>
-            </a:pPr>
-            <a:r>
-              <a:t>Observed writes</a:t>
+                <a:latin typeface="Apple SD Gothic Neo"/>
+              </a:defRPr>
+            </a:pPr>
+            <a:r>
+              <a:t>observed write</a:t>
             </a:r>
           </a:p>
           <a:p>
@@ -4721,11 +4721,11 @@
                 <a:solidFill>
                   <a:srgbClr val="1B1F2A"/>
                 </a:solidFill>
-                <a:latin typeface="Aptos"/>
-              </a:defRPr>
-            </a:pPr>
-            <a:r>
-              <a:t>are emitted</a:t>
+                <a:latin typeface="Apple SD Gothic Neo"/>
+              </a:defRPr>
+            </a:pPr>
+            <a:r>
+              <a:t>이벤트 방출</a:t>
             </a:r>
           </a:p>
         </p:txBody>
@@ -4800,11 +4800,11 @@
                 <a:solidFill>
                   <a:srgbClr val="A9B7D0"/>
                 </a:solidFill>
-                <a:latin typeface="Aptos"/>
-              </a:defRPr>
-            </a:pPr>
-            <a:r>
-              <a:t>current state</a:t>
+                <a:latin typeface="Apple SD Gothic Neo"/>
+              </a:defRPr>
+            </a:pPr>
+            <a:r>
+              <a:t>현재 상태</a:t>
             </a:r>
           </a:p>
         </p:txBody>
@@ -4836,7 +4836,7 @@
                 <a:solidFill>
                   <a:srgbClr val="FFFFFF"/>
                 </a:solidFill>
-                <a:latin typeface="Aptos"/>
+                <a:latin typeface="Apple SD Gothic Neo"/>
               </a:defRPr>
             </a:pPr>
             <a:r>
@@ -4872,11 +4872,11 @@
                 <a:solidFill>
                   <a:srgbClr val="A9B7D0"/>
                 </a:solidFill>
-                <a:latin typeface="Aptos"/>
-              </a:defRPr>
-            </a:pPr>
-            <a:r>
-              <a:t>proof claim</a:t>
+                <a:latin typeface="Apple SD Gothic Neo"/>
+              </a:defRPr>
+            </a:pPr>
+            <a:r>
+              <a:t>증명 주장</a:t>
             </a:r>
           </a:p>
         </p:txBody>
@@ -4908,7 +4908,7 @@
                 <a:solidFill>
                   <a:srgbClr val="FFFFFF"/>
                 </a:solidFill>
-                <a:latin typeface="Aptos"/>
+                <a:latin typeface="Apple SD Gothic Neo"/>
               </a:defRPr>
             </a:pPr>
             <a:r>
@@ -4987,11 +4987,11 @@
                 <a:solidFill>
                   <a:srgbClr val="A9B7D0"/>
                 </a:solidFill>
-                <a:latin typeface="Aptos"/>
-              </a:defRPr>
-            </a:pPr>
-            <a:r>
-              <a:t>next state</a:t>
+                <a:latin typeface="Apple SD Gothic Neo"/>
+              </a:defRPr>
+            </a:pPr>
+            <a:r>
+              <a:t>다음 상태</a:t>
             </a:r>
           </a:p>
         </p:txBody>
@@ -5023,7 +5023,7 @@
                 <a:solidFill>
                   <a:srgbClr val="FFFFFF"/>
                 </a:solidFill>
-                <a:latin typeface="Aptos"/>
+                <a:latin typeface="Apple SD Gothic Neo"/>
               </a:defRPr>
             </a:pPr>
             <a:r>
@@ -5171,11 +5171,11 @@
                 <a:solidFill>
                   <a:srgbClr val="2563EB"/>
                 </a:solidFill>
-                <a:latin typeface="Aptos"/>
-              </a:defRPr>
-            </a:pPr>
-            <a:r>
-              <a:t>TOKEN MOVEMENT</a:t>
+                <a:latin typeface="Apple SD Gothic Neo"/>
+              </a:defRPr>
+            </a:pPr>
+            <a:r>
+              <a:t>토큰 이동</a:t>
             </a:r>
           </a:p>
         </p:txBody>
@@ -5207,11 +5207,11 @@
                 <a:solidFill>
                   <a:srgbClr val="101828"/>
                 </a:solidFill>
-                <a:latin typeface="Aptos Display"/>
-              </a:defRPr>
-            </a:pPr>
-            <a:r>
-              <a:t>Custody and Accounting Are Deliberately Split</a:t>
+                <a:latin typeface="Apple SD Gothic Neo"/>
+              </a:defRPr>
+            </a:pPr>
+            <a:r>
+              <a:t>Custody와 Accounting은 의도적으로 분리된다</a:t>
             </a:r>
           </a:p>
         </p:txBody>
@@ -5243,11 +5243,11 @@
                 <a:solidFill>
                   <a:srgbClr val="5C667A"/>
                 </a:solidFill>
-                <a:latin typeface="Aptos"/>
-              </a:defRPr>
-            </a:pPr>
-            <a:r>
-              <a:t>Canonical tokens remain in the shared L1 vault; channel state records accounting and notes.</a:t>
+                <a:latin typeface="Apple SD Gothic Neo"/>
+              </a:defRPr>
+            </a:pPr>
+            <a:r>
+              <a:t>canonical token은 공유 L1 vault에 남고, 채널 상태는 accounting과 note를 기록한다.</a:t>
             </a:r>
           </a:p>
         </p:txBody>
@@ -5322,7 +5322,7 @@
                 <a:solidFill>
                   <a:srgbClr val="5C667A"/>
                 </a:solidFill>
-                <a:latin typeface="Aptos"/>
+                <a:latin typeface="Apple SD Gothic Neo"/>
               </a:defRPr>
             </a:pPr>
             <a:r>
@@ -5358,7 +5358,7 @@
                 <a:solidFill>
                   <a:srgbClr val="5C667A"/>
                 </a:solidFill>
-                <a:latin typeface="Aptos"/>
+                <a:latin typeface="Apple SD Gothic Neo"/>
               </a:defRPr>
             </a:pPr>
             <a:r>
@@ -5439,7 +5439,7 @@
                 <a:solidFill>
                   <a:srgbClr val="1B1F2A"/>
                 </a:solidFill>
-                <a:latin typeface="Aptos"/>
+                <a:latin typeface="Apple SD Gothic Neo"/>
               </a:defRPr>
             </a:pPr>
             <a:r>
@@ -5520,7 +5520,7 @@
                 <a:solidFill>
                   <a:srgbClr val="1B1F2A"/>
                 </a:solidFill>
-                <a:latin typeface="Aptos"/>
+                <a:latin typeface="Apple SD Gothic Neo"/>
               </a:defRPr>
             </a:pPr>
             <a:r>
@@ -5533,7 +5533,7 @@
                 <a:solidFill>
                   <a:srgbClr val="1B1F2A"/>
                 </a:solidFill>
-                <a:latin typeface="Aptos"/>
+                <a:latin typeface="Apple SD Gothic Neo"/>
               </a:defRPr>
             </a:pPr>
             <a:r>
@@ -5614,7 +5614,7 @@
                 <a:solidFill>
                   <a:srgbClr val="1B1F2A"/>
                 </a:solidFill>
-                <a:latin typeface="Aptos"/>
+                <a:latin typeface="Apple SD Gothic Neo"/>
               </a:defRPr>
             </a:pPr>
             <a:r>
@@ -5627,7 +5627,7 @@
                 <a:solidFill>
                   <a:srgbClr val="1B1F2A"/>
                 </a:solidFill>
-                <a:latin typeface="Aptos"/>
+                <a:latin typeface="Apple SD Gothic Neo"/>
               </a:defRPr>
             </a:pPr>
             <a:r>
@@ -5708,7 +5708,7 @@
                 <a:solidFill>
                   <a:srgbClr val="1B1F2A"/>
                 </a:solidFill>
-                <a:latin typeface="Aptos"/>
+                <a:latin typeface="Apple SD Gothic Neo"/>
               </a:defRPr>
             </a:pPr>
             <a:r>
@@ -5721,7 +5721,7 @@
                 <a:solidFill>
                   <a:srgbClr val="1B1F2A"/>
                 </a:solidFill>
-                <a:latin typeface="Aptos"/>
+                <a:latin typeface="Apple SD Gothic Neo"/>
               </a:defRPr>
             </a:pPr>
             <a:r>
@@ -5858,15 +5858,51 @@
           <a:lstStyle/>
           <a:p>
             <a:pPr algn="ctr">
-              <a:defRPr sz="1500" b="0">
+              <a:defRPr sz="1400" b="0">
                 <a:solidFill>
                   <a:srgbClr val="5C667A"/>
                 </a:solidFill>
-                <a:latin typeface="Aptos"/>
-              </a:defRPr>
-            </a:pPr>
-            <a:r>
-              <a:t>Deposit / withdraw accounting uses Groth16 updateTree proofs. Rich DApp execution uses Tokamak proofs over registered metadata.</a:t>
+                <a:latin typeface="Apple SD Gothic Neo"/>
+              </a:defRPr>
+            </a:pPr>
+            <a:r>
+              <a:t>fund/claim은 bridge-level available balance를 움직이고, deposit/withdraw channel은 Groth16 updateTree proof로 channel-token-vault root를 갱신한다.</a:t>
+            </a:r>
+          </a:p>
+        </p:txBody>
+      </p:sp>
+      <p:sp>
+        <p:nvSpPr>
+          <p:cNvPr id="21" name="TextBox 20"/>
+          <p:cNvSpPr txBox="1"/>
+          <p:nvPr/>
+        </p:nvSpPr>
+        <p:spPr>
+          <a:xfrm>
+            <a:off x="1572768" y="4983480"/>
+            <a:ext cx="9052560" cy="329184"/>
+          </a:xfrm>
+          <a:prstGeom prst="rect">
+            <a:avLst/>
+          </a:prstGeom>
+          <a:noFill/>
+        </p:spPr>
+        <p:txBody>
+          <a:bodyPr wrap="square" lIns="18288" rIns="18288" tIns="9144" bIns="9144" anchor="ctr">
+            <a:spAutoFit/>
+          </a:bodyPr>
+          <a:lstStyle/>
+          <a:p>
+            <a:pPr algn="ctr">
+              <a:defRPr sz="1300" b="0">
+                <a:solidFill>
+                  <a:srgbClr val="5C667A"/>
+                </a:solidFill>
+                <a:latin typeface="Apple SD Gothic Neo"/>
+              </a:defRPr>
+            </a:pPr>
+            <a:r>
+              <a:t>join toll은 별도 treasury에 기록되며, exit refund는 시간 감쇠 스케줄과 zero channel balance 조건을 따른다.</a:t>
             </a:r>
           </a:p>
         </p:txBody>
@@ -5967,11 +6003,11 @@
                 <a:solidFill>
                   <a:srgbClr val="2563EB"/>
                 </a:solidFill>
-                <a:latin typeface="Aptos"/>
-              </a:defRPr>
-            </a:pPr>
-            <a:r>
-              <a:t>PRIVATE-STATE EXAMPLE</a:t>
+                <a:latin typeface="Apple SD Gothic Neo"/>
+              </a:defRPr>
+            </a:pPr>
+            <a:r>
+              <a:t>PRIVATE-STATE 예제</a:t>
             </a:r>
           </a:p>
         </p:txBody>
@@ -6003,11 +6039,11 @@
                 <a:solidFill>
                   <a:srgbClr val="101828"/>
                 </a:solidFill>
-                <a:latin typeface="Aptos Display"/>
-              </a:defRPr>
-            </a:pPr>
-            <a:r>
-              <a:t>A Bridge-Coupled zk-Note Payment DApp</a:t>
+                <a:latin typeface="Apple SD Gothic Neo"/>
+              </a:defRPr>
+            </a:pPr>
+            <a:r>
+              <a:t>Bridge-Coupled zk-Note Payment DApp</a:t>
             </a:r>
           </a:p>
         </p:txBody>
@@ -6039,11 +6075,11 @@
                 <a:solidFill>
                   <a:srgbClr val="5C667A"/>
                 </a:solidFill>
-                <a:latin typeface="Aptos"/>
-              </a:defRPr>
-            </a:pPr>
-            <a:r>
-              <a:t>Private-state keeps TON custody on L1 while channel-local state records balances, commitments, and nullifiers.</a:t>
+                <a:latin typeface="Apple SD Gothic Neo"/>
+              </a:defRPr>
+            </a:pPr>
+            <a:r>
+              <a:t>private-state는 TON custody를 L1에 유지하면서 채널 로컬 상태에 balances, commitments, nullifiers를 기록한다.</a:t>
             </a:r>
           </a:p>
         </p:txBody>
@@ -6118,7 +6154,7 @@
                 <a:solidFill>
                   <a:srgbClr val="5C667A"/>
                 </a:solidFill>
-                <a:latin typeface="Aptos"/>
+                <a:latin typeface="Apple SD Gothic Neo"/>
               </a:defRPr>
             </a:pPr>
             <a:r>
@@ -6154,7 +6190,7 @@
                 <a:solidFill>
                   <a:srgbClr val="5C667A"/>
                 </a:solidFill>
-                <a:latin typeface="Aptos"/>
+                <a:latin typeface="Apple SD Gothic Neo"/>
               </a:defRPr>
             </a:pPr>
             <a:r>
@@ -6278,7 +6314,7 @@
                 <a:solidFill>
                   <a:srgbClr val="1B1F2A"/>
                 </a:solidFill>
-                <a:latin typeface="Aptos Display"/>
+                <a:latin typeface="Apple SD Gothic Neo"/>
               </a:defRPr>
             </a:pPr>
             <a:r>
@@ -6314,11 +6350,11 @@
                 <a:solidFill>
                   <a:srgbClr val="5C667A"/>
                 </a:solidFill>
-                <a:latin typeface="Aptos"/>
-              </a:defRPr>
-            </a:pPr>
-            <a:r>
-              <a:t>Accounting-only liquid balances. The controller mutates balances; the vault is not canonical custody.</a:t>
+                <a:latin typeface="Apple SD Gothic Neo"/>
+              </a:defRPr>
+            </a:pPr>
+            <a:r>
+              <a:t>accounting-only liquid balance를 추적한다. controller만 balance를 변경하며 canonical custody는 아니다.</a:t>
             </a:r>
           </a:p>
         </p:txBody>
@@ -6438,7 +6474,7 @@
                 <a:solidFill>
                   <a:srgbClr val="1B1F2A"/>
                 </a:solidFill>
-                <a:latin typeface="Aptos Display"/>
+                <a:latin typeface="Apple SD Gothic Neo"/>
               </a:defRPr>
             </a:pPr>
             <a:r>
@@ -6474,11 +6510,11 @@
                 <a:solidFill>
                   <a:srgbClr val="5C667A"/>
                 </a:solidFill>
-                <a:latin typeface="Aptos"/>
-              </a:defRPr>
-            </a:pPr>
-            <a:r>
-              <a:t>User-facing note lifecycle: mint from liquid balance, transfer notes, redeem notes back to liquid balance.</a:t>
+                <a:latin typeface="Apple SD Gothic Neo"/>
+              </a:defRPr>
+            </a:pPr>
+            <a:r>
+              <a:t>mint, transfer, redeem으로 note lifecycle을 제공한다. commitment 중복과 nullifier 재사용을 거부한다.</a:t>
             </a:r>
           </a:p>
         </p:txBody>
@@ -6545,7 +6581,7 @@
                 <a:solidFill>
                   <a:srgbClr val="2563EB"/>
                 </a:solidFill>
-                <a:latin typeface="Aptos"/>
+                <a:latin typeface="Apple SD Gothic Neo"/>
               </a:defRPr>
             </a:pPr>
             <a:r>
@@ -6650,7 +6686,7 @@
                 <a:solidFill>
                   <a:srgbClr val="2563EB"/>
                 </a:solidFill>
-                <a:latin typeface="Aptos"/>
+                <a:latin typeface="Apple SD Gothic Neo"/>
               </a:defRPr>
             </a:pPr>
             <a:r>
@@ -6668,7 +6704,7 @@
         <p:spPr>
           <a:xfrm>
             <a:off x="530352" y="804672"/>
-            <a:ext cx="8046720" cy="932688"/>
+            <a:ext cx="8046720" cy="640080"/>
           </a:xfrm>
           <a:prstGeom prst="rect">
             <a:avLst/>
@@ -6682,15 +6718,15 @@
           <a:lstStyle/>
           <a:p>
             <a:pPr>
-              <a:defRPr sz="2800" b="1">
+              <a:defRPr sz="3400" b="1">
                 <a:solidFill>
                   <a:srgbClr val="101828"/>
                 </a:solidFill>
-                <a:latin typeface="Aptos Display"/>
-              </a:defRPr>
-            </a:pPr>
-            <a:r>
-              <a:t>Value Moves Through Three Representations</a:t>
+                <a:latin typeface="Apple SD Gothic Neo"/>
+              </a:defRPr>
+            </a:pPr>
+            <a:r>
+              <a:t>가치는 세 가지 표현을 거쳐 이동한다</a:t>
             </a:r>
           </a:p>
         </p:txBody>
@@ -6703,7 +6739,7 @@
         </p:nvSpPr>
         <p:spPr>
           <a:xfrm>
-            <a:off x="548640" y="1719072"/>
+            <a:off x="548640" y="1444752"/>
             <a:ext cx="7863840" cy="438912"/>
           </a:xfrm>
           <a:prstGeom prst="rect">
@@ -6722,11 +6758,11 @@
                 <a:solidFill>
                   <a:srgbClr val="5C667A"/>
                 </a:solidFill>
-                <a:latin typeface="Aptos"/>
-              </a:defRPr>
-            </a:pPr>
-            <a:r>
-              <a:t>Bridge liquidity, L2 accounting, and private notes are separate protocol objects.</a:t>
+                <a:latin typeface="Apple SD Gothic Neo"/>
+              </a:defRPr>
+            </a:pPr>
+            <a:r>
+              <a:t>bridge liquidity, L2 accounting, private note는 서로 다른 protocol object다.</a:t>
             </a:r>
           </a:p>
         </p:txBody>
@@ -6801,7 +6837,7 @@
                 <a:solidFill>
                   <a:srgbClr val="5C667A"/>
                 </a:solidFill>
-                <a:latin typeface="Aptos"/>
+                <a:latin typeface="Apple SD Gothic Neo"/>
               </a:defRPr>
             </a:pPr>
             <a:r>
@@ -6837,7 +6873,7 @@
                 <a:solidFill>
                   <a:srgbClr val="5C667A"/>
                 </a:solidFill>
-                <a:latin typeface="Aptos"/>
+                <a:latin typeface="Apple SD Gothic Neo"/>
               </a:defRPr>
             </a:pPr>
             <a:r>
@@ -6918,11 +6954,11 @@
                 <a:solidFill>
                   <a:srgbClr val="1B1F2A"/>
                 </a:solidFill>
-                <a:latin typeface="Aptos"/>
-              </a:defRPr>
-            </a:pPr>
-            <a:r>
-              <a:t>deposit bridge</a:t>
+                <a:latin typeface="Apple SD Gothic Neo"/>
+              </a:defRPr>
+            </a:pPr>
+            <a:r>
+              <a:t>브릿지 입금</a:t>
             </a:r>
           </a:p>
         </p:txBody>
@@ -7034,11 +7070,11 @@
                 <a:solidFill>
                   <a:srgbClr val="1B1F2A"/>
                 </a:solidFill>
-                <a:latin typeface="Aptos"/>
-              </a:defRPr>
-            </a:pPr>
-            <a:r>
-              <a:t>deposit channel</a:t>
+                <a:latin typeface="Apple SD Gothic Neo"/>
+              </a:defRPr>
+            </a:pPr>
+            <a:r>
+              <a:t>채널 입금</a:t>
             </a:r>
           </a:p>
         </p:txBody>
@@ -7150,11 +7186,11 @@
                 <a:solidFill>
                   <a:srgbClr val="1B1F2A"/>
                 </a:solidFill>
-                <a:latin typeface="Aptos"/>
-              </a:defRPr>
-            </a:pPr>
-            <a:r>
-              <a:t>mint notes</a:t>
+                <a:latin typeface="Apple SD Gothic Neo"/>
+              </a:defRPr>
+            </a:pPr>
+            <a:r>
+              <a:t>note mint</a:t>
             </a:r>
           </a:p>
         </p:txBody>
@@ -7266,11 +7302,11 @@
                 <a:solidFill>
                   <a:srgbClr val="1B1F2A"/>
                 </a:solidFill>
-                <a:latin typeface="Aptos"/>
-              </a:defRPr>
-            </a:pPr>
-            <a:r>
-              <a:t>transfer notes</a:t>
+                <a:latin typeface="Apple SD Gothic Neo"/>
+              </a:defRPr>
+            </a:pPr>
+            <a:r>
+              <a:t>note transfer</a:t>
             </a:r>
           </a:p>
         </p:txBody>
@@ -7382,11 +7418,11 @@
                 <a:solidFill>
                   <a:srgbClr val="1B1F2A"/>
                 </a:solidFill>
-                <a:latin typeface="Aptos"/>
-              </a:defRPr>
-            </a:pPr>
-            <a:r>
-              <a:t>redeem notes</a:t>
+                <a:latin typeface="Apple SD Gothic Neo"/>
+              </a:defRPr>
+            </a:pPr>
+            <a:r>
+              <a:t>note redeem</a:t>
             </a:r>
           </a:p>
         </p:txBody>
@@ -7498,11 +7534,11 @@
                 <a:solidFill>
                   <a:srgbClr val="1B1F2A"/>
                 </a:solidFill>
-                <a:latin typeface="Aptos"/>
-              </a:defRPr>
-            </a:pPr>
-            <a:r>
-              <a:t>withdraw channel</a:t>
+                <a:latin typeface="Apple SD Gothic Neo"/>
+              </a:defRPr>
+            </a:pPr>
+            <a:r>
+              <a:t>채널 출금</a:t>
             </a:r>
           </a:p>
         </p:txBody>
@@ -7614,11 +7650,11 @@
                 <a:solidFill>
                   <a:srgbClr val="1B1F2A"/>
                 </a:solidFill>
-                <a:latin typeface="Aptos"/>
-              </a:defRPr>
-            </a:pPr>
-            <a:r>
-              <a:t>withdraw bridge</a:t>
+                <a:latin typeface="Apple SD Gothic Neo"/>
+              </a:defRPr>
+            </a:pPr>
+            <a:r>
+              <a:t>브릿지 출금</a:t>
             </a:r>
           </a:p>
         </p:txBody>
@@ -7695,7 +7731,7 @@
                 <a:solidFill>
                   <a:srgbClr val="1B1F2A"/>
                 </a:solidFill>
-                <a:latin typeface="Aptos"/>
+                <a:latin typeface="Apple SD Gothic Neo"/>
               </a:defRPr>
             </a:pPr>
             <a:r>
@@ -7776,7 +7812,7 @@
                 <a:solidFill>
                   <a:srgbClr val="1B1F2A"/>
                 </a:solidFill>
-                <a:latin typeface="Aptos"/>
+                <a:latin typeface="Apple SD Gothic Neo"/>
               </a:defRPr>
             </a:pPr>
             <a:r>
@@ -7857,7 +7893,7 @@
                 <a:solidFill>
                   <a:srgbClr val="1B1F2A"/>
                 </a:solidFill>
-                <a:latin typeface="Aptos"/>
+                <a:latin typeface="Apple SD Gothic Neo"/>
               </a:defRPr>
             </a:pPr>
             <a:r>
@@ -7962,11 +7998,11 @@
                 <a:solidFill>
                   <a:srgbClr val="2563EB"/>
                 </a:solidFill>
-                <a:latin typeface="Aptos"/>
-              </a:defRPr>
-            </a:pPr>
-            <a:r>
-              <a:t>PRIVACY BOUNDARY</a:t>
+                <a:latin typeface="Apple SD Gothic Neo"/>
+              </a:defRPr>
+            </a:pPr>
+            <a:r>
+              <a:t>프라이버시 경계</a:t>
             </a:r>
           </a:p>
         </p:txBody>
@@ -7998,11 +8034,11 @@
                 <a:solidFill>
                   <a:srgbClr val="101828"/>
                 </a:solidFill>
-                <a:latin typeface="Aptos Display"/>
-              </a:defRPr>
-            </a:pPr>
-            <a:r>
-              <a:t>Programmed Disclosure, Not Invisible Activity</a:t>
+                <a:latin typeface="Apple SD Gothic Neo"/>
+              </a:defRPr>
+            </a:pPr>
+            <a:r>
+              <a:t>Programmed Disclosure이지 Invisible Activity가 아니다</a:t>
             </a:r>
           </a:p>
         </p:txBody>
@@ -8034,11 +8070,11 @@
                 <a:solidFill>
                   <a:srgbClr val="5C667A"/>
                 </a:solidFill>
-                <a:latin typeface="Aptos"/>
-              </a:defRPr>
-            </a:pPr>
-            <a:r>
-              <a:t>The DApp decides which public observations exist after proof acceptance.</a:t>
+                <a:latin typeface="Apple SD Gothic Neo"/>
+              </a:defRPr>
+            </a:pPr>
+            <a:r>
+              <a:t>proof acceptance 이후 어떤 public observation을 남길지는 DApp 설계가 결정한다.</a:t>
             </a:r>
           </a:p>
         </p:txBody>
@@ -8113,7 +8149,7 @@
                 <a:solidFill>
                   <a:srgbClr val="5C667A"/>
                 </a:solidFill>
-                <a:latin typeface="Aptos"/>
+                <a:latin typeface="Apple SD Gothic Neo"/>
               </a:defRPr>
             </a:pPr>
             <a:r>
@@ -8149,7 +8185,7 @@
                 <a:solidFill>
                   <a:srgbClr val="5C667A"/>
                 </a:solidFill>
-                <a:latin typeface="Aptos"/>
+                <a:latin typeface="Apple SD Gothic Neo"/>
               </a:defRPr>
             </a:pPr>
             <a:r>
@@ -8230,11 +8266,11 @@
                 <a:solidFill>
                   <a:srgbClr val="21A67A"/>
                 </a:solidFill>
-                <a:latin typeface="Aptos Display"/>
-              </a:defRPr>
-            </a:pPr>
-            <a:r>
-              <a:t>Hidden from public contract state</a:t>
+                <a:latin typeface="Apple SD Gothic Neo"/>
+              </a:defRPr>
+            </a:pPr>
+            <a:r>
+              <a:t>Public contract state에서 숨겨지는 것</a:t>
             </a:r>
           </a:p>
         </p:txBody>
@@ -8309,7 +8345,7 @@
                 <a:solidFill>
                   <a:srgbClr val="1B1F2A"/>
                 </a:solidFill>
-                <a:latin typeface="Aptos"/>
+                <a:latin typeface="Apple SD Gothic Neo"/>
               </a:defRPr>
             </a:pPr>
             <a:r>
@@ -8388,7 +8424,7 @@
                 <a:solidFill>
                   <a:srgbClr val="1B1F2A"/>
                 </a:solidFill>
-                <a:latin typeface="Aptos"/>
+                <a:latin typeface="Apple SD Gothic Neo"/>
               </a:defRPr>
             </a:pPr>
             <a:r>
@@ -8467,7 +8503,7 @@
                 <a:solidFill>
                   <a:srgbClr val="1B1F2A"/>
                 </a:solidFill>
-                <a:latin typeface="Aptos"/>
+                <a:latin typeface="Apple SD Gothic Neo"/>
               </a:defRPr>
             </a:pPr>
             <a:r>
@@ -8546,7 +8582,7 @@
                 <a:solidFill>
                   <a:srgbClr val="1B1F2A"/>
                 </a:solidFill>
-                <a:latin typeface="Aptos"/>
+                <a:latin typeface="Apple SD Gothic Neo"/>
               </a:defRPr>
             </a:pPr>
             <a:r>
@@ -8627,11 +8663,11 @@
                 <a:solidFill>
                   <a:srgbClr val="F59E0B"/>
                 </a:solidFill>
-                <a:latin typeface="Aptos Display"/>
-              </a:defRPr>
-            </a:pPr>
-            <a:r>
-              <a:t>Visible monitoring surface</a:t>
+                <a:latin typeface="Apple SD Gothic Neo"/>
+              </a:defRPr>
+            </a:pPr>
+            <a:r>
+              <a:t>보이는 monitoring surface</a:t>
             </a:r>
           </a:p>
         </p:txBody>
@@ -8644,7 +8680,7 @@
         </p:nvSpPr>
         <p:spPr>
           <a:xfrm>
-            <a:off x="6931152" y="3163824"/>
+            <a:off x="6931152" y="3127248"/>
             <a:ext cx="73152" cy="73152"/>
           </a:xfrm>
           <a:prstGeom prst="ellipse">
@@ -8687,8 +8723,8 @@
         </p:nvSpPr>
         <p:spPr>
           <a:xfrm>
-            <a:off x="7095744" y="3090672"/>
-            <a:ext cx="3493008" cy="384048"/>
+            <a:off x="7095744" y="3054096"/>
+            <a:ext cx="3493008" cy="320040"/>
           </a:xfrm>
           <a:prstGeom prst="rect">
             <a:avLst/>
@@ -8702,11 +8738,11 @@
           <a:lstStyle/>
           <a:p>
             <a:pPr>
-              <a:defRPr sz="1600" b="0">
+              <a:defRPr sz="1500" b="0">
                 <a:solidFill>
                   <a:srgbClr val="1B1F2A"/>
                 </a:solidFill>
-                <a:latin typeface="Aptos"/>
+                <a:latin typeface="Apple SD Gothic Neo"/>
               </a:defRPr>
             </a:pPr>
             <a:r>
@@ -8723,7 +8759,7 @@
         </p:nvSpPr>
         <p:spPr>
           <a:xfrm>
-            <a:off x="6931152" y="3575304"/>
+            <a:off x="6931152" y="3474720"/>
             <a:ext cx="73152" cy="73152"/>
           </a:xfrm>
           <a:prstGeom prst="ellipse">
@@ -8766,8 +8802,8 @@
         </p:nvSpPr>
         <p:spPr>
           <a:xfrm>
-            <a:off x="7095744" y="3502152"/>
-            <a:ext cx="3493008" cy="384048"/>
+            <a:off x="7095744" y="3401568"/>
+            <a:ext cx="3493008" cy="320040"/>
           </a:xfrm>
           <a:prstGeom prst="rect">
             <a:avLst/>
@@ -8781,11 +8817,11 @@
           <a:lstStyle/>
           <a:p>
             <a:pPr>
-              <a:defRPr sz="1600" b="0">
+              <a:defRPr sz="1500" b="0">
                 <a:solidFill>
                   <a:srgbClr val="1B1F2A"/>
                 </a:solidFill>
-                <a:latin typeface="Aptos"/>
+                <a:latin typeface="Apple SD Gothic Neo"/>
               </a:defRPr>
             </a:pPr>
             <a:r>
@@ -8802,7 +8838,7 @@
         </p:nvSpPr>
         <p:spPr>
           <a:xfrm>
-            <a:off x="6931152" y="3986784"/>
+            <a:off x="6931152" y="3822191"/>
             <a:ext cx="73152" cy="73152"/>
           </a:xfrm>
           <a:prstGeom prst="ellipse">
@@ -8845,8 +8881,8 @@
         </p:nvSpPr>
         <p:spPr>
           <a:xfrm>
-            <a:off x="7095744" y="3913632"/>
-            <a:ext cx="3493008" cy="384048"/>
+            <a:off x="7095744" y="3749039"/>
+            <a:ext cx="3493008" cy="320040"/>
           </a:xfrm>
           <a:prstGeom prst="rect">
             <a:avLst/>
@@ -8860,15 +8896,15 @@
           <a:lstStyle/>
           <a:p>
             <a:pPr>
-              <a:defRPr sz="1600" b="0">
+              <a:defRPr sz="1500" b="0">
                 <a:solidFill>
                   <a:srgbClr val="1B1F2A"/>
                 </a:solidFill>
-                <a:latin typeface="Aptos"/>
-              </a:defRPr>
-            </a:pPr>
-            <a:r>
-              <a:t>commitments and nullifiers</a:t>
+                <a:latin typeface="Apple SD Gothic Neo"/>
+              </a:defRPr>
+            </a:pPr>
+            <a:r>
+              <a:t>root movement와 storage writes</a:t>
             </a:r>
           </a:p>
         </p:txBody>
@@ -8881,7 +8917,7 @@
         </p:nvSpPr>
         <p:spPr>
           <a:xfrm>
-            <a:off x="6931152" y="4398264"/>
+            <a:off x="6931152" y="4169664"/>
             <a:ext cx="73152" cy="73152"/>
           </a:xfrm>
           <a:prstGeom prst="ellipse">
@@ -8924,8 +8960,8 @@
         </p:nvSpPr>
         <p:spPr>
           <a:xfrm>
-            <a:off x="7095744" y="4325112"/>
-            <a:ext cx="3493008" cy="384048"/>
+            <a:off x="7095744" y="4096512"/>
+            <a:ext cx="3493008" cy="320040"/>
           </a:xfrm>
           <a:prstGeom prst="rect">
             <a:avLst/>
@@ -8939,11 +8975,90 @@
           <a:lstStyle/>
           <a:p>
             <a:pPr>
-              <a:defRPr sz="1600" b="0">
+              <a:defRPr sz="1500" b="0">
                 <a:solidFill>
                   <a:srgbClr val="1B1F2A"/>
                 </a:solidFill>
-                <a:latin typeface="Aptos"/>
+                <a:latin typeface="Apple SD Gothic Neo"/>
+              </a:defRPr>
+            </a:pPr>
+            <a:r>
+              <a:t>commitments와 nullifiers</a:t>
+            </a:r>
+          </a:p>
+        </p:txBody>
+      </p:sp>
+      <p:sp>
+        <p:nvSpPr>
+          <p:cNvPr id="29" name="Oval 28"/>
+          <p:cNvSpPr/>
+          <p:nvPr/>
+        </p:nvSpPr>
+        <p:spPr>
+          <a:xfrm>
+            <a:off x="6931152" y="4517136"/>
+            <a:ext cx="73152" cy="73152"/>
+          </a:xfrm>
+          <a:prstGeom prst="ellipse">
+            <a:avLst/>
+          </a:prstGeom>
+          <a:solidFill>
+            <a:srgbClr val="F59E0B"/>
+          </a:solidFill>
+          <a:ln>
+            <a:noFill/>
+          </a:ln>
+        </p:spPr>
+        <p:style>
+          <a:lnRef idx="1">
+            <a:schemeClr val="accent1"/>
+          </a:lnRef>
+          <a:fillRef idx="3">
+            <a:schemeClr val="accent1"/>
+          </a:fillRef>
+          <a:effectRef idx="2">
+            <a:schemeClr val="accent1"/>
+          </a:effectRef>
+          <a:fontRef idx="minor">
+            <a:schemeClr val="lt1"/>
+          </a:fontRef>
+        </p:style>
+        <p:txBody>
+          <a:bodyPr rtlCol="0" anchor="ctr"/>
+          <a:lstStyle/>
+          <a:p>
+            <a:pPr algn="ctr"/>
+          </a:p>
+        </p:txBody>
+      </p:sp>
+      <p:sp>
+        <p:nvSpPr>
+          <p:cNvPr id="30" name="TextBox 29"/>
+          <p:cNvSpPr txBox="1"/>
+          <p:nvPr/>
+        </p:nvSpPr>
+        <p:spPr>
+          <a:xfrm>
+            <a:off x="7095744" y="4443983"/>
+            <a:ext cx="3493008" cy="320040"/>
+          </a:xfrm>
+          <a:prstGeom prst="rect">
+            <a:avLst/>
+          </a:prstGeom>
+          <a:noFill/>
+        </p:spPr>
+        <p:txBody>
+          <a:bodyPr wrap="square" lIns="18288" rIns="18288" tIns="9144" bIns="9144" anchor="t">
+            <a:spAutoFit/>
+          </a:bodyPr>
+          <a:lstStyle/>
+          <a:p>
+            <a:pPr>
+              <a:defRPr sz="1500" b="0">
+                <a:solidFill>
+                  <a:srgbClr val="1B1F2A"/>
+                </a:solidFill>
+                <a:latin typeface="Apple SD Gothic Neo"/>
               </a:defRPr>
             </a:pPr>
             <a:r>
@@ -9048,7 +9163,7 @@
                 <a:solidFill>
                   <a:srgbClr val="2563EB"/>
                 </a:solidFill>
-                <a:latin typeface="Aptos"/>
+                <a:latin typeface="Apple SD Gothic Neo"/>
               </a:defRPr>
             </a:pPr>
             <a:r>
@@ -9066,7 +9181,7 @@
         <p:spPr>
           <a:xfrm>
             <a:off x="530352" y="804672"/>
-            <a:ext cx="8046720" cy="932688"/>
+            <a:ext cx="8046720" cy="640080"/>
           </a:xfrm>
           <a:prstGeom prst="rect">
             <a:avLst/>
@@ -9080,15 +9195,15 @@
           <a:lstStyle/>
           <a:p>
             <a:pPr>
-              <a:defRPr sz="2800" b="1">
+              <a:defRPr sz="3400" b="1">
                 <a:solidFill>
                   <a:srgbClr val="101828"/>
                 </a:solidFill>
-                <a:latin typeface="Aptos Display"/>
-              </a:defRPr>
-            </a:pPr>
-            <a:r>
-              <a:t>The Bridge Rejects Ambiguous State Meaning</a:t>
+                <a:latin typeface="Apple SD Gothic Neo"/>
+              </a:defRPr>
+            </a:pPr>
+            <a:r>
+              <a:t>브릿지는 모호한 상태 의미를 거부한다</a:t>
             </a:r>
           </a:p>
         </p:txBody>
@@ -9101,7 +9216,7 @@
         </p:nvSpPr>
         <p:spPr>
           <a:xfrm>
-            <a:off x="548640" y="1719072"/>
+            <a:off x="548640" y="1444752"/>
             <a:ext cx="7863840" cy="438912"/>
           </a:xfrm>
           <a:prstGeom prst="rect">
@@ -9120,11 +9235,11 @@
                 <a:solidFill>
                   <a:srgbClr val="5C667A"/>
                 </a:solidFill>
-                <a:latin typeface="Aptos"/>
-              </a:defRPr>
-            </a:pPr>
-            <a:r>
-              <a:t>The abstract spec turns implementation assumptions into explicit admissibility constraints.</a:t>
+                <a:latin typeface="Apple SD Gothic Neo"/>
+              </a:defRPr>
+            </a:pPr>
+            <a:r>
+              <a:t>구현체의 안전 가정은 명시적인 admissibility constraint로 나타난다.</a:t>
             </a:r>
           </a:p>
         </p:txBody>
@@ -9199,7 +9314,7 @@
                 <a:solidFill>
                   <a:srgbClr val="5C667A"/>
                 </a:solidFill>
-                <a:latin typeface="Aptos"/>
+                <a:latin typeface="Apple SD Gothic Neo"/>
               </a:defRPr>
             </a:pPr>
             <a:r>
@@ -9235,7 +9350,7 @@
                 <a:solidFill>
                   <a:srgbClr val="5C667A"/>
                 </a:solidFill>
-                <a:latin typeface="Aptos"/>
+                <a:latin typeface="Apple SD Gothic Neo"/>
               </a:defRPr>
             </a:pPr>
             <a:r>
@@ -9314,7 +9429,7 @@
                 <a:solidFill>
                   <a:srgbClr val="A9B7D0"/>
                 </a:solidFill>
-                <a:latin typeface="Aptos"/>
+                <a:latin typeface="Apple SD Gothic Neo"/>
               </a:defRPr>
             </a:pPr>
             <a:r>
@@ -9350,7 +9465,7 @@
                 <a:solidFill>
                   <a:srgbClr val="FFFFFF"/>
                 </a:solidFill>
-                <a:latin typeface="Aptos"/>
+                <a:latin typeface="Apple SD Gothic Neo"/>
               </a:defRPr>
             </a:pPr>
             <a:r>
@@ -9386,7 +9501,7 @@
                 <a:solidFill>
                   <a:srgbClr val="A9B7D0"/>
                 </a:solidFill>
-                <a:latin typeface="Aptos"/>
+                <a:latin typeface="Apple SD Gothic Neo"/>
               </a:defRPr>
             </a:pPr>
             <a:r>
@@ -9422,7 +9537,7 @@
                 <a:solidFill>
                   <a:srgbClr val="FFFFFF"/>
                 </a:solidFill>
-                <a:latin typeface="Aptos"/>
+                <a:latin typeface="Apple SD Gothic Neo"/>
               </a:defRPr>
             </a:pPr>
             <a:r>
@@ -9501,7 +9616,7 @@
                 <a:solidFill>
                   <a:srgbClr val="A9B7D0"/>
                 </a:solidFill>
-                <a:latin typeface="Aptos"/>
+                <a:latin typeface="Apple SD Gothic Neo"/>
               </a:defRPr>
             </a:pPr>
             <a:r>
@@ -9537,7 +9652,7 @@
                 <a:solidFill>
                   <a:srgbClr val="FFFFFF"/>
                 </a:solidFill>
-                <a:latin typeface="Aptos"/>
+                <a:latin typeface="Apple SD Gothic Neo"/>
               </a:defRPr>
             </a:pPr>
             <a:r>
@@ -9616,7 +9731,7 @@
                 <a:solidFill>
                   <a:srgbClr val="A9B7D0"/>
                 </a:solidFill>
-                <a:latin typeface="Aptos"/>
+                <a:latin typeface="Apple SD Gothic Neo"/>
               </a:defRPr>
             </a:pPr>
             <a:r>
@@ -9652,7 +9767,7 @@
                 <a:solidFill>
                   <a:srgbClr val="FFFFFF"/>
                 </a:solidFill>
-                <a:latin typeface="Aptos"/>
+                <a:latin typeface="Apple SD Gothic Neo"/>
               </a:defRPr>
             </a:pPr>
             <a:r>
@@ -9819,7 +9934,7 @@
                 <a:solidFill>
                   <a:srgbClr val="1B1F2A"/>
                 </a:solidFill>
-                <a:latin typeface="Aptos Display"/>
+                <a:latin typeface="Apple SD Gothic Neo"/>
               </a:defRPr>
             </a:pPr>
             <a:r>
@@ -9855,11 +9970,11 @@
                 <a:solidFill>
                   <a:srgbClr val="5C667A"/>
                 </a:solidFill>
-                <a:latin typeface="Aptos"/>
-              </a:defRPr>
-            </a:pPr>
-            <a:r>
-              <a:t>Every root vector, storage-write descriptor, snapshot, and proof input must use the same DApp-wide storage order.</a:t>
+                <a:latin typeface="Apple SD Gothic Neo"/>
+              </a:defRPr>
+            </a:pPr>
+            <a:r>
+              <a:t>root vector, storage-write descriptor, snapshot, proof input은 같은 DApp-wide storage order를 사용해야 한다.</a:t>
             </a:r>
           </a:p>
         </p:txBody>
@@ -9979,7 +10094,7 @@
                 <a:solidFill>
                   <a:srgbClr val="1B1F2A"/>
                 </a:solidFill>
-                <a:latin typeface="Aptos Display"/>
+                <a:latin typeface="Apple SD Gothic Neo"/>
               </a:defRPr>
             </a:pPr>
             <a:r>
@@ -10015,11 +10130,11 @@
                 <a:solidFill>
                   <a:srgbClr val="5C667A"/>
                 </a:solidFill>
-                <a:latin typeface="Aptos"/>
-              </a:defRPr>
-            </a:pPr>
-            <a:r>
-              <a:t>A state update becomes meaningful only when proof verification and bridge metadata checks both succeed.</a:t>
+                <a:latin typeface="Apple SD Gothic Neo"/>
+              </a:defRPr>
+            </a:pPr>
+            <a:r>
+              <a:t>state update는 proof verification과 bridge metadata check가 모두 성공할 때만 의미를 갖는다.</a:t>
             </a:r>
           </a:p>
         </p:txBody>
@@ -10139,7 +10254,7 @@
                 <a:solidFill>
                   <a:srgbClr val="1B1F2A"/>
                 </a:solidFill>
-                <a:latin typeface="Aptos Display"/>
+                <a:latin typeface="Apple SD Gothic Neo"/>
               </a:defRPr>
             </a:pPr>
             <a:r>
@@ -10175,11 +10290,11 @@
                 <a:solidFill>
                   <a:srgbClr val="5C667A"/>
                 </a:solidFill>
-                <a:latin typeface="Aptos"/>
-              </a:defRPr>
-            </a:pPr>
-            <a:r>
-              <a:t>The bridge does not accept a selector merely because it exists in deployed bytecode.</a:t>
+                <a:latin typeface="Apple SD Gothic Neo"/>
+              </a:defRPr>
+            </a:pPr>
+            <a:r>
+              <a:t>배포 bytecode에 selector가 존재한다는 이유만으로 브릿지가 실행을 받아들이지는 않는다.</a:t>
             </a:r>
           </a:p>
         </p:txBody>
@@ -10280,11 +10395,11 @@
                 <a:solidFill>
                   <a:srgbClr val="2563EB"/>
                 </a:solidFill>
-                <a:latin typeface="Aptos"/>
-              </a:defRPr>
-            </a:pPr>
-            <a:r>
-              <a:t>IMPLEMENTATION MAPPING</a:t>
+                <a:latin typeface="Apple SD Gothic Neo"/>
+              </a:defRPr>
+            </a:pPr>
+            <a:r>
+              <a:t>구현 매핑</a:t>
             </a:r>
           </a:p>
         </p:txBody>
@@ -10298,7 +10413,7 @@
         <p:spPr>
           <a:xfrm>
             <a:off x="530352" y="804672"/>
-            <a:ext cx="8046720" cy="932688"/>
+            <a:ext cx="8046720" cy="640080"/>
           </a:xfrm>
           <a:prstGeom prst="rect">
             <a:avLst/>
@@ -10312,15 +10427,15 @@
           <a:lstStyle/>
           <a:p>
             <a:pPr>
-              <a:defRPr sz="2800" b="1">
+              <a:defRPr sz="3400" b="1">
                 <a:solidFill>
                   <a:srgbClr val="101828"/>
                 </a:solidFill>
-                <a:latin typeface="Aptos Display"/>
-              </a:defRPr>
-            </a:pPr>
-            <a:r>
-              <a:t>Concepts to Contracts and Scripts</a:t>
+                <a:latin typeface="Apple SD Gothic Neo"/>
+              </a:defRPr>
+            </a:pPr>
+            <a:r>
+              <a:t>개념에서 Contracts와 Scripts로</a:t>
             </a:r>
           </a:p>
         </p:txBody>
@@ -10333,7 +10448,7 @@
         </p:nvSpPr>
         <p:spPr>
           <a:xfrm>
-            <a:off x="548640" y="1719072"/>
+            <a:off x="548640" y="1444752"/>
             <a:ext cx="7863840" cy="438912"/>
           </a:xfrm>
           <a:prstGeom prst="rect">
@@ -10352,11 +10467,11 @@
                 <a:solidFill>
                   <a:srgbClr val="5C667A"/>
                 </a:solidFill>
-                <a:latin typeface="Aptos"/>
-              </a:defRPr>
-            </a:pPr>
-            <a:r>
-              <a:t>The current codebase separates stable protocol roles from volatile deployment details.</a:t>
+                <a:latin typeface="Apple SD Gothic Neo"/>
+              </a:defRPr>
+            </a:pPr>
+            <a:r>
+              <a:t>현재 코드베이스는 stable protocol role과 deployment detail을 분리한다.</a:t>
             </a:r>
           </a:p>
         </p:txBody>
@@ -10431,7 +10546,7 @@
                 <a:solidFill>
                   <a:srgbClr val="5C667A"/>
                 </a:solidFill>
-                <a:latin typeface="Aptos"/>
+                <a:latin typeface="Apple SD Gothic Neo"/>
               </a:defRPr>
             </a:pPr>
             <a:r>
@@ -10467,7 +10582,7 @@
                 <a:solidFill>
                   <a:srgbClr val="5C667A"/>
                 </a:solidFill>
-                <a:latin typeface="Aptos"/>
+                <a:latin typeface="Apple SD Gothic Neo"/>
               </a:defRPr>
             </a:pPr>
             <a:r>
@@ -10548,7 +10663,7 @@
                 <a:solidFill>
                   <a:srgbClr val="1B1F2A"/>
                 </a:solidFill>
-                <a:latin typeface="Aptos"/>
+                <a:latin typeface="Apple SD Gothic Neo"/>
               </a:defRPr>
             </a:pPr>
             <a:r>
@@ -10620,7 +10735,7 @@
                 <a:solidFill>
                   <a:srgbClr val="1B1F2A"/>
                 </a:solidFill>
-                <a:latin typeface="Aptos"/>
+                <a:latin typeface="Apple SD Gothic Neo"/>
               </a:defRPr>
             </a:pPr>
             <a:r>
@@ -10735,7 +10850,7 @@
                 <a:solidFill>
                   <a:srgbClr val="1B1F2A"/>
                 </a:solidFill>
-                <a:latin typeface="Aptos"/>
+                <a:latin typeface="Apple SD Gothic Neo"/>
               </a:defRPr>
             </a:pPr>
             <a:r>
@@ -10850,7 +10965,7 @@
                 <a:solidFill>
                   <a:srgbClr val="1B1F2A"/>
                 </a:solidFill>
-                <a:latin typeface="Aptos"/>
+                <a:latin typeface="Apple SD Gothic Neo"/>
               </a:defRPr>
             </a:pPr>
             <a:r>
@@ -10965,7 +11080,7 @@
                 <a:solidFill>
                   <a:srgbClr val="1B1F2A"/>
                 </a:solidFill>
-                <a:latin typeface="Aptos"/>
+                <a:latin typeface="Apple SD Gothic Neo"/>
               </a:defRPr>
             </a:pPr>
             <a:r>
@@ -11080,7 +11195,7 @@
                 <a:solidFill>
                   <a:srgbClr val="1B1F2A"/>
                 </a:solidFill>
-                <a:latin typeface="Aptos"/>
+                <a:latin typeface="Apple SD Gothic Neo"/>
               </a:defRPr>
             </a:pPr>
             <a:r>
@@ -11195,7 +11310,7 @@
                 <a:solidFill>
                   <a:srgbClr val="1B1F2A"/>
                 </a:solidFill>
-                <a:latin typeface="Aptos"/>
+                <a:latin typeface="Apple SD Gothic Neo"/>
               </a:defRPr>
             </a:pPr>
             <a:r>
@@ -11379,11 +11494,11 @@
                 <a:solidFill>
                   <a:srgbClr val="2563EB"/>
                 </a:solidFill>
-                <a:latin typeface="Aptos"/>
-              </a:defRPr>
-            </a:pPr>
-            <a:r>
-              <a:t>DEVELOPER WORKFLOW</a:t>
+                <a:latin typeface="Apple SD Gothic Neo"/>
+              </a:defRPr>
+            </a:pPr>
+            <a:r>
+              <a:t>개발자 WORKFLOW</a:t>
             </a:r>
           </a:p>
         </p:txBody>
@@ -11397,7 +11512,7 @@
         <p:spPr>
           <a:xfrm>
             <a:off x="530352" y="804672"/>
-            <a:ext cx="8046720" cy="932688"/>
+            <a:ext cx="8046720" cy="640080"/>
           </a:xfrm>
           <a:prstGeom prst="rect">
             <a:avLst/>
@@ -11411,15 +11526,15 @@
           <a:lstStyle/>
           <a:p>
             <a:pPr>
-              <a:defRPr sz="2800" b="1">
+              <a:defRPr sz="3400" b="1">
                 <a:solidFill>
                   <a:srgbClr val="101828"/>
                 </a:solidFill>
-                <a:latin typeface="Aptos Display"/>
-              </a:defRPr>
-            </a:pPr>
-            <a:r>
-              <a:t>How to Implement and Operate a Channel</a:t>
+                <a:latin typeface="Apple SD Gothic Neo"/>
+              </a:defRPr>
+            </a:pPr>
+            <a:r>
+              <a:t>채널을 구현하고 운영하는 방법</a:t>
             </a:r>
           </a:p>
         </p:txBody>
@@ -11432,7 +11547,7 @@
         </p:nvSpPr>
         <p:spPr>
           <a:xfrm>
-            <a:off x="548640" y="1719072"/>
+            <a:off x="548640" y="1444752"/>
             <a:ext cx="7863840" cy="438912"/>
           </a:xfrm>
           <a:prstGeom prst="rect">
@@ -11451,11 +11566,11 @@
                 <a:solidFill>
                   <a:srgbClr val="5C667A"/>
                 </a:solidFill>
-                <a:latin typeface="Aptos"/>
-              </a:defRPr>
-            </a:pPr>
-            <a:r>
-              <a:t>The workflow turns contracts, synthesizer metadata, and CLI proof generation into one bridge-coupled path.</a:t>
+                <a:latin typeface="Apple SD Gothic Neo"/>
+              </a:defRPr>
+            </a:pPr>
+            <a:r>
+              <a:t>contracts, synthesizer metadata, CLI proof generation이 하나의 bridge-coupled path로 연결된다.</a:t>
             </a:r>
           </a:p>
         </p:txBody>
@@ -11530,7 +11645,7 @@
                 <a:solidFill>
                   <a:srgbClr val="5C667A"/>
                 </a:solidFill>
-                <a:latin typeface="Aptos"/>
+                <a:latin typeface="Apple SD Gothic Neo"/>
               </a:defRPr>
             </a:pPr>
             <a:r>
@@ -11566,7 +11681,7 @@
                 <a:solidFill>
                   <a:srgbClr val="5C667A"/>
                 </a:solidFill>
-                <a:latin typeface="Aptos"/>
+                <a:latin typeface="Apple SD Gothic Neo"/>
               </a:defRPr>
             </a:pPr>
             <a:r>
@@ -11690,7 +11805,7 @@
                 <a:solidFill>
                   <a:srgbClr val="FFFFFF"/>
                 </a:solidFill>
-                <a:latin typeface="Aptos"/>
+                <a:latin typeface="Apple SD Gothic Neo"/>
               </a:defRPr>
             </a:pPr>
             <a:r>
@@ -11726,11 +11841,11 @@
                 <a:solidFill>
                   <a:srgbClr val="1B1F2A"/>
                 </a:solidFill>
-                <a:latin typeface="Aptos"/>
-              </a:defRPr>
-            </a:pPr>
-            <a:r>
-              <a:t>Deploy bridge stack</a:t>
+                <a:latin typeface="Apple SD Gothic Neo"/>
+              </a:defRPr>
+            </a:pPr>
+            <a:r>
+              <a:t>bridge stack 배포</a:t>
             </a:r>
           </a:p>
         </p:txBody>
@@ -11885,7 +12000,7 @@
                 <a:solidFill>
                   <a:srgbClr val="FFFFFF"/>
                 </a:solidFill>
-                <a:latin typeface="Aptos"/>
+                <a:latin typeface="Apple SD Gothic Neo"/>
               </a:defRPr>
             </a:pPr>
             <a:r>
@@ -11921,11 +12036,11 @@
                 <a:solidFill>
                   <a:srgbClr val="1B1F2A"/>
                 </a:solidFill>
-                <a:latin typeface="Aptos"/>
-              </a:defRPr>
-            </a:pPr>
-            <a:r>
-              <a:t>Deploy private-state DApp</a:t>
+                <a:latin typeface="Apple SD Gothic Neo"/>
+              </a:defRPr>
+            </a:pPr>
+            <a:r>
+              <a:t>private-state DApp 배포</a:t>
             </a:r>
           </a:p>
         </p:txBody>
@@ -12080,7 +12195,7 @@
                 <a:solidFill>
                   <a:srgbClr val="FFFFFF"/>
                 </a:solidFill>
-                <a:latin typeface="Aptos"/>
+                <a:latin typeface="Apple SD Gothic Neo"/>
               </a:defRPr>
             </a:pPr>
             <a:r>
@@ -12116,11 +12231,11 @@
                 <a:solidFill>
                   <a:srgbClr val="1B1F2A"/>
                 </a:solidFill>
-                <a:latin typeface="Aptos"/>
-              </a:defRPr>
-            </a:pPr>
-            <a:r>
-              <a:t>Synthesize and preprocess examples</a:t>
+                <a:latin typeface="Apple SD Gothic Neo"/>
+              </a:defRPr>
+            </a:pPr>
+            <a:r>
+              <a:t>example synthesize와 preprocess</a:t>
             </a:r>
           </a:p>
         </p:txBody>
@@ -12275,7 +12390,7 @@
                 <a:solidFill>
                   <a:srgbClr val="FFFFFF"/>
                 </a:solidFill>
-                <a:latin typeface="Aptos"/>
+                <a:latin typeface="Apple SD Gothic Neo"/>
               </a:defRPr>
             </a:pPr>
             <a:r>
@@ -12311,11 +12426,11 @@
                 <a:solidFill>
                   <a:srgbClr val="1B1F2A"/>
                 </a:solidFill>
-                <a:latin typeface="Aptos"/>
-              </a:defRPr>
-            </a:pPr>
-            <a:r>
-              <a:t>Register DApp metadata</a:t>
+                <a:latin typeface="Apple SD Gothic Neo"/>
+              </a:defRPr>
+            </a:pPr>
+            <a:r>
+              <a:t>DApp metadata 등록</a:t>
             </a:r>
           </a:p>
         </p:txBody>
@@ -12470,7 +12585,7 @@
                 <a:solidFill>
                   <a:srgbClr val="FFFFFF"/>
                 </a:solidFill>
-                <a:latin typeface="Aptos"/>
+                <a:latin typeface="Apple SD Gothic Neo"/>
               </a:defRPr>
             </a:pPr>
             <a:r>
@@ -12506,11 +12621,11 @@
                 <a:solidFill>
                   <a:srgbClr val="1B1F2A"/>
                 </a:solidFill>
-                <a:latin typeface="Aptos"/>
-              </a:defRPr>
-            </a:pPr>
-            <a:r>
-              <a:t>Create or join a channel</a:t>
+                <a:latin typeface="Apple SD Gothic Neo"/>
+              </a:defRPr>
+            </a:pPr>
+            <a:r>
+              <a:t>channel create 또는 join</a:t>
             </a:r>
           </a:p>
         </p:txBody>
@@ -12665,7 +12780,7 @@
                 <a:solidFill>
                   <a:srgbClr val="FFFFFF"/>
                 </a:solidFill>
-                <a:latin typeface="Aptos"/>
+                <a:latin typeface="Apple SD Gothic Neo"/>
               </a:defRPr>
             </a:pPr>
             <a:r>
@@ -12701,11 +12816,11 @@
                 <a:solidFill>
                   <a:srgbClr val="1B1F2A"/>
                 </a:solidFill>
-                <a:latin typeface="Aptos"/>
-              </a:defRPr>
-            </a:pPr>
-            <a:r>
-              <a:t>Submit proof-backed wallet operations</a:t>
+                <a:latin typeface="Apple SD Gothic Neo"/>
+              </a:defRPr>
+            </a:pPr>
+            <a:r>
+              <a:t>proof-backed wallet operation 제출</a:t>
             </a:r>
           </a:p>
         </p:txBody>
@@ -12806,7 +12921,7 @@
                 <a:solidFill>
                   <a:srgbClr val="2563EB"/>
                 </a:solidFill>
-                <a:latin typeface="Aptos"/>
+                <a:latin typeface="Apple SD Gothic Neo"/>
               </a:defRPr>
             </a:pPr>
             <a:r>
@@ -12824,7 +12939,7 @@
         <p:spPr>
           <a:xfrm>
             <a:off x="530352" y="804672"/>
-            <a:ext cx="8046720" cy="932688"/>
+            <a:ext cx="8046720" cy="640080"/>
           </a:xfrm>
           <a:prstGeom prst="rect">
             <a:avLst/>
@@ -12838,15 +12953,15 @@
           <a:lstStyle/>
           <a:p>
             <a:pPr>
-              <a:defRPr sz="2800" b="1">
+              <a:defRPr sz="3400" b="1">
                 <a:solidFill>
                   <a:srgbClr val="101828"/>
                 </a:solidFill>
-                <a:latin typeface="Aptos Display"/>
-              </a:defRPr>
-            </a:pPr>
-            <a:r>
-              <a:t>Open Research and Engineering Questions</a:t>
+                <a:latin typeface="Apple SD Gothic Neo"/>
+              </a:defRPr>
+            </a:pPr>
+            <a:r>
+              <a:t>열린 연구 및 엔지니어링 질문</a:t>
             </a:r>
           </a:p>
         </p:txBody>
@@ -12859,7 +12974,7 @@
         </p:nvSpPr>
         <p:spPr>
           <a:xfrm>
-            <a:off x="548640" y="1719072"/>
+            <a:off x="548640" y="1444752"/>
             <a:ext cx="7863840" cy="438912"/>
           </a:xfrm>
           <a:prstGeom prst="rect">
@@ -12878,11 +12993,11 @@
                 <a:solidFill>
                   <a:srgbClr val="5C667A"/>
                 </a:solidFill>
-                <a:latin typeface="Aptos"/>
-              </a:defRPr>
-            </a:pPr>
-            <a:r>
-              <a:t>The design chooses explicit policy and isolation over some forms of global flexibility.</a:t>
+                <a:latin typeface="Apple SD Gothic Neo"/>
+              </a:defRPr>
+            </a:pPr>
+            <a:r>
+              <a:t>이 설계는 일부 global flexibility보다 explicit policy와 isolation을 선택한다.</a:t>
             </a:r>
           </a:p>
         </p:txBody>
@@ -12957,7 +13072,7 @@
                 <a:solidFill>
                   <a:srgbClr val="5C667A"/>
                 </a:solidFill>
-                <a:latin typeface="Aptos"/>
+                <a:latin typeface="Apple SD Gothic Neo"/>
               </a:defRPr>
             </a:pPr>
             <a:r>
@@ -12993,7 +13108,7 @@
                 <a:solidFill>
                   <a:srgbClr val="5C667A"/>
                 </a:solidFill>
-                <a:latin typeface="Aptos"/>
+                <a:latin typeface="Apple SD Gothic Neo"/>
               </a:defRPr>
             </a:pPr>
             <a:r>
@@ -13117,7 +13232,7 @@
                 <a:solidFill>
                   <a:srgbClr val="1B1F2A"/>
                 </a:solidFill>
-                <a:latin typeface="Aptos Display"/>
+                <a:latin typeface="Apple SD Gothic Neo"/>
               </a:defRPr>
             </a:pPr>
             <a:r>
@@ -13153,11 +13268,11 @@
                 <a:solidFill>
                   <a:srgbClr val="5C667A"/>
                 </a:solidFill>
-                <a:latin typeface="Aptos"/>
-              </a:defRPr>
-            </a:pPr>
-            <a:r>
-              <a:t>Per-channel execution gives tight safety boundaries, but cross-channel composition is not the primary optimization target.</a:t>
+                <a:latin typeface="Apple SD Gothic Neo"/>
+              </a:defRPr>
+            </a:pPr>
+            <a:r>
+              <a:t>per-channel execution은 강한 safety boundary를 주지만, cross-channel composition이 주된 최적화 대상은 아니다.</a:t>
             </a:r>
           </a:p>
         </p:txBody>
@@ -13277,7 +13392,7 @@
                 <a:solidFill>
                   <a:srgbClr val="1B1F2A"/>
                 </a:solidFill>
-                <a:latin typeface="Aptos Display"/>
+                <a:latin typeface="Apple SD Gothic Neo"/>
               </a:defRPr>
             </a:pPr>
             <a:r>
@@ -13313,11 +13428,11 @@
                 <a:solidFill>
                   <a:srgbClr val="5C667A"/>
                 </a:solidFill>
-                <a:latin typeface="Aptos"/>
-              </a:defRPr>
-            </a:pPr>
-            <a:r>
-              <a:t>Channel policy bugs normally require a new channel or migration path rather than in-place rewriting.</a:t>
+                <a:latin typeface="Apple SD Gothic Neo"/>
+              </a:defRPr>
+            </a:pPr>
+            <a:r>
+              <a:t>channel policy bug는 보통 in-place rewrite가 아니라 새 channel이나 migration path를 요구한다.</a:t>
             </a:r>
           </a:p>
         </p:txBody>
@@ -13437,7 +13552,7 @@
                 <a:solidFill>
                   <a:srgbClr val="1B1F2A"/>
                 </a:solidFill>
-                <a:latin typeface="Aptos Display"/>
+                <a:latin typeface="Apple SD Gothic Neo"/>
               </a:defRPr>
             </a:pPr>
             <a:r>
@@ -13473,11 +13588,11 @@
                 <a:solidFill>
                   <a:srgbClr val="5C667A"/>
                 </a:solidFill>
-                <a:latin typeface="Aptos"/>
-              </a:defRPr>
-            </a:pPr>
-            <a:r>
-              <a:t>Storage keys are projected into a finite leaf domain, so capacity and collision risk are channel-lifetime concerns.</a:t>
+                <a:latin typeface="Apple SD Gothic Neo"/>
+              </a:defRPr>
+            </a:pPr>
+            <a:r>
+              <a:t>storage key는 finite leaf domain에 투영되므로 capacity와 collision risk는 channel lifetime concern이다.</a:t>
             </a:r>
           </a:p>
         </p:txBody>
@@ -13597,7 +13712,7 @@
                 <a:solidFill>
                   <a:srgbClr val="1B1F2A"/>
                 </a:solidFill>
-                <a:latin typeface="Aptos Display"/>
+                <a:latin typeface="Apple SD Gothic Neo"/>
               </a:defRPr>
             </a:pPr>
             <a:r>
@@ -13633,11 +13748,11 @@
                 <a:solidFill>
                   <a:srgbClr val="5C667A"/>
                 </a:solidFill>
-                <a:latin typeface="Aptos"/>
-              </a:defRPr>
-            </a:pPr>
-            <a:r>
-              <a:t>Compliance, auditability, and selective disclosure must be programmed and documented per DApp.</a:t>
+                <a:latin typeface="Apple SD Gothic Neo"/>
+              </a:defRPr>
+            </a:pPr>
+            <a:r>
+              <a:t>compliance, auditability, selective disclosure는 DApp별로 프로그램하고 문서화해야 한다.</a:t>
             </a:r>
           </a:p>
         </p:txBody>
@@ -13738,7 +13853,7 @@
                 <a:solidFill>
                   <a:srgbClr val="2563EB"/>
                 </a:solidFill>
-                <a:latin typeface="Aptos"/>
+                <a:latin typeface="Apple SD Gothic Neo"/>
               </a:defRPr>
             </a:pPr>
             <a:r>
@@ -13774,11 +13889,11 @@
                 <a:solidFill>
                   <a:srgbClr val="101828"/>
                 </a:solidFill>
-                <a:latin typeface="Aptos Display"/>
-              </a:defRPr>
-            </a:pPr>
-            <a:r>
-              <a:t>What to Remember</a:t>
+                <a:latin typeface="Apple SD Gothic Neo"/>
+              </a:defRPr>
+            </a:pPr>
+            <a:r>
+              <a:t>기억해야 할 것</a:t>
             </a:r>
           </a:p>
         </p:txBody>
@@ -13810,11 +13925,11 @@
                 <a:solidFill>
                   <a:srgbClr val="5C667A"/>
                 </a:solidFill>
-                <a:latin typeface="Aptos"/>
-              </a:defRPr>
-            </a:pPr>
-            <a:r>
-              <a:t>Tokamak Private App Channels are a bridge fabric for validity-proven DApp-specific execution.</a:t>
+                <a:latin typeface="Apple SD Gothic Neo"/>
+              </a:defRPr>
+            </a:pPr>
+            <a:r>
+              <a:t>Tokamak Private App Channels는 validity-proven DApp-specific execution을 위한 bridge fabric이다.</a:t>
             </a:r>
           </a:p>
         </p:txBody>
@@ -13889,7 +14004,7 @@
                 <a:solidFill>
                   <a:srgbClr val="5C667A"/>
                 </a:solidFill>
-                <a:latin typeface="Aptos"/>
+                <a:latin typeface="Apple SD Gothic Neo"/>
               </a:defRPr>
             </a:pPr>
             <a:r>
@@ -13925,7 +14040,7 @@
                 <a:solidFill>
                   <a:srgbClr val="5C667A"/>
                 </a:solidFill>
-                <a:latin typeface="Aptos"/>
+                <a:latin typeface="Apple SD Gothic Neo"/>
               </a:defRPr>
             </a:pPr>
             <a:r>
@@ -14000,15 +14115,15 @@
           <a:lstStyle/>
           <a:p>
             <a:pPr>
-              <a:defRPr sz="1800" b="0">
+              <a:defRPr sz="1700" b="0">
                 <a:solidFill>
                   <a:srgbClr val="1B1F2A"/>
                 </a:solidFill>
-                <a:latin typeface="Aptos"/>
-              </a:defRPr>
-            </a:pPr>
-            <a:r>
-              <a:t>Ethereum remains the custody and validity anchor.</a:t>
+                <a:latin typeface="Apple SD Gothic Neo"/>
+              </a:defRPr>
+            </a:pPr>
+            <a:r>
+              <a:t>Ethereum은 custody와 validity anchor로 남는다.</a:t>
             </a:r>
           </a:p>
         </p:txBody>
@@ -14079,15 +14194,15 @@
           <a:lstStyle/>
           <a:p>
             <a:pPr>
-              <a:defRPr sz="1800" b="0">
+              <a:defRPr sz="1700" b="0">
                 <a:solidFill>
                   <a:srgbClr val="1B1F2A"/>
                 </a:solidFill>
-                <a:latin typeface="Aptos"/>
-              </a:defRPr>
-            </a:pPr>
-            <a:r>
-              <a:t>The bridge admits execution through registered metadata, not arbitrary ABI interpretation.</a:t>
+                <a:latin typeface="Apple SD Gothic Neo"/>
+              </a:defRPr>
+            </a:pPr>
+            <a:r>
+              <a:t>브릿지는 arbitrary ABI interpretation이 아니라 registered metadata로 실행을 admission한다.</a:t>
             </a:r>
           </a:p>
         </p:txBody>
@@ -14158,15 +14273,15 @@
           <a:lstStyle/>
           <a:p>
             <a:pPr>
-              <a:defRPr sz="1800" b="0">
+              <a:defRPr sz="1700" b="0">
                 <a:solidFill>
                   <a:srgbClr val="1B1F2A"/>
                 </a:solidFill>
-                <a:latin typeface="Aptos"/>
-              </a:defRPr>
-            </a:pPr>
-            <a:r>
-              <a:t>Each channel snapshots its DApp policy, verifier bindings, function root, and storage vector.</a:t>
+                <a:latin typeface="Apple SD Gothic Neo"/>
+              </a:defRPr>
+            </a:pPr>
+            <a:r>
+              <a:t>각 채널은 DApp policy, verifier binding, function root, storage vector를 snapshot한다.</a:t>
             </a:r>
           </a:p>
         </p:txBody>
@@ -14237,15 +14352,15 @@
           <a:lstStyle/>
           <a:p>
             <a:pPr>
-              <a:defRPr sz="1800" b="0">
+              <a:defRPr sz="1700" b="0">
                 <a:solidFill>
                   <a:srgbClr val="1B1F2A"/>
                 </a:solidFill>
-                <a:latin typeface="Aptos"/>
-              </a:defRPr>
-            </a:pPr>
-            <a:r>
-              <a:t>Tokamak proofs and Groth16 accounting proofs serve different bridge responsibilities.</a:t>
+                <a:latin typeface="Apple SD Gothic Neo"/>
+              </a:defRPr>
+            </a:pPr>
+            <a:r>
+              <a:t>Tokamak proof와 Groth16 accounting proof는 서로 다른 bridge responsibility를 맡는다.</a:t>
             </a:r>
           </a:p>
         </p:txBody>
@@ -14316,15 +14431,15 @@
           <a:lstStyle/>
           <a:p>
             <a:pPr>
-              <a:defRPr sz="1800" b="0">
+              <a:defRPr sz="1700" b="0">
                 <a:solidFill>
                   <a:srgbClr val="1B1F2A"/>
                 </a:solidFill>
-                <a:latin typeface="Aptos"/>
-              </a:defRPr>
-            </a:pPr>
-            <a:r>
-              <a:t>Private-state demonstrates DApp-programmed privacy with transparent L1 entry and exit.</a:t>
+                <a:latin typeface="Apple SD Gothic Neo"/>
+              </a:defRPr>
+            </a:pPr>
+            <a:r>
+              <a:t>private-state는 공개 L1 entry/exit 위에서 DApp-programmed privacy를 보여준다.</a:t>
             </a:r>
           </a:p>
         </p:txBody>
@@ -14399,11 +14514,11 @@
                 <a:solidFill>
                   <a:srgbClr val="FFFFFF"/>
                 </a:solidFill>
-                <a:latin typeface="Aptos"/>
-              </a:defRPr>
-            </a:pPr>
-            <a:r>
-              <a:t>The central question is not only whether a proof verifies, but what policy gives that proof meaning.</a:t>
+                <a:latin typeface="Apple SD Gothic Neo"/>
+              </a:defRPr>
+            </a:pPr>
+            <a:r>
+              <a:t>핵심 질문은 proof가 verify되는가뿐 아니라, 어떤 policy가 그 proof에 의미를 부여하는가이다.</a:t>
             </a:r>
           </a:p>
         </p:txBody>
@@ -14504,11 +14619,11 @@
                 <a:solidFill>
                   <a:srgbClr val="2563EB"/>
                 </a:solidFill>
-                <a:latin typeface="Aptos"/>
-              </a:defRPr>
-            </a:pPr>
-            <a:r>
-              <a:t>BACKGROUND</a:t>
+                <a:latin typeface="Apple SD Gothic Neo"/>
+              </a:defRPr>
+            </a:pPr>
+            <a:r>
+              <a:t>배경</a:t>
             </a:r>
           </a:p>
         </p:txBody>
@@ -14540,11 +14655,11 @@
                 <a:solidFill>
                   <a:srgbClr val="101828"/>
                 </a:solidFill>
-                <a:latin typeface="Aptos Display"/>
-              </a:defRPr>
-            </a:pPr>
-            <a:r>
-              <a:t>Why App-Specific Channels?</a:t>
+                <a:latin typeface="Apple SD Gothic Neo"/>
+              </a:defRPr>
+            </a:pPr>
+            <a:r>
+              <a:t>왜 App-Specific Channel인가?</a:t>
             </a:r>
           </a:p>
         </p:txBody>
@@ -14576,11 +14691,11 @@
                 <a:solidFill>
                   <a:srgbClr val="5C667A"/>
                 </a:solidFill>
-                <a:latin typeface="Aptos"/>
-              </a:defRPr>
-            </a:pPr>
-            <a:r>
-              <a:t>The system narrows the execution domain so privacy, custody, and proof meaning are easier to reason about.</a:t>
+                <a:latin typeface="Apple SD Gothic Neo"/>
+              </a:defRPr>
+            </a:pPr>
+            <a:r>
+              <a:t>실행 범위를 DApp 단위로 좁히면 프라이버시, 자산 보관, 증명의 의미를 더 명확하게 정의할 수 있다.</a:t>
             </a:r>
           </a:p>
         </p:txBody>
@@ -14655,7 +14770,7 @@
                 <a:solidFill>
                   <a:srgbClr val="5C667A"/>
                 </a:solidFill>
-                <a:latin typeface="Aptos"/>
+                <a:latin typeface="Apple SD Gothic Neo"/>
               </a:defRPr>
             </a:pPr>
             <a:r>
@@ -14691,7 +14806,7 @@
                 <a:solidFill>
                   <a:srgbClr val="5C667A"/>
                 </a:solidFill>
-                <a:latin typeface="Aptos"/>
+                <a:latin typeface="Apple SD Gothic Neo"/>
               </a:defRPr>
             </a:pPr>
             <a:r>
@@ -14815,11 +14930,11 @@
                 <a:solidFill>
                   <a:srgbClr val="1B1F2A"/>
                 </a:solidFill>
-                <a:latin typeface="Aptos Display"/>
-              </a:defRPr>
-            </a:pPr>
-            <a:r>
-              <a:t>Custody ambiguity</a:t>
+                <a:latin typeface="Apple SD Gothic Neo"/>
+              </a:defRPr>
+            </a:pPr>
+            <a:r>
+              <a:t>자산 보관의 모호성</a:t>
             </a:r>
           </a:p>
         </p:txBody>
@@ -14851,11 +14966,11 @@
                 <a:solidFill>
                   <a:srgbClr val="5C667A"/>
                 </a:solidFill>
-                <a:latin typeface="Aptos"/>
-              </a:defRPr>
-            </a:pPr>
-            <a:r>
-              <a:t>Private execution should not move the canonical asset into an opaque operator custody model.</a:t>
+                <a:latin typeface="Apple SD Gothic Neo"/>
+              </a:defRPr>
+            </a:pPr>
+            <a:r>
+              <a:t>프라이빗 실행이 canonical asset을 불투명한 운영자 보관 모델로 옮기면 정산 신뢰 경계가 흐려진다.</a:t>
             </a:r>
           </a:p>
         </p:txBody>
@@ -14975,11 +15090,11 @@
                 <a:solidFill>
                   <a:srgbClr val="1B1F2A"/>
                 </a:solidFill>
-                <a:latin typeface="Aptos Display"/>
-              </a:defRPr>
-            </a:pPr>
-            <a:r>
-              <a:t>Proof interpretation</a:t>
+                <a:latin typeface="Apple SD Gothic Neo"/>
+              </a:defRPr>
+            </a:pPr>
+            <a:r>
+              <a:t>증명 의미의 모호성</a:t>
             </a:r>
           </a:p>
         </p:txBody>
@@ -15011,11 +15126,11 @@
                 <a:solidFill>
                   <a:srgbClr val="5C667A"/>
                 </a:solidFill>
-                <a:latin typeface="Aptos"/>
-              </a:defRPr>
-            </a:pPr>
-            <a:r>
-              <a:t>A proof is only meaningful when the bridge knows which function, storage surface, and public-input layout it describes.</a:t>
+                <a:latin typeface="Apple SD Gothic Neo"/>
+              </a:defRPr>
+            </a:pPr>
+            <a:r>
+              <a:t>증명은 어떤 함수, 저장소 표면, public input layout을 설명하는지 브릿지가 알 때만 의미가 있다.</a:t>
             </a:r>
           </a:p>
         </p:txBody>
@@ -15135,11 +15250,11 @@
                 <a:solidFill>
                   <a:srgbClr val="1B1F2A"/>
                 </a:solidFill>
-                <a:latin typeface="Aptos Display"/>
-              </a:defRPr>
-            </a:pPr>
-            <a:r>
-              <a:t>Privacy overclaiming</a:t>
+                <a:latin typeface="Apple SD Gothic Neo"/>
+              </a:defRPr>
+            </a:pPr>
+            <a:r>
+              <a:t>프라이버시 과잉 주장</a:t>
             </a:r>
           </a:p>
         </p:txBody>
@@ -15171,11 +15286,11 @@
                 <a:solidFill>
                   <a:srgbClr val="5C667A"/>
                 </a:solidFill>
-                <a:latin typeface="Aptos"/>
-              </a:defRPr>
-            </a:pPr>
-            <a:r>
-              <a:t>The bridge lowers the settlement disclosure surface, but semantic privacy must be programmed by each DApp.</a:t>
+                <a:latin typeface="Apple SD Gothic Neo"/>
+              </a:defRPr>
+            </a:pPr>
+            <a:r>
+              <a:t>브릿지는 공개 표면을 줄일 수 있지만, 의미론적 프라이버시는 각 DApp이 직접 프로그램해야 한다.</a:t>
             </a:r>
           </a:p>
         </p:txBody>
@@ -15207,11 +15322,11 @@
                 <a:solidFill>
                   <a:srgbClr val="2563EB"/>
                 </a:solidFill>
-                <a:latin typeface="Aptos Display"/>
-              </a:defRPr>
-            </a:pPr>
-            <a:r>
-              <a:t>Design response</a:t>
+                <a:latin typeface="Apple SD Gothic Neo"/>
+              </a:defRPr>
+            </a:pPr>
+            <a:r>
+              <a:t>설계 응답</a:t>
             </a:r>
           </a:p>
         </p:txBody>
@@ -15286,11 +15401,11 @@
                 <a:solidFill>
                   <a:srgbClr val="1B1F2A"/>
                 </a:solidFill>
-                <a:latin typeface="Aptos"/>
-              </a:defRPr>
-            </a:pPr>
-            <a:r>
-              <a:t>Keep canonical custody and proof acceptance on Ethereum.</a:t>
+                <a:latin typeface="Apple SD Gothic Neo"/>
+              </a:defRPr>
+            </a:pPr>
+            <a:r>
+              <a:t>canonical custody와 proof acceptance를 Ethereum에 둔다.</a:t>
             </a:r>
           </a:p>
         </p:txBody>
@@ -15365,11 +15480,11 @@
                 <a:solidFill>
                   <a:srgbClr val="1B1F2A"/>
                 </a:solidFill>
-                <a:latin typeface="Aptos"/>
-              </a:defRPr>
-            </a:pPr>
-            <a:r>
-              <a:t>Admit execution through bridge-managed DApp metadata.</a:t>
+                <a:latin typeface="Apple SD Gothic Neo"/>
+              </a:defRPr>
+            </a:pPr>
+            <a:r>
+              <a:t>브릿지가 관리하는 DApp metadata로 실행을 admission한다.</a:t>
             </a:r>
           </a:p>
         </p:txBody>
@@ -15444,11 +15559,11 @@
                 <a:solidFill>
                   <a:srgbClr val="1B1F2A"/>
                 </a:solidFill>
-                <a:latin typeface="Aptos"/>
-              </a:defRPr>
-            </a:pPr>
-            <a:r>
-              <a:t>Snapshot the channel policy when users choose to join.</a:t>
+                <a:latin typeface="Apple SD Gothic Neo"/>
+              </a:defRPr>
+            </a:pPr>
+            <a:r>
+              <a:t>사용자가 참여하는 시점의 channel policy를 스냅샷으로 고정한다.</a:t>
             </a:r>
           </a:p>
         </p:txBody>
@@ -15549,11 +15664,11 @@
                 <a:solidFill>
                   <a:srgbClr val="2563EB"/>
                 </a:solidFill>
-                <a:latin typeface="Aptos"/>
-              </a:defRPr>
-            </a:pPr>
-            <a:r>
-              <a:t>PURPOSE</a:t>
+                <a:latin typeface="Apple SD Gothic Neo"/>
+              </a:defRPr>
+            </a:pPr>
+            <a:r>
+              <a:t>목적</a:t>
             </a:r>
           </a:p>
         </p:txBody>
@@ -15585,11 +15700,11 @@
                 <a:solidFill>
                   <a:srgbClr val="101828"/>
                 </a:solidFill>
-                <a:latin typeface="Aptos Display"/>
-              </a:defRPr>
-            </a:pPr>
-            <a:r>
-              <a:t>The Core Thesis</a:t>
+                <a:latin typeface="Apple SD Gothic Neo"/>
+              </a:defRPr>
+            </a:pPr>
+            <a:r>
+              <a:t>핵심 테제</a:t>
             </a:r>
           </a:p>
         </p:txBody>
@@ -15621,11 +15736,11 @@
                 <a:solidFill>
                   <a:srgbClr val="5C667A"/>
                 </a:solidFill>
-                <a:latin typeface="Aptos"/>
-              </a:defRPr>
-            </a:pPr>
-            <a:r>
-              <a:t>Users join a specific channel policy, not a mutable generic rollup.</a:t>
+                <a:latin typeface="Apple SD Gothic Neo"/>
+              </a:defRPr>
+            </a:pPr>
+            <a:r>
+              <a:t>사용자는 mutable generic rollup이 아니라 특정 channel policy에 참여한다.</a:t>
             </a:r>
           </a:p>
         </p:txBody>
@@ -15700,7 +15815,7 @@
                 <a:solidFill>
                   <a:srgbClr val="5C667A"/>
                 </a:solidFill>
-                <a:latin typeface="Aptos"/>
+                <a:latin typeface="Apple SD Gothic Neo"/>
               </a:defRPr>
             </a:pPr>
             <a:r>
@@ -15736,7 +15851,7 @@
                 <a:solidFill>
                   <a:srgbClr val="5C667A"/>
                 </a:solidFill>
-                <a:latin typeface="Aptos"/>
+                <a:latin typeface="Apple SD Gothic Neo"/>
               </a:defRPr>
             </a:pPr>
             <a:r>
@@ -15817,11 +15932,11 @@
                 <a:solidFill>
                   <a:srgbClr val="D94A4A"/>
                 </a:solidFill>
-                <a:latin typeface="Aptos Display"/>
-              </a:defRPr>
-            </a:pPr>
-            <a:r>
-              <a:t>Generic rollup mindset</a:t>
+                <a:latin typeface="Apple SD Gothic Neo"/>
+              </a:defRPr>
+            </a:pPr>
+            <a:r>
+              <a:t>Generic rollup 관점</a:t>
             </a:r>
           </a:p>
         </p:txBody>
@@ -15896,11 +16011,11 @@
                 <a:solidFill>
                   <a:srgbClr val="1B1F2A"/>
                 </a:solidFill>
-                <a:latin typeface="Aptos"/>
-              </a:defRPr>
-            </a:pPr>
-            <a:r>
-              <a:t>One global execution environment</a:t>
+                <a:latin typeface="Apple SD Gothic Neo"/>
+              </a:defRPr>
+            </a:pPr>
+            <a:r>
+              <a:t>하나의 전역 실행 환경</a:t>
             </a:r>
           </a:p>
         </p:txBody>
@@ -15975,11 +16090,11 @@
                 <a:solidFill>
                   <a:srgbClr val="1B1F2A"/>
                 </a:solidFill>
-                <a:latin typeface="Aptos"/>
-              </a:defRPr>
-            </a:pPr>
-            <a:r>
-              <a:t>Application policy is often downstream of rollup policy</a:t>
+                <a:latin typeface="Apple SD Gothic Neo"/>
+              </a:defRPr>
+            </a:pPr>
+            <a:r>
+              <a:t>Application policy가 rollup policy의 하위 문제로 밀림</a:t>
             </a:r>
           </a:p>
         </p:txBody>
@@ -16054,11 +16169,11 @@
                 <a:solidFill>
                   <a:srgbClr val="1B1F2A"/>
                 </a:solidFill>
-                <a:latin typeface="Aptos"/>
-              </a:defRPr>
-            </a:pPr>
-            <a:r>
-              <a:t>Privacy assumptions can become implicit</a:t>
+                <a:latin typeface="Apple SD Gothic Neo"/>
+              </a:defRPr>
+            </a:pPr>
+            <a:r>
+              <a:t>프라이버시 가정이 암묵화되기 쉬움</a:t>
             </a:r>
           </a:p>
         </p:txBody>
@@ -16135,11 +16250,11 @@
                 <a:solidFill>
                   <a:srgbClr val="21A67A"/>
                 </a:solidFill>
-                <a:latin typeface="Aptos Display"/>
-              </a:defRPr>
-            </a:pPr>
-            <a:r>
-              <a:t>Private App Channel mindset</a:t>
+                <a:latin typeface="Apple SD Gothic Neo"/>
+              </a:defRPr>
+            </a:pPr>
+            <a:r>
+              <a:t>Private App Channel 관점</a:t>
             </a:r>
           </a:p>
         </p:txBody>
@@ -16214,11 +16329,11 @@
                 <a:solidFill>
                   <a:srgbClr val="1B1F2A"/>
                 </a:solidFill>
-                <a:latin typeface="Aptos"/>
-              </a:defRPr>
-            </a:pPr>
-            <a:r>
-              <a:t>One registered DApp per channel</a:t>
+                <a:latin typeface="Apple SD Gothic Neo"/>
+              </a:defRPr>
+            </a:pPr>
+            <a:r>
+              <a:t>채널마다 하나의 registered DApp</a:t>
             </a:r>
           </a:p>
         </p:txBody>
@@ -16293,11 +16408,11 @@
                 <a:solidFill>
                   <a:srgbClr val="1B1F2A"/>
                 </a:solidFill>
-                <a:latin typeface="Aptos"/>
-              </a:defRPr>
-            </a:pPr>
-            <a:r>
-              <a:t>Immutable policy snapshot at creation</a:t>
+                <a:latin typeface="Apple SD Gothic Neo"/>
+              </a:defRPr>
+            </a:pPr>
+            <a:r>
+              <a:t>생성 시점의 immutable policy snapshot</a:t>
             </a:r>
           </a:p>
         </p:txBody>
@@ -16372,11 +16487,11 @@
                 <a:solidFill>
                   <a:srgbClr val="1B1F2A"/>
                 </a:solidFill>
-                <a:latin typeface="Aptos"/>
-              </a:defRPr>
-            </a:pPr>
-            <a:r>
-              <a:t>DApp-programmed disclosure model</a:t>
+                <a:latin typeface="Apple SD Gothic Neo"/>
+              </a:defRPr>
+            </a:pPr>
+            <a:r>
+              <a:t>DApp이 직접 설계하는 disclosure model</a:t>
             </a:r>
           </a:p>
         </p:txBody>
@@ -16424,8 +16539,8 @@
         </p:nvSpPr>
         <p:spPr>
           <a:xfrm>
-            <a:off x="4709160" y="5074920"/>
-            <a:ext cx="2743200" cy="228600"/>
+            <a:off x="4389120" y="5074920"/>
+            <a:ext cx="3383280" cy="228600"/>
           </a:xfrm>
           <a:prstGeom prst="rect">
             <a:avLst/>
@@ -16443,11 +16558,11 @@
                 <a:solidFill>
                   <a:srgbClr val="2563EB"/>
                 </a:solidFill>
-                <a:latin typeface="Aptos"/>
-              </a:defRPr>
-            </a:pPr>
-            <a:r>
-              <a:t>policy choice becomes explicit</a:t>
+                <a:latin typeface="Apple SD Gothic Neo"/>
+              </a:defRPr>
+            </a:pPr>
+            <a:r>
+              <a:t>policy choice가 명시적인 사용자 선택이 된다</a:t>
             </a:r>
           </a:p>
         </p:txBody>
@@ -16548,11 +16663,11 @@
                 <a:solidFill>
                   <a:srgbClr val="2563EB"/>
                 </a:solidFill>
-                <a:latin typeface="Aptos"/>
-              </a:defRPr>
-            </a:pPr>
-            <a:r>
-              <a:t>SYSTEM MODEL</a:t>
+                <a:latin typeface="Apple SD Gothic Neo"/>
+              </a:defRPr>
+            </a:pPr>
+            <a:r>
+              <a:t>시스템 모델</a:t>
             </a:r>
           </a:p>
         </p:txBody>
@@ -16566,7 +16681,7 @@
         <p:spPr>
           <a:xfrm>
             <a:off x="530352" y="804672"/>
-            <a:ext cx="8046720" cy="932688"/>
+            <a:ext cx="8046720" cy="640080"/>
           </a:xfrm>
           <a:prstGeom prst="rect">
             <a:avLst/>
@@ -16580,15 +16695,15 @@
           <a:lstStyle/>
           <a:p>
             <a:pPr>
-              <a:defRPr sz="2800" b="1">
+              <a:defRPr sz="3400" b="1">
                 <a:solidFill>
                   <a:srgbClr val="101828"/>
                 </a:solidFill>
-                <a:latin typeface="Aptos Display"/>
-              </a:defRPr>
-            </a:pPr>
-            <a:r>
-              <a:t>Actors, Contracts, and State Domains</a:t>
+                <a:latin typeface="Apple SD Gothic Neo"/>
+              </a:defRPr>
+            </a:pPr>
+            <a:r>
+              <a:t>참여자, 컨트랙트, 상태 도메인</a:t>
             </a:r>
           </a:p>
         </p:txBody>
@@ -16601,7 +16716,7 @@
         </p:nvSpPr>
         <p:spPr>
           <a:xfrm>
-            <a:off x="548640" y="1719072"/>
+            <a:off x="548640" y="1444752"/>
             <a:ext cx="7863840" cy="438912"/>
           </a:xfrm>
           <a:prstGeom prst="rect">
@@ -16620,11 +16735,11 @@
                 <a:solidFill>
                   <a:srgbClr val="5C667A"/>
                 </a:solidFill>
-                <a:latin typeface="Aptos"/>
-              </a:defRPr>
-            </a:pPr>
-            <a:r>
-              <a:t>The bridge fabric is shared, while each channel is a DApp-scoped execution domain.</a:t>
+                <a:latin typeface="Apple SD Gothic Neo"/>
+              </a:defRPr>
+            </a:pPr>
+            <a:r>
+              <a:t>브릿지 fabric은 공유되지만 각 채널은 DApp 단위의 실행 도메인이다.</a:t>
             </a:r>
           </a:p>
         </p:txBody>
@@ -16699,7 +16814,7 @@
                 <a:solidFill>
                   <a:srgbClr val="5C667A"/>
                 </a:solidFill>
-                <a:latin typeface="Aptos"/>
+                <a:latin typeface="Apple SD Gothic Neo"/>
               </a:defRPr>
             </a:pPr>
             <a:r>
@@ -16735,7 +16850,7 @@
                 <a:solidFill>
                   <a:srgbClr val="5C667A"/>
                 </a:solidFill>
-                <a:latin typeface="Aptos"/>
+                <a:latin typeface="Apple SD Gothic Neo"/>
               </a:defRPr>
             </a:pPr>
             <a:r>
@@ -16812,11 +16927,11 @@
           <a:lstStyle/>
           <a:p>
             <a:pPr algn="ctr">
-              <a:defRPr sz="1350" b="1">
+              <a:defRPr sz="1200" b="1">
                 <a:solidFill>
                   <a:srgbClr val="1B1F2A"/>
                 </a:solidFill>
-                <a:latin typeface="Aptos"/>
+                <a:latin typeface="Apple SD Gothic Neo"/>
               </a:defRPr>
             </a:pPr>
             <a:r>
@@ -16897,7 +17012,7 @@
                 <a:solidFill>
                   <a:srgbClr val="1B1F2A"/>
                 </a:solidFill>
-                <a:latin typeface="Aptos"/>
+                <a:latin typeface="Apple SD Gothic Neo"/>
               </a:defRPr>
             </a:pPr>
             <a:r>
@@ -16978,7 +17093,7 @@
                 <a:solidFill>
                   <a:srgbClr val="1B1F2A"/>
                 </a:solidFill>
-                <a:latin typeface="Aptos"/>
+                <a:latin typeface="Apple SD Gothic Neo"/>
               </a:defRPr>
             </a:pPr>
             <a:r>
@@ -17059,7 +17174,7 @@
                 <a:solidFill>
                   <a:srgbClr val="1B1F2A"/>
                 </a:solidFill>
-                <a:latin typeface="Aptos"/>
+                <a:latin typeface="Apple SD Gothic Neo"/>
               </a:defRPr>
             </a:pPr>
             <a:r>
@@ -17140,7 +17255,7 @@
                 <a:solidFill>
                   <a:srgbClr val="1B1F2A"/>
                 </a:solidFill>
-                <a:latin typeface="Aptos"/>
+                <a:latin typeface="Apple SD Gothic Neo"/>
               </a:defRPr>
             </a:pPr>
             <a:r>
@@ -17221,7 +17336,7 @@
                 <a:solidFill>
                   <a:srgbClr val="1B1F2A"/>
                 </a:solidFill>
-                <a:latin typeface="Aptos"/>
+                <a:latin typeface="Apple SD Gothic Neo"/>
               </a:defRPr>
             </a:pPr>
             <a:r>
@@ -17302,7 +17417,7 @@
                 <a:solidFill>
                   <a:srgbClr val="1B1F2A"/>
                 </a:solidFill>
-                <a:latin typeface="Aptos"/>
+                <a:latin typeface="Apple SD Gothic Neo"/>
               </a:defRPr>
             </a:pPr>
             <a:r>
@@ -17383,7 +17498,7 @@
                 <a:solidFill>
                   <a:srgbClr val="1B1F2A"/>
                 </a:solidFill>
-                <a:latin typeface="Aptos"/>
+                <a:latin typeface="Apple SD Gothic Neo"/>
               </a:defRPr>
             </a:pPr>
             <a:r>
@@ -17699,11 +17814,11 @@
                 <a:solidFill>
                   <a:srgbClr val="5C667A"/>
                 </a:solidFill>
-                <a:latin typeface="Aptos"/>
-              </a:defRPr>
-            </a:pPr>
-            <a:r>
-              <a:t>Shared L1 control plane</a:t>
+                <a:latin typeface="Apple SD Gothic Neo"/>
+              </a:defRPr>
+            </a:pPr>
+            <a:r>
+              <a:t>공유 L1 control plane</a:t>
             </a:r>
           </a:p>
         </p:txBody>
@@ -17735,11 +17850,11 @@
                 <a:solidFill>
                   <a:srgbClr val="5C667A"/>
                 </a:solidFill>
-                <a:latin typeface="Aptos"/>
-              </a:defRPr>
-            </a:pPr>
-            <a:r>
-              <a:t>Per-channel execution surface</a:t>
+                <a:latin typeface="Apple SD Gothic Neo"/>
+              </a:defRPr>
+            </a:pPr>
+            <a:r>
+              <a:t>채널별 실행 표면</a:t>
             </a:r>
           </a:p>
         </p:txBody>
@@ -17840,11 +17955,11 @@
                 <a:solidFill>
                   <a:srgbClr val="2563EB"/>
                 </a:solidFill>
-                <a:latin typeface="Aptos"/>
-              </a:defRPr>
-            </a:pPr>
-            <a:r>
-              <a:t>RESEARCH DIFFERENTIATION</a:t>
+                <a:latin typeface="Apple SD Gothic Neo"/>
+              </a:defRPr>
+            </a:pPr>
+            <a:r>
+              <a:t>연구 차별성</a:t>
             </a:r>
           </a:p>
         </p:txBody>
@@ -17876,11 +17991,11 @@
                 <a:solidFill>
                   <a:srgbClr val="101828"/>
                 </a:solidFill>
-                <a:latin typeface="Aptos Display"/>
-              </a:defRPr>
-            </a:pPr>
-            <a:r>
-              <a:t>What Is Different?</a:t>
+                <a:latin typeface="Apple SD Gothic Neo"/>
+              </a:defRPr>
+            </a:pPr>
+            <a:r>
+              <a:t>무엇이 다른가?</a:t>
             </a:r>
           </a:p>
         </p:txBody>
@@ -17912,11 +18027,11 @@
                 <a:solidFill>
                   <a:srgbClr val="5C667A"/>
                 </a:solidFill>
-                <a:latin typeface="Aptos"/>
-              </a:defRPr>
-            </a:pPr>
-            <a:r>
-              <a:t>The bridge is DApp-aware at admission time and DApp-agnostic at settlement time.</a:t>
+                <a:latin typeface="Apple SD Gothic Neo"/>
+              </a:defRPr>
+            </a:pPr>
+            <a:r>
+              <a:t>브릿지는 admission 시점에는 DApp-aware이고, 정산 시점에는 자산 보관 규칙을 일반화한다.</a:t>
             </a:r>
           </a:p>
         </p:txBody>
@@ -17991,7 +18106,7 @@
                 <a:solidFill>
                   <a:srgbClr val="5C667A"/>
                 </a:solidFill>
-                <a:latin typeface="Aptos"/>
+                <a:latin typeface="Apple SD Gothic Neo"/>
               </a:defRPr>
             </a:pPr>
             <a:r>
@@ -18027,7 +18142,7 @@
                 <a:solidFill>
                   <a:srgbClr val="5C667A"/>
                 </a:solidFill>
-                <a:latin typeface="Aptos"/>
+                <a:latin typeface="Apple SD Gothic Neo"/>
               </a:defRPr>
             </a:pPr>
             <a:r>
@@ -18151,7 +18266,7 @@
                 <a:solidFill>
                   <a:srgbClr val="1B1F2A"/>
                 </a:solidFill>
-                <a:latin typeface="Aptos Display"/>
+                <a:latin typeface="Apple SD Gothic Neo"/>
               </a:defRPr>
             </a:pPr>
             <a:r>
@@ -18187,11 +18302,11 @@
                 <a:solidFill>
                   <a:srgbClr val="5C667A"/>
                 </a:solidFill>
-                <a:latin typeface="Aptos"/>
-              </a:defRPr>
-            </a:pPr>
-            <a:r>
-              <a:t>Registered metadata defines the bridge vocabulary for function selectors, preprocess hashes, storage roots, and public-input offsets.</a:t>
+                <a:latin typeface="Apple SD Gothic Neo"/>
+              </a:defRPr>
+            </a:pPr>
+            <a:r>
+              <a:t>등록 metadata가 function selector, preprocess hash, storage root, public input offset에 대한 브릿지 vocabulary를 정의한다.</a:t>
             </a:r>
           </a:p>
         </p:txBody>
@@ -18311,7 +18426,7 @@
                 <a:solidFill>
                   <a:srgbClr val="1B1F2A"/>
                 </a:solidFill>
-                <a:latin typeface="Aptos Display"/>
+                <a:latin typeface="Apple SD Gothic Neo"/>
               </a:defRPr>
             </a:pPr>
             <a:r>
@@ -18347,11 +18462,11 @@
                 <a:solidFill>
                   <a:srgbClr val="5C667A"/>
                 </a:solidFill>
-                <a:latin typeface="Aptos"/>
-              </a:defRPr>
-            </a:pPr>
-            <a:r>
-              <a:t>Existing channels keep the verifier snapshot, function root, managed storage vector, and refund policy they accepted at creation.</a:t>
+                <a:latin typeface="Apple SD Gothic Neo"/>
+              </a:defRPr>
+            </a:pPr>
+            <a:r>
+              <a:t>기존 채널은 생성 시점에 수락한 verifier snapshot, function root, managed storage vector, refund policy를 유지한다.</a:t>
             </a:r>
           </a:p>
         </p:txBody>
@@ -18471,7 +18586,7 @@
                 <a:solidFill>
                   <a:srgbClr val="1B1F2A"/>
                 </a:solidFill>
-                <a:latin typeface="Aptos Display"/>
+                <a:latin typeface="Apple SD Gothic Neo"/>
               </a:defRPr>
             </a:pPr>
             <a:r>
@@ -18507,11 +18622,11 @@
                 <a:solidFill>
                   <a:srgbClr val="5C667A"/>
                 </a:solidFill>
-                <a:latin typeface="Aptos"/>
-              </a:defRPr>
-            </a:pPr>
-            <a:r>
-              <a:t>Tokamak proofs cover general DApp execution; Groth16 updateTree proofs cover channel-token-vault accounting.</a:t>
+                <a:latin typeface="Apple SD Gothic Neo"/>
+              </a:defRPr>
+            </a:pPr>
+            <a:r>
+              <a:t>Tokamak proof는 DApp 실행을, Groth16 updateTree proof는 channel-token-vault accounting을 담당한다.</a:t>
             </a:r>
           </a:p>
         </p:txBody>
@@ -18586,11 +18701,11 @@
                 <a:solidFill>
                   <a:srgbClr val="FFFFFF"/>
                 </a:solidFill>
-                <a:latin typeface="Aptos"/>
-              </a:defRPr>
-            </a:pPr>
-            <a:r>
-              <a:t>Research lens: validity proofs, metadata admission, and channel-local policy replace a monolithic rollup while preserving Ethereum settlement.</a:t>
+                <a:latin typeface="Apple SD Gothic Neo"/>
+              </a:defRPr>
+            </a:pPr>
+            <a:r>
+              <a:t>연구 관점: monolithic rollup 대신 validity proof, metadata admission, channel-local policy를 결합해 Ethereum 정산을 보존한다.</a:t>
             </a:r>
           </a:p>
         </p:txBody>
@@ -18691,7 +18806,7 @@
                 <a:solidFill>
                   <a:srgbClr val="2563EB"/>
                 </a:solidFill>
-                <a:latin typeface="Aptos"/>
+                <a:latin typeface="Apple SD Gothic Neo"/>
               </a:defRPr>
             </a:pPr>
             <a:r>
@@ -18709,7 +18824,7 @@
         <p:spPr>
           <a:xfrm>
             <a:off x="530352" y="804672"/>
-            <a:ext cx="8046720" cy="932688"/>
+            <a:ext cx="8046720" cy="640080"/>
           </a:xfrm>
           <a:prstGeom prst="rect">
             <a:avLst/>
@@ -18723,15 +18838,15 @@
           <a:lstStyle/>
           <a:p>
             <a:pPr>
-              <a:defRPr sz="2800" b="1">
+              <a:defRPr sz="3400" b="1">
                 <a:solidFill>
                   <a:srgbClr val="101828"/>
                 </a:solidFill>
-                <a:latin typeface="Aptos Display"/>
-              </a:defRPr>
-            </a:pPr>
-            <a:r>
-              <a:t>What Is Fixed at Channel Creation?</a:t>
+                <a:latin typeface="Apple SD Gothic Neo"/>
+              </a:defRPr>
+            </a:pPr>
+            <a:r>
+              <a:t>채널 생성 시 무엇이 고정되는가?</a:t>
             </a:r>
           </a:p>
         </p:txBody>
@@ -18744,7 +18859,7 @@
         </p:nvSpPr>
         <p:spPr>
           <a:xfrm>
-            <a:off x="548640" y="1719072"/>
+            <a:off x="548640" y="1444752"/>
             <a:ext cx="7863840" cy="438912"/>
           </a:xfrm>
           <a:prstGeom prst="rect">
@@ -18763,11 +18878,11 @@
                 <a:solidFill>
                   <a:srgbClr val="5C667A"/>
                 </a:solidFill>
-                <a:latin typeface="Aptos"/>
-              </a:defRPr>
-            </a:pPr>
-            <a:r>
-              <a:t>A channel snapshots the execution grammar that users are about to accept.</a:t>
+                <a:latin typeface="Apple SD Gothic Neo"/>
+              </a:defRPr>
+            </a:pPr>
+            <a:r>
+              <a:t>채널은 사용자가 수락하려는 실행 문법을 스냅샷으로 보존한다.</a:t>
             </a:r>
           </a:p>
         </p:txBody>
@@ -18842,7 +18957,7 @@
                 <a:solidFill>
                   <a:srgbClr val="5C667A"/>
                 </a:solidFill>
-                <a:latin typeface="Aptos"/>
+                <a:latin typeface="Apple SD Gothic Neo"/>
               </a:defRPr>
             </a:pPr>
             <a:r>
@@ -18878,7 +18993,7 @@
                 <a:solidFill>
                   <a:srgbClr val="5C667A"/>
                 </a:solidFill>
-                <a:latin typeface="Aptos"/>
+                <a:latin typeface="Apple SD Gothic Neo"/>
               </a:defRPr>
             </a:pPr>
             <a:r>
@@ -19002,7 +19117,7 @@
                 <a:solidFill>
                   <a:srgbClr val="1B1F2A"/>
                 </a:solidFill>
-                <a:latin typeface="Aptos"/>
+                <a:latin typeface="Apple SD Gothic Neo"/>
               </a:defRPr>
             </a:pPr>
             <a:r>
@@ -19126,7 +19241,7 @@
                 <a:solidFill>
                   <a:srgbClr val="1B1F2A"/>
                 </a:solidFill>
-                <a:latin typeface="Aptos"/>
+                <a:latin typeface="Apple SD Gothic Neo"/>
               </a:defRPr>
             </a:pPr>
             <a:r>
@@ -19250,7 +19365,7 @@
                 <a:solidFill>
                   <a:srgbClr val="1B1F2A"/>
                 </a:solidFill>
-                <a:latin typeface="Aptos"/>
+                <a:latin typeface="Apple SD Gothic Neo"/>
               </a:defRPr>
             </a:pPr>
             <a:r>
@@ -19374,7 +19489,7 @@
                 <a:solidFill>
                   <a:srgbClr val="1B1F2A"/>
                 </a:solidFill>
-                <a:latin typeface="Aptos"/>
+                <a:latin typeface="Apple SD Gothic Neo"/>
               </a:defRPr>
             </a:pPr>
             <a:r>
@@ -19498,7 +19613,7 @@
                 <a:solidFill>
                   <a:srgbClr val="1B1F2A"/>
                 </a:solidFill>
-                <a:latin typeface="Aptos"/>
+                <a:latin typeface="Apple SD Gothic Neo"/>
               </a:defRPr>
             </a:pPr>
             <a:r>
@@ -19622,7 +19737,7 @@
                 <a:solidFill>
                   <a:srgbClr val="1B1F2A"/>
                 </a:solidFill>
-                <a:latin typeface="Aptos"/>
+                <a:latin typeface="Apple SD Gothic Neo"/>
               </a:defRPr>
             </a:pPr>
             <a:r>
@@ -19746,11 +19861,11 @@
                 <a:solidFill>
                   <a:srgbClr val="1B1F2A"/>
                 </a:solidFill>
-                <a:latin typeface="Aptos"/>
-              </a:defRPr>
-            </a:pPr>
-            <a:r>
-              <a:t>genesis proof context</a:t>
+                <a:latin typeface="Apple SD Gothic Neo"/>
+              </a:defRPr>
+            </a:pPr>
+            <a:r>
+              <a:t>genesis aPubBlockHash</a:t>
             </a:r>
           </a:p>
         </p:txBody>
@@ -19782,11 +19897,11 @@
                 <a:solidFill>
                   <a:srgbClr val="2563EB"/>
                 </a:solidFill>
-                <a:latin typeface="Aptos"/>
-              </a:defRPr>
-            </a:pPr>
-            <a:r>
-              <a:t>Future metadata or verifier changes affect future channels; they do not silently rewrite already-created channels.</a:t>
+                <a:latin typeface="Apple SD Gothic Neo"/>
+              </a:defRPr>
+            </a:pPr>
+            <a:r>
+              <a:t>이후 metadata나 verifier가 바뀌어도 이미 생성된 채널의 정책은 조용히 재작성되지 않는다.</a:t>
             </a:r>
           </a:p>
         </p:txBody>
@@ -19887,11 +20002,11 @@
                 <a:solidFill>
                   <a:srgbClr val="2563EB"/>
                 </a:solidFill>
-                <a:latin typeface="Aptos"/>
-              </a:defRPr>
-            </a:pPr>
-            <a:r>
-              <a:t>BRIDGE ARCHITECTURE</a:t>
+                <a:latin typeface="Apple SD Gothic Neo"/>
+              </a:defRPr>
+            </a:pPr>
+            <a:r>
+              <a:t>브릿지 구조</a:t>
             </a:r>
           </a:p>
         </p:txBody>
@@ -19905,7 +20020,7 @@
         <p:spPr>
           <a:xfrm>
             <a:off x="530352" y="804672"/>
-            <a:ext cx="8046720" cy="932688"/>
+            <a:ext cx="8046720" cy="640080"/>
           </a:xfrm>
           <a:prstGeom prst="rect">
             <a:avLst/>
@@ -19919,15 +20034,15 @@
           <a:lstStyle/>
           <a:p>
             <a:pPr>
-              <a:defRPr sz="2800" b="1">
+              <a:defRPr sz="3400" b="1">
                 <a:solidFill>
                   <a:srgbClr val="101828"/>
                 </a:solidFill>
-                <a:latin typeface="Aptos Display"/>
-              </a:defRPr>
-            </a:pPr>
-            <a:r>
-              <a:t>Shared Control Plane, Isolated Channels</a:t>
+                <a:latin typeface="Apple SD Gothic Neo"/>
+              </a:defRPr>
+            </a:pPr>
+            <a:r>
+              <a:t>공유 Control Plane, 격리된 Channel</a:t>
             </a:r>
           </a:p>
         </p:txBody>
@@ -19940,7 +20055,7 @@
         </p:nvSpPr>
         <p:spPr>
           <a:xfrm>
-            <a:off x="548640" y="1719072"/>
+            <a:off x="548640" y="1444752"/>
             <a:ext cx="7863840" cy="438912"/>
           </a:xfrm>
           <a:prstGeom prst="rect">
@@ -19959,11 +20074,11 @@
                 <a:solidFill>
                   <a:srgbClr val="5C667A"/>
                 </a:solidFill>
-                <a:latin typeface="Aptos"/>
-              </a:defRPr>
-            </a:pPr>
-            <a:r>
-              <a:t>Root contracts coordinate custody and admission; channel managers track channel-local commitments.</a:t>
+                <a:latin typeface="Apple SD Gothic Neo"/>
+              </a:defRPr>
+            </a:pPr>
+            <a:r>
+              <a:t>루트 컨트랙트는 custody와 admission을 조정하고, ChannelManager는 채널별 commitment를 추적한다.</a:t>
             </a:r>
           </a:p>
         </p:txBody>
@@ -20038,7 +20153,7 @@
                 <a:solidFill>
                   <a:srgbClr val="5C667A"/>
                 </a:solidFill>
-                <a:latin typeface="Aptos"/>
+                <a:latin typeface="Apple SD Gothic Neo"/>
               </a:defRPr>
             </a:pPr>
             <a:r>
@@ -20074,7 +20189,7 @@
                 <a:solidFill>
                   <a:srgbClr val="5C667A"/>
                 </a:solidFill>
-                <a:latin typeface="Aptos"/>
+                <a:latin typeface="Apple SD Gothic Neo"/>
               </a:defRPr>
             </a:pPr>
             <a:r>
@@ -20155,11 +20270,11 @@
                 <a:solidFill>
                   <a:srgbClr val="1B1F2A"/>
                 </a:solidFill>
-                <a:latin typeface="Aptos Display"/>
-              </a:defRPr>
-            </a:pPr>
-            <a:r>
-              <a:t>Shared Ethereum Control Plane</a:t>
+                <a:latin typeface="Apple SD Gothic Neo"/>
+              </a:defRPr>
+            </a:pPr>
+            <a:r>
+              <a:t>공유 Ethereum Control Plane</a:t>
             </a:r>
           </a:p>
         </p:txBody>
@@ -20236,7 +20351,7 @@
                 <a:solidFill>
                   <a:srgbClr val="1B1F2A"/>
                 </a:solidFill>
-                <a:latin typeface="Aptos"/>
+                <a:latin typeface="Apple SD Gothic Neo"/>
               </a:defRPr>
             </a:pPr>
             <a:r>
@@ -20317,7 +20432,7 @@
                 <a:solidFill>
                   <a:srgbClr val="1B1F2A"/>
                 </a:solidFill>
-                <a:latin typeface="Aptos"/>
+                <a:latin typeface="Apple SD Gothic Neo"/>
               </a:defRPr>
             </a:pPr>
             <a:r>
@@ -20398,7 +20513,7 @@
                 <a:solidFill>
                   <a:srgbClr val="1B1F2A"/>
                 </a:solidFill>
-                <a:latin typeface="Aptos"/>
+                <a:latin typeface="Apple SD Gothic Neo"/>
               </a:defRPr>
             </a:pPr>
             <a:r>
@@ -20479,7 +20594,7 @@
                 <a:solidFill>
                   <a:srgbClr val="1B1F2A"/>
                 </a:solidFill>
-                <a:latin typeface="Aptos"/>
+                <a:latin typeface="Apple SD Gothic Neo"/>
               </a:defRPr>
             </a:pPr>
             <a:r>
@@ -20560,11 +20675,11 @@
                 <a:solidFill>
                   <a:srgbClr val="1B1F2A"/>
                 </a:solidFill>
-                <a:latin typeface="Aptos Display"/>
-              </a:defRPr>
-            </a:pPr>
-            <a:r>
-              <a:t>Per-Channel Execution Domains</a:t>
+                <a:latin typeface="Apple SD Gothic Neo"/>
+              </a:defRPr>
+            </a:pPr>
+            <a:r>
+              <a:t>채널별 실행 도메인</a:t>
             </a:r>
           </a:p>
         </p:txBody>
@@ -20637,11 +20752,11 @@
           <a:lstStyle/>
           <a:p>
             <a:pPr algn="ctr">
-              <a:defRPr sz="1100" b="1">
+              <a:defRPr sz="1050" b="1">
                 <a:solidFill>
                   <a:srgbClr val="1B1F2A"/>
                 </a:solidFill>
-                <a:latin typeface="Aptos"/>
+                <a:latin typeface="Apple SD Gothic Neo"/>
               </a:defRPr>
             </a:pPr>
             <a:r>
@@ -20650,11 +20765,11 @@
           </a:p>
           <a:p>
             <a:pPr algn="ctr">
-              <a:defRPr sz="1100" b="1">
+              <a:defRPr sz="1050" b="1">
                 <a:solidFill>
                   <a:srgbClr val="1B1F2A"/>
                 </a:solidFill>
-                <a:latin typeface="Aptos"/>
+                <a:latin typeface="Apple SD Gothic Neo"/>
               </a:defRPr>
             </a:pPr>
             <a:r>
@@ -20766,11 +20881,11 @@
           <a:lstStyle/>
           <a:p>
             <a:pPr algn="ctr">
-              <a:defRPr sz="1100" b="1">
+              <a:defRPr sz="1050" b="1">
                 <a:solidFill>
                   <a:srgbClr val="1B1F2A"/>
                 </a:solidFill>
-                <a:latin typeface="Aptos"/>
+                <a:latin typeface="Apple SD Gothic Neo"/>
               </a:defRPr>
             </a:pPr>
             <a:r>
@@ -20779,11 +20894,11 @@
           </a:p>
           <a:p>
             <a:pPr algn="ctr">
-              <a:defRPr sz="1100" b="1">
+              <a:defRPr sz="1050" b="1">
                 <a:solidFill>
                   <a:srgbClr val="1B1F2A"/>
                 </a:solidFill>
-                <a:latin typeface="Aptos"/>
+                <a:latin typeface="Apple SD Gothic Neo"/>
               </a:defRPr>
             </a:pPr>
             <a:r>
@@ -20895,11 +21010,11 @@
           <a:lstStyle/>
           <a:p>
             <a:pPr algn="ctr">
-              <a:defRPr sz="1100" b="1">
+              <a:defRPr sz="1050" b="1">
                 <a:solidFill>
                   <a:srgbClr val="1B1F2A"/>
                 </a:solidFill>
-                <a:latin typeface="Aptos"/>
+                <a:latin typeface="Apple SD Gothic Neo"/>
               </a:defRPr>
             </a:pPr>
             <a:r>
@@ -20908,11 +21023,11 @@
           </a:p>
           <a:p>
             <a:pPr algn="ctr">
-              <a:defRPr sz="1100" b="1">
+              <a:defRPr sz="1050" b="1">
                 <a:solidFill>
                   <a:srgbClr val="1B1F2A"/>
                 </a:solidFill>
-                <a:latin typeface="Aptos"/>
+                <a:latin typeface="Apple SD Gothic Neo"/>
               </a:defRPr>
             </a:pPr>
             <a:r>
@@ -20983,11 +21098,11 @@
                 <a:solidFill>
                   <a:srgbClr val="5C667A"/>
                 </a:solidFill>
-                <a:latin typeface="Aptos"/>
-              </a:defRPr>
-            </a:pPr>
-            <a:r>
-              <a:t>Isolation is the safety default: one channel should not rewrite another channel's accepted state.</a:t>
+                <a:latin typeface="Apple SD Gothic Neo"/>
+              </a:defRPr>
+            </a:pPr>
+            <a:r>
+              <a:t>기본 안전성은 isolation이다. 한 채널은 다른 채널이 수락한 상태 의미를 재작성할 수 없어야 한다.</a:t>
             </a:r>
           </a:p>
         </p:txBody>
@@ -21088,11 +21203,11 @@
                 <a:solidFill>
                   <a:srgbClr val="2563EB"/>
                 </a:solidFill>
-                <a:latin typeface="Aptos"/>
-              </a:defRPr>
-            </a:pPr>
-            <a:r>
-              <a:t>DAPP REGISTRATION</a:t>
+                <a:latin typeface="Apple SD Gothic Neo"/>
+              </a:defRPr>
+            </a:pPr>
+            <a:r>
+              <a:t>DAPP 등록</a:t>
             </a:r>
           </a:p>
         </p:txBody>
@@ -21106,7 +21221,7 @@
         <p:spPr>
           <a:xfrm>
             <a:off x="530352" y="804672"/>
-            <a:ext cx="8046720" cy="932688"/>
+            <a:ext cx="8046720" cy="640080"/>
           </a:xfrm>
           <a:prstGeom prst="rect">
             <a:avLst/>
@@ -21120,15 +21235,15 @@
           <a:lstStyle/>
           <a:p>
             <a:pPr>
-              <a:defRPr sz="2800" b="1">
+              <a:defRPr sz="3400" b="1">
                 <a:solidFill>
                   <a:srgbClr val="101828"/>
                 </a:solidFill>
-                <a:latin typeface="Aptos Display"/>
-              </a:defRPr>
-            </a:pPr>
-            <a:r>
-              <a:t>Metadata Is the Admission Boundary</a:t>
+                <a:latin typeface="Apple SD Gothic Neo"/>
+              </a:defRPr>
+            </a:pPr>
+            <a:r>
+              <a:t>Metadata가 Admission Boundary다</a:t>
             </a:r>
           </a:p>
         </p:txBody>
@@ -21141,7 +21256,7 @@
         </p:nvSpPr>
         <p:spPr>
           <a:xfrm>
-            <a:off x="548640" y="1719072"/>
+            <a:off x="548640" y="1444752"/>
             <a:ext cx="7863840" cy="438912"/>
           </a:xfrm>
           <a:prstGeom prst="rect">
@@ -21160,11 +21275,11 @@
                 <a:solidFill>
                   <a:srgbClr val="5C667A"/>
                 </a:solidFill>
-                <a:latin typeface="Aptos"/>
-              </a:defRPr>
-            </a:pPr>
-            <a:r>
-              <a:t>A Solidity function is not enough; the bridge admits only registered proof vocabulary.</a:t>
+                <a:latin typeface="Apple SD Gothic Neo"/>
+              </a:defRPr>
+            </a:pPr>
+            <a:r>
+              <a:t>Solidity 함수 존재만으로는 부족하다. 브릿지는 등록된 proof vocabulary만 받아들인다.</a:t>
             </a:r>
           </a:p>
         </p:txBody>
@@ -21239,7 +21354,7 @@
                 <a:solidFill>
                   <a:srgbClr val="5C667A"/>
                 </a:solidFill>
-                <a:latin typeface="Aptos"/>
+                <a:latin typeface="Apple SD Gothic Neo"/>
               </a:defRPr>
             </a:pPr>
             <a:r>
@@ -21275,7 +21390,7 @@
                 <a:solidFill>
                   <a:srgbClr val="5C667A"/>
                 </a:solidFill>
-                <a:latin typeface="Aptos"/>
+                <a:latin typeface="Apple SD Gothic Neo"/>
               </a:defRPr>
             </a:pPr>
             <a:r>
@@ -21356,11 +21471,11 @@
                 <a:solidFill>
                   <a:srgbClr val="1B1F2A"/>
                 </a:solidFill>
-                <a:latin typeface="Aptos Display"/>
-              </a:defRPr>
-            </a:pPr>
-            <a:r>
-              <a:t>Registration payload</a:t>
+                <a:latin typeface="Apple SD Gothic Neo"/>
+              </a:defRPr>
+            </a:pPr>
+            <a:r>
+              <a:t>등록 payload</a:t>
             </a:r>
           </a:p>
         </p:txBody>
@@ -21431,11 +21546,11 @@
           <a:lstStyle/>
           <a:p>
             <a:pPr>
-              <a:defRPr sz="1300" b="0">
+              <a:defRPr sz="1250" b="0">
                 <a:solidFill>
                   <a:srgbClr val="1B1F2A"/>
                 </a:solidFill>
-                <a:latin typeface="Aptos"/>
+                <a:latin typeface="Apple SD Gothic Neo"/>
               </a:defRPr>
             </a:pPr>
             <a:r>
@@ -21510,15 +21625,15 @@
           <a:lstStyle/>
           <a:p>
             <a:pPr>
-              <a:defRPr sz="1300" b="0">
+              <a:defRPr sz="1250" b="0">
                 <a:solidFill>
                   <a:srgbClr val="1B1F2A"/>
                 </a:solidFill>
-                <a:latin typeface="Aptos"/>
-              </a:defRPr>
-            </a:pPr>
-            <a:r>
-              <a:t>pre-allocated storage keys</a:t>
+                <a:latin typeface="Apple SD Gothic Neo"/>
+              </a:defRPr>
+            </a:pPr>
+            <a:r>
+              <a:t>정확히 하나의 channel-token-vault storage</a:t>
             </a:r>
           </a:p>
         </p:txBody>
@@ -21589,15 +21704,15 @@
           <a:lstStyle/>
           <a:p>
             <a:pPr>
-              <a:defRPr sz="1300" b="0">
+              <a:defRPr sz="1250" b="0">
                 <a:solidFill>
                   <a:srgbClr val="1B1F2A"/>
                 </a:solidFill>
-                <a:latin typeface="Aptos"/>
-              </a:defRPr>
-            </a:pPr>
-            <a:r>
-              <a:t>user storage slots</a:t>
+                <a:latin typeface="Apple SD Gothic Neo"/>
+              </a:defRPr>
+            </a:pPr>
+            <a:r>
+              <a:t>pre-allocated storage keys</a:t>
             </a:r>
           </a:p>
         </p:txBody>
@@ -21668,15 +21783,15 @@
           <a:lstStyle/>
           <a:p>
             <a:pPr>
-              <a:defRPr sz="1300" b="0">
+              <a:defRPr sz="1250" b="0">
                 <a:solidFill>
                   <a:srgbClr val="1B1F2A"/>
                 </a:solidFill>
-                <a:latin typeface="Aptos"/>
-              </a:defRPr>
-            </a:pPr>
-            <a:r>
-              <a:t>supported function list</a:t>
+                <a:latin typeface="Apple SD Gothic Neo"/>
+              </a:defRPr>
+            </a:pPr>
+            <a:r>
+              <a:t>user storage slots</a:t>
             </a:r>
           </a:p>
         </p:txBody>
@@ -21747,15 +21862,15 @@
           <a:lstStyle/>
           <a:p>
             <a:pPr>
-              <a:defRPr sz="1300" b="0">
+              <a:defRPr sz="1250" b="0">
                 <a:solidFill>
                   <a:srgbClr val="1B1F2A"/>
                 </a:solidFill>
-                <a:latin typeface="Aptos"/>
-              </a:defRPr>
-            </a:pPr>
-            <a:r>
-              <a:t>preprocess hash per function</a:t>
+                <a:latin typeface="Apple SD Gothic Neo"/>
+              </a:defRPr>
+            </a:pPr>
+            <a:r>
+              <a:t>supported function list</a:t>
             </a:r>
           </a:p>
         </p:txBody>
@@ -21826,15 +21941,15 @@
           <a:lstStyle/>
           <a:p>
             <a:pPr>
-              <a:defRPr sz="1300" b="0">
+              <a:defRPr sz="1250" b="0">
                 <a:solidFill>
                   <a:srgbClr val="1B1F2A"/>
                 </a:solidFill>
-                <a:latin typeface="Aptos"/>
-              </a:defRPr>
-            </a:pPr>
-            <a:r>
-              <a:t>instance layout offsets</a:t>
+                <a:latin typeface="Apple SD Gothic Neo"/>
+              </a:defRPr>
+            </a:pPr>
+            <a:r>
+              <a:t>function별 preprocess hash</a:t>
             </a:r>
           </a:p>
         </p:txBody>
@@ -21905,11 +22020,11 @@
           <a:lstStyle/>
           <a:p>
             <a:pPr>
-              <a:defRPr sz="1300" b="0">
+              <a:defRPr sz="1250" b="0">
                 <a:solidFill>
                   <a:srgbClr val="1B1F2A"/>
                 </a:solidFill>
-                <a:latin typeface="Aptos"/>
+                <a:latin typeface="Apple SD Gothic Neo"/>
               </a:defRPr>
             </a:pPr>
             <a:r>
@@ -21984,11 +22099,11 @@
           <a:lstStyle/>
           <a:p>
             <a:pPr>
-              <a:defRPr sz="1300" b="0">
+              <a:defRPr sz="1250" b="0">
                 <a:solidFill>
                   <a:srgbClr val="1B1F2A"/>
                 </a:solidFill>
-                <a:latin typeface="Aptos"/>
+                <a:latin typeface="Apple SD Gothic Neo"/>
               </a:defRPr>
             </a:pPr>
             <a:r>
@@ -22069,7 +22184,7 @@
                 <a:solidFill>
                   <a:srgbClr val="1B1F2A"/>
                 </a:solidFill>
-                <a:latin typeface="Aptos Display"/>
+                <a:latin typeface="Apple SD Gothic Neo"/>
               </a:defRPr>
             </a:pPr>
             <a:r>
@@ -22144,15 +22259,15 @@
           <a:lstStyle/>
           <a:p>
             <a:pPr>
-              <a:defRPr sz="1350" b="0">
+              <a:defRPr sz="1300" b="0">
                 <a:solidFill>
                   <a:srgbClr val="1B1F2A"/>
                 </a:solidFill>
-                <a:latin typeface="Aptos"/>
-              </a:defRPr>
-            </a:pPr>
-            <a:r>
-              <a:t>Does this DApp exist?</a:t>
+                <a:latin typeface="Apple SD Gothic Neo"/>
+              </a:defRPr>
+            </a:pPr>
+            <a:r>
+              <a:t>이 DApp이 등록되어 있는가?</a:t>
             </a:r>
           </a:p>
         </p:txBody>
@@ -22223,15 +22338,15 @@
           <a:lstStyle/>
           <a:p>
             <a:pPr>
-              <a:defRPr sz="1350" b="0">
+              <a:defRPr sz="1300" b="0">
                 <a:solidFill>
                   <a:srgbClr val="1B1F2A"/>
                 </a:solidFill>
-                <a:latin typeface="Aptos"/>
-              </a:defRPr>
-            </a:pPr>
-            <a:r>
-              <a:t>Is the function root admissible?</a:t>
+                <a:latin typeface="Apple SD Gothic Neo"/>
+              </a:defRPr>
+            </a:pPr>
+            <a:r>
+              <a:t>function root가 admissible한가?</a:t>
             </a:r>
           </a:p>
         </p:txBody>
@@ -22302,15 +22417,15 @@
           <a:lstStyle/>
           <a:p>
             <a:pPr>
-              <a:defRPr sz="1350" b="0">
+              <a:defRPr sz="1300" b="0">
                 <a:solidFill>
                   <a:srgbClr val="1B1F2A"/>
                 </a:solidFill>
-                <a:latin typeface="Aptos"/>
-              </a:defRPr>
-            </a:pPr>
-            <a:r>
-              <a:t>Does the preprocess hash match?</a:t>
+                <a:latin typeface="Apple SD Gothic Neo"/>
+              </a:defRPr>
+            </a:pPr>
+            <a:r>
+              <a:t>preprocess hash가 일치하는가?</a:t>
             </a:r>
           </a:p>
         </p:txBody>
@@ -22381,15 +22496,15 @@
           <a:lstStyle/>
           <a:p>
             <a:pPr>
-              <a:defRPr sz="1350" b="0">
+              <a:defRPr sz="1300" b="0">
                 <a:solidFill>
                   <a:srgbClr val="1B1F2A"/>
                 </a:solidFill>
-                <a:latin typeface="Aptos"/>
-              </a:defRPr>
-            </a:pPr>
-            <a:r>
-              <a:t>Do storage-write indices stay in the managed vector?</a:t>
+                <a:latin typeface="Apple SD Gothic Neo"/>
+              </a:defRPr>
+            </a:pPr>
+            <a:r>
+              <a:t>storage-write index가 managed vector 안에 있는가?</a:t>
             </a:r>
           </a:p>
         </p:txBody>
@@ -22460,15 +22575,15 @@
           <a:lstStyle/>
           <a:p>
             <a:pPr>
-              <a:defRPr sz="1350" b="0">
+              <a:defRPr sz="1300" b="0">
                 <a:solidFill>
                   <a:srgbClr val="1B1F2A"/>
                 </a:solidFill>
-                <a:latin typeface="Aptos"/>
-              </a:defRPr>
-            </a:pPr>
-            <a:r>
-              <a:t>Do public-input offsets decode expected fields?</a:t>
+                <a:latin typeface="Apple SD Gothic Neo"/>
+              </a:defRPr>
+            </a:pPr>
+            <a:r>
+              <a:t>event topic 수와 public input layout이 허용 범위인가?</a:t>
             </a:r>
           </a:p>
         </p:txBody>
@@ -22604,11 +22719,11 @@
                 <a:solidFill>
                   <a:srgbClr val="2563EB"/>
                 </a:solidFill>
-                <a:latin typeface="Aptos"/>
-              </a:defRPr>
-            </a:pPr>
-            <a:r>
-              <a:t>CHANNEL CREATION</a:t>
+                <a:latin typeface="Apple SD Gothic Neo"/>
+              </a:defRPr>
+            </a:pPr>
+            <a:r>
+              <a:t>채널 생성</a:t>
             </a:r>
           </a:p>
         </p:txBody>
@@ -22640,11 +22755,11 @@
                 <a:solidFill>
                   <a:srgbClr val="101828"/>
                 </a:solidFill>
-                <a:latin typeface="Aptos Display"/>
-              </a:defRPr>
-            </a:pPr>
-            <a:r>
-              <a:t>From Registered DApp to Live Channel</a:t>
+                <a:latin typeface="Apple SD Gothic Neo"/>
+              </a:defRPr>
+            </a:pPr>
+            <a:r>
+              <a:t>Registered DApp에서 Live Channel로</a:t>
             </a:r>
           </a:p>
         </p:txBody>
@@ -22676,11 +22791,11 @@
                 <a:solidFill>
                   <a:srgbClr val="5C667A"/>
                 </a:solidFill>
-                <a:latin typeface="Aptos"/>
-              </a:defRPr>
-            </a:pPr>
-            <a:r>
-              <a:t>Creation is permissionless at the bridge level after a DApp is registered.</a:t>
+                <a:latin typeface="Apple SD Gothic Neo"/>
+              </a:defRPr>
+            </a:pPr>
+            <a:r>
+              <a:t>DApp 등록 후에는 누구나 해당 metadata digest를 기대값으로 제시해 채널 생성을 요청할 수 있다.</a:t>
             </a:r>
           </a:p>
         </p:txBody>
@@ -22755,7 +22870,7 @@
                 <a:solidFill>
                   <a:srgbClr val="5C667A"/>
                 </a:solidFill>
-                <a:latin typeface="Aptos"/>
+                <a:latin typeface="Apple SD Gothic Neo"/>
               </a:defRPr>
             </a:pPr>
             <a:r>
@@ -22791,7 +22906,7 @@
                 <a:solidFill>
                   <a:srgbClr val="5C667A"/>
                 </a:solidFill>
-                <a:latin typeface="Aptos"/>
+                <a:latin typeface="Apple SD Gothic Neo"/>
               </a:defRPr>
             </a:pPr>
             <a:r>
@@ -22870,7 +22985,7 @@
                 <a:solidFill>
                   <a:srgbClr val="FFFFFF"/>
                 </a:solidFill>
-                <a:latin typeface="Aptos"/>
+                <a:latin typeface="Apple SD Gothic Neo"/>
               </a:defRPr>
             </a:pPr>
             <a:r>
@@ -22951,11 +23066,11 @@
                 <a:solidFill>
                   <a:srgbClr val="1B1F2A"/>
                 </a:solidFill>
-                <a:latin typeface="Aptos"/>
-              </a:defRPr>
-            </a:pPr>
-            <a:r>
-              <a:t>Check DApp metadata</a:t>
+                <a:latin typeface="Apple SD Gothic Neo"/>
+              </a:defRPr>
+            </a:pPr>
+            <a:r>
+              <a:t>metadata digest 확인</a:t>
             </a:r>
           </a:p>
         </p:txBody>
@@ -23065,7 +23180,7 @@
                 <a:solidFill>
                   <a:srgbClr val="FFFFFF"/>
                 </a:solidFill>
-                <a:latin typeface="Aptos"/>
+                <a:latin typeface="Apple SD Gothic Neo"/>
               </a:defRPr>
             </a:pPr>
             <a:r>
@@ -23146,11 +23261,11 @@
                 <a:solidFill>
                   <a:srgbClr val="1B1F2A"/>
                 </a:solidFill>
-                <a:latin typeface="Aptos"/>
-              </a:defRPr>
-            </a:pPr>
-            <a:r>
-              <a:t>Bind leader and asset</a:t>
+                <a:latin typeface="Apple SD Gothic Neo"/>
+              </a:defRPr>
+            </a:pPr>
+            <a:r>
+              <a:t>leader와 asset binding</a:t>
             </a:r>
           </a:p>
         </p:txBody>
@@ -23260,7 +23375,7 @@
                 <a:solidFill>
                   <a:srgbClr val="FFFFFF"/>
                 </a:solidFill>
-                <a:latin typeface="Aptos"/>
+                <a:latin typeface="Apple SD Gothic Neo"/>
               </a:defRPr>
             </a:pPr>
             <a:r>
@@ -23341,11 +23456,11 @@
                 <a:solidFill>
                   <a:srgbClr val="1B1F2A"/>
                 </a:solidFill>
-                <a:latin typeface="Aptos"/>
-              </a:defRPr>
-            </a:pPr>
-            <a:r>
-              <a:t>Snapshot verifiers and function root</a:t>
+                <a:latin typeface="Apple SD Gothic Neo"/>
+              </a:defRPr>
+            </a:pPr>
+            <a:r>
+              <a:t>verifier와 function root snapshot</a:t>
             </a:r>
           </a:p>
         </p:txBody>
@@ -23455,7 +23570,7 @@
                 <a:solidFill>
                   <a:srgbClr val="FFFFFF"/>
                 </a:solidFill>
-                <a:latin typeface="Aptos"/>
+                <a:latin typeface="Apple SD Gothic Neo"/>
               </a:defRPr>
             </a:pPr>
             <a:r>
@@ -23536,11 +23651,11 @@
                 <a:solidFill>
                   <a:srgbClr val="1B1F2A"/>
                 </a:solidFill>
-                <a:latin typeface="Aptos"/>
-              </a:defRPr>
-            </a:pPr>
-            <a:r>
-              <a:t>Deploy ChannelManager</a:t>
+                <a:latin typeface="Apple SD Gothic Neo"/>
+              </a:defRPr>
+            </a:pPr>
+            <a:r>
+              <a:t>ChannelManager 배포</a:t>
             </a:r>
           </a:p>
         </p:txBody>
@@ -23650,7 +23765,7 @@
                 <a:solidFill>
                   <a:srgbClr val="FFFFFF"/>
                 </a:solidFill>
-                <a:latin typeface="Aptos"/>
+                <a:latin typeface="Apple SD Gothic Neo"/>
               </a:defRPr>
             </a:pPr>
             <a:r>
@@ -23731,11 +23846,11 @@
                 <a:solidFill>
                   <a:srgbClr val="1B1F2A"/>
                 </a:solidFill>
-                <a:latin typeface="Aptos"/>
-              </a:defRPr>
-            </a:pPr>
-            <a:r>
-              <a:t>Initialize commitment and proof context</a:t>
+                <a:latin typeface="Apple SD Gothic Neo"/>
+              </a:defRPr>
+            </a:pPr>
+            <a:r>
+              <a:t>root hash와 aPubBlockHash 초기화</a:t>
             </a:r>
           </a:p>
         </p:txBody>
@@ -23767,11 +23882,11 @@
                 <a:solidFill>
                   <a:srgbClr val="5C667A"/>
                 </a:solidFill>
-                <a:latin typeface="Aptos"/>
-              </a:defRPr>
-            </a:pPr>
-            <a:r>
-              <a:t>The creator chooses only exposed channel parameters. The execution grammar comes from registration metadata.</a:t>
+                <a:latin typeface="Apple SD Gothic Neo"/>
+              </a:defRPr>
+            </a:pPr>
+            <a:r>
+              <a:t>생성자는 exposed channel parameter만 선택한다. 실행 문법은 등록 metadata와 verifier snapshot에서 온다.</a:t>
             </a:r>
           </a:p>
         </p:txBody>

</xml_diff>

<commit_message>
Fix bridge deck system model layout
</commit_message>
<xml_diff>
--- a/bridge/docs/dev/spec.pptx
+++ b/bridge/docs/dev/spec.pptx
@@ -16867,7 +16867,7 @@
         </p:nvSpPr>
         <p:spPr>
           <a:xfrm>
-            <a:off x="667512" y="2633472"/>
+            <a:off x="667512" y="2926080"/>
             <a:ext cx="1810512" cy="658368"/>
           </a:xfrm>
           <a:prstGeom prst="roundRect">
@@ -16912,7 +16912,7 @@
         </p:nvSpPr>
         <p:spPr>
           <a:xfrm>
-            <a:off x="731520" y="2706624"/>
+            <a:off x="731520" y="2999232"/>
             <a:ext cx="1682495" cy="512063"/>
           </a:xfrm>
           <a:prstGeom prst="rect">
@@ -16948,7 +16948,7 @@
         </p:nvSpPr>
         <p:spPr>
           <a:xfrm>
-            <a:off x="3255264" y="1828800"/>
+            <a:off x="3255264" y="2139696"/>
             <a:ext cx="1673352" cy="603504"/>
           </a:xfrm>
           <a:prstGeom prst="roundRect">
@@ -16993,7 +16993,7 @@
         </p:nvSpPr>
         <p:spPr>
           <a:xfrm>
-            <a:off x="3319272" y="1901952"/>
+            <a:off x="3319272" y="2212848"/>
             <a:ext cx="1545336" cy="457200"/>
           </a:xfrm>
           <a:prstGeom prst="rect">
@@ -17029,7 +17029,7 @@
         </p:nvSpPr>
         <p:spPr>
           <a:xfrm>
-            <a:off x="3255264" y="2962656"/>
+            <a:off x="3255264" y="3246120"/>
             <a:ext cx="1673352" cy="603504"/>
           </a:xfrm>
           <a:prstGeom prst="roundRect">
@@ -17074,7 +17074,7 @@
         </p:nvSpPr>
         <p:spPr>
           <a:xfrm>
-            <a:off x="3319272" y="3035808"/>
+            <a:off x="3319272" y="3319272"/>
             <a:ext cx="1545336" cy="457200"/>
           </a:xfrm>
           <a:prstGeom prst="rect">
@@ -17110,7 +17110,7 @@
         </p:nvSpPr>
         <p:spPr>
           <a:xfrm>
-            <a:off x="3255264" y="4096512"/>
+            <a:off x="3255264" y="4352544"/>
             <a:ext cx="1673352" cy="603504"/>
           </a:xfrm>
           <a:prstGeom prst="roundRect">
@@ -17155,7 +17155,7 @@
         </p:nvSpPr>
         <p:spPr>
           <a:xfrm>
-            <a:off x="3319272" y="4169664"/>
+            <a:off x="3319272" y="4425696"/>
             <a:ext cx="1545336" cy="457200"/>
           </a:xfrm>
           <a:prstGeom prst="rect">
@@ -17191,7 +17191,7 @@
         </p:nvSpPr>
         <p:spPr>
           <a:xfrm>
-            <a:off x="5833872" y="2633472"/>
+            <a:off x="5833872" y="2926080"/>
             <a:ext cx="1993392" cy="658368"/>
           </a:xfrm>
           <a:prstGeom prst="roundRect">
@@ -17236,7 +17236,7 @@
         </p:nvSpPr>
         <p:spPr>
           <a:xfrm>
-            <a:off x="5897880" y="2706624"/>
+            <a:off x="5897880" y="2999232"/>
             <a:ext cx="1865376" cy="512063"/>
           </a:xfrm>
           <a:prstGeom prst="rect">
@@ -17272,7 +17272,7 @@
         </p:nvSpPr>
         <p:spPr>
           <a:xfrm>
-            <a:off x="8631936" y="1965960"/>
+            <a:off x="8631936" y="2286000"/>
             <a:ext cx="1883664" cy="548640"/>
           </a:xfrm>
           <a:prstGeom prst="roundRect">
@@ -17317,7 +17317,7 @@
         </p:nvSpPr>
         <p:spPr>
           <a:xfrm>
-            <a:off x="8695944" y="2039112"/>
+            <a:off x="8695944" y="2359152"/>
             <a:ext cx="1755648" cy="402335"/>
           </a:xfrm>
           <a:prstGeom prst="rect">
@@ -17353,7 +17353,7 @@
         </p:nvSpPr>
         <p:spPr>
           <a:xfrm>
-            <a:off x="8631936" y="3310128"/>
+            <a:off x="8631936" y="3611880"/>
             <a:ext cx="1883664" cy="548640"/>
           </a:xfrm>
           <a:prstGeom prst="roundRect">
@@ -17398,7 +17398,7 @@
         </p:nvSpPr>
         <p:spPr>
           <a:xfrm>
-            <a:off x="8695944" y="3383280"/>
+            <a:off x="8695944" y="3685032"/>
             <a:ext cx="1755648" cy="402335"/>
           </a:xfrm>
           <a:prstGeom prst="rect">
@@ -17434,7 +17434,7 @@
         </p:nvSpPr>
         <p:spPr>
           <a:xfrm>
-            <a:off x="8631936" y="4654296"/>
+            <a:off x="8631936" y="4937760"/>
             <a:ext cx="1883664" cy="548640"/>
           </a:xfrm>
           <a:prstGeom prst="roundRect">
@@ -17479,7 +17479,7 @@
         </p:nvSpPr>
         <p:spPr>
           <a:xfrm>
-            <a:off x="8695944" y="4727448"/>
+            <a:off x="8695944" y="5010912"/>
             <a:ext cx="1755648" cy="402335"/>
           </a:xfrm>
           <a:prstGeom prst="rect">
@@ -17515,8 +17515,8 @@
         </p:nvCxnSpPr>
         <p:spPr>
           <a:xfrm flipV="1">
-            <a:off x="2478024" y="2130552"/>
-            <a:ext cx="777240" cy="822960"/>
+            <a:off x="2478024" y="2441448"/>
+            <a:ext cx="777240" cy="813816"/>
           </a:xfrm>
           <a:prstGeom prst="line">
             <a:avLst/>
@@ -17550,8 +17550,8 @@
         </p:nvCxnSpPr>
         <p:spPr>
           <a:xfrm>
-            <a:off x="2478024" y="2953512"/>
-            <a:ext cx="777240" cy="310896"/>
+            <a:off x="2478024" y="3255264"/>
+            <a:ext cx="777240" cy="292608"/>
           </a:xfrm>
           <a:prstGeom prst="line">
             <a:avLst/>
@@ -17585,8 +17585,8 @@
         </p:nvCxnSpPr>
         <p:spPr>
           <a:xfrm>
-            <a:off x="4928616" y="2130552"/>
-            <a:ext cx="905256" cy="822960"/>
+            <a:off x="4928616" y="2441448"/>
+            <a:ext cx="905256" cy="813816"/>
           </a:xfrm>
           <a:prstGeom prst="line">
             <a:avLst/>
@@ -17620,8 +17620,8 @@
         </p:nvCxnSpPr>
         <p:spPr>
           <a:xfrm flipV="1">
-            <a:off x="4928616" y="2953512"/>
-            <a:ext cx="905256" cy="310896"/>
+            <a:off x="4928616" y="3255264"/>
+            <a:ext cx="905256" cy="292608"/>
           </a:xfrm>
           <a:prstGeom prst="line">
             <a:avLst/>
@@ -17655,8 +17655,8 @@
         </p:nvCxnSpPr>
         <p:spPr>
           <a:xfrm flipV="1">
-            <a:off x="4928616" y="2953512"/>
-            <a:ext cx="905256" cy="1444752"/>
+            <a:off x="4928616" y="3255264"/>
+            <a:ext cx="905256" cy="1399032"/>
           </a:xfrm>
           <a:prstGeom prst="line">
             <a:avLst/>
@@ -17690,8 +17690,8 @@
         </p:nvCxnSpPr>
         <p:spPr>
           <a:xfrm flipV="1">
-            <a:off x="7827264" y="2240280"/>
-            <a:ext cx="804672" cy="713232"/>
+            <a:off x="7827264" y="2560320"/>
+            <a:ext cx="804672" cy="694944"/>
           </a:xfrm>
           <a:prstGeom prst="line">
             <a:avLst/>
@@ -17725,7 +17725,7 @@
         </p:nvCxnSpPr>
         <p:spPr>
           <a:xfrm>
-            <a:off x="7827264" y="2953512"/>
+            <a:off x="7827264" y="3255264"/>
             <a:ext cx="804672" cy="630936"/>
           </a:xfrm>
           <a:prstGeom prst="line">
@@ -17760,8 +17760,8 @@
         </p:nvCxnSpPr>
         <p:spPr>
           <a:xfrm>
-            <a:off x="7827264" y="2953512"/>
-            <a:ext cx="804672" cy="1975104"/>
+            <a:off x="7827264" y="3255264"/>
+            <a:ext cx="804672" cy="1956816"/>
           </a:xfrm>
           <a:prstGeom prst="line">
             <a:avLst/>
@@ -17795,8 +17795,8 @@
         </p:nvSpPr>
         <p:spPr>
           <a:xfrm>
-            <a:off x="3017520" y="1335024"/>
-            <a:ext cx="2468880" cy="182880"/>
+            <a:off x="2926080" y="1847088"/>
+            <a:ext cx="2697480" cy="182880"/>
           </a:xfrm>
           <a:prstGeom prst="rect">
             <a:avLst/>
@@ -17831,8 +17831,8 @@
         </p:nvSpPr>
         <p:spPr>
           <a:xfrm>
-            <a:off x="5577840" y="2130552"/>
-            <a:ext cx="2560320" cy="182880"/>
+            <a:off x="5559552" y="2395728"/>
+            <a:ext cx="2697480" cy="182880"/>
           </a:xfrm>
           <a:prstGeom prst="rect">
             <a:avLst/>

</xml_diff>

<commit_message>
Add finite leaf lifecycle analysis to bridge deck
</commit_message>
<xml_diff>
--- a/bridge/docs/dev/spec.pptx
+++ b/bridge/docs/dev/spec.pptx
@@ -12961,7 +12961,7 @@
               </a:defRPr>
             </a:pPr>
             <a:r>
-              <a:t>열린 연구 및 엔지니어링 질문</a:t>
+              <a:t>Finite Leaf와 Channel Lifecycle</a:t>
             </a:r>
           </a:p>
         </p:txBody>
@@ -12997,7 +12997,7 @@
               </a:defRPr>
             </a:pPr>
             <a:r>
-              <a:t>이 설계는 일부 global flexibility보다 explicit policy와 isolation을 선택한다.</a:t>
+              <a:t>finite Merkle tree는 key collision risk를 만들고, join toll refund schedule은 slot 점유 비용을 시간 함수로 만든다.</a:t>
             </a:r>
           </a:p>
         </p:txBody>
@@ -13125,8 +13125,8 @@
         </p:nvSpPr>
         <p:spPr>
           <a:xfrm>
-            <a:off x="859536" y="2176272"/>
-            <a:ext cx="4956048" cy="1261872"/>
+            <a:off x="841248" y="2048256"/>
+            <a:ext cx="4645152" cy="3346704"/>
           </a:xfrm>
           <a:prstGeom prst="roundRect">
             <a:avLst/>
@@ -13164,20 +13164,56 @@
       </p:sp>
       <p:sp>
         <p:nvSpPr>
-          <p:cNvPr id="10" name="Rectangle 9"/>
+          <p:cNvPr id="10" name="TextBox 9"/>
+          <p:cNvSpPr txBox="1"/>
+          <p:nvPr/>
+        </p:nvSpPr>
+        <p:spPr>
+          <a:xfrm>
+            <a:off x="1078992" y="2267712"/>
+            <a:ext cx="4023360" cy="237744"/>
+          </a:xfrm>
+          <a:prstGeom prst="rect">
+            <a:avLst/>
+          </a:prstGeom>
+          <a:noFill/>
+        </p:spPr>
+        <p:txBody>
+          <a:bodyPr wrap="square" lIns="18288" rIns="18288" tIns="9144" bIns="9144" anchor="t">
+            <a:spAutoFit/>
+          </a:bodyPr>
+          <a:lstStyle/>
+          <a:p>
+            <a:pPr>
+              <a:defRPr sz="1500" b="1">
+                <a:solidFill>
+                  <a:srgbClr val="1B1F2A"/>
+                </a:solidFill>
+                <a:latin typeface="Apple SD Gothic Neo"/>
+              </a:defRPr>
+            </a:pPr>
+            <a:r>
+              <a:t>현재 구현의 leaf projection</a:t>
+            </a:r>
+          </a:p>
+        </p:txBody>
+      </p:sp>
+      <p:sp>
+        <p:nvSpPr>
+          <p:cNvPr id="11" name="Rounded Rectangle 10"/>
           <p:cNvSpPr/>
           <p:nvPr/>
         </p:nvSpPr>
         <p:spPr>
           <a:xfrm>
-            <a:off x="859536" y="2176272"/>
-            <a:ext cx="45720" cy="1261872"/>
-          </a:xfrm>
-          <a:prstGeom prst="rect">
+            <a:off x="1078992" y="2670048"/>
+            <a:ext cx="4059936" cy="786384"/>
+          </a:xfrm>
+          <a:prstGeom prst="roundRect">
             <a:avLst/>
           </a:prstGeom>
           <a:solidFill>
-            <a:srgbClr val="2563EB"/>
+            <a:srgbClr val="152238"/>
           </a:solidFill>
           <a:ln>
             <a:noFill/>
@@ -13207,14 +13243,63 @@
       </p:sp>
       <p:sp>
         <p:nvSpPr>
-          <p:cNvPr id="11" name="TextBox 10"/>
-          <p:cNvSpPr txBox="1"/>
-          <p:nvPr/>
-        </p:nvSpPr>
-        <p:spPr>
-          <a:xfrm>
-            <a:off x="1060704" y="2340864"/>
-            <a:ext cx="4553712" cy="256032"/>
+          <p:cNvPr id="12" name="TextBox 11"/>
+          <p:cNvSpPr txBox="1"/>
+          <p:nvPr/>
+        </p:nvSpPr>
+        <p:spPr>
+          <a:xfrm>
+            <a:off x="1234440" y="2816352"/>
+            <a:ext cx="3749039" cy="420624"/>
+          </a:xfrm>
+          <a:prstGeom prst="rect">
+            <a:avLst/>
+          </a:prstGeom>
+          <a:noFill/>
+        </p:spPr>
+        <p:txBody>
+          <a:bodyPr wrap="square" lIns="18288" rIns="18288" tIns="9144" bIns="9144" anchor="ctr">
+            <a:spAutoFit/>
+          </a:bodyPr>
+          <a:lstStyle/>
+          <a:p>
+            <a:pPr algn="ctr">
+              <a:defRPr sz="1500" b="1">
+                <a:solidFill>
+                  <a:srgbClr val="FFFFFF"/>
+                </a:solidFill>
+                <a:latin typeface="Apple SD Gothic Neo"/>
+              </a:defRPr>
+            </a:pPr>
+            <a:r>
+              <a:t>N = 2^d,   d = 36</a:t>
+            </a:r>
+          </a:p>
+          <a:p>
+            <a:pPr algn="ctr">
+              <a:defRPr sz="1500" b="1">
+                <a:solidFill>
+                  <a:srgbClr val="FFFFFF"/>
+                </a:solidFill>
+                <a:latin typeface="Apple SD Gothic Neo"/>
+              </a:defRPr>
+            </a:pPr>
+            <a:r>
+              <a:t>LeafIndex(k) = k mod N</a:t>
+            </a:r>
+          </a:p>
+        </p:txBody>
+      </p:sp>
+      <p:sp>
+        <p:nvSpPr>
+          <p:cNvPr id="13" name="TextBox 12"/>
+          <p:cNvSpPr txBox="1"/>
+          <p:nvPr/>
+        </p:nvSpPr>
+        <p:spPr>
+          <a:xfrm>
+            <a:off x="1078992" y="3685032"/>
+            <a:ext cx="4114800" cy="329184"/>
           </a:xfrm>
           <a:prstGeom prst="rect">
             <a:avLst/>
@@ -13228,7 +13313,88 @@
           <a:lstStyle/>
           <a:p>
             <a:pPr>
-              <a:defRPr sz="1600" b="1">
+              <a:defRPr sz="1180" b="0">
+                <a:solidFill>
+                  <a:srgbClr val="5C667A"/>
+                </a:solidFill>
+                <a:latin typeface="Apple SD Gothic Neo"/>
+              </a:defRPr>
+            </a:pPr>
+            <a:r>
+              <a:t>고정된 future nullifier leaf에 대해, 미래 storage key가 Poisson rate λ로 도착하면:</a:t>
+            </a:r>
+          </a:p>
+        </p:txBody>
+      </p:sp>
+      <p:sp>
+        <p:nvSpPr>
+          <p:cNvPr id="14" name="Rounded Rectangle 13"/>
+          <p:cNvSpPr/>
+          <p:nvPr/>
+        </p:nvSpPr>
+        <p:spPr>
+          <a:xfrm>
+            <a:off x="1078992" y="4059936"/>
+            <a:ext cx="4059936" cy="512064"/>
+          </a:xfrm>
+          <a:prstGeom prst="roundRect">
+            <a:avLst/>
+          </a:prstGeom>
+          <a:solidFill>
+            <a:srgbClr val="F6F8FC"/>
+          </a:solidFill>
+          <a:ln w="12700">
+            <a:solidFill>
+              <a:srgbClr val="D8DDE6"/>
+            </a:solidFill>
+          </a:ln>
+        </p:spPr>
+        <p:style>
+          <a:lnRef idx="1">
+            <a:schemeClr val="accent1"/>
+          </a:lnRef>
+          <a:fillRef idx="3">
+            <a:schemeClr val="accent1"/>
+          </a:fillRef>
+          <a:effectRef idx="2">
+            <a:schemeClr val="accent1"/>
+          </a:effectRef>
+          <a:fontRef idx="minor">
+            <a:schemeClr val="lt1"/>
+          </a:fontRef>
+        </p:style>
+        <p:txBody>
+          <a:bodyPr rtlCol="0" anchor="ctr"/>
+          <a:lstStyle/>
+          <a:p>
+            <a:pPr algn="ctr"/>
+          </a:p>
+        </p:txBody>
+      </p:sp>
+      <p:sp>
+        <p:nvSpPr>
+          <p:cNvPr id="15" name="TextBox 14"/>
+          <p:cNvSpPr txBox="1"/>
+          <p:nvPr/>
+        </p:nvSpPr>
+        <p:spPr>
+          <a:xfrm>
+            <a:off x="1188720" y="4215384"/>
+            <a:ext cx="3840480" cy="201168"/>
+          </a:xfrm>
+          <a:prstGeom prst="rect">
+            <a:avLst/>
+          </a:prstGeom>
+          <a:noFill/>
+        </p:spPr>
+        <p:txBody>
+          <a:bodyPr wrap="square" lIns="18288" rIns="18288" tIns="9144" bIns="9144" anchor="ctr">
+            <a:spAutoFit/>
+          </a:bodyPr>
+          <a:lstStyle/>
+          <a:p>
+            <a:pPr algn="ctr">
+              <a:defRPr sz="1220" b="1">
                 <a:solidFill>
                   <a:srgbClr val="1B1F2A"/>
                 </a:solidFill>
@@ -13236,21 +13402,21 @@
               </a:defRPr>
             </a:pPr>
             <a:r>
-              <a:t>Isolation vs composability</a:t>
-            </a:r>
-          </a:p>
-        </p:txBody>
-      </p:sp>
-      <p:sp>
-        <p:nvSpPr>
-          <p:cNvPr id="12" name="TextBox 11"/>
-          <p:cNvSpPr txBox="1"/>
-          <p:nvPr/>
-        </p:nvSpPr>
-        <p:spPr>
-          <a:xfrm>
-            <a:off x="1060704" y="2724912"/>
-            <a:ext cx="4553712" cy="603503"/>
+              <a:t>P_collision(t) = 1 - exp(-λ · 1440t · 2^-d)</a:t>
+            </a:r>
+          </a:p>
+        </p:txBody>
+      </p:sp>
+      <p:sp>
+        <p:nvSpPr>
+          <p:cNvPr id="16" name="TextBox 15"/>
+          <p:cNvSpPr txBox="1"/>
+          <p:nvPr/>
+        </p:nvSpPr>
+        <p:spPr>
+          <a:xfrm>
+            <a:off x="1078992" y="4718304"/>
+            <a:ext cx="4069080" cy="347472"/>
           </a:xfrm>
           <a:prstGeom prst="rect">
             <a:avLst/>
@@ -13264,7 +13430,7 @@
           <a:lstStyle/>
           <a:p>
             <a:pPr>
-              <a:defRPr sz="1250" b="0">
+              <a:defRPr sz="1070" b="0">
                 <a:solidFill>
                   <a:srgbClr val="5C667A"/>
                 </a:solidFill>
@@ -13272,21 +13438,21 @@
               </a:defRPr>
             </a:pPr>
             <a:r>
-              <a:t>per-channel execution은 강한 safety boundary를 주지만, cross-channel composition이 주된 최적화 대상은 아니다.</a:t>
-            </a:r>
-          </a:p>
-        </p:txBody>
-      </p:sp>
-      <p:sp>
-        <p:nvSpPr>
-          <p:cNvPr id="13" name="Rounded Rectangle 12"/>
+              <a:t>t는 days 단위. 그래프는 λ = 1 leaf/minute 모델이며, 보라색 선이 current d = 36이다.</a:t>
+            </a:r>
+          </a:p>
+        </p:txBody>
+      </p:sp>
+      <p:sp>
+        <p:nvSpPr>
+          <p:cNvPr id="17" name="Rounded Rectangle 16"/>
           <p:cNvSpPr/>
           <p:nvPr/>
         </p:nvSpPr>
         <p:spPr>
           <a:xfrm>
-            <a:off x="6382512" y="2176272"/>
-            <a:ext cx="4956048" cy="1261872"/>
+            <a:off x="5806440" y="2029968"/>
+            <a:ext cx="5413248" cy="3401568"/>
           </a:xfrm>
           <a:prstGeom prst="roundRect">
             <a:avLst/>
@@ -13322,22 +13488,46 @@
           </a:p>
         </p:txBody>
       </p:sp>
-      <p:sp>
-        <p:nvSpPr>
-          <p:cNvPr id="14" name="Rectangle 13"/>
+      <p:pic>
+        <p:nvPicPr>
+          <p:cNvPr id="18" name="Picture 17" descr="collision-probability.png"/>
+          <p:cNvPicPr>
+            <a:picLocks noChangeAspect="1"/>
+          </p:cNvPicPr>
+          <p:nvPr/>
+        </p:nvPicPr>
+        <p:blipFill>
+          <a:blip r:embed="rId2"/>
+          <a:stretch>
+            <a:fillRect/>
+          </a:stretch>
+        </p:blipFill>
+        <p:spPr>
+          <a:xfrm>
+            <a:off x="5971032" y="2176272"/>
+            <a:ext cx="5074920" cy="3072384"/>
+          </a:xfrm>
+          <a:prstGeom prst="rect">
+            <a:avLst/>
+          </a:prstGeom>
+        </p:spPr>
+      </p:pic>
+      <p:sp>
+        <p:nvSpPr>
+          <p:cNvPr id="19" name="Rounded Rectangle 18"/>
           <p:cNvSpPr/>
           <p:nvPr/>
         </p:nvSpPr>
         <p:spPr>
           <a:xfrm>
-            <a:off x="6382512" y="2176272"/>
-            <a:ext cx="45720" cy="1261872"/>
-          </a:xfrm>
-          <a:prstGeom prst="rect">
+            <a:off x="969264" y="5532120"/>
+            <a:ext cx="10222992" cy="493776"/>
+          </a:xfrm>
+          <a:prstGeom prst="roundRect">
             <a:avLst/>
           </a:prstGeom>
           <a:solidFill>
-            <a:srgbClr val="F59E0B"/>
+            <a:srgbClr val="152238"/>
           </a:solidFill>
           <a:ln>
             <a:noFill/>
@@ -13367,14 +13557,50 @@
       </p:sp>
       <p:sp>
         <p:nvSpPr>
-          <p:cNvPr id="15" name="TextBox 14"/>
-          <p:cNvSpPr txBox="1"/>
-          <p:nvPr/>
-        </p:nvSpPr>
-        <p:spPr>
-          <a:xfrm>
-            <a:off x="6583680" y="2340864"/>
-            <a:ext cx="4553712" cy="256032"/>
+          <p:cNvPr id="20" name="TextBox 19"/>
+          <p:cNvSpPr txBox="1"/>
+          <p:nvPr/>
+        </p:nvSpPr>
+        <p:spPr>
+          <a:xfrm>
+            <a:off x="1133856" y="5678424"/>
+            <a:ext cx="9893808" cy="164592"/>
+          </a:xfrm>
+          <a:prstGeom prst="rect">
+            <a:avLst/>
+          </a:prstGeom>
+          <a:noFill/>
+        </p:spPr>
+        <p:txBody>
+          <a:bodyPr wrap="square" lIns="18288" rIns="18288" tIns="9144" bIns="9144" anchor="ctr">
+            <a:spAutoFit/>
+          </a:bodyPr>
+          <a:lstStyle/>
+          <a:p>
+            <a:pPr algn="ctr">
+              <a:defRPr sz="1170" b="1">
+                <a:solidFill>
+                  <a:srgbClr val="FFFFFF"/>
+                </a:solidFill>
+                <a:latin typeface="Apple SD Gothic Neo"/>
+              </a:defRPr>
+            </a:pPr>
+            <a:r>
+              <a:t>refund = paidJoinToll × bps(elapsed) / 10,000    |    default bps: ≤6h 75%, ≤24h 50%, ≤3d 25%, &gt;3d 0%</a:t>
+            </a:r>
+          </a:p>
+        </p:txBody>
+      </p:sp>
+      <p:sp>
+        <p:nvSpPr>
+          <p:cNvPr id="21" name="TextBox 20"/>
+          <p:cNvSpPr txBox="1"/>
+          <p:nvPr/>
+        </p:nvSpPr>
+        <p:spPr>
+          <a:xfrm>
+            <a:off x="5870448" y="5358384"/>
+            <a:ext cx="4892040" cy="146304"/>
           </a:xfrm>
           <a:prstGeom prst="rect">
             <a:avLst/>
@@ -13388,43 +13614,7 @@
           <a:lstStyle/>
           <a:p>
             <a:pPr>
-              <a:defRPr sz="1600" b="1">
-                <a:solidFill>
-                  <a:srgbClr val="1B1F2A"/>
-                </a:solidFill>
-                <a:latin typeface="Apple SD Gothic Neo"/>
-              </a:defRPr>
-            </a:pPr>
-            <a:r>
-              <a:t>Immutable policy vs upgradeability</a:t>
-            </a:r>
-          </a:p>
-        </p:txBody>
-      </p:sp>
-      <p:sp>
-        <p:nvSpPr>
-          <p:cNvPr id="16" name="TextBox 15"/>
-          <p:cNvSpPr txBox="1"/>
-          <p:nvPr/>
-        </p:nvSpPr>
-        <p:spPr>
-          <a:xfrm>
-            <a:off x="6583680" y="2724912"/>
-            <a:ext cx="4553712" cy="603503"/>
-          </a:xfrm>
-          <a:prstGeom prst="rect">
-            <a:avLst/>
-          </a:prstGeom>
-          <a:noFill/>
-        </p:spPr>
-        <p:txBody>
-          <a:bodyPr wrap="square" lIns="18288" rIns="18288" tIns="9144" bIns="9144" anchor="t">
-            <a:spAutoFit/>
-          </a:bodyPr>
-          <a:lstStyle/>
-          <a:p>
-            <a:pPr>
-              <a:defRPr sz="1250" b="0">
+              <a:defRPr sz="780" b="0">
                 <a:solidFill>
                   <a:srgbClr val="5C667A"/>
                 </a:solidFill>
@@ -13432,327 +13622,7 @@
               </a:defRPr>
             </a:pPr>
             <a:r>
-              <a:t>channel policy bug는 보통 in-place rewrite가 아니라 새 channel이나 migration path를 요구한다.</a:t>
-            </a:r>
-          </a:p>
-        </p:txBody>
-      </p:sp>
-      <p:sp>
-        <p:nvSpPr>
-          <p:cNvPr id="17" name="Rounded Rectangle 16"/>
-          <p:cNvSpPr/>
-          <p:nvPr/>
-        </p:nvSpPr>
-        <p:spPr>
-          <a:xfrm>
-            <a:off x="859536" y="3931920"/>
-            <a:ext cx="4956048" cy="1261872"/>
-          </a:xfrm>
-          <a:prstGeom prst="roundRect">
-            <a:avLst/>
-          </a:prstGeom>
-          <a:solidFill>
-            <a:srgbClr val="FFFFFF"/>
-          </a:solidFill>
-          <a:ln w="12700">
-            <a:solidFill>
-              <a:srgbClr val="D8DDE6"/>
-            </a:solidFill>
-          </a:ln>
-        </p:spPr>
-        <p:style>
-          <a:lnRef idx="1">
-            <a:schemeClr val="accent1"/>
-          </a:lnRef>
-          <a:fillRef idx="3">
-            <a:schemeClr val="accent1"/>
-          </a:fillRef>
-          <a:effectRef idx="2">
-            <a:schemeClr val="accent1"/>
-          </a:effectRef>
-          <a:fontRef idx="minor">
-            <a:schemeClr val="lt1"/>
-          </a:fontRef>
-        </p:style>
-        <p:txBody>
-          <a:bodyPr rtlCol="0" anchor="ctr"/>
-          <a:lstStyle/>
-          <a:p>
-            <a:pPr algn="ctr"/>
-          </a:p>
-        </p:txBody>
-      </p:sp>
-      <p:sp>
-        <p:nvSpPr>
-          <p:cNvPr id="18" name="Rectangle 17"/>
-          <p:cNvSpPr/>
-          <p:nvPr/>
-        </p:nvSpPr>
-        <p:spPr>
-          <a:xfrm>
-            <a:off x="859536" y="3931920"/>
-            <a:ext cx="45720" cy="1261872"/>
-          </a:xfrm>
-          <a:prstGeom prst="rect">
-            <a:avLst/>
-          </a:prstGeom>
-          <a:solidFill>
-            <a:srgbClr val="D94A4A"/>
-          </a:solidFill>
-          <a:ln>
-            <a:noFill/>
-          </a:ln>
-        </p:spPr>
-        <p:style>
-          <a:lnRef idx="1">
-            <a:schemeClr val="accent1"/>
-          </a:lnRef>
-          <a:fillRef idx="3">
-            <a:schemeClr val="accent1"/>
-          </a:fillRef>
-          <a:effectRef idx="2">
-            <a:schemeClr val="accent1"/>
-          </a:effectRef>
-          <a:fontRef idx="minor">
-            <a:schemeClr val="lt1"/>
-          </a:fontRef>
-        </p:style>
-        <p:txBody>
-          <a:bodyPr rtlCol="0" anchor="ctr"/>
-          <a:lstStyle/>
-          <a:p>
-            <a:pPr algn="ctr"/>
-          </a:p>
-        </p:txBody>
-      </p:sp>
-      <p:sp>
-        <p:nvSpPr>
-          <p:cNvPr id="19" name="TextBox 18"/>
-          <p:cNvSpPr txBox="1"/>
-          <p:nvPr/>
-        </p:nvSpPr>
-        <p:spPr>
-          <a:xfrm>
-            <a:off x="1060704" y="4096511"/>
-            <a:ext cx="4553712" cy="256032"/>
-          </a:xfrm>
-          <a:prstGeom prst="rect">
-            <a:avLst/>
-          </a:prstGeom>
-          <a:noFill/>
-        </p:spPr>
-        <p:txBody>
-          <a:bodyPr wrap="square" lIns="18288" rIns="18288" tIns="9144" bIns="9144" anchor="t">
-            <a:spAutoFit/>
-          </a:bodyPr>
-          <a:lstStyle/>
-          <a:p>
-            <a:pPr>
-              <a:defRPr sz="1600" b="1">
-                <a:solidFill>
-                  <a:srgbClr val="1B1F2A"/>
-                </a:solidFill>
-                <a:latin typeface="Apple SD Gothic Neo"/>
-              </a:defRPr>
-            </a:pPr>
-            <a:r>
-              <a:t>Finite Merkle leaf capacity</a:t>
-            </a:r>
-          </a:p>
-        </p:txBody>
-      </p:sp>
-      <p:sp>
-        <p:nvSpPr>
-          <p:cNvPr id="20" name="TextBox 19"/>
-          <p:cNvSpPr txBox="1"/>
-          <p:nvPr/>
-        </p:nvSpPr>
-        <p:spPr>
-          <a:xfrm>
-            <a:off x="1060704" y="4480559"/>
-            <a:ext cx="4553712" cy="603503"/>
-          </a:xfrm>
-          <a:prstGeom prst="rect">
-            <a:avLst/>
-          </a:prstGeom>
-          <a:noFill/>
-        </p:spPr>
-        <p:txBody>
-          <a:bodyPr wrap="square" lIns="18288" rIns="18288" tIns="9144" bIns="9144" anchor="t">
-            <a:spAutoFit/>
-          </a:bodyPr>
-          <a:lstStyle/>
-          <a:p>
-            <a:pPr>
-              <a:defRPr sz="1250" b="0">
-                <a:solidFill>
-                  <a:srgbClr val="5C667A"/>
-                </a:solidFill>
-                <a:latin typeface="Apple SD Gothic Neo"/>
-              </a:defRPr>
-            </a:pPr>
-            <a:r>
-              <a:t>storage key는 finite leaf domain에 투영되므로 capacity와 collision risk는 channel lifetime concern이다.</a:t>
-            </a:r>
-          </a:p>
-        </p:txBody>
-      </p:sp>
-      <p:sp>
-        <p:nvSpPr>
-          <p:cNvPr id="21" name="Rounded Rectangle 20"/>
-          <p:cNvSpPr/>
-          <p:nvPr/>
-        </p:nvSpPr>
-        <p:spPr>
-          <a:xfrm>
-            <a:off x="6382512" y="3931920"/>
-            <a:ext cx="4956048" cy="1261872"/>
-          </a:xfrm>
-          <a:prstGeom prst="roundRect">
-            <a:avLst/>
-          </a:prstGeom>
-          <a:solidFill>
-            <a:srgbClr val="FFFFFF"/>
-          </a:solidFill>
-          <a:ln w="12700">
-            <a:solidFill>
-              <a:srgbClr val="D8DDE6"/>
-            </a:solidFill>
-          </a:ln>
-        </p:spPr>
-        <p:style>
-          <a:lnRef idx="1">
-            <a:schemeClr val="accent1"/>
-          </a:lnRef>
-          <a:fillRef idx="3">
-            <a:schemeClr val="accent1"/>
-          </a:fillRef>
-          <a:effectRef idx="2">
-            <a:schemeClr val="accent1"/>
-          </a:effectRef>
-          <a:fontRef idx="minor">
-            <a:schemeClr val="lt1"/>
-          </a:fontRef>
-        </p:style>
-        <p:txBody>
-          <a:bodyPr rtlCol="0" anchor="ctr"/>
-          <a:lstStyle/>
-          <a:p>
-            <a:pPr algn="ctr"/>
-          </a:p>
-        </p:txBody>
-      </p:sp>
-      <p:sp>
-        <p:nvSpPr>
-          <p:cNvPr id="22" name="Rectangle 21"/>
-          <p:cNvSpPr/>
-          <p:nvPr/>
-        </p:nvSpPr>
-        <p:spPr>
-          <a:xfrm>
-            <a:off x="6382512" y="3931920"/>
-            <a:ext cx="45720" cy="1261872"/>
-          </a:xfrm>
-          <a:prstGeom prst="rect">
-            <a:avLst/>
-          </a:prstGeom>
-          <a:solidFill>
-            <a:srgbClr val="21A67A"/>
-          </a:solidFill>
-          <a:ln>
-            <a:noFill/>
-          </a:ln>
-        </p:spPr>
-        <p:style>
-          <a:lnRef idx="1">
-            <a:schemeClr val="accent1"/>
-          </a:lnRef>
-          <a:fillRef idx="3">
-            <a:schemeClr val="accent1"/>
-          </a:fillRef>
-          <a:effectRef idx="2">
-            <a:schemeClr val="accent1"/>
-          </a:effectRef>
-          <a:fontRef idx="minor">
-            <a:schemeClr val="lt1"/>
-          </a:fontRef>
-        </p:style>
-        <p:txBody>
-          <a:bodyPr rtlCol="0" anchor="ctr"/>
-          <a:lstStyle/>
-          <a:p>
-            <a:pPr algn="ctr"/>
-          </a:p>
-        </p:txBody>
-      </p:sp>
-      <p:sp>
-        <p:nvSpPr>
-          <p:cNvPr id="23" name="TextBox 22"/>
-          <p:cNvSpPr txBox="1"/>
-          <p:nvPr/>
-        </p:nvSpPr>
-        <p:spPr>
-          <a:xfrm>
-            <a:off x="6583680" y="4096511"/>
-            <a:ext cx="4553712" cy="256032"/>
-          </a:xfrm>
-          <a:prstGeom prst="rect">
-            <a:avLst/>
-          </a:prstGeom>
-          <a:noFill/>
-        </p:spPr>
-        <p:txBody>
-          <a:bodyPr wrap="square" lIns="18288" rIns="18288" tIns="9144" bIns="9144" anchor="t">
-            <a:spAutoFit/>
-          </a:bodyPr>
-          <a:lstStyle/>
-          <a:p>
-            <a:pPr>
-              <a:defRPr sz="1600" b="1">
-                <a:solidFill>
-                  <a:srgbClr val="1B1F2A"/>
-                </a:solidFill>
-                <a:latin typeface="Apple SD Gothic Neo"/>
-              </a:defRPr>
-            </a:pPr>
-            <a:r>
-              <a:t>DApp-specific disclosure</a:t>
-            </a:r>
-          </a:p>
-        </p:txBody>
-      </p:sp>
-      <p:sp>
-        <p:nvSpPr>
-          <p:cNvPr id="24" name="TextBox 23"/>
-          <p:cNvSpPr txBox="1"/>
-          <p:nvPr/>
-        </p:nvSpPr>
-        <p:spPr>
-          <a:xfrm>
-            <a:off x="6583680" y="4480559"/>
-            <a:ext cx="4553712" cy="603503"/>
-          </a:xfrm>
-          <a:prstGeom prst="rect">
-            <a:avLst/>
-          </a:prstGeom>
-          <a:noFill/>
-        </p:spPr>
-        <p:txBody>
-          <a:bodyPr wrap="square" lIns="18288" rIns="18288" tIns="9144" bIns="9144" anchor="t">
-            <a:spAutoFit/>
-          </a:bodyPr>
-          <a:lstStyle/>
-          <a:p>
-            <a:pPr>
-              <a:defRPr sz="1250" b="0">
-                <a:solidFill>
-                  <a:srgbClr val="5C667A"/>
-                </a:solidFill>
-                <a:latin typeface="Apple SD Gothic Neo"/>
-              </a:defRPr>
-            </a:pPr>
-            <a:r>
-              <a:t>compliance, auditability, selective disclosure는 DApp별로 프로그램하고 문서화해야 한다.</a:t>
+              <a:t>출처: bridge-private-state mainnet security review의 collision model + BridgeCore/ChannelManager 현 구현</a:t>
             </a:r>
           </a:p>
         </p:txBody>

</xml_diff>

<commit_message>
Restore tradeoffs slide in bridge deck
</commit_message>
<xml_diff>
--- a/bridge/docs/dev/spec.pptx
+++ b/bridge/docs/dev/spec.pptx
@@ -24,6 +24,7 @@
     <p:sldId id="272" r:id="rId23"/>
     <p:sldId id="273" r:id="rId24"/>
     <p:sldId id="274" r:id="rId25"/>
+    <p:sldId id="275" r:id="rId26"/>
   </p:sldIdLst>
   <p:sldSz cx="12191999" cy="6858000" type="screen4x3"/>
   <p:notesSz cx="6858000" cy="9144000"/>
@@ -12961,7 +12962,7 @@
               </a:defRPr>
             </a:pPr>
             <a:r>
-              <a:t>Finite Leaf와 Channel Lifecycle</a:t>
+              <a:t>열린 연구 및 엔지니어링 질문</a:t>
             </a:r>
           </a:p>
         </p:txBody>
@@ -12997,7 +12998,7 @@
               </a:defRPr>
             </a:pPr>
             <a:r>
-              <a:t>finite Merkle tree는 key collision risk를 만들고, join toll refund schedule은 slot 점유 비용을 시간 함수로 만든다.</a:t>
+              <a:t>이 설계는 일부 global flexibility보다 explicit policy와 isolation을 선택한다.</a:t>
             </a:r>
           </a:p>
         </p:txBody>
@@ -13125,8 +13126,8 @@
         </p:nvSpPr>
         <p:spPr>
           <a:xfrm>
-            <a:off x="841248" y="2048256"/>
-            <a:ext cx="4645152" cy="3346704"/>
+            <a:off x="859536" y="2176272"/>
+            <a:ext cx="4956048" cy="1261872"/>
           </a:xfrm>
           <a:prstGeom prst="roundRect">
             <a:avLst/>
@@ -13164,56 +13165,20 @@
       </p:sp>
       <p:sp>
         <p:nvSpPr>
-          <p:cNvPr id="10" name="TextBox 9"/>
-          <p:cNvSpPr txBox="1"/>
-          <p:nvPr/>
-        </p:nvSpPr>
-        <p:spPr>
-          <a:xfrm>
-            <a:off x="1078992" y="2267712"/>
-            <a:ext cx="4023360" cy="237744"/>
-          </a:xfrm>
-          <a:prstGeom prst="rect">
-            <a:avLst/>
-          </a:prstGeom>
-          <a:noFill/>
-        </p:spPr>
-        <p:txBody>
-          <a:bodyPr wrap="square" lIns="18288" rIns="18288" tIns="9144" bIns="9144" anchor="t">
-            <a:spAutoFit/>
-          </a:bodyPr>
-          <a:lstStyle/>
-          <a:p>
-            <a:pPr>
-              <a:defRPr sz="1500" b="1">
-                <a:solidFill>
-                  <a:srgbClr val="1B1F2A"/>
-                </a:solidFill>
-                <a:latin typeface="Apple SD Gothic Neo"/>
-              </a:defRPr>
-            </a:pPr>
-            <a:r>
-              <a:t>현재 구현의 leaf projection</a:t>
-            </a:r>
-          </a:p>
-        </p:txBody>
-      </p:sp>
-      <p:sp>
-        <p:nvSpPr>
-          <p:cNvPr id="11" name="Rounded Rectangle 10"/>
+          <p:cNvPr id="10" name="Rectangle 9"/>
           <p:cNvSpPr/>
           <p:nvPr/>
         </p:nvSpPr>
         <p:spPr>
           <a:xfrm>
-            <a:off x="1078992" y="2670048"/>
-            <a:ext cx="4059936" cy="786384"/>
-          </a:xfrm>
-          <a:prstGeom prst="roundRect">
+            <a:off x="859536" y="2176272"/>
+            <a:ext cx="45720" cy="1261872"/>
+          </a:xfrm>
+          <a:prstGeom prst="rect">
             <a:avLst/>
           </a:prstGeom>
           <a:solidFill>
-            <a:srgbClr val="152238"/>
+            <a:srgbClr val="2563EB"/>
           </a:solidFill>
           <a:ln>
             <a:noFill/>
@@ -13243,63 +13208,50 @@
       </p:sp>
       <p:sp>
         <p:nvSpPr>
+          <p:cNvPr id="11" name="TextBox 10"/>
+          <p:cNvSpPr txBox="1"/>
+          <p:nvPr/>
+        </p:nvSpPr>
+        <p:spPr>
+          <a:xfrm>
+            <a:off x="1060704" y="2340864"/>
+            <a:ext cx="4553712" cy="256032"/>
+          </a:xfrm>
+          <a:prstGeom prst="rect">
+            <a:avLst/>
+          </a:prstGeom>
+          <a:noFill/>
+        </p:spPr>
+        <p:txBody>
+          <a:bodyPr wrap="square" lIns="18288" rIns="18288" tIns="9144" bIns="9144" anchor="t">
+            <a:spAutoFit/>
+          </a:bodyPr>
+          <a:lstStyle/>
+          <a:p>
+            <a:pPr>
+              <a:defRPr sz="1600" b="1">
+                <a:solidFill>
+                  <a:srgbClr val="1B1F2A"/>
+                </a:solidFill>
+                <a:latin typeface="Apple SD Gothic Neo"/>
+              </a:defRPr>
+            </a:pPr>
+            <a:r>
+              <a:t>Isolation vs composability</a:t>
+            </a:r>
+          </a:p>
+        </p:txBody>
+      </p:sp>
+      <p:sp>
+        <p:nvSpPr>
           <p:cNvPr id="12" name="TextBox 11"/>
           <p:cNvSpPr txBox="1"/>
           <p:nvPr/>
         </p:nvSpPr>
         <p:spPr>
           <a:xfrm>
-            <a:off x="1234440" y="2816352"/>
-            <a:ext cx="3749039" cy="420624"/>
-          </a:xfrm>
-          <a:prstGeom prst="rect">
-            <a:avLst/>
-          </a:prstGeom>
-          <a:noFill/>
-        </p:spPr>
-        <p:txBody>
-          <a:bodyPr wrap="square" lIns="18288" rIns="18288" tIns="9144" bIns="9144" anchor="ctr">
-            <a:spAutoFit/>
-          </a:bodyPr>
-          <a:lstStyle/>
-          <a:p>
-            <a:pPr algn="ctr">
-              <a:defRPr sz="1500" b="1">
-                <a:solidFill>
-                  <a:srgbClr val="FFFFFF"/>
-                </a:solidFill>
-                <a:latin typeface="Apple SD Gothic Neo"/>
-              </a:defRPr>
-            </a:pPr>
-            <a:r>
-              <a:t>N = 2^d,   d = 36</a:t>
-            </a:r>
-          </a:p>
-          <a:p>
-            <a:pPr algn="ctr">
-              <a:defRPr sz="1500" b="1">
-                <a:solidFill>
-                  <a:srgbClr val="FFFFFF"/>
-                </a:solidFill>
-                <a:latin typeface="Apple SD Gothic Neo"/>
-              </a:defRPr>
-            </a:pPr>
-            <a:r>
-              <a:t>LeafIndex(k) = k mod N</a:t>
-            </a:r>
-          </a:p>
-        </p:txBody>
-      </p:sp>
-      <p:sp>
-        <p:nvSpPr>
-          <p:cNvPr id="13" name="TextBox 12"/>
-          <p:cNvSpPr txBox="1"/>
-          <p:nvPr/>
-        </p:nvSpPr>
-        <p:spPr>
-          <a:xfrm>
-            <a:off x="1078992" y="3685032"/>
-            <a:ext cx="4114800" cy="329184"/>
+            <a:off x="1060704" y="2724912"/>
+            <a:ext cx="4553712" cy="603503"/>
           </a:xfrm>
           <a:prstGeom prst="rect">
             <a:avLst/>
@@ -13313,7 +13265,7 @@
           <a:lstStyle/>
           <a:p>
             <a:pPr>
-              <a:defRPr sz="1180" b="0">
+              <a:defRPr sz="1250" b="0">
                 <a:solidFill>
                   <a:srgbClr val="5C667A"/>
                 </a:solidFill>
@@ -13321,138 +13273,21 @@
               </a:defRPr>
             </a:pPr>
             <a:r>
-              <a:t>고정된 future nullifier leaf에 대해, 미래 storage key가 Poisson rate λ로 도착하면:</a:t>
-            </a:r>
-          </a:p>
-        </p:txBody>
-      </p:sp>
-      <p:sp>
-        <p:nvSpPr>
-          <p:cNvPr id="14" name="Rounded Rectangle 13"/>
+              <a:t>per-channel execution은 강한 safety boundary를 주지만, cross-channel composition이 주된 최적화 대상은 아니다.</a:t>
+            </a:r>
+          </a:p>
+        </p:txBody>
+      </p:sp>
+      <p:sp>
+        <p:nvSpPr>
+          <p:cNvPr id="13" name="Rounded Rectangle 12"/>
           <p:cNvSpPr/>
           <p:nvPr/>
         </p:nvSpPr>
         <p:spPr>
           <a:xfrm>
-            <a:off x="1078992" y="4059936"/>
-            <a:ext cx="4059936" cy="512064"/>
-          </a:xfrm>
-          <a:prstGeom prst="roundRect">
-            <a:avLst/>
-          </a:prstGeom>
-          <a:solidFill>
-            <a:srgbClr val="F6F8FC"/>
-          </a:solidFill>
-          <a:ln w="12700">
-            <a:solidFill>
-              <a:srgbClr val="D8DDE6"/>
-            </a:solidFill>
-          </a:ln>
-        </p:spPr>
-        <p:style>
-          <a:lnRef idx="1">
-            <a:schemeClr val="accent1"/>
-          </a:lnRef>
-          <a:fillRef idx="3">
-            <a:schemeClr val="accent1"/>
-          </a:fillRef>
-          <a:effectRef idx="2">
-            <a:schemeClr val="accent1"/>
-          </a:effectRef>
-          <a:fontRef idx="minor">
-            <a:schemeClr val="lt1"/>
-          </a:fontRef>
-        </p:style>
-        <p:txBody>
-          <a:bodyPr rtlCol="0" anchor="ctr"/>
-          <a:lstStyle/>
-          <a:p>
-            <a:pPr algn="ctr"/>
-          </a:p>
-        </p:txBody>
-      </p:sp>
-      <p:sp>
-        <p:nvSpPr>
-          <p:cNvPr id="15" name="TextBox 14"/>
-          <p:cNvSpPr txBox="1"/>
-          <p:nvPr/>
-        </p:nvSpPr>
-        <p:spPr>
-          <a:xfrm>
-            <a:off x="1188720" y="4215384"/>
-            <a:ext cx="3840480" cy="201168"/>
-          </a:xfrm>
-          <a:prstGeom prst="rect">
-            <a:avLst/>
-          </a:prstGeom>
-          <a:noFill/>
-        </p:spPr>
-        <p:txBody>
-          <a:bodyPr wrap="square" lIns="18288" rIns="18288" tIns="9144" bIns="9144" anchor="ctr">
-            <a:spAutoFit/>
-          </a:bodyPr>
-          <a:lstStyle/>
-          <a:p>
-            <a:pPr algn="ctr">
-              <a:defRPr sz="1220" b="1">
-                <a:solidFill>
-                  <a:srgbClr val="1B1F2A"/>
-                </a:solidFill>
-                <a:latin typeface="Apple SD Gothic Neo"/>
-              </a:defRPr>
-            </a:pPr>
-            <a:r>
-              <a:t>P_collision(t) = 1 - exp(-λ · 1440t · 2^-d)</a:t>
-            </a:r>
-          </a:p>
-        </p:txBody>
-      </p:sp>
-      <p:sp>
-        <p:nvSpPr>
-          <p:cNvPr id="16" name="TextBox 15"/>
-          <p:cNvSpPr txBox="1"/>
-          <p:nvPr/>
-        </p:nvSpPr>
-        <p:spPr>
-          <a:xfrm>
-            <a:off x="1078992" y="4718304"/>
-            <a:ext cx="4069080" cy="347472"/>
-          </a:xfrm>
-          <a:prstGeom prst="rect">
-            <a:avLst/>
-          </a:prstGeom>
-          <a:noFill/>
-        </p:spPr>
-        <p:txBody>
-          <a:bodyPr wrap="square" lIns="18288" rIns="18288" tIns="9144" bIns="9144" anchor="t">
-            <a:spAutoFit/>
-          </a:bodyPr>
-          <a:lstStyle/>
-          <a:p>
-            <a:pPr>
-              <a:defRPr sz="1070" b="0">
-                <a:solidFill>
-                  <a:srgbClr val="5C667A"/>
-                </a:solidFill>
-                <a:latin typeface="Apple SD Gothic Neo"/>
-              </a:defRPr>
-            </a:pPr>
-            <a:r>
-              <a:t>t는 days 단위. 그래프는 λ = 1 leaf/minute 모델이며, 보라색 선이 current d = 36이다.</a:t>
-            </a:r>
-          </a:p>
-        </p:txBody>
-      </p:sp>
-      <p:sp>
-        <p:nvSpPr>
-          <p:cNvPr id="17" name="Rounded Rectangle 16"/>
-          <p:cNvSpPr/>
-          <p:nvPr/>
-        </p:nvSpPr>
-        <p:spPr>
-          <a:xfrm>
-            <a:off x="5806440" y="2029968"/>
-            <a:ext cx="5413248" cy="3401568"/>
+            <a:off x="6382512" y="2176272"/>
+            <a:ext cx="4956048" cy="1261872"/>
           </a:xfrm>
           <a:prstGeom prst="roundRect">
             <a:avLst/>
@@ -13488,46 +13323,22 @@
           </a:p>
         </p:txBody>
       </p:sp>
-      <p:pic>
-        <p:nvPicPr>
-          <p:cNvPr id="18" name="Picture 17" descr="collision-probability.png"/>
-          <p:cNvPicPr>
-            <a:picLocks noChangeAspect="1"/>
-          </p:cNvPicPr>
-          <p:nvPr/>
-        </p:nvPicPr>
-        <p:blipFill>
-          <a:blip r:embed="rId2"/>
-          <a:stretch>
-            <a:fillRect/>
-          </a:stretch>
-        </p:blipFill>
-        <p:spPr>
-          <a:xfrm>
-            <a:off x="5971032" y="2176272"/>
-            <a:ext cx="5074920" cy="3072384"/>
-          </a:xfrm>
-          <a:prstGeom prst="rect">
-            <a:avLst/>
-          </a:prstGeom>
-        </p:spPr>
-      </p:pic>
-      <p:sp>
-        <p:nvSpPr>
-          <p:cNvPr id="19" name="Rounded Rectangle 18"/>
+      <p:sp>
+        <p:nvSpPr>
+          <p:cNvPr id="14" name="Rectangle 13"/>
           <p:cNvSpPr/>
           <p:nvPr/>
         </p:nvSpPr>
         <p:spPr>
           <a:xfrm>
-            <a:off x="969264" y="5532120"/>
-            <a:ext cx="10222992" cy="493776"/>
-          </a:xfrm>
-          <a:prstGeom prst="roundRect">
+            <a:off x="6382512" y="2176272"/>
+            <a:ext cx="45720" cy="1261872"/>
+          </a:xfrm>
+          <a:prstGeom prst="rect">
             <a:avLst/>
           </a:prstGeom>
           <a:solidFill>
-            <a:srgbClr val="152238"/>
+            <a:srgbClr val="F59E0B"/>
           </a:solidFill>
           <a:ln>
             <a:noFill/>
@@ -13557,50 +13368,210 @@
       </p:sp>
       <p:sp>
         <p:nvSpPr>
+          <p:cNvPr id="15" name="TextBox 14"/>
+          <p:cNvSpPr txBox="1"/>
+          <p:nvPr/>
+        </p:nvSpPr>
+        <p:spPr>
+          <a:xfrm>
+            <a:off x="6583680" y="2340864"/>
+            <a:ext cx="4553712" cy="256032"/>
+          </a:xfrm>
+          <a:prstGeom prst="rect">
+            <a:avLst/>
+          </a:prstGeom>
+          <a:noFill/>
+        </p:spPr>
+        <p:txBody>
+          <a:bodyPr wrap="square" lIns="18288" rIns="18288" tIns="9144" bIns="9144" anchor="t">
+            <a:spAutoFit/>
+          </a:bodyPr>
+          <a:lstStyle/>
+          <a:p>
+            <a:pPr>
+              <a:defRPr sz="1600" b="1">
+                <a:solidFill>
+                  <a:srgbClr val="1B1F2A"/>
+                </a:solidFill>
+                <a:latin typeface="Apple SD Gothic Neo"/>
+              </a:defRPr>
+            </a:pPr>
+            <a:r>
+              <a:t>Immutable policy vs upgradeability</a:t>
+            </a:r>
+          </a:p>
+        </p:txBody>
+      </p:sp>
+      <p:sp>
+        <p:nvSpPr>
+          <p:cNvPr id="16" name="TextBox 15"/>
+          <p:cNvSpPr txBox="1"/>
+          <p:nvPr/>
+        </p:nvSpPr>
+        <p:spPr>
+          <a:xfrm>
+            <a:off x="6583680" y="2724912"/>
+            <a:ext cx="4553712" cy="603503"/>
+          </a:xfrm>
+          <a:prstGeom prst="rect">
+            <a:avLst/>
+          </a:prstGeom>
+          <a:noFill/>
+        </p:spPr>
+        <p:txBody>
+          <a:bodyPr wrap="square" lIns="18288" rIns="18288" tIns="9144" bIns="9144" anchor="t">
+            <a:spAutoFit/>
+          </a:bodyPr>
+          <a:lstStyle/>
+          <a:p>
+            <a:pPr>
+              <a:defRPr sz="1250" b="0">
+                <a:solidFill>
+                  <a:srgbClr val="5C667A"/>
+                </a:solidFill>
+                <a:latin typeface="Apple SD Gothic Neo"/>
+              </a:defRPr>
+            </a:pPr>
+            <a:r>
+              <a:t>channel policy bug는 보통 in-place rewrite가 아니라 새 channel이나 migration path를 요구한다.</a:t>
+            </a:r>
+          </a:p>
+        </p:txBody>
+      </p:sp>
+      <p:sp>
+        <p:nvSpPr>
+          <p:cNvPr id="17" name="Rounded Rectangle 16"/>
+          <p:cNvSpPr/>
+          <p:nvPr/>
+        </p:nvSpPr>
+        <p:spPr>
+          <a:xfrm>
+            <a:off x="859536" y="3931920"/>
+            <a:ext cx="4956048" cy="1261872"/>
+          </a:xfrm>
+          <a:prstGeom prst="roundRect">
+            <a:avLst/>
+          </a:prstGeom>
+          <a:solidFill>
+            <a:srgbClr val="FFFFFF"/>
+          </a:solidFill>
+          <a:ln w="12700">
+            <a:solidFill>
+              <a:srgbClr val="D8DDE6"/>
+            </a:solidFill>
+          </a:ln>
+        </p:spPr>
+        <p:style>
+          <a:lnRef idx="1">
+            <a:schemeClr val="accent1"/>
+          </a:lnRef>
+          <a:fillRef idx="3">
+            <a:schemeClr val="accent1"/>
+          </a:fillRef>
+          <a:effectRef idx="2">
+            <a:schemeClr val="accent1"/>
+          </a:effectRef>
+          <a:fontRef idx="minor">
+            <a:schemeClr val="lt1"/>
+          </a:fontRef>
+        </p:style>
+        <p:txBody>
+          <a:bodyPr rtlCol="0" anchor="ctr"/>
+          <a:lstStyle/>
+          <a:p>
+            <a:pPr algn="ctr"/>
+          </a:p>
+        </p:txBody>
+      </p:sp>
+      <p:sp>
+        <p:nvSpPr>
+          <p:cNvPr id="18" name="Rectangle 17"/>
+          <p:cNvSpPr/>
+          <p:nvPr/>
+        </p:nvSpPr>
+        <p:spPr>
+          <a:xfrm>
+            <a:off x="859536" y="3931920"/>
+            <a:ext cx="45720" cy="1261872"/>
+          </a:xfrm>
+          <a:prstGeom prst="rect">
+            <a:avLst/>
+          </a:prstGeom>
+          <a:solidFill>
+            <a:srgbClr val="D94A4A"/>
+          </a:solidFill>
+          <a:ln>
+            <a:noFill/>
+          </a:ln>
+        </p:spPr>
+        <p:style>
+          <a:lnRef idx="1">
+            <a:schemeClr val="accent1"/>
+          </a:lnRef>
+          <a:fillRef idx="3">
+            <a:schemeClr val="accent1"/>
+          </a:fillRef>
+          <a:effectRef idx="2">
+            <a:schemeClr val="accent1"/>
+          </a:effectRef>
+          <a:fontRef idx="minor">
+            <a:schemeClr val="lt1"/>
+          </a:fontRef>
+        </p:style>
+        <p:txBody>
+          <a:bodyPr rtlCol="0" anchor="ctr"/>
+          <a:lstStyle/>
+          <a:p>
+            <a:pPr algn="ctr"/>
+          </a:p>
+        </p:txBody>
+      </p:sp>
+      <p:sp>
+        <p:nvSpPr>
+          <p:cNvPr id="19" name="TextBox 18"/>
+          <p:cNvSpPr txBox="1"/>
+          <p:nvPr/>
+        </p:nvSpPr>
+        <p:spPr>
+          <a:xfrm>
+            <a:off x="1060704" y="4096511"/>
+            <a:ext cx="4553712" cy="256032"/>
+          </a:xfrm>
+          <a:prstGeom prst="rect">
+            <a:avLst/>
+          </a:prstGeom>
+          <a:noFill/>
+        </p:spPr>
+        <p:txBody>
+          <a:bodyPr wrap="square" lIns="18288" rIns="18288" tIns="9144" bIns="9144" anchor="t">
+            <a:spAutoFit/>
+          </a:bodyPr>
+          <a:lstStyle/>
+          <a:p>
+            <a:pPr>
+              <a:defRPr sz="1600" b="1">
+                <a:solidFill>
+                  <a:srgbClr val="1B1F2A"/>
+                </a:solidFill>
+                <a:latin typeface="Apple SD Gothic Neo"/>
+              </a:defRPr>
+            </a:pPr>
+            <a:r>
+              <a:t>Finite Merkle leaf capacity</a:t>
+            </a:r>
+          </a:p>
+        </p:txBody>
+      </p:sp>
+      <p:sp>
+        <p:nvSpPr>
           <p:cNvPr id="20" name="TextBox 19"/>
           <p:cNvSpPr txBox="1"/>
           <p:nvPr/>
         </p:nvSpPr>
         <p:spPr>
           <a:xfrm>
-            <a:off x="1133856" y="5678424"/>
-            <a:ext cx="9893808" cy="164592"/>
-          </a:xfrm>
-          <a:prstGeom prst="rect">
-            <a:avLst/>
-          </a:prstGeom>
-          <a:noFill/>
-        </p:spPr>
-        <p:txBody>
-          <a:bodyPr wrap="square" lIns="18288" rIns="18288" tIns="9144" bIns="9144" anchor="ctr">
-            <a:spAutoFit/>
-          </a:bodyPr>
-          <a:lstStyle/>
-          <a:p>
-            <a:pPr algn="ctr">
-              <a:defRPr sz="1170" b="1">
-                <a:solidFill>
-                  <a:srgbClr val="FFFFFF"/>
-                </a:solidFill>
-                <a:latin typeface="Apple SD Gothic Neo"/>
-              </a:defRPr>
-            </a:pPr>
-            <a:r>
-              <a:t>refund = paidJoinToll × bps(elapsed) / 10,000    |    default bps: ≤6h 75%, ≤24h 50%, ≤3d 25%, &gt;3d 0%</a:t>
-            </a:r>
-          </a:p>
-        </p:txBody>
-      </p:sp>
-      <p:sp>
-        <p:nvSpPr>
-          <p:cNvPr id="21" name="TextBox 20"/>
-          <p:cNvSpPr txBox="1"/>
-          <p:nvPr/>
-        </p:nvSpPr>
-        <p:spPr>
-          <a:xfrm>
-            <a:off x="5870448" y="5358384"/>
-            <a:ext cx="4892040" cy="146304"/>
+            <a:off x="1060704" y="4480559"/>
+            <a:ext cx="4553712" cy="603503"/>
           </a:xfrm>
           <a:prstGeom prst="rect">
             <a:avLst/>
@@ -13614,7 +13585,7 @@
           <a:lstStyle/>
           <a:p>
             <a:pPr>
-              <a:defRPr sz="780" b="0">
+              <a:defRPr sz="1250" b="0">
                 <a:solidFill>
                   <a:srgbClr val="5C667A"/>
                 </a:solidFill>
@@ -13622,7 +13593,167 @@
               </a:defRPr>
             </a:pPr>
             <a:r>
-              <a:t>출처: bridge-private-state mainnet security review의 collision model + BridgeCore/ChannelManager 현 구현</a:t>
+              <a:t>storage key는 finite leaf domain에 투영되므로 capacity와 collision risk는 channel lifetime concern이다.</a:t>
+            </a:r>
+          </a:p>
+        </p:txBody>
+      </p:sp>
+      <p:sp>
+        <p:nvSpPr>
+          <p:cNvPr id="21" name="Rounded Rectangle 20"/>
+          <p:cNvSpPr/>
+          <p:nvPr/>
+        </p:nvSpPr>
+        <p:spPr>
+          <a:xfrm>
+            <a:off x="6382512" y="3931920"/>
+            <a:ext cx="4956048" cy="1261872"/>
+          </a:xfrm>
+          <a:prstGeom prst="roundRect">
+            <a:avLst/>
+          </a:prstGeom>
+          <a:solidFill>
+            <a:srgbClr val="FFFFFF"/>
+          </a:solidFill>
+          <a:ln w="12700">
+            <a:solidFill>
+              <a:srgbClr val="D8DDE6"/>
+            </a:solidFill>
+          </a:ln>
+        </p:spPr>
+        <p:style>
+          <a:lnRef idx="1">
+            <a:schemeClr val="accent1"/>
+          </a:lnRef>
+          <a:fillRef idx="3">
+            <a:schemeClr val="accent1"/>
+          </a:fillRef>
+          <a:effectRef idx="2">
+            <a:schemeClr val="accent1"/>
+          </a:effectRef>
+          <a:fontRef idx="minor">
+            <a:schemeClr val="lt1"/>
+          </a:fontRef>
+        </p:style>
+        <p:txBody>
+          <a:bodyPr rtlCol="0" anchor="ctr"/>
+          <a:lstStyle/>
+          <a:p>
+            <a:pPr algn="ctr"/>
+          </a:p>
+        </p:txBody>
+      </p:sp>
+      <p:sp>
+        <p:nvSpPr>
+          <p:cNvPr id="22" name="Rectangle 21"/>
+          <p:cNvSpPr/>
+          <p:nvPr/>
+        </p:nvSpPr>
+        <p:spPr>
+          <a:xfrm>
+            <a:off x="6382512" y="3931920"/>
+            <a:ext cx="45720" cy="1261872"/>
+          </a:xfrm>
+          <a:prstGeom prst="rect">
+            <a:avLst/>
+          </a:prstGeom>
+          <a:solidFill>
+            <a:srgbClr val="21A67A"/>
+          </a:solidFill>
+          <a:ln>
+            <a:noFill/>
+          </a:ln>
+        </p:spPr>
+        <p:style>
+          <a:lnRef idx="1">
+            <a:schemeClr val="accent1"/>
+          </a:lnRef>
+          <a:fillRef idx="3">
+            <a:schemeClr val="accent1"/>
+          </a:fillRef>
+          <a:effectRef idx="2">
+            <a:schemeClr val="accent1"/>
+          </a:effectRef>
+          <a:fontRef idx="minor">
+            <a:schemeClr val="lt1"/>
+          </a:fontRef>
+        </p:style>
+        <p:txBody>
+          <a:bodyPr rtlCol="0" anchor="ctr"/>
+          <a:lstStyle/>
+          <a:p>
+            <a:pPr algn="ctr"/>
+          </a:p>
+        </p:txBody>
+      </p:sp>
+      <p:sp>
+        <p:nvSpPr>
+          <p:cNvPr id="23" name="TextBox 22"/>
+          <p:cNvSpPr txBox="1"/>
+          <p:nvPr/>
+        </p:nvSpPr>
+        <p:spPr>
+          <a:xfrm>
+            <a:off x="6583680" y="4096511"/>
+            <a:ext cx="4553712" cy="256032"/>
+          </a:xfrm>
+          <a:prstGeom prst="rect">
+            <a:avLst/>
+          </a:prstGeom>
+          <a:noFill/>
+        </p:spPr>
+        <p:txBody>
+          <a:bodyPr wrap="square" lIns="18288" rIns="18288" tIns="9144" bIns="9144" anchor="t">
+            <a:spAutoFit/>
+          </a:bodyPr>
+          <a:lstStyle/>
+          <a:p>
+            <a:pPr>
+              <a:defRPr sz="1600" b="1">
+                <a:solidFill>
+                  <a:srgbClr val="1B1F2A"/>
+                </a:solidFill>
+                <a:latin typeface="Apple SD Gothic Neo"/>
+              </a:defRPr>
+            </a:pPr>
+            <a:r>
+              <a:t>DApp-specific disclosure</a:t>
+            </a:r>
+          </a:p>
+        </p:txBody>
+      </p:sp>
+      <p:sp>
+        <p:nvSpPr>
+          <p:cNvPr id="24" name="TextBox 23"/>
+          <p:cNvSpPr txBox="1"/>
+          <p:nvPr/>
+        </p:nvSpPr>
+        <p:spPr>
+          <a:xfrm>
+            <a:off x="6583680" y="4480559"/>
+            <a:ext cx="4553712" cy="603503"/>
+          </a:xfrm>
+          <a:prstGeom prst="rect">
+            <a:avLst/>
+          </a:prstGeom>
+          <a:noFill/>
+        </p:spPr>
+        <p:txBody>
+          <a:bodyPr wrap="square" lIns="18288" rIns="18288" tIns="9144" bIns="9144" anchor="t">
+            <a:spAutoFit/>
+          </a:bodyPr>
+          <a:lstStyle/>
+          <a:p>
+            <a:pPr>
+              <a:defRPr sz="1250" b="0">
+                <a:solidFill>
+                  <a:srgbClr val="5C667A"/>
+                </a:solidFill>
+                <a:latin typeface="Apple SD Gothic Neo"/>
+              </a:defRPr>
+            </a:pPr>
+            <a:r>
+              <a:t>compliance, auditability, selective disclosure는 DApp별로 프로그램하고 문서화해야 한다.</a:t>
             </a:r>
           </a:p>
         </p:txBody>
@@ -13727,7 +13858,7 @@
               </a:defRPr>
             </a:pPr>
             <a:r>
-              <a:t>TAKEAWAYS</a:t>
+              <a:t>LIFECYCLE RISK</a:t>
             </a:r>
           </a:p>
         </p:txBody>
@@ -13763,7 +13894,7 @@
               </a:defRPr>
             </a:pPr>
             <a:r>
-              <a:t>기억해야 할 것</a:t>
+              <a:t>Finite Leaf와 Channel Lifecycle</a:t>
             </a:r>
           </a:p>
         </p:txBody>
@@ -13799,7 +13930,7 @@
               </a:defRPr>
             </a:pPr>
             <a:r>
-              <a:t>Tokamak Private App Channels는 validity-proven DApp-specific execution을 위한 bridge fabric이다.</a:t>
+              <a:t>finite Merkle tree는 key collision risk를 만들고, join toll refund schedule은 slot 점유 비용을 시간 함수로 만든다.</a:t>
             </a:r>
           </a:p>
         </p:txBody>
@@ -13921,23 +14052,25 @@
       </p:sp>
       <p:sp>
         <p:nvSpPr>
-          <p:cNvPr id="9" name="Oval 8"/>
+          <p:cNvPr id="9" name="Rounded Rectangle 8"/>
           <p:cNvSpPr/>
           <p:nvPr/>
         </p:nvSpPr>
         <p:spPr>
           <a:xfrm>
-            <a:off x="1216152" y="2377440"/>
-            <a:ext cx="73152" cy="73152"/>
-          </a:xfrm>
-          <a:prstGeom prst="ellipse">
+            <a:off x="841248" y="2048256"/>
+            <a:ext cx="4645152" cy="3346704"/>
+          </a:xfrm>
+          <a:prstGeom prst="roundRect">
             <a:avLst/>
           </a:prstGeom>
           <a:solidFill>
-            <a:srgbClr val="2563EB"/>
+            <a:srgbClr val="FFFFFF"/>
           </a:solidFill>
-          <a:ln>
-            <a:noFill/>
+          <a:ln w="12700">
+            <a:solidFill>
+              <a:srgbClr val="D8DDE6"/>
+            </a:solidFill>
           </a:ln>
         </p:spPr>
         <p:style>
@@ -13970,8 +14103,8 @@
         </p:nvSpPr>
         <p:spPr>
           <a:xfrm>
-            <a:off x="1380744" y="2304288"/>
-            <a:ext cx="9162288" cy="502919"/>
+            <a:off x="1078992" y="2267712"/>
+            <a:ext cx="4023360" cy="237744"/>
           </a:xfrm>
           <a:prstGeom prst="rect">
             <a:avLst/>
@@ -13985,7 +14118,7 @@
           <a:lstStyle/>
           <a:p>
             <a:pPr>
-              <a:defRPr sz="1700" b="0">
+              <a:defRPr sz="1500" b="1">
                 <a:solidFill>
                   <a:srgbClr val="1B1F2A"/>
                 </a:solidFill>
@@ -13993,337 +14126,21 @@
               </a:defRPr>
             </a:pPr>
             <a:r>
-              <a:t>Ethereum은 custody와 validity anchor로 남는다.</a:t>
-            </a:r>
-          </a:p>
-        </p:txBody>
-      </p:sp>
-      <p:sp>
-        <p:nvSpPr>
-          <p:cNvPr id="11" name="Oval 10"/>
+              <a:t>현재 구현의 leaf projection</a:t>
+            </a:r>
+          </a:p>
+        </p:txBody>
+      </p:sp>
+      <p:sp>
+        <p:nvSpPr>
+          <p:cNvPr id="11" name="Rounded Rectangle 10"/>
           <p:cNvSpPr/>
           <p:nvPr/>
         </p:nvSpPr>
         <p:spPr>
           <a:xfrm>
-            <a:off x="1216152" y="2907792"/>
-            <a:ext cx="73152" cy="73152"/>
-          </a:xfrm>
-          <a:prstGeom prst="ellipse">
-            <a:avLst/>
-          </a:prstGeom>
-          <a:solidFill>
-            <a:srgbClr val="2563EB"/>
-          </a:solidFill>
-          <a:ln>
-            <a:noFill/>
-          </a:ln>
-        </p:spPr>
-        <p:style>
-          <a:lnRef idx="1">
-            <a:schemeClr val="accent1"/>
-          </a:lnRef>
-          <a:fillRef idx="3">
-            <a:schemeClr val="accent1"/>
-          </a:fillRef>
-          <a:effectRef idx="2">
-            <a:schemeClr val="accent1"/>
-          </a:effectRef>
-          <a:fontRef idx="minor">
-            <a:schemeClr val="lt1"/>
-          </a:fontRef>
-        </p:style>
-        <p:txBody>
-          <a:bodyPr rtlCol="0" anchor="ctr"/>
-          <a:lstStyle/>
-          <a:p>
-            <a:pPr algn="ctr"/>
-          </a:p>
-        </p:txBody>
-      </p:sp>
-      <p:sp>
-        <p:nvSpPr>
-          <p:cNvPr id="12" name="TextBox 11"/>
-          <p:cNvSpPr txBox="1"/>
-          <p:nvPr/>
-        </p:nvSpPr>
-        <p:spPr>
-          <a:xfrm>
-            <a:off x="1380744" y="2834640"/>
-            <a:ext cx="9162288" cy="502919"/>
-          </a:xfrm>
-          <a:prstGeom prst="rect">
-            <a:avLst/>
-          </a:prstGeom>
-          <a:noFill/>
-        </p:spPr>
-        <p:txBody>
-          <a:bodyPr wrap="square" lIns="18288" rIns="18288" tIns="9144" bIns="9144" anchor="t">
-            <a:spAutoFit/>
-          </a:bodyPr>
-          <a:lstStyle/>
-          <a:p>
-            <a:pPr>
-              <a:defRPr sz="1700" b="0">
-                <a:solidFill>
-                  <a:srgbClr val="1B1F2A"/>
-                </a:solidFill>
-                <a:latin typeface="Apple SD Gothic Neo"/>
-              </a:defRPr>
-            </a:pPr>
-            <a:r>
-              <a:t>브릿지는 arbitrary ABI interpretation이 아니라 registered metadata로 실행을 admission한다.</a:t>
-            </a:r>
-          </a:p>
-        </p:txBody>
-      </p:sp>
-      <p:sp>
-        <p:nvSpPr>
-          <p:cNvPr id="13" name="Oval 12"/>
-          <p:cNvSpPr/>
-          <p:nvPr/>
-        </p:nvSpPr>
-        <p:spPr>
-          <a:xfrm>
-            <a:off x="1216152" y="3438144"/>
-            <a:ext cx="73152" cy="73152"/>
-          </a:xfrm>
-          <a:prstGeom prst="ellipse">
-            <a:avLst/>
-          </a:prstGeom>
-          <a:solidFill>
-            <a:srgbClr val="2563EB"/>
-          </a:solidFill>
-          <a:ln>
-            <a:noFill/>
-          </a:ln>
-        </p:spPr>
-        <p:style>
-          <a:lnRef idx="1">
-            <a:schemeClr val="accent1"/>
-          </a:lnRef>
-          <a:fillRef idx="3">
-            <a:schemeClr val="accent1"/>
-          </a:fillRef>
-          <a:effectRef idx="2">
-            <a:schemeClr val="accent1"/>
-          </a:effectRef>
-          <a:fontRef idx="minor">
-            <a:schemeClr val="lt1"/>
-          </a:fontRef>
-        </p:style>
-        <p:txBody>
-          <a:bodyPr rtlCol="0" anchor="ctr"/>
-          <a:lstStyle/>
-          <a:p>
-            <a:pPr algn="ctr"/>
-          </a:p>
-        </p:txBody>
-      </p:sp>
-      <p:sp>
-        <p:nvSpPr>
-          <p:cNvPr id="14" name="TextBox 13"/>
-          <p:cNvSpPr txBox="1"/>
-          <p:nvPr/>
-        </p:nvSpPr>
-        <p:spPr>
-          <a:xfrm>
-            <a:off x="1380744" y="3364991"/>
-            <a:ext cx="9162288" cy="502919"/>
-          </a:xfrm>
-          <a:prstGeom prst="rect">
-            <a:avLst/>
-          </a:prstGeom>
-          <a:noFill/>
-        </p:spPr>
-        <p:txBody>
-          <a:bodyPr wrap="square" lIns="18288" rIns="18288" tIns="9144" bIns="9144" anchor="t">
-            <a:spAutoFit/>
-          </a:bodyPr>
-          <a:lstStyle/>
-          <a:p>
-            <a:pPr>
-              <a:defRPr sz="1700" b="0">
-                <a:solidFill>
-                  <a:srgbClr val="1B1F2A"/>
-                </a:solidFill>
-                <a:latin typeface="Apple SD Gothic Neo"/>
-              </a:defRPr>
-            </a:pPr>
-            <a:r>
-              <a:t>각 채널은 DApp policy, verifier binding, function root, storage vector를 snapshot한다.</a:t>
-            </a:r>
-          </a:p>
-        </p:txBody>
-      </p:sp>
-      <p:sp>
-        <p:nvSpPr>
-          <p:cNvPr id="15" name="Oval 14"/>
-          <p:cNvSpPr/>
-          <p:nvPr/>
-        </p:nvSpPr>
-        <p:spPr>
-          <a:xfrm>
-            <a:off x="1216152" y="3968496"/>
-            <a:ext cx="73152" cy="73152"/>
-          </a:xfrm>
-          <a:prstGeom prst="ellipse">
-            <a:avLst/>
-          </a:prstGeom>
-          <a:solidFill>
-            <a:srgbClr val="2563EB"/>
-          </a:solidFill>
-          <a:ln>
-            <a:noFill/>
-          </a:ln>
-        </p:spPr>
-        <p:style>
-          <a:lnRef idx="1">
-            <a:schemeClr val="accent1"/>
-          </a:lnRef>
-          <a:fillRef idx="3">
-            <a:schemeClr val="accent1"/>
-          </a:fillRef>
-          <a:effectRef idx="2">
-            <a:schemeClr val="accent1"/>
-          </a:effectRef>
-          <a:fontRef idx="minor">
-            <a:schemeClr val="lt1"/>
-          </a:fontRef>
-        </p:style>
-        <p:txBody>
-          <a:bodyPr rtlCol="0" anchor="ctr"/>
-          <a:lstStyle/>
-          <a:p>
-            <a:pPr algn="ctr"/>
-          </a:p>
-        </p:txBody>
-      </p:sp>
-      <p:sp>
-        <p:nvSpPr>
-          <p:cNvPr id="16" name="TextBox 15"/>
-          <p:cNvSpPr txBox="1"/>
-          <p:nvPr/>
-        </p:nvSpPr>
-        <p:spPr>
-          <a:xfrm>
-            <a:off x="1380744" y="3895344"/>
-            <a:ext cx="9162288" cy="502919"/>
-          </a:xfrm>
-          <a:prstGeom prst="rect">
-            <a:avLst/>
-          </a:prstGeom>
-          <a:noFill/>
-        </p:spPr>
-        <p:txBody>
-          <a:bodyPr wrap="square" lIns="18288" rIns="18288" tIns="9144" bIns="9144" anchor="t">
-            <a:spAutoFit/>
-          </a:bodyPr>
-          <a:lstStyle/>
-          <a:p>
-            <a:pPr>
-              <a:defRPr sz="1700" b="0">
-                <a:solidFill>
-                  <a:srgbClr val="1B1F2A"/>
-                </a:solidFill>
-                <a:latin typeface="Apple SD Gothic Neo"/>
-              </a:defRPr>
-            </a:pPr>
-            <a:r>
-              <a:t>Tokamak proof와 Groth16 accounting proof는 서로 다른 bridge responsibility를 맡는다.</a:t>
-            </a:r>
-          </a:p>
-        </p:txBody>
-      </p:sp>
-      <p:sp>
-        <p:nvSpPr>
-          <p:cNvPr id="17" name="Oval 16"/>
-          <p:cNvSpPr/>
-          <p:nvPr/>
-        </p:nvSpPr>
-        <p:spPr>
-          <a:xfrm>
-            <a:off x="1216152" y="4498848"/>
-            <a:ext cx="73152" cy="73152"/>
-          </a:xfrm>
-          <a:prstGeom prst="ellipse">
-            <a:avLst/>
-          </a:prstGeom>
-          <a:solidFill>
-            <a:srgbClr val="2563EB"/>
-          </a:solidFill>
-          <a:ln>
-            <a:noFill/>
-          </a:ln>
-        </p:spPr>
-        <p:style>
-          <a:lnRef idx="1">
-            <a:schemeClr val="accent1"/>
-          </a:lnRef>
-          <a:fillRef idx="3">
-            <a:schemeClr val="accent1"/>
-          </a:fillRef>
-          <a:effectRef idx="2">
-            <a:schemeClr val="accent1"/>
-          </a:effectRef>
-          <a:fontRef idx="minor">
-            <a:schemeClr val="lt1"/>
-          </a:fontRef>
-        </p:style>
-        <p:txBody>
-          <a:bodyPr rtlCol="0" anchor="ctr"/>
-          <a:lstStyle/>
-          <a:p>
-            <a:pPr algn="ctr"/>
-          </a:p>
-        </p:txBody>
-      </p:sp>
-      <p:sp>
-        <p:nvSpPr>
-          <p:cNvPr id="18" name="TextBox 17"/>
-          <p:cNvSpPr txBox="1"/>
-          <p:nvPr/>
-        </p:nvSpPr>
-        <p:spPr>
-          <a:xfrm>
-            <a:off x="1380744" y="4425696"/>
-            <a:ext cx="9162288" cy="502919"/>
-          </a:xfrm>
-          <a:prstGeom prst="rect">
-            <a:avLst/>
-          </a:prstGeom>
-          <a:noFill/>
-        </p:spPr>
-        <p:txBody>
-          <a:bodyPr wrap="square" lIns="18288" rIns="18288" tIns="9144" bIns="9144" anchor="t">
-            <a:spAutoFit/>
-          </a:bodyPr>
-          <a:lstStyle/>
-          <a:p>
-            <a:pPr>
-              <a:defRPr sz="1700" b="0">
-                <a:solidFill>
-                  <a:srgbClr val="1B1F2A"/>
-                </a:solidFill>
-                <a:latin typeface="Apple SD Gothic Neo"/>
-              </a:defRPr>
-            </a:pPr>
-            <a:r>
-              <a:t>private-state는 공개 L1 entry/exit 위에서 DApp-programmed privacy를 보여준다.</a:t>
-            </a:r>
-          </a:p>
-        </p:txBody>
-      </p:sp>
-      <p:sp>
-        <p:nvSpPr>
-          <p:cNvPr id="19" name="Rounded Rectangle 18"/>
-          <p:cNvSpPr/>
-          <p:nvPr/>
-        </p:nvSpPr>
-        <p:spPr>
-          <a:xfrm>
-            <a:off x="1463040" y="5413248"/>
-            <a:ext cx="9253728" cy="475488"/>
+            <a:off x="1078992" y="2670048"/>
+            <a:ext cx="4059936" cy="786384"/>
           </a:xfrm>
           <a:prstGeom prst="roundRect">
             <a:avLst/>
@@ -14359,14 +14176,328 @@
       </p:sp>
       <p:sp>
         <p:nvSpPr>
+          <p:cNvPr id="12" name="TextBox 11"/>
+          <p:cNvSpPr txBox="1"/>
+          <p:nvPr/>
+        </p:nvSpPr>
+        <p:spPr>
+          <a:xfrm>
+            <a:off x="1234440" y="2816352"/>
+            <a:ext cx="3749039" cy="420624"/>
+          </a:xfrm>
+          <a:prstGeom prst="rect">
+            <a:avLst/>
+          </a:prstGeom>
+          <a:noFill/>
+        </p:spPr>
+        <p:txBody>
+          <a:bodyPr wrap="square" lIns="18288" rIns="18288" tIns="9144" bIns="9144" anchor="ctr">
+            <a:spAutoFit/>
+          </a:bodyPr>
+          <a:lstStyle/>
+          <a:p>
+            <a:pPr algn="ctr">
+              <a:defRPr sz="1500" b="1">
+                <a:solidFill>
+                  <a:srgbClr val="FFFFFF"/>
+                </a:solidFill>
+                <a:latin typeface="Apple SD Gothic Neo"/>
+              </a:defRPr>
+            </a:pPr>
+            <a:r>
+              <a:t>N = 2^d,   d = 36</a:t>
+            </a:r>
+          </a:p>
+          <a:p>
+            <a:pPr algn="ctr">
+              <a:defRPr sz="1500" b="1">
+                <a:solidFill>
+                  <a:srgbClr val="FFFFFF"/>
+                </a:solidFill>
+                <a:latin typeface="Apple SD Gothic Neo"/>
+              </a:defRPr>
+            </a:pPr>
+            <a:r>
+              <a:t>LeafIndex(k) = k mod N</a:t>
+            </a:r>
+          </a:p>
+        </p:txBody>
+      </p:sp>
+      <p:sp>
+        <p:nvSpPr>
+          <p:cNvPr id="13" name="TextBox 12"/>
+          <p:cNvSpPr txBox="1"/>
+          <p:nvPr/>
+        </p:nvSpPr>
+        <p:spPr>
+          <a:xfrm>
+            <a:off x="1078992" y="3685032"/>
+            <a:ext cx="4114800" cy="329184"/>
+          </a:xfrm>
+          <a:prstGeom prst="rect">
+            <a:avLst/>
+          </a:prstGeom>
+          <a:noFill/>
+        </p:spPr>
+        <p:txBody>
+          <a:bodyPr wrap="square" lIns="18288" rIns="18288" tIns="9144" bIns="9144" anchor="t">
+            <a:spAutoFit/>
+          </a:bodyPr>
+          <a:lstStyle/>
+          <a:p>
+            <a:pPr>
+              <a:defRPr sz="1180" b="0">
+                <a:solidFill>
+                  <a:srgbClr val="5C667A"/>
+                </a:solidFill>
+                <a:latin typeface="Apple SD Gothic Neo"/>
+              </a:defRPr>
+            </a:pPr>
+            <a:r>
+              <a:t>고정된 future nullifier leaf에 대해, 미래 storage key가 Poisson rate λ로 도착하면:</a:t>
+            </a:r>
+          </a:p>
+        </p:txBody>
+      </p:sp>
+      <p:sp>
+        <p:nvSpPr>
+          <p:cNvPr id="14" name="Rounded Rectangle 13"/>
+          <p:cNvSpPr/>
+          <p:nvPr/>
+        </p:nvSpPr>
+        <p:spPr>
+          <a:xfrm>
+            <a:off x="1078992" y="4059936"/>
+            <a:ext cx="4059936" cy="512064"/>
+          </a:xfrm>
+          <a:prstGeom prst="roundRect">
+            <a:avLst/>
+          </a:prstGeom>
+          <a:solidFill>
+            <a:srgbClr val="F6F8FC"/>
+          </a:solidFill>
+          <a:ln w="12700">
+            <a:solidFill>
+              <a:srgbClr val="D8DDE6"/>
+            </a:solidFill>
+          </a:ln>
+        </p:spPr>
+        <p:style>
+          <a:lnRef idx="1">
+            <a:schemeClr val="accent1"/>
+          </a:lnRef>
+          <a:fillRef idx="3">
+            <a:schemeClr val="accent1"/>
+          </a:fillRef>
+          <a:effectRef idx="2">
+            <a:schemeClr val="accent1"/>
+          </a:effectRef>
+          <a:fontRef idx="minor">
+            <a:schemeClr val="lt1"/>
+          </a:fontRef>
+        </p:style>
+        <p:txBody>
+          <a:bodyPr rtlCol="0" anchor="ctr"/>
+          <a:lstStyle/>
+          <a:p>
+            <a:pPr algn="ctr"/>
+          </a:p>
+        </p:txBody>
+      </p:sp>
+      <p:sp>
+        <p:nvSpPr>
+          <p:cNvPr id="15" name="TextBox 14"/>
+          <p:cNvSpPr txBox="1"/>
+          <p:nvPr/>
+        </p:nvSpPr>
+        <p:spPr>
+          <a:xfrm>
+            <a:off x="1188720" y="4215384"/>
+            <a:ext cx="3840480" cy="201168"/>
+          </a:xfrm>
+          <a:prstGeom prst="rect">
+            <a:avLst/>
+          </a:prstGeom>
+          <a:noFill/>
+        </p:spPr>
+        <p:txBody>
+          <a:bodyPr wrap="square" lIns="18288" rIns="18288" tIns="9144" bIns="9144" anchor="ctr">
+            <a:spAutoFit/>
+          </a:bodyPr>
+          <a:lstStyle/>
+          <a:p>
+            <a:pPr algn="ctr">
+              <a:defRPr sz="1220" b="1">
+                <a:solidFill>
+                  <a:srgbClr val="1B1F2A"/>
+                </a:solidFill>
+                <a:latin typeface="Apple SD Gothic Neo"/>
+              </a:defRPr>
+            </a:pPr>
+            <a:r>
+              <a:t>P_collision(t) = 1 - exp(-λ · 1440t · 2^-d)</a:t>
+            </a:r>
+          </a:p>
+        </p:txBody>
+      </p:sp>
+      <p:sp>
+        <p:nvSpPr>
+          <p:cNvPr id="16" name="TextBox 15"/>
+          <p:cNvSpPr txBox="1"/>
+          <p:nvPr/>
+        </p:nvSpPr>
+        <p:spPr>
+          <a:xfrm>
+            <a:off x="1078992" y="4718304"/>
+            <a:ext cx="4069080" cy="347472"/>
+          </a:xfrm>
+          <a:prstGeom prst="rect">
+            <a:avLst/>
+          </a:prstGeom>
+          <a:noFill/>
+        </p:spPr>
+        <p:txBody>
+          <a:bodyPr wrap="square" lIns="18288" rIns="18288" tIns="9144" bIns="9144" anchor="t">
+            <a:spAutoFit/>
+          </a:bodyPr>
+          <a:lstStyle/>
+          <a:p>
+            <a:pPr>
+              <a:defRPr sz="1070" b="0">
+                <a:solidFill>
+                  <a:srgbClr val="5C667A"/>
+                </a:solidFill>
+                <a:latin typeface="Apple SD Gothic Neo"/>
+              </a:defRPr>
+            </a:pPr>
+            <a:r>
+              <a:t>t는 days 단위. 그래프는 λ = 1 leaf/minute 모델이며, 보라색 선이 current d = 36이다.</a:t>
+            </a:r>
+          </a:p>
+        </p:txBody>
+      </p:sp>
+      <p:sp>
+        <p:nvSpPr>
+          <p:cNvPr id="17" name="Rounded Rectangle 16"/>
+          <p:cNvSpPr/>
+          <p:nvPr/>
+        </p:nvSpPr>
+        <p:spPr>
+          <a:xfrm>
+            <a:off x="5806440" y="2029968"/>
+            <a:ext cx="5413248" cy="3401568"/>
+          </a:xfrm>
+          <a:prstGeom prst="roundRect">
+            <a:avLst/>
+          </a:prstGeom>
+          <a:solidFill>
+            <a:srgbClr val="FFFFFF"/>
+          </a:solidFill>
+          <a:ln w="12700">
+            <a:solidFill>
+              <a:srgbClr val="D8DDE6"/>
+            </a:solidFill>
+          </a:ln>
+        </p:spPr>
+        <p:style>
+          <a:lnRef idx="1">
+            <a:schemeClr val="accent1"/>
+          </a:lnRef>
+          <a:fillRef idx="3">
+            <a:schemeClr val="accent1"/>
+          </a:fillRef>
+          <a:effectRef idx="2">
+            <a:schemeClr val="accent1"/>
+          </a:effectRef>
+          <a:fontRef idx="minor">
+            <a:schemeClr val="lt1"/>
+          </a:fontRef>
+        </p:style>
+        <p:txBody>
+          <a:bodyPr rtlCol="0" anchor="ctr"/>
+          <a:lstStyle/>
+          <a:p>
+            <a:pPr algn="ctr"/>
+          </a:p>
+        </p:txBody>
+      </p:sp>
+      <p:pic>
+        <p:nvPicPr>
+          <p:cNvPr id="18" name="Picture 17" descr="collision-probability.png"/>
+          <p:cNvPicPr>
+            <a:picLocks noChangeAspect="1"/>
+          </p:cNvPicPr>
+          <p:nvPr/>
+        </p:nvPicPr>
+        <p:blipFill>
+          <a:blip r:embed="rId2"/>
+          <a:stretch>
+            <a:fillRect/>
+          </a:stretch>
+        </p:blipFill>
+        <p:spPr>
+          <a:xfrm>
+            <a:off x="5971032" y="2176272"/>
+            <a:ext cx="5074920" cy="3072384"/>
+          </a:xfrm>
+          <a:prstGeom prst="rect">
+            <a:avLst/>
+          </a:prstGeom>
+        </p:spPr>
+      </p:pic>
+      <p:sp>
+        <p:nvSpPr>
+          <p:cNvPr id="19" name="Rounded Rectangle 18"/>
+          <p:cNvSpPr/>
+          <p:nvPr/>
+        </p:nvSpPr>
+        <p:spPr>
+          <a:xfrm>
+            <a:off x="969264" y="5532120"/>
+            <a:ext cx="10222992" cy="493776"/>
+          </a:xfrm>
+          <a:prstGeom prst="roundRect">
+            <a:avLst/>
+          </a:prstGeom>
+          <a:solidFill>
+            <a:srgbClr val="152238"/>
+          </a:solidFill>
+          <a:ln>
+            <a:noFill/>
+          </a:ln>
+        </p:spPr>
+        <p:style>
+          <a:lnRef idx="1">
+            <a:schemeClr val="accent1"/>
+          </a:lnRef>
+          <a:fillRef idx="3">
+            <a:schemeClr val="accent1"/>
+          </a:fillRef>
+          <a:effectRef idx="2">
+            <a:schemeClr val="accent1"/>
+          </a:effectRef>
+          <a:fontRef idx="minor">
+            <a:schemeClr val="lt1"/>
+          </a:fontRef>
+        </p:style>
+        <p:txBody>
+          <a:bodyPr rtlCol="0" anchor="ctr"/>
+          <a:lstStyle/>
+          <a:p>
+            <a:pPr algn="ctr"/>
+          </a:p>
+        </p:txBody>
+      </p:sp>
+      <p:sp>
+        <p:nvSpPr>
           <p:cNvPr id="20" name="TextBox 19"/>
           <p:cNvSpPr txBox="1"/>
           <p:nvPr/>
         </p:nvSpPr>
         <p:spPr>
           <a:xfrm>
-            <a:off x="1719072" y="5550408"/>
-            <a:ext cx="8741664" cy="219456"/>
+            <a:off x="1133856" y="5678424"/>
+            <a:ext cx="9893808" cy="164592"/>
           </a:xfrm>
           <a:prstGeom prst="rect">
             <a:avLst/>
@@ -14380,7 +14511,7 @@
           <a:lstStyle/>
           <a:p>
             <a:pPr algn="ctr">
-              <a:defRPr sz="1400" b="1">
+              <a:defRPr sz="1170" b="1">
                 <a:solidFill>
                   <a:srgbClr val="FFFFFF"/>
                 </a:solidFill>
@@ -14388,7 +14519,43 @@
               </a:defRPr>
             </a:pPr>
             <a:r>
-              <a:t>핵심 질문은 proof가 verify되는가뿐 아니라, 어떤 policy가 그 proof에 의미를 부여하는가이다.</a:t>
+              <a:t>refund = paidJoinToll × bps(elapsed) / 10,000    |    default bps: ≤6h 75%, ≤24h 50%, ≤3d 25%, &gt;3d 0%</a:t>
+            </a:r>
+          </a:p>
+        </p:txBody>
+      </p:sp>
+      <p:sp>
+        <p:nvSpPr>
+          <p:cNvPr id="21" name="TextBox 20"/>
+          <p:cNvSpPr txBox="1"/>
+          <p:nvPr/>
+        </p:nvSpPr>
+        <p:spPr>
+          <a:xfrm>
+            <a:off x="5870448" y="5358384"/>
+            <a:ext cx="4892040" cy="146304"/>
+          </a:xfrm>
+          <a:prstGeom prst="rect">
+            <a:avLst/>
+          </a:prstGeom>
+          <a:noFill/>
+        </p:spPr>
+        <p:txBody>
+          <a:bodyPr wrap="square" lIns="18288" rIns="18288" tIns="9144" bIns="9144" anchor="t">
+            <a:spAutoFit/>
+          </a:bodyPr>
+          <a:lstStyle/>
+          <a:p>
+            <a:pPr>
+              <a:defRPr sz="780" b="0">
+                <a:solidFill>
+                  <a:srgbClr val="5C667A"/>
+                </a:solidFill>
+                <a:latin typeface="Apple SD Gothic Neo"/>
+              </a:defRPr>
+            </a:pPr>
+            <a:r>
+              <a:t>출처: bridge-private-state mainnet security review의 collision model + BridgeCore/ChannelManager 현 구현</a:t>
             </a:r>
           </a:p>
         </p:txBody>
@@ -15434,6 +15601,772 @@
             </a:pPr>
             <a:r>
               <a:t>사용자가 참여하는 시점의 channel policy를 스냅샷으로 고정한다.</a:t>
+            </a:r>
+          </a:p>
+        </p:txBody>
+      </p:sp>
+    </p:spTree>
+  </p:cSld>
+  <p:clrMapOvr>
+    <a:masterClrMapping/>
+  </p:clrMapOvr>
+</p:sld>
+</file>
+
+<file path=ppt/slides/slide20.xml><?xml version="1.0" encoding="utf-8"?>
+<p:sld xmlns:a="http://schemas.openxmlformats.org/drawingml/2006/main" xmlns:p="http://schemas.openxmlformats.org/presentationml/2006/main" xmlns:r="http://schemas.openxmlformats.org/officeDocument/2006/relationships">
+  <p:cSld>
+    <p:bg>
+      <p:bgPr>
+        <a:solidFill>
+          <a:srgbClr val="F7F8FA"/>
+        </a:solidFill>
+        <a:effectLst/>
+      </p:bgPr>
+    </p:bg>
+    <p:spTree>
+      <p:nvGrpSpPr>
+        <p:cNvPr id="1" name=""/>
+        <p:cNvGrpSpPr/>
+        <p:nvPr/>
+      </p:nvGrpSpPr>
+      <p:grpSpPr/>
+      <p:sp>
+        <p:nvSpPr>
+          <p:cNvPr id="2" name="Rectangle 1"/>
+          <p:cNvSpPr/>
+          <p:nvPr/>
+        </p:nvSpPr>
+        <p:spPr>
+          <a:xfrm>
+            <a:off x="0" y="0"/>
+            <a:ext cx="146304" cy="6858000"/>
+          </a:xfrm>
+          <a:prstGeom prst="rect">
+            <a:avLst/>
+          </a:prstGeom>
+          <a:solidFill>
+            <a:srgbClr val="2563EB"/>
+          </a:solidFill>
+          <a:ln>
+            <a:noFill/>
+          </a:ln>
+        </p:spPr>
+        <p:style>
+          <a:lnRef idx="1">
+            <a:schemeClr val="accent1"/>
+          </a:lnRef>
+          <a:fillRef idx="3">
+            <a:schemeClr val="accent1"/>
+          </a:fillRef>
+          <a:effectRef idx="2">
+            <a:schemeClr val="accent1"/>
+          </a:effectRef>
+          <a:fontRef idx="minor">
+            <a:schemeClr val="lt1"/>
+          </a:fontRef>
+        </p:style>
+        <p:txBody>
+          <a:bodyPr rtlCol="0" anchor="ctr"/>
+          <a:lstStyle/>
+          <a:p>
+            <a:pPr algn="ctr"/>
+          </a:p>
+        </p:txBody>
+      </p:sp>
+      <p:sp>
+        <p:nvSpPr>
+          <p:cNvPr id="3" name="TextBox 2"/>
+          <p:cNvSpPr txBox="1"/>
+          <p:nvPr/>
+        </p:nvSpPr>
+        <p:spPr>
+          <a:xfrm>
+            <a:off x="548640" y="411480"/>
+            <a:ext cx="5303520" cy="228600"/>
+          </a:xfrm>
+          <a:prstGeom prst="rect">
+            <a:avLst/>
+          </a:prstGeom>
+          <a:noFill/>
+        </p:spPr>
+        <p:txBody>
+          <a:bodyPr wrap="square" lIns="18288" rIns="18288" tIns="9144" bIns="9144" anchor="t">
+            <a:spAutoFit/>
+          </a:bodyPr>
+          <a:lstStyle/>
+          <a:p>
+            <a:pPr>
+              <a:defRPr sz="1100" b="1">
+                <a:solidFill>
+                  <a:srgbClr val="2563EB"/>
+                </a:solidFill>
+                <a:latin typeface="Apple SD Gothic Neo"/>
+              </a:defRPr>
+            </a:pPr>
+            <a:r>
+              <a:t>TAKEAWAYS</a:t>
+            </a:r>
+          </a:p>
+        </p:txBody>
+      </p:sp>
+      <p:sp>
+        <p:nvSpPr>
+          <p:cNvPr id="4" name="TextBox 3"/>
+          <p:cNvSpPr txBox="1"/>
+          <p:nvPr/>
+        </p:nvSpPr>
+        <p:spPr>
+          <a:xfrm>
+            <a:off x="530352" y="804672"/>
+            <a:ext cx="8046720" cy="640080"/>
+          </a:xfrm>
+          <a:prstGeom prst="rect">
+            <a:avLst/>
+          </a:prstGeom>
+          <a:noFill/>
+        </p:spPr>
+        <p:txBody>
+          <a:bodyPr wrap="square" lIns="18288" rIns="18288" tIns="9144" bIns="9144" anchor="t">
+            <a:spAutoFit/>
+          </a:bodyPr>
+          <a:lstStyle/>
+          <a:p>
+            <a:pPr>
+              <a:defRPr sz="3400" b="1">
+                <a:solidFill>
+                  <a:srgbClr val="101828"/>
+                </a:solidFill>
+                <a:latin typeface="Apple SD Gothic Neo"/>
+              </a:defRPr>
+            </a:pPr>
+            <a:r>
+              <a:t>기억해야 할 것</a:t>
+            </a:r>
+          </a:p>
+        </p:txBody>
+      </p:sp>
+      <p:sp>
+        <p:nvSpPr>
+          <p:cNvPr id="5" name="TextBox 4"/>
+          <p:cNvSpPr txBox="1"/>
+          <p:nvPr/>
+        </p:nvSpPr>
+        <p:spPr>
+          <a:xfrm>
+            <a:off x="548640" y="1444752"/>
+            <a:ext cx="7863840" cy="438912"/>
+          </a:xfrm>
+          <a:prstGeom prst="rect">
+            <a:avLst/>
+          </a:prstGeom>
+          <a:noFill/>
+        </p:spPr>
+        <p:txBody>
+          <a:bodyPr wrap="square" lIns="18288" rIns="18288" tIns="9144" bIns="9144" anchor="t">
+            <a:spAutoFit/>
+          </a:bodyPr>
+          <a:lstStyle/>
+          <a:p>
+            <a:pPr>
+              <a:defRPr sz="1500" b="0">
+                <a:solidFill>
+                  <a:srgbClr val="5C667A"/>
+                </a:solidFill>
+                <a:latin typeface="Apple SD Gothic Neo"/>
+              </a:defRPr>
+            </a:pPr>
+            <a:r>
+              <a:t>Tokamak Private App Channels는 validity-proven DApp-specific execution을 위한 bridge fabric이다.</a:t>
+            </a:r>
+          </a:p>
+        </p:txBody>
+      </p:sp>
+      <p:sp>
+        <p:nvSpPr>
+          <p:cNvPr id="6" name="Rectangle 5"/>
+          <p:cNvSpPr/>
+          <p:nvPr/>
+        </p:nvSpPr>
+        <p:spPr>
+          <a:xfrm>
+            <a:off x="530352" y="6364224"/>
+            <a:ext cx="11109960" cy="9144"/>
+          </a:xfrm>
+          <a:prstGeom prst="rect">
+            <a:avLst/>
+          </a:prstGeom>
+          <a:solidFill>
+            <a:srgbClr val="D8DDE6"/>
+          </a:solidFill>
+          <a:ln>
+            <a:noFill/>
+          </a:ln>
+        </p:spPr>
+        <p:style>
+          <a:lnRef idx="1">
+            <a:schemeClr val="accent1"/>
+          </a:lnRef>
+          <a:fillRef idx="3">
+            <a:schemeClr val="accent1"/>
+          </a:fillRef>
+          <a:effectRef idx="2">
+            <a:schemeClr val="accent1"/>
+          </a:effectRef>
+          <a:fontRef idx="minor">
+            <a:schemeClr val="lt1"/>
+          </a:fontRef>
+        </p:style>
+        <p:txBody>
+          <a:bodyPr rtlCol="0" anchor="ctr"/>
+          <a:lstStyle/>
+          <a:p>
+            <a:pPr algn="ctr"/>
+          </a:p>
+        </p:txBody>
+      </p:sp>
+      <p:sp>
+        <p:nvSpPr>
+          <p:cNvPr id="7" name="TextBox 6"/>
+          <p:cNvSpPr txBox="1"/>
+          <p:nvPr/>
+        </p:nvSpPr>
+        <p:spPr>
+          <a:xfrm>
+            <a:off x="530352" y="6473952"/>
+            <a:ext cx="3291840" cy="164592"/>
+          </a:xfrm>
+          <a:prstGeom prst="rect">
+            <a:avLst/>
+          </a:prstGeom>
+          <a:noFill/>
+        </p:spPr>
+        <p:txBody>
+          <a:bodyPr wrap="square" lIns="18288" rIns="18288" tIns="9144" bIns="9144" anchor="t">
+            <a:spAutoFit/>
+          </a:bodyPr>
+          <a:lstStyle/>
+          <a:p>
+            <a:pPr>
+              <a:defRPr sz="800" b="0">
+                <a:solidFill>
+                  <a:srgbClr val="5C667A"/>
+                </a:solidFill>
+                <a:latin typeface="Apple SD Gothic Neo"/>
+              </a:defRPr>
+            </a:pPr>
+            <a:r>
+              <a:t>Tokamak Private App Channels</a:t>
+            </a:r>
+          </a:p>
+        </p:txBody>
+      </p:sp>
+      <p:sp>
+        <p:nvSpPr>
+          <p:cNvPr id="8" name="TextBox 7"/>
+          <p:cNvSpPr txBox="1"/>
+          <p:nvPr/>
+        </p:nvSpPr>
+        <p:spPr>
+          <a:xfrm>
+            <a:off x="11292840" y="6473952"/>
+            <a:ext cx="320040" cy="164592"/>
+          </a:xfrm>
+          <a:prstGeom prst="rect">
+            <a:avLst/>
+          </a:prstGeom>
+          <a:noFill/>
+        </p:spPr>
+        <p:txBody>
+          <a:bodyPr wrap="square" lIns="18288" rIns="18288" tIns="9144" bIns="9144" anchor="t">
+            <a:spAutoFit/>
+          </a:bodyPr>
+          <a:lstStyle/>
+          <a:p>
+            <a:pPr algn="r">
+              <a:defRPr sz="800" b="0">
+                <a:solidFill>
+                  <a:srgbClr val="5C667A"/>
+                </a:solidFill>
+                <a:latin typeface="Apple SD Gothic Neo"/>
+              </a:defRPr>
+            </a:pPr>
+            <a:r>
+              <a:t>20</a:t>
+            </a:r>
+          </a:p>
+        </p:txBody>
+      </p:sp>
+      <p:sp>
+        <p:nvSpPr>
+          <p:cNvPr id="9" name="Oval 8"/>
+          <p:cNvSpPr/>
+          <p:nvPr/>
+        </p:nvSpPr>
+        <p:spPr>
+          <a:xfrm>
+            <a:off x="1216152" y="2377440"/>
+            <a:ext cx="73152" cy="73152"/>
+          </a:xfrm>
+          <a:prstGeom prst="ellipse">
+            <a:avLst/>
+          </a:prstGeom>
+          <a:solidFill>
+            <a:srgbClr val="2563EB"/>
+          </a:solidFill>
+          <a:ln>
+            <a:noFill/>
+          </a:ln>
+        </p:spPr>
+        <p:style>
+          <a:lnRef idx="1">
+            <a:schemeClr val="accent1"/>
+          </a:lnRef>
+          <a:fillRef idx="3">
+            <a:schemeClr val="accent1"/>
+          </a:fillRef>
+          <a:effectRef idx="2">
+            <a:schemeClr val="accent1"/>
+          </a:effectRef>
+          <a:fontRef idx="minor">
+            <a:schemeClr val="lt1"/>
+          </a:fontRef>
+        </p:style>
+        <p:txBody>
+          <a:bodyPr rtlCol="0" anchor="ctr"/>
+          <a:lstStyle/>
+          <a:p>
+            <a:pPr algn="ctr"/>
+          </a:p>
+        </p:txBody>
+      </p:sp>
+      <p:sp>
+        <p:nvSpPr>
+          <p:cNvPr id="10" name="TextBox 9"/>
+          <p:cNvSpPr txBox="1"/>
+          <p:nvPr/>
+        </p:nvSpPr>
+        <p:spPr>
+          <a:xfrm>
+            <a:off x="1380744" y="2304288"/>
+            <a:ext cx="9162288" cy="502919"/>
+          </a:xfrm>
+          <a:prstGeom prst="rect">
+            <a:avLst/>
+          </a:prstGeom>
+          <a:noFill/>
+        </p:spPr>
+        <p:txBody>
+          <a:bodyPr wrap="square" lIns="18288" rIns="18288" tIns="9144" bIns="9144" anchor="t">
+            <a:spAutoFit/>
+          </a:bodyPr>
+          <a:lstStyle/>
+          <a:p>
+            <a:pPr>
+              <a:defRPr sz="1700" b="0">
+                <a:solidFill>
+                  <a:srgbClr val="1B1F2A"/>
+                </a:solidFill>
+                <a:latin typeface="Apple SD Gothic Neo"/>
+              </a:defRPr>
+            </a:pPr>
+            <a:r>
+              <a:t>Ethereum은 custody와 validity anchor로 남는다.</a:t>
+            </a:r>
+          </a:p>
+        </p:txBody>
+      </p:sp>
+      <p:sp>
+        <p:nvSpPr>
+          <p:cNvPr id="11" name="Oval 10"/>
+          <p:cNvSpPr/>
+          <p:nvPr/>
+        </p:nvSpPr>
+        <p:spPr>
+          <a:xfrm>
+            <a:off x="1216152" y="2907792"/>
+            <a:ext cx="73152" cy="73152"/>
+          </a:xfrm>
+          <a:prstGeom prst="ellipse">
+            <a:avLst/>
+          </a:prstGeom>
+          <a:solidFill>
+            <a:srgbClr val="2563EB"/>
+          </a:solidFill>
+          <a:ln>
+            <a:noFill/>
+          </a:ln>
+        </p:spPr>
+        <p:style>
+          <a:lnRef idx="1">
+            <a:schemeClr val="accent1"/>
+          </a:lnRef>
+          <a:fillRef idx="3">
+            <a:schemeClr val="accent1"/>
+          </a:fillRef>
+          <a:effectRef idx="2">
+            <a:schemeClr val="accent1"/>
+          </a:effectRef>
+          <a:fontRef idx="minor">
+            <a:schemeClr val="lt1"/>
+          </a:fontRef>
+        </p:style>
+        <p:txBody>
+          <a:bodyPr rtlCol="0" anchor="ctr"/>
+          <a:lstStyle/>
+          <a:p>
+            <a:pPr algn="ctr"/>
+          </a:p>
+        </p:txBody>
+      </p:sp>
+      <p:sp>
+        <p:nvSpPr>
+          <p:cNvPr id="12" name="TextBox 11"/>
+          <p:cNvSpPr txBox="1"/>
+          <p:nvPr/>
+        </p:nvSpPr>
+        <p:spPr>
+          <a:xfrm>
+            <a:off x="1380744" y="2834640"/>
+            <a:ext cx="9162288" cy="502919"/>
+          </a:xfrm>
+          <a:prstGeom prst="rect">
+            <a:avLst/>
+          </a:prstGeom>
+          <a:noFill/>
+        </p:spPr>
+        <p:txBody>
+          <a:bodyPr wrap="square" lIns="18288" rIns="18288" tIns="9144" bIns="9144" anchor="t">
+            <a:spAutoFit/>
+          </a:bodyPr>
+          <a:lstStyle/>
+          <a:p>
+            <a:pPr>
+              <a:defRPr sz="1700" b="0">
+                <a:solidFill>
+                  <a:srgbClr val="1B1F2A"/>
+                </a:solidFill>
+                <a:latin typeface="Apple SD Gothic Neo"/>
+              </a:defRPr>
+            </a:pPr>
+            <a:r>
+              <a:t>브릿지는 arbitrary ABI interpretation이 아니라 registered metadata로 실행을 admission한다.</a:t>
+            </a:r>
+          </a:p>
+        </p:txBody>
+      </p:sp>
+      <p:sp>
+        <p:nvSpPr>
+          <p:cNvPr id="13" name="Oval 12"/>
+          <p:cNvSpPr/>
+          <p:nvPr/>
+        </p:nvSpPr>
+        <p:spPr>
+          <a:xfrm>
+            <a:off x="1216152" y="3438144"/>
+            <a:ext cx="73152" cy="73152"/>
+          </a:xfrm>
+          <a:prstGeom prst="ellipse">
+            <a:avLst/>
+          </a:prstGeom>
+          <a:solidFill>
+            <a:srgbClr val="2563EB"/>
+          </a:solidFill>
+          <a:ln>
+            <a:noFill/>
+          </a:ln>
+        </p:spPr>
+        <p:style>
+          <a:lnRef idx="1">
+            <a:schemeClr val="accent1"/>
+          </a:lnRef>
+          <a:fillRef idx="3">
+            <a:schemeClr val="accent1"/>
+          </a:fillRef>
+          <a:effectRef idx="2">
+            <a:schemeClr val="accent1"/>
+          </a:effectRef>
+          <a:fontRef idx="minor">
+            <a:schemeClr val="lt1"/>
+          </a:fontRef>
+        </p:style>
+        <p:txBody>
+          <a:bodyPr rtlCol="0" anchor="ctr"/>
+          <a:lstStyle/>
+          <a:p>
+            <a:pPr algn="ctr"/>
+          </a:p>
+        </p:txBody>
+      </p:sp>
+      <p:sp>
+        <p:nvSpPr>
+          <p:cNvPr id="14" name="TextBox 13"/>
+          <p:cNvSpPr txBox="1"/>
+          <p:nvPr/>
+        </p:nvSpPr>
+        <p:spPr>
+          <a:xfrm>
+            <a:off x="1380744" y="3364991"/>
+            <a:ext cx="9162288" cy="502919"/>
+          </a:xfrm>
+          <a:prstGeom prst="rect">
+            <a:avLst/>
+          </a:prstGeom>
+          <a:noFill/>
+        </p:spPr>
+        <p:txBody>
+          <a:bodyPr wrap="square" lIns="18288" rIns="18288" tIns="9144" bIns="9144" anchor="t">
+            <a:spAutoFit/>
+          </a:bodyPr>
+          <a:lstStyle/>
+          <a:p>
+            <a:pPr>
+              <a:defRPr sz="1700" b="0">
+                <a:solidFill>
+                  <a:srgbClr val="1B1F2A"/>
+                </a:solidFill>
+                <a:latin typeface="Apple SD Gothic Neo"/>
+              </a:defRPr>
+            </a:pPr>
+            <a:r>
+              <a:t>각 채널은 DApp policy, verifier binding, function root, storage vector를 snapshot한다.</a:t>
+            </a:r>
+          </a:p>
+        </p:txBody>
+      </p:sp>
+      <p:sp>
+        <p:nvSpPr>
+          <p:cNvPr id="15" name="Oval 14"/>
+          <p:cNvSpPr/>
+          <p:nvPr/>
+        </p:nvSpPr>
+        <p:spPr>
+          <a:xfrm>
+            <a:off x="1216152" y="3968496"/>
+            <a:ext cx="73152" cy="73152"/>
+          </a:xfrm>
+          <a:prstGeom prst="ellipse">
+            <a:avLst/>
+          </a:prstGeom>
+          <a:solidFill>
+            <a:srgbClr val="2563EB"/>
+          </a:solidFill>
+          <a:ln>
+            <a:noFill/>
+          </a:ln>
+        </p:spPr>
+        <p:style>
+          <a:lnRef idx="1">
+            <a:schemeClr val="accent1"/>
+          </a:lnRef>
+          <a:fillRef idx="3">
+            <a:schemeClr val="accent1"/>
+          </a:fillRef>
+          <a:effectRef idx="2">
+            <a:schemeClr val="accent1"/>
+          </a:effectRef>
+          <a:fontRef idx="minor">
+            <a:schemeClr val="lt1"/>
+          </a:fontRef>
+        </p:style>
+        <p:txBody>
+          <a:bodyPr rtlCol="0" anchor="ctr"/>
+          <a:lstStyle/>
+          <a:p>
+            <a:pPr algn="ctr"/>
+          </a:p>
+        </p:txBody>
+      </p:sp>
+      <p:sp>
+        <p:nvSpPr>
+          <p:cNvPr id="16" name="TextBox 15"/>
+          <p:cNvSpPr txBox="1"/>
+          <p:nvPr/>
+        </p:nvSpPr>
+        <p:spPr>
+          <a:xfrm>
+            <a:off x="1380744" y="3895344"/>
+            <a:ext cx="9162288" cy="502919"/>
+          </a:xfrm>
+          <a:prstGeom prst="rect">
+            <a:avLst/>
+          </a:prstGeom>
+          <a:noFill/>
+        </p:spPr>
+        <p:txBody>
+          <a:bodyPr wrap="square" lIns="18288" rIns="18288" tIns="9144" bIns="9144" anchor="t">
+            <a:spAutoFit/>
+          </a:bodyPr>
+          <a:lstStyle/>
+          <a:p>
+            <a:pPr>
+              <a:defRPr sz="1700" b="0">
+                <a:solidFill>
+                  <a:srgbClr val="1B1F2A"/>
+                </a:solidFill>
+                <a:latin typeface="Apple SD Gothic Neo"/>
+              </a:defRPr>
+            </a:pPr>
+            <a:r>
+              <a:t>Tokamak proof와 Groth16 accounting proof는 서로 다른 bridge responsibility를 맡는다.</a:t>
+            </a:r>
+          </a:p>
+        </p:txBody>
+      </p:sp>
+      <p:sp>
+        <p:nvSpPr>
+          <p:cNvPr id="17" name="Oval 16"/>
+          <p:cNvSpPr/>
+          <p:nvPr/>
+        </p:nvSpPr>
+        <p:spPr>
+          <a:xfrm>
+            <a:off x="1216152" y="4498848"/>
+            <a:ext cx="73152" cy="73152"/>
+          </a:xfrm>
+          <a:prstGeom prst="ellipse">
+            <a:avLst/>
+          </a:prstGeom>
+          <a:solidFill>
+            <a:srgbClr val="2563EB"/>
+          </a:solidFill>
+          <a:ln>
+            <a:noFill/>
+          </a:ln>
+        </p:spPr>
+        <p:style>
+          <a:lnRef idx="1">
+            <a:schemeClr val="accent1"/>
+          </a:lnRef>
+          <a:fillRef idx="3">
+            <a:schemeClr val="accent1"/>
+          </a:fillRef>
+          <a:effectRef idx="2">
+            <a:schemeClr val="accent1"/>
+          </a:effectRef>
+          <a:fontRef idx="minor">
+            <a:schemeClr val="lt1"/>
+          </a:fontRef>
+        </p:style>
+        <p:txBody>
+          <a:bodyPr rtlCol="0" anchor="ctr"/>
+          <a:lstStyle/>
+          <a:p>
+            <a:pPr algn="ctr"/>
+          </a:p>
+        </p:txBody>
+      </p:sp>
+      <p:sp>
+        <p:nvSpPr>
+          <p:cNvPr id="18" name="TextBox 17"/>
+          <p:cNvSpPr txBox="1"/>
+          <p:nvPr/>
+        </p:nvSpPr>
+        <p:spPr>
+          <a:xfrm>
+            <a:off x="1380744" y="4425696"/>
+            <a:ext cx="9162288" cy="502919"/>
+          </a:xfrm>
+          <a:prstGeom prst="rect">
+            <a:avLst/>
+          </a:prstGeom>
+          <a:noFill/>
+        </p:spPr>
+        <p:txBody>
+          <a:bodyPr wrap="square" lIns="18288" rIns="18288" tIns="9144" bIns="9144" anchor="t">
+            <a:spAutoFit/>
+          </a:bodyPr>
+          <a:lstStyle/>
+          <a:p>
+            <a:pPr>
+              <a:defRPr sz="1700" b="0">
+                <a:solidFill>
+                  <a:srgbClr val="1B1F2A"/>
+                </a:solidFill>
+                <a:latin typeface="Apple SD Gothic Neo"/>
+              </a:defRPr>
+            </a:pPr>
+            <a:r>
+              <a:t>private-state는 공개 L1 entry/exit 위에서 DApp-programmed privacy를 보여준다.</a:t>
+            </a:r>
+          </a:p>
+        </p:txBody>
+      </p:sp>
+      <p:sp>
+        <p:nvSpPr>
+          <p:cNvPr id="19" name="Rounded Rectangle 18"/>
+          <p:cNvSpPr/>
+          <p:nvPr/>
+        </p:nvSpPr>
+        <p:spPr>
+          <a:xfrm>
+            <a:off x="1463040" y="5413248"/>
+            <a:ext cx="9253728" cy="475488"/>
+          </a:xfrm>
+          <a:prstGeom prst="roundRect">
+            <a:avLst/>
+          </a:prstGeom>
+          <a:solidFill>
+            <a:srgbClr val="152238"/>
+          </a:solidFill>
+          <a:ln>
+            <a:noFill/>
+          </a:ln>
+        </p:spPr>
+        <p:style>
+          <a:lnRef idx="1">
+            <a:schemeClr val="accent1"/>
+          </a:lnRef>
+          <a:fillRef idx="3">
+            <a:schemeClr val="accent1"/>
+          </a:fillRef>
+          <a:effectRef idx="2">
+            <a:schemeClr val="accent1"/>
+          </a:effectRef>
+          <a:fontRef idx="minor">
+            <a:schemeClr val="lt1"/>
+          </a:fontRef>
+        </p:style>
+        <p:txBody>
+          <a:bodyPr rtlCol="0" anchor="ctr"/>
+          <a:lstStyle/>
+          <a:p>
+            <a:pPr algn="ctr"/>
+          </a:p>
+        </p:txBody>
+      </p:sp>
+      <p:sp>
+        <p:nvSpPr>
+          <p:cNvPr id="20" name="TextBox 19"/>
+          <p:cNvSpPr txBox="1"/>
+          <p:nvPr/>
+        </p:nvSpPr>
+        <p:spPr>
+          <a:xfrm>
+            <a:off x="1719072" y="5550408"/>
+            <a:ext cx="8741664" cy="219456"/>
+          </a:xfrm>
+          <a:prstGeom prst="rect">
+            <a:avLst/>
+          </a:prstGeom>
+          <a:noFill/>
+        </p:spPr>
+        <p:txBody>
+          <a:bodyPr wrap="square" lIns="18288" rIns="18288" tIns="9144" bIns="9144" anchor="ctr">
+            <a:spAutoFit/>
+          </a:bodyPr>
+          <a:lstStyle/>
+          <a:p>
+            <a:pPr algn="ctr">
+              <a:defRPr sz="1400" b="1">
+                <a:solidFill>
+                  <a:srgbClr val="FFFFFF"/>
+                </a:solidFill>
+                <a:latin typeface="Apple SD Gothic Neo"/>
+              </a:defRPr>
+            </a:pPr>
+            <a:r>
+              <a:t>핵심 질문은 proof가 verify되는가뿐 아니라, 어떤 policy가 그 proof에 의미를 부여하는가이다.</a:t>
             </a:r>
           </a:p>
         </p:txBody>

</xml_diff>

<commit_message>
Clarify bridge proof verification model
</commit_message>
<xml_diff>
--- a/bridge/docs/dev/spec.pptx
+++ b/bridge/docs/dev/spec.pptx
@@ -5172,7 +5172,7 @@
               </a:defRPr>
             </a:pPr>
             <a:r>
-              <a:t>브릿지는 DApp transaction 원문을 실행하지 않고, registered metadata와 verifier로 proof의 의미를 검증한다.</a:t>
+              <a:t>브릿지의 실제 책임은 원문 transaction 실행이 아니라, 등록된 verifier와 metadata로 proof/public input을 검증하는 것이다.</a:t>
             </a:r>
           </a:p>
         </p:txBody>
@@ -5294,13 +5294,85 @@
       </p:sp>
       <p:sp>
         <p:nvSpPr>
-          <p:cNvPr id="9" name="Rounded Rectangle 8"/>
+          <p:cNvPr id="9" name="TextBox 8"/>
+          <p:cNvSpPr txBox="1"/>
+          <p:nvPr/>
+        </p:nvSpPr>
+        <p:spPr>
+          <a:xfrm>
+            <a:off x="1078992" y="2267712"/>
+            <a:ext cx="1133856" cy="201168"/>
+          </a:xfrm>
+          <a:prstGeom prst="rect">
+            <a:avLst/>
+          </a:prstGeom>
+          <a:noFill/>
+        </p:spPr>
+        <p:txBody>
+          <a:bodyPr wrap="square" lIns="18288" rIns="18288" tIns="9144" bIns="9144" anchor="t">
+            <a:spAutoFit/>
+          </a:bodyPr>
+          <a:lstStyle/>
+          <a:p>
+            <a:pPr>
+              <a:defRPr sz="1100" b="1">
+                <a:solidFill>
+                  <a:srgbClr val="5C667A"/>
+                </a:solidFill>
+                <a:latin typeface="Apple SD Gothic Neo"/>
+              </a:defRPr>
+            </a:pPr>
+            <a:r>
+              <a:t>채널 내부</a:t>
+            </a:r>
+          </a:p>
+        </p:txBody>
+      </p:sp>
+      <p:sp>
+        <p:nvSpPr>
+          <p:cNvPr id="10" name="TextBox 9"/>
+          <p:cNvSpPr txBox="1"/>
+          <p:nvPr/>
+        </p:nvSpPr>
+        <p:spPr>
+          <a:xfrm>
+            <a:off x="5074920" y="2267712"/>
+            <a:ext cx="1234440" cy="201168"/>
+          </a:xfrm>
+          <a:prstGeom prst="rect">
+            <a:avLst/>
+          </a:prstGeom>
+          <a:noFill/>
+        </p:spPr>
+        <p:txBody>
+          <a:bodyPr wrap="square" lIns="18288" rIns="18288" tIns="9144" bIns="9144" anchor="t">
+            <a:spAutoFit/>
+          </a:bodyPr>
+          <a:lstStyle/>
+          <a:p>
+            <a:pPr>
+              <a:defRPr sz="1100" b="1">
+                <a:solidFill>
+                  <a:srgbClr val="2563EB"/>
+                </a:solidFill>
+                <a:latin typeface="Apple SD Gothic Neo"/>
+              </a:defRPr>
+            </a:pPr>
+            <a:r>
+              <a:t>브릿지 입력</a:t>
+            </a:r>
+          </a:p>
+        </p:txBody>
+      </p:sp>
+      <p:sp>
+        <p:nvSpPr>
+          <p:cNvPr id="11" name="Rounded Rectangle 10"/>
           <p:cNvSpPr/>
           <p:nvPr/>
         </p:nvSpPr>
         <p:spPr>
           <a:xfrm>
-            <a:off x="859536" y="2834640"/>
+            <a:off x="859536" y="2743200"/>
             <a:ext cx="1755648" cy="640080"/>
           </a:xfrm>
           <a:prstGeom prst="roundRect">
@@ -5339,13 +5411,13 @@
       </p:sp>
       <p:sp>
         <p:nvSpPr>
-          <p:cNvPr id="10" name="TextBox 9"/>
-          <p:cNvSpPr txBox="1"/>
-          <p:nvPr/>
-        </p:nvSpPr>
-        <p:spPr>
-          <a:xfrm>
-            <a:off x="923544" y="2907792"/>
+          <p:cNvPr id="12" name="TextBox 11"/>
+          <p:cNvSpPr txBox="1"/>
+          <p:nvPr/>
+        </p:nvSpPr>
+        <p:spPr>
+          <a:xfrm>
+            <a:off x="923544" y="2816352"/>
             <a:ext cx="1627631" cy="493775"/>
           </a:xfrm>
           <a:prstGeom prst="rect">
@@ -5388,13 +5460,13 @@
       </p:sp>
       <p:sp>
         <p:nvSpPr>
-          <p:cNvPr id="11" name="Rounded Rectangle 10"/>
+          <p:cNvPr id="13" name="Rounded Rectangle 12"/>
           <p:cNvSpPr/>
           <p:nvPr/>
         </p:nvSpPr>
         <p:spPr>
           <a:xfrm>
-            <a:off x="3072384" y="2834640"/>
+            <a:off x="3072384" y="2743200"/>
             <a:ext cx="1280160" cy="640080"/>
           </a:xfrm>
           <a:prstGeom prst="roundRect">
@@ -5433,13 +5505,13 @@
       </p:sp>
       <p:sp>
         <p:nvSpPr>
-          <p:cNvPr id="12" name="TextBox 11"/>
-          <p:cNvSpPr txBox="1"/>
-          <p:nvPr/>
-        </p:nvSpPr>
-        <p:spPr>
-          <a:xfrm>
-            <a:off x="3136391" y="2907792"/>
+          <p:cNvPr id="14" name="TextBox 13"/>
+          <p:cNvSpPr txBox="1"/>
+          <p:nvPr/>
+        </p:nvSpPr>
+        <p:spPr>
+          <a:xfrm>
+            <a:off x="3136391" y="2816352"/>
             <a:ext cx="1152143" cy="493775"/>
           </a:xfrm>
           <a:prstGeom prst="rect">
@@ -5469,14 +5541,14 @@
       </p:sp>
       <p:sp>
         <p:nvSpPr>
-          <p:cNvPr id="13" name="Rounded Rectangle 12"/>
+          <p:cNvPr id="15" name="Rounded Rectangle 14"/>
           <p:cNvSpPr/>
           <p:nvPr/>
         </p:nvSpPr>
         <p:spPr>
           <a:xfrm>
-            <a:off x="4791456" y="2834640"/>
-            <a:ext cx="1115568" cy="640080"/>
+            <a:off x="4791456" y="2706624"/>
+            <a:ext cx="1371600" cy="713232"/>
           </a:xfrm>
           <a:prstGeom prst="roundRect">
             <a:avLst/>
@@ -5514,14 +5586,14 @@
       </p:sp>
       <p:sp>
         <p:nvSpPr>
-          <p:cNvPr id="14" name="TextBox 13"/>
-          <p:cNvSpPr txBox="1"/>
-          <p:nvPr/>
-        </p:nvSpPr>
-        <p:spPr>
-          <a:xfrm>
-            <a:off x="4855464" y="2907792"/>
-            <a:ext cx="987552" cy="493775"/>
+          <p:cNvPr id="16" name="TextBox 15"/>
+          <p:cNvSpPr txBox="1"/>
+          <p:nvPr/>
+        </p:nvSpPr>
+        <p:spPr>
+          <a:xfrm>
+            <a:off x="4855464" y="2779776"/>
+            <a:ext cx="1243584" cy="566928"/>
           </a:xfrm>
           <a:prstGeom prst="rect">
             <a:avLst/>
@@ -5535,7 +5607,7 @@
           <a:lstStyle/>
           <a:p>
             <a:pPr algn="ctr">
-              <a:defRPr sz="1200" b="1">
+              <a:defRPr sz="1100" b="1">
                 <a:solidFill>
                   <a:srgbClr val="1B1F2A"/>
                 </a:solidFill>
@@ -5546,18 +5618,31 @@
               <a:t>ZKP</a:t>
             </a:r>
           </a:p>
-        </p:txBody>
-      </p:sp>
-      <p:sp>
-        <p:nvSpPr>
-          <p:cNvPr id="15" name="Rounded Rectangle 14"/>
+          <a:p>
+            <a:pPr algn="ctr">
+              <a:defRPr sz="1100" b="1">
+                <a:solidFill>
+                  <a:srgbClr val="1B1F2A"/>
+                </a:solidFill>
+                <a:latin typeface="Apple SD Gothic Neo"/>
+              </a:defRPr>
+            </a:pPr>
+            <a:r>
+              <a:t>+ public input</a:t>
+            </a:r>
+          </a:p>
+        </p:txBody>
+      </p:sp>
+      <p:sp>
+        <p:nvSpPr>
+          <p:cNvPr id="17" name="Rounded Rectangle 16"/>
           <p:cNvSpPr/>
           <p:nvPr/>
         </p:nvSpPr>
         <p:spPr>
           <a:xfrm>
-            <a:off x="6382512" y="2724912"/>
-            <a:ext cx="2176272" cy="859536"/>
+            <a:off x="6565392" y="2651760"/>
+            <a:ext cx="2212848" cy="822960"/>
           </a:xfrm>
           <a:prstGeom prst="roundRect">
             <a:avLst/>
@@ -5595,14 +5680,14 @@
       </p:sp>
       <p:sp>
         <p:nvSpPr>
-          <p:cNvPr id="16" name="TextBox 15"/>
-          <p:cNvSpPr txBox="1"/>
-          <p:nvPr/>
-        </p:nvSpPr>
-        <p:spPr>
-          <a:xfrm>
-            <a:off x="6446520" y="2798064"/>
-            <a:ext cx="2048255" cy="713231"/>
+          <p:cNvPr id="18" name="TextBox 17"/>
+          <p:cNvSpPr txBox="1"/>
+          <p:nvPr/>
+        </p:nvSpPr>
+        <p:spPr>
+          <a:xfrm>
+            <a:off x="6629400" y="2724912"/>
+            <a:ext cx="2084831" cy="676656"/>
           </a:xfrm>
           <a:prstGeom prst="rect">
             <a:avLst/>
@@ -5644,13 +5729,13 @@
       </p:sp>
       <p:sp>
         <p:nvSpPr>
-          <p:cNvPr id="17" name="Rounded Rectangle 16"/>
+          <p:cNvPr id="19" name="Rounded Rectangle 18"/>
           <p:cNvSpPr/>
           <p:nvPr/>
         </p:nvSpPr>
         <p:spPr>
           <a:xfrm>
-            <a:off x="9162288" y="2834640"/>
+            <a:off x="9345168" y="2743200"/>
             <a:ext cx="1554480" cy="640080"/>
           </a:xfrm>
           <a:prstGeom prst="roundRect">
@@ -5689,13 +5774,13 @@
       </p:sp>
       <p:sp>
         <p:nvSpPr>
-          <p:cNvPr id="18" name="TextBox 17"/>
-          <p:cNvSpPr txBox="1"/>
-          <p:nvPr/>
-        </p:nvSpPr>
-        <p:spPr>
-          <a:xfrm>
-            <a:off x="9226296" y="2907792"/>
+          <p:cNvPr id="20" name="TextBox 19"/>
+          <p:cNvSpPr txBox="1"/>
+          <p:nvPr/>
+        </p:nvSpPr>
+        <p:spPr>
+          <a:xfrm>
+            <a:off x="9409176" y="2816352"/>
             <a:ext cx="1426464" cy="493775"/>
           </a:xfrm>
           <a:prstGeom prst="rect">
@@ -5736,76 +5821,6 @@
           </a:p>
         </p:txBody>
       </p:sp>
-      <p:cxnSp>
-        <p:nvCxnSpPr>
-          <p:cNvPr id="19" name="Connector 18"/>
-          <p:cNvCxnSpPr/>
-          <p:nvPr/>
-        </p:nvCxnSpPr>
-        <p:spPr>
-          <a:xfrm>
-            <a:off x="2615184" y="3154680"/>
-            <a:ext cx="457200" cy="0"/>
-          </a:xfrm>
-          <a:prstGeom prst="line">
-            <a:avLst/>
-          </a:prstGeom>
-          <a:ln w="25400">
-            <a:solidFill>
-              <a:srgbClr val="2563EB"/>
-            </a:solidFill>
-          </a:ln>
-        </p:spPr>
-        <p:style>
-          <a:lnRef idx="2">
-            <a:schemeClr val="accent1"/>
-          </a:lnRef>
-          <a:fillRef idx="0">
-            <a:schemeClr val="accent1"/>
-          </a:fillRef>
-          <a:effectRef idx="1">
-            <a:schemeClr val="accent1"/>
-          </a:effectRef>
-          <a:fontRef idx="minor">
-            <a:schemeClr val="tx1"/>
-          </a:fontRef>
-        </p:style>
-      </p:cxnSp>
-      <p:cxnSp>
-        <p:nvCxnSpPr>
-          <p:cNvPr id="20" name="Connector 19"/>
-          <p:cNvCxnSpPr/>
-          <p:nvPr/>
-        </p:nvCxnSpPr>
-        <p:spPr>
-          <a:xfrm>
-            <a:off x="4352544" y="3154680"/>
-            <a:ext cx="438912" cy="0"/>
-          </a:xfrm>
-          <a:prstGeom prst="line">
-            <a:avLst/>
-          </a:prstGeom>
-          <a:ln w="25400">
-            <a:solidFill>
-              <a:srgbClr val="2563EB"/>
-            </a:solidFill>
-          </a:ln>
-        </p:spPr>
-        <p:style>
-          <a:lnRef idx="2">
-            <a:schemeClr val="accent1"/>
-          </a:lnRef>
-          <a:fillRef idx="0">
-            <a:schemeClr val="accent1"/>
-          </a:fillRef>
-          <a:effectRef idx="1">
-            <a:schemeClr val="accent1"/>
-          </a:effectRef>
-          <a:fontRef idx="minor">
-            <a:schemeClr val="tx1"/>
-          </a:fontRef>
-        </p:style>
-      </p:cxnSp>
       <p:cxnSp>
         <p:nvCxnSpPr>
           <p:cNvPr id="21" name="Connector 20"/>
@@ -5814,15 +5829,15 @@
         </p:nvCxnSpPr>
         <p:spPr>
           <a:xfrm>
-            <a:off x="5907024" y="3154680"/>
-            <a:ext cx="475488" cy="0"/>
+            <a:off x="2615184" y="3063240"/>
+            <a:ext cx="457200" cy="0"/>
           </a:xfrm>
           <a:prstGeom prst="line">
             <a:avLst/>
           </a:prstGeom>
           <a:ln w="25400">
             <a:solidFill>
-              <a:srgbClr val="2563EB"/>
+              <a:srgbClr val="5C667A"/>
             </a:solidFill>
           </a:ln>
         </p:spPr>
@@ -5849,8 +5864,8 @@
         </p:nvCxnSpPr>
         <p:spPr>
           <a:xfrm>
-            <a:off x="8558784" y="3154680"/>
-            <a:ext cx="603504" cy="0"/>
+            <a:off x="4352544" y="3063240"/>
+            <a:ext cx="438912" cy="0"/>
           </a:xfrm>
           <a:prstGeom prst="line">
             <a:avLst/>
@@ -5876,26 +5891,168 @@
           </a:fontRef>
         </p:style>
       </p:cxnSp>
-      <p:sp>
-        <p:nvSpPr>
-          <p:cNvPr id="23" name="Rounded Rectangle 22"/>
+      <p:cxnSp>
+        <p:nvCxnSpPr>
+          <p:cNvPr id="23" name="Connector 22"/>
+          <p:cNvCxnSpPr/>
+          <p:nvPr/>
+        </p:nvCxnSpPr>
+        <p:spPr>
+          <a:xfrm>
+            <a:off x="6163056" y="3063240"/>
+            <a:ext cx="402336" cy="0"/>
+          </a:xfrm>
+          <a:prstGeom prst="line">
+            <a:avLst/>
+          </a:prstGeom>
+          <a:ln w="25400">
+            <a:solidFill>
+              <a:srgbClr val="2563EB"/>
+            </a:solidFill>
+          </a:ln>
+        </p:spPr>
+        <p:style>
+          <a:lnRef idx="2">
+            <a:schemeClr val="accent1"/>
+          </a:lnRef>
+          <a:fillRef idx="0">
+            <a:schemeClr val="accent1"/>
+          </a:fillRef>
+          <a:effectRef idx="1">
+            <a:schemeClr val="accent1"/>
+          </a:effectRef>
+          <a:fontRef idx="minor">
+            <a:schemeClr val="tx1"/>
+          </a:fontRef>
+        </p:style>
+      </p:cxnSp>
+      <p:cxnSp>
+        <p:nvCxnSpPr>
+          <p:cNvPr id="24" name="Connector 23"/>
+          <p:cNvCxnSpPr/>
+          <p:nvPr/>
+        </p:nvCxnSpPr>
+        <p:spPr>
+          <a:xfrm>
+            <a:off x="8778240" y="3063240"/>
+            <a:ext cx="566928" cy="0"/>
+          </a:xfrm>
+          <a:prstGeom prst="line">
+            <a:avLst/>
+          </a:prstGeom>
+          <a:ln w="25400">
+            <a:solidFill>
+              <a:srgbClr val="2563EB"/>
+            </a:solidFill>
+          </a:ln>
+        </p:spPr>
+        <p:style>
+          <a:lnRef idx="2">
+            <a:schemeClr val="accent1"/>
+          </a:lnRef>
+          <a:fillRef idx="0">
+            <a:schemeClr val="accent1"/>
+          </a:fillRef>
+          <a:effectRef idx="1">
+            <a:schemeClr val="accent1"/>
+          </a:effectRef>
+          <a:fontRef idx="minor">
+            <a:schemeClr val="tx1"/>
+          </a:fontRef>
+        </p:style>
+      </p:cxnSp>
+      <p:cxnSp>
+        <p:nvCxnSpPr>
+          <p:cNvPr id="25" name="Connector 24"/>
+          <p:cNvCxnSpPr/>
+          <p:nvPr/>
+        </p:nvCxnSpPr>
+        <p:spPr>
+          <a:xfrm>
+            <a:off x="4590288" y="2359152"/>
+            <a:ext cx="0" cy="1325880"/>
+          </a:xfrm>
+          <a:prstGeom prst="line">
+            <a:avLst/>
+          </a:prstGeom>
+          <a:ln w="17780">
+            <a:solidFill>
+              <a:srgbClr val="2563EB"/>
+            </a:solidFill>
+            <a:prstDash val="dash"/>
+          </a:ln>
+        </p:spPr>
+        <p:style>
+          <a:lnRef idx="2">
+            <a:schemeClr val="accent1"/>
+          </a:lnRef>
+          <a:fillRef idx="0">
+            <a:schemeClr val="accent1"/>
+          </a:fillRef>
+          <a:effectRef idx="1">
+            <a:schemeClr val="accent1"/>
+          </a:effectRef>
+          <a:fontRef idx="minor">
+            <a:schemeClr val="tx1"/>
+          </a:fontRef>
+        </p:style>
+      </p:cxnSp>
+      <p:sp>
+        <p:nvSpPr>
+          <p:cNvPr id="26" name="TextBox 25"/>
+          <p:cNvSpPr txBox="1"/>
+          <p:nvPr/>
+        </p:nvSpPr>
+        <p:spPr>
+          <a:xfrm>
+            <a:off x="4160520" y="3703320"/>
+            <a:ext cx="1170432" cy="164592"/>
+          </a:xfrm>
+          <a:prstGeom prst="rect">
+            <a:avLst/>
+          </a:prstGeom>
+          <a:noFill/>
+        </p:spPr>
+        <p:txBody>
+          <a:bodyPr wrap="square" lIns="18288" rIns="18288" tIns="9144" bIns="9144" anchor="t">
+            <a:spAutoFit/>
+          </a:bodyPr>
+          <a:lstStyle/>
+          <a:p>
+            <a:pPr>
+              <a:defRPr sz="850" b="1">
+                <a:solidFill>
+                  <a:srgbClr val="2563EB"/>
+                </a:solidFill>
+                <a:latin typeface="Apple SD Gothic Neo"/>
+              </a:defRPr>
+            </a:pPr>
+            <a:r>
+              <a:t>only proof crosses</a:t>
+            </a:r>
+          </a:p>
+        </p:txBody>
+      </p:sp>
+      <p:sp>
+        <p:nvSpPr>
+          <p:cNvPr id="27" name="Rounded Rectangle 26"/>
           <p:cNvSpPr/>
           <p:nvPr/>
         </p:nvSpPr>
         <p:spPr>
           <a:xfrm>
-            <a:off x="932688" y="4251960"/>
-            <a:ext cx="4553712" cy="658368"/>
+            <a:off x="896112" y="4206240"/>
+            <a:ext cx="4059936" cy="804672"/>
           </a:xfrm>
           <a:prstGeom prst="roundRect">
             <a:avLst/>
           </a:prstGeom>
           <a:solidFill>
-            <a:srgbClr val="FFF4DE"/>
+            <a:srgbClr val="FFF2F2"/>
           </a:solidFill>
           <a:ln w="12700">
             <a:solidFill>
-              <a:srgbClr val="D8DDE6"/>
+              <a:srgbClr val="D94A4A"/>
             </a:solidFill>
           </a:ln>
         </p:spPr>
@@ -5923,14 +6080,14 @@
       </p:sp>
       <p:sp>
         <p:nvSpPr>
-          <p:cNvPr id="24" name="TextBox 23"/>
-          <p:cNvSpPr txBox="1"/>
-          <p:nvPr/>
-        </p:nvSpPr>
-        <p:spPr>
-          <a:xfrm>
-            <a:off x="1170432" y="4462272"/>
-            <a:ext cx="4096512" cy="201168"/>
+          <p:cNvPr id="28" name="TextBox 27"/>
+          <p:cNvSpPr txBox="1"/>
+          <p:nvPr/>
+        </p:nvSpPr>
+        <p:spPr>
+          <a:xfrm>
+            <a:off x="1225296" y="4370832"/>
+            <a:ext cx="1353312" cy="182880"/>
           </a:xfrm>
           <a:prstGeom prst="rect">
             <a:avLst/>
@@ -5944,7 +6101,43 @@
           <a:lstStyle/>
           <a:p>
             <a:pPr>
-              <a:defRPr sz="1250" b="1">
+              <a:defRPr sz="1050" b="1">
+                <a:solidFill>
+                  <a:srgbClr val="D94A4A"/>
+                </a:solidFill>
+                <a:latin typeface="Apple SD Gothic Neo"/>
+              </a:defRPr>
+            </a:pPr>
+            <a:r>
+              <a:t>사용하지 않는 경로</a:t>
+            </a:r>
+          </a:p>
+        </p:txBody>
+      </p:sp>
+      <p:sp>
+        <p:nvSpPr>
+          <p:cNvPr id="29" name="TextBox 28"/>
+          <p:cNvSpPr txBox="1"/>
+          <p:nvPr/>
+        </p:nvSpPr>
+        <p:spPr>
+          <a:xfrm>
+            <a:off x="1225296" y="4608576"/>
+            <a:ext cx="3346704" cy="182880"/>
+          </a:xfrm>
+          <a:prstGeom prst="rect">
+            <a:avLst/>
+          </a:prstGeom>
+          <a:noFill/>
+        </p:spPr>
+        <p:txBody>
+          <a:bodyPr wrap="square" lIns="18288" rIns="18288" tIns="9144" bIns="9144" anchor="t">
+            <a:spAutoFit/>
+          </a:bodyPr>
+          <a:lstStyle/>
+          <a:p>
+            <a:pPr>
+              <a:defRPr sz="1150" b="1">
                 <a:solidFill>
                   <a:srgbClr val="1B1F2A"/>
                 </a:solidFill>
@@ -5952,21 +6145,91 @@
               </a:defRPr>
             </a:pPr>
             <a:r>
-              <a:t>Replay model: L1이 transaction semantics를 직접 실행하거나 해석한다.</a:t>
-            </a:r>
-          </a:p>
-        </p:txBody>
-      </p:sp>
-      <p:sp>
-        <p:nvSpPr>
-          <p:cNvPr id="25" name="Rounded Rectangle 24"/>
+              <a:t>L1 replay / transaction semantics 직접 실행</a:t>
+            </a:r>
+          </a:p>
+        </p:txBody>
+      </p:sp>
+      <p:cxnSp>
+        <p:nvCxnSpPr>
+          <p:cNvPr id="30" name="Connector 29"/>
+          <p:cNvCxnSpPr/>
+          <p:nvPr/>
+        </p:nvCxnSpPr>
+        <p:spPr>
+          <a:xfrm>
+            <a:off x="987552" y="4343400"/>
+            <a:ext cx="146304" cy="338328"/>
+          </a:xfrm>
+          <a:prstGeom prst="line">
+            <a:avLst/>
+          </a:prstGeom>
+          <a:ln w="25400">
+            <a:solidFill>
+              <a:srgbClr val="D94A4A"/>
+            </a:solidFill>
+          </a:ln>
+        </p:spPr>
+        <p:style>
+          <a:lnRef idx="2">
+            <a:schemeClr val="accent1"/>
+          </a:lnRef>
+          <a:fillRef idx="0">
+            <a:schemeClr val="accent1"/>
+          </a:fillRef>
+          <a:effectRef idx="1">
+            <a:schemeClr val="accent1"/>
+          </a:effectRef>
+          <a:fontRef idx="minor">
+            <a:schemeClr val="tx1"/>
+          </a:fontRef>
+        </p:style>
+      </p:cxnSp>
+      <p:cxnSp>
+        <p:nvCxnSpPr>
+          <p:cNvPr id="31" name="Connector 30"/>
+          <p:cNvCxnSpPr/>
+          <p:nvPr/>
+        </p:nvCxnSpPr>
+        <p:spPr>
+          <a:xfrm flipH="1">
+            <a:off x="987552" y="4343400"/>
+            <a:ext cx="146304" cy="338328"/>
+          </a:xfrm>
+          <a:prstGeom prst="line">
+            <a:avLst/>
+          </a:prstGeom>
+          <a:ln w="25400">
+            <a:solidFill>
+              <a:srgbClr val="D94A4A"/>
+            </a:solidFill>
+          </a:ln>
+        </p:spPr>
+        <p:style>
+          <a:lnRef idx="2">
+            <a:schemeClr val="accent1"/>
+          </a:lnRef>
+          <a:fillRef idx="0">
+            <a:schemeClr val="accent1"/>
+          </a:fillRef>
+          <a:effectRef idx="1">
+            <a:schemeClr val="accent1"/>
+          </a:effectRef>
+          <a:fontRef idx="minor">
+            <a:schemeClr val="tx1"/>
+          </a:fontRef>
+        </p:style>
+      </p:cxnSp>
+      <p:sp>
+        <p:nvSpPr>
+          <p:cNvPr id="32" name="Rounded Rectangle 31"/>
           <p:cNvSpPr/>
           <p:nvPr/>
         </p:nvSpPr>
         <p:spPr>
           <a:xfrm>
-            <a:off x="5907024" y="4251960"/>
-            <a:ext cx="4736592" cy="658368"/>
+            <a:off x="5376672" y="4114800"/>
+            <a:ext cx="5248656" cy="960120"/>
           </a:xfrm>
           <a:prstGeom prst="roundRect">
             <a:avLst/>
@@ -5976,7 +6239,7 @@
           </a:solidFill>
           <a:ln w="12700">
             <a:solidFill>
-              <a:srgbClr val="D8DDE6"/>
+              <a:srgbClr val="21A67A"/>
             </a:solidFill>
           </a:ln>
         </p:spPr>
@@ -6004,14 +6267,50 @@
       </p:sp>
       <p:sp>
         <p:nvSpPr>
-          <p:cNvPr id="26" name="TextBox 25"/>
-          <p:cNvSpPr txBox="1"/>
-          <p:nvPr/>
-        </p:nvSpPr>
-        <p:spPr>
-          <a:xfrm>
-            <a:off x="6144768" y="4462272"/>
-            <a:ext cx="4297680" cy="201168"/>
+          <p:cNvPr id="33" name="TextBox 32"/>
+          <p:cNvSpPr txBox="1"/>
+          <p:nvPr/>
+        </p:nvSpPr>
+        <p:spPr>
+          <a:xfrm>
+            <a:off x="5669280" y="4297680"/>
+            <a:ext cx="914400" cy="182880"/>
+          </a:xfrm>
+          <a:prstGeom prst="rect">
+            <a:avLst/>
+          </a:prstGeom>
+          <a:noFill/>
+        </p:spPr>
+        <p:txBody>
+          <a:bodyPr wrap="square" lIns="18288" rIns="18288" tIns="9144" bIns="9144" anchor="t">
+            <a:spAutoFit/>
+          </a:bodyPr>
+          <a:lstStyle/>
+          <a:p>
+            <a:pPr>
+              <a:defRPr sz="1050" b="1">
+                <a:solidFill>
+                  <a:srgbClr val="21A67A"/>
+                </a:solidFill>
+                <a:latin typeface="Apple SD Gothic Neo"/>
+              </a:defRPr>
+            </a:pPr>
+            <a:r>
+              <a:t>실제 경로</a:t>
+            </a:r>
+          </a:p>
+        </p:txBody>
+      </p:sp>
+      <p:sp>
+        <p:nvSpPr>
+          <p:cNvPr id="34" name="TextBox 33"/>
+          <p:cNvSpPr txBox="1"/>
+          <p:nvPr/>
+        </p:nvSpPr>
+        <p:spPr>
+          <a:xfrm>
+            <a:off x="5669280" y="4553712"/>
+            <a:ext cx="4443984" cy="219456"/>
           </a:xfrm>
           <a:prstGeom prst="rect">
             <a:avLst/>
@@ -6033,21 +6332,57 @@
               </a:defRPr>
             </a:pPr>
             <a:r>
-              <a:t>Proof verification model: L1은 proof, public input, metadata만 확인한다.</a:t>
-            </a:r>
-          </a:p>
-        </p:txBody>
-      </p:sp>
-      <p:sp>
-        <p:nvSpPr>
-          <p:cNvPr id="27" name="Rounded Rectangle 26"/>
+              <a:t>L1은 proof, public input, registered metadata만 확인한다.</a:t>
+            </a:r>
+          </a:p>
+        </p:txBody>
+      </p:sp>
+      <p:sp>
+        <p:nvSpPr>
+          <p:cNvPr id="35" name="TextBox 34"/>
+          <p:cNvSpPr txBox="1"/>
+          <p:nvPr/>
+        </p:nvSpPr>
+        <p:spPr>
+          <a:xfrm>
+            <a:off x="5669280" y="4773168"/>
+            <a:ext cx="4590288" cy="182880"/>
+          </a:xfrm>
+          <a:prstGeom prst="rect">
+            <a:avLst/>
+          </a:prstGeom>
+          <a:noFill/>
+        </p:spPr>
+        <p:txBody>
+          <a:bodyPr wrap="square" lIns="18288" rIns="18288" tIns="9144" bIns="9144" anchor="t">
+            <a:spAutoFit/>
+          </a:bodyPr>
+          <a:lstStyle/>
+          <a:p>
+            <a:pPr>
+              <a:defRPr sz="1050" b="0">
+                <a:solidFill>
+                  <a:srgbClr val="5C667A"/>
+                </a:solidFill>
+                <a:latin typeface="Apple SD Gothic Neo"/>
+              </a:defRPr>
+            </a:pPr>
+            <a:r>
+              <a:t>원본 transaction과 witness는 브릿지/Ethereum에서 실행되거나 해석되지 않는다.</a:t>
+            </a:r>
+          </a:p>
+        </p:txBody>
+      </p:sp>
+      <p:sp>
+        <p:nvSpPr>
+          <p:cNvPr id="36" name="Rounded Rectangle 35"/>
           <p:cNvSpPr/>
           <p:nvPr/>
         </p:nvSpPr>
         <p:spPr>
           <a:xfrm>
-            <a:off x="1078992" y="5321808"/>
-            <a:ext cx="10040112" cy="457200"/>
+            <a:off x="1078992" y="5413248"/>
+            <a:ext cx="10040112" cy="438912"/>
           </a:xfrm>
           <a:prstGeom prst="roundRect">
             <a:avLst/>
@@ -6083,13 +6418,13 @@
       </p:sp>
       <p:sp>
         <p:nvSpPr>
-          <p:cNvPr id="28" name="TextBox 27"/>
-          <p:cNvSpPr txBox="1"/>
-          <p:nvPr/>
-        </p:nvSpPr>
-        <p:spPr>
-          <a:xfrm>
-            <a:off x="1316736" y="5449824"/>
+          <p:cNvPr id="37" name="TextBox 36"/>
+          <p:cNvSpPr txBox="1"/>
+          <p:nvPr/>
+        </p:nvSpPr>
+        <p:spPr>
+          <a:xfrm>
+            <a:off x="1316736" y="5532120"/>
             <a:ext cx="9582912" cy="164592"/>
           </a:xfrm>
           <a:prstGeom prst="rect">
@@ -6104,7 +6439,7 @@
           <a:lstStyle/>
           <a:p>
             <a:pPr algn="ctr">
-              <a:defRPr sz="1280" b="1">
+              <a:defRPr sz="1300" b="1">
                 <a:solidFill>
                   <a:srgbClr val="FFFFFF"/>
                 </a:solidFill>
@@ -6112,7 +6447,7 @@
               </a:defRPr>
             </a:pPr>
             <a:r>
-              <a:t>Ethereum은 원본 transaction을 보지 않아도 transition validity를 받아들일 수 있다.</a:t>
+              <a:t>따라서 이 시스템의 bridge model은 proof verification model 하나다.</a:t>
             </a:r>
           </a:p>
         </p:txBody>

</xml_diff>

<commit_message>
Expand policy examples in bridge deck overview
</commit_message>
<xml_diff>
--- a/bridge/docs/dev/spec.pptx
+++ b/bridge/docs/dev/spec.pptx
@@ -34039,7 +34039,7 @@
         </p:nvSpPr>
         <p:spPr>
           <a:xfrm>
-            <a:off x="804672" y="1883664"/>
+            <a:off x="804672" y="1828800"/>
             <a:ext cx="2377440" cy="237744"/>
           </a:xfrm>
           <a:prstGeom prst="rect">
@@ -34054,7 +34054,7 @@
           <a:lstStyle/>
           <a:p>
             <a:pPr>
-              <a:defRPr sz="1500" b="1">
+              <a:defRPr sz="1400" b="1">
                 <a:solidFill>
                   <a:srgbClr val="2563EB"/>
                 </a:solidFill>
@@ -34075,7 +34075,7 @@
         </p:nvSpPr>
         <p:spPr>
           <a:xfrm>
-            <a:off x="4956048" y="1883664"/>
+            <a:off x="4956048" y="1828800"/>
             <a:ext cx="1463040" cy="237744"/>
           </a:xfrm>
           <a:prstGeom prst="rect">
@@ -34090,7 +34090,7 @@
           <a:lstStyle/>
           <a:p>
             <a:pPr>
-              <a:defRPr sz="1500" b="1">
+              <a:defRPr sz="1400" b="1">
                 <a:solidFill>
                   <a:srgbClr val="354052"/>
                 </a:solidFill>
@@ -34111,7 +34111,7 @@
         </p:nvSpPr>
         <p:spPr>
           <a:xfrm>
-            <a:off x="8028431" y="1883664"/>
+            <a:off x="8028431" y="1828800"/>
             <a:ext cx="2011680" cy="237744"/>
           </a:xfrm>
           <a:prstGeom prst="rect">
@@ -34126,7 +34126,7 @@
           <a:lstStyle/>
           <a:p>
             <a:pPr>
-              <a:defRPr sz="1500" b="1">
+              <a:defRPr sz="1400" b="1">
                 <a:solidFill>
                   <a:srgbClr val="21A67A"/>
                 </a:solidFill>
@@ -34147,8 +34147,8 @@
         </p:nvSpPr>
         <p:spPr>
           <a:xfrm>
-            <a:off x="713232" y="2267712"/>
-            <a:ext cx="2606040" cy="384048"/>
+            <a:off x="713232" y="2157984"/>
+            <a:ext cx="2606040" cy="310896"/>
           </a:xfrm>
           <a:prstGeom prst="roundRect">
             <a:avLst/>
@@ -34192,8 +34192,8 @@
         </p:nvSpPr>
         <p:spPr>
           <a:xfrm>
-            <a:off x="914400" y="2368296"/>
-            <a:ext cx="2194560" cy="146304"/>
+            <a:off x="914400" y="2240279"/>
+            <a:ext cx="2194560" cy="128016"/>
           </a:xfrm>
           <a:prstGeom prst="rect">
             <a:avLst/>
@@ -34207,7 +34207,7 @@
           <a:lstStyle/>
           <a:p>
             <a:pPr>
-              <a:defRPr sz="1150" b="1">
+              <a:defRPr sz="1060" b="1">
                 <a:solidFill>
                   <a:srgbClr val="1B1F2A"/>
                 </a:solidFill>
@@ -34228,8 +34228,8 @@
         </p:nvSpPr>
         <p:spPr>
           <a:xfrm>
-            <a:off x="713232" y="2834640"/>
-            <a:ext cx="2606040" cy="384048"/>
+            <a:off x="713232" y="2615184"/>
+            <a:ext cx="2606040" cy="310896"/>
           </a:xfrm>
           <a:prstGeom prst="roundRect">
             <a:avLst/>
@@ -34273,8 +34273,8 @@
         </p:nvSpPr>
         <p:spPr>
           <a:xfrm>
-            <a:off x="914400" y="2935224"/>
-            <a:ext cx="2194560" cy="146304"/>
+            <a:off x="914400" y="2697479"/>
+            <a:ext cx="2194560" cy="128016"/>
           </a:xfrm>
           <a:prstGeom prst="rect">
             <a:avLst/>
@@ -34288,7 +34288,7 @@
           <a:lstStyle/>
           <a:p>
             <a:pPr>
-              <a:defRPr sz="1150" b="1">
+              <a:defRPr sz="1060" b="1">
                 <a:solidFill>
                   <a:srgbClr val="1B1F2A"/>
                 </a:solidFill>
@@ -34309,8 +34309,8 @@
         </p:nvSpPr>
         <p:spPr>
           <a:xfrm>
-            <a:off x="713232" y="3401568"/>
-            <a:ext cx="2606040" cy="384048"/>
+            <a:off x="713232" y="3072384"/>
+            <a:ext cx="2606040" cy="310896"/>
           </a:xfrm>
           <a:prstGeom prst="roundRect">
             <a:avLst/>
@@ -34354,8 +34354,8 @@
         </p:nvSpPr>
         <p:spPr>
           <a:xfrm>
-            <a:off x="914400" y="3502151"/>
-            <a:ext cx="2194560" cy="146304"/>
+            <a:off x="914400" y="3154679"/>
+            <a:ext cx="2194560" cy="128016"/>
           </a:xfrm>
           <a:prstGeom prst="rect">
             <a:avLst/>
@@ -34369,7 +34369,7 @@
           <a:lstStyle/>
           <a:p>
             <a:pPr>
-              <a:defRPr sz="1150" b="1">
+              <a:defRPr sz="1060" b="1">
                 <a:solidFill>
                   <a:srgbClr val="1B1F2A"/>
                 </a:solidFill>
@@ -34390,8 +34390,8 @@
         </p:nvSpPr>
         <p:spPr>
           <a:xfrm>
-            <a:off x="713232" y="3913632"/>
-            <a:ext cx="2606040" cy="1115568"/>
+            <a:off x="713232" y="3675887"/>
+            <a:ext cx="4005072" cy="1335024"/>
           </a:xfrm>
           <a:prstGeom prst="roundRect">
             <a:avLst/>
@@ -34435,8 +34435,8 @@
         </p:nvSpPr>
         <p:spPr>
           <a:xfrm>
-            <a:off x="914400" y="4069080"/>
-            <a:ext cx="1463040" cy="164592"/>
+            <a:off x="914400" y="3822191"/>
+            <a:ext cx="1645920" cy="164592"/>
           </a:xfrm>
           <a:prstGeom prst="rect">
             <a:avLst/>
@@ -34450,7 +34450,7 @@
           <a:lstStyle/>
           <a:p>
             <a:pPr>
-              <a:defRPr sz="1120" b="1">
+              <a:defRPr sz="1140" b="1">
                 <a:solidFill>
                   <a:srgbClr val="2563EB"/>
                 </a:solidFill>
@@ -34471,7 +34471,7 @@
         </p:nvSpPr>
         <p:spPr>
           <a:xfrm>
-            <a:off x="950976" y="4425696"/>
+            <a:off x="950976" y="4169664"/>
             <a:ext cx="73152" cy="73152"/>
           </a:xfrm>
           <a:prstGeom prst="ellipse">
@@ -34514,8 +34514,8 @@
         </p:nvSpPr>
         <p:spPr>
           <a:xfrm>
-            <a:off x="1115568" y="4352544"/>
-            <a:ext cx="1828800" cy="173736"/>
+            <a:off x="1115568" y="4096512"/>
+            <a:ext cx="1554480" cy="192024"/>
           </a:xfrm>
           <a:prstGeom prst="rect">
             <a:avLst/>
@@ -34529,7 +34529,7 @@
           <a:lstStyle/>
           <a:p>
             <a:pPr>
-              <a:defRPr sz="980" b="0">
+              <a:defRPr sz="1050" b="0">
                 <a:solidFill>
                   <a:srgbClr val="1B1F2A"/>
                 </a:solidFill>
@@ -34537,7 +34537,7 @@
               </a:defRPr>
             </a:pPr>
             <a:r>
-              <a:t>proof 의미</a:t>
+              <a:t>DApp 실행 종류</a:t>
             </a:r>
           </a:p>
         </p:txBody>
@@ -34550,7 +34550,7 @@
         </p:nvSpPr>
         <p:spPr>
           <a:xfrm>
-            <a:off x="950976" y="4626864"/>
+            <a:off x="950976" y="4389120"/>
             <a:ext cx="73152" cy="73152"/>
           </a:xfrm>
           <a:prstGeom prst="ellipse">
@@ -34593,8 +34593,8 @@
         </p:nvSpPr>
         <p:spPr>
           <a:xfrm>
-            <a:off x="1115568" y="4553712"/>
-            <a:ext cx="1828800" cy="173736"/>
+            <a:off x="1115568" y="4315968"/>
+            <a:ext cx="1554480" cy="192024"/>
           </a:xfrm>
           <a:prstGeom prst="rect">
             <a:avLst/>
@@ -34608,7 +34608,7 @@
           <a:lstStyle/>
           <a:p>
             <a:pPr>
-              <a:defRPr sz="980" b="0">
+              <a:defRPr sz="1050" b="0">
                 <a:solidFill>
                   <a:srgbClr val="1B1F2A"/>
                 </a:solidFill>
@@ -34616,7 +34616,7 @@
               </a:defRPr>
             </a:pPr>
             <a:r>
-              <a:t>public input</a:t>
+              <a:t>받을 proof</a:t>
             </a:r>
           </a:p>
         </p:txBody>
@@ -34629,7 +34629,7 @@
         </p:nvSpPr>
         <p:spPr>
           <a:xfrm>
-            <a:off x="950976" y="4828032"/>
+            <a:off x="950976" y="4608576"/>
             <a:ext cx="73152" cy="73152"/>
           </a:xfrm>
           <a:prstGeom prst="ellipse">
@@ -34672,8 +34672,8 @@
         </p:nvSpPr>
         <p:spPr>
           <a:xfrm>
-            <a:off x="1115568" y="4754880"/>
-            <a:ext cx="1828800" cy="173736"/>
+            <a:off x="1115568" y="4535424"/>
+            <a:ext cx="1554480" cy="192024"/>
           </a:xfrm>
           <a:prstGeom prst="rect">
             <a:avLst/>
@@ -34687,7 +34687,7 @@
           <a:lstStyle/>
           <a:p>
             <a:pPr>
-              <a:defRPr sz="980" b="0">
+              <a:defRPr sz="1050" b="0">
                 <a:solidFill>
                   <a:srgbClr val="1B1F2A"/>
                 </a:solidFill>
@@ -34695,21 +34695,179 @@
               </a:defRPr>
             </a:pPr>
             <a:r>
-              <a:t>공개 데이터 범위</a:t>
-            </a:r>
-          </a:p>
-        </p:txBody>
-      </p:sp>
-      <p:sp>
-        <p:nvSpPr>
-          <p:cNvPr id="26" name="Rounded Rectangle 25"/>
+              <a:t>볼 public input</a:t>
+            </a:r>
+          </a:p>
+        </p:txBody>
+      </p:sp>
+      <p:sp>
+        <p:nvSpPr>
+          <p:cNvPr id="26" name="Oval 25"/>
           <p:cNvSpPr/>
           <p:nvPr/>
         </p:nvSpPr>
         <p:spPr>
           <a:xfrm>
-            <a:off x="4407408" y="2359152"/>
-            <a:ext cx="1828800" cy="2231136"/>
+            <a:off x="2852928" y="4169664"/>
+            <a:ext cx="73152" cy="73152"/>
+          </a:xfrm>
+          <a:prstGeom prst="ellipse">
+            <a:avLst/>
+          </a:prstGeom>
+          <a:solidFill>
+            <a:srgbClr val="2563EB"/>
+          </a:solidFill>
+          <a:ln>
+            <a:noFill/>
+          </a:ln>
+        </p:spPr>
+        <p:style>
+          <a:lnRef idx="1">
+            <a:schemeClr val="accent1"/>
+          </a:lnRef>
+          <a:fillRef idx="3">
+            <a:schemeClr val="accent1"/>
+          </a:fillRef>
+          <a:effectRef idx="2">
+            <a:schemeClr val="accent1"/>
+          </a:effectRef>
+          <a:fontRef idx="minor">
+            <a:schemeClr val="lt1"/>
+          </a:fontRef>
+        </p:style>
+        <p:txBody>
+          <a:bodyPr rtlCol="0" anchor="ctr"/>
+          <a:lstStyle/>
+          <a:p>
+            <a:pPr algn="ctr"/>
+          </a:p>
+        </p:txBody>
+      </p:sp>
+      <p:sp>
+        <p:nvSpPr>
+          <p:cNvPr id="27" name="TextBox 26"/>
+          <p:cNvSpPr txBox="1"/>
+          <p:nvPr/>
+        </p:nvSpPr>
+        <p:spPr>
+          <a:xfrm>
+            <a:off x="3017520" y="4096512"/>
+            <a:ext cx="1463040" cy="192024"/>
+          </a:xfrm>
+          <a:prstGeom prst="rect">
+            <a:avLst/>
+          </a:prstGeom>
+          <a:noFill/>
+        </p:spPr>
+        <p:txBody>
+          <a:bodyPr wrap="square" lIns="18288" rIns="18288" tIns="9144" bIns="9144" anchor="t">
+            <a:spAutoFit/>
+          </a:bodyPr>
+          <a:lstStyle/>
+          <a:p>
+            <a:pPr>
+              <a:defRPr sz="1050" b="0">
+                <a:solidFill>
+                  <a:srgbClr val="1B1F2A"/>
+                </a:solidFill>
+                <a:latin typeface="Apple SD Gothic Neo"/>
+              </a:defRPr>
+            </a:pPr>
+            <a:r>
+              <a:t>허용 상태 변경</a:t>
+            </a:r>
+          </a:p>
+        </p:txBody>
+      </p:sp>
+      <p:sp>
+        <p:nvSpPr>
+          <p:cNvPr id="28" name="Oval 27"/>
+          <p:cNvSpPr/>
+          <p:nvPr/>
+        </p:nvSpPr>
+        <p:spPr>
+          <a:xfrm>
+            <a:off x="2852928" y="4389120"/>
+            <a:ext cx="73152" cy="73152"/>
+          </a:xfrm>
+          <a:prstGeom prst="ellipse">
+            <a:avLst/>
+          </a:prstGeom>
+          <a:solidFill>
+            <a:srgbClr val="2563EB"/>
+          </a:solidFill>
+          <a:ln>
+            <a:noFill/>
+          </a:ln>
+        </p:spPr>
+        <p:style>
+          <a:lnRef idx="1">
+            <a:schemeClr val="accent1"/>
+          </a:lnRef>
+          <a:fillRef idx="3">
+            <a:schemeClr val="accent1"/>
+          </a:fillRef>
+          <a:effectRef idx="2">
+            <a:schemeClr val="accent1"/>
+          </a:effectRef>
+          <a:fontRef idx="minor">
+            <a:schemeClr val="lt1"/>
+          </a:fontRef>
+        </p:style>
+        <p:txBody>
+          <a:bodyPr rtlCol="0" anchor="ctr"/>
+          <a:lstStyle/>
+          <a:p>
+            <a:pPr algn="ctr"/>
+          </a:p>
+        </p:txBody>
+      </p:sp>
+      <p:sp>
+        <p:nvSpPr>
+          <p:cNvPr id="29" name="TextBox 28"/>
+          <p:cNvSpPr txBox="1"/>
+          <p:nvPr/>
+        </p:nvSpPr>
+        <p:spPr>
+          <a:xfrm>
+            <a:off x="3017520" y="4315968"/>
+            <a:ext cx="1463040" cy="192024"/>
+          </a:xfrm>
+          <a:prstGeom prst="rect">
+            <a:avLst/>
+          </a:prstGeom>
+          <a:noFill/>
+        </p:spPr>
+        <p:txBody>
+          <a:bodyPr wrap="square" lIns="18288" rIns="18288" tIns="9144" bIns="9144" anchor="t">
+            <a:spAutoFit/>
+          </a:bodyPr>
+          <a:lstStyle/>
+          <a:p>
+            <a:pPr>
+              <a:defRPr sz="1050" b="0">
+                <a:solidFill>
+                  <a:srgbClr val="1B1F2A"/>
+                </a:solidFill>
+                <a:latin typeface="Apple SD Gothic Neo"/>
+              </a:defRPr>
+            </a:pPr>
+            <a:r>
+              <a:t>공개 / 비공개 범위</a:t>
+            </a:r>
+          </a:p>
+        </p:txBody>
+      </p:sp>
+      <p:sp>
+        <p:nvSpPr>
+          <p:cNvPr id="30" name="Rounded Rectangle 29"/>
+          <p:cNvSpPr/>
+          <p:nvPr/>
+        </p:nvSpPr>
+        <p:spPr>
+          <a:xfrm>
+            <a:off x="4407408" y="2231136"/>
+            <a:ext cx="1828800" cy="1609344"/>
           </a:xfrm>
           <a:prstGeom prst="roundRect">
             <a:avLst/>
@@ -34747,14 +34905,14 @@
       </p:sp>
       <p:sp>
         <p:nvSpPr>
-          <p:cNvPr id="27" name="TextBox 26"/>
-          <p:cNvSpPr txBox="1"/>
-          <p:nvPr/>
-        </p:nvSpPr>
-        <p:spPr>
-          <a:xfrm>
-            <a:off x="4645152" y="2615184"/>
-            <a:ext cx="1353312" cy="237744"/>
+          <p:cNvPr id="31" name="TextBox 30"/>
+          <p:cNvSpPr txBox="1"/>
+          <p:nvPr/>
+        </p:nvSpPr>
+        <p:spPr>
+          <a:xfrm>
+            <a:off x="4645152" y="2450592"/>
+            <a:ext cx="1353312" cy="219456"/>
           </a:xfrm>
           <a:prstGeom prst="rect">
             <a:avLst/>
@@ -34768,7 +34926,7 @@
           <a:lstStyle/>
           <a:p>
             <a:pPr algn="ctr">
-              <a:defRPr sz="1700" b="1">
+              <a:defRPr sz="1600" b="1">
                 <a:solidFill>
                   <a:srgbClr val="1B1F2A"/>
                 </a:solidFill>
@@ -34783,14 +34941,14 @@
       </p:sp>
       <p:sp>
         <p:nvSpPr>
-          <p:cNvPr id="28" name="Rounded Rectangle 27"/>
+          <p:cNvPr id="32" name="Rounded Rectangle 31"/>
           <p:cNvSpPr/>
           <p:nvPr/>
         </p:nvSpPr>
         <p:spPr>
           <a:xfrm>
-            <a:off x="4645152" y="3072384"/>
-            <a:ext cx="1353312" cy="201168"/>
+            <a:off x="4645152" y="2852928"/>
+            <a:ext cx="1353312" cy="146304"/>
           </a:xfrm>
           <a:prstGeom prst="roundRect">
             <a:avLst/>
@@ -34828,14 +34986,14 @@
       </p:sp>
       <p:sp>
         <p:nvSpPr>
-          <p:cNvPr id="29" name="TextBox 28"/>
-          <p:cNvSpPr txBox="1"/>
-          <p:nvPr/>
-        </p:nvSpPr>
-        <p:spPr>
-          <a:xfrm>
-            <a:off x="4681728" y="3118104"/>
-            <a:ext cx="1280160" cy="73152"/>
+          <p:cNvPr id="33" name="TextBox 32"/>
+          <p:cNvSpPr txBox="1"/>
+          <p:nvPr/>
+        </p:nvSpPr>
+        <p:spPr>
+          <a:xfrm>
+            <a:off x="4681728" y="2880360"/>
+            <a:ext cx="1280160" cy="54864"/>
           </a:xfrm>
           <a:prstGeom prst="rect">
             <a:avLst/>
@@ -34849,7 +35007,7 @@
           <a:lstStyle/>
           <a:p>
             <a:pPr algn="ctr">
-              <a:defRPr sz="730" b="1">
+              <a:defRPr sz="630" b="1">
                 <a:solidFill>
                   <a:srgbClr val="5C667A"/>
                 </a:solidFill>
@@ -34864,14 +35022,14 @@
       </p:sp>
       <p:sp>
         <p:nvSpPr>
-          <p:cNvPr id="30" name="Rounded Rectangle 29"/>
+          <p:cNvPr id="34" name="Rounded Rectangle 33"/>
           <p:cNvSpPr/>
           <p:nvPr/>
         </p:nvSpPr>
         <p:spPr>
           <a:xfrm>
-            <a:off x="4645152" y="3383279"/>
-            <a:ext cx="1353312" cy="201168"/>
+            <a:off x="4645152" y="3081528"/>
+            <a:ext cx="1353312" cy="146304"/>
           </a:xfrm>
           <a:prstGeom prst="roundRect">
             <a:avLst/>
@@ -34909,14 +35067,14 @@
       </p:sp>
       <p:sp>
         <p:nvSpPr>
-          <p:cNvPr id="31" name="TextBox 30"/>
-          <p:cNvSpPr txBox="1"/>
-          <p:nvPr/>
-        </p:nvSpPr>
-        <p:spPr>
-          <a:xfrm>
-            <a:off x="4681728" y="3429000"/>
-            <a:ext cx="1280160" cy="73152"/>
+          <p:cNvPr id="35" name="TextBox 34"/>
+          <p:cNvSpPr txBox="1"/>
+          <p:nvPr/>
+        </p:nvSpPr>
+        <p:spPr>
+          <a:xfrm>
+            <a:off x="4681728" y="3108960"/>
+            <a:ext cx="1280160" cy="54864"/>
           </a:xfrm>
           <a:prstGeom prst="rect">
             <a:avLst/>
@@ -34930,7 +35088,7 @@
           <a:lstStyle/>
           <a:p>
             <a:pPr algn="ctr">
-              <a:defRPr sz="730" b="1">
+              <a:defRPr sz="630" b="1">
                 <a:solidFill>
                   <a:srgbClr val="5C667A"/>
                 </a:solidFill>
@@ -34945,14 +35103,14 @@
       </p:sp>
       <p:sp>
         <p:nvSpPr>
-          <p:cNvPr id="32" name="Rounded Rectangle 31"/>
+          <p:cNvPr id="36" name="Rounded Rectangle 35"/>
           <p:cNvSpPr/>
           <p:nvPr/>
         </p:nvSpPr>
         <p:spPr>
           <a:xfrm>
-            <a:off x="4645152" y="3694176"/>
-            <a:ext cx="1353312" cy="201168"/>
+            <a:off x="4645152" y="3310128"/>
+            <a:ext cx="1353312" cy="146304"/>
           </a:xfrm>
           <a:prstGeom prst="roundRect">
             <a:avLst/>
@@ -34990,14 +35148,14 @@
       </p:sp>
       <p:sp>
         <p:nvSpPr>
-          <p:cNvPr id="33" name="TextBox 32"/>
-          <p:cNvSpPr txBox="1"/>
-          <p:nvPr/>
-        </p:nvSpPr>
-        <p:spPr>
-          <a:xfrm>
-            <a:off x="4681728" y="3739896"/>
-            <a:ext cx="1280160" cy="73152"/>
+          <p:cNvPr id="37" name="TextBox 36"/>
+          <p:cNvSpPr txBox="1"/>
+          <p:nvPr/>
+        </p:nvSpPr>
+        <p:spPr>
+          <a:xfrm>
+            <a:off x="4681728" y="3337560"/>
+            <a:ext cx="1280160" cy="54864"/>
           </a:xfrm>
           <a:prstGeom prst="rect">
             <a:avLst/>
@@ -35011,7 +35169,7 @@
           <a:lstStyle/>
           <a:p>
             <a:pPr algn="ctr">
-              <a:defRPr sz="730" b="1">
+              <a:defRPr sz="630" b="1">
                 <a:solidFill>
                   <a:srgbClr val="5C667A"/>
                 </a:solidFill>
@@ -35026,14 +35184,14 @@
       </p:sp>
       <p:sp>
         <p:nvSpPr>
-          <p:cNvPr id="34" name="Rounded Rectangle 33"/>
+          <p:cNvPr id="38" name="Rounded Rectangle 37"/>
           <p:cNvSpPr/>
           <p:nvPr/>
         </p:nvSpPr>
         <p:spPr>
           <a:xfrm>
-            <a:off x="4645152" y="4005072"/>
-            <a:ext cx="1353312" cy="201168"/>
+            <a:off x="4645152" y="3538728"/>
+            <a:ext cx="1353312" cy="146304"/>
           </a:xfrm>
           <a:prstGeom prst="roundRect">
             <a:avLst/>
@@ -35071,14 +35229,14 @@
       </p:sp>
       <p:sp>
         <p:nvSpPr>
-          <p:cNvPr id="35" name="TextBox 34"/>
-          <p:cNvSpPr txBox="1"/>
-          <p:nvPr/>
-        </p:nvSpPr>
-        <p:spPr>
-          <a:xfrm>
-            <a:off x="4681728" y="4050791"/>
-            <a:ext cx="1280160" cy="73152"/>
+          <p:cNvPr id="39" name="TextBox 38"/>
+          <p:cNvSpPr txBox="1"/>
+          <p:nvPr/>
+        </p:nvSpPr>
+        <p:spPr>
+          <a:xfrm>
+            <a:off x="4681728" y="3566160"/>
+            <a:ext cx="1280160" cy="54864"/>
           </a:xfrm>
           <a:prstGeom prst="rect">
             <a:avLst/>
@@ -35092,7 +35250,7 @@
           <a:lstStyle/>
           <a:p>
             <a:pPr algn="ctr">
-              <a:defRPr sz="730" b="1">
+              <a:defRPr sz="630" b="1">
                 <a:solidFill>
                   <a:srgbClr val="5C667A"/>
                 </a:solidFill>
@@ -35107,14 +35265,14 @@
       </p:sp>
       <p:sp>
         <p:nvSpPr>
-          <p:cNvPr id="36" name="Rounded Rectangle 35"/>
+          <p:cNvPr id="40" name="Rounded Rectangle 39"/>
           <p:cNvSpPr/>
           <p:nvPr/>
         </p:nvSpPr>
         <p:spPr>
           <a:xfrm>
-            <a:off x="7552944" y="2267712"/>
-            <a:ext cx="3054096" cy="384048"/>
+            <a:off x="7552944" y="2157984"/>
+            <a:ext cx="3054096" cy="310896"/>
           </a:xfrm>
           <a:prstGeom prst="roundRect">
             <a:avLst/>
@@ -35152,14 +35310,14 @@
       </p:sp>
       <p:sp>
         <p:nvSpPr>
-          <p:cNvPr id="37" name="TextBox 36"/>
-          <p:cNvSpPr txBox="1"/>
-          <p:nvPr/>
-        </p:nvSpPr>
-        <p:spPr>
-          <a:xfrm>
-            <a:off x="7772400" y="2368296"/>
-            <a:ext cx="2487168" cy="146304"/>
+          <p:cNvPr id="41" name="TextBox 40"/>
+          <p:cNvSpPr txBox="1"/>
+          <p:nvPr/>
+        </p:nvSpPr>
+        <p:spPr>
+          <a:xfrm>
+            <a:off x="7772400" y="2240279"/>
+            <a:ext cx="2487168" cy="128016"/>
           </a:xfrm>
           <a:prstGeom prst="rect">
             <a:avLst/>
@@ -35173,7 +35331,7 @@
           <a:lstStyle/>
           <a:p>
             <a:pPr>
-              <a:defRPr sz="1150" b="1">
+              <a:defRPr sz="1060" b="1">
                 <a:solidFill>
                   <a:srgbClr val="1B1F2A"/>
                 </a:solidFill>
@@ -35188,14 +35346,14 @@
       </p:sp>
       <p:sp>
         <p:nvSpPr>
-          <p:cNvPr id="38" name="Rounded Rectangle 37"/>
+          <p:cNvPr id="42" name="Rounded Rectangle 41"/>
           <p:cNvSpPr/>
           <p:nvPr/>
         </p:nvSpPr>
         <p:spPr>
           <a:xfrm>
-            <a:off x="7552944" y="2834640"/>
-            <a:ext cx="3054096" cy="384048"/>
+            <a:off x="7552944" y="2615184"/>
+            <a:ext cx="3054096" cy="310896"/>
           </a:xfrm>
           <a:prstGeom prst="roundRect">
             <a:avLst/>
@@ -35233,14 +35391,14 @@
       </p:sp>
       <p:sp>
         <p:nvSpPr>
-          <p:cNvPr id="39" name="TextBox 38"/>
-          <p:cNvSpPr txBox="1"/>
-          <p:nvPr/>
-        </p:nvSpPr>
-        <p:spPr>
-          <a:xfrm>
-            <a:off x="7772400" y="2935224"/>
-            <a:ext cx="2487168" cy="146304"/>
+          <p:cNvPr id="43" name="TextBox 42"/>
+          <p:cNvSpPr txBox="1"/>
+          <p:nvPr/>
+        </p:nvSpPr>
+        <p:spPr>
+          <a:xfrm>
+            <a:off x="7772400" y="2697479"/>
+            <a:ext cx="2487168" cy="128016"/>
           </a:xfrm>
           <a:prstGeom prst="rect">
             <a:avLst/>
@@ -35254,7 +35412,7 @@
           <a:lstStyle/>
           <a:p>
             <a:pPr>
-              <a:defRPr sz="1150" b="1">
+              <a:defRPr sz="1060" b="1">
                 <a:solidFill>
                   <a:srgbClr val="1B1F2A"/>
                 </a:solidFill>
@@ -35269,14 +35427,14 @@
       </p:sp>
       <p:sp>
         <p:nvSpPr>
-          <p:cNvPr id="40" name="Rounded Rectangle 39"/>
+          <p:cNvPr id="44" name="Rounded Rectangle 43"/>
           <p:cNvSpPr/>
           <p:nvPr/>
         </p:nvSpPr>
         <p:spPr>
           <a:xfrm>
-            <a:off x="7552944" y="3401568"/>
-            <a:ext cx="3054096" cy="384048"/>
+            <a:off x="7552944" y="3072384"/>
+            <a:ext cx="3054096" cy="310896"/>
           </a:xfrm>
           <a:prstGeom prst="roundRect">
             <a:avLst/>
@@ -35314,14 +35472,14 @@
       </p:sp>
       <p:sp>
         <p:nvSpPr>
-          <p:cNvPr id="41" name="TextBox 40"/>
-          <p:cNvSpPr txBox="1"/>
-          <p:nvPr/>
-        </p:nvSpPr>
-        <p:spPr>
-          <a:xfrm>
-            <a:off x="7772400" y="3502151"/>
-            <a:ext cx="2487168" cy="146304"/>
+          <p:cNvPr id="45" name="TextBox 44"/>
+          <p:cNvSpPr txBox="1"/>
+          <p:nvPr/>
+        </p:nvSpPr>
+        <p:spPr>
+          <a:xfrm>
+            <a:off x="7772400" y="3154679"/>
+            <a:ext cx="2487168" cy="128016"/>
           </a:xfrm>
           <a:prstGeom prst="rect">
             <a:avLst/>
@@ -35335,7 +35493,7 @@
           <a:lstStyle/>
           <a:p>
             <a:pPr>
-              <a:defRPr sz="1150" b="1">
+              <a:defRPr sz="1060" b="1">
                 <a:solidFill>
                   <a:srgbClr val="1B1F2A"/>
                 </a:solidFill>
@@ -35350,14 +35508,14 @@
       </p:sp>
       <p:sp>
         <p:nvSpPr>
-          <p:cNvPr id="42" name="Rounded Rectangle 41"/>
+          <p:cNvPr id="46" name="Rounded Rectangle 45"/>
           <p:cNvSpPr/>
           <p:nvPr/>
         </p:nvSpPr>
         <p:spPr>
           <a:xfrm>
-            <a:off x="7552944" y="3913632"/>
-            <a:ext cx="3054096" cy="1115568"/>
+            <a:off x="6839712" y="3675887"/>
+            <a:ext cx="3767328" cy="1335024"/>
           </a:xfrm>
           <a:prstGeom prst="roundRect">
             <a:avLst/>
@@ -35395,14 +35553,14 @@
       </p:sp>
       <p:sp>
         <p:nvSpPr>
-          <p:cNvPr id="43" name="TextBox 42"/>
-          <p:cNvSpPr txBox="1"/>
-          <p:nvPr/>
-        </p:nvSpPr>
-        <p:spPr>
-          <a:xfrm>
-            <a:off x="7754112" y="4069080"/>
-            <a:ext cx="1700784" cy="164592"/>
+          <p:cNvPr id="47" name="TextBox 46"/>
+          <p:cNvSpPr txBox="1"/>
+          <p:nvPr/>
+        </p:nvSpPr>
+        <p:spPr>
+          <a:xfrm>
+            <a:off x="7040880" y="3822191"/>
+            <a:ext cx="1755648" cy="164592"/>
           </a:xfrm>
           <a:prstGeom prst="rect">
             <a:avLst/>
@@ -35416,7 +35574,7 @@
           <a:lstStyle/>
           <a:p>
             <a:pPr>
-              <a:defRPr sz="1120" b="1">
+              <a:defRPr sz="1140" b="1">
                 <a:solidFill>
                   <a:srgbClr val="21A67A"/>
                 </a:solidFill>
@@ -35431,13 +35589,13 @@
       </p:sp>
       <p:sp>
         <p:nvSpPr>
-          <p:cNvPr id="44" name="Oval 43"/>
+          <p:cNvPr id="48" name="Oval 47"/>
           <p:cNvSpPr/>
           <p:nvPr/>
         </p:nvSpPr>
         <p:spPr>
           <a:xfrm>
-            <a:off x="7808975" y="4425696"/>
+            <a:off x="7077456" y="4169664"/>
             <a:ext cx="73152" cy="73152"/>
           </a:xfrm>
           <a:prstGeom prst="ellipse">
@@ -35474,14 +35632,14 @@
       </p:sp>
       <p:sp>
         <p:nvSpPr>
-          <p:cNvPr id="45" name="TextBox 44"/>
-          <p:cNvSpPr txBox="1"/>
-          <p:nvPr/>
-        </p:nvSpPr>
-        <p:spPr>
-          <a:xfrm>
-            <a:off x="7973567" y="4352544"/>
-            <a:ext cx="2066543" cy="137160"/>
+          <p:cNvPr id="49" name="TextBox 48"/>
+          <p:cNvSpPr txBox="1"/>
+          <p:nvPr/>
+        </p:nvSpPr>
+        <p:spPr>
+          <a:xfrm>
+            <a:off x="7242048" y="4096512"/>
+            <a:ext cx="1389888" cy="192024"/>
           </a:xfrm>
           <a:prstGeom prst="rect">
             <a:avLst/>
@@ -35495,7 +35653,7 @@
           <a:lstStyle/>
           <a:p>
             <a:pPr>
-              <a:defRPr sz="980" b="0">
+              <a:defRPr sz="1050" b="0">
                 <a:solidFill>
                   <a:srgbClr val="1B1F2A"/>
                 </a:solidFill>
@@ -35510,13 +35668,13 @@
       </p:sp>
       <p:sp>
         <p:nvSpPr>
-          <p:cNvPr id="46" name="Oval 45"/>
+          <p:cNvPr id="50" name="Oval 49"/>
           <p:cNvSpPr/>
           <p:nvPr/>
         </p:nvSpPr>
         <p:spPr>
           <a:xfrm>
-            <a:off x="7808975" y="4590288"/>
+            <a:off x="7077456" y="4389120"/>
             <a:ext cx="73152" cy="73152"/>
           </a:xfrm>
           <a:prstGeom prst="ellipse">
@@ -35553,14 +35711,14 @@
       </p:sp>
       <p:sp>
         <p:nvSpPr>
-          <p:cNvPr id="47" name="TextBox 46"/>
-          <p:cNvSpPr txBox="1"/>
-          <p:nvPr/>
-        </p:nvSpPr>
-        <p:spPr>
-          <a:xfrm>
-            <a:off x="7973567" y="4517136"/>
-            <a:ext cx="2066543" cy="137160"/>
+          <p:cNvPr id="51" name="TextBox 50"/>
+          <p:cNvSpPr txBox="1"/>
+          <p:nvPr/>
+        </p:nvSpPr>
+        <p:spPr>
+          <a:xfrm>
+            <a:off x="7242048" y="4315968"/>
+            <a:ext cx="1389888" cy="192024"/>
           </a:xfrm>
           <a:prstGeom prst="rect">
             <a:avLst/>
@@ -35574,7 +35732,7 @@
           <a:lstStyle/>
           <a:p>
             <a:pPr>
-              <a:defRPr sz="980" b="0">
+              <a:defRPr sz="1050" b="0">
                 <a:solidFill>
                   <a:srgbClr val="1B1F2A"/>
                 </a:solidFill>
@@ -35582,20 +35740,20 @@
               </a:defRPr>
             </a:pPr>
             <a:r>
-              <a:t>초기 상태</a:t>
-            </a:r>
-          </a:p>
-        </p:txBody>
-      </p:sp>
-      <p:sp>
-        <p:nvSpPr>
-          <p:cNvPr id="48" name="Oval 47"/>
+              <a:t>다루는 asset</a:t>
+            </a:r>
+          </a:p>
+        </p:txBody>
+      </p:sp>
+      <p:sp>
+        <p:nvSpPr>
+          <p:cNvPr id="52" name="Oval 51"/>
           <p:cNvSpPr/>
           <p:nvPr/>
         </p:nvSpPr>
         <p:spPr>
           <a:xfrm>
-            <a:off x="7808975" y="4754880"/>
+            <a:off x="7077456" y="4608576"/>
             <a:ext cx="73152" cy="73152"/>
           </a:xfrm>
           <a:prstGeom prst="ellipse">
@@ -35632,14 +35790,14 @@
       </p:sp>
       <p:sp>
         <p:nvSpPr>
-          <p:cNvPr id="49" name="TextBox 48"/>
-          <p:cNvSpPr txBox="1"/>
-          <p:nvPr/>
-        </p:nvSpPr>
-        <p:spPr>
-          <a:xfrm>
-            <a:off x="7973567" y="4681728"/>
-            <a:ext cx="2066543" cy="137160"/>
+          <p:cNvPr id="53" name="TextBox 52"/>
+          <p:cNvSpPr txBox="1"/>
+          <p:nvPr/>
+        </p:nvSpPr>
+        <p:spPr>
+          <a:xfrm>
+            <a:off x="7242048" y="4535424"/>
+            <a:ext cx="1389888" cy="192024"/>
           </a:xfrm>
           <a:prstGeom prst="rect">
             <a:avLst/>
@@ -35653,7 +35811,7 @@
           <a:lstStyle/>
           <a:p>
             <a:pPr>
-              <a:defRPr sz="980" b="0">
+              <a:defRPr sz="1050" b="0">
                 <a:solidFill>
                   <a:srgbClr val="1B1F2A"/>
                 </a:solidFill>
@@ -35661,20 +35819,20 @@
               </a:defRPr>
             </a:pPr>
             <a:r>
-              <a:t>참여 조건</a:t>
-            </a:r>
-          </a:p>
-        </p:txBody>
-      </p:sp>
-      <p:sp>
-        <p:nvSpPr>
-          <p:cNvPr id="50" name="Oval 49"/>
+              <a:t>초기 상태</a:t>
+            </a:r>
+          </a:p>
+        </p:txBody>
+      </p:sp>
+      <p:sp>
+        <p:nvSpPr>
+          <p:cNvPr id="54" name="Oval 53"/>
           <p:cNvSpPr/>
           <p:nvPr/>
         </p:nvSpPr>
         <p:spPr>
           <a:xfrm>
-            <a:off x="7808975" y="4919472"/>
+            <a:off x="8924544" y="4169664"/>
             <a:ext cx="73152" cy="73152"/>
           </a:xfrm>
           <a:prstGeom prst="ellipse">
@@ -35711,14 +35869,14 @@
       </p:sp>
       <p:sp>
         <p:nvSpPr>
-          <p:cNvPr id="51" name="TextBox 50"/>
-          <p:cNvSpPr txBox="1"/>
-          <p:nvPr/>
-        </p:nvSpPr>
-        <p:spPr>
-          <a:xfrm>
-            <a:off x="7973567" y="4846320"/>
-            <a:ext cx="2066543" cy="137160"/>
+          <p:cNvPr id="55" name="TextBox 54"/>
+          <p:cNvSpPr txBox="1"/>
+          <p:nvPr/>
+        </p:nvSpPr>
+        <p:spPr>
+          <a:xfrm>
+            <a:off x="9089136" y="4096512"/>
+            <a:ext cx="1298448" cy="192024"/>
           </a:xfrm>
           <a:prstGeom prst="rect">
             <a:avLst/>
@@ -35732,7 +35890,7 @@
           <a:lstStyle/>
           <a:p>
             <a:pPr>
-              <a:defRPr sz="980" b="0">
+              <a:defRPr sz="1050" b="0">
                 <a:solidFill>
                   <a:srgbClr val="1B1F2A"/>
                 </a:solidFill>
@@ -35740,21 +35898,179 @@
               </a:defRPr>
             </a:pPr>
             <a:r>
-              <a:t>운영 방법</a:t>
+              <a:t>DA 책임</a:t>
+            </a:r>
+          </a:p>
+        </p:txBody>
+      </p:sp>
+      <p:sp>
+        <p:nvSpPr>
+          <p:cNvPr id="56" name="Oval 55"/>
+          <p:cNvSpPr/>
+          <p:nvPr/>
+        </p:nvSpPr>
+        <p:spPr>
+          <a:xfrm>
+            <a:off x="8924544" y="4389120"/>
+            <a:ext cx="73152" cy="73152"/>
+          </a:xfrm>
+          <a:prstGeom prst="ellipse">
+            <a:avLst/>
+          </a:prstGeom>
+          <a:solidFill>
+            <a:srgbClr val="21A67A"/>
+          </a:solidFill>
+          <a:ln>
+            <a:noFill/>
+          </a:ln>
+        </p:spPr>
+        <p:style>
+          <a:lnRef idx="1">
+            <a:schemeClr val="accent1"/>
+          </a:lnRef>
+          <a:fillRef idx="3">
+            <a:schemeClr val="accent1"/>
+          </a:fillRef>
+          <a:effectRef idx="2">
+            <a:schemeClr val="accent1"/>
+          </a:effectRef>
+          <a:fontRef idx="minor">
+            <a:schemeClr val="lt1"/>
+          </a:fontRef>
+        </p:style>
+        <p:txBody>
+          <a:bodyPr rtlCol="0" anchor="ctr"/>
+          <a:lstStyle/>
+          <a:p>
+            <a:pPr algn="ctr"/>
+          </a:p>
+        </p:txBody>
+      </p:sp>
+      <p:sp>
+        <p:nvSpPr>
+          <p:cNvPr id="57" name="TextBox 56"/>
+          <p:cNvSpPr txBox="1"/>
+          <p:nvPr/>
+        </p:nvSpPr>
+        <p:spPr>
+          <a:xfrm>
+            <a:off x="9089136" y="4315968"/>
+            <a:ext cx="1298448" cy="192024"/>
+          </a:xfrm>
+          <a:prstGeom prst="rect">
+            <a:avLst/>
+          </a:prstGeom>
+          <a:noFill/>
+        </p:spPr>
+        <p:txBody>
+          <a:bodyPr wrap="square" lIns="18288" rIns="18288" tIns="9144" bIns="9144" anchor="t">
+            <a:spAutoFit/>
+          </a:bodyPr>
+          <a:lstStyle/>
+          <a:p>
+            <a:pPr>
+              <a:defRPr sz="1050" b="0">
+                <a:solidFill>
+                  <a:srgbClr val="1B1F2A"/>
+                </a:solidFill>
+                <a:latin typeface="Apple SD Gothic Neo"/>
+              </a:defRPr>
+            </a:pPr>
+            <a:r>
+              <a:t>disclosure 권한</a:t>
+            </a:r>
+          </a:p>
+        </p:txBody>
+      </p:sp>
+      <p:sp>
+        <p:nvSpPr>
+          <p:cNvPr id="58" name="Oval 57"/>
+          <p:cNvSpPr/>
+          <p:nvPr/>
+        </p:nvSpPr>
+        <p:spPr>
+          <a:xfrm>
+            <a:off x="8924544" y="4608576"/>
+            <a:ext cx="73152" cy="73152"/>
+          </a:xfrm>
+          <a:prstGeom prst="ellipse">
+            <a:avLst/>
+          </a:prstGeom>
+          <a:solidFill>
+            <a:srgbClr val="21A67A"/>
+          </a:solidFill>
+          <a:ln>
+            <a:noFill/>
+          </a:ln>
+        </p:spPr>
+        <p:style>
+          <a:lnRef idx="1">
+            <a:schemeClr val="accent1"/>
+          </a:lnRef>
+          <a:fillRef idx="3">
+            <a:schemeClr val="accent1"/>
+          </a:fillRef>
+          <a:effectRef idx="2">
+            <a:schemeClr val="accent1"/>
+          </a:effectRef>
+          <a:fontRef idx="minor">
+            <a:schemeClr val="lt1"/>
+          </a:fontRef>
+        </p:style>
+        <p:txBody>
+          <a:bodyPr rtlCol="0" anchor="ctr"/>
+          <a:lstStyle/>
+          <a:p>
+            <a:pPr algn="ctr"/>
+          </a:p>
+        </p:txBody>
+      </p:sp>
+      <p:sp>
+        <p:nvSpPr>
+          <p:cNvPr id="59" name="TextBox 58"/>
+          <p:cNvSpPr txBox="1"/>
+          <p:nvPr/>
+        </p:nvSpPr>
+        <p:spPr>
+          <a:xfrm>
+            <a:off x="9089136" y="4535424"/>
+            <a:ext cx="1298448" cy="192024"/>
+          </a:xfrm>
+          <a:prstGeom prst="rect">
+            <a:avLst/>
+          </a:prstGeom>
+          <a:noFill/>
+        </p:spPr>
+        <p:txBody>
+          <a:bodyPr wrap="square" lIns="18288" rIns="18288" tIns="9144" bIns="9144" anchor="t">
+            <a:spAutoFit/>
+          </a:bodyPr>
+          <a:lstStyle/>
+          <a:p>
+            <a:pPr>
+              <a:defRPr sz="1050" b="0">
+                <a:solidFill>
+                  <a:srgbClr val="1B1F2A"/>
+                </a:solidFill>
+                <a:latin typeface="Apple SD Gothic Neo"/>
+              </a:defRPr>
+            </a:pPr>
+            <a:r>
+              <a:t>참여 / 종료 조건</a:t>
             </a:r>
           </a:p>
         </p:txBody>
       </p:sp>
       <p:cxnSp>
         <p:nvCxnSpPr>
-          <p:cNvPr id="52" name="Connector 51"/>
+          <p:cNvPr id="60" name="Connector 59"/>
           <p:cNvCxnSpPr/>
           <p:nvPr/>
         </p:nvCxnSpPr>
         <p:spPr>
           <a:xfrm>
-            <a:off x="3319272" y="2459736"/>
-            <a:ext cx="1088136" cy="850392"/>
+            <a:off x="3319272" y="2313432"/>
+            <a:ext cx="1088136" cy="722376"/>
           </a:xfrm>
           <a:prstGeom prst="line">
             <a:avLst/>
@@ -35782,14 +36098,14 @@
       </p:cxnSp>
       <p:cxnSp>
         <p:nvCxnSpPr>
-          <p:cNvPr id="53" name="Connector 52"/>
+          <p:cNvPr id="61" name="Connector 60"/>
           <p:cNvCxnSpPr/>
           <p:nvPr/>
         </p:nvCxnSpPr>
         <p:spPr>
           <a:xfrm>
-            <a:off x="3319272" y="3026664"/>
-            <a:ext cx="1088136" cy="283464"/>
+            <a:off x="3319272" y="2770632"/>
+            <a:ext cx="1088136" cy="265176"/>
           </a:xfrm>
           <a:prstGeom prst="line">
             <a:avLst/>
@@ -35817,14 +36133,14 @@
       </p:cxnSp>
       <p:cxnSp>
         <p:nvCxnSpPr>
-          <p:cNvPr id="54" name="Connector 53"/>
+          <p:cNvPr id="62" name="Connector 61"/>
           <p:cNvCxnSpPr/>
           <p:nvPr/>
         </p:nvCxnSpPr>
         <p:spPr>
           <a:xfrm flipV="1">
-            <a:off x="3319272" y="3310128"/>
-            <a:ext cx="1088136" cy="283464"/>
+            <a:off x="3319272" y="3035808"/>
+            <a:ext cx="1088136" cy="192024"/>
           </a:xfrm>
           <a:prstGeom prst="line">
             <a:avLst/>
@@ -35852,14 +36168,14 @@
       </p:cxnSp>
       <p:cxnSp>
         <p:nvCxnSpPr>
-          <p:cNvPr id="55" name="Connector 54"/>
+          <p:cNvPr id="63" name="Connector 62"/>
           <p:cNvCxnSpPr/>
           <p:nvPr/>
         </p:nvCxnSpPr>
         <p:spPr>
           <a:xfrm flipV="1">
-            <a:off x="6236208" y="2459736"/>
-            <a:ext cx="1316736" cy="850392"/>
+            <a:off x="6236208" y="2313432"/>
+            <a:ext cx="1316736" cy="722376"/>
           </a:xfrm>
           <a:prstGeom prst="line">
             <a:avLst/>
@@ -35887,14 +36203,14 @@
       </p:cxnSp>
       <p:cxnSp>
         <p:nvCxnSpPr>
-          <p:cNvPr id="56" name="Connector 55"/>
+          <p:cNvPr id="64" name="Connector 63"/>
           <p:cNvCxnSpPr/>
           <p:nvPr/>
         </p:nvCxnSpPr>
         <p:spPr>
           <a:xfrm flipV="1">
-            <a:off x="6236208" y="3026664"/>
-            <a:ext cx="1316736" cy="283464"/>
+            <a:off x="6236208" y="2770632"/>
+            <a:ext cx="1316736" cy="265176"/>
           </a:xfrm>
           <a:prstGeom prst="line">
             <a:avLst/>
@@ -35922,14 +36238,14 @@
       </p:cxnSp>
       <p:cxnSp>
         <p:nvCxnSpPr>
-          <p:cNvPr id="57" name="Connector 56"/>
+          <p:cNvPr id="65" name="Connector 64"/>
           <p:cNvCxnSpPr/>
           <p:nvPr/>
         </p:nvCxnSpPr>
         <p:spPr>
           <a:xfrm>
-            <a:off x="6236208" y="3310128"/>
-            <a:ext cx="1316736" cy="283464"/>
+            <a:off x="6236208" y="3035808"/>
+            <a:ext cx="1316736" cy="192024"/>
           </a:xfrm>
           <a:prstGeom prst="line">
             <a:avLst/>
@@ -35957,7 +36273,7 @@
       </p:cxnSp>
       <p:sp>
         <p:nvSpPr>
-          <p:cNvPr id="58" name="Rounded Rectangle 57"/>
+          <p:cNvPr id="66" name="Rounded Rectangle 65"/>
           <p:cNvSpPr/>
           <p:nvPr/>
         </p:nvSpPr>
@@ -36000,7 +36316,7 @@
       </p:sp>
       <p:sp>
         <p:nvSpPr>
-          <p:cNvPr id="59" name="TextBox 58"/>
+          <p:cNvPr id="67" name="TextBox 66"/>
           <p:cNvSpPr txBox="1"/>
           <p:nvPr/>
         </p:nvSpPr>

</xml_diff>

<commit_message>
Improve bridge overview label readability
</commit_message>
<xml_diff>
--- a/bridge/docs/dev/spec.pptx
+++ b/bridge/docs/dev/spec.pptx
@@ -34866,8 +34866,8 @@
         </p:nvSpPr>
         <p:spPr>
           <a:xfrm>
-            <a:off x="4407408" y="2231136"/>
-            <a:ext cx="1828800" cy="1609344"/>
+            <a:off x="4187952" y="2103120"/>
+            <a:ext cx="2267712" cy="1938528"/>
           </a:xfrm>
           <a:prstGeom prst="roundRect">
             <a:avLst/>
@@ -34911,8 +34911,8 @@
         </p:nvSpPr>
         <p:spPr>
           <a:xfrm>
-            <a:off x="4645152" y="2450592"/>
-            <a:ext cx="1353312" cy="219456"/>
+            <a:off x="4480560" y="2322576"/>
+            <a:ext cx="1682496" cy="274320"/>
           </a:xfrm>
           <a:prstGeom prst="rect">
             <a:avLst/>
@@ -34926,7 +34926,7 @@
           <a:lstStyle/>
           <a:p>
             <a:pPr algn="ctr">
-              <a:defRPr sz="1600" b="1">
+              <a:defRPr sz="1900" b="1">
                 <a:solidFill>
                   <a:srgbClr val="1B1F2A"/>
                 </a:solidFill>
@@ -34947,8 +34947,8 @@
         </p:nvSpPr>
         <p:spPr>
           <a:xfrm>
-            <a:off x="4645152" y="2852928"/>
-            <a:ext cx="1353312" cy="146304"/>
+            <a:off x="4480560" y="2761488"/>
+            <a:ext cx="1682496" cy="237744"/>
           </a:xfrm>
           <a:prstGeom prst="roundRect">
             <a:avLst/>
@@ -34992,8 +34992,8 @@
         </p:nvSpPr>
         <p:spPr>
           <a:xfrm>
-            <a:off x="4681728" y="2880360"/>
-            <a:ext cx="1280160" cy="54864"/>
+            <a:off x="4544568" y="2825496"/>
+            <a:ext cx="1554480" cy="82296"/>
           </a:xfrm>
           <a:prstGeom prst="rect">
             <a:avLst/>
@@ -35007,7 +35007,7 @@
           <a:lstStyle/>
           <a:p>
             <a:pPr algn="ctr">
-              <a:defRPr sz="630" b="1">
+              <a:defRPr sz="1019" b="1">
                 <a:solidFill>
                   <a:srgbClr val="5C667A"/>
                 </a:solidFill>
@@ -35028,8 +35028,8 @@
         </p:nvSpPr>
         <p:spPr>
           <a:xfrm>
-            <a:off x="4645152" y="3081528"/>
-            <a:ext cx="1353312" cy="146304"/>
+            <a:off x="4480560" y="3072384"/>
+            <a:ext cx="1682496" cy="237744"/>
           </a:xfrm>
           <a:prstGeom prst="roundRect">
             <a:avLst/>
@@ -35073,8 +35073,8 @@
         </p:nvSpPr>
         <p:spPr>
           <a:xfrm>
-            <a:off x="4681728" y="3108960"/>
-            <a:ext cx="1280160" cy="54864"/>
+            <a:off x="4544568" y="3136391"/>
+            <a:ext cx="1554480" cy="82296"/>
           </a:xfrm>
           <a:prstGeom prst="rect">
             <a:avLst/>
@@ -35088,7 +35088,7 @@
           <a:lstStyle/>
           <a:p>
             <a:pPr algn="ctr">
-              <a:defRPr sz="630" b="1">
+              <a:defRPr sz="1019" b="1">
                 <a:solidFill>
                   <a:srgbClr val="5C667A"/>
                 </a:solidFill>
@@ -35109,8 +35109,8 @@
         </p:nvSpPr>
         <p:spPr>
           <a:xfrm>
-            <a:off x="4645152" y="3310128"/>
-            <a:ext cx="1353312" cy="146304"/>
+            <a:off x="4480560" y="3383280"/>
+            <a:ext cx="1682496" cy="237744"/>
           </a:xfrm>
           <a:prstGeom prst="roundRect">
             <a:avLst/>
@@ -35154,8 +35154,8 @@
         </p:nvSpPr>
         <p:spPr>
           <a:xfrm>
-            <a:off x="4681728" y="3337560"/>
-            <a:ext cx="1280160" cy="54864"/>
+            <a:off x="4544568" y="3447288"/>
+            <a:ext cx="1554480" cy="82296"/>
           </a:xfrm>
           <a:prstGeom prst="rect">
             <a:avLst/>
@@ -35169,7 +35169,7 @@
           <a:lstStyle/>
           <a:p>
             <a:pPr algn="ctr">
-              <a:defRPr sz="630" b="1">
+              <a:defRPr sz="1019" b="1">
                 <a:solidFill>
                   <a:srgbClr val="5C667A"/>
                 </a:solidFill>
@@ -35190,8 +35190,8 @@
         </p:nvSpPr>
         <p:spPr>
           <a:xfrm>
-            <a:off x="4645152" y="3538728"/>
-            <a:ext cx="1353312" cy="146304"/>
+            <a:off x="4480560" y="3694176"/>
+            <a:ext cx="1682496" cy="237744"/>
           </a:xfrm>
           <a:prstGeom prst="roundRect">
             <a:avLst/>
@@ -35235,8 +35235,8 @@
         </p:nvSpPr>
         <p:spPr>
           <a:xfrm>
-            <a:off x="4681728" y="3566160"/>
-            <a:ext cx="1280160" cy="54864"/>
+            <a:off x="4544568" y="3758183"/>
+            <a:ext cx="1554480" cy="82296"/>
           </a:xfrm>
           <a:prstGeom prst="rect">
             <a:avLst/>
@@ -35250,7 +35250,7 @@
           <a:lstStyle/>
           <a:p>
             <a:pPr algn="ctr">
-              <a:defRPr sz="630" b="1">
+              <a:defRPr sz="1019" b="1">
                 <a:solidFill>
                   <a:srgbClr val="5C667A"/>
                 </a:solidFill>
@@ -36070,7 +36070,7 @@
         <p:spPr>
           <a:xfrm>
             <a:off x="3319272" y="2313432"/>
-            <a:ext cx="1088136" cy="722376"/>
+            <a:ext cx="868680" cy="758952"/>
           </a:xfrm>
           <a:prstGeom prst="line">
             <a:avLst/>
@@ -36105,7 +36105,7 @@
         <p:spPr>
           <a:xfrm>
             <a:off x="3319272" y="2770632"/>
-            <a:ext cx="1088136" cy="265176"/>
+            <a:ext cx="868680" cy="301752"/>
           </a:xfrm>
           <a:prstGeom prst="line">
             <a:avLst/>
@@ -36139,8 +36139,8 @@
         </p:nvCxnSpPr>
         <p:spPr>
           <a:xfrm flipV="1">
-            <a:off x="3319272" y="3035808"/>
-            <a:ext cx="1088136" cy="192024"/>
+            <a:off x="3319272" y="3072384"/>
+            <a:ext cx="868680" cy="155448"/>
           </a:xfrm>
           <a:prstGeom prst="line">
             <a:avLst/>
@@ -36174,8 +36174,8 @@
         </p:nvCxnSpPr>
         <p:spPr>
           <a:xfrm flipV="1">
-            <a:off x="6236208" y="2313432"/>
-            <a:ext cx="1316736" cy="722376"/>
+            <a:off x="6455664" y="2313432"/>
+            <a:ext cx="1097280" cy="758952"/>
           </a:xfrm>
           <a:prstGeom prst="line">
             <a:avLst/>
@@ -36209,8 +36209,8 @@
         </p:nvCxnSpPr>
         <p:spPr>
           <a:xfrm flipV="1">
-            <a:off x="6236208" y="2770632"/>
-            <a:ext cx="1316736" cy="265176"/>
+            <a:off x="6455664" y="2770632"/>
+            <a:ext cx="1097280" cy="301752"/>
           </a:xfrm>
           <a:prstGeom prst="line">
             <a:avLst/>
@@ -36244,8 +36244,8 @@
         </p:nvCxnSpPr>
         <p:spPr>
           <a:xfrm>
-            <a:off x="6236208" y="3035808"/>
-            <a:ext cx="1316736" cy="192024"/>
+            <a:off x="6455664" y="3072384"/>
+            <a:ext cx="1097280" cy="155448"/>
           </a:xfrm>
           <a:prstGeom prst="line">
             <a:avLst/>

</xml_diff>

<commit_message>
Clarify L2 operating mode options in deck
</commit_message>
<xml_diff>
--- a/bridge/docs/dev/spec.pptx
+++ b/bridge/docs/dev/spec.pptx
@@ -14274,7 +14274,7 @@
             <a:avLst/>
           </a:prstGeom>
           <a:solidFill>
-            <a:srgbClr val="F4F7FB"/>
+            <a:srgbClr val="FFFFFF"/>
           </a:solidFill>
           <a:ln w="12700">
             <a:solidFill>
@@ -14312,8 +14312,8 @@
         </p:nvSpPr>
         <p:spPr>
           <a:xfrm>
-            <a:off x="7059168" y="3950208"/>
-            <a:ext cx="1463040" cy="182880"/>
+            <a:off x="7059168" y="3931920"/>
+            <a:ext cx="2852928" cy="182880"/>
           </a:xfrm>
           <a:prstGeom prst="rect">
             <a:avLst/>
@@ -14327,7 +14327,7 @@
           <a:lstStyle/>
           <a:p>
             <a:pPr>
-              <a:defRPr sz="1300" b="1">
+              <a:defRPr sz="1250" b="1">
                 <a:solidFill>
                   <a:srgbClr val="354052"/>
                 </a:solidFill>
@@ -14335,27 +14335,63 @@
               </a:defRPr>
             </a:pPr>
             <a:r>
-              <a:t>L2 운영 형태</a:t>
-            </a:r>
-          </a:p>
-        </p:txBody>
-      </p:sp>
-      <p:sp>
-        <p:nvSpPr>
-          <p:cNvPr id="46" name="Rounded Rectangle 45"/>
+              <a:t>Channel policy가 고르는 운영 방식</a:t>
+            </a:r>
+          </a:p>
+        </p:txBody>
+      </p:sp>
+      <p:sp>
+        <p:nvSpPr>
+          <p:cNvPr id="46" name="TextBox 45"/>
+          <p:cNvSpPr txBox="1"/>
+          <p:nvPr/>
+        </p:nvSpPr>
+        <p:spPr>
+          <a:xfrm>
+            <a:off x="7077456" y="4187952"/>
+            <a:ext cx="2596896" cy="146304"/>
+          </a:xfrm>
+          <a:prstGeom prst="rect">
+            <a:avLst/>
+          </a:prstGeom>
+          <a:noFill/>
+        </p:spPr>
+        <p:txBody>
+          <a:bodyPr wrap="square" lIns="18288" rIns="18288" tIns="9144" bIns="9144" anchor="t">
+            <a:spAutoFit/>
+          </a:bodyPr>
+          <a:lstStyle/>
+          <a:p>
+            <a:pPr>
+              <a:defRPr sz="880" b="0">
+                <a:solidFill>
+                  <a:srgbClr val="5C667A"/>
+                </a:solidFill>
+                <a:latin typeface="Apple SD Gothic Neo"/>
+              </a:defRPr>
+            </a:pPr>
+            <a:r>
+              <a:t>왼쪽 block 색상과 무관한 배치 옵션</a:t>
+            </a:r>
+          </a:p>
+        </p:txBody>
+      </p:sp>
+      <p:sp>
+        <p:nvSpPr>
+          <p:cNvPr id="47" name="Rounded Rectangle 46"/>
           <p:cNvSpPr/>
           <p:nvPr/>
         </p:nvSpPr>
         <p:spPr>
           <a:xfrm>
-            <a:off x="7114032" y="4315968"/>
-            <a:ext cx="950976" cy="310896"/>
+            <a:off x="7114032" y="4407408"/>
+            <a:ext cx="950976" cy="219456"/>
           </a:xfrm>
           <a:prstGeom prst="roundRect">
             <a:avLst/>
           </a:prstGeom>
           <a:solidFill>
-            <a:srgbClr val="E9F1FF"/>
+            <a:srgbClr val="FFFFFF"/>
           </a:solidFill>
           <a:ln w="12700">
             <a:solidFill>
@@ -14387,14 +14423,14 @@
       </p:sp>
       <p:sp>
         <p:nvSpPr>
-          <p:cNvPr id="47" name="TextBox 46"/>
-          <p:cNvSpPr txBox="1"/>
-          <p:nvPr/>
-        </p:nvSpPr>
-        <p:spPr>
-          <a:xfrm>
-            <a:off x="7168896" y="4398264"/>
-            <a:ext cx="841248" cy="91440"/>
+          <p:cNvPr id="48" name="TextBox 47"/>
+          <p:cNvSpPr txBox="1"/>
+          <p:nvPr/>
+        </p:nvSpPr>
+        <p:spPr>
+          <a:xfrm>
+            <a:off x="7168896" y="4462272"/>
+            <a:ext cx="841248" cy="73152"/>
           </a:xfrm>
           <a:prstGeom prst="rect">
             <a:avLst/>
@@ -14408,9 +14444,9 @@
           <a:lstStyle/>
           <a:p>
             <a:pPr algn="ctr">
-              <a:defRPr sz="840" b="1">
-                <a:solidFill>
-                  <a:srgbClr val="1B1F2A"/>
+              <a:defRPr sz="760" b="1">
+                <a:solidFill>
+                  <a:srgbClr val="354052"/>
                 </a:solidFill>
                 <a:latin typeface="Apple SD Gothic Neo"/>
               </a:defRPr>
@@ -14423,20 +14459,20 @@
       </p:sp>
       <p:sp>
         <p:nvSpPr>
-          <p:cNvPr id="48" name="Rounded Rectangle 47"/>
+          <p:cNvPr id="49" name="Rounded Rectangle 48"/>
           <p:cNvSpPr/>
           <p:nvPr/>
         </p:nvSpPr>
         <p:spPr>
           <a:xfrm>
-            <a:off x="8247888" y="4315968"/>
-            <a:ext cx="950976" cy="310896"/>
+            <a:off x="8247888" y="4407408"/>
+            <a:ext cx="950976" cy="219456"/>
           </a:xfrm>
           <a:prstGeom prst="roundRect">
             <a:avLst/>
           </a:prstGeom>
           <a:solidFill>
-            <a:srgbClr val="E8F7F0"/>
+            <a:srgbClr val="FFFFFF"/>
           </a:solidFill>
           <a:ln w="12700">
             <a:solidFill>
@@ -14468,14 +14504,14 @@
       </p:sp>
       <p:sp>
         <p:nvSpPr>
-          <p:cNvPr id="49" name="TextBox 48"/>
-          <p:cNvSpPr txBox="1"/>
-          <p:nvPr/>
-        </p:nvSpPr>
-        <p:spPr>
-          <a:xfrm>
-            <a:off x="8302752" y="4398264"/>
-            <a:ext cx="841248" cy="91440"/>
+          <p:cNvPr id="50" name="TextBox 49"/>
+          <p:cNvSpPr txBox="1"/>
+          <p:nvPr/>
+        </p:nvSpPr>
+        <p:spPr>
+          <a:xfrm>
+            <a:off x="8302752" y="4462272"/>
+            <a:ext cx="841248" cy="73152"/>
           </a:xfrm>
           <a:prstGeom prst="rect">
             <a:avLst/>
@@ -14489,9 +14525,9 @@
           <a:lstStyle/>
           <a:p>
             <a:pPr algn="ctr">
-              <a:defRPr sz="840" b="1">
-                <a:solidFill>
-                  <a:srgbClr val="1B1F2A"/>
+              <a:defRPr sz="760" b="1">
+                <a:solidFill>
+                  <a:srgbClr val="354052"/>
                 </a:solidFill>
                 <a:latin typeface="Apple SD Gothic Neo"/>
               </a:defRPr>
@@ -14504,20 +14540,20 @@
       </p:sp>
       <p:sp>
         <p:nvSpPr>
-          <p:cNvPr id="50" name="Rounded Rectangle 49"/>
+          <p:cNvPr id="51" name="Rounded Rectangle 50"/>
           <p:cNvSpPr/>
           <p:nvPr/>
         </p:nvSpPr>
         <p:spPr>
           <a:xfrm>
-            <a:off x="9381744" y="4315968"/>
-            <a:ext cx="950976" cy="310896"/>
+            <a:off x="9381744" y="4407408"/>
+            <a:ext cx="950976" cy="219456"/>
           </a:xfrm>
           <a:prstGeom prst="roundRect">
             <a:avLst/>
           </a:prstGeom>
           <a:solidFill>
-            <a:srgbClr val="FFF4DE"/>
+            <a:srgbClr val="FFFFFF"/>
           </a:solidFill>
           <a:ln w="12700">
             <a:solidFill>
@@ -14549,14 +14585,14 @@
       </p:sp>
       <p:sp>
         <p:nvSpPr>
-          <p:cNvPr id="51" name="TextBox 50"/>
-          <p:cNvSpPr txBox="1"/>
-          <p:nvPr/>
-        </p:nvSpPr>
-        <p:spPr>
-          <a:xfrm>
-            <a:off x="9436608" y="4398264"/>
-            <a:ext cx="841248" cy="91440"/>
+          <p:cNvPr id="52" name="TextBox 51"/>
+          <p:cNvSpPr txBox="1"/>
+          <p:nvPr/>
+        </p:nvSpPr>
+        <p:spPr>
+          <a:xfrm>
+            <a:off x="9436608" y="4462272"/>
+            <a:ext cx="841248" cy="73152"/>
           </a:xfrm>
           <a:prstGeom prst="rect">
             <a:avLst/>
@@ -14570,35 +14606,22 @@
           <a:lstStyle/>
           <a:p>
             <a:pPr algn="ctr">
-              <a:defRPr sz="840" b="1">
-                <a:solidFill>
-                  <a:srgbClr val="1B1F2A"/>
-                </a:solidFill>
-                <a:latin typeface="Apple SD Gothic Neo"/>
-              </a:defRPr>
-            </a:pPr>
-            <a:r>
-              <a:t>serverless</a:t>
-            </a:r>
-          </a:p>
-          <a:p>
-            <a:pPr algn="ctr">
-              <a:defRPr sz="840" b="1">
-                <a:solidFill>
-                  <a:srgbClr val="1B1F2A"/>
-                </a:solidFill>
-                <a:latin typeface="Apple SD Gothic Neo"/>
-              </a:defRPr>
-            </a:pPr>
-            <a:r>
-              <a:t>local users</a:t>
-            </a:r>
-          </a:p>
-        </p:txBody>
-      </p:sp>
-      <p:sp>
-        <p:nvSpPr>
-          <p:cNvPr id="52" name="Rounded Rectangle 51"/>
+              <a:defRPr sz="760" b="1">
+                <a:solidFill>
+                  <a:srgbClr val="354052"/>
+                </a:solidFill>
+                <a:latin typeface="Apple SD Gothic Neo"/>
+              </a:defRPr>
+            </a:pPr>
+            <a:r>
+              <a:t>serverless local users</a:t>
+            </a:r>
+          </a:p>
+        </p:txBody>
+      </p:sp>
+      <p:sp>
+        <p:nvSpPr>
+          <p:cNvPr id="53" name="Rounded Rectangle 52"/>
           <p:cNvSpPr/>
           <p:nvPr/>
         </p:nvSpPr>
@@ -14641,7 +14664,7 @@
       </p:sp>
       <p:sp>
         <p:nvSpPr>
-          <p:cNvPr id="53" name="TextBox 52"/>
+          <p:cNvPr id="54" name="TextBox 53"/>
           <p:cNvSpPr txBox="1"/>
           <p:nvPr/>
         </p:nvSpPr>

</xml_diff>

<commit_message>
Clarify state transition overview slide
</commit_message>
<xml_diff>
--- a/bridge/docs/dev/spec.pptx
+++ b/bridge/docs/dev/spec.pptx
@@ -13416,7 +13416,7 @@
         </p:nvSpPr>
         <p:spPr>
           <a:xfrm>
-            <a:off x="713232" y="3803904"/>
+            <a:off x="713232" y="3730752"/>
             <a:ext cx="3017520" cy="201168"/>
           </a:xfrm>
           <a:prstGeom prst="rect">
@@ -13452,8 +13452,8 @@
         </p:nvSpPr>
         <p:spPr>
           <a:xfrm>
-            <a:off x="786384" y="4133087"/>
-            <a:ext cx="1572768" cy="749808"/>
+            <a:off x="786384" y="4041648"/>
+            <a:ext cx="1572768" cy="914400"/>
           </a:xfrm>
           <a:prstGeom prst="roundRect">
             <a:avLst/>
@@ -13497,7 +13497,7 @@
         </p:nvSpPr>
         <p:spPr>
           <a:xfrm>
-            <a:off x="896112" y="4251960"/>
+            <a:off x="896112" y="4151376"/>
             <a:ext cx="1353312" cy="146304"/>
           </a:xfrm>
           <a:prstGeom prst="rect">
@@ -13512,7 +13512,7 @@
           <a:lstStyle/>
           <a:p>
             <a:pPr algn="ctr">
-              <a:defRPr sz="1050" b="1">
+              <a:defRPr sz="1030" b="1">
                 <a:solidFill>
                   <a:srgbClr val="1B1F2A"/>
                 </a:solidFill>
@@ -13533,8 +13533,8 @@
         </p:nvSpPr>
         <p:spPr>
           <a:xfrm>
-            <a:off x="923544" y="4480560"/>
-            <a:ext cx="1298448" cy="201168"/>
+            <a:off x="923544" y="4370832"/>
+            <a:ext cx="1298448" cy="384048"/>
           </a:xfrm>
           <a:prstGeom prst="rect">
             <a:avLst/>
@@ -13548,7 +13548,7 @@
           <a:lstStyle/>
           <a:p>
             <a:pPr algn="ctr">
-              <a:defRPr sz="960" b="1">
+              <a:defRPr sz="919" b="1">
                 <a:solidFill>
                   <a:srgbClr val="5C667A"/>
                 </a:solidFill>
@@ -13556,7 +13556,20 @@
               </a:defRPr>
             </a:pPr>
             <a:r>
-              <a:t>DApp txs</a:t>
+              <a:t>state R_k</a:t>
+            </a:r>
+          </a:p>
+          <a:p>
+            <a:pPr algn="ctr">
+              <a:defRPr sz="919" b="1">
+                <a:solidFill>
+                  <a:srgbClr val="5C667A"/>
+                </a:solidFill>
+                <a:latin typeface="Apple SD Gothic Neo"/>
+              </a:defRPr>
+            </a:pPr>
+            <a:r>
+              <a:t>+ tx batch</a:t>
             </a:r>
           </a:p>
         </p:txBody>
@@ -13569,7 +13582,7 @@
         </p:nvCxnSpPr>
         <p:spPr>
           <a:xfrm>
-            <a:off x="2359152" y="4507992"/>
+            <a:off x="2359152" y="4498848"/>
             <a:ext cx="301751" cy="0"/>
           </a:xfrm>
           <a:prstGeom prst="line">
@@ -13604,8 +13617,8 @@
         </p:nvSpPr>
         <p:spPr>
           <a:xfrm>
-            <a:off x="2779776" y="4133087"/>
-            <a:ext cx="1572768" cy="749808"/>
+            <a:off x="2779776" y="4041648"/>
+            <a:ext cx="1572768" cy="914400"/>
           </a:xfrm>
           <a:prstGeom prst="roundRect">
             <a:avLst/>
@@ -13649,7 +13662,7 @@
         </p:nvSpPr>
         <p:spPr>
           <a:xfrm>
-            <a:off x="2889504" y="4251960"/>
+            <a:off x="2889504" y="4151376"/>
             <a:ext cx="1353312" cy="146304"/>
           </a:xfrm>
           <a:prstGeom prst="rect">
@@ -13664,7 +13677,7 @@
           <a:lstStyle/>
           <a:p>
             <a:pPr algn="ctr">
-              <a:defRPr sz="1050" b="1">
+              <a:defRPr sz="1030" b="1">
                 <a:solidFill>
                   <a:srgbClr val="1B1F2A"/>
                 </a:solidFill>
@@ -13685,8 +13698,8 @@
         </p:nvSpPr>
         <p:spPr>
           <a:xfrm>
-            <a:off x="2916936" y="4480560"/>
-            <a:ext cx="1298448" cy="201168"/>
+            <a:off x="2916936" y="4370832"/>
+            <a:ext cx="1298448" cy="384048"/>
           </a:xfrm>
           <a:prstGeom prst="rect">
             <a:avLst/>
@@ -13700,7 +13713,7 @@
           <a:lstStyle/>
           <a:p>
             <a:pPr algn="ctr">
-              <a:defRPr sz="960" b="1">
+              <a:defRPr sz="860" b="1">
                 <a:solidFill>
                   <a:srgbClr val="5C667A"/>
                 </a:solidFill>
@@ -13708,12 +13721,12 @@
               </a:defRPr>
             </a:pPr>
             <a:r>
-              <a:t>DApp txs</a:t>
+              <a:t>execute txs</a:t>
             </a:r>
           </a:p>
           <a:p>
             <a:pPr algn="ctr">
-              <a:defRPr sz="960" b="1">
+              <a:defRPr sz="860" b="1">
                 <a:solidFill>
                   <a:srgbClr val="5C667A"/>
                 </a:solidFill>
@@ -13721,7 +13734,20 @@
               </a:defRPr>
             </a:pPr>
             <a:r>
-              <a:t>+ proof pi</a:t>
+              <a:t>R_k -&gt; R_k+1</a:t>
+            </a:r>
+          </a:p>
+          <a:p>
+            <a:pPr algn="ctr">
+              <a:defRPr sz="860" b="1">
+                <a:solidFill>
+                  <a:srgbClr val="5C667A"/>
+                </a:solidFill>
+                <a:latin typeface="Apple SD Gothic Neo"/>
+              </a:defRPr>
+            </a:pPr>
+            <a:r>
+              <a:t>proof pi</a:t>
             </a:r>
           </a:p>
         </p:txBody>
@@ -13734,7 +13760,7 @@
         </p:nvCxnSpPr>
         <p:spPr>
           <a:xfrm>
-            <a:off x="4352544" y="4507992"/>
+            <a:off x="4352544" y="4498848"/>
             <a:ext cx="301752" cy="0"/>
           </a:xfrm>
           <a:prstGeom prst="line">
@@ -13769,8 +13795,8 @@
         </p:nvSpPr>
         <p:spPr>
           <a:xfrm>
-            <a:off x="4773168" y="4133087"/>
-            <a:ext cx="1572768" cy="749808"/>
+            <a:off x="4773168" y="4041648"/>
+            <a:ext cx="1572768" cy="914400"/>
           </a:xfrm>
           <a:prstGeom prst="roundRect">
             <a:avLst/>
@@ -13814,7 +13840,7 @@
         </p:nvSpPr>
         <p:spPr>
           <a:xfrm>
-            <a:off x="4882896" y="4251960"/>
+            <a:off x="4882896" y="4151376"/>
             <a:ext cx="1353312" cy="146304"/>
           </a:xfrm>
           <a:prstGeom prst="rect">
@@ -13829,7 +13855,7 @@
           <a:lstStyle/>
           <a:p>
             <a:pPr algn="ctr">
-              <a:defRPr sz="1050" b="1">
+              <a:defRPr sz="1030" b="1">
                 <a:solidFill>
                   <a:srgbClr val="1B1F2A"/>
                 </a:solidFill>
@@ -13850,8 +13876,8 @@
         </p:nvSpPr>
         <p:spPr>
           <a:xfrm>
-            <a:off x="4910328" y="4480560"/>
-            <a:ext cx="1298448" cy="201168"/>
+            <a:off x="4910328" y="4370832"/>
+            <a:ext cx="1298448" cy="384048"/>
           </a:xfrm>
           <a:prstGeom prst="rect">
             <a:avLst/>
@@ -13865,7 +13891,7 @@
           <a:lstStyle/>
           <a:p>
             <a:pPr algn="ctr">
-              <a:defRPr sz="960" b="1">
+              <a:defRPr sz="919" b="1">
                 <a:solidFill>
                   <a:srgbClr val="5C667A"/>
                 </a:solidFill>
@@ -13873,12 +13899,12 @@
               </a:defRPr>
             </a:pPr>
             <a:r>
-              <a:t>next local</a:t>
+              <a:t>state R_k+1</a:t>
             </a:r>
           </a:p>
           <a:p>
             <a:pPr algn="ctr">
-              <a:defRPr sz="960" b="1">
+              <a:defRPr sz="919" b="1">
                 <a:solidFill>
                   <a:srgbClr val="5C667A"/>
                 </a:solidFill>
@@ -13886,7 +13912,7 @@
               </a:defRPr>
             </a:pPr>
             <a:r>
-              <a:t>state</a:t>
+              <a:t>+ next txs</a:t>
             </a:r>
           </a:p>
         </p:txBody>
@@ -13900,7 +13926,7 @@
         <p:spPr>
           <a:xfrm flipV="1">
             <a:off x="3712463" y="3163824"/>
-            <a:ext cx="0" cy="969263"/>
+            <a:ext cx="0" cy="877824"/>
           </a:xfrm>
           <a:prstGeom prst="line">
             <a:avLst/>
@@ -14313,7 +14339,43 @@
         <p:spPr>
           <a:xfrm>
             <a:off x="7059168" y="3931920"/>
-            <a:ext cx="2852928" cy="182880"/>
+            <a:ext cx="2103120" cy="164592"/>
+          </a:xfrm>
+          <a:prstGeom prst="rect">
+            <a:avLst/>
+          </a:prstGeom>
+          <a:noFill/>
+        </p:spPr>
+        <p:txBody>
+          <a:bodyPr wrap="square" lIns="18288" rIns="18288" tIns="9144" bIns="9144" anchor="t">
+            <a:spAutoFit/>
+          </a:bodyPr>
+          <a:lstStyle/>
+          <a:p>
+            <a:pPr>
+              <a:defRPr sz="1120" b="1">
+                <a:solidFill>
+                  <a:srgbClr val="5C667A"/>
+                </a:solidFill>
+                <a:latin typeface="Apple SD Gothic Neo"/>
+              </a:defRPr>
+            </a:pPr>
+            <a:r>
+              <a:t>Channel policy field</a:t>
+            </a:r>
+          </a:p>
+        </p:txBody>
+      </p:sp>
+      <p:sp>
+        <p:nvSpPr>
+          <p:cNvPr id="46" name="TextBox 45"/>
+          <p:cNvSpPr txBox="1"/>
+          <p:nvPr/>
+        </p:nvSpPr>
+        <p:spPr>
+          <a:xfrm>
+            <a:off x="7059168" y="4142232"/>
+            <a:ext cx="2514600" cy="182880"/>
           </a:xfrm>
           <a:prstGeom prst="rect">
             <a:avLst/>
@@ -14335,43 +14397,7 @@
               </a:defRPr>
             </a:pPr>
             <a:r>
-              <a:t>Channel policy가 고르는 운영 방식</a:t>
-            </a:r>
-          </a:p>
-        </p:txBody>
-      </p:sp>
-      <p:sp>
-        <p:nvSpPr>
-          <p:cNvPr id="46" name="TextBox 45"/>
-          <p:cNvSpPr txBox="1"/>
-          <p:nvPr/>
-        </p:nvSpPr>
-        <p:spPr>
-          <a:xfrm>
-            <a:off x="7077456" y="4187952"/>
-            <a:ext cx="2596896" cy="146304"/>
-          </a:xfrm>
-          <a:prstGeom prst="rect">
-            <a:avLst/>
-          </a:prstGeom>
-          <a:noFill/>
-        </p:spPr>
-        <p:txBody>
-          <a:bodyPr wrap="square" lIns="18288" rIns="18288" tIns="9144" bIns="9144" anchor="t">
-            <a:spAutoFit/>
-          </a:bodyPr>
-          <a:lstStyle/>
-          <a:p>
-            <a:pPr>
-              <a:defRPr sz="880" b="0">
-                <a:solidFill>
-                  <a:srgbClr val="5C667A"/>
-                </a:solidFill>
-                <a:latin typeface="Apple SD Gothic Neo"/>
-              </a:defRPr>
-            </a:pPr>
-            <a:r>
-              <a:t>왼쪽 block 색상과 무관한 배치 옵션</a:t>
+              <a:t>Data availability 운영 방식</a:t>
             </a:r>
           </a:p>
         </p:txBody>
@@ -14384,7 +14410,7 @@
         </p:nvSpPr>
         <p:spPr>
           <a:xfrm>
-            <a:off x="7114032" y="4407408"/>
+            <a:off x="7114032" y="4462272"/>
             <a:ext cx="950976" cy="219456"/>
           </a:xfrm>
           <a:prstGeom prst="roundRect">
@@ -14429,7 +14455,7 @@
         </p:nvSpPr>
         <p:spPr>
           <a:xfrm>
-            <a:off x="7168896" y="4462272"/>
+            <a:off x="7168896" y="4517136"/>
             <a:ext cx="841248" cy="73152"/>
           </a:xfrm>
           <a:prstGeom prst="rect">
@@ -14465,7 +14491,7 @@
         </p:nvSpPr>
         <p:spPr>
           <a:xfrm>
-            <a:off x="8247888" y="4407408"/>
+            <a:off x="8247888" y="4462272"/>
             <a:ext cx="950976" cy="219456"/>
           </a:xfrm>
           <a:prstGeom prst="roundRect">
@@ -14510,7 +14536,7 @@
         </p:nvSpPr>
         <p:spPr>
           <a:xfrm>
-            <a:off x="8302752" y="4462272"/>
+            <a:off x="8302752" y="4517136"/>
             <a:ext cx="841248" cy="73152"/>
           </a:xfrm>
           <a:prstGeom prst="rect">
@@ -14546,7 +14572,7 @@
         </p:nvSpPr>
         <p:spPr>
           <a:xfrm>
-            <a:off x="9381744" y="4407408"/>
+            <a:off x="9381744" y="4462272"/>
             <a:ext cx="950976" cy="219456"/>
           </a:xfrm>
           <a:prstGeom prst="roundRect">
@@ -14591,7 +14617,7 @@
         </p:nvSpPr>
         <p:spPr>
           <a:xfrm>
-            <a:off x="9436608" y="4462272"/>
+            <a:off x="9436608" y="4517136"/>
             <a:ext cx="841248" cy="73152"/>
           </a:xfrm>
           <a:prstGeom prst="rect">

</xml_diff>

<commit_message>
Update title slide presenter details
</commit_message>
<xml_diff>
--- a/bridge/docs/dev/spec.pptx
+++ b/bridge/docs/dev/spec.pptx
@@ -3866,8 +3866,8 @@
         </p:nvSpPr>
         <p:spPr>
           <a:xfrm>
-            <a:off x="685800" y="5760720"/>
-            <a:ext cx="5943600" cy="219456"/>
+            <a:off x="685800" y="5504688"/>
+            <a:ext cx="5943600" cy="658368"/>
           </a:xfrm>
           <a:prstGeom prst="rect">
             <a:avLst/>
@@ -3881,7 +3881,7 @@
           <a:lstStyle/>
           <a:p>
             <a:pPr>
-              <a:defRPr sz="1300" b="0">
+              <a:defRPr sz="1250" b="0">
                 <a:solidFill>
                   <a:srgbClr val="AEBAD0"/>
                 </a:solidFill>
@@ -3889,7 +3889,33 @@
               </a:defRPr>
             </a:pPr>
             <a:r>
-              <a:t>대상: 대학원 연구자와 프로토콜 개발자</a:t>
+              <a:t>2026년 5월 27일</a:t>
+            </a:r>
+          </a:p>
+          <a:p>
+            <a:pPr>
+              <a:defRPr sz="1250" b="0">
+                <a:solidFill>
+                  <a:srgbClr val="AEBAD0"/>
+                </a:solidFill>
+                <a:latin typeface="Apple SD Gothic Neo"/>
+              </a:defRPr>
+            </a:pPr>
+            <a:r>
+              <a:t>장재혁</a:t>
+            </a:r>
+          </a:p>
+          <a:p>
+            <a:pPr>
+              <a:defRPr sz="1250" b="0">
+                <a:solidFill>
+                  <a:srgbClr val="AEBAD0"/>
+                </a:solidFill>
+                <a:latin typeface="Apple SD Gothic Neo"/>
+              </a:defRPr>
+            </a:pPr>
+            <a:r>
+              <a:t>Tokamak Network</a:t>
             </a:r>
           </a:p>
         </p:txBody>

</xml_diff>

<commit_message>
Clarify DApp metadata derivation slide
</commit_message>
<xml_diff>
--- a/bridge/docs/dev/spec.pptx
+++ b/bridge/docs/dev/spec.pptx
@@ -35322,7 +35322,7 @@
               </a:defRPr>
             </a:pPr>
             <a:r>
-              <a:t>브릿지는 DApp deployment를 runtime call target으로 쓰지 않고, compiler가 만든 metadata vocabulary를 admission 기준으로 사용한다.</a:t>
+              <a:t>브릿지는 배포된 DApp을 호출하지 않는다. bytecode에서 만든 metadata를 보고 proof를 받아들일지 결정한다.</a:t>
             </a:r>
           </a:p>
         </p:txBody>
@@ -35450,8 +35450,8 @@
         </p:nvSpPr>
         <p:spPr>
           <a:xfrm>
-            <a:off x="640080" y="2514600"/>
-            <a:ext cx="1645920" cy="676656"/>
+            <a:off x="749808" y="2542032"/>
+            <a:ext cx="2157984" cy="804672"/>
           </a:xfrm>
           <a:prstGeom prst="roundRect">
             <a:avLst/>
@@ -35495,22 +35495,58 @@
         </p:nvSpPr>
         <p:spPr>
           <a:xfrm>
-            <a:off x="704088" y="2587752"/>
-            <a:ext cx="1517904" cy="530352"/>
-          </a:xfrm>
-          <a:prstGeom prst="rect">
-            <a:avLst/>
-          </a:prstGeom>
-          <a:noFill/>
-        </p:spPr>
-        <p:txBody>
-          <a:bodyPr wrap="square" lIns="18288" rIns="18288" tIns="9144" bIns="9144" anchor="ctr">
-            <a:spAutoFit/>
-          </a:bodyPr>
-          <a:lstStyle/>
-          <a:p>
-            <a:pPr algn="ctr">
-              <a:defRPr sz="1120" b="1">
+            <a:off x="914400" y="2660904"/>
+            <a:ext cx="566928" cy="182880"/>
+          </a:xfrm>
+          <a:prstGeom prst="rect">
+            <a:avLst/>
+          </a:prstGeom>
+          <a:noFill/>
+        </p:spPr>
+        <p:txBody>
+          <a:bodyPr wrap="square" lIns="18288" rIns="18288" tIns="9144" bIns="9144" anchor="t">
+            <a:spAutoFit/>
+          </a:bodyPr>
+          <a:lstStyle/>
+          <a:p>
+            <a:pPr>
+              <a:defRPr sz="930" b="1">
+                <a:solidFill>
+                  <a:srgbClr val="5C667A"/>
+                </a:solidFill>
+                <a:latin typeface="Apple SD Gothic Neo"/>
+              </a:defRPr>
+            </a:pPr>
+            <a:r>
+              <a:t>데이터</a:t>
+            </a:r>
+          </a:p>
+        </p:txBody>
+      </p:sp>
+      <p:sp>
+        <p:nvSpPr>
+          <p:cNvPr id="11" name="TextBox 10"/>
+          <p:cNvSpPr txBox="1"/>
+          <p:nvPr/>
+        </p:nvSpPr>
+        <p:spPr>
+          <a:xfrm>
+            <a:off x="914400" y="2862072"/>
+            <a:ext cx="1755648" cy="201168"/>
+          </a:xfrm>
+          <a:prstGeom prst="rect">
+            <a:avLst/>
+          </a:prstGeom>
+          <a:noFill/>
+        </p:spPr>
+        <p:txBody>
+          <a:bodyPr wrap="square" lIns="18288" rIns="18288" tIns="9144" bIns="9144" anchor="t">
+            <a:spAutoFit/>
+          </a:bodyPr>
+          <a:lstStyle/>
+          <a:p>
+            <a:pPr>
+              <a:defRPr sz="1280" b="1">
                 <a:solidFill>
                   <a:srgbClr val="1B1F2A"/>
                 </a:solidFill>
@@ -35518,172 +35554,57 @@
               </a:defRPr>
             </a:pPr>
             <a:r>
-              <a:t>Solidity DApp</a:t>
-            </a:r>
-          </a:p>
-        </p:txBody>
-      </p:sp>
-      <p:cxnSp>
-        <p:nvCxnSpPr>
-          <p:cNvPr id="11" name="Connector 10"/>
-          <p:cNvCxnSpPr/>
-          <p:nvPr/>
-        </p:nvCxnSpPr>
-        <p:spPr>
-          <a:xfrm>
-            <a:off x="2286000" y="2852928"/>
-            <a:ext cx="457200" cy="0"/>
-          </a:xfrm>
-          <a:prstGeom prst="line">
-            <a:avLst/>
-          </a:prstGeom>
-          <a:ln w="25400">
-            <a:solidFill>
-              <a:srgbClr val="2563EB"/>
-            </a:solidFill>
-          </a:ln>
-        </p:spPr>
-        <p:style>
-          <a:lnRef idx="2">
-            <a:schemeClr val="accent1"/>
-          </a:lnRef>
-          <a:fillRef idx="0">
-            <a:schemeClr val="accent1"/>
-          </a:fillRef>
-          <a:effectRef idx="1">
-            <a:schemeClr val="accent1"/>
-          </a:effectRef>
-          <a:fontRef idx="minor">
-            <a:schemeClr val="tx1"/>
-          </a:fontRef>
-        </p:style>
-      </p:cxnSp>
-      <p:sp>
-        <p:nvSpPr>
-          <p:cNvPr id="12" name="Rounded Rectangle 11"/>
+              <a:t>Solidity source</a:t>
+            </a:r>
+          </a:p>
+        </p:txBody>
+      </p:sp>
+      <p:sp>
+        <p:nvSpPr>
+          <p:cNvPr id="12" name="TextBox 11"/>
+          <p:cNvSpPr txBox="1"/>
+          <p:nvPr/>
+        </p:nvSpPr>
+        <p:spPr>
+          <a:xfrm>
+            <a:off x="914400" y="3090672"/>
+            <a:ext cx="1755648" cy="146304"/>
+          </a:xfrm>
+          <a:prstGeom prst="rect">
+            <a:avLst/>
+          </a:prstGeom>
+          <a:noFill/>
+        </p:spPr>
+        <p:txBody>
+          <a:bodyPr wrap="square" lIns="18288" rIns="18288" tIns="9144" bIns="9144" anchor="t">
+            <a:spAutoFit/>
+          </a:bodyPr>
+          <a:lstStyle/>
+          <a:p>
+            <a:pPr>
+              <a:defRPr sz="880" b="0">
+                <a:solidFill>
+                  <a:srgbClr val="5C667A"/>
+                </a:solidFill>
+                <a:latin typeface="Apple SD Gothic Neo"/>
+              </a:defRPr>
+            </a:pPr>
+            <a:r>
+              <a:t>DApp logic</a:t>
+            </a:r>
+          </a:p>
+        </p:txBody>
+      </p:sp>
+      <p:sp>
+        <p:nvSpPr>
+          <p:cNvPr id="13" name="Rounded Rectangle 12"/>
           <p:cNvSpPr/>
           <p:nvPr/>
         </p:nvSpPr>
         <p:spPr>
           <a:xfrm>
-            <a:off x="2862072" y="2514600"/>
-            <a:ext cx="1645920" cy="676656"/>
-          </a:xfrm>
-          <a:prstGeom prst="roundRect">
-            <a:avLst/>
-          </a:prstGeom>
-          <a:solidFill>
-            <a:srgbClr val="E8F7F0"/>
-          </a:solidFill>
-          <a:ln w="12700">
-            <a:solidFill>
-              <a:srgbClr val="D8DDE6"/>
-            </a:solidFill>
-          </a:ln>
-        </p:spPr>
-        <p:style>
-          <a:lnRef idx="1">
-            <a:schemeClr val="accent1"/>
-          </a:lnRef>
-          <a:fillRef idx="3">
-            <a:schemeClr val="accent1"/>
-          </a:fillRef>
-          <a:effectRef idx="2">
-            <a:schemeClr val="accent1"/>
-          </a:effectRef>
-          <a:fontRef idx="minor">
-            <a:schemeClr val="lt1"/>
-          </a:fontRef>
-        </p:style>
-        <p:txBody>
-          <a:bodyPr rtlCol="0" anchor="ctr"/>
-          <a:lstStyle/>
-          <a:p>
-            <a:pPr algn="ctr"/>
-          </a:p>
-        </p:txBody>
-      </p:sp>
-      <p:sp>
-        <p:nvSpPr>
-          <p:cNvPr id="13" name="TextBox 12"/>
-          <p:cNvSpPr txBox="1"/>
-          <p:nvPr/>
-        </p:nvSpPr>
-        <p:spPr>
-          <a:xfrm>
-            <a:off x="2926079" y="2587752"/>
-            <a:ext cx="1517904" cy="530352"/>
-          </a:xfrm>
-          <a:prstGeom prst="rect">
-            <a:avLst/>
-          </a:prstGeom>
-          <a:noFill/>
-        </p:spPr>
-        <p:txBody>
-          <a:bodyPr wrap="square" lIns="18288" rIns="18288" tIns="9144" bIns="9144" anchor="ctr">
-            <a:spAutoFit/>
-          </a:bodyPr>
-          <a:lstStyle/>
-          <a:p>
-            <a:pPr algn="ctr">
-              <a:defRPr sz="1120" b="1">
-                <a:solidFill>
-                  <a:srgbClr val="1B1F2A"/>
-                </a:solidFill>
-                <a:latin typeface="Apple SD Gothic Neo"/>
-              </a:defRPr>
-            </a:pPr>
-            <a:r>
-              <a:t>solidity compiler</a:t>
-            </a:r>
-          </a:p>
-        </p:txBody>
-      </p:sp>
-      <p:cxnSp>
-        <p:nvCxnSpPr>
-          <p:cNvPr id="14" name="Connector 13"/>
-          <p:cNvCxnSpPr/>
-          <p:nvPr/>
-        </p:nvCxnSpPr>
-        <p:spPr>
-          <a:xfrm>
-            <a:off x="4507992" y="2852928"/>
-            <a:ext cx="457200" cy="0"/>
-          </a:xfrm>
-          <a:prstGeom prst="line">
-            <a:avLst/>
-          </a:prstGeom>
-          <a:ln w="25400">
-            <a:solidFill>
-              <a:srgbClr val="2563EB"/>
-            </a:solidFill>
-          </a:ln>
-        </p:spPr>
-        <p:style>
-          <a:lnRef idx="2">
-            <a:schemeClr val="accent1"/>
-          </a:lnRef>
-          <a:fillRef idx="0">
-            <a:schemeClr val="accent1"/>
-          </a:fillRef>
-          <a:effectRef idx="1">
-            <a:schemeClr val="accent1"/>
-          </a:effectRef>
-          <a:fontRef idx="minor">
-            <a:schemeClr val="tx1"/>
-          </a:fontRef>
-        </p:style>
-      </p:cxnSp>
-      <p:sp>
-        <p:nvSpPr>
-          <p:cNvPr id="15" name="Rounded Rectangle 14"/>
-          <p:cNvSpPr/>
-          <p:nvPr/>
-        </p:nvSpPr>
-        <p:spPr>
-          <a:xfrm>
-            <a:off x="5084064" y="2514600"/>
-            <a:ext cx="1645920" cy="676656"/>
+            <a:off x="4864608" y="2542032"/>
+            <a:ext cx="2157984" cy="804672"/>
           </a:xfrm>
           <a:prstGeom prst="roundRect">
             <a:avLst/>
@@ -35721,214 +35642,122 @@
       </p:sp>
       <p:sp>
         <p:nvSpPr>
+          <p:cNvPr id="14" name="TextBox 13"/>
+          <p:cNvSpPr txBox="1"/>
+          <p:nvPr/>
+        </p:nvSpPr>
+        <p:spPr>
+          <a:xfrm>
+            <a:off x="5029200" y="2660904"/>
+            <a:ext cx="566928" cy="182880"/>
+          </a:xfrm>
+          <a:prstGeom prst="rect">
+            <a:avLst/>
+          </a:prstGeom>
+          <a:noFill/>
+        </p:spPr>
+        <p:txBody>
+          <a:bodyPr wrap="square" lIns="18288" rIns="18288" tIns="9144" bIns="9144" anchor="t">
+            <a:spAutoFit/>
+          </a:bodyPr>
+          <a:lstStyle/>
+          <a:p>
+            <a:pPr>
+              <a:defRPr sz="930" b="1">
+                <a:solidFill>
+                  <a:srgbClr val="5C667A"/>
+                </a:solidFill>
+                <a:latin typeface="Apple SD Gothic Neo"/>
+              </a:defRPr>
+            </a:pPr>
+            <a:r>
+              <a:t>데이터</a:t>
+            </a:r>
+          </a:p>
+        </p:txBody>
+      </p:sp>
+      <p:sp>
+        <p:nvSpPr>
+          <p:cNvPr id="15" name="TextBox 14"/>
+          <p:cNvSpPr txBox="1"/>
+          <p:nvPr/>
+        </p:nvSpPr>
+        <p:spPr>
+          <a:xfrm>
+            <a:off x="5029200" y="2862072"/>
+            <a:ext cx="1755648" cy="201168"/>
+          </a:xfrm>
+          <a:prstGeom prst="rect">
+            <a:avLst/>
+          </a:prstGeom>
+          <a:noFill/>
+        </p:spPr>
+        <p:txBody>
+          <a:bodyPr wrap="square" lIns="18288" rIns="18288" tIns="9144" bIns="9144" anchor="t">
+            <a:spAutoFit/>
+          </a:bodyPr>
+          <a:lstStyle/>
+          <a:p>
+            <a:pPr>
+              <a:defRPr sz="1280" b="1">
+                <a:solidFill>
+                  <a:srgbClr val="1B1F2A"/>
+                </a:solidFill>
+                <a:latin typeface="Apple SD Gothic Neo"/>
+              </a:defRPr>
+            </a:pPr>
+            <a:r>
+              <a:t>deployed bytecode</a:t>
+            </a:r>
+          </a:p>
+        </p:txBody>
+      </p:sp>
+      <p:sp>
+        <p:nvSpPr>
           <p:cNvPr id="16" name="TextBox 15"/>
           <p:cNvSpPr txBox="1"/>
           <p:nvPr/>
         </p:nvSpPr>
         <p:spPr>
           <a:xfrm>
-            <a:off x="5148072" y="2587752"/>
-            <a:ext cx="1517904" cy="530352"/>
-          </a:xfrm>
-          <a:prstGeom prst="rect">
-            <a:avLst/>
-          </a:prstGeom>
-          <a:noFill/>
-        </p:spPr>
-        <p:txBody>
-          <a:bodyPr wrap="square" lIns="18288" rIns="18288" tIns="9144" bIns="9144" anchor="ctr">
-            <a:spAutoFit/>
-          </a:bodyPr>
-          <a:lstStyle/>
-          <a:p>
-            <a:pPr algn="ctr">
-              <a:defRPr sz="1120" b="1">
-                <a:solidFill>
-                  <a:srgbClr val="1B1F2A"/>
-                </a:solidFill>
-                <a:latin typeface="Apple SD Gothic Neo"/>
-              </a:defRPr>
-            </a:pPr>
-            <a:r>
-              <a:t>deployed bytecode</a:t>
-            </a:r>
-          </a:p>
-        </p:txBody>
-      </p:sp>
-      <p:cxnSp>
-        <p:nvCxnSpPr>
-          <p:cNvPr id="17" name="Connector 16"/>
-          <p:cNvCxnSpPr/>
-          <p:nvPr/>
-        </p:nvCxnSpPr>
-        <p:spPr>
-          <a:xfrm>
-            <a:off x="6729984" y="2852928"/>
-            <a:ext cx="457200" cy="0"/>
-          </a:xfrm>
-          <a:prstGeom prst="line">
-            <a:avLst/>
-          </a:prstGeom>
-          <a:ln w="25400">
-            <a:solidFill>
-              <a:srgbClr val="2563EB"/>
-            </a:solidFill>
-          </a:ln>
-        </p:spPr>
-        <p:style>
-          <a:lnRef idx="2">
-            <a:schemeClr val="accent1"/>
-          </a:lnRef>
-          <a:fillRef idx="0">
-            <a:schemeClr val="accent1"/>
-          </a:fillRef>
-          <a:effectRef idx="1">
-            <a:schemeClr val="accent1"/>
-          </a:effectRef>
-          <a:fontRef idx="minor">
-            <a:schemeClr val="tx1"/>
-          </a:fontRef>
-        </p:style>
-      </p:cxnSp>
-      <p:sp>
-        <p:nvSpPr>
-          <p:cNvPr id="18" name="Rounded Rectangle 17"/>
+            <a:off x="5029200" y="3090672"/>
+            <a:ext cx="1755648" cy="146304"/>
+          </a:xfrm>
+          <a:prstGeom prst="rect">
+            <a:avLst/>
+          </a:prstGeom>
+          <a:noFill/>
+        </p:spPr>
+        <p:txBody>
+          <a:bodyPr wrap="square" lIns="18288" rIns="18288" tIns="9144" bIns="9144" anchor="t">
+            <a:spAutoFit/>
+          </a:bodyPr>
+          <a:lstStyle/>
+          <a:p>
+            <a:pPr>
+              <a:defRPr sz="880" b="0">
+                <a:solidFill>
+                  <a:srgbClr val="5C667A"/>
+                </a:solidFill>
+                <a:latin typeface="Apple SD Gothic Neo"/>
+              </a:defRPr>
+            </a:pPr>
+            <a:r>
+              <a:t>compiler input</a:t>
+            </a:r>
+          </a:p>
+        </p:txBody>
+      </p:sp>
+      <p:sp>
+        <p:nvSpPr>
+          <p:cNvPr id="17" name="Rounded Rectangle 16"/>
           <p:cNvSpPr/>
           <p:nvPr/>
         </p:nvSpPr>
         <p:spPr>
           <a:xfrm>
-            <a:off x="7306056" y="2514600"/>
-            <a:ext cx="1645920" cy="676656"/>
-          </a:xfrm>
-          <a:prstGeom prst="roundRect">
-            <a:avLst/>
-          </a:prstGeom>
-          <a:solidFill>
-            <a:srgbClr val="E8FBFF"/>
-          </a:solidFill>
-          <a:ln w="12700">
-            <a:solidFill>
-              <a:srgbClr val="D8DDE6"/>
-            </a:solidFill>
-          </a:ln>
-        </p:spPr>
-        <p:style>
-          <a:lnRef idx="1">
-            <a:schemeClr val="accent1"/>
-          </a:lnRef>
-          <a:fillRef idx="3">
-            <a:schemeClr val="accent1"/>
-          </a:fillRef>
-          <a:effectRef idx="2">
-            <a:schemeClr val="accent1"/>
-          </a:effectRef>
-          <a:fontRef idx="minor">
-            <a:schemeClr val="lt1"/>
-          </a:fontRef>
-        </p:style>
-        <p:txBody>
-          <a:bodyPr rtlCol="0" anchor="ctr"/>
-          <a:lstStyle/>
-          <a:p>
-            <a:pPr algn="ctr"/>
-          </a:p>
-        </p:txBody>
-      </p:sp>
-      <p:sp>
-        <p:nvSpPr>
-          <p:cNvPr id="19" name="TextBox 18"/>
-          <p:cNvSpPr txBox="1"/>
-          <p:nvPr/>
-        </p:nvSpPr>
-        <p:spPr>
-          <a:xfrm>
-            <a:off x="7370064" y="2587752"/>
-            <a:ext cx="1517904" cy="530352"/>
-          </a:xfrm>
-          <a:prstGeom prst="rect">
-            <a:avLst/>
-          </a:prstGeom>
-          <a:noFill/>
-        </p:spPr>
-        <p:txBody>
-          <a:bodyPr wrap="square" lIns="18288" rIns="18288" tIns="9144" bIns="9144" anchor="ctr">
-            <a:spAutoFit/>
-          </a:bodyPr>
-          <a:lstStyle/>
-          <a:p>
-            <a:pPr algn="ctr">
-              <a:defRPr sz="1120" b="1">
-                <a:solidFill>
-                  <a:srgbClr val="1B1F2A"/>
-                </a:solidFill>
-                <a:latin typeface="Apple SD Gothic Neo"/>
-              </a:defRPr>
-            </a:pPr>
-            <a:r>
-              <a:t>Tokamak zk-EVM</a:t>
-            </a:r>
-          </a:p>
-          <a:p>
-            <a:pPr algn="ctr">
-              <a:defRPr sz="1120" b="1">
-                <a:solidFill>
-                  <a:srgbClr val="1B1F2A"/>
-                </a:solidFill>
-                <a:latin typeface="Apple SD Gothic Neo"/>
-              </a:defRPr>
-            </a:pPr>
-            <a:r>
-              <a:t>compiler</a:t>
-            </a:r>
-          </a:p>
-        </p:txBody>
-      </p:sp>
-      <p:cxnSp>
-        <p:nvCxnSpPr>
-          <p:cNvPr id="20" name="Connector 19"/>
-          <p:cNvCxnSpPr/>
-          <p:nvPr/>
-        </p:nvCxnSpPr>
-        <p:spPr>
-          <a:xfrm>
-            <a:off x="8951976" y="2852928"/>
-            <a:ext cx="457200" cy="0"/>
-          </a:xfrm>
-          <a:prstGeom prst="line">
-            <a:avLst/>
-          </a:prstGeom>
-          <a:ln w="25400">
-            <a:solidFill>
-              <a:srgbClr val="2563EB"/>
-            </a:solidFill>
-          </a:ln>
-        </p:spPr>
-        <p:style>
-          <a:lnRef idx="2">
-            <a:schemeClr val="accent1"/>
-          </a:lnRef>
-          <a:fillRef idx="0">
-            <a:schemeClr val="accent1"/>
-          </a:fillRef>
-          <a:effectRef idx="1">
-            <a:schemeClr val="accent1"/>
-          </a:effectRef>
-          <a:fontRef idx="minor">
-            <a:schemeClr val="tx1"/>
-          </a:fontRef>
-        </p:style>
-      </p:cxnSp>
-      <p:sp>
-        <p:nvSpPr>
-          <p:cNvPr id="21" name="Rounded Rectangle 20"/>
-          <p:cNvSpPr/>
-          <p:nvPr/>
-        </p:nvSpPr>
-        <p:spPr>
-          <a:xfrm>
-            <a:off x="9528048" y="2514600"/>
-            <a:ext cx="1645920" cy="676656"/>
+            <a:off x="8979408" y="2542032"/>
+            <a:ext cx="2157984" cy="804672"/>
           </a:xfrm>
           <a:prstGeom prst="roundRect">
             <a:avLst/>
@@ -35966,28 +35795,64 @@
       </p:sp>
       <p:sp>
         <p:nvSpPr>
-          <p:cNvPr id="22" name="TextBox 21"/>
-          <p:cNvSpPr txBox="1"/>
-          <p:nvPr/>
-        </p:nvSpPr>
-        <p:spPr>
-          <a:xfrm>
-            <a:off x="9592056" y="2587752"/>
-            <a:ext cx="1517904" cy="530352"/>
-          </a:xfrm>
-          <a:prstGeom prst="rect">
-            <a:avLst/>
-          </a:prstGeom>
-          <a:noFill/>
-        </p:spPr>
-        <p:txBody>
-          <a:bodyPr wrap="square" lIns="18288" rIns="18288" tIns="9144" bIns="9144" anchor="ctr">
-            <a:spAutoFit/>
-          </a:bodyPr>
-          <a:lstStyle/>
-          <a:p>
-            <a:pPr algn="ctr">
-              <a:defRPr sz="1120" b="1">
+          <p:cNvPr id="18" name="TextBox 17"/>
+          <p:cNvSpPr txBox="1"/>
+          <p:nvPr/>
+        </p:nvSpPr>
+        <p:spPr>
+          <a:xfrm>
+            <a:off x="9144000" y="2660904"/>
+            <a:ext cx="566928" cy="182880"/>
+          </a:xfrm>
+          <a:prstGeom prst="rect">
+            <a:avLst/>
+          </a:prstGeom>
+          <a:noFill/>
+        </p:spPr>
+        <p:txBody>
+          <a:bodyPr wrap="square" lIns="18288" rIns="18288" tIns="9144" bIns="9144" anchor="t">
+            <a:spAutoFit/>
+          </a:bodyPr>
+          <a:lstStyle/>
+          <a:p>
+            <a:pPr>
+              <a:defRPr sz="930" b="1">
+                <a:solidFill>
+                  <a:srgbClr val="5C667A"/>
+                </a:solidFill>
+                <a:latin typeface="Apple SD Gothic Neo"/>
+              </a:defRPr>
+            </a:pPr>
+            <a:r>
+              <a:t>데이터</a:t>
+            </a:r>
+          </a:p>
+        </p:txBody>
+      </p:sp>
+      <p:sp>
+        <p:nvSpPr>
+          <p:cNvPr id="19" name="TextBox 18"/>
+          <p:cNvSpPr txBox="1"/>
+          <p:nvPr/>
+        </p:nvSpPr>
+        <p:spPr>
+          <a:xfrm>
+            <a:off x="9144000" y="2862072"/>
+            <a:ext cx="1755648" cy="201168"/>
+          </a:xfrm>
+          <a:prstGeom prst="rect">
+            <a:avLst/>
+          </a:prstGeom>
+          <a:noFill/>
+        </p:spPr>
+        <p:txBody>
+          <a:bodyPr wrap="square" lIns="18288" rIns="18288" tIns="9144" bIns="9144" anchor="t">
+            <a:spAutoFit/>
+          </a:bodyPr>
+          <a:lstStyle/>
+          <a:p>
+            <a:pPr>
+              <a:defRPr sz="1280" b="1">
                 <a:solidFill>
                   <a:srgbClr val="1B1F2A"/>
                 </a:solidFill>
@@ -36000,6 +35865,112 @@
           </a:p>
         </p:txBody>
       </p:sp>
+      <p:sp>
+        <p:nvSpPr>
+          <p:cNvPr id="20" name="TextBox 19"/>
+          <p:cNvSpPr txBox="1"/>
+          <p:nvPr/>
+        </p:nvSpPr>
+        <p:spPr>
+          <a:xfrm>
+            <a:off x="9144000" y="3090672"/>
+            <a:ext cx="1755648" cy="146304"/>
+          </a:xfrm>
+          <a:prstGeom prst="rect">
+            <a:avLst/>
+          </a:prstGeom>
+          <a:noFill/>
+        </p:spPr>
+        <p:txBody>
+          <a:bodyPr wrap="square" lIns="18288" rIns="18288" tIns="9144" bIns="9144" anchor="t">
+            <a:spAutoFit/>
+          </a:bodyPr>
+          <a:lstStyle/>
+          <a:p>
+            <a:pPr>
+              <a:defRPr sz="880" b="0">
+                <a:solidFill>
+                  <a:srgbClr val="5C667A"/>
+                </a:solidFill>
+                <a:latin typeface="Apple SD Gothic Neo"/>
+              </a:defRPr>
+            </a:pPr>
+            <a:r>
+              <a:t>bridge input</a:t>
+            </a:r>
+          </a:p>
+        </p:txBody>
+      </p:sp>
+      <p:cxnSp>
+        <p:nvCxnSpPr>
+          <p:cNvPr id="21" name="Connector 20"/>
+          <p:cNvCxnSpPr/>
+          <p:nvPr/>
+        </p:nvCxnSpPr>
+        <p:spPr>
+          <a:xfrm>
+            <a:off x="2999232" y="2944368"/>
+            <a:ext cx="1627632" cy="0"/>
+          </a:xfrm>
+          <a:prstGeom prst="line">
+            <a:avLst/>
+          </a:prstGeom>
+          <a:ln w="25400">
+            <a:solidFill>
+              <a:srgbClr val="2563EB"/>
+            </a:solidFill>
+          </a:ln>
+        </p:spPr>
+        <p:style>
+          <a:lnRef idx="2">
+            <a:schemeClr val="accent1"/>
+          </a:lnRef>
+          <a:fillRef idx="0">
+            <a:schemeClr val="accent1"/>
+          </a:fillRef>
+          <a:effectRef idx="1">
+            <a:schemeClr val="accent1"/>
+          </a:effectRef>
+          <a:fontRef idx="minor">
+            <a:schemeClr val="tx1"/>
+          </a:fontRef>
+        </p:style>
+      </p:cxnSp>
+      <p:cxnSp>
+        <p:nvCxnSpPr>
+          <p:cNvPr id="22" name="Connector 21"/>
+          <p:cNvCxnSpPr/>
+          <p:nvPr/>
+        </p:nvCxnSpPr>
+        <p:spPr>
+          <a:xfrm>
+            <a:off x="7114032" y="2944368"/>
+            <a:ext cx="1627632" cy="0"/>
+          </a:xfrm>
+          <a:prstGeom prst="line">
+            <a:avLst/>
+          </a:prstGeom>
+          <a:ln w="25400">
+            <a:solidFill>
+              <a:srgbClr val="21A67A"/>
+            </a:solidFill>
+          </a:ln>
+        </p:spPr>
+        <p:style>
+          <a:lnRef idx="2">
+            <a:schemeClr val="accent1"/>
+          </a:lnRef>
+          <a:fillRef idx="0">
+            <a:schemeClr val="accent1"/>
+          </a:fillRef>
+          <a:effectRef idx="1">
+            <a:schemeClr val="accent1"/>
+          </a:effectRef>
+          <a:fontRef idx="minor">
+            <a:schemeClr val="tx1"/>
+          </a:fontRef>
+        </p:style>
+      </p:cxnSp>
       <p:sp>
         <p:nvSpPr>
           <p:cNvPr id="23" name="Rounded Rectangle 22"/>
@@ -36008,8 +35979,206 @@
         </p:nvSpPr>
         <p:spPr>
           <a:xfrm>
-            <a:off x="804672" y="4096512"/>
-            <a:ext cx="3291840" cy="1097280"/>
+            <a:off x="3035808" y="2148840"/>
+            <a:ext cx="1554480" cy="347472"/>
+          </a:xfrm>
+          <a:prstGeom prst="roundRect">
+            <a:avLst/>
+          </a:prstGeom>
+          <a:solidFill>
+            <a:srgbClr val="E8F7F0"/>
+          </a:solidFill>
+          <a:ln w="12700">
+            <a:solidFill>
+              <a:srgbClr val="21A67A"/>
+            </a:solidFill>
+          </a:ln>
+        </p:spPr>
+        <p:style>
+          <a:lnRef idx="1">
+            <a:schemeClr val="accent1"/>
+          </a:lnRef>
+          <a:fillRef idx="3">
+            <a:schemeClr val="accent1"/>
+          </a:fillRef>
+          <a:effectRef idx="2">
+            <a:schemeClr val="accent1"/>
+          </a:effectRef>
+          <a:fontRef idx="minor">
+            <a:schemeClr val="lt1"/>
+          </a:fontRef>
+        </p:style>
+        <p:txBody>
+          <a:bodyPr rtlCol="0" anchor="ctr"/>
+          <a:lstStyle/>
+          <a:p>
+            <a:pPr algn="ctr"/>
+          </a:p>
+        </p:txBody>
+      </p:sp>
+      <p:sp>
+        <p:nvSpPr>
+          <p:cNvPr id="24" name="TextBox 23"/>
+          <p:cNvSpPr txBox="1"/>
+          <p:nvPr/>
+        </p:nvSpPr>
+        <p:spPr>
+          <a:xfrm>
+            <a:off x="3136392" y="2258568"/>
+            <a:ext cx="1353312" cy="137160"/>
+          </a:xfrm>
+          <a:prstGeom prst="rect">
+            <a:avLst/>
+          </a:prstGeom>
+          <a:noFill/>
+        </p:spPr>
+        <p:txBody>
+          <a:bodyPr wrap="square" lIns="18288" rIns="18288" tIns="9144" bIns="9144" anchor="ctr">
+            <a:spAutoFit/>
+          </a:bodyPr>
+          <a:lstStyle/>
+          <a:p>
+            <a:pPr algn="ctr">
+              <a:defRPr sz="880" b="1">
+                <a:solidFill>
+                  <a:srgbClr val="21A67A"/>
+                </a:solidFill>
+                <a:latin typeface="Apple SD Gothic Neo"/>
+              </a:defRPr>
+            </a:pPr>
+            <a:r>
+              <a:t>함수: solidity compiler</a:t>
+            </a:r>
+          </a:p>
+        </p:txBody>
+      </p:sp>
+      <p:sp>
+        <p:nvSpPr>
+          <p:cNvPr id="25" name="Rounded Rectangle 24"/>
+          <p:cNvSpPr/>
+          <p:nvPr/>
+        </p:nvSpPr>
+        <p:spPr>
+          <a:xfrm>
+            <a:off x="7059168" y="2148840"/>
+            <a:ext cx="1792224" cy="347472"/>
+          </a:xfrm>
+          <a:prstGeom prst="roundRect">
+            <a:avLst/>
+          </a:prstGeom>
+          <a:solidFill>
+            <a:srgbClr val="E8FBFF"/>
+          </a:solidFill>
+          <a:ln w="12700">
+            <a:solidFill>
+              <a:srgbClr val="00A6B2"/>
+            </a:solidFill>
+          </a:ln>
+        </p:spPr>
+        <p:style>
+          <a:lnRef idx="1">
+            <a:schemeClr val="accent1"/>
+          </a:lnRef>
+          <a:fillRef idx="3">
+            <a:schemeClr val="accent1"/>
+          </a:fillRef>
+          <a:effectRef idx="2">
+            <a:schemeClr val="accent1"/>
+          </a:effectRef>
+          <a:fontRef idx="minor">
+            <a:schemeClr val="lt1"/>
+          </a:fontRef>
+        </p:style>
+        <p:txBody>
+          <a:bodyPr rtlCol="0" anchor="ctr"/>
+          <a:lstStyle/>
+          <a:p>
+            <a:pPr algn="ctr"/>
+          </a:p>
+        </p:txBody>
+      </p:sp>
+      <p:sp>
+        <p:nvSpPr>
+          <p:cNvPr id="26" name="TextBox 25"/>
+          <p:cNvSpPr txBox="1"/>
+          <p:nvPr/>
+        </p:nvSpPr>
+        <p:spPr>
+          <a:xfrm>
+            <a:off x="7159752" y="2258568"/>
+            <a:ext cx="1591056" cy="137160"/>
+          </a:xfrm>
+          <a:prstGeom prst="rect">
+            <a:avLst/>
+          </a:prstGeom>
+          <a:noFill/>
+        </p:spPr>
+        <p:txBody>
+          <a:bodyPr wrap="square" lIns="18288" rIns="18288" tIns="9144" bIns="9144" anchor="ctr">
+            <a:spAutoFit/>
+          </a:bodyPr>
+          <a:lstStyle/>
+          <a:p>
+            <a:pPr algn="ctr">
+              <a:defRPr sz="860" b="1">
+                <a:solidFill>
+                  <a:srgbClr val="00A6B2"/>
+                </a:solidFill>
+                <a:latin typeface="Apple SD Gothic Neo"/>
+              </a:defRPr>
+            </a:pPr>
+            <a:r>
+              <a:t>함수: Tokamak zk-EVM compiler</a:t>
+            </a:r>
+          </a:p>
+        </p:txBody>
+      </p:sp>
+      <p:sp>
+        <p:nvSpPr>
+          <p:cNvPr id="27" name="TextBox 26"/>
+          <p:cNvSpPr txBox="1"/>
+          <p:nvPr/>
+        </p:nvSpPr>
+        <p:spPr>
+          <a:xfrm>
+            <a:off x="3246120" y="3584448"/>
+            <a:ext cx="5623560" cy="201168"/>
+          </a:xfrm>
+          <a:prstGeom prst="rect">
+            <a:avLst/>
+          </a:prstGeom>
+          <a:noFill/>
+        </p:spPr>
+        <p:txBody>
+          <a:bodyPr wrap="square" lIns="18288" rIns="18288" tIns="9144" bIns="9144" anchor="ctr">
+            <a:spAutoFit/>
+          </a:bodyPr>
+          <a:lstStyle/>
+          <a:p>
+            <a:pPr algn="ctr">
+              <a:defRPr sz="1200" b="0">
+                <a:solidFill>
+                  <a:srgbClr val="5C667A"/>
+                </a:solidFill>
+                <a:latin typeface="Apple SD Gothic Neo"/>
+              </a:defRPr>
+            </a:pPr>
+            <a:r>
+              <a:t>함수는 데이터를 바꾸고, 브릿지는 최종 metadata를 등록 기준으로 사용한다.</a:t>
+            </a:r>
+          </a:p>
+        </p:txBody>
+      </p:sp>
+      <p:sp>
+        <p:nvSpPr>
+          <p:cNvPr id="28" name="Rounded Rectangle 27"/>
+          <p:cNvSpPr/>
+          <p:nvPr/>
+        </p:nvSpPr>
+        <p:spPr>
+          <a:xfrm>
+            <a:off x="804672" y="4224528"/>
+            <a:ext cx="3291840" cy="1005840"/>
           </a:xfrm>
           <a:prstGeom prst="roundRect">
             <a:avLst/>
@@ -36047,13 +36216,13 @@
       </p:sp>
       <p:sp>
         <p:nvSpPr>
-          <p:cNvPr id="24" name="TextBox 23"/>
-          <p:cNvSpPr txBox="1"/>
-          <p:nvPr/>
-        </p:nvSpPr>
-        <p:spPr>
-          <a:xfrm>
-            <a:off x="1060704" y="4297680"/>
+          <p:cNvPr id="29" name="TextBox 28"/>
+          <p:cNvSpPr txBox="1"/>
+          <p:nvPr/>
+        </p:nvSpPr>
+        <p:spPr>
+          <a:xfrm>
+            <a:off x="1060704" y="4425696"/>
             <a:ext cx="2743200" cy="219456"/>
           </a:xfrm>
           <a:prstGeom prst="rect">
@@ -36068,7 +36237,7 @@
           <a:lstStyle/>
           <a:p>
             <a:pPr>
-              <a:defRPr sz="1400" b="1">
+              <a:defRPr sz="1320" b="1">
                 <a:solidFill>
                   <a:srgbClr val="2563EB"/>
                 </a:solidFill>
@@ -36076,21 +36245,21 @@
               </a:defRPr>
             </a:pPr>
             <a:r>
-              <a:t>Ethereum deployment의 역할</a:t>
-            </a:r>
-          </a:p>
-        </p:txBody>
-      </p:sp>
-      <p:sp>
-        <p:nvSpPr>
-          <p:cNvPr id="25" name="TextBox 24"/>
-          <p:cNvSpPr txBox="1"/>
-          <p:nvPr/>
-        </p:nvSpPr>
-        <p:spPr>
-          <a:xfrm>
-            <a:off x="1060704" y="4617720"/>
-            <a:ext cx="2697480" cy="420624"/>
+              <a:t>DApp deployment는 왜 필요한가?</a:t>
+            </a:r>
+          </a:p>
+        </p:txBody>
+      </p:sp>
+      <p:sp>
+        <p:nvSpPr>
+          <p:cNvPr id="30" name="TextBox 29"/>
+          <p:cNvSpPr txBox="1"/>
+          <p:nvPr/>
+        </p:nvSpPr>
+        <p:spPr>
+          <a:xfrm>
+            <a:off x="1060704" y="4736592"/>
+            <a:ext cx="2697480" cy="365760"/>
           </a:xfrm>
           <a:prstGeom prst="rect">
             <a:avLst/>
@@ -36104,7 +36273,7 @@
           <a:lstStyle/>
           <a:p>
             <a:pPr>
-              <a:defRPr sz="1019" b="0">
+              <a:defRPr sz="1000" b="0">
                 <a:solidFill>
                   <a:srgbClr val="5C667A"/>
                 </a:solidFill>
@@ -36112,21 +36281,21 @@
               </a:defRPr>
             </a:pPr>
             <a:r>
-              <a:t>compiler 입력 bytecode를 만들고, 개발자가 Solidity 로직을 점검할 접근성을 제공한다.</a:t>
-            </a:r>
-          </a:p>
-        </p:txBody>
-      </p:sp>
-      <p:sp>
-        <p:nvSpPr>
-          <p:cNvPr id="26" name="Rounded Rectangle 25"/>
+              <a:t>compiler가 읽을 bytecode를 만들고, 개발자가 같은 로직을 직접 점검할 수 있게 한다.</a:t>
+            </a:r>
+          </a:p>
+        </p:txBody>
+      </p:sp>
+      <p:sp>
+        <p:nvSpPr>
+          <p:cNvPr id="31" name="Rounded Rectangle 30"/>
           <p:cNvSpPr/>
           <p:nvPr/>
         </p:nvSpPr>
         <p:spPr>
           <a:xfrm>
-            <a:off x="4443984" y="4096512"/>
-            <a:ext cx="3291840" cy="1097280"/>
+            <a:off x="4443984" y="4224528"/>
+            <a:ext cx="3291840" cy="1005840"/>
           </a:xfrm>
           <a:prstGeom prst="roundRect">
             <a:avLst/>
@@ -36164,13 +36333,13 @@
       </p:sp>
       <p:sp>
         <p:nvSpPr>
-          <p:cNvPr id="27" name="TextBox 26"/>
-          <p:cNvSpPr txBox="1"/>
-          <p:nvPr/>
-        </p:nvSpPr>
-        <p:spPr>
-          <a:xfrm>
-            <a:off x="4700016" y="4297680"/>
+          <p:cNvPr id="32" name="TextBox 31"/>
+          <p:cNvSpPr txBox="1"/>
+          <p:nvPr/>
+        </p:nvSpPr>
+        <p:spPr>
+          <a:xfrm>
+            <a:off x="4700016" y="4425696"/>
             <a:ext cx="2743200" cy="219456"/>
           </a:xfrm>
           <a:prstGeom prst="rect">
@@ -36185,29 +36354,29 @@
           <a:lstStyle/>
           <a:p>
             <a:pPr>
-              <a:defRPr sz="1400" b="1">
-                <a:solidFill>
-                  <a:srgbClr val="F59E0B"/>
-                </a:solidFill>
-                <a:latin typeface="Apple SD Gothic Neo"/>
-              </a:defRPr>
-            </a:pPr>
-            <a:r>
-              <a:t>Bridge가 직접 하지 않는 것</a:t>
-            </a:r>
-          </a:p>
-        </p:txBody>
-      </p:sp>
-      <p:sp>
-        <p:nvSpPr>
-          <p:cNvPr id="28" name="TextBox 27"/>
-          <p:cNvSpPr txBox="1"/>
-          <p:nvPr/>
-        </p:nvSpPr>
-        <p:spPr>
-          <a:xfrm>
-            <a:off x="4700016" y="4617720"/>
-            <a:ext cx="2697480" cy="420624"/>
+              <a:defRPr sz="1320" b="1">
+                <a:solidFill>
+                  <a:srgbClr val="21A67A"/>
+                </a:solidFill>
+                <a:latin typeface="Apple SD Gothic Neo"/>
+              </a:defRPr>
+            </a:pPr>
+            <a:r>
+              <a:t>Bridge는 무엇을 보나?</a:t>
+            </a:r>
+          </a:p>
+        </p:txBody>
+      </p:sp>
+      <p:sp>
+        <p:nvSpPr>
+          <p:cNvPr id="33" name="TextBox 32"/>
+          <p:cNvSpPr txBox="1"/>
+          <p:nvPr/>
+        </p:nvSpPr>
+        <p:spPr>
+          <a:xfrm>
+            <a:off x="4700016" y="4736592"/>
+            <a:ext cx="2697480" cy="365760"/>
           </a:xfrm>
           <a:prstGeom prst="rect">
             <a:avLst/>
@@ -36221,7 +36390,7 @@
           <a:lstStyle/>
           <a:p>
             <a:pPr>
-              <a:defRPr sz="1019" b="0">
+              <a:defRPr sz="1000" b="0">
                 <a:solidFill>
                   <a:srgbClr val="5C667A"/>
                 </a:solidFill>
@@ -36229,21 +36398,21 @@
               </a:defRPr>
             </a:pPr>
             <a:r>
-              <a:t>DApp deployment를 호출해 transaction을 replay하거나 Solidity runtime을 실행하지 않는다.</a:t>
-            </a:r>
-          </a:p>
-        </p:txBody>
-      </p:sp>
-      <p:sp>
-        <p:nvSpPr>
-          <p:cNvPr id="29" name="Rounded Rectangle 28"/>
+              <a:t>허용 함수, storage 범위, public input 형식이 들어 있는 DApp metadata를 본다.</a:t>
+            </a:r>
+          </a:p>
+        </p:txBody>
+      </p:sp>
+      <p:sp>
+        <p:nvSpPr>
+          <p:cNvPr id="34" name="Rounded Rectangle 33"/>
           <p:cNvSpPr/>
           <p:nvPr/>
         </p:nvSpPr>
         <p:spPr>
           <a:xfrm>
-            <a:off x="8083296" y="4096512"/>
-            <a:ext cx="3291840" cy="1097280"/>
+            <a:off x="8083296" y="4224528"/>
+            <a:ext cx="3291840" cy="1005840"/>
           </a:xfrm>
           <a:prstGeom prst="roundRect">
             <a:avLst/>
@@ -36281,13 +36450,13 @@
       </p:sp>
       <p:sp>
         <p:nvSpPr>
-          <p:cNvPr id="30" name="TextBox 29"/>
-          <p:cNvSpPr txBox="1"/>
-          <p:nvPr/>
-        </p:nvSpPr>
-        <p:spPr>
-          <a:xfrm>
-            <a:off x="8339327" y="4297680"/>
+          <p:cNvPr id="35" name="TextBox 34"/>
+          <p:cNvSpPr txBox="1"/>
+          <p:nvPr/>
+        </p:nvSpPr>
+        <p:spPr>
+          <a:xfrm>
+            <a:off x="8339327" y="4425696"/>
             <a:ext cx="2743200" cy="219456"/>
           </a:xfrm>
           <a:prstGeom prst="rect">
@@ -36302,29 +36471,29 @@
           <a:lstStyle/>
           <a:p>
             <a:pPr>
-              <a:defRPr sz="1400" b="1">
-                <a:solidFill>
-                  <a:srgbClr val="21A67A"/>
-                </a:solidFill>
-                <a:latin typeface="Apple SD Gothic Neo"/>
-              </a:defRPr>
-            </a:pPr>
-            <a:r>
-              <a:t>Bridge가 실제로 쓰는 것</a:t>
-            </a:r>
-          </a:p>
-        </p:txBody>
-      </p:sp>
-      <p:sp>
-        <p:nvSpPr>
-          <p:cNvPr id="31" name="TextBox 30"/>
-          <p:cNvSpPr txBox="1"/>
-          <p:nvPr/>
-        </p:nvSpPr>
-        <p:spPr>
-          <a:xfrm>
-            <a:off x="8339327" y="4617720"/>
-            <a:ext cx="2697480" cy="420624"/>
+              <a:defRPr sz="1320" b="1">
+                <a:solidFill>
+                  <a:srgbClr val="F59E0B"/>
+                </a:solidFill>
+                <a:latin typeface="Apple SD Gothic Neo"/>
+              </a:defRPr>
+            </a:pPr>
+            <a:r>
+              <a:t>Bridge는 무엇을 하지 않나?</a:t>
+            </a:r>
+          </a:p>
+        </p:txBody>
+      </p:sp>
+      <p:sp>
+        <p:nvSpPr>
+          <p:cNvPr id="36" name="TextBox 35"/>
+          <p:cNvSpPr txBox="1"/>
+          <p:nvPr/>
+        </p:nvSpPr>
+        <p:spPr>
+          <a:xfrm>
+            <a:off x="8339327" y="4736592"/>
+            <a:ext cx="2697480" cy="365760"/>
           </a:xfrm>
           <a:prstGeom prst="rect">
             <a:avLst/>
@@ -36338,7 +36507,7 @@
           <a:lstStyle/>
           <a:p>
             <a:pPr>
-              <a:defRPr sz="1019" b="0">
+              <a:defRPr sz="1000" b="0">
                 <a:solidFill>
                   <a:srgbClr val="5C667A"/>
                 </a:solidFill>
@@ -36346,7 +36515,7 @@
               </a:defRPr>
             </a:pPr>
             <a:r>
-              <a:t>function metadata, storage vector, preprocess hash, public input layout 같은 registration artifact다.</a:t>
+              <a:t>배포된 DApp을 호출하거나 transaction을 L1에서 다시 실행하지 않는다.</a:t>
             </a:r>
           </a:p>
         </p:txBody>

</xml_diff>

<commit_message>
Increase deck minimum text size
</commit_message>
<xml_diff>
--- a/bridge/docs/dev/spec.pptx
+++ b/bridge/docs/dev/spec.pptx
@@ -3259,7 +3259,7 @@
         <p:spPr>
           <a:xfrm>
             <a:off x="685800" y="3127248"/>
-            <a:ext cx="1188720" cy="292608"/>
+            <a:ext cx="1188720" cy="365760"/>
           </a:xfrm>
           <a:prstGeom prst="roundRect">
             <a:avLst/>
@@ -3301,7 +3301,7 @@
         </p:nvSpPr>
         <p:spPr>
           <a:xfrm>
-            <a:off x="713232" y="3191256"/>
+            <a:off x="713232" y="3209544"/>
             <a:ext cx="1133856" cy="164592"/>
           </a:xfrm>
           <a:prstGeom prst="rect">
@@ -3316,7 +3316,7 @@
           <a:lstStyle/>
           <a:p>
             <a:pPr algn="ctr">
-              <a:defRPr sz="1050" b="1">
+              <a:defRPr sz="1300" b="1">
                 <a:solidFill>
                   <a:srgbClr val="FFFFFF"/>
                 </a:solidFill>
@@ -3338,7 +3338,7 @@
         <p:spPr>
           <a:xfrm>
             <a:off x="2066543" y="3127248"/>
-            <a:ext cx="1188720" cy="292608"/>
+            <a:ext cx="1188720" cy="365760"/>
           </a:xfrm>
           <a:prstGeom prst="roundRect">
             <a:avLst/>
@@ -3380,7 +3380,7 @@
         </p:nvSpPr>
         <p:spPr>
           <a:xfrm>
-            <a:off x="2093975" y="3191256"/>
+            <a:off x="2093975" y="3209544"/>
             <a:ext cx="1133856" cy="164592"/>
           </a:xfrm>
           <a:prstGeom prst="rect">
@@ -3395,7 +3395,7 @@
           <a:lstStyle/>
           <a:p>
             <a:pPr algn="ctr">
-              <a:defRPr sz="1050" b="1">
+              <a:defRPr sz="1300" b="1">
                 <a:solidFill>
                   <a:srgbClr val="FFFFFF"/>
                 </a:solidFill>
@@ -3417,7 +3417,7 @@
         <p:spPr>
           <a:xfrm>
             <a:off x="3456432" y="3127248"/>
-            <a:ext cx="1371600" cy="292608"/>
+            <a:ext cx="1371600" cy="365760"/>
           </a:xfrm>
           <a:prstGeom prst="roundRect">
             <a:avLst/>
@@ -3459,7 +3459,7 @@
         </p:nvSpPr>
         <p:spPr>
           <a:xfrm>
-            <a:off x="3483863" y="3191256"/>
+            <a:off x="3483863" y="3209544"/>
             <a:ext cx="1316736" cy="164592"/>
           </a:xfrm>
           <a:prstGeom prst="rect">
@@ -3474,7 +3474,7 @@
           <a:lstStyle/>
           <a:p>
             <a:pPr algn="ctr">
-              <a:defRPr sz="1050" b="1">
+              <a:defRPr sz="1300" b="1">
                 <a:solidFill>
                   <a:srgbClr val="FFFFFF"/>
                 </a:solidFill>
@@ -3872,7 +3872,7 @@
           <a:lstStyle/>
           <a:p>
             <a:pPr>
-              <a:defRPr sz="1250" b="0">
+              <a:defRPr sz="1300" b="0">
                 <a:solidFill>
                   <a:srgbClr val="AEBAD0"/>
                 </a:solidFill>
@@ -3885,7 +3885,7 @@
           </a:p>
           <a:p>
             <a:pPr>
-              <a:defRPr sz="1250" b="0">
+              <a:defRPr sz="1300" b="0">
                 <a:solidFill>
                   <a:srgbClr val="AEBAD0"/>
                 </a:solidFill>
@@ -3898,7 +3898,7 @@
           </a:p>
           <a:p>
             <a:pPr>
-              <a:defRPr sz="1250" b="0">
+              <a:defRPr sz="1300" b="0">
                 <a:solidFill>
                   <a:srgbClr val="AEBAD0"/>
                 </a:solidFill>
@@ -4003,7 +4003,7 @@
           <a:lstStyle/>
           <a:p>
             <a:pPr>
-              <a:defRPr sz="1100" b="1">
+              <a:defRPr sz="1300" b="1">
                 <a:solidFill>
                   <a:srgbClr val="2563EB"/>
                 </a:solidFill>
@@ -4139,8 +4139,8 @@
         </p:nvSpPr>
         <p:spPr>
           <a:xfrm>
-            <a:off x="530352" y="6473952"/>
-            <a:ext cx="3291840" cy="164592"/>
+            <a:off x="530352" y="6419088"/>
+            <a:ext cx="4389120" cy="292608"/>
           </a:xfrm>
           <a:prstGeom prst="rect">
             <a:avLst/>
@@ -4154,7 +4154,7 @@
           <a:lstStyle/>
           <a:p>
             <a:pPr>
-              <a:defRPr sz="800" b="0">
+              <a:defRPr sz="1300" b="0">
                 <a:solidFill>
                   <a:srgbClr val="5C667A"/>
                 </a:solidFill>
@@ -4175,8 +4175,8 @@
         </p:nvSpPr>
         <p:spPr>
           <a:xfrm>
-            <a:off x="11292840" y="6473952"/>
-            <a:ext cx="320040" cy="164592"/>
+            <a:off x="11119104" y="6419088"/>
+            <a:ext cx="502920" cy="292608"/>
           </a:xfrm>
           <a:prstGeom prst="rect">
             <a:avLst/>
@@ -4190,7 +4190,7 @@
           <a:lstStyle/>
           <a:p>
             <a:pPr algn="r">
-              <a:defRPr sz="800" b="0">
+              <a:defRPr sz="1300" b="0">
                 <a:solidFill>
                   <a:srgbClr val="5C667A"/>
                 </a:solidFill>
@@ -4350,7 +4350,7 @@
           <a:lstStyle/>
           <a:p>
             <a:pPr>
-              <a:defRPr sz="1220" b="0">
+              <a:defRPr sz="1300" b="0">
                 <a:solidFill>
                   <a:srgbClr val="1B1F2A"/>
                 </a:solidFill>
@@ -4429,7 +4429,7 @@
           <a:lstStyle/>
           <a:p>
             <a:pPr>
-              <a:defRPr sz="1220" b="0">
+              <a:defRPr sz="1300" b="0">
                 <a:solidFill>
                   <a:srgbClr val="1B1F2A"/>
                 </a:solidFill>
@@ -4508,7 +4508,7 @@
           <a:lstStyle/>
           <a:p>
             <a:pPr>
-              <a:defRPr sz="1220" b="0">
+              <a:defRPr sz="1300" b="0">
                 <a:solidFill>
                   <a:srgbClr val="1B1F2A"/>
                 </a:solidFill>
@@ -4668,7 +4668,7 @@
           <a:lstStyle/>
           <a:p>
             <a:pPr>
-              <a:defRPr sz="1200" b="0">
+              <a:defRPr sz="1300" b="0">
                 <a:solidFill>
                   <a:srgbClr val="1B1F2A"/>
                 </a:solidFill>
@@ -4747,7 +4747,7 @@
           <a:lstStyle/>
           <a:p>
             <a:pPr>
-              <a:defRPr sz="1200" b="0">
+              <a:defRPr sz="1300" b="0">
                 <a:solidFill>
                   <a:srgbClr val="1B1F2A"/>
                 </a:solidFill>
@@ -4826,7 +4826,7 @@
           <a:lstStyle/>
           <a:p>
             <a:pPr>
-              <a:defRPr sz="1200" b="0">
+              <a:defRPr sz="1300" b="0">
                 <a:solidFill>
                   <a:srgbClr val="1B1F2A"/>
                 </a:solidFill>
@@ -4905,7 +4905,7 @@
           <a:lstStyle/>
           <a:p>
             <a:pPr>
-              <a:defRPr sz="1200" b="0">
+              <a:defRPr sz="1300" b="0">
                 <a:solidFill>
                   <a:srgbClr val="1B1F2A"/>
                 </a:solidFill>
@@ -4984,7 +4984,7 @@
           <a:lstStyle/>
           <a:p>
             <a:pPr algn="ctr">
-              <a:defRPr sz="1210" b="1">
+              <a:defRPr sz="1300" b="1">
                 <a:solidFill>
                   <a:srgbClr val="FFFFFF"/>
                 </a:solidFill>
@@ -5089,7 +5089,7 @@
           <a:lstStyle/>
           <a:p>
             <a:pPr>
-              <a:defRPr sz="1100" b="1">
+              <a:defRPr sz="1300" b="1">
                 <a:solidFill>
                   <a:srgbClr val="2563EB"/>
                 </a:solidFill>
@@ -5225,8 +5225,8 @@
         </p:nvSpPr>
         <p:spPr>
           <a:xfrm>
-            <a:off x="530352" y="6473952"/>
-            <a:ext cx="3291840" cy="164592"/>
+            <a:off x="530352" y="6419088"/>
+            <a:ext cx="4389120" cy="292608"/>
           </a:xfrm>
           <a:prstGeom prst="rect">
             <a:avLst/>
@@ -5240,7 +5240,7 @@
           <a:lstStyle/>
           <a:p>
             <a:pPr>
-              <a:defRPr sz="800" b="0">
+              <a:defRPr sz="1300" b="0">
                 <a:solidFill>
                   <a:srgbClr val="5C667A"/>
                 </a:solidFill>
@@ -5261,8 +5261,8 @@
         </p:nvSpPr>
         <p:spPr>
           <a:xfrm>
-            <a:off x="11292840" y="6473952"/>
-            <a:ext cx="320040" cy="164592"/>
+            <a:off x="11119104" y="6419088"/>
+            <a:ext cx="502920" cy="292608"/>
           </a:xfrm>
           <a:prstGeom prst="rect">
             <a:avLst/>
@@ -5276,7 +5276,7 @@
           <a:lstStyle/>
           <a:p>
             <a:pPr algn="r">
-              <a:defRPr sz="800" b="0">
+              <a:defRPr sz="1300" b="0">
                 <a:solidFill>
                   <a:srgbClr val="5C667A"/>
                 </a:solidFill>
@@ -5436,7 +5436,7 @@
           <a:lstStyle/>
           <a:p>
             <a:pPr algn="ctr">
-              <a:defRPr sz="1200" b="1">
+              <a:defRPr sz="1300" b="1">
                 <a:solidFill>
                   <a:srgbClr val="1B1F2A"/>
                 </a:solidFill>
@@ -5631,7 +5631,7 @@
           <a:lstStyle/>
           <a:p>
             <a:pPr algn="ctr">
-              <a:defRPr sz="1200" b="1">
+              <a:defRPr sz="1300" b="1">
                 <a:solidFill>
                   <a:srgbClr val="1B1F2A"/>
                 </a:solidFill>
@@ -5826,7 +5826,7 @@
           <a:lstStyle/>
           <a:p>
             <a:pPr algn="ctr">
-              <a:defRPr sz="1200" b="1">
+              <a:defRPr sz="1300" b="1">
                 <a:solidFill>
                   <a:srgbClr val="1B1F2A"/>
                 </a:solidFill>
@@ -6021,7 +6021,7 @@
           <a:lstStyle/>
           <a:p>
             <a:pPr algn="ctr">
-              <a:defRPr sz="1200" b="1">
+              <a:defRPr sz="1300" b="1">
                 <a:solidFill>
                   <a:srgbClr val="1B1F2A"/>
                 </a:solidFill>
@@ -6216,7 +6216,7 @@
           <a:lstStyle/>
           <a:p>
             <a:pPr algn="ctr">
-              <a:defRPr sz="1200" b="1">
+              <a:defRPr sz="1300" b="1">
                 <a:solidFill>
                   <a:srgbClr val="1B1F2A"/>
                 </a:solidFill>
@@ -6357,7 +6357,7 @@
           <a:lstStyle/>
           <a:p>
             <a:pPr>
-              <a:defRPr sz="1100" b="1">
+              <a:defRPr sz="1300" b="1">
                 <a:solidFill>
                   <a:srgbClr val="2563EB"/>
                 </a:solidFill>
@@ -6493,8 +6493,8 @@
         </p:nvSpPr>
         <p:spPr>
           <a:xfrm>
-            <a:off x="530352" y="6473952"/>
-            <a:ext cx="3291840" cy="164592"/>
+            <a:off x="530352" y="6419088"/>
+            <a:ext cx="4389120" cy="292608"/>
           </a:xfrm>
           <a:prstGeom prst="rect">
             <a:avLst/>
@@ -6508,7 +6508,7 @@
           <a:lstStyle/>
           <a:p>
             <a:pPr>
-              <a:defRPr sz="800" b="0">
+              <a:defRPr sz="1300" b="0">
                 <a:solidFill>
                   <a:srgbClr val="5C667A"/>
                 </a:solidFill>
@@ -6529,8 +6529,8 @@
         </p:nvSpPr>
         <p:spPr>
           <a:xfrm>
-            <a:off x="11292840" y="6473952"/>
-            <a:ext cx="320040" cy="164592"/>
+            <a:off x="11119104" y="6419088"/>
+            <a:ext cx="502920" cy="292608"/>
           </a:xfrm>
           <a:prstGeom prst="rect">
             <a:avLst/>
@@ -6544,7 +6544,7 @@
           <a:lstStyle/>
           <a:p>
             <a:pPr algn="r">
-              <a:defRPr sz="800" b="0">
+              <a:defRPr sz="1300" b="0">
                 <a:solidFill>
                   <a:srgbClr val="5C667A"/>
                 </a:solidFill>
@@ -7417,7 +7417,7 @@
           <a:lstStyle/>
           <a:p>
             <a:pPr algn="ctr">
-              <a:defRPr sz="1250" b="1">
+              <a:defRPr sz="1300" b="1">
                 <a:solidFill>
                   <a:srgbClr val="FFFFFF"/>
                 </a:solidFill>
@@ -7522,7 +7522,7 @@
           <a:lstStyle/>
           <a:p>
             <a:pPr>
-              <a:defRPr sz="1100" b="1">
+              <a:defRPr sz="1300" b="1">
                 <a:solidFill>
                   <a:srgbClr val="2563EB"/>
                 </a:solidFill>
@@ -7658,8 +7658,8 @@
         </p:nvSpPr>
         <p:spPr>
           <a:xfrm>
-            <a:off x="530352" y="6473952"/>
-            <a:ext cx="3291840" cy="164592"/>
+            <a:off x="530352" y="6419088"/>
+            <a:ext cx="4389120" cy="292608"/>
           </a:xfrm>
           <a:prstGeom prst="rect">
             <a:avLst/>
@@ -7673,7 +7673,7 @@
           <a:lstStyle/>
           <a:p>
             <a:pPr>
-              <a:defRPr sz="800" b="0">
+              <a:defRPr sz="1300" b="0">
                 <a:solidFill>
                   <a:srgbClr val="5C667A"/>
                 </a:solidFill>
@@ -7694,8 +7694,8 @@
         </p:nvSpPr>
         <p:spPr>
           <a:xfrm>
-            <a:off x="11292840" y="6473952"/>
-            <a:ext cx="320040" cy="164592"/>
+            <a:off x="11119104" y="6419088"/>
+            <a:ext cx="502920" cy="292608"/>
           </a:xfrm>
           <a:prstGeom prst="rect">
             <a:avLst/>
@@ -7709,7 +7709,7 @@
           <a:lstStyle/>
           <a:p>
             <a:pPr algn="r">
-              <a:defRPr sz="800" b="0">
+              <a:defRPr sz="1300" b="0">
                 <a:solidFill>
                   <a:srgbClr val="5C667A"/>
                 </a:solidFill>
@@ -7745,7 +7745,7 @@
           <a:lstStyle/>
           <a:p>
             <a:pPr>
-              <a:defRPr sz="1100" b="1">
+              <a:defRPr sz="1300" b="1">
                 <a:solidFill>
                   <a:srgbClr val="5C667A"/>
                 </a:solidFill>
@@ -7781,7 +7781,7 @@
           <a:lstStyle/>
           <a:p>
             <a:pPr>
-              <a:defRPr sz="1100" b="1">
+              <a:defRPr sz="1300" b="1">
                 <a:solidFill>
                   <a:srgbClr val="2563EB"/>
                 </a:solidFill>
@@ -7862,7 +7862,7 @@
           <a:lstStyle/>
           <a:p>
             <a:pPr algn="ctr">
-              <a:defRPr sz="1100" b="1">
+              <a:defRPr sz="1300" b="1">
                 <a:solidFill>
                   <a:srgbClr val="1B1F2A"/>
                 </a:solidFill>
@@ -7875,7 +7875,7 @@
           </a:p>
           <a:p>
             <a:pPr algn="ctr">
-              <a:defRPr sz="1100" b="1">
+              <a:defRPr sz="1300" b="1">
                 <a:solidFill>
                   <a:srgbClr val="1B1F2A"/>
                 </a:solidFill>
@@ -7956,7 +7956,7 @@
           <a:lstStyle/>
           <a:p>
             <a:pPr algn="ctr">
-              <a:defRPr sz="1200" b="1">
+              <a:defRPr sz="1300" b="1">
                 <a:solidFill>
                   <a:srgbClr val="1B1F2A"/>
                 </a:solidFill>
@@ -8037,7 +8037,7 @@
           <a:lstStyle/>
           <a:p>
             <a:pPr algn="ctr">
-              <a:defRPr sz="1100" b="1">
+              <a:defRPr sz="1300" b="1">
                 <a:solidFill>
                   <a:srgbClr val="1B1F2A"/>
                 </a:solidFill>
@@ -8050,7 +8050,7 @@
           </a:p>
           <a:p>
             <a:pPr algn="ctr">
-              <a:defRPr sz="1100" b="1">
+              <a:defRPr sz="1300" b="1">
                 <a:solidFill>
                   <a:srgbClr val="1B1F2A"/>
                 </a:solidFill>
@@ -8131,7 +8131,7 @@
           <a:lstStyle/>
           <a:p>
             <a:pPr algn="ctr">
-              <a:defRPr sz="1100" b="1">
+              <a:defRPr sz="1300" b="1">
                 <a:solidFill>
                   <a:srgbClr val="1B1F2A"/>
                 </a:solidFill>
@@ -8144,7 +8144,7 @@
           </a:p>
           <a:p>
             <a:pPr algn="ctr">
-              <a:defRPr sz="1100" b="1">
+              <a:defRPr sz="1300" b="1">
                 <a:solidFill>
                   <a:srgbClr val="1B1F2A"/>
                 </a:solidFill>
@@ -8225,7 +8225,7 @@
           <a:lstStyle/>
           <a:p>
             <a:pPr algn="ctr">
-              <a:defRPr sz="1100" b="1">
+              <a:defRPr sz="1300" b="1">
                 <a:solidFill>
                   <a:srgbClr val="1B1F2A"/>
                 </a:solidFill>
@@ -8238,7 +8238,7 @@
           </a:p>
           <a:p>
             <a:pPr algn="ctr">
-              <a:defRPr sz="1100" b="1">
+              <a:defRPr sz="1300" b="1">
                 <a:solidFill>
                   <a:srgbClr val="1B1F2A"/>
                 </a:solidFill>
@@ -8450,7 +8450,7 @@
           <a:lstStyle/>
           <a:p>
             <a:pPr>
-              <a:defRPr sz="850" b="1">
+              <a:defRPr sz="1300" b="1">
                 <a:solidFill>
                   <a:srgbClr val="2563EB"/>
                 </a:solidFill>
@@ -8531,7 +8531,7 @@
           <a:lstStyle/>
           <a:p>
             <a:pPr>
-              <a:defRPr sz="1050" b="1">
+              <a:defRPr sz="1300" b="1">
                 <a:solidFill>
                   <a:srgbClr val="D94A4A"/>
                 </a:solidFill>
@@ -8567,7 +8567,7 @@
           <a:lstStyle/>
           <a:p>
             <a:pPr>
-              <a:defRPr sz="1150" b="1">
+              <a:defRPr sz="1300" b="1">
                 <a:solidFill>
                   <a:srgbClr val="1B1F2A"/>
                 </a:solidFill>
@@ -8704,7 +8704,7 @@
         <p:spPr>
           <a:xfrm>
             <a:off x="5669280" y="4297680"/>
-            <a:ext cx="914400" cy="182880"/>
+            <a:ext cx="914400" cy="219456"/>
           </a:xfrm>
           <a:prstGeom prst="rect">
             <a:avLst/>
@@ -8718,7 +8718,7 @@
           <a:lstStyle/>
           <a:p>
             <a:pPr>
-              <a:defRPr sz="1050" b="1">
+              <a:defRPr sz="1300" b="1">
                 <a:solidFill>
                   <a:srgbClr val="21A67A"/>
                 </a:solidFill>
@@ -8754,7 +8754,7 @@
           <a:lstStyle/>
           <a:p>
             <a:pPr>
-              <a:defRPr sz="1250" b="1">
+              <a:defRPr sz="1300" b="1">
                 <a:solidFill>
                   <a:srgbClr val="1B1F2A"/>
                 </a:solidFill>
@@ -8775,8 +8775,8 @@
         </p:nvSpPr>
         <p:spPr>
           <a:xfrm>
-            <a:off x="5669280" y="4773168"/>
-            <a:ext cx="4590288" cy="182880"/>
+            <a:off x="5669280" y="4754880"/>
+            <a:ext cx="4590288" cy="219456"/>
           </a:xfrm>
           <a:prstGeom prst="rect">
             <a:avLst/>
@@ -8790,7 +8790,7 @@
           <a:lstStyle/>
           <a:p>
             <a:pPr>
-              <a:defRPr sz="1050" b="0">
+              <a:defRPr sz="1300" b="0">
                 <a:solidFill>
                   <a:srgbClr val="5C667A"/>
                 </a:solidFill>
@@ -8798,7 +8798,7 @@
               </a:defRPr>
             </a:pPr>
             <a:r>
-              <a:t>원본 transaction과 witness는 브릿지/Ethereum에서 실행되거나 해석되지 않는다.</a:t>
+              <a:t>원본 tx와 witness는 L1에서 실행되지 않는다.</a:t>
             </a:r>
           </a:p>
         </p:txBody>
@@ -8974,7 +8974,7 @@
           <a:lstStyle/>
           <a:p>
             <a:pPr>
-              <a:defRPr sz="1100" b="1">
+              <a:defRPr sz="1300" b="1">
                 <a:solidFill>
                   <a:srgbClr val="2563EB"/>
                 </a:solidFill>
@@ -9110,8 +9110,8 @@
         </p:nvSpPr>
         <p:spPr>
           <a:xfrm>
-            <a:off x="530352" y="6473952"/>
-            <a:ext cx="3291840" cy="164592"/>
+            <a:off x="530352" y="6419088"/>
+            <a:ext cx="4389120" cy="292608"/>
           </a:xfrm>
           <a:prstGeom prst="rect">
             <a:avLst/>
@@ -9125,7 +9125,7 @@
           <a:lstStyle/>
           <a:p>
             <a:pPr>
-              <a:defRPr sz="800" b="0">
+              <a:defRPr sz="1300" b="0">
                 <a:solidFill>
                   <a:srgbClr val="5C667A"/>
                 </a:solidFill>
@@ -9146,8 +9146,8 @@
         </p:nvSpPr>
         <p:spPr>
           <a:xfrm>
-            <a:off x="11292840" y="6473952"/>
-            <a:ext cx="320040" cy="164592"/>
+            <a:off x="11119104" y="6419088"/>
+            <a:ext cx="502920" cy="292608"/>
           </a:xfrm>
           <a:prstGeom prst="rect">
             <a:avLst/>
@@ -9161,7 +9161,7 @@
           <a:lstStyle/>
           <a:p>
             <a:pPr algn="r">
-              <a:defRPr sz="800" b="0">
+              <a:defRPr sz="1300" b="0">
                 <a:solidFill>
                   <a:srgbClr val="5C667A"/>
                 </a:solidFill>
@@ -9197,7 +9197,7 @@
           <a:lstStyle/>
           <a:p>
             <a:pPr>
-              <a:defRPr sz="1250" b="1">
+              <a:defRPr sz="1300" b="1">
                 <a:solidFill>
                   <a:srgbClr val="2563EB"/>
                 </a:solidFill>
@@ -9278,7 +9278,7 @@
           <a:lstStyle/>
           <a:p>
             <a:pPr algn="ctr">
-              <a:defRPr sz="1050" b="1">
+              <a:defRPr sz="1300" b="1">
                 <a:solidFill>
                   <a:srgbClr val="1B1F2A"/>
                 </a:solidFill>
@@ -9314,7 +9314,7 @@
           <a:lstStyle/>
           <a:p>
             <a:pPr algn="ctr">
-              <a:defRPr sz="960" b="1">
+              <a:defRPr sz="1300" b="1">
                 <a:solidFill>
                   <a:srgbClr val="5C667A"/>
                 </a:solidFill>
@@ -9327,7 +9327,7 @@
           </a:p>
           <a:p>
             <a:pPr algn="ctr">
-              <a:defRPr sz="960" b="1">
+              <a:defRPr sz="1300" b="1">
                 <a:solidFill>
                   <a:srgbClr val="5C667A"/>
                 </a:solidFill>
@@ -9443,7 +9443,7 @@
           <a:lstStyle/>
           <a:p>
             <a:pPr algn="ctr">
-              <a:defRPr sz="1050" b="1">
+              <a:defRPr sz="1300" b="1">
                 <a:solidFill>
                   <a:srgbClr val="1B1F2A"/>
                 </a:solidFill>
@@ -9479,7 +9479,7 @@
           <a:lstStyle/>
           <a:p>
             <a:pPr algn="ctr">
-              <a:defRPr sz="960" b="1">
+              <a:defRPr sz="1300" b="1">
                 <a:solidFill>
                   <a:srgbClr val="5C667A"/>
                 </a:solidFill>
@@ -9492,7 +9492,7 @@
           </a:p>
           <a:p>
             <a:pPr algn="ctr">
-              <a:defRPr sz="960" b="1">
+              <a:defRPr sz="1300" b="1">
                 <a:solidFill>
                   <a:srgbClr val="5C667A"/>
                 </a:solidFill>
@@ -9608,7 +9608,7 @@
           <a:lstStyle/>
           <a:p>
             <a:pPr algn="ctr">
-              <a:defRPr sz="1050" b="1">
+              <a:defRPr sz="1300" b="1">
                 <a:solidFill>
                   <a:srgbClr val="1B1F2A"/>
                 </a:solidFill>
@@ -9644,7 +9644,7 @@
           <a:lstStyle/>
           <a:p>
             <a:pPr algn="ctr">
-              <a:defRPr sz="960" b="1">
+              <a:defRPr sz="1300" b="1">
                 <a:solidFill>
                   <a:srgbClr val="5C667A"/>
                 </a:solidFill>
@@ -9657,7 +9657,7 @@
           </a:p>
           <a:p>
             <a:pPr algn="ctr">
-              <a:defRPr sz="960" b="1">
+              <a:defRPr sz="1300" b="1">
                 <a:solidFill>
                   <a:srgbClr val="5C667A"/>
                 </a:solidFill>
@@ -9672,88 +9672,7 @@
       </p:sp>
       <p:sp>
         <p:nvSpPr>
-          <p:cNvPr id="21" name="Rounded Rectangle 20"/>
-          <p:cNvSpPr/>
-          <p:nvPr/>
-        </p:nvSpPr>
-        <p:spPr>
-          <a:xfrm>
-            <a:off x="2697480" y="2249424"/>
-            <a:ext cx="1719072" cy="219456"/>
-          </a:xfrm>
-          <a:prstGeom prst="roundRect">
-            <a:avLst/>
-          </a:prstGeom>
-          <a:solidFill>
-            <a:srgbClr val="E9F1FF"/>
-          </a:solidFill>
-          <a:ln w="12700">
-            <a:solidFill>
-              <a:srgbClr val="2563EB"/>
-            </a:solidFill>
-          </a:ln>
-        </p:spPr>
-        <p:style>
-          <a:lnRef idx="1">
-            <a:schemeClr val="accent1"/>
-          </a:lnRef>
-          <a:fillRef idx="3">
-            <a:schemeClr val="accent1"/>
-          </a:fillRef>
-          <a:effectRef idx="2">
-            <a:schemeClr val="accent1"/>
-          </a:effectRef>
-          <a:fontRef idx="minor">
-            <a:schemeClr val="lt1"/>
-          </a:fontRef>
-        </p:style>
-        <p:txBody>
-          <a:bodyPr rtlCol="0" anchor="ctr"/>
-          <a:lstStyle/>
-          <a:p>
-            <a:pPr algn="ctr"/>
-          </a:p>
-        </p:txBody>
-      </p:sp>
-      <p:sp>
-        <p:nvSpPr>
-          <p:cNvPr id="22" name="TextBox 21"/>
-          <p:cNvSpPr txBox="1"/>
-          <p:nvPr/>
-        </p:nvSpPr>
-        <p:spPr>
-          <a:xfrm>
-            <a:off x="2761488" y="2304288"/>
-            <a:ext cx="1591056" cy="73152"/>
-          </a:xfrm>
-          <a:prstGeom prst="rect">
-            <a:avLst/>
-          </a:prstGeom>
-          <a:noFill/>
-        </p:spPr>
-        <p:txBody>
-          <a:bodyPr wrap="square" lIns="18288" rIns="18288" tIns="9144" bIns="9144" anchor="ctr">
-            <a:spAutoFit/>
-          </a:bodyPr>
-          <a:lstStyle/>
-          <a:p>
-            <a:pPr algn="ctr">
-              <a:defRPr sz="840" b="1">
-                <a:solidFill>
-                  <a:srgbClr val="2563EB"/>
-                </a:solidFill>
-                <a:latin typeface="Apple SD Gothic Neo"/>
-              </a:defRPr>
-            </a:pPr>
-            <a:r>
-              <a:t>L1 block 안의 bridge tx</a:t>
-            </a:r>
-          </a:p>
-        </p:txBody>
-      </p:sp>
-      <p:sp>
-        <p:nvSpPr>
-          <p:cNvPr id="23" name="TextBox 22"/>
+          <p:cNvPr id="21" name="TextBox 20"/>
           <p:cNvSpPr txBox="1"/>
           <p:nvPr/>
         </p:nvSpPr>
@@ -9774,7 +9693,7 @@
           <a:lstStyle/>
           <a:p>
             <a:pPr>
-              <a:defRPr sz="1250" b="1">
+              <a:defRPr sz="1300" b="1">
                 <a:solidFill>
                   <a:srgbClr val="21A67A"/>
                 </a:solidFill>
@@ -9789,7 +9708,7 @@
       </p:sp>
       <p:sp>
         <p:nvSpPr>
-          <p:cNvPr id="24" name="Rounded Rectangle 23"/>
+          <p:cNvPr id="22" name="Rounded Rectangle 21"/>
           <p:cNvSpPr/>
           <p:nvPr/>
         </p:nvSpPr>
@@ -9834,7 +9753,7 @@
       </p:sp>
       <p:sp>
         <p:nvSpPr>
-          <p:cNvPr id="25" name="TextBox 24"/>
+          <p:cNvPr id="23" name="TextBox 22"/>
           <p:cNvSpPr txBox="1"/>
           <p:nvPr/>
         </p:nvSpPr>
@@ -9855,7 +9774,7 @@
           <a:lstStyle/>
           <a:p>
             <a:pPr algn="ctr">
-              <a:defRPr sz="1030" b="1">
+              <a:defRPr sz="1300" b="1">
                 <a:solidFill>
                   <a:srgbClr val="1B1F2A"/>
                 </a:solidFill>
@@ -9870,7 +9789,7 @@
       </p:sp>
       <p:sp>
         <p:nvSpPr>
-          <p:cNvPr id="26" name="TextBox 25"/>
+          <p:cNvPr id="24" name="TextBox 23"/>
           <p:cNvSpPr txBox="1"/>
           <p:nvPr/>
         </p:nvSpPr>
@@ -9891,7 +9810,7 @@
           <a:lstStyle/>
           <a:p>
             <a:pPr algn="ctr">
-              <a:defRPr sz="919" b="1">
+              <a:defRPr sz="1300" b="1">
                 <a:solidFill>
                   <a:srgbClr val="5C667A"/>
                 </a:solidFill>
@@ -9904,7 +9823,7 @@
           </a:p>
           <a:p>
             <a:pPr algn="ctr">
-              <a:defRPr sz="919" b="1">
+              <a:defRPr sz="1300" b="1">
                 <a:solidFill>
                   <a:srgbClr val="5C667A"/>
                 </a:solidFill>
@@ -9919,7 +9838,7 @@
       </p:sp>
       <p:cxnSp>
         <p:nvCxnSpPr>
-          <p:cNvPr id="27" name="Connector 26"/>
+          <p:cNvPr id="25" name="Connector 24"/>
           <p:cNvCxnSpPr/>
           <p:nvPr/>
         </p:nvCxnSpPr>
@@ -9954,7 +9873,7 @@
       </p:cxnSp>
       <p:sp>
         <p:nvSpPr>
-          <p:cNvPr id="28" name="Rounded Rectangle 27"/>
+          <p:cNvPr id="26" name="Rounded Rectangle 25"/>
           <p:cNvSpPr/>
           <p:nvPr/>
         </p:nvSpPr>
@@ -9999,7 +9918,7 @@
       </p:sp>
       <p:sp>
         <p:nvSpPr>
-          <p:cNvPr id="29" name="TextBox 28"/>
+          <p:cNvPr id="27" name="TextBox 26"/>
           <p:cNvSpPr txBox="1"/>
           <p:nvPr/>
         </p:nvSpPr>
@@ -10020,7 +9939,7 @@
           <a:lstStyle/>
           <a:p>
             <a:pPr algn="ctr">
-              <a:defRPr sz="1030" b="1">
+              <a:defRPr sz="1300" b="1">
                 <a:solidFill>
                   <a:srgbClr val="1B1F2A"/>
                 </a:solidFill>
@@ -10035,7 +9954,7 @@
       </p:sp>
       <p:sp>
         <p:nvSpPr>
-          <p:cNvPr id="30" name="TextBox 29"/>
+          <p:cNvPr id="28" name="TextBox 27"/>
           <p:cNvSpPr txBox="1"/>
           <p:nvPr/>
         </p:nvSpPr>
@@ -10056,7 +9975,7 @@
           <a:lstStyle/>
           <a:p>
             <a:pPr algn="ctr">
-              <a:defRPr sz="860" b="1">
+              <a:defRPr sz="1300" b="1">
                 <a:solidFill>
                   <a:srgbClr val="5C667A"/>
                 </a:solidFill>
@@ -10069,7 +9988,7 @@
           </a:p>
           <a:p>
             <a:pPr algn="ctr">
-              <a:defRPr sz="860" b="1">
+              <a:defRPr sz="1300" b="1">
                 <a:solidFill>
                   <a:srgbClr val="5C667A"/>
                 </a:solidFill>
@@ -10082,7 +10001,7 @@
           </a:p>
           <a:p>
             <a:pPr algn="ctr">
-              <a:defRPr sz="860" b="1">
+              <a:defRPr sz="1300" b="1">
                 <a:solidFill>
                   <a:srgbClr val="5C667A"/>
                 </a:solidFill>
@@ -10097,7 +10016,7 @@
       </p:sp>
       <p:cxnSp>
         <p:nvCxnSpPr>
-          <p:cNvPr id="31" name="Connector 30"/>
+          <p:cNvPr id="29" name="Connector 28"/>
           <p:cNvCxnSpPr/>
           <p:nvPr/>
         </p:nvCxnSpPr>
@@ -10132,7 +10051,7 @@
       </p:cxnSp>
       <p:sp>
         <p:nvSpPr>
-          <p:cNvPr id="32" name="Rounded Rectangle 31"/>
+          <p:cNvPr id="30" name="Rounded Rectangle 29"/>
           <p:cNvSpPr/>
           <p:nvPr/>
         </p:nvSpPr>
@@ -10177,7 +10096,7 @@
       </p:sp>
       <p:sp>
         <p:nvSpPr>
-          <p:cNvPr id="33" name="TextBox 32"/>
+          <p:cNvPr id="31" name="TextBox 30"/>
           <p:cNvSpPr txBox="1"/>
           <p:nvPr/>
         </p:nvSpPr>
@@ -10198,7 +10117,7 @@
           <a:lstStyle/>
           <a:p>
             <a:pPr algn="ctr">
-              <a:defRPr sz="1030" b="1">
+              <a:defRPr sz="1300" b="1">
                 <a:solidFill>
                   <a:srgbClr val="1B1F2A"/>
                 </a:solidFill>
@@ -10213,7 +10132,7 @@
       </p:sp>
       <p:sp>
         <p:nvSpPr>
-          <p:cNvPr id="34" name="TextBox 33"/>
+          <p:cNvPr id="32" name="TextBox 31"/>
           <p:cNvSpPr txBox="1"/>
           <p:nvPr/>
         </p:nvSpPr>
@@ -10234,7 +10153,7 @@
           <a:lstStyle/>
           <a:p>
             <a:pPr algn="ctr">
-              <a:defRPr sz="919" b="1">
+              <a:defRPr sz="1300" b="1">
                 <a:solidFill>
                   <a:srgbClr val="5C667A"/>
                 </a:solidFill>
@@ -10247,7 +10166,7 @@
           </a:p>
           <a:p>
             <a:pPr algn="ctr">
-              <a:defRPr sz="919" b="1">
+              <a:defRPr sz="1300" b="1">
                 <a:solidFill>
                   <a:srgbClr val="5C667A"/>
                 </a:solidFill>
@@ -10262,7 +10181,7 @@
       </p:sp>
       <p:cxnSp>
         <p:nvCxnSpPr>
-          <p:cNvPr id="35" name="Connector 34"/>
+          <p:cNvPr id="33" name="Connector 32"/>
           <p:cNvCxnSpPr/>
           <p:nvPr/>
         </p:nvCxnSpPr>
@@ -10297,7 +10216,7 @@
       </p:cxnSp>
       <p:sp>
         <p:nvSpPr>
-          <p:cNvPr id="36" name="Rounded Rectangle 35"/>
+          <p:cNvPr id="34" name="Rounded Rectangle 33"/>
           <p:cNvSpPr/>
           <p:nvPr/>
         </p:nvSpPr>
@@ -10342,14 +10261,14 @@
       </p:sp>
       <p:sp>
         <p:nvSpPr>
-          <p:cNvPr id="37" name="TextBox 36"/>
-          <p:cNvSpPr txBox="1"/>
-          <p:nvPr/>
-        </p:nvSpPr>
-        <p:spPr>
-          <a:xfrm>
-            <a:off x="4114800" y="3383280"/>
-            <a:ext cx="1847088" cy="164592"/>
+          <p:cNvPr id="35" name="TextBox 34"/>
+          <p:cNvSpPr txBox="1"/>
+          <p:nvPr/>
+        </p:nvSpPr>
+        <p:spPr>
+          <a:xfrm>
+            <a:off x="4114800" y="3346704"/>
+            <a:ext cx="1847088" cy="237744"/>
           </a:xfrm>
           <a:prstGeom prst="rect">
             <a:avLst/>
@@ -10363,7 +10282,7 @@
           <a:lstStyle/>
           <a:p>
             <a:pPr algn="ctr">
-              <a:defRPr sz="960" b="1">
+              <a:defRPr sz="1300" b="1">
                 <a:solidFill>
                   <a:srgbClr val="1B1F2A"/>
                 </a:solidFill>
@@ -10371,12 +10290,12 @@
               </a:defRPr>
             </a:pPr>
             <a:r>
-              <a:t>L2 block proof + 공개 데이터가</a:t>
+              <a:t>bridge tx carries</a:t>
             </a:r>
           </a:p>
           <a:p>
             <a:pPr algn="ctr">
-              <a:defRPr sz="960" b="1">
+              <a:defRPr sz="1300" b="1">
                 <a:solidFill>
                   <a:srgbClr val="1B1F2A"/>
                 </a:solidFill>
@@ -10384,14 +10303,14 @@
               </a:defRPr>
             </a:pPr>
             <a:r>
-              <a:t>bridge tx에 담긴다</a:t>
-            </a:r>
-          </a:p>
-        </p:txBody>
-      </p:sp>
-      <p:sp>
-        <p:nvSpPr>
-          <p:cNvPr id="38" name="Rounded Rectangle 37"/>
+              <a:t>L2 proof + public data</a:t>
+            </a:r>
+          </a:p>
+        </p:txBody>
+      </p:sp>
+      <p:sp>
+        <p:nvSpPr>
+          <p:cNvPr id="36" name="Rounded Rectangle 35"/>
           <p:cNvSpPr/>
           <p:nvPr/>
         </p:nvSpPr>
@@ -10436,7 +10355,7 @@
       </p:sp>
       <p:sp>
         <p:nvSpPr>
-          <p:cNvPr id="39" name="TextBox 38"/>
+          <p:cNvPr id="37" name="TextBox 36"/>
           <p:cNvSpPr txBox="1"/>
           <p:nvPr/>
         </p:nvSpPr>
@@ -10472,7 +10391,7 @@
       </p:sp>
       <p:sp>
         <p:nvSpPr>
-          <p:cNvPr id="40" name="Oval 39"/>
+          <p:cNvPr id="38" name="Oval 37"/>
           <p:cNvSpPr/>
           <p:nvPr/>
         </p:nvSpPr>
@@ -10515,7 +10434,7 @@
       </p:sp>
       <p:sp>
         <p:nvSpPr>
-          <p:cNvPr id="41" name="TextBox 40"/>
+          <p:cNvPr id="39" name="TextBox 38"/>
           <p:cNvSpPr txBox="1"/>
           <p:nvPr/>
         </p:nvSpPr>
@@ -10536,7 +10455,7 @@
           <a:lstStyle/>
           <a:p>
             <a:pPr>
-              <a:defRPr sz="1080" b="0">
+              <a:defRPr sz="1300" b="0">
                 <a:solidFill>
                   <a:srgbClr val="1B1F2A"/>
                 </a:solidFill>
@@ -10551,7 +10470,7 @@
       </p:sp>
       <p:sp>
         <p:nvSpPr>
-          <p:cNvPr id="42" name="Oval 41"/>
+          <p:cNvPr id="40" name="Oval 39"/>
           <p:cNvSpPr/>
           <p:nvPr/>
         </p:nvSpPr>
@@ -10594,7 +10513,7 @@
       </p:sp>
       <p:sp>
         <p:nvSpPr>
-          <p:cNvPr id="43" name="TextBox 42"/>
+          <p:cNvPr id="41" name="TextBox 40"/>
           <p:cNvSpPr txBox="1"/>
           <p:nvPr/>
         </p:nvSpPr>
@@ -10615,7 +10534,7 @@
           <a:lstStyle/>
           <a:p>
             <a:pPr>
-              <a:defRPr sz="1080" b="0">
+              <a:defRPr sz="1300" b="0">
                 <a:solidFill>
                   <a:srgbClr val="1B1F2A"/>
                 </a:solidFill>
@@ -10630,7 +10549,7 @@
       </p:sp>
       <p:sp>
         <p:nvSpPr>
-          <p:cNvPr id="44" name="Rounded Rectangle 43"/>
+          <p:cNvPr id="42" name="Rounded Rectangle 41"/>
           <p:cNvSpPr/>
           <p:nvPr/>
         </p:nvSpPr>
@@ -10675,14 +10594,14 @@
       </p:sp>
       <p:sp>
         <p:nvSpPr>
-          <p:cNvPr id="45" name="TextBox 44"/>
+          <p:cNvPr id="43" name="TextBox 42"/>
           <p:cNvSpPr txBox="1"/>
           <p:nvPr/>
         </p:nvSpPr>
         <p:spPr>
           <a:xfrm>
             <a:off x="7059168" y="3931920"/>
-            <a:ext cx="2103120" cy="164592"/>
+            <a:ext cx="2103120" cy="219456"/>
           </a:xfrm>
           <a:prstGeom prst="rect">
             <a:avLst/>
@@ -10696,7 +10615,7 @@
           <a:lstStyle/>
           <a:p>
             <a:pPr>
-              <a:defRPr sz="1120" b="1">
+              <a:defRPr sz="1300" b="1">
                 <a:solidFill>
                   <a:srgbClr val="5C667A"/>
                 </a:solidFill>
@@ -10711,7 +10630,7 @@
       </p:sp>
       <p:sp>
         <p:nvSpPr>
-          <p:cNvPr id="46" name="TextBox 45"/>
+          <p:cNvPr id="44" name="TextBox 43"/>
           <p:cNvSpPr txBox="1"/>
           <p:nvPr/>
         </p:nvSpPr>
@@ -10732,7 +10651,7 @@
           <a:lstStyle/>
           <a:p>
             <a:pPr>
-              <a:defRPr sz="1250" b="1">
+              <a:defRPr sz="1300" b="1">
                 <a:solidFill>
                   <a:srgbClr val="354052"/>
                 </a:solidFill>
@@ -10747,14 +10666,14 @@
       </p:sp>
       <p:sp>
         <p:nvSpPr>
-          <p:cNvPr id="47" name="Rounded Rectangle 46"/>
+          <p:cNvPr id="45" name="Rounded Rectangle 44"/>
           <p:cNvSpPr/>
           <p:nvPr/>
         </p:nvSpPr>
         <p:spPr>
           <a:xfrm>
-            <a:off x="7114032" y="4462272"/>
-            <a:ext cx="950976" cy="219456"/>
+            <a:off x="7040880" y="4443984"/>
+            <a:ext cx="1078992" cy="329184"/>
           </a:xfrm>
           <a:prstGeom prst="roundRect">
             <a:avLst/>
@@ -10792,14 +10711,14 @@
       </p:sp>
       <p:sp>
         <p:nvSpPr>
-          <p:cNvPr id="48" name="TextBox 47"/>
-          <p:cNvSpPr txBox="1"/>
-          <p:nvPr/>
-        </p:nvSpPr>
-        <p:spPr>
-          <a:xfrm>
-            <a:off x="7168896" y="4517136"/>
-            <a:ext cx="841248" cy="73152"/>
+          <p:cNvPr id="46" name="TextBox 45"/>
+          <p:cNvSpPr txBox="1"/>
+          <p:nvPr/>
+        </p:nvSpPr>
+        <p:spPr>
+          <a:xfrm>
+            <a:off x="7095744" y="4535424"/>
+            <a:ext cx="969264" cy="109728"/>
           </a:xfrm>
           <a:prstGeom prst="rect">
             <a:avLst/>
@@ -10813,7 +10732,7 @@
           <a:lstStyle/>
           <a:p>
             <a:pPr algn="ctr">
-              <a:defRPr sz="760" b="1">
+              <a:defRPr sz="1300" b="1">
                 <a:solidFill>
                   <a:srgbClr val="354052"/>
                 </a:solidFill>
@@ -10828,14 +10747,14 @@
       </p:sp>
       <p:sp>
         <p:nvSpPr>
-          <p:cNvPr id="49" name="Rounded Rectangle 48"/>
+          <p:cNvPr id="47" name="Rounded Rectangle 46"/>
           <p:cNvSpPr/>
           <p:nvPr/>
         </p:nvSpPr>
         <p:spPr>
           <a:xfrm>
-            <a:off x="8247888" y="4462272"/>
-            <a:ext cx="950976" cy="219456"/>
+            <a:off x="8275320" y="4443984"/>
+            <a:ext cx="1078992" cy="329184"/>
           </a:xfrm>
           <a:prstGeom prst="roundRect">
             <a:avLst/>
@@ -10873,14 +10792,14 @@
       </p:sp>
       <p:sp>
         <p:nvSpPr>
-          <p:cNvPr id="50" name="TextBox 49"/>
-          <p:cNvSpPr txBox="1"/>
-          <p:nvPr/>
-        </p:nvSpPr>
-        <p:spPr>
-          <a:xfrm>
-            <a:off x="8302752" y="4517136"/>
-            <a:ext cx="841248" cy="73152"/>
+          <p:cNvPr id="48" name="TextBox 47"/>
+          <p:cNvSpPr txBox="1"/>
+          <p:nvPr/>
+        </p:nvSpPr>
+        <p:spPr>
+          <a:xfrm>
+            <a:off x="8330183" y="4535424"/>
+            <a:ext cx="969264" cy="109728"/>
           </a:xfrm>
           <a:prstGeom prst="rect">
             <a:avLst/>
@@ -10894,7 +10813,7 @@
           <a:lstStyle/>
           <a:p>
             <a:pPr algn="ctr">
-              <a:defRPr sz="760" b="1">
+              <a:defRPr sz="1300" b="1">
                 <a:solidFill>
                   <a:srgbClr val="354052"/>
                 </a:solidFill>
@@ -10909,14 +10828,14 @@
       </p:sp>
       <p:sp>
         <p:nvSpPr>
-          <p:cNvPr id="51" name="Rounded Rectangle 50"/>
+          <p:cNvPr id="49" name="Rounded Rectangle 48"/>
           <p:cNvSpPr/>
           <p:nvPr/>
         </p:nvSpPr>
         <p:spPr>
           <a:xfrm>
-            <a:off x="9381744" y="4462272"/>
-            <a:ext cx="950976" cy="219456"/>
+            <a:off x="9509760" y="4443984"/>
+            <a:ext cx="1078992" cy="329184"/>
           </a:xfrm>
           <a:prstGeom prst="roundRect">
             <a:avLst/>
@@ -10954,14 +10873,14 @@
       </p:sp>
       <p:sp>
         <p:nvSpPr>
-          <p:cNvPr id="52" name="TextBox 51"/>
-          <p:cNvSpPr txBox="1"/>
-          <p:nvPr/>
-        </p:nvSpPr>
-        <p:spPr>
-          <a:xfrm>
-            <a:off x="9436608" y="4517136"/>
-            <a:ext cx="841248" cy="73152"/>
+          <p:cNvPr id="50" name="TextBox 49"/>
+          <p:cNvSpPr txBox="1"/>
+          <p:nvPr/>
+        </p:nvSpPr>
+        <p:spPr>
+          <a:xfrm>
+            <a:off x="9564624" y="4535424"/>
+            <a:ext cx="969264" cy="109728"/>
           </a:xfrm>
           <a:prstGeom prst="rect">
             <a:avLst/>
@@ -10975,7 +10894,7 @@
           <a:lstStyle/>
           <a:p>
             <a:pPr algn="ctr">
-              <a:defRPr sz="760" b="1">
+              <a:defRPr sz="1300" b="1">
                 <a:solidFill>
                   <a:srgbClr val="354052"/>
                 </a:solidFill>
@@ -10990,7 +10909,7 @@
       </p:sp>
       <p:sp>
         <p:nvSpPr>
-          <p:cNvPr id="53" name="Rounded Rectangle 52"/>
+          <p:cNvPr id="51" name="Rounded Rectangle 50"/>
           <p:cNvSpPr/>
           <p:nvPr/>
         </p:nvSpPr>
@@ -11033,7 +10952,7 @@
       </p:sp>
       <p:sp>
         <p:nvSpPr>
-          <p:cNvPr id="54" name="TextBox 53"/>
+          <p:cNvPr id="52" name="TextBox 51"/>
           <p:cNvSpPr txBox="1"/>
           <p:nvPr/>
         </p:nvSpPr>
@@ -11054,7 +10973,7 @@
           <a:lstStyle/>
           <a:p>
             <a:pPr algn="ctr">
-              <a:defRPr sz="1260" b="1">
+              <a:defRPr sz="1300" b="1">
                 <a:solidFill>
                   <a:srgbClr val="FFFFFF"/>
                 </a:solidFill>
@@ -11159,7 +11078,7 @@
           <a:lstStyle/>
           <a:p>
             <a:pPr>
-              <a:defRPr sz="1100" b="1">
+              <a:defRPr sz="1300" b="1">
                 <a:solidFill>
                   <a:srgbClr val="2563EB"/>
                 </a:solidFill>
@@ -11295,8 +11214,8 @@
         </p:nvSpPr>
         <p:spPr>
           <a:xfrm>
-            <a:off x="530352" y="6473952"/>
-            <a:ext cx="3291840" cy="164592"/>
+            <a:off x="530352" y="6419088"/>
+            <a:ext cx="4389120" cy="292608"/>
           </a:xfrm>
           <a:prstGeom prst="rect">
             <a:avLst/>
@@ -11310,7 +11229,7 @@
           <a:lstStyle/>
           <a:p>
             <a:pPr>
-              <a:defRPr sz="800" b="0">
+              <a:defRPr sz="1300" b="0">
                 <a:solidFill>
                   <a:srgbClr val="5C667A"/>
                 </a:solidFill>
@@ -11331,8 +11250,8 @@
         </p:nvSpPr>
         <p:spPr>
           <a:xfrm>
-            <a:off x="11292840" y="6473952"/>
-            <a:ext cx="320040" cy="164592"/>
+            <a:off x="11119104" y="6419088"/>
+            <a:ext cx="502920" cy="292608"/>
           </a:xfrm>
           <a:prstGeom prst="rect">
             <a:avLst/>
@@ -11346,7 +11265,7 @@
           <a:lstStyle/>
           <a:p>
             <a:pPr algn="r">
-              <a:defRPr sz="800" b="0">
+              <a:defRPr sz="1300" b="0">
                 <a:solidFill>
                   <a:srgbClr val="5C667A"/>
                 </a:solidFill>
@@ -11506,7 +11425,7 @@
           <a:lstStyle/>
           <a:p>
             <a:pPr>
-              <a:defRPr sz="1180" b="0">
+              <a:defRPr sz="1300" b="0">
                 <a:solidFill>
                   <a:srgbClr val="1B1F2A"/>
                 </a:solidFill>
@@ -11585,7 +11504,7 @@
           <a:lstStyle/>
           <a:p>
             <a:pPr>
-              <a:defRPr sz="1180" b="0">
+              <a:defRPr sz="1300" b="0">
                 <a:solidFill>
                   <a:srgbClr val="1B1F2A"/>
                 </a:solidFill>
@@ -11664,7 +11583,7 @@
           <a:lstStyle/>
           <a:p>
             <a:pPr>
-              <a:defRPr sz="1180" b="0">
+              <a:defRPr sz="1300" b="0">
                 <a:solidFill>
                   <a:srgbClr val="1B1F2A"/>
                 </a:solidFill>
@@ -11824,7 +11743,7 @@
           <a:lstStyle/>
           <a:p>
             <a:pPr>
-              <a:defRPr sz="1180" b="0">
+              <a:defRPr sz="1300" b="0">
                 <a:solidFill>
                   <a:srgbClr val="1B1F2A"/>
                 </a:solidFill>
@@ -11903,7 +11822,7 @@
           <a:lstStyle/>
           <a:p>
             <a:pPr>
-              <a:defRPr sz="1180" b="0">
+              <a:defRPr sz="1300" b="0">
                 <a:solidFill>
                   <a:srgbClr val="1B1F2A"/>
                 </a:solidFill>
@@ -11982,7 +11901,7 @@
           <a:lstStyle/>
           <a:p>
             <a:pPr>
-              <a:defRPr sz="1180" b="0">
+              <a:defRPr sz="1300" b="0">
                 <a:solidFill>
                   <a:srgbClr val="1B1F2A"/>
                 </a:solidFill>
@@ -12142,7 +12061,7 @@
           <a:lstStyle/>
           <a:p>
             <a:pPr>
-              <a:defRPr sz="1180" b="0">
+              <a:defRPr sz="1300" b="0">
                 <a:solidFill>
                   <a:srgbClr val="1B1F2A"/>
                 </a:solidFill>
@@ -12221,7 +12140,7 @@
           <a:lstStyle/>
           <a:p>
             <a:pPr>
-              <a:defRPr sz="1180" b="0">
+              <a:defRPr sz="1300" b="0">
                 <a:solidFill>
                   <a:srgbClr val="1B1F2A"/>
                 </a:solidFill>
@@ -12300,7 +12219,7 @@
           <a:lstStyle/>
           <a:p>
             <a:pPr>
-              <a:defRPr sz="1180" b="0">
+              <a:defRPr sz="1300" b="0">
                 <a:solidFill>
                   <a:srgbClr val="1B1F2A"/>
                 </a:solidFill>
@@ -12556,7 +12475,7 @@
           <a:lstStyle/>
           <a:p>
             <a:pPr>
-              <a:defRPr sz="1100" b="1">
+              <a:defRPr sz="1300" b="1">
                 <a:solidFill>
                   <a:srgbClr val="2563EB"/>
                 </a:solidFill>
@@ -12692,8 +12611,8 @@
         </p:nvSpPr>
         <p:spPr>
           <a:xfrm>
-            <a:off x="530352" y="6473952"/>
-            <a:ext cx="3291840" cy="164592"/>
+            <a:off x="530352" y="6419088"/>
+            <a:ext cx="4389120" cy="292608"/>
           </a:xfrm>
           <a:prstGeom prst="rect">
             <a:avLst/>
@@ -12707,7 +12626,7 @@
           <a:lstStyle/>
           <a:p>
             <a:pPr>
-              <a:defRPr sz="800" b="0">
+              <a:defRPr sz="1300" b="0">
                 <a:solidFill>
                   <a:srgbClr val="5C667A"/>
                 </a:solidFill>
@@ -12728,8 +12647,8 @@
         </p:nvSpPr>
         <p:spPr>
           <a:xfrm>
-            <a:off x="11292840" y="6473952"/>
-            <a:ext cx="320040" cy="164592"/>
+            <a:off x="11119104" y="6419088"/>
+            <a:ext cx="502920" cy="292608"/>
           </a:xfrm>
           <a:prstGeom prst="rect">
             <a:avLst/>
@@ -12743,7 +12662,7 @@
           <a:lstStyle/>
           <a:p>
             <a:pPr algn="r">
-              <a:defRPr sz="800" b="0">
+              <a:defRPr sz="1300" b="0">
                 <a:solidFill>
                   <a:srgbClr val="5C667A"/>
                 </a:solidFill>
@@ -12903,7 +12822,7 @@
           <a:lstStyle/>
           <a:p>
             <a:pPr>
-              <a:defRPr sz="1250" b="0">
+              <a:defRPr sz="1300" b="0">
                 <a:solidFill>
                   <a:srgbClr val="1B1F2A"/>
                 </a:solidFill>
@@ -12982,7 +12901,7 @@
           <a:lstStyle/>
           <a:p>
             <a:pPr>
-              <a:defRPr sz="1250" b="0">
+              <a:defRPr sz="1300" b="0">
                 <a:solidFill>
                   <a:srgbClr val="1B1F2A"/>
                 </a:solidFill>
@@ -13061,7 +12980,7 @@
           <a:lstStyle/>
           <a:p>
             <a:pPr>
-              <a:defRPr sz="1250" b="0">
+              <a:defRPr sz="1300" b="0">
                 <a:solidFill>
                   <a:srgbClr val="1B1F2A"/>
                 </a:solidFill>
@@ -13221,7 +13140,7 @@
           <a:lstStyle/>
           <a:p>
             <a:pPr>
-              <a:defRPr sz="1250" b="0">
+              <a:defRPr sz="1300" b="0">
                 <a:solidFill>
                   <a:srgbClr val="1B1F2A"/>
                 </a:solidFill>
@@ -13300,7 +13219,7 @@
           <a:lstStyle/>
           <a:p>
             <a:pPr>
-              <a:defRPr sz="1250" b="0">
+              <a:defRPr sz="1300" b="0">
                 <a:solidFill>
                   <a:srgbClr val="1B1F2A"/>
                 </a:solidFill>
@@ -13379,7 +13298,7 @@
           <a:lstStyle/>
           <a:p>
             <a:pPr>
-              <a:defRPr sz="1250" b="0">
+              <a:defRPr sz="1300" b="0">
                 <a:solidFill>
                   <a:srgbClr val="1B1F2A"/>
                 </a:solidFill>
@@ -13458,7 +13377,7 @@
           <a:lstStyle/>
           <a:p>
             <a:pPr>
-              <a:defRPr sz="1250" b="0">
+              <a:defRPr sz="1300" b="0">
                 <a:solidFill>
                   <a:srgbClr val="1B1F2A"/>
                 </a:solidFill>
@@ -13618,7 +13537,7 @@
           <a:lstStyle/>
           <a:p>
             <a:pPr>
-              <a:defRPr sz="1250" b="0">
+              <a:defRPr sz="1300" b="0">
                 <a:solidFill>
                   <a:srgbClr val="1B1F2A"/>
                 </a:solidFill>
@@ -13697,7 +13616,7 @@
           <a:lstStyle/>
           <a:p>
             <a:pPr>
-              <a:defRPr sz="1250" b="0">
+              <a:defRPr sz="1300" b="0">
                 <a:solidFill>
                   <a:srgbClr val="1B1F2A"/>
                 </a:solidFill>
@@ -13776,7 +13695,7 @@
           <a:lstStyle/>
           <a:p>
             <a:pPr>
-              <a:defRPr sz="1250" b="0">
+              <a:defRPr sz="1300" b="0">
                 <a:solidFill>
                   <a:srgbClr val="1B1F2A"/>
                 </a:solidFill>
@@ -13855,7 +13774,7 @@
           <a:lstStyle/>
           <a:p>
             <a:pPr algn="ctr">
-              <a:defRPr sz="1250" b="1">
+              <a:defRPr sz="1300" b="1">
                 <a:solidFill>
                   <a:srgbClr val="FFFFFF"/>
                 </a:solidFill>
@@ -13960,7 +13879,7 @@
           <a:lstStyle/>
           <a:p>
             <a:pPr>
-              <a:defRPr sz="1100" b="1">
+              <a:defRPr sz="1300" b="1">
                 <a:solidFill>
                   <a:srgbClr val="2563EB"/>
                 </a:solidFill>
@@ -14096,8 +14015,8 @@
         </p:nvSpPr>
         <p:spPr>
           <a:xfrm>
-            <a:off x="530352" y="6473952"/>
-            <a:ext cx="3291840" cy="164592"/>
+            <a:off x="530352" y="6419088"/>
+            <a:ext cx="4389120" cy="292608"/>
           </a:xfrm>
           <a:prstGeom prst="rect">
             <a:avLst/>
@@ -14111,7 +14030,7 @@
           <a:lstStyle/>
           <a:p>
             <a:pPr>
-              <a:defRPr sz="800" b="0">
+              <a:defRPr sz="1300" b="0">
                 <a:solidFill>
                   <a:srgbClr val="5C667A"/>
                 </a:solidFill>
@@ -14132,8 +14051,8 @@
         </p:nvSpPr>
         <p:spPr>
           <a:xfrm>
-            <a:off x="11292840" y="6473952"/>
-            <a:ext cx="320040" cy="164592"/>
+            <a:off x="11119104" y="6419088"/>
+            <a:ext cx="502920" cy="292608"/>
           </a:xfrm>
           <a:prstGeom prst="rect">
             <a:avLst/>
@@ -14147,7 +14066,7 @@
           <a:lstStyle/>
           <a:p>
             <a:pPr algn="r">
-              <a:defRPr sz="800" b="0">
+              <a:defRPr sz="1300" b="0">
                 <a:solidFill>
                   <a:srgbClr val="5C667A"/>
                 </a:solidFill>
@@ -14307,7 +14226,7 @@
           <a:lstStyle/>
           <a:p>
             <a:pPr>
-              <a:defRPr sz="1250" b="0">
+              <a:defRPr sz="1300" b="0">
                 <a:solidFill>
                   <a:srgbClr val="1B1F2A"/>
                 </a:solidFill>
@@ -14386,7 +14305,7 @@
           <a:lstStyle/>
           <a:p>
             <a:pPr>
-              <a:defRPr sz="1250" b="0">
+              <a:defRPr sz="1300" b="0">
                 <a:solidFill>
                   <a:srgbClr val="1B1F2A"/>
                 </a:solidFill>
@@ -14465,7 +14384,7 @@
           <a:lstStyle/>
           <a:p>
             <a:pPr>
-              <a:defRPr sz="1250" b="0">
+              <a:defRPr sz="1300" b="0">
                 <a:solidFill>
                   <a:srgbClr val="1B1F2A"/>
                 </a:solidFill>
@@ -14625,7 +14544,7 @@
           <a:lstStyle/>
           <a:p>
             <a:pPr>
-              <a:defRPr sz="1250" b="0">
+              <a:defRPr sz="1300" b="0">
                 <a:solidFill>
                   <a:srgbClr val="1B1F2A"/>
                 </a:solidFill>
@@ -14704,7 +14623,7 @@
           <a:lstStyle/>
           <a:p>
             <a:pPr>
-              <a:defRPr sz="1250" b="0">
+              <a:defRPr sz="1300" b="0">
                 <a:solidFill>
                   <a:srgbClr val="1B1F2A"/>
                 </a:solidFill>
@@ -14783,7 +14702,7 @@
           <a:lstStyle/>
           <a:p>
             <a:pPr>
-              <a:defRPr sz="1250" b="0">
+              <a:defRPr sz="1300" b="0">
                 <a:solidFill>
                   <a:srgbClr val="1B1F2A"/>
                 </a:solidFill>
@@ -14862,7 +14781,7 @@
           <a:lstStyle/>
           <a:p>
             <a:pPr>
-              <a:defRPr sz="1250" b="0">
+              <a:defRPr sz="1300" b="0">
                 <a:solidFill>
                   <a:srgbClr val="1B1F2A"/>
                 </a:solidFill>
@@ -15022,7 +14941,7 @@
           <a:lstStyle/>
           <a:p>
             <a:pPr>
-              <a:defRPr sz="1250" b="0">
+              <a:defRPr sz="1300" b="0">
                 <a:solidFill>
                   <a:srgbClr val="1B1F2A"/>
                 </a:solidFill>
@@ -15101,7 +15020,7 @@
           <a:lstStyle/>
           <a:p>
             <a:pPr>
-              <a:defRPr sz="1250" b="0">
+              <a:defRPr sz="1300" b="0">
                 <a:solidFill>
                   <a:srgbClr val="1B1F2A"/>
                 </a:solidFill>
@@ -15180,7 +15099,7 @@
           <a:lstStyle/>
           <a:p>
             <a:pPr>
-              <a:defRPr sz="1250" b="0">
+              <a:defRPr sz="1300" b="0">
                 <a:solidFill>
                   <a:srgbClr val="1B1F2A"/>
                 </a:solidFill>
@@ -15259,7 +15178,7 @@
           <a:lstStyle/>
           <a:p>
             <a:pPr algn="ctr">
-              <a:defRPr sz="1250" b="1">
+              <a:defRPr sz="1300" b="1">
                 <a:solidFill>
                   <a:srgbClr val="FFFFFF"/>
                 </a:solidFill>
@@ -15364,7 +15283,7 @@
           <a:lstStyle/>
           <a:p>
             <a:pPr>
-              <a:defRPr sz="1100" b="1">
+              <a:defRPr sz="1300" b="1">
                 <a:solidFill>
                   <a:srgbClr val="2563EB"/>
                 </a:solidFill>
@@ -15500,8 +15419,8 @@
         </p:nvSpPr>
         <p:spPr>
           <a:xfrm>
-            <a:off x="530352" y="6473952"/>
-            <a:ext cx="3291840" cy="164592"/>
+            <a:off x="530352" y="6419088"/>
+            <a:ext cx="4389120" cy="292608"/>
           </a:xfrm>
           <a:prstGeom prst="rect">
             <a:avLst/>
@@ -15515,7 +15434,7 @@
           <a:lstStyle/>
           <a:p>
             <a:pPr>
-              <a:defRPr sz="800" b="0">
+              <a:defRPr sz="1300" b="0">
                 <a:solidFill>
                   <a:srgbClr val="5C667A"/>
                 </a:solidFill>
@@ -15536,8 +15455,8 @@
         </p:nvSpPr>
         <p:spPr>
           <a:xfrm>
-            <a:off x="11292840" y="6473952"/>
-            <a:ext cx="320040" cy="164592"/>
+            <a:off x="11119104" y="6419088"/>
+            <a:ext cx="502920" cy="292608"/>
           </a:xfrm>
           <a:prstGeom prst="rect">
             <a:avLst/>
@@ -15551,7 +15470,7 @@
           <a:lstStyle/>
           <a:p>
             <a:pPr algn="r">
-              <a:defRPr sz="800" b="0">
+              <a:defRPr sz="1300" b="0">
                 <a:solidFill>
                   <a:srgbClr val="5C667A"/>
                 </a:solidFill>
@@ -15711,7 +15630,7 @@
           <a:lstStyle/>
           <a:p>
             <a:pPr>
-              <a:defRPr sz="1220" b="0">
+              <a:defRPr sz="1300" b="0">
                 <a:solidFill>
                   <a:srgbClr val="1B1F2A"/>
                 </a:solidFill>
@@ -15790,7 +15709,7 @@
           <a:lstStyle/>
           <a:p>
             <a:pPr>
-              <a:defRPr sz="1220" b="0">
+              <a:defRPr sz="1300" b="0">
                 <a:solidFill>
                   <a:srgbClr val="1B1F2A"/>
                 </a:solidFill>
@@ -15869,7 +15788,7 @@
           <a:lstStyle/>
           <a:p>
             <a:pPr>
-              <a:defRPr sz="1220" b="0">
+              <a:defRPr sz="1300" b="0">
                 <a:solidFill>
                   <a:srgbClr val="1B1F2A"/>
                 </a:solidFill>
@@ -15948,7 +15867,7 @@
           <a:lstStyle/>
           <a:p>
             <a:pPr>
-              <a:defRPr sz="1220" b="0">
+              <a:defRPr sz="1300" b="0">
                 <a:solidFill>
                   <a:srgbClr val="1B1F2A"/>
                 </a:solidFill>
@@ -16108,7 +16027,7 @@
           <a:lstStyle/>
           <a:p>
             <a:pPr>
-              <a:defRPr sz="1220" b="0">
+              <a:defRPr sz="1300" b="0">
                 <a:solidFill>
                   <a:srgbClr val="1B1F2A"/>
                 </a:solidFill>
@@ -16187,7 +16106,7 @@
           <a:lstStyle/>
           <a:p>
             <a:pPr>
-              <a:defRPr sz="1220" b="0">
+              <a:defRPr sz="1300" b="0">
                 <a:solidFill>
                   <a:srgbClr val="1B1F2A"/>
                 </a:solidFill>
@@ -16266,7 +16185,7 @@
           <a:lstStyle/>
           <a:p>
             <a:pPr>
-              <a:defRPr sz="1220" b="0">
+              <a:defRPr sz="1300" b="0">
                 <a:solidFill>
                   <a:srgbClr val="1B1F2A"/>
                 </a:solidFill>
@@ -16345,7 +16264,7 @@
           <a:lstStyle/>
           <a:p>
             <a:pPr>
-              <a:defRPr sz="1220" b="0">
+              <a:defRPr sz="1300" b="0">
                 <a:solidFill>
                   <a:srgbClr val="1B1F2A"/>
                 </a:solidFill>
@@ -16424,7 +16343,7 @@
           <a:lstStyle/>
           <a:p>
             <a:pPr algn="ctr">
-              <a:defRPr sz="1250" b="1">
+              <a:defRPr sz="1300" b="1">
                 <a:solidFill>
                   <a:srgbClr val="FFFFFF"/>
                 </a:solidFill>
@@ -16529,7 +16448,7 @@
           <a:lstStyle/>
           <a:p>
             <a:pPr>
-              <a:defRPr sz="1100" b="1">
+              <a:defRPr sz="1300" b="1">
                 <a:solidFill>
                   <a:srgbClr val="2563EB"/>
                 </a:solidFill>
@@ -16665,8 +16584,8 @@
         </p:nvSpPr>
         <p:spPr>
           <a:xfrm>
-            <a:off x="530352" y="6473952"/>
-            <a:ext cx="3291840" cy="164592"/>
+            <a:off x="530352" y="6419088"/>
+            <a:ext cx="4389120" cy="292608"/>
           </a:xfrm>
           <a:prstGeom prst="rect">
             <a:avLst/>
@@ -16680,7 +16599,7 @@
           <a:lstStyle/>
           <a:p>
             <a:pPr>
-              <a:defRPr sz="800" b="0">
+              <a:defRPr sz="1300" b="0">
                 <a:solidFill>
                   <a:srgbClr val="5C667A"/>
                 </a:solidFill>
@@ -16701,8 +16620,8 @@
         </p:nvSpPr>
         <p:spPr>
           <a:xfrm>
-            <a:off x="11292840" y="6473952"/>
-            <a:ext cx="320040" cy="164592"/>
+            <a:off x="11119104" y="6419088"/>
+            <a:ext cx="502920" cy="292608"/>
           </a:xfrm>
           <a:prstGeom prst="rect">
             <a:avLst/>
@@ -16716,7 +16635,7 @@
           <a:lstStyle/>
           <a:p>
             <a:pPr algn="r">
-              <a:defRPr sz="800" b="0">
+              <a:defRPr sz="1300" b="0">
                 <a:solidFill>
                   <a:srgbClr val="5C667A"/>
                 </a:solidFill>
@@ -17361,7 +17280,7 @@
           <a:lstStyle/>
           <a:p>
             <a:pPr>
-              <a:defRPr sz="1100" b="1">
+              <a:defRPr sz="1300" b="1">
                 <a:solidFill>
                   <a:srgbClr val="2563EB"/>
                 </a:solidFill>
@@ -17497,8 +17416,8 @@
         </p:nvSpPr>
         <p:spPr>
           <a:xfrm>
-            <a:off x="530352" y="6473952"/>
-            <a:ext cx="3291840" cy="164592"/>
+            <a:off x="530352" y="6419088"/>
+            <a:ext cx="4389120" cy="292608"/>
           </a:xfrm>
           <a:prstGeom prst="rect">
             <a:avLst/>
@@ -17512,7 +17431,7 @@
           <a:lstStyle/>
           <a:p>
             <a:pPr>
-              <a:defRPr sz="800" b="0">
+              <a:defRPr sz="1300" b="0">
                 <a:solidFill>
                   <a:srgbClr val="5C667A"/>
                 </a:solidFill>
@@ -17533,8 +17452,8 @@
         </p:nvSpPr>
         <p:spPr>
           <a:xfrm>
-            <a:off x="11292840" y="6473952"/>
-            <a:ext cx="320040" cy="164592"/>
+            <a:off x="11119104" y="6419088"/>
+            <a:ext cx="502920" cy="292608"/>
           </a:xfrm>
           <a:prstGeom prst="rect">
             <a:avLst/>
@@ -17548,7 +17467,7 @@
           <a:lstStyle/>
           <a:p>
             <a:pPr algn="r">
-              <a:defRPr sz="800" b="0">
+              <a:defRPr sz="1300" b="0">
                 <a:solidFill>
                   <a:srgbClr val="5C667A"/>
                 </a:solidFill>
@@ -17708,7 +17627,7 @@
           <a:lstStyle/>
           <a:p>
             <a:pPr>
-              <a:defRPr sz="1250" b="0">
+              <a:defRPr sz="1300" b="0">
                 <a:solidFill>
                   <a:srgbClr val="5C667A"/>
                 </a:solidFill>
@@ -17868,7 +17787,7 @@
           <a:lstStyle/>
           <a:p>
             <a:pPr>
-              <a:defRPr sz="1250" b="0">
+              <a:defRPr sz="1300" b="0">
                 <a:solidFill>
                   <a:srgbClr val="5C667A"/>
                 </a:solidFill>
@@ -18028,7 +17947,7 @@
           <a:lstStyle/>
           <a:p>
             <a:pPr>
-              <a:defRPr sz="1250" b="0">
+              <a:defRPr sz="1300" b="0">
                 <a:solidFill>
                   <a:srgbClr val="5C667A"/>
                 </a:solidFill>
@@ -18212,7 +18131,7 @@
           <a:lstStyle/>
           <a:p>
             <a:pPr>
-              <a:defRPr sz="1100" b="1">
+              <a:defRPr sz="1300" b="1">
                 <a:solidFill>
                   <a:srgbClr val="2563EB"/>
                 </a:solidFill>
@@ -18348,8 +18267,8 @@
         </p:nvSpPr>
         <p:spPr>
           <a:xfrm>
-            <a:off x="530352" y="6473952"/>
-            <a:ext cx="3291840" cy="164592"/>
+            <a:off x="530352" y="6419088"/>
+            <a:ext cx="4389120" cy="292608"/>
           </a:xfrm>
           <a:prstGeom prst="rect">
             <a:avLst/>
@@ -18363,7 +18282,7 @@
           <a:lstStyle/>
           <a:p>
             <a:pPr>
-              <a:defRPr sz="800" b="0">
+              <a:defRPr sz="1300" b="0">
                 <a:solidFill>
                   <a:srgbClr val="5C667A"/>
                 </a:solidFill>
@@ -18384,8 +18303,8 @@
         </p:nvSpPr>
         <p:spPr>
           <a:xfrm>
-            <a:off x="11292840" y="6473952"/>
-            <a:ext cx="320040" cy="164592"/>
+            <a:off x="11119104" y="6419088"/>
+            <a:ext cx="502920" cy="292608"/>
           </a:xfrm>
           <a:prstGeom prst="rect">
             <a:avLst/>
@@ -18399,7 +18318,7 @@
           <a:lstStyle/>
           <a:p>
             <a:pPr algn="r">
-              <a:defRPr sz="800" b="0">
+              <a:defRPr sz="1300" b="0">
                 <a:solidFill>
                   <a:srgbClr val="5C667A"/>
                 </a:solidFill>
@@ -18559,7 +18478,7 @@
           <a:lstStyle/>
           <a:p>
             <a:pPr>
-              <a:defRPr sz="1250" b="0">
+              <a:defRPr sz="1300" b="0">
                 <a:solidFill>
                   <a:srgbClr val="5C667A"/>
                 </a:solidFill>
@@ -18719,7 +18638,7 @@
           <a:lstStyle/>
           <a:p>
             <a:pPr>
-              <a:defRPr sz="1250" b="0">
+              <a:defRPr sz="1300" b="0">
                 <a:solidFill>
                   <a:srgbClr val="5C667A"/>
                 </a:solidFill>
@@ -18895,7 +18814,7 @@
           <a:lstStyle/>
           <a:p>
             <a:pPr>
-              <a:defRPr sz="1100" b="1">
+              <a:defRPr sz="1300" b="1">
                 <a:solidFill>
                   <a:srgbClr val="2563EB"/>
                 </a:solidFill>
@@ -19031,8 +18950,8 @@
         </p:nvSpPr>
         <p:spPr>
           <a:xfrm>
-            <a:off x="530352" y="6473952"/>
-            <a:ext cx="3291840" cy="164592"/>
+            <a:off x="530352" y="6419088"/>
+            <a:ext cx="4389120" cy="292608"/>
           </a:xfrm>
           <a:prstGeom prst="rect">
             <a:avLst/>
@@ -19046,7 +18965,7 @@
           <a:lstStyle/>
           <a:p>
             <a:pPr>
-              <a:defRPr sz="800" b="0">
+              <a:defRPr sz="1300" b="0">
                 <a:solidFill>
                   <a:srgbClr val="5C667A"/>
                 </a:solidFill>
@@ -19067,8 +18986,8 @@
         </p:nvSpPr>
         <p:spPr>
           <a:xfrm>
-            <a:off x="11292840" y="6473952"/>
-            <a:ext cx="320040" cy="164592"/>
+            <a:off x="11119104" y="6419088"/>
+            <a:ext cx="502920" cy="292608"/>
           </a:xfrm>
           <a:prstGeom prst="rect">
             <a:avLst/>
@@ -19082,7 +19001,7 @@
           <a:lstStyle/>
           <a:p>
             <a:pPr algn="r">
-              <a:defRPr sz="800" b="0">
+              <a:defRPr sz="1300" b="0">
                 <a:solidFill>
                   <a:srgbClr val="5C667A"/>
                 </a:solidFill>
@@ -19242,7 +19161,7 @@
           <a:lstStyle/>
           <a:p>
             <a:pPr>
-              <a:defRPr sz="1250" b="0">
+              <a:defRPr sz="1300" b="0">
                 <a:solidFill>
                   <a:srgbClr val="1B1F2A"/>
                 </a:solidFill>
@@ -19321,7 +19240,7 @@
           <a:lstStyle/>
           <a:p>
             <a:pPr>
-              <a:defRPr sz="1250" b="0">
+              <a:defRPr sz="1300" b="0">
                 <a:solidFill>
                   <a:srgbClr val="1B1F2A"/>
                 </a:solidFill>
@@ -19400,7 +19319,7 @@
           <a:lstStyle/>
           <a:p>
             <a:pPr>
-              <a:defRPr sz="1250" b="0">
+              <a:defRPr sz="1300" b="0">
                 <a:solidFill>
                   <a:srgbClr val="1B1F2A"/>
                 </a:solidFill>
@@ -19479,7 +19398,7 @@
           <a:lstStyle/>
           <a:p>
             <a:pPr>
-              <a:defRPr sz="1250" b="0">
+              <a:defRPr sz="1300" b="0">
                 <a:solidFill>
                   <a:srgbClr val="1B1F2A"/>
                 </a:solidFill>
@@ -19558,7 +19477,7 @@
           <a:lstStyle/>
           <a:p>
             <a:pPr>
-              <a:defRPr sz="1250" b="0">
+              <a:defRPr sz="1300" b="0">
                 <a:solidFill>
                   <a:srgbClr val="1B1F2A"/>
                 </a:solidFill>
@@ -19718,7 +19637,7 @@
           <a:lstStyle/>
           <a:p>
             <a:pPr>
-              <a:defRPr sz="1250" b="0">
+              <a:defRPr sz="1300" b="0">
                 <a:solidFill>
                   <a:srgbClr val="1B1F2A"/>
                 </a:solidFill>
@@ -19797,7 +19716,7 @@
           <a:lstStyle/>
           <a:p>
             <a:pPr>
-              <a:defRPr sz="1250" b="0">
+              <a:defRPr sz="1300" b="0">
                 <a:solidFill>
                   <a:srgbClr val="1B1F2A"/>
                 </a:solidFill>
@@ -19876,7 +19795,7 @@
           <a:lstStyle/>
           <a:p>
             <a:pPr>
-              <a:defRPr sz="1250" b="0">
+              <a:defRPr sz="1300" b="0">
                 <a:solidFill>
                   <a:srgbClr val="1B1F2A"/>
                 </a:solidFill>
@@ -19955,7 +19874,7 @@
           <a:lstStyle/>
           <a:p>
             <a:pPr>
-              <a:defRPr sz="1250" b="0">
+              <a:defRPr sz="1300" b="0">
                 <a:solidFill>
                   <a:srgbClr val="1B1F2A"/>
                 </a:solidFill>
@@ -20034,7 +19953,7 @@
           <a:lstStyle/>
           <a:p>
             <a:pPr>
-              <a:defRPr sz="1250" b="0">
+              <a:defRPr sz="1300" b="0">
                 <a:solidFill>
                   <a:srgbClr val="1B1F2A"/>
                 </a:solidFill>
@@ -20194,7 +20113,7 @@
           <a:lstStyle/>
           <a:p>
             <a:pPr>
-              <a:defRPr sz="1200" b="0">
+              <a:defRPr sz="1300" b="0">
                 <a:solidFill>
                   <a:srgbClr val="1B1F2A"/>
                 </a:solidFill>
@@ -20273,7 +20192,7 @@
           <a:lstStyle/>
           <a:p>
             <a:pPr>
-              <a:defRPr sz="1200" b="0">
+              <a:defRPr sz="1300" b="0">
                 <a:solidFill>
                   <a:srgbClr val="1B1F2A"/>
                 </a:solidFill>
@@ -20352,7 +20271,7 @@
           <a:lstStyle/>
           <a:p>
             <a:pPr>
-              <a:defRPr sz="1200" b="0">
+              <a:defRPr sz="1300" b="0">
                 <a:solidFill>
                   <a:srgbClr val="1B1F2A"/>
                 </a:solidFill>
@@ -20431,7 +20350,7 @@
           <a:lstStyle/>
           <a:p>
             <a:pPr>
-              <a:defRPr sz="1200" b="0">
+              <a:defRPr sz="1300" b="0">
                 <a:solidFill>
                   <a:srgbClr val="1B1F2A"/>
                 </a:solidFill>
@@ -20510,7 +20429,7 @@
           <a:lstStyle/>
           <a:p>
             <a:pPr>
-              <a:defRPr sz="1200" b="0">
+              <a:defRPr sz="1300" b="0">
                 <a:solidFill>
                   <a:srgbClr val="1B1F2A"/>
                 </a:solidFill>
@@ -20589,7 +20508,7 @@
           <a:lstStyle/>
           <a:p>
             <a:pPr algn="ctr">
-              <a:defRPr sz="1260" b="1">
+              <a:defRPr sz="1300" b="1">
                 <a:solidFill>
                   <a:srgbClr val="FFFFFF"/>
                 </a:solidFill>
@@ -20694,7 +20613,7 @@
           <a:lstStyle/>
           <a:p>
             <a:pPr>
-              <a:defRPr sz="1100" b="1">
+              <a:defRPr sz="1300" b="1">
                 <a:solidFill>
                   <a:srgbClr val="2563EB"/>
                 </a:solidFill>
@@ -20830,8 +20749,8 @@
         </p:nvSpPr>
         <p:spPr>
           <a:xfrm>
-            <a:off x="530352" y="6473952"/>
-            <a:ext cx="3291840" cy="164592"/>
+            <a:off x="530352" y="6419088"/>
+            <a:ext cx="4389120" cy="292608"/>
           </a:xfrm>
           <a:prstGeom prst="rect">
             <a:avLst/>
@@ -20845,7 +20764,7 @@
           <a:lstStyle/>
           <a:p>
             <a:pPr>
-              <a:defRPr sz="800" b="0">
+              <a:defRPr sz="1300" b="0">
                 <a:solidFill>
                   <a:srgbClr val="5C667A"/>
                 </a:solidFill>
@@ -20866,8 +20785,8 @@
         </p:nvSpPr>
         <p:spPr>
           <a:xfrm>
-            <a:off x="11292840" y="6473952"/>
-            <a:ext cx="320040" cy="164592"/>
+            <a:off x="11119104" y="6419088"/>
+            <a:ext cx="502920" cy="292608"/>
           </a:xfrm>
           <a:prstGeom prst="rect">
             <a:avLst/>
@@ -20881,7 +20800,7 @@
           <a:lstStyle/>
           <a:p>
             <a:pPr algn="r">
-              <a:defRPr sz="800" b="0">
+              <a:defRPr sz="1300" b="0">
                 <a:solidFill>
                   <a:srgbClr val="5C667A"/>
                 </a:solidFill>
@@ -21859,7 +21778,7 @@
           <a:lstStyle/>
           <a:p>
             <a:pPr>
-              <a:defRPr sz="1100" b="1">
+              <a:defRPr sz="1300" b="1">
                 <a:solidFill>
                   <a:srgbClr val="2563EB"/>
                 </a:solidFill>
@@ -21995,8 +21914,8 @@
         </p:nvSpPr>
         <p:spPr>
           <a:xfrm>
-            <a:off x="530352" y="6473952"/>
-            <a:ext cx="3291840" cy="164592"/>
+            <a:off x="530352" y="6419088"/>
+            <a:ext cx="4389120" cy="292608"/>
           </a:xfrm>
           <a:prstGeom prst="rect">
             <a:avLst/>
@@ -22010,7 +21929,7 @@
           <a:lstStyle/>
           <a:p>
             <a:pPr>
-              <a:defRPr sz="800" b="0">
+              <a:defRPr sz="1300" b="0">
                 <a:solidFill>
                   <a:srgbClr val="5C667A"/>
                 </a:solidFill>
@@ -22031,8 +21950,8 @@
         </p:nvSpPr>
         <p:spPr>
           <a:xfrm>
-            <a:off x="11292840" y="6473952"/>
-            <a:ext cx="320040" cy="164592"/>
+            <a:off x="11119104" y="6419088"/>
+            <a:ext cx="502920" cy="292608"/>
           </a:xfrm>
           <a:prstGeom prst="rect">
             <a:avLst/>
@@ -22046,7 +21965,7 @@
           <a:lstStyle/>
           <a:p>
             <a:pPr algn="r">
-              <a:defRPr sz="800" b="0">
+              <a:defRPr sz="1300" b="0">
                 <a:solidFill>
                   <a:srgbClr val="5C667A"/>
                 </a:solidFill>
@@ -22212,7 +22131,7 @@
           <a:lstStyle/>
           <a:p>
             <a:pPr>
-              <a:defRPr sz="1270" b="0">
+              <a:defRPr sz="1300" b="0">
                 <a:solidFill>
                   <a:srgbClr val="5C667A"/>
                 </a:solidFill>
@@ -22378,7 +22297,7 @@
           <a:lstStyle/>
           <a:p>
             <a:pPr>
-              <a:defRPr sz="1270" b="0">
+              <a:defRPr sz="1300" b="0">
                 <a:solidFill>
                   <a:srgbClr val="5C667A"/>
                 </a:solidFill>
@@ -22562,7 +22481,7 @@
           <a:lstStyle/>
           <a:p>
             <a:pPr>
-              <a:defRPr sz="1100" b="1">
+              <a:defRPr sz="1300" b="1">
                 <a:solidFill>
                   <a:srgbClr val="2563EB"/>
                 </a:solidFill>
@@ -22698,8 +22617,8 @@
         </p:nvSpPr>
         <p:spPr>
           <a:xfrm>
-            <a:off x="530352" y="6473952"/>
-            <a:ext cx="3291840" cy="164592"/>
+            <a:off x="530352" y="6419088"/>
+            <a:ext cx="4389120" cy="292608"/>
           </a:xfrm>
           <a:prstGeom prst="rect">
             <a:avLst/>
@@ -22713,7 +22632,7 @@
           <a:lstStyle/>
           <a:p>
             <a:pPr>
-              <a:defRPr sz="800" b="0">
+              <a:defRPr sz="1300" b="0">
                 <a:solidFill>
                   <a:srgbClr val="5C667A"/>
                 </a:solidFill>
@@ -22734,8 +22653,8 @@
         </p:nvSpPr>
         <p:spPr>
           <a:xfrm>
-            <a:off x="11292840" y="6473952"/>
-            <a:ext cx="320040" cy="164592"/>
+            <a:off x="11119104" y="6419088"/>
+            <a:ext cx="502920" cy="292608"/>
           </a:xfrm>
           <a:prstGeom prst="rect">
             <a:avLst/>
@@ -22749,7 +22668,7 @@
           <a:lstStyle/>
           <a:p>
             <a:pPr algn="r">
-              <a:defRPr sz="800" b="0">
+              <a:defRPr sz="1300" b="0">
                 <a:solidFill>
                   <a:srgbClr val="5C667A"/>
                 </a:solidFill>
@@ -22909,7 +22828,7 @@
           <a:lstStyle/>
           <a:p>
             <a:pPr>
-              <a:defRPr sz="1250" b="0">
+              <a:defRPr sz="1300" b="0">
                 <a:solidFill>
                   <a:srgbClr val="1B1F2A"/>
                 </a:solidFill>
@@ -22988,7 +22907,7 @@
           <a:lstStyle/>
           <a:p>
             <a:pPr>
-              <a:defRPr sz="1250" b="0">
+              <a:defRPr sz="1300" b="0">
                 <a:solidFill>
                   <a:srgbClr val="1B1F2A"/>
                 </a:solidFill>
@@ -23067,7 +22986,7 @@
           <a:lstStyle/>
           <a:p>
             <a:pPr>
-              <a:defRPr sz="1250" b="0">
+              <a:defRPr sz="1300" b="0">
                 <a:solidFill>
                   <a:srgbClr val="1B1F2A"/>
                 </a:solidFill>
@@ -23146,7 +23065,7 @@
           <a:lstStyle/>
           <a:p>
             <a:pPr>
-              <a:defRPr sz="1250" b="0">
+              <a:defRPr sz="1300" b="0">
                 <a:solidFill>
                   <a:srgbClr val="1B1F2A"/>
                 </a:solidFill>
@@ -23306,7 +23225,7 @@
           <a:lstStyle/>
           <a:p>
             <a:pPr>
-              <a:defRPr sz="1220" b="0">
+              <a:defRPr sz="1300" b="0">
                 <a:solidFill>
                   <a:srgbClr val="1B1F2A"/>
                 </a:solidFill>
@@ -23385,7 +23304,7 @@
           <a:lstStyle/>
           <a:p>
             <a:pPr>
-              <a:defRPr sz="1220" b="0">
+              <a:defRPr sz="1300" b="0">
                 <a:solidFill>
                   <a:srgbClr val="1B1F2A"/>
                 </a:solidFill>
@@ -23464,7 +23383,7 @@
           <a:lstStyle/>
           <a:p>
             <a:pPr>
-              <a:defRPr sz="1220" b="0">
+              <a:defRPr sz="1300" b="0">
                 <a:solidFill>
                   <a:srgbClr val="1B1F2A"/>
                 </a:solidFill>
@@ -23543,7 +23462,7 @@
           <a:lstStyle/>
           <a:p>
             <a:pPr>
-              <a:defRPr sz="1220" b="0">
+              <a:defRPr sz="1300" b="0">
                 <a:solidFill>
                   <a:srgbClr val="1B1F2A"/>
                 </a:solidFill>
@@ -23622,7 +23541,7 @@
           <a:lstStyle/>
           <a:p>
             <a:pPr>
-              <a:defRPr sz="1220" b="0">
+              <a:defRPr sz="1300" b="0">
                 <a:solidFill>
                   <a:srgbClr val="1B1F2A"/>
                 </a:solidFill>
@@ -23782,7 +23701,7 @@
           <a:lstStyle/>
           <a:p>
             <a:pPr>
-              <a:defRPr sz="1170" b="0">
+              <a:defRPr sz="1300" b="0">
                 <a:solidFill>
                   <a:srgbClr val="1B1F2A"/>
                 </a:solidFill>
@@ -23861,7 +23780,7 @@
           <a:lstStyle/>
           <a:p>
             <a:pPr>
-              <a:defRPr sz="1170" b="0">
+              <a:defRPr sz="1300" b="0">
                 <a:solidFill>
                   <a:srgbClr val="1B1F2A"/>
                 </a:solidFill>
@@ -23940,7 +23859,7 @@
           <a:lstStyle/>
           <a:p>
             <a:pPr>
-              <a:defRPr sz="1170" b="0">
+              <a:defRPr sz="1300" b="0">
                 <a:solidFill>
                   <a:srgbClr val="1B1F2A"/>
                 </a:solidFill>
@@ -24019,7 +23938,7 @@
           <a:lstStyle/>
           <a:p>
             <a:pPr>
-              <a:defRPr sz="1170" b="0">
+              <a:defRPr sz="1300" b="0">
                 <a:solidFill>
                   <a:srgbClr val="1B1F2A"/>
                 </a:solidFill>
@@ -24098,7 +24017,7 @@
           <a:lstStyle/>
           <a:p>
             <a:pPr algn="ctr">
-              <a:defRPr sz="1250" b="1">
+              <a:defRPr sz="1300" b="1">
                 <a:solidFill>
                   <a:srgbClr val="FFFFFF"/>
                 </a:solidFill>
@@ -24203,7 +24122,7 @@
           <a:lstStyle/>
           <a:p>
             <a:pPr>
-              <a:defRPr sz="1100" b="1">
+              <a:defRPr sz="1300" b="1">
                 <a:solidFill>
                   <a:srgbClr val="2563EB"/>
                 </a:solidFill>
@@ -24339,8 +24258,8 @@
         </p:nvSpPr>
         <p:spPr>
           <a:xfrm>
-            <a:off x="530352" y="6473952"/>
-            <a:ext cx="3291840" cy="164592"/>
+            <a:off x="530352" y="6419088"/>
+            <a:ext cx="4389120" cy="292608"/>
           </a:xfrm>
           <a:prstGeom prst="rect">
             <a:avLst/>
@@ -24354,7 +24273,7 @@
           <a:lstStyle/>
           <a:p>
             <a:pPr>
-              <a:defRPr sz="800" b="0">
+              <a:defRPr sz="1300" b="0">
                 <a:solidFill>
                   <a:srgbClr val="5C667A"/>
                 </a:solidFill>
@@ -24375,8 +24294,8 @@
         </p:nvSpPr>
         <p:spPr>
           <a:xfrm>
-            <a:off x="11292840" y="6473952"/>
-            <a:ext cx="320040" cy="164592"/>
+            <a:off x="11119104" y="6419088"/>
+            <a:ext cx="502920" cy="292608"/>
           </a:xfrm>
           <a:prstGeom prst="rect">
             <a:avLst/>
@@ -24390,7 +24309,7 @@
           <a:lstStyle/>
           <a:p>
             <a:pPr algn="r">
-              <a:defRPr sz="800" b="0">
+              <a:defRPr sz="1300" b="0">
                 <a:solidFill>
                   <a:srgbClr val="5C667A"/>
                 </a:solidFill>
@@ -24550,7 +24469,7 @@
           <a:lstStyle/>
           <a:p>
             <a:pPr>
-              <a:defRPr sz="1250" b="0">
+              <a:defRPr sz="1300" b="0">
                 <a:solidFill>
                   <a:srgbClr val="1B1F2A"/>
                 </a:solidFill>
@@ -24629,7 +24548,7 @@
           <a:lstStyle/>
           <a:p>
             <a:pPr>
-              <a:defRPr sz="1250" b="0">
+              <a:defRPr sz="1300" b="0">
                 <a:solidFill>
                   <a:srgbClr val="1B1F2A"/>
                 </a:solidFill>
@@ -24708,7 +24627,7 @@
           <a:lstStyle/>
           <a:p>
             <a:pPr>
-              <a:defRPr sz="1250" b="0">
+              <a:defRPr sz="1300" b="0">
                 <a:solidFill>
                   <a:srgbClr val="1B1F2A"/>
                 </a:solidFill>
@@ -24787,7 +24706,7 @@
           <a:lstStyle/>
           <a:p>
             <a:pPr>
-              <a:defRPr sz="1250" b="0">
+              <a:defRPr sz="1300" b="0">
                 <a:solidFill>
                   <a:srgbClr val="1B1F2A"/>
                 </a:solidFill>
@@ -24947,7 +24866,7 @@
           <a:lstStyle/>
           <a:p>
             <a:pPr>
-              <a:defRPr sz="1180" b="0">
+              <a:defRPr sz="1300" b="0">
                 <a:solidFill>
                   <a:srgbClr val="1B1F2A"/>
                 </a:solidFill>
@@ -25026,7 +24945,7 @@
           <a:lstStyle/>
           <a:p>
             <a:pPr>
-              <a:defRPr sz="1180" b="0">
+              <a:defRPr sz="1300" b="0">
                 <a:solidFill>
                   <a:srgbClr val="1B1F2A"/>
                 </a:solidFill>
@@ -25105,7 +25024,7 @@
           <a:lstStyle/>
           <a:p>
             <a:pPr>
-              <a:defRPr sz="1180" b="0">
+              <a:defRPr sz="1300" b="0">
                 <a:solidFill>
                   <a:srgbClr val="1B1F2A"/>
                 </a:solidFill>
@@ -25184,7 +25103,7 @@
           <a:lstStyle/>
           <a:p>
             <a:pPr>
-              <a:defRPr sz="1180" b="0">
+              <a:defRPr sz="1300" b="0">
                 <a:solidFill>
                   <a:srgbClr val="1B1F2A"/>
                 </a:solidFill>
@@ -25344,7 +25263,7 @@
           <a:lstStyle/>
           <a:p>
             <a:pPr>
-              <a:defRPr sz="1180" b="0">
+              <a:defRPr sz="1300" b="0">
                 <a:solidFill>
                   <a:srgbClr val="1B1F2A"/>
                 </a:solidFill>
@@ -25423,7 +25342,7 @@
           <a:lstStyle/>
           <a:p>
             <a:pPr>
-              <a:defRPr sz="1180" b="0">
+              <a:defRPr sz="1300" b="0">
                 <a:solidFill>
                   <a:srgbClr val="1B1F2A"/>
                 </a:solidFill>
@@ -25502,7 +25421,7 @@
           <a:lstStyle/>
           <a:p>
             <a:pPr>
-              <a:defRPr sz="1180" b="0">
+              <a:defRPr sz="1300" b="0">
                 <a:solidFill>
                   <a:srgbClr val="1B1F2A"/>
                 </a:solidFill>
@@ -25581,7 +25500,7 @@
           <a:lstStyle/>
           <a:p>
             <a:pPr>
-              <a:defRPr sz="1180" b="0">
+              <a:defRPr sz="1300" b="0">
                 <a:solidFill>
                   <a:srgbClr val="1B1F2A"/>
                 </a:solidFill>
@@ -25660,7 +25579,7 @@
           <a:lstStyle/>
           <a:p>
             <a:pPr>
-              <a:defRPr sz="1180" b="0">
+              <a:defRPr sz="1300" b="0">
                 <a:solidFill>
                   <a:srgbClr val="1B1F2A"/>
                 </a:solidFill>
@@ -25739,7 +25658,7 @@
           <a:lstStyle/>
           <a:p>
             <a:pPr algn="ctr">
-              <a:defRPr sz="1280" b="1">
+              <a:defRPr sz="1300" b="1">
                 <a:solidFill>
                   <a:srgbClr val="FFFFFF"/>
                 </a:solidFill>
@@ -25844,7 +25763,7 @@
           <a:lstStyle/>
           <a:p>
             <a:pPr>
-              <a:defRPr sz="1100" b="1">
+              <a:defRPr sz="1300" b="1">
                 <a:solidFill>
                   <a:srgbClr val="2563EB"/>
                 </a:solidFill>
@@ -25980,8 +25899,8 @@
         </p:nvSpPr>
         <p:spPr>
           <a:xfrm>
-            <a:off x="530352" y="6473952"/>
-            <a:ext cx="3291840" cy="164592"/>
+            <a:off x="530352" y="6419088"/>
+            <a:ext cx="4389120" cy="292608"/>
           </a:xfrm>
           <a:prstGeom prst="rect">
             <a:avLst/>
@@ -25995,7 +25914,7 @@
           <a:lstStyle/>
           <a:p>
             <a:pPr>
-              <a:defRPr sz="800" b="0">
+              <a:defRPr sz="1300" b="0">
                 <a:solidFill>
                   <a:srgbClr val="5C667A"/>
                 </a:solidFill>
@@ -26016,8 +25935,8 @@
         </p:nvSpPr>
         <p:spPr>
           <a:xfrm>
-            <a:off x="11292840" y="6473952"/>
-            <a:ext cx="320040" cy="164592"/>
+            <a:off x="11119104" y="6419088"/>
+            <a:ext cx="502920" cy="292608"/>
           </a:xfrm>
           <a:prstGeom prst="rect">
             <a:avLst/>
@@ -26031,7 +25950,7 @@
           <a:lstStyle/>
           <a:p>
             <a:pPr algn="r">
-              <a:defRPr sz="800" b="0">
+              <a:defRPr sz="1300" b="0">
                 <a:solidFill>
                   <a:srgbClr val="5C667A"/>
                 </a:solidFill>
@@ -26240,7 +26159,7 @@
           <a:lstStyle/>
           <a:p>
             <a:pPr>
-              <a:defRPr sz="1180" b="0">
+              <a:defRPr sz="1300" b="0">
                 <a:solidFill>
                   <a:srgbClr val="5C667A"/>
                 </a:solidFill>
@@ -26321,7 +26240,7 @@
           <a:lstStyle/>
           <a:p>
             <a:pPr algn="ctr">
-              <a:defRPr sz="1220" b="1">
+              <a:defRPr sz="1300" b="1">
                 <a:solidFill>
                   <a:srgbClr val="1B1F2A"/>
                 </a:solidFill>
@@ -26357,7 +26276,7 @@
           <a:lstStyle/>
           <a:p>
             <a:pPr>
-              <a:defRPr sz="1070" b="0">
+              <a:defRPr sz="1300" b="0">
                 <a:solidFill>
                   <a:srgbClr val="5C667A"/>
                 </a:solidFill>
@@ -26505,7 +26424,7 @@
           <a:lstStyle/>
           <a:p>
             <a:pPr algn="ctr">
-              <a:defRPr sz="1170" b="1">
+              <a:defRPr sz="1300" b="1">
                 <a:solidFill>
                   <a:srgbClr val="FFFFFF"/>
                 </a:solidFill>
@@ -26526,8 +26445,8 @@
         </p:nvSpPr>
         <p:spPr>
           <a:xfrm>
-            <a:off x="5870448" y="5358384"/>
-            <a:ext cx="4892040" cy="146304"/>
+            <a:off x="6163056" y="5175504"/>
+            <a:ext cx="4480560" cy="219456"/>
           </a:xfrm>
           <a:prstGeom prst="rect">
             <a:avLst/>
@@ -26541,7 +26460,7 @@
           <a:lstStyle/>
           <a:p>
             <a:pPr>
-              <a:defRPr sz="780" b="0">
+              <a:defRPr sz="1300" b="0">
                 <a:solidFill>
                   <a:srgbClr val="5C667A"/>
                 </a:solidFill>
@@ -26549,7 +26468,7 @@
               </a:defRPr>
             </a:pPr>
             <a:r>
-              <a:t>출처: bridge-private-state mainnet security review의 collision model + BridgeCore/ChannelManager 현 구현</a:t>
+              <a:t>출처: review + BridgeCore/ChannelManager</a:t>
             </a:r>
           </a:p>
         </p:txBody>
@@ -26646,7 +26565,7 @@
           <a:lstStyle/>
           <a:p>
             <a:pPr>
-              <a:defRPr sz="1100" b="1">
+              <a:defRPr sz="1300" b="1">
                 <a:solidFill>
                   <a:srgbClr val="2563EB"/>
                 </a:solidFill>
@@ -26782,8 +26701,8 @@
         </p:nvSpPr>
         <p:spPr>
           <a:xfrm>
-            <a:off x="530352" y="6473952"/>
-            <a:ext cx="3291840" cy="164592"/>
+            <a:off x="530352" y="6419088"/>
+            <a:ext cx="4389120" cy="292608"/>
           </a:xfrm>
           <a:prstGeom prst="rect">
             <a:avLst/>
@@ -26797,7 +26716,7 @@
           <a:lstStyle/>
           <a:p>
             <a:pPr>
-              <a:defRPr sz="800" b="0">
+              <a:defRPr sz="1300" b="0">
                 <a:solidFill>
                   <a:srgbClr val="5C667A"/>
                 </a:solidFill>
@@ -26818,8 +26737,8 @@
         </p:nvSpPr>
         <p:spPr>
           <a:xfrm>
-            <a:off x="11292840" y="6473952"/>
-            <a:ext cx="320040" cy="164592"/>
+            <a:off x="11119104" y="6419088"/>
+            <a:ext cx="502920" cy="292608"/>
           </a:xfrm>
           <a:prstGeom prst="rect">
             <a:avLst/>
@@ -26833,7 +26752,7 @@
           <a:lstStyle/>
           <a:p>
             <a:pPr algn="r">
-              <a:defRPr sz="800" b="0">
+              <a:defRPr sz="1300" b="0">
                 <a:solidFill>
                   <a:srgbClr val="5C667A"/>
                 </a:solidFill>
@@ -27412,7 +27331,7 @@
           <a:lstStyle/>
           <a:p>
             <a:pPr>
-              <a:defRPr sz="1100" b="1">
+              <a:defRPr sz="1300" b="1">
                 <a:solidFill>
                   <a:srgbClr val="2563EB"/>
                 </a:solidFill>
@@ -27548,8 +27467,8 @@
         </p:nvSpPr>
         <p:spPr>
           <a:xfrm>
-            <a:off x="530352" y="6473952"/>
-            <a:ext cx="3291840" cy="164592"/>
+            <a:off x="530352" y="6419088"/>
+            <a:ext cx="4389120" cy="292608"/>
           </a:xfrm>
           <a:prstGeom prst="rect">
             <a:avLst/>
@@ -27563,7 +27482,7 @@
           <a:lstStyle/>
           <a:p>
             <a:pPr>
-              <a:defRPr sz="800" b="0">
+              <a:defRPr sz="1300" b="0">
                 <a:solidFill>
                   <a:srgbClr val="5C667A"/>
                 </a:solidFill>
@@ -27584,8 +27503,8 @@
         </p:nvSpPr>
         <p:spPr>
           <a:xfrm>
-            <a:off x="11292840" y="6473952"/>
-            <a:ext cx="320040" cy="164592"/>
+            <a:off x="11119104" y="6419088"/>
+            <a:ext cx="502920" cy="292608"/>
           </a:xfrm>
           <a:prstGeom prst="rect">
             <a:avLst/>
@@ -27599,7 +27518,7 @@
           <a:lstStyle/>
           <a:p>
             <a:pPr algn="r">
-              <a:defRPr sz="800" b="0">
+              <a:defRPr sz="1300" b="0">
                 <a:solidFill>
                   <a:srgbClr val="5C667A"/>
                 </a:solidFill>
@@ -27759,7 +27678,7 @@
           <a:lstStyle/>
           <a:p>
             <a:pPr>
-              <a:defRPr sz="1250" b="0">
+              <a:defRPr sz="1300" b="0">
                 <a:solidFill>
                   <a:srgbClr val="5C667A"/>
                 </a:solidFill>
@@ -27919,7 +27838,7 @@
           <a:lstStyle/>
           <a:p>
             <a:pPr>
-              <a:defRPr sz="1250" b="0">
+              <a:defRPr sz="1300" b="0">
                 <a:solidFill>
                   <a:srgbClr val="5C667A"/>
                 </a:solidFill>
@@ -28079,7 +27998,7 @@
           <a:lstStyle/>
           <a:p>
             <a:pPr>
-              <a:defRPr sz="1250" b="0">
+              <a:defRPr sz="1300" b="0">
                 <a:solidFill>
                   <a:srgbClr val="5C667A"/>
                 </a:solidFill>
@@ -28457,7 +28376,7 @@
           <a:lstStyle/>
           <a:p>
             <a:pPr>
-              <a:defRPr sz="1100" b="1">
+              <a:defRPr sz="1300" b="1">
                 <a:solidFill>
                   <a:srgbClr val="2563EB"/>
                 </a:solidFill>
@@ -28593,8 +28512,8 @@
         </p:nvSpPr>
         <p:spPr>
           <a:xfrm>
-            <a:off x="530352" y="6473952"/>
-            <a:ext cx="3291840" cy="164592"/>
+            <a:off x="530352" y="6419088"/>
+            <a:ext cx="4389120" cy="292608"/>
           </a:xfrm>
           <a:prstGeom prst="rect">
             <a:avLst/>
@@ -28608,7 +28527,7 @@
           <a:lstStyle/>
           <a:p>
             <a:pPr>
-              <a:defRPr sz="800" b="0">
+              <a:defRPr sz="1300" b="0">
                 <a:solidFill>
                   <a:srgbClr val="5C667A"/>
                 </a:solidFill>
@@ -28629,8 +28548,8 @@
         </p:nvSpPr>
         <p:spPr>
           <a:xfrm>
-            <a:off x="11292840" y="6473952"/>
-            <a:ext cx="320040" cy="164592"/>
+            <a:off x="11119104" y="6419088"/>
+            <a:ext cx="502920" cy="292608"/>
           </a:xfrm>
           <a:prstGeom prst="rect">
             <a:avLst/>
@@ -28644,7 +28563,7 @@
           <a:lstStyle/>
           <a:p>
             <a:pPr algn="r">
-              <a:defRPr sz="800" b="0">
+              <a:defRPr sz="1300" b="0">
                 <a:solidFill>
                   <a:srgbClr val="5C667A"/>
                 </a:solidFill>
@@ -28804,7 +28723,7 @@
           <a:lstStyle/>
           <a:p>
             <a:pPr>
-              <a:defRPr sz="1250" b="0">
+              <a:defRPr sz="1300" b="0">
                 <a:solidFill>
                   <a:srgbClr val="5C667A"/>
                 </a:solidFill>
@@ -28964,7 +28883,7 @@
           <a:lstStyle/>
           <a:p>
             <a:pPr>
-              <a:defRPr sz="1250" b="0">
+              <a:defRPr sz="1300" b="0">
                 <a:solidFill>
                   <a:srgbClr val="5C667A"/>
                 </a:solidFill>
@@ -29124,7 +29043,7 @@
           <a:lstStyle/>
           <a:p>
             <a:pPr>
-              <a:defRPr sz="1250" b="0">
+              <a:defRPr sz="1300" b="0">
                 <a:solidFill>
                   <a:srgbClr val="5C667A"/>
                 </a:solidFill>
@@ -29310,7 +29229,7 @@
           <a:lstStyle/>
           <a:p>
             <a:pPr>
-              <a:defRPr sz="1100" b="1">
+              <a:defRPr sz="1300" b="1">
                 <a:solidFill>
                   <a:srgbClr val="2563EB"/>
                 </a:solidFill>
@@ -29446,8 +29365,8 @@
         </p:nvSpPr>
         <p:spPr>
           <a:xfrm>
-            <a:off x="530352" y="6473952"/>
-            <a:ext cx="3291840" cy="164592"/>
+            <a:off x="530352" y="6419088"/>
+            <a:ext cx="4389120" cy="292608"/>
           </a:xfrm>
           <a:prstGeom prst="rect">
             <a:avLst/>
@@ -29461,7 +29380,7 @@
           <a:lstStyle/>
           <a:p>
             <a:pPr>
-              <a:defRPr sz="800" b="0">
+              <a:defRPr sz="1300" b="0">
                 <a:solidFill>
                   <a:srgbClr val="5C667A"/>
                 </a:solidFill>
@@ -29482,8 +29401,8 @@
         </p:nvSpPr>
         <p:spPr>
           <a:xfrm>
-            <a:off x="11292840" y="6473952"/>
-            <a:ext cx="320040" cy="164592"/>
+            <a:off x="11119104" y="6419088"/>
+            <a:ext cx="502920" cy="292608"/>
           </a:xfrm>
           <a:prstGeom prst="rect">
             <a:avLst/>
@@ -29497,7 +29416,7 @@
           <a:lstStyle/>
           <a:p>
             <a:pPr algn="r">
-              <a:defRPr sz="800" b="0">
+              <a:defRPr sz="1300" b="0">
                 <a:solidFill>
                   <a:srgbClr val="5C667A"/>
                 </a:solidFill>
@@ -29686,7 +29605,7 @@
           <a:lstStyle/>
           <a:p>
             <a:pPr>
-              <a:defRPr sz="1060" b="1">
+              <a:defRPr sz="1300" b="1">
                 <a:solidFill>
                   <a:srgbClr val="1B1F2A"/>
                 </a:solidFill>
@@ -29767,7 +29686,7 @@
           <a:lstStyle/>
           <a:p>
             <a:pPr>
-              <a:defRPr sz="1060" b="1">
+              <a:defRPr sz="1300" b="1">
                 <a:solidFill>
                   <a:srgbClr val="1B1F2A"/>
                 </a:solidFill>
@@ -29848,7 +29767,7 @@
           <a:lstStyle/>
           <a:p>
             <a:pPr>
-              <a:defRPr sz="1060" b="1">
+              <a:defRPr sz="1300" b="1">
                 <a:solidFill>
                   <a:srgbClr val="1B1F2A"/>
                 </a:solidFill>
@@ -29929,7 +29848,7 @@
           <a:lstStyle/>
           <a:p>
             <a:pPr>
-              <a:defRPr sz="1140" b="1">
+              <a:defRPr sz="1300" b="1">
                 <a:solidFill>
                   <a:srgbClr val="2563EB"/>
                 </a:solidFill>
@@ -30008,7 +29927,7 @@
           <a:lstStyle/>
           <a:p>
             <a:pPr>
-              <a:defRPr sz="1050" b="0">
+              <a:defRPr sz="1300" b="0">
                 <a:solidFill>
                   <a:srgbClr val="1B1F2A"/>
                 </a:solidFill>
@@ -30087,7 +30006,7 @@
           <a:lstStyle/>
           <a:p>
             <a:pPr>
-              <a:defRPr sz="1050" b="0">
+              <a:defRPr sz="1300" b="0">
                 <a:solidFill>
                   <a:srgbClr val="1B1F2A"/>
                 </a:solidFill>
@@ -30166,7 +30085,7 @@
           <a:lstStyle/>
           <a:p>
             <a:pPr>
-              <a:defRPr sz="1050" b="0">
+              <a:defRPr sz="1300" b="0">
                 <a:solidFill>
                   <a:srgbClr val="1B1F2A"/>
                 </a:solidFill>
@@ -30245,7 +30164,7 @@
           <a:lstStyle/>
           <a:p>
             <a:pPr>
-              <a:defRPr sz="1050" b="0">
+              <a:defRPr sz="1300" b="0">
                 <a:solidFill>
                   <a:srgbClr val="1B1F2A"/>
                 </a:solidFill>
@@ -30324,7 +30243,7 @@
           <a:lstStyle/>
           <a:p>
             <a:pPr>
-              <a:defRPr sz="1050" b="0">
+              <a:defRPr sz="1300" b="0">
                 <a:solidFill>
                   <a:srgbClr val="1B1F2A"/>
                 </a:solidFill>
@@ -30486,7 +30405,7 @@
           <a:lstStyle/>
           <a:p>
             <a:pPr algn="ctr">
-              <a:defRPr sz="1019" b="1">
+              <a:defRPr sz="1300" b="1">
                 <a:solidFill>
                   <a:srgbClr val="5C667A"/>
                 </a:solidFill>
@@ -30567,7 +30486,7 @@
           <a:lstStyle/>
           <a:p>
             <a:pPr algn="ctr">
-              <a:defRPr sz="1019" b="1">
+              <a:defRPr sz="1300" b="1">
                 <a:solidFill>
                   <a:srgbClr val="5C667A"/>
                 </a:solidFill>
@@ -30648,7 +30567,7 @@
           <a:lstStyle/>
           <a:p>
             <a:pPr algn="ctr">
-              <a:defRPr sz="1019" b="1">
+              <a:defRPr sz="1300" b="1">
                 <a:solidFill>
                   <a:srgbClr val="5C667A"/>
                 </a:solidFill>
@@ -30729,7 +30648,7 @@
           <a:lstStyle/>
           <a:p>
             <a:pPr algn="ctr">
-              <a:defRPr sz="1019" b="1">
+              <a:defRPr sz="1300" b="1">
                 <a:solidFill>
                   <a:srgbClr val="5C667A"/>
                 </a:solidFill>
@@ -30810,7 +30729,7 @@
           <a:lstStyle/>
           <a:p>
             <a:pPr>
-              <a:defRPr sz="1060" b="1">
+              <a:defRPr sz="1300" b="1">
                 <a:solidFill>
                   <a:srgbClr val="1B1F2A"/>
                 </a:solidFill>
@@ -30891,7 +30810,7 @@
           <a:lstStyle/>
           <a:p>
             <a:pPr>
-              <a:defRPr sz="1060" b="1">
+              <a:defRPr sz="1300" b="1">
                 <a:solidFill>
                   <a:srgbClr val="1B1F2A"/>
                 </a:solidFill>
@@ -30972,7 +30891,7 @@
           <a:lstStyle/>
           <a:p>
             <a:pPr>
-              <a:defRPr sz="1060" b="1">
+              <a:defRPr sz="1300" b="1">
                 <a:solidFill>
                   <a:srgbClr val="1B1F2A"/>
                 </a:solidFill>
@@ -31053,7 +30972,7 @@
           <a:lstStyle/>
           <a:p>
             <a:pPr>
-              <a:defRPr sz="1140" b="1">
+              <a:defRPr sz="1300" b="1">
                 <a:solidFill>
                   <a:srgbClr val="21A67A"/>
                 </a:solidFill>
@@ -31132,7 +31051,7 @@
           <a:lstStyle/>
           <a:p>
             <a:pPr>
-              <a:defRPr sz="1050" b="0">
+              <a:defRPr sz="1300" b="0">
                 <a:solidFill>
                   <a:srgbClr val="1B1F2A"/>
                 </a:solidFill>
@@ -31211,7 +31130,7 @@
           <a:lstStyle/>
           <a:p>
             <a:pPr>
-              <a:defRPr sz="1050" b="0">
+              <a:defRPr sz="1300" b="0">
                 <a:solidFill>
                   <a:srgbClr val="1B1F2A"/>
                 </a:solidFill>
@@ -31290,7 +31209,7 @@
           <a:lstStyle/>
           <a:p>
             <a:pPr>
-              <a:defRPr sz="1050" b="0">
+              <a:defRPr sz="1300" b="0">
                 <a:solidFill>
                   <a:srgbClr val="1B1F2A"/>
                 </a:solidFill>
@@ -31369,7 +31288,7 @@
           <a:lstStyle/>
           <a:p>
             <a:pPr>
-              <a:defRPr sz="1050" b="0">
+              <a:defRPr sz="1300" b="0">
                 <a:solidFill>
                   <a:srgbClr val="1B1F2A"/>
                 </a:solidFill>
@@ -31448,7 +31367,7 @@
           <a:lstStyle/>
           <a:p>
             <a:pPr>
-              <a:defRPr sz="1050" b="0">
+              <a:defRPr sz="1300" b="0">
                 <a:solidFill>
                   <a:srgbClr val="1B1F2A"/>
                 </a:solidFill>
@@ -31527,7 +31446,7 @@
           <a:lstStyle/>
           <a:p>
             <a:pPr>
-              <a:defRPr sz="1050" b="0">
+              <a:defRPr sz="1300" b="0">
                 <a:solidFill>
                   <a:srgbClr val="1B1F2A"/>
                 </a:solidFill>
@@ -31816,7 +31735,7 @@
           <a:lstStyle/>
           <a:p>
             <a:pPr algn="ctr">
-              <a:defRPr sz="1250" b="1">
+              <a:defRPr sz="1300" b="1">
                 <a:solidFill>
                   <a:srgbClr val="FFFFFF"/>
                 </a:solidFill>
@@ -31921,7 +31840,7 @@
           <a:lstStyle/>
           <a:p>
             <a:pPr>
-              <a:defRPr sz="1100" b="1">
+              <a:defRPr sz="1300" b="1">
                 <a:solidFill>
                   <a:srgbClr val="2563EB"/>
                 </a:solidFill>
@@ -32057,8 +31976,8 @@
         </p:nvSpPr>
         <p:spPr>
           <a:xfrm>
-            <a:off x="530352" y="6473952"/>
-            <a:ext cx="3291840" cy="164592"/>
+            <a:off x="530352" y="6419088"/>
+            <a:ext cx="4389120" cy="292608"/>
           </a:xfrm>
           <a:prstGeom prst="rect">
             <a:avLst/>
@@ -32072,7 +31991,7 @@
           <a:lstStyle/>
           <a:p>
             <a:pPr>
-              <a:defRPr sz="800" b="0">
+              <a:defRPr sz="1300" b="0">
                 <a:solidFill>
                   <a:srgbClr val="5C667A"/>
                 </a:solidFill>
@@ -32093,8 +32012,8 @@
         </p:nvSpPr>
         <p:spPr>
           <a:xfrm>
-            <a:off x="11292840" y="6473952"/>
-            <a:ext cx="320040" cy="164592"/>
+            <a:off x="11119104" y="6419088"/>
+            <a:ext cx="502920" cy="292608"/>
           </a:xfrm>
           <a:prstGeom prst="rect">
             <a:avLst/>
@@ -32108,7 +32027,7 @@
           <a:lstStyle/>
           <a:p>
             <a:pPr algn="r">
-              <a:defRPr sz="800" b="0">
+              <a:defRPr sz="1300" b="0">
                 <a:solidFill>
                   <a:srgbClr val="5C667A"/>
                 </a:solidFill>
@@ -32920,7 +32839,7 @@
           <a:lstStyle/>
           <a:p>
             <a:pPr>
-              <a:defRPr sz="1100" b="1">
+              <a:defRPr sz="1300" b="1">
                 <a:solidFill>
                   <a:srgbClr val="2563EB"/>
                 </a:solidFill>
@@ -33056,8 +32975,8 @@
         </p:nvSpPr>
         <p:spPr>
           <a:xfrm>
-            <a:off x="530352" y="6473952"/>
-            <a:ext cx="3291840" cy="164592"/>
+            <a:off x="530352" y="6419088"/>
+            <a:ext cx="4389120" cy="292608"/>
           </a:xfrm>
           <a:prstGeom prst="rect">
             <a:avLst/>
@@ -33071,7 +32990,7 @@
           <a:lstStyle/>
           <a:p>
             <a:pPr>
-              <a:defRPr sz="800" b="0">
+              <a:defRPr sz="1300" b="0">
                 <a:solidFill>
                   <a:srgbClr val="5C667A"/>
                 </a:solidFill>
@@ -33092,8 +33011,8 @@
         </p:nvSpPr>
         <p:spPr>
           <a:xfrm>
-            <a:off x="11292840" y="6473952"/>
-            <a:ext cx="320040" cy="164592"/>
+            <a:off x="11119104" y="6419088"/>
+            <a:ext cx="502920" cy="292608"/>
           </a:xfrm>
           <a:prstGeom prst="rect">
             <a:avLst/>
@@ -33107,7 +33026,7 @@
           <a:lstStyle/>
           <a:p>
             <a:pPr algn="r">
-              <a:defRPr sz="800" b="0">
+              <a:defRPr sz="1300" b="0">
                 <a:solidFill>
                   <a:srgbClr val="5C667A"/>
                 </a:solidFill>
@@ -33269,7 +33188,7 @@
           <a:lstStyle/>
           <a:p>
             <a:pPr algn="ctr">
-              <a:defRPr sz="1200" b="1">
+              <a:defRPr sz="1300" b="1">
                 <a:solidFill>
                   <a:srgbClr val="1B1F2A"/>
                 </a:solidFill>
@@ -33350,7 +33269,7 @@
           <a:lstStyle/>
           <a:p>
             <a:pPr algn="ctr">
-              <a:defRPr sz="1200" b="1">
+              <a:defRPr sz="1300" b="1">
                 <a:solidFill>
                   <a:srgbClr val="1B1F2A"/>
                 </a:solidFill>
@@ -33431,7 +33350,7 @@
           <a:lstStyle/>
           <a:p>
             <a:pPr algn="ctr">
-              <a:defRPr sz="1200" b="1">
+              <a:defRPr sz="1300" b="1">
                 <a:solidFill>
                   <a:srgbClr val="1B1F2A"/>
                 </a:solidFill>
@@ -33512,7 +33431,7 @@
           <a:lstStyle/>
           <a:p>
             <a:pPr algn="ctr">
-              <a:defRPr sz="1200" b="1">
+              <a:defRPr sz="1300" b="1">
                 <a:solidFill>
                   <a:srgbClr val="1B1F2A"/>
                 </a:solidFill>
@@ -33674,7 +33593,7 @@
           <a:lstStyle/>
           <a:p>
             <a:pPr algn="ctr">
-              <a:defRPr sz="1050" b="1">
+              <a:defRPr sz="1300" b="1">
                 <a:solidFill>
                   <a:srgbClr val="1B1F2A"/>
                 </a:solidFill>
@@ -33687,7 +33606,7 @@
           </a:p>
           <a:p>
             <a:pPr algn="ctr">
-              <a:defRPr sz="1050" b="1">
+              <a:defRPr sz="1300" b="1">
                 <a:solidFill>
                   <a:srgbClr val="1B1F2A"/>
                 </a:solidFill>
@@ -33803,7 +33722,7 @@
           <a:lstStyle/>
           <a:p>
             <a:pPr algn="ctr">
-              <a:defRPr sz="1050" b="1">
+              <a:defRPr sz="1300" b="1">
                 <a:solidFill>
                   <a:srgbClr val="1B1F2A"/>
                 </a:solidFill>
@@ -33816,7 +33735,7 @@
           </a:p>
           <a:p>
             <a:pPr algn="ctr">
-              <a:defRPr sz="1050" b="1">
+              <a:defRPr sz="1300" b="1">
                 <a:solidFill>
                   <a:srgbClr val="1B1F2A"/>
                 </a:solidFill>
@@ -33932,7 +33851,7 @@
           <a:lstStyle/>
           <a:p>
             <a:pPr algn="ctr">
-              <a:defRPr sz="1050" b="1">
+              <a:defRPr sz="1300" b="1">
                 <a:solidFill>
                   <a:srgbClr val="1B1F2A"/>
                 </a:solidFill>
@@ -33945,7 +33864,7 @@
           </a:p>
           <a:p>
             <a:pPr algn="ctr">
-              <a:defRPr sz="1050" b="1">
+              <a:defRPr sz="1300" b="1">
                 <a:solidFill>
                   <a:srgbClr val="1B1F2A"/>
                 </a:solidFill>
@@ -34121,7 +34040,7 @@
           <a:lstStyle/>
           <a:p>
             <a:pPr>
-              <a:defRPr sz="1100" b="1">
+              <a:defRPr sz="1300" b="1">
                 <a:solidFill>
                   <a:srgbClr val="2563EB"/>
                 </a:solidFill>
@@ -34257,8 +34176,8 @@
         </p:nvSpPr>
         <p:spPr>
           <a:xfrm>
-            <a:off x="530352" y="6473952"/>
-            <a:ext cx="3291840" cy="164592"/>
+            <a:off x="530352" y="6419088"/>
+            <a:ext cx="4389120" cy="292608"/>
           </a:xfrm>
           <a:prstGeom prst="rect">
             <a:avLst/>
@@ -34272,7 +34191,7 @@
           <a:lstStyle/>
           <a:p>
             <a:pPr>
-              <a:defRPr sz="800" b="0">
+              <a:defRPr sz="1300" b="0">
                 <a:solidFill>
                   <a:srgbClr val="5C667A"/>
                 </a:solidFill>
@@ -34293,8 +34212,8 @@
         </p:nvSpPr>
         <p:spPr>
           <a:xfrm>
-            <a:off x="11292840" y="6473952"/>
-            <a:ext cx="320040" cy="164592"/>
+            <a:off x="11119104" y="6419088"/>
+            <a:ext cx="502920" cy="292608"/>
           </a:xfrm>
           <a:prstGeom prst="rect">
             <a:avLst/>
@@ -34308,7 +34227,7 @@
           <a:lstStyle/>
           <a:p>
             <a:pPr algn="r">
-              <a:defRPr sz="800" b="0">
+              <a:defRPr sz="1300" b="0">
                 <a:solidFill>
                   <a:srgbClr val="5C667A"/>
                 </a:solidFill>
@@ -35242,7 +35161,7 @@
           <a:lstStyle/>
           <a:p>
             <a:pPr>
-              <a:defRPr sz="1100" b="1">
+              <a:defRPr sz="1300" b="1">
                 <a:solidFill>
                   <a:srgbClr val="2563EB"/>
                 </a:solidFill>
@@ -35378,8 +35297,8 @@
         </p:nvSpPr>
         <p:spPr>
           <a:xfrm>
-            <a:off x="530352" y="6473952"/>
-            <a:ext cx="3291840" cy="164592"/>
+            <a:off x="530352" y="6419088"/>
+            <a:ext cx="4389120" cy="292608"/>
           </a:xfrm>
           <a:prstGeom prst="rect">
             <a:avLst/>
@@ -35393,7 +35312,7 @@
           <a:lstStyle/>
           <a:p>
             <a:pPr>
-              <a:defRPr sz="800" b="0">
+              <a:defRPr sz="1300" b="0">
                 <a:solidFill>
                   <a:srgbClr val="5C667A"/>
                 </a:solidFill>
@@ -35414,8 +35333,8 @@
         </p:nvSpPr>
         <p:spPr>
           <a:xfrm>
-            <a:off x="11292840" y="6473952"/>
-            <a:ext cx="320040" cy="164592"/>
+            <a:off x="11119104" y="6419088"/>
+            <a:ext cx="502920" cy="292608"/>
           </a:xfrm>
           <a:prstGeom prst="rect">
             <a:avLst/>
@@ -35429,7 +35348,7 @@
           <a:lstStyle/>
           <a:p>
             <a:pPr algn="r">
-              <a:defRPr sz="800" b="0">
+              <a:defRPr sz="1300" b="0">
                 <a:solidFill>
                   <a:srgbClr val="5C667A"/>
                 </a:solidFill>
@@ -35510,7 +35429,7 @@
           <a:lstStyle/>
           <a:p>
             <a:pPr>
-              <a:defRPr sz="930" b="1">
+              <a:defRPr sz="1300" b="1">
                 <a:solidFill>
                   <a:srgbClr val="5C667A"/>
                 </a:solidFill>
@@ -35546,7 +35465,7 @@
           <a:lstStyle/>
           <a:p>
             <a:pPr>
-              <a:defRPr sz="1280" b="1">
+              <a:defRPr sz="1300" b="1">
                 <a:solidFill>
                   <a:srgbClr val="1B1F2A"/>
                 </a:solidFill>
@@ -35582,7 +35501,7 @@
           <a:lstStyle/>
           <a:p>
             <a:pPr>
-              <a:defRPr sz="880" b="0">
+              <a:defRPr sz="1300" b="0">
                 <a:solidFill>
                   <a:srgbClr val="5C667A"/>
                 </a:solidFill>
@@ -35663,7 +35582,7 @@
           <a:lstStyle/>
           <a:p>
             <a:pPr>
-              <a:defRPr sz="930" b="1">
+              <a:defRPr sz="1300" b="1">
                 <a:solidFill>
                   <a:srgbClr val="5C667A"/>
                 </a:solidFill>
@@ -35699,7 +35618,7 @@
           <a:lstStyle/>
           <a:p>
             <a:pPr>
-              <a:defRPr sz="1280" b="1">
+              <a:defRPr sz="1300" b="1">
                 <a:solidFill>
                   <a:srgbClr val="1B1F2A"/>
                 </a:solidFill>
@@ -35735,7 +35654,7 @@
           <a:lstStyle/>
           <a:p>
             <a:pPr>
-              <a:defRPr sz="880" b="0">
+              <a:defRPr sz="1300" b="0">
                 <a:solidFill>
                   <a:srgbClr val="5C667A"/>
                 </a:solidFill>
@@ -35816,7 +35735,7 @@
           <a:lstStyle/>
           <a:p>
             <a:pPr>
-              <a:defRPr sz="930" b="1">
+              <a:defRPr sz="1300" b="1">
                 <a:solidFill>
                   <a:srgbClr val="5C667A"/>
                 </a:solidFill>
@@ -35852,7 +35771,7 @@
           <a:lstStyle/>
           <a:p>
             <a:pPr>
-              <a:defRPr sz="1280" b="1">
+              <a:defRPr sz="1300" b="1">
                 <a:solidFill>
                   <a:srgbClr val="1B1F2A"/>
                 </a:solidFill>
@@ -35888,7 +35807,7 @@
           <a:lstStyle/>
           <a:p>
             <a:pPr>
-              <a:defRPr sz="880" b="0">
+              <a:defRPr sz="1300" b="0">
                 <a:solidFill>
                   <a:srgbClr val="5C667A"/>
                 </a:solidFill>
@@ -36039,7 +35958,7 @@
           <a:lstStyle/>
           <a:p>
             <a:pPr algn="ctr">
-              <a:defRPr sz="880" b="1">
+              <a:defRPr sz="1300" b="1">
                 <a:solidFill>
                   <a:srgbClr val="21A67A"/>
                 </a:solidFill>
@@ -36120,7 +36039,7 @@
           <a:lstStyle/>
           <a:p>
             <a:pPr algn="ctr">
-              <a:defRPr sz="860" b="1">
+              <a:defRPr sz="1300" b="1">
                 <a:solidFill>
                   <a:srgbClr val="00A6B2"/>
                 </a:solidFill>
@@ -36156,7 +36075,7 @@
           <a:lstStyle/>
           <a:p>
             <a:pPr algn="ctr">
-              <a:defRPr sz="1200" b="0">
+              <a:defRPr sz="1300" b="0">
                 <a:solidFill>
                   <a:srgbClr val="5C667A"/>
                 </a:solidFill>
@@ -36177,8 +36096,8 @@
         </p:nvSpPr>
         <p:spPr>
           <a:xfrm>
-            <a:off x="804672" y="4224528"/>
-            <a:ext cx="3291840" cy="1005840"/>
+            <a:off x="804672" y="4151376"/>
+            <a:ext cx="3291840" cy="1225296"/>
           </a:xfrm>
           <a:prstGeom prst="roundRect">
             <a:avLst/>
@@ -36259,7 +36178,7 @@
         <p:spPr>
           <a:xfrm>
             <a:off x="1060704" y="4736592"/>
-            <a:ext cx="2697480" cy="365760"/>
+            <a:ext cx="2697480" cy="457200"/>
           </a:xfrm>
           <a:prstGeom prst="rect">
             <a:avLst/>
@@ -36273,7 +36192,7 @@
           <a:lstStyle/>
           <a:p>
             <a:pPr>
-              <a:defRPr sz="1000" b="0">
+              <a:defRPr sz="1300" b="0">
                 <a:solidFill>
                   <a:srgbClr val="5C667A"/>
                 </a:solidFill>
@@ -36281,7 +36200,7 @@
               </a:defRPr>
             </a:pPr>
             <a:r>
-              <a:t>compiler가 읽을 bytecode를 만들고, 개발자가 같은 로직을 직접 점검할 수 있게 한다.</a:t>
+              <a:t>bytecode를 만든다. 개발자가 같은 로직을 점검할 수 있다.</a:t>
             </a:r>
           </a:p>
         </p:txBody>
@@ -36294,8 +36213,8 @@
         </p:nvSpPr>
         <p:spPr>
           <a:xfrm>
-            <a:off x="4443984" y="4224528"/>
-            <a:ext cx="3291840" cy="1005840"/>
+            <a:off x="4443984" y="4151376"/>
+            <a:ext cx="3291840" cy="1225296"/>
           </a:xfrm>
           <a:prstGeom prst="roundRect">
             <a:avLst/>
@@ -36376,7 +36295,7 @@
         <p:spPr>
           <a:xfrm>
             <a:off x="4700016" y="4736592"/>
-            <a:ext cx="2697480" cy="365760"/>
+            <a:ext cx="2697480" cy="457200"/>
           </a:xfrm>
           <a:prstGeom prst="rect">
             <a:avLst/>
@@ -36390,7 +36309,7 @@
           <a:lstStyle/>
           <a:p>
             <a:pPr>
-              <a:defRPr sz="1000" b="0">
+              <a:defRPr sz="1300" b="0">
                 <a:solidFill>
                   <a:srgbClr val="5C667A"/>
                 </a:solidFill>
@@ -36398,7 +36317,7 @@
               </a:defRPr>
             </a:pPr>
             <a:r>
-              <a:t>허용 함수, storage 범위, public input 형식이 들어 있는 DApp metadata를 본다.</a:t>
+              <a:t>허용 함수, storage 범위, public input 형식을 본다.</a:t>
             </a:r>
           </a:p>
         </p:txBody>
@@ -36411,8 +36330,8 @@
         </p:nvSpPr>
         <p:spPr>
           <a:xfrm>
-            <a:off x="8083296" y="4224528"/>
-            <a:ext cx="3291840" cy="1005840"/>
+            <a:off x="8083296" y="4151376"/>
+            <a:ext cx="3291840" cy="1225296"/>
           </a:xfrm>
           <a:prstGeom prst="roundRect">
             <a:avLst/>
@@ -36493,7 +36412,7 @@
         <p:spPr>
           <a:xfrm>
             <a:off x="8339327" y="4736592"/>
-            <a:ext cx="2697480" cy="365760"/>
+            <a:ext cx="2697480" cy="457200"/>
           </a:xfrm>
           <a:prstGeom prst="rect">
             <a:avLst/>
@@ -36507,7 +36426,7 @@
           <a:lstStyle/>
           <a:p>
             <a:pPr>
-              <a:defRPr sz="1000" b="0">
+              <a:defRPr sz="1300" b="0">
                 <a:solidFill>
                   <a:srgbClr val="5C667A"/>
                 </a:solidFill>
@@ -36515,7 +36434,7 @@
               </a:defRPr>
             </a:pPr>
             <a:r>
-              <a:t>배포된 DApp을 호출하거나 transaction을 L1에서 다시 실행하지 않는다.</a:t>
+              <a:t>DApp 호출도, L1 replay도 하지 않는다.</a:t>
             </a:r>
           </a:p>
         </p:txBody>

</xml_diff>

<commit_message>
Add related resources slide
</commit_message>
<xml_diff>
--- a/bridge/docs/dev/spec.pptx
+++ b/bridge/docs/dev/spec.pptx
@@ -32,6 +32,7 @@
     <p:sldId id="280" r:id="rId31"/>
     <p:sldId id="281" r:id="rId32"/>
     <p:sldId id="282" r:id="rId33"/>
+    <p:sldId id="283" r:id="rId34"/>
   </p:sldIdLst>
   <p:sldSz cx="12191999" cy="6858000" type="screen4x3"/>
   <p:notesSz cx="6858000" cy="9144000"/>
@@ -27235,6 +27236,580 @@
             </a:pPr>
             <a:r>
               <a:t>핵심 질문은 proof가 verify되는가뿐 아니라, 어떤 policy가 그 proof에 의미를 부여하는가이다.</a:t>
+            </a:r>
+          </a:p>
+        </p:txBody>
+      </p:sp>
+    </p:spTree>
+  </p:cSld>
+  <p:clrMapOvr>
+    <a:masterClrMapping/>
+  </p:clrMapOvr>
+</p:sld>
+</file>
+
+<file path=ppt/slides/slide28.xml><?xml version="1.0" encoding="utf-8"?>
+<p:sld xmlns:a="http://schemas.openxmlformats.org/drawingml/2006/main" xmlns:p="http://schemas.openxmlformats.org/presentationml/2006/main" xmlns:r="http://schemas.openxmlformats.org/officeDocument/2006/relationships">
+  <p:cSld>
+    <p:bg>
+      <p:bgPr>
+        <a:solidFill>
+          <a:srgbClr val="F7F8FA"/>
+        </a:solidFill>
+        <a:effectLst/>
+      </p:bgPr>
+    </p:bg>
+    <p:spTree>
+      <p:nvGrpSpPr>
+        <p:cNvPr id="1" name=""/>
+        <p:cNvGrpSpPr/>
+        <p:nvPr/>
+      </p:nvGrpSpPr>
+      <p:grpSpPr/>
+      <p:sp>
+        <p:nvSpPr>
+          <p:cNvPr id="2" name="Rectangle 1"/>
+          <p:cNvSpPr/>
+          <p:nvPr/>
+        </p:nvSpPr>
+        <p:spPr>
+          <a:xfrm>
+            <a:off x="0" y="0"/>
+            <a:ext cx="146304" cy="6858000"/>
+          </a:xfrm>
+          <a:prstGeom prst="rect">
+            <a:avLst/>
+          </a:prstGeom>
+          <a:solidFill>
+            <a:srgbClr val="2563EB"/>
+          </a:solidFill>
+          <a:ln>
+            <a:noFill/>
+          </a:ln>
+        </p:spPr>
+        <p:style>
+          <a:lnRef idx="1">
+            <a:schemeClr val="accent1"/>
+          </a:lnRef>
+          <a:fillRef idx="3">
+            <a:schemeClr val="accent1"/>
+          </a:fillRef>
+          <a:effectRef idx="2">
+            <a:schemeClr val="accent1"/>
+          </a:effectRef>
+          <a:fontRef idx="minor">
+            <a:schemeClr val="lt1"/>
+          </a:fontRef>
+        </p:style>
+        <p:txBody>
+          <a:bodyPr rtlCol="0" anchor="ctr"/>
+          <a:lstStyle/>
+          <a:p>
+            <a:pPr algn="ctr"/>
+          </a:p>
+        </p:txBody>
+      </p:sp>
+      <p:sp>
+        <p:nvSpPr>
+          <p:cNvPr id="3" name="TextBox 2"/>
+          <p:cNvSpPr txBox="1"/>
+          <p:nvPr/>
+        </p:nvSpPr>
+        <p:spPr>
+          <a:xfrm>
+            <a:off x="548640" y="411480"/>
+            <a:ext cx="5303520" cy="228600"/>
+          </a:xfrm>
+          <a:prstGeom prst="rect">
+            <a:avLst/>
+          </a:prstGeom>
+          <a:noFill/>
+        </p:spPr>
+        <p:txBody>
+          <a:bodyPr wrap="square" lIns="18288" rIns="18288" tIns="9144" bIns="9144" anchor="t">
+            <a:spAutoFit/>
+          </a:bodyPr>
+          <a:lstStyle/>
+          <a:p>
+            <a:pPr>
+              <a:defRPr sz="1300" b="1">
+                <a:solidFill>
+                  <a:srgbClr val="2563EB"/>
+                </a:solidFill>
+                <a:latin typeface="Apple SD Gothic Neo"/>
+              </a:defRPr>
+            </a:pPr>
+            <a:r>
+              <a:t>자료</a:t>
+            </a:r>
+          </a:p>
+        </p:txBody>
+      </p:sp>
+      <p:sp>
+        <p:nvSpPr>
+          <p:cNvPr id="4" name="TextBox 3"/>
+          <p:cNvSpPr txBox="1"/>
+          <p:nvPr/>
+        </p:nvSpPr>
+        <p:spPr>
+          <a:xfrm>
+            <a:off x="530352" y="804672"/>
+            <a:ext cx="8046720" cy="640080"/>
+          </a:xfrm>
+          <a:prstGeom prst="rect">
+            <a:avLst/>
+          </a:prstGeom>
+          <a:noFill/>
+        </p:spPr>
+        <p:txBody>
+          <a:bodyPr wrap="square" lIns="18288" rIns="18288" tIns="9144" bIns="9144" anchor="t">
+            <a:spAutoFit/>
+          </a:bodyPr>
+          <a:lstStyle/>
+          <a:p>
+            <a:pPr>
+              <a:defRPr sz="3400" b="1">
+                <a:solidFill>
+                  <a:srgbClr val="101828"/>
+                </a:solidFill>
+                <a:latin typeface="Apple SD Gothic Neo"/>
+              </a:defRPr>
+            </a:pPr>
+            <a:r>
+              <a:t>함께 보면 좋은 자료</a:t>
+            </a:r>
+          </a:p>
+        </p:txBody>
+      </p:sp>
+      <p:sp>
+        <p:nvSpPr>
+          <p:cNvPr id="5" name="TextBox 4"/>
+          <p:cNvSpPr txBox="1"/>
+          <p:nvPr/>
+        </p:nvSpPr>
+        <p:spPr>
+          <a:xfrm>
+            <a:off x="548640" y="1444752"/>
+            <a:ext cx="7863840" cy="438912"/>
+          </a:xfrm>
+          <a:prstGeom prst="rect">
+            <a:avLst/>
+          </a:prstGeom>
+          <a:noFill/>
+        </p:spPr>
+        <p:txBody>
+          <a:bodyPr wrap="square" lIns="18288" rIns="18288" tIns="9144" bIns="9144" anchor="t">
+            <a:spAutoFit/>
+          </a:bodyPr>
+          <a:lstStyle/>
+          <a:p>
+            <a:pPr>
+              <a:defRPr sz="1500" b="0">
+                <a:solidFill>
+                  <a:srgbClr val="5C667A"/>
+                </a:solidFill>
+                <a:latin typeface="Apple SD Gothic Neo"/>
+              </a:defRPr>
+            </a:pPr>
+            <a:r>
+              <a:t>브릿지 이해에 필요한 배경 자료를 모아둔다. 목록은 이후 확장한다.</a:t>
+            </a:r>
+          </a:p>
+        </p:txBody>
+      </p:sp>
+      <p:sp>
+        <p:nvSpPr>
+          <p:cNvPr id="6" name="Rectangle 5"/>
+          <p:cNvSpPr/>
+          <p:nvPr/>
+        </p:nvSpPr>
+        <p:spPr>
+          <a:xfrm>
+            <a:off x="530352" y="6364224"/>
+            <a:ext cx="11109960" cy="9144"/>
+          </a:xfrm>
+          <a:prstGeom prst="rect">
+            <a:avLst/>
+          </a:prstGeom>
+          <a:solidFill>
+            <a:srgbClr val="D8DDE6"/>
+          </a:solidFill>
+          <a:ln>
+            <a:noFill/>
+          </a:ln>
+        </p:spPr>
+        <p:style>
+          <a:lnRef idx="1">
+            <a:schemeClr val="accent1"/>
+          </a:lnRef>
+          <a:fillRef idx="3">
+            <a:schemeClr val="accent1"/>
+          </a:fillRef>
+          <a:effectRef idx="2">
+            <a:schemeClr val="accent1"/>
+          </a:effectRef>
+          <a:fontRef idx="minor">
+            <a:schemeClr val="lt1"/>
+          </a:fontRef>
+        </p:style>
+        <p:txBody>
+          <a:bodyPr rtlCol="0" anchor="ctr"/>
+          <a:lstStyle/>
+          <a:p>
+            <a:pPr algn="ctr"/>
+          </a:p>
+        </p:txBody>
+      </p:sp>
+      <p:sp>
+        <p:nvSpPr>
+          <p:cNvPr id="7" name="TextBox 6"/>
+          <p:cNvSpPr txBox="1"/>
+          <p:nvPr/>
+        </p:nvSpPr>
+        <p:spPr>
+          <a:xfrm>
+            <a:off x="530352" y="6419088"/>
+            <a:ext cx="4389120" cy="292608"/>
+          </a:xfrm>
+          <a:prstGeom prst="rect">
+            <a:avLst/>
+          </a:prstGeom>
+          <a:noFill/>
+        </p:spPr>
+        <p:txBody>
+          <a:bodyPr wrap="square" lIns="18288" rIns="18288" tIns="9144" bIns="9144" anchor="t">
+            <a:spAutoFit/>
+          </a:bodyPr>
+          <a:lstStyle/>
+          <a:p>
+            <a:pPr>
+              <a:defRPr sz="1300" b="0">
+                <a:solidFill>
+                  <a:srgbClr val="5C667A"/>
+                </a:solidFill>
+                <a:latin typeface="Apple SD Gothic Neo"/>
+              </a:defRPr>
+            </a:pPr>
+            <a:r>
+              <a:t>Tokamak Private App Channels</a:t>
+            </a:r>
+          </a:p>
+        </p:txBody>
+      </p:sp>
+      <p:sp>
+        <p:nvSpPr>
+          <p:cNvPr id="8" name="TextBox 7"/>
+          <p:cNvSpPr txBox="1"/>
+          <p:nvPr/>
+        </p:nvSpPr>
+        <p:spPr>
+          <a:xfrm>
+            <a:off x="11119104" y="6419088"/>
+            <a:ext cx="502920" cy="292608"/>
+          </a:xfrm>
+          <a:prstGeom prst="rect">
+            <a:avLst/>
+          </a:prstGeom>
+          <a:noFill/>
+        </p:spPr>
+        <p:txBody>
+          <a:bodyPr wrap="square" lIns="18288" rIns="18288" tIns="9144" bIns="9144" anchor="t">
+            <a:spAutoFit/>
+          </a:bodyPr>
+          <a:lstStyle/>
+          <a:p>
+            <a:pPr algn="r">
+              <a:defRPr sz="1300" b="0">
+                <a:solidFill>
+                  <a:srgbClr val="5C667A"/>
+                </a:solidFill>
+                <a:latin typeface="Apple SD Gothic Neo"/>
+              </a:defRPr>
+            </a:pPr>
+            <a:r>
+              <a:t>28</a:t>
+            </a:r>
+          </a:p>
+        </p:txBody>
+      </p:sp>
+      <p:sp>
+        <p:nvSpPr>
+          <p:cNvPr id="9" name="Rounded Rectangle 8"/>
+          <p:cNvSpPr/>
+          <p:nvPr/>
+        </p:nvSpPr>
+        <p:spPr>
+          <a:xfrm>
+            <a:off x="841248" y="2157984"/>
+            <a:ext cx="10387584" cy="1682496"/>
+          </a:xfrm>
+          <a:prstGeom prst="roundRect">
+            <a:avLst/>
+          </a:prstGeom>
+          <a:solidFill>
+            <a:srgbClr val="FFFFFF"/>
+          </a:solidFill>
+          <a:ln w="12700">
+            <a:solidFill>
+              <a:srgbClr val="D8DDE6"/>
+            </a:solidFill>
+          </a:ln>
+        </p:spPr>
+        <p:style>
+          <a:lnRef idx="1">
+            <a:schemeClr val="accent1"/>
+          </a:lnRef>
+          <a:fillRef idx="3">
+            <a:schemeClr val="accent1"/>
+          </a:fillRef>
+          <a:effectRef idx="2">
+            <a:schemeClr val="accent1"/>
+          </a:effectRef>
+          <a:fontRef idx="minor">
+            <a:schemeClr val="lt1"/>
+          </a:fontRef>
+        </p:style>
+        <p:txBody>
+          <a:bodyPr rtlCol="0" anchor="ctr"/>
+          <a:lstStyle/>
+          <a:p>
+            <a:pPr algn="ctr"/>
+          </a:p>
+        </p:txBody>
+      </p:sp>
+      <p:sp>
+        <p:nvSpPr>
+          <p:cNvPr id="10" name="TextBox 9"/>
+          <p:cNvSpPr txBox="1"/>
+          <p:nvPr/>
+        </p:nvSpPr>
+        <p:spPr>
+          <a:xfrm>
+            <a:off x="1170432" y="2450592"/>
+            <a:ext cx="4754880" cy="310896"/>
+          </a:xfrm>
+          <a:prstGeom prst="rect">
+            <a:avLst/>
+          </a:prstGeom>
+          <a:noFill/>
+        </p:spPr>
+        <p:txBody>
+          <a:bodyPr wrap="square" lIns="18288" rIns="18288" tIns="9144" bIns="9144" anchor="t">
+            <a:spAutoFit/>
+          </a:bodyPr>
+          <a:lstStyle/>
+          <a:p>
+            <a:pPr>
+              <a:defRPr sz="1900" b="1">
+                <a:solidFill>
+                  <a:srgbClr val="2563EB"/>
+                </a:solidFill>
+                <a:latin typeface="Apple SD Gothic Neo"/>
+              </a:defRPr>
+            </a:pPr>
+            <a:r>
+              <a:t>Tokamak zk-EVM 설명 자료</a:t>
+            </a:r>
+          </a:p>
+        </p:txBody>
+      </p:sp>
+      <p:sp>
+        <p:nvSpPr>
+          <p:cNvPr id="11" name="TextBox 10"/>
+          <p:cNvSpPr txBox="1"/>
+          <p:nvPr/>
+        </p:nvSpPr>
+        <p:spPr>
+          <a:xfrm>
+            <a:off x="1170432" y="2889504"/>
+            <a:ext cx="8138160" cy="310896"/>
+          </a:xfrm>
+          <a:prstGeom prst="rect">
+            <a:avLst/>
+          </a:prstGeom>
+          <a:noFill/>
+        </p:spPr>
+        <p:txBody>
+          <a:bodyPr wrap="square" lIns="18288" rIns="18288" tIns="9144" bIns="9144" anchor="t">
+            <a:spAutoFit/>
+          </a:bodyPr>
+          <a:lstStyle/>
+          <a:p>
+            <a:pPr>
+              <a:defRPr sz="1500" b="0">
+                <a:solidFill>
+                  <a:srgbClr val="1B1F2A"/>
+                </a:solidFill>
+                <a:latin typeface="Apple SD Gothic Neo"/>
+              </a:defRPr>
+            </a:pPr>
+            <a:r>
+              <a:t>Tokamak zk-EVM의 실행, 증명, compiler/verifier 배경을 이해하기 위한 발표 자료.</a:t>
+            </a:r>
+          </a:p>
+        </p:txBody>
+      </p:sp>
+      <p:sp>
+        <p:nvSpPr>
+          <p:cNvPr id="12" name="Rounded Rectangle 11">
+            <a:hlinkClick r:id="rId2"/>
+          </p:cNvPr>
+          <p:cNvSpPr/>
+          <p:nvPr/>
+        </p:nvSpPr>
+        <p:spPr>
+          <a:xfrm>
+            <a:off x="8942832" y="2743200"/>
+            <a:ext cx="1536192" cy="438912"/>
+          </a:xfrm>
+          <a:prstGeom prst="roundRect">
+            <a:avLst/>
+          </a:prstGeom>
+          <a:solidFill>
+            <a:srgbClr val="E9F1FF"/>
+          </a:solidFill>
+          <a:ln w="12700">
+            <a:solidFill>
+              <a:srgbClr val="2563EB"/>
+            </a:solidFill>
+          </a:ln>
+        </p:spPr>
+        <p:style>
+          <a:lnRef idx="1">
+            <a:schemeClr val="accent1"/>
+          </a:lnRef>
+          <a:fillRef idx="3">
+            <a:schemeClr val="accent1"/>
+          </a:fillRef>
+          <a:effectRef idx="2">
+            <a:schemeClr val="accent1"/>
+          </a:effectRef>
+          <a:fontRef idx="minor">
+            <a:schemeClr val="lt1"/>
+          </a:fontRef>
+        </p:style>
+        <p:txBody>
+          <a:bodyPr rtlCol="0" anchor="ctr"/>
+          <a:lstStyle/>
+          <a:p>
+            <a:pPr algn="ctr"/>
+          </a:p>
+        </p:txBody>
+      </p:sp>
+      <p:sp>
+        <p:nvSpPr>
+          <p:cNvPr id="13" name="TextBox 12"/>
+          <p:cNvSpPr txBox="1"/>
+          <p:nvPr/>
+        </p:nvSpPr>
+        <p:spPr>
+          <a:xfrm>
+            <a:off x="9079992" y="2889504"/>
+            <a:ext cx="1261872" cy="146304"/>
+          </a:xfrm>
+          <a:prstGeom prst="rect">
+            <a:avLst/>
+          </a:prstGeom>
+          <a:noFill/>
+        </p:spPr>
+        <p:txBody>
+          <a:bodyPr wrap="square" lIns="18288" rIns="18288" tIns="9144" bIns="9144" anchor="ctr">
+            <a:spAutoFit/>
+          </a:bodyPr>
+          <a:lstStyle/>
+          <a:p>
+            <a:pPr algn="ctr">
+              <a:defRPr sz="1350" b="1">
+                <a:solidFill>
+                  <a:srgbClr val="2563EB"/>
+                </a:solidFill>
+                <a:latin typeface="Apple SD Gothic Neo"/>
+              </a:defRPr>
+            </a:pPr>
+            <a:r>
+              <a:rPr>
+                <a:hlinkClick r:id="rId2"/>
+              </a:rPr>
+              <a:t>Google Slides</a:t>
+            </a:r>
+          </a:p>
+        </p:txBody>
+      </p:sp>
+      <p:sp>
+        <p:nvSpPr>
+          <p:cNvPr id="14" name="Rounded Rectangle 13"/>
+          <p:cNvSpPr/>
+          <p:nvPr/>
+        </p:nvSpPr>
+        <p:spPr>
+          <a:xfrm>
+            <a:off x="969264" y="5285232"/>
+            <a:ext cx="10222992" cy="493776"/>
+          </a:xfrm>
+          <a:prstGeom prst="roundRect">
+            <a:avLst/>
+          </a:prstGeom>
+          <a:solidFill>
+            <a:srgbClr val="152238"/>
+          </a:solidFill>
+          <a:ln>
+            <a:noFill/>
+          </a:ln>
+        </p:spPr>
+        <p:style>
+          <a:lnRef idx="1">
+            <a:schemeClr val="accent1"/>
+          </a:lnRef>
+          <a:fillRef idx="3">
+            <a:schemeClr val="accent1"/>
+          </a:fillRef>
+          <a:effectRef idx="2">
+            <a:schemeClr val="accent1"/>
+          </a:effectRef>
+          <a:fontRef idx="minor">
+            <a:schemeClr val="lt1"/>
+          </a:fontRef>
+        </p:style>
+        <p:txBody>
+          <a:bodyPr rtlCol="0" anchor="ctr"/>
+          <a:lstStyle/>
+          <a:p>
+            <a:pPr algn="ctr"/>
+          </a:p>
+        </p:txBody>
+      </p:sp>
+      <p:sp>
+        <p:nvSpPr>
+          <p:cNvPr id="15" name="TextBox 14"/>
+          <p:cNvSpPr txBox="1"/>
+          <p:nvPr/>
+        </p:nvSpPr>
+        <p:spPr>
+          <a:xfrm>
+            <a:off x="1225296" y="5431536"/>
+            <a:ext cx="9710928" cy="201168"/>
+          </a:xfrm>
+          <a:prstGeom prst="rect">
+            <a:avLst/>
+          </a:prstGeom>
+          <a:noFill/>
+        </p:spPr>
+        <p:txBody>
+          <a:bodyPr wrap="square" lIns="18288" rIns="18288" tIns="9144" bIns="9144" anchor="ctr">
+            <a:spAutoFit/>
+          </a:bodyPr>
+          <a:lstStyle/>
+          <a:p>
+            <a:pPr algn="ctr">
+              <a:defRPr sz="1400" b="1">
+                <a:solidFill>
+                  <a:srgbClr val="FFFFFF"/>
+                </a:solidFill>
+                <a:latin typeface="Apple SD Gothic Neo"/>
+              </a:defRPr>
+            </a:pPr>
+            <a:r>
+              <a:t>추가 자료는 같은 형식으로 계속 확장한다.</a:t>
             </a:r>
           </a:p>
         </p:txBody>

</xml_diff>

<commit_message>
Add zkEVM video resource link
</commit_message>
<xml_diff>
--- a/bridge/docs/dev/spec.pptx
+++ b/bridge/docs/dev/spec.pptx
@@ -27540,8 +27540,8 @@
         </p:nvSpPr>
         <p:spPr>
           <a:xfrm>
-            <a:off x="841248" y="2157984"/>
-            <a:ext cx="10387584" cy="1682496"/>
+            <a:off x="841248" y="2029968"/>
+            <a:ext cx="10387584" cy="1188720"/>
           </a:xfrm>
           <a:prstGeom prst="roundRect">
             <a:avLst/>
@@ -27585,7 +27585,7 @@
         </p:nvSpPr>
         <p:spPr>
           <a:xfrm>
-            <a:off x="1170432" y="2450592"/>
+            <a:off x="1170432" y="2267712"/>
             <a:ext cx="4754880" cy="310896"/>
           </a:xfrm>
           <a:prstGeom prst="rect">
@@ -27600,7 +27600,7 @@
           <a:lstStyle/>
           <a:p>
             <a:pPr>
-              <a:defRPr sz="1900" b="1">
+              <a:defRPr sz="1800" b="1">
                 <a:solidFill>
                   <a:srgbClr val="2563EB"/>
                 </a:solidFill>
@@ -27621,8 +27621,8 @@
         </p:nvSpPr>
         <p:spPr>
           <a:xfrm>
-            <a:off x="1170432" y="2889504"/>
-            <a:ext cx="8138160" cy="310896"/>
+            <a:off x="1170432" y="2706624"/>
+            <a:ext cx="7726679" cy="256032"/>
           </a:xfrm>
           <a:prstGeom prst="rect">
             <a:avLst/>
@@ -27636,7 +27636,7 @@
           <a:lstStyle/>
           <a:p>
             <a:pPr>
-              <a:defRPr sz="1500" b="0">
+              <a:defRPr sz="1450" b="0">
                 <a:solidFill>
                   <a:srgbClr val="1B1F2A"/>
                 </a:solidFill>
@@ -27659,8 +27659,8 @@
         </p:nvSpPr>
         <p:spPr>
           <a:xfrm>
-            <a:off x="8942832" y="2743200"/>
-            <a:ext cx="1536192" cy="438912"/>
+            <a:off x="9107424" y="2450592"/>
+            <a:ext cx="1444752" cy="420624"/>
           </a:xfrm>
           <a:prstGeom prst="roundRect">
             <a:avLst/>
@@ -27704,8 +27704,8 @@
         </p:nvSpPr>
         <p:spPr>
           <a:xfrm>
-            <a:off x="9079992" y="2889504"/>
-            <a:ext cx="1261872" cy="146304"/>
+            <a:off x="9217152" y="2587752"/>
+            <a:ext cx="1225296" cy="146304"/>
           </a:xfrm>
           <a:prstGeom prst="rect">
             <a:avLst/>
@@ -27738,6 +27738,209 @@
       <p:sp>
         <p:nvSpPr>
           <p:cNvPr id="14" name="Rounded Rectangle 13"/>
+          <p:cNvSpPr/>
+          <p:nvPr/>
+        </p:nvSpPr>
+        <p:spPr>
+          <a:xfrm>
+            <a:off x="841248" y="3493008"/>
+            <a:ext cx="10387584" cy="1188720"/>
+          </a:xfrm>
+          <a:prstGeom prst="roundRect">
+            <a:avLst/>
+          </a:prstGeom>
+          <a:solidFill>
+            <a:srgbClr val="FFFFFF"/>
+          </a:solidFill>
+          <a:ln w="12700">
+            <a:solidFill>
+              <a:srgbClr val="D8DDE6"/>
+            </a:solidFill>
+          </a:ln>
+        </p:spPr>
+        <p:style>
+          <a:lnRef idx="1">
+            <a:schemeClr val="accent1"/>
+          </a:lnRef>
+          <a:fillRef idx="3">
+            <a:schemeClr val="accent1"/>
+          </a:fillRef>
+          <a:effectRef idx="2">
+            <a:schemeClr val="accent1"/>
+          </a:effectRef>
+          <a:fontRef idx="minor">
+            <a:schemeClr val="lt1"/>
+          </a:fontRef>
+        </p:style>
+        <p:txBody>
+          <a:bodyPr rtlCol="0" anchor="ctr"/>
+          <a:lstStyle/>
+          <a:p>
+            <a:pPr algn="ctr"/>
+          </a:p>
+        </p:txBody>
+      </p:sp>
+      <p:sp>
+        <p:nvSpPr>
+          <p:cNvPr id="15" name="TextBox 14"/>
+          <p:cNvSpPr txBox="1"/>
+          <p:nvPr/>
+        </p:nvSpPr>
+        <p:spPr>
+          <a:xfrm>
+            <a:off x="1170432" y="3730752"/>
+            <a:ext cx="5120640" cy="310896"/>
+          </a:xfrm>
+          <a:prstGeom prst="rect">
+            <a:avLst/>
+          </a:prstGeom>
+          <a:noFill/>
+        </p:spPr>
+        <p:txBody>
+          <a:bodyPr wrap="square" lIns="18288" rIns="18288" tIns="9144" bIns="9144" anchor="t">
+            <a:spAutoFit/>
+          </a:bodyPr>
+          <a:lstStyle/>
+          <a:p>
+            <a:pPr>
+              <a:defRPr sz="1800" b="1">
+                <a:solidFill>
+                  <a:srgbClr val="21A67A"/>
+                </a:solidFill>
+                <a:latin typeface="Apple SD Gothic Neo"/>
+              </a:defRPr>
+            </a:pPr>
+            <a:r>
+              <a:t>Tokamak zk-EVM 쉬운 설명 영상</a:t>
+            </a:r>
+          </a:p>
+        </p:txBody>
+      </p:sp>
+      <p:sp>
+        <p:nvSpPr>
+          <p:cNvPr id="16" name="TextBox 15"/>
+          <p:cNvSpPr txBox="1"/>
+          <p:nvPr/>
+        </p:nvSpPr>
+        <p:spPr>
+          <a:xfrm>
+            <a:off x="1170432" y="4169663"/>
+            <a:ext cx="7726679" cy="256032"/>
+          </a:xfrm>
+          <a:prstGeom prst="rect">
+            <a:avLst/>
+          </a:prstGeom>
+          <a:noFill/>
+        </p:spPr>
+        <p:txBody>
+          <a:bodyPr wrap="square" lIns="18288" rIns="18288" tIns="9144" bIns="9144" anchor="t">
+            <a:spAutoFit/>
+          </a:bodyPr>
+          <a:lstStyle/>
+          <a:p>
+            <a:pPr>
+              <a:defRPr sz="1450" b="0">
+                <a:solidFill>
+                  <a:srgbClr val="1B1F2A"/>
+                </a:solidFill>
+                <a:latin typeface="Apple SD Gothic Neo"/>
+              </a:defRPr>
+            </a:pPr>
+            <a:r>
+              <a:t>Tokamak zk-EVM의 핵심 아이디어를 더 쉽게 따라가기 위한 입문 영상.</a:t>
+            </a:r>
+          </a:p>
+        </p:txBody>
+      </p:sp>
+      <p:sp>
+        <p:nvSpPr>
+          <p:cNvPr id="17" name="Rounded Rectangle 16">
+            <a:hlinkClick r:id="rId3"/>
+          </p:cNvPr>
+          <p:cNvSpPr/>
+          <p:nvPr/>
+        </p:nvSpPr>
+        <p:spPr>
+          <a:xfrm>
+            <a:off x="9107424" y="3913632"/>
+            <a:ext cx="1444752" cy="420624"/>
+          </a:xfrm>
+          <a:prstGeom prst="roundRect">
+            <a:avLst/>
+          </a:prstGeom>
+          <a:solidFill>
+            <a:srgbClr val="E8F7F0"/>
+          </a:solidFill>
+          <a:ln w="12700">
+            <a:solidFill>
+              <a:srgbClr val="21A67A"/>
+            </a:solidFill>
+          </a:ln>
+        </p:spPr>
+        <p:style>
+          <a:lnRef idx="1">
+            <a:schemeClr val="accent1"/>
+          </a:lnRef>
+          <a:fillRef idx="3">
+            <a:schemeClr val="accent1"/>
+          </a:fillRef>
+          <a:effectRef idx="2">
+            <a:schemeClr val="accent1"/>
+          </a:effectRef>
+          <a:fontRef idx="minor">
+            <a:schemeClr val="lt1"/>
+          </a:fontRef>
+        </p:style>
+        <p:txBody>
+          <a:bodyPr rtlCol="0" anchor="ctr"/>
+          <a:lstStyle/>
+          <a:p>
+            <a:pPr algn="ctr"/>
+          </a:p>
+        </p:txBody>
+      </p:sp>
+      <p:sp>
+        <p:nvSpPr>
+          <p:cNvPr id="18" name="TextBox 17"/>
+          <p:cNvSpPr txBox="1"/>
+          <p:nvPr/>
+        </p:nvSpPr>
+        <p:spPr>
+          <a:xfrm>
+            <a:off x="9217152" y="4050791"/>
+            <a:ext cx="1225296" cy="146304"/>
+          </a:xfrm>
+          <a:prstGeom prst="rect">
+            <a:avLst/>
+          </a:prstGeom>
+          <a:noFill/>
+        </p:spPr>
+        <p:txBody>
+          <a:bodyPr wrap="square" lIns="18288" rIns="18288" tIns="9144" bIns="9144" anchor="ctr">
+            <a:spAutoFit/>
+          </a:bodyPr>
+          <a:lstStyle/>
+          <a:p>
+            <a:pPr algn="ctr">
+              <a:defRPr sz="1350" b="1">
+                <a:solidFill>
+                  <a:srgbClr val="21A67A"/>
+                </a:solidFill>
+                <a:latin typeface="Apple SD Gothic Neo"/>
+              </a:defRPr>
+            </a:pPr>
+            <a:r>
+              <a:rPr>
+                <a:hlinkClick r:id="rId3"/>
+              </a:rPr>
+              <a:t>YouTube</a:t>
+            </a:r>
+          </a:p>
+        </p:txBody>
+      </p:sp>
+      <p:sp>
+        <p:nvSpPr>
+          <p:cNvPr id="19" name="Rounded Rectangle 18"/>
           <p:cNvSpPr/>
           <p:nvPr/>
         </p:nvSpPr>
@@ -27780,7 +27983,7 @@
       </p:sp>
       <p:sp>
         <p:nvSpPr>
-          <p:cNvPr id="15" name="TextBox 14"/>
+          <p:cNvPr id="20" name="TextBox 19"/>
           <p:cNvSpPr txBox="1"/>
           <p:nvPr/>
         </p:nvSpPr>

</xml_diff>

<commit_message>
Remove internal note from resources slide
</commit_message>
<xml_diff>
--- a/bridge/docs/dev/spec.pptx
+++ b/bridge/docs/dev/spec.pptx
@@ -27412,7 +27412,7 @@
               </a:defRPr>
             </a:pPr>
             <a:r>
-              <a:t>브릿지 이해에 필요한 배경 자료를 모아둔다. 목록은 이후 확장한다.</a:t>
+              <a:t>브릿지 이해에 필요한 배경 자료.</a:t>
             </a:r>
           </a:p>
         </p:txBody>
@@ -27934,85 +27934,6 @@
                 <a:hlinkClick r:id="rId3"/>
               </a:rPr>
               <a:t>YouTube</a:t>
-            </a:r>
-          </a:p>
-        </p:txBody>
-      </p:sp>
-      <p:sp>
-        <p:nvSpPr>
-          <p:cNvPr id="19" name="Rounded Rectangle 18"/>
-          <p:cNvSpPr/>
-          <p:nvPr/>
-        </p:nvSpPr>
-        <p:spPr>
-          <a:xfrm>
-            <a:off x="969264" y="5285232"/>
-            <a:ext cx="10222992" cy="493776"/>
-          </a:xfrm>
-          <a:prstGeom prst="roundRect">
-            <a:avLst/>
-          </a:prstGeom>
-          <a:solidFill>
-            <a:srgbClr val="152238"/>
-          </a:solidFill>
-          <a:ln>
-            <a:noFill/>
-          </a:ln>
-        </p:spPr>
-        <p:style>
-          <a:lnRef idx="1">
-            <a:schemeClr val="accent1"/>
-          </a:lnRef>
-          <a:fillRef idx="3">
-            <a:schemeClr val="accent1"/>
-          </a:fillRef>
-          <a:effectRef idx="2">
-            <a:schemeClr val="accent1"/>
-          </a:effectRef>
-          <a:fontRef idx="minor">
-            <a:schemeClr val="lt1"/>
-          </a:fontRef>
-        </p:style>
-        <p:txBody>
-          <a:bodyPr rtlCol="0" anchor="ctr"/>
-          <a:lstStyle/>
-          <a:p>
-            <a:pPr algn="ctr"/>
-          </a:p>
-        </p:txBody>
-      </p:sp>
-      <p:sp>
-        <p:nvSpPr>
-          <p:cNvPr id="20" name="TextBox 19"/>
-          <p:cNvSpPr txBox="1"/>
-          <p:nvPr/>
-        </p:nvSpPr>
-        <p:spPr>
-          <a:xfrm>
-            <a:off x="1225296" y="5431536"/>
-            <a:ext cx="9710928" cy="201168"/>
-          </a:xfrm>
-          <a:prstGeom prst="rect">
-            <a:avLst/>
-          </a:prstGeom>
-          <a:noFill/>
-        </p:spPr>
-        <p:txBody>
-          <a:bodyPr wrap="square" lIns="18288" rIns="18288" tIns="9144" bIns="9144" anchor="ctr">
-            <a:spAutoFit/>
-          </a:bodyPr>
-          <a:lstStyle/>
-          <a:p>
-            <a:pPr algn="ctr">
-              <a:defRPr sz="1400" b="1">
-                <a:solidFill>
-                  <a:srgbClr val="FFFFFF"/>
-                </a:solidFill>
-                <a:latin typeface="Apple SD Gothic Neo"/>
-              </a:defRPr>
-            </a:pPr>
-            <a:r>
-              <a:t>추가 자료는 같은 형식으로 계속 확장한다.</a:t>
             </a:r>
           </a:p>
         </p:txBody>

</xml_diff>

<commit_message>
Add official docs and paper resources
</commit_message>
<xml_diff>
--- a/bridge/docs/dev/spec.pptx
+++ b/bridge/docs/dev/spec.pptx
@@ -27541,7 +27541,7 @@
         <p:spPr>
           <a:xfrm>
             <a:off x="841248" y="2029968"/>
-            <a:ext cx="10387584" cy="1188720"/>
+            <a:ext cx="4983480" cy="1243584"/>
           </a:xfrm>
           <a:prstGeom prst="roundRect">
             <a:avLst/>
@@ -27585,8 +27585,8 @@
         </p:nvSpPr>
         <p:spPr>
           <a:xfrm>
-            <a:off x="1170432" y="2267712"/>
-            <a:ext cx="4754880" cy="310896"/>
+            <a:off x="1115568" y="2249424"/>
+            <a:ext cx="3273552" cy="274320"/>
           </a:xfrm>
           <a:prstGeom prst="rect">
             <a:avLst/>
@@ -27600,7 +27600,7 @@
           <a:lstStyle/>
           <a:p>
             <a:pPr>
-              <a:defRPr sz="1800" b="1">
+              <a:defRPr sz="1580" b="1">
                 <a:solidFill>
                   <a:srgbClr val="2563EB"/>
                 </a:solidFill>
@@ -27621,8 +27621,8 @@
         </p:nvSpPr>
         <p:spPr>
           <a:xfrm>
-            <a:off x="1170432" y="2706624"/>
-            <a:ext cx="7726679" cy="256032"/>
+            <a:off x="1115568" y="2670048"/>
+            <a:ext cx="3291840" cy="329184"/>
           </a:xfrm>
           <a:prstGeom prst="rect">
             <a:avLst/>
@@ -27636,7 +27636,7 @@
           <a:lstStyle/>
           <a:p>
             <a:pPr>
-              <a:defRPr sz="1450" b="0">
+              <a:defRPr sz="1350" b="0">
                 <a:solidFill>
                   <a:srgbClr val="1B1F2A"/>
                 </a:solidFill>
@@ -27644,7 +27644,7 @@
               </a:defRPr>
             </a:pPr>
             <a:r>
-              <a:t>Tokamak zk-EVM의 실행, 증명, compiler/verifier 배경을 이해하기 위한 발표 자료.</a:t>
+              <a:t>실행, 증명, compiler/verifier 배경을 이해하기 위한 발표 자료.</a:t>
             </a:r>
           </a:p>
         </p:txBody>
@@ -27659,8 +27659,8 @@
         </p:nvSpPr>
         <p:spPr>
           <a:xfrm>
-            <a:off x="9107424" y="2450592"/>
-            <a:ext cx="1444752" cy="420624"/>
+            <a:off x="4443984" y="2542032"/>
+            <a:ext cx="1078992" cy="384048"/>
           </a:xfrm>
           <a:prstGeom prst="roundRect">
             <a:avLst/>
@@ -27704,8 +27704,8 @@
         </p:nvSpPr>
         <p:spPr>
           <a:xfrm>
-            <a:off x="9217152" y="2587752"/>
-            <a:ext cx="1225296" cy="146304"/>
+            <a:off x="4526280" y="2670048"/>
+            <a:ext cx="914400" cy="128016"/>
           </a:xfrm>
           <a:prstGeom prst="rect">
             <a:avLst/>
@@ -27719,7 +27719,7 @@
           <a:lstStyle/>
           <a:p>
             <a:pPr algn="ctr">
-              <a:defRPr sz="1350" b="1">
+              <a:defRPr sz="1320" b="1">
                 <a:solidFill>
                   <a:srgbClr val="2563EB"/>
                 </a:solidFill>
@@ -27730,7 +27730,7 @@
               <a:rPr>
                 <a:hlinkClick r:id="rId2"/>
               </a:rPr>
-              <a:t>Google Slides</a:t>
+              <a:t>Slides</a:t>
             </a:r>
           </a:p>
         </p:txBody>
@@ -27743,8 +27743,8 @@
         </p:nvSpPr>
         <p:spPr>
           <a:xfrm>
-            <a:off x="841248" y="3493008"/>
-            <a:ext cx="10387584" cy="1188720"/>
+            <a:off x="6245352" y="2029968"/>
+            <a:ext cx="4983480" cy="1243584"/>
           </a:xfrm>
           <a:prstGeom prst="roundRect">
             <a:avLst/>
@@ -27788,8 +27788,8 @@
         </p:nvSpPr>
         <p:spPr>
           <a:xfrm>
-            <a:off x="1170432" y="3730752"/>
-            <a:ext cx="5120640" cy="310896"/>
+            <a:off x="6519672" y="2249424"/>
+            <a:ext cx="3273552" cy="274320"/>
           </a:xfrm>
           <a:prstGeom prst="rect">
             <a:avLst/>
@@ -27803,7 +27803,7 @@
           <a:lstStyle/>
           <a:p>
             <a:pPr>
-              <a:defRPr sz="1800" b="1">
+              <a:defRPr sz="1580" b="1">
                 <a:solidFill>
                   <a:srgbClr val="21A67A"/>
                 </a:solidFill>
@@ -27824,8 +27824,8 @@
         </p:nvSpPr>
         <p:spPr>
           <a:xfrm>
-            <a:off x="1170432" y="4169663"/>
-            <a:ext cx="7726679" cy="256032"/>
+            <a:off x="6519672" y="2670048"/>
+            <a:ext cx="3291840" cy="329184"/>
           </a:xfrm>
           <a:prstGeom prst="rect">
             <a:avLst/>
@@ -27839,7 +27839,7 @@
           <a:lstStyle/>
           <a:p>
             <a:pPr>
-              <a:defRPr sz="1450" b="0">
+              <a:defRPr sz="1350" b="0">
                 <a:solidFill>
                   <a:srgbClr val="1B1F2A"/>
                 </a:solidFill>
@@ -27847,7 +27847,7 @@
               </a:defRPr>
             </a:pPr>
             <a:r>
-              <a:t>Tokamak zk-EVM의 핵심 아이디어를 더 쉽게 따라가기 위한 입문 영상.</a:t>
+              <a:t>핵심 아이디어를 빠르게 따라가기 위한 입문 영상.</a:t>
             </a:r>
           </a:p>
         </p:txBody>
@@ -27862,8 +27862,8 @@
         </p:nvSpPr>
         <p:spPr>
           <a:xfrm>
-            <a:off x="9107424" y="3913632"/>
-            <a:ext cx="1444752" cy="420624"/>
+            <a:off x="9848088" y="2542032"/>
+            <a:ext cx="1078992" cy="384048"/>
           </a:xfrm>
           <a:prstGeom prst="roundRect">
             <a:avLst/>
@@ -27907,8 +27907,8 @@
         </p:nvSpPr>
         <p:spPr>
           <a:xfrm>
-            <a:off x="9217152" y="4050791"/>
-            <a:ext cx="1225296" cy="146304"/>
+            <a:off x="9930384" y="2670048"/>
+            <a:ext cx="914400" cy="128016"/>
           </a:xfrm>
           <a:prstGeom prst="rect">
             <a:avLst/>
@@ -27922,7 +27922,7 @@
           <a:lstStyle/>
           <a:p>
             <a:pPr algn="ctr">
-              <a:defRPr sz="1350" b="1">
+              <a:defRPr sz="1320" b="1">
                 <a:solidFill>
                   <a:srgbClr val="21A67A"/>
                 </a:solidFill>
@@ -27934,6 +27934,412 @@
                 <a:hlinkClick r:id="rId3"/>
               </a:rPr>
               <a:t>YouTube</a:t>
+            </a:r>
+          </a:p>
+        </p:txBody>
+      </p:sp>
+      <p:sp>
+        <p:nvSpPr>
+          <p:cNvPr id="19" name="Rounded Rectangle 18"/>
+          <p:cNvSpPr/>
+          <p:nvPr/>
+        </p:nvSpPr>
+        <p:spPr>
+          <a:xfrm>
+            <a:off x="841248" y="3584448"/>
+            <a:ext cx="4983480" cy="1243584"/>
+          </a:xfrm>
+          <a:prstGeom prst="roundRect">
+            <a:avLst/>
+          </a:prstGeom>
+          <a:solidFill>
+            <a:srgbClr val="FFFFFF"/>
+          </a:solidFill>
+          <a:ln w="12700">
+            <a:solidFill>
+              <a:srgbClr val="D8DDE6"/>
+            </a:solidFill>
+          </a:ln>
+        </p:spPr>
+        <p:style>
+          <a:lnRef idx="1">
+            <a:schemeClr val="accent1"/>
+          </a:lnRef>
+          <a:fillRef idx="3">
+            <a:schemeClr val="accent1"/>
+          </a:fillRef>
+          <a:effectRef idx="2">
+            <a:schemeClr val="accent1"/>
+          </a:effectRef>
+          <a:fontRef idx="minor">
+            <a:schemeClr val="lt1"/>
+          </a:fontRef>
+        </p:style>
+        <p:txBody>
+          <a:bodyPr rtlCol="0" anchor="ctr"/>
+          <a:lstStyle/>
+          <a:p>
+            <a:pPr algn="ctr"/>
+          </a:p>
+        </p:txBody>
+      </p:sp>
+      <p:sp>
+        <p:nvSpPr>
+          <p:cNvPr id="20" name="TextBox 19"/>
+          <p:cNvSpPr txBox="1"/>
+          <p:nvPr/>
+        </p:nvSpPr>
+        <p:spPr>
+          <a:xfrm>
+            <a:off x="1115568" y="3803904"/>
+            <a:ext cx="3273552" cy="274320"/>
+          </a:xfrm>
+          <a:prstGeom prst="rect">
+            <a:avLst/>
+          </a:prstGeom>
+          <a:noFill/>
+        </p:spPr>
+        <p:txBody>
+          <a:bodyPr wrap="square" lIns="18288" rIns="18288" tIns="9144" bIns="9144" anchor="t">
+            <a:spAutoFit/>
+          </a:bodyPr>
+          <a:lstStyle/>
+          <a:p>
+            <a:pPr>
+              <a:defRPr sz="1580" b="1">
+                <a:solidFill>
+                  <a:srgbClr val="6D5BD0"/>
+                </a:solidFill>
+                <a:latin typeface="Apple SD Gothic Neo"/>
+              </a:defRPr>
+            </a:pPr>
+            <a:r>
+              <a:t>공식 기술 문서</a:t>
+            </a:r>
+          </a:p>
+        </p:txBody>
+      </p:sp>
+      <p:sp>
+        <p:nvSpPr>
+          <p:cNvPr id="21" name="TextBox 20"/>
+          <p:cNvSpPr txBox="1"/>
+          <p:nvPr/>
+        </p:nvSpPr>
+        <p:spPr>
+          <a:xfrm>
+            <a:off x="1115568" y="4224528"/>
+            <a:ext cx="3291840" cy="329184"/>
+          </a:xfrm>
+          <a:prstGeom prst="rect">
+            <a:avLst/>
+          </a:prstGeom>
+          <a:noFill/>
+        </p:spPr>
+        <p:txBody>
+          <a:bodyPr wrap="square" lIns="18288" rIns="18288" tIns="9144" bIns="9144" anchor="t">
+            <a:spAutoFit/>
+          </a:bodyPr>
+          <a:lstStyle/>
+          <a:p>
+            <a:pPr>
+              <a:defRPr sz="1350" b="0">
+                <a:solidFill>
+                  <a:srgbClr val="1B1F2A"/>
+                </a:solidFill>
+                <a:latin typeface="Apple SD Gothic Neo"/>
+              </a:defRPr>
+            </a:pPr>
+            <a:r>
+              <a:t>Private App Channels, bridge, DApp 구조를 정리한 개발 문서.</a:t>
+            </a:r>
+          </a:p>
+        </p:txBody>
+      </p:sp>
+      <p:sp>
+        <p:nvSpPr>
+          <p:cNvPr id="22" name="Rounded Rectangle 21">
+            <a:hlinkClick r:id="rId4"/>
+          </p:cNvPr>
+          <p:cNvSpPr/>
+          <p:nvPr/>
+        </p:nvSpPr>
+        <p:spPr>
+          <a:xfrm>
+            <a:off x="4443984" y="4096512"/>
+            <a:ext cx="1078992" cy="384048"/>
+          </a:xfrm>
+          <a:prstGeom prst="roundRect">
+            <a:avLst/>
+          </a:prstGeom>
+          <a:solidFill>
+            <a:srgbClr val="F1EEFF"/>
+          </a:solidFill>
+          <a:ln w="12700">
+            <a:solidFill>
+              <a:srgbClr val="6D5BD0"/>
+            </a:solidFill>
+          </a:ln>
+        </p:spPr>
+        <p:style>
+          <a:lnRef idx="1">
+            <a:schemeClr val="accent1"/>
+          </a:lnRef>
+          <a:fillRef idx="3">
+            <a:schemeClr val="accent1"/>
+          </a:fillRef>
+          <a:effectRef idx="2">
+            <a:schemeClr val="accent1"/>
+          </a:effectRef>
+          <a:fontRef idx="minor">
+            <a:schemeClr val="lt1"/>
+          </a:fontRef>
+        </p:style>
+        <p:txBody>
+          <a:bodyPr rtlCol="0" anchor="ctr"/>
+          <a:lstStyle/>
+          <a:p>
+            <a:pPr algn="ctr"/>
+          </a:p>
+        </p:txBody>
+      </p:sp>
+      <p:sp>
+        <p:nvSpPr>
+          <p:cNvPr id="23" name="TextBox 22"/>
+          <p:cNvSpPr txBox="1"/>
+          <p:nvPr/>
+        </p:nvSpPr>
+        <p:spPr>
+          <a:xfrm>
+            <a:off x="4526280" y="4224528"/>
+            <a:ext cx="914400" cy="128016"/>
+          </a:xfrm>
+          <a:prstGeom prst="rect">
+            <a:avLst/>
+          </a:prstGeom>
+          <a:noFill/>
+        </p:spPr>
+        <p:txBody>
+          <a:bodyPr wrap="square" lIns="18288" rIns="18288" tIns="9144" bIns="9144" anchor="ctr">
+            <a:spAutoFit/>
+          </a:bodyPr>
+          <a:lstStyle/>
+          <a:p>
+            <a:pPr algn="ctr">
+              <a:defRPr sz="1320" b="1">
+                <a:solidFill>
+                  <a:srgbClr val="6D5BD0"/>
+                </a:solidFill>
+                <a:latin typeface="Apple SD Gothic Neo"/>
+              </a:defRPr>
+            </a:pPr>
+            <a:r>
+              <a:rPr>
+                <a:hlinkClick r:id="rId4"/>
+              </a:rPr>
+              <a:t>GitHub</a:t>
+            </a:r>
+          </a:p>
+        </p:txBody>
+      </p:sp>
+      <p:sp>
+        <p:nvSpPr>
+          <p:cNvPr id="24" name="Rounded Rectangle 23"/>
+          <p:cNvSpPr/>
+          <p:nvPr/>
+        </p:nvSpPr>
+        <p:spPr>
+          <a:xfrm>
+            <a:off x="6245352" y="3584448"/>
+            <a:ext cx="4983480" cy="1243584"/>
+          </a:xfrm>
+          <a:prstGeom prst="roundRect">
+            <a:avLst/>
+          </a:prstGeom>
+          <a:solidFill>
+            <a:srgbClr val="FFFFFF"/>
+          </a:solidFill>
+          <a:ln w="12700">
+            <a:solidFill>
+              <a:srgbClr val="D8DDE6"/>
+            </a:solidFill>
+          </a:ln>
+        </p:spPr>
+        <p:style>
+          <a:lnRef idx="1">
+            <a:schemeClr val="accent1"/>
+          </a:lnRef>
+          <a:fillRef idx="3">
+            <a:schemeClr val="accent1"/>
+          </a:fillRef>
+          <a:effectRef idx="2">
+            <a:schemeClr val="accent1"/>
+          </a:effectRef>
+          <a:fontRef idx="minor">
+            <a:schemeClr val="lt1"/>
+          </a:fontRef>
+        </p:style>
+        <p:txBody>
+          <a:bodyPr rtlCol="0" anchor="ctr"/>
+          <a:lstStyle/>
+          <a:p>
+            <a:pPr algn="ctr"/>
+          </a:p>
+        </p:txBody>
+      </p:sp>
+      <p:sp>
+        <p:nvSpPr>
+          <p:cNvPr id="25" name="TextBox 24"/>
+          <p:cNvSpPr txBox="1"/>
+          <p:nvPr/>
+        </p:nvSpPr>
+        <p:spPr>
+          <a:xfrm>
+            <a:off x="6519672" y="3803904"/>
+            <a:ext cx="3273552" cy="274320"/>
+          </a:xfrm>
+          <a:prstGeom prst="rect">
+            <a:avLst/>
+          </a:prstGeom>
+          <a:noFill/>
+        </p:spPr>
+        <p:txBody>
+          <a:bodyPr wrap="square" lIns="18288" rIns="18288" tIns="9144" bIns="9144" anchor="t">
+            <a:spAutoFit/>
+          </a:bodyPr>
+          <a:lstStyle/>
+          <a:p>
+            <a:pPr>
+              <a:defRPr sz="1580" b="1">
+                <a:solidFill>
+                  <a:srgbClr val="F59E0B"/>
+                </a:solidFill>
+                <a:latin typeface="Apple SD Gothic Neo"/>
+              </a:defRPr>
+            </a:pPr>
+            <a:r>
+              <a:t>Tokamak zk-EVM ePrint 논문</a:t>
+            </a:r>
+          </a:p>
+        </p:txBody>
+      </p:sp>
+      <p:sp>
+        <p:nvSpPr>
+          <p:cNvPr id="26" name="TextBox 25"/>
+          <p:cNvSpPr txBox="1"/>
+          <p:nvPr/>
+        </p:nvSpPr>
+        <p:spPr>
+          <a:xfrm>
+            <a:off x="6519672" y="4224528"/>
+            <a:ext cx="3291840" cy="329184"/>
+          </a:xfrm>
+          <a:prstGeom prst="rect">
+            <a:avLst/>
+          </a:prstGeom>
+          <a:noFill/>
+        </p:spPr>
+        <p:txBody>
+          <a:bodyPr wrap="square" lIns="18288" rIns="18288" tIns="9144" bIns="9144" anchor="t">
+            <a:spAutoFit/>
+          </a:bodyPr>
+          <a:lstStyle/>
+          <a:p>
+            <a:pPr>
+              <a:defRPr sz="1350" b="0">
+                <a:solidFill>
+                  <a:srgbClr val="1B1F2A"/>
+                </a:solidFill>
+                <a:latin typeface="Apple SD Gothic Neo"/>
+              </a:defRPr>
+            </a:pPr>
+            <a:r>
+              <a:t>Tokamak zk-EVM 설계와 증명 시스템을 다룬 아카이브 논문.</a:t>
+            </a:r>
+          </a:p>
+        </p:txBody>
+      </p:sp>
+      <p:sp>
+        <p:nvSpPr>
+          <p:cNvPr id="27" name="Rounded Rectangle 26">
+            <a:hlinkClick r:id="rId5"/>
+          </p:cNvPr>
+          <p:cNvSpPr/>
+          <p:nvPr/>
+        </p:nvSpPr>
+        <p:spPr>
+          <a:xfrm>
+            <a:off x="9848088" y="4096512"/>
+            <a:ext cx="1078992" cy="384048"/>
+          </a:xfrm>
+          <a:prstGeom prst="roundRect">
+            <a:avLst/>
+          </a:prstGeom>
+          <a:solidFill>
+            <a:srgbClr val="FFF4DE"/>
+          </a:solidFill>
+          <a:ln w="12700">
+            <a:solidFill>
+              <a:srgbClr val="F59E0B"/>
+            </a:solidFill>
+          </a:ln>
+        </p:spPr>
+        <p:style>
+          <a:lnRef idx="1">
+            <a:schemeClr val="accent1"/>
+          </a:lnRef>
+          <a:fillRef idx="3">
+            <a:schemeClr val="accent1"/>
+          </a:fillRef>
+          <a:effectRef idx="2">
+            <a:schemeClr val="accent1"/>
+          </a:effectRef>
+          <a:fontRef idx="minor">
+            <a:schemeClr val="lt1"/>
+          </a:fontRef>
+        </p:style>
+        <p:txBody>
+          <a:bodyPr rtlCol="0" anchor="ctr"/>
+          <a:lstStyle/>
+          <a:p>
+            <a:pPr algn="ctr"/>
+          </a:p>
+        </p:txBody>
+      </p:sp>
+      <p:sp>
+        <p:nvSpPr>
+          <p:cNvPr id="28" name="TextBox 27"/>
+          <p:cNvSpPr txBox="1"/>
+          <p:nvPr/>
+        </p:nvSpPr>
+        <p:spPr>
+          <a:xfrm>
+            <a:off x="9930384" y="4224528"/>
+            <a:ext cx="914400" cy="128016"/>
+          </a:xfrm>
+          <a:prstGeom prst="rect">
+            <a:avLst/>
+          </a:prstGeom>
+          <a:noFill/>
+        </p:spPr>
+        <p:txBody>
+          <a:bodyPr wrap="square" lIns="18288" rIns="18288" tIns="9144" bIns="9144" anchor="ctr">
+            <a:spAutoFit/>
+          </a:bodyPr>
+          <a:lstStyle/>
+          <a:p>
+            <a:pPr algn="ctr">
+              <a:defRPr sz="1320" b="1">
+                <a:solidFill>
+                  <a:srgbClr val="F59E0B"/>
+                </a:solidFill>
+                <a:latin typeface="Apple SD Gothic Neo"/>
+              </a:defRPr>
+            </a:pPr>
+            <a:r>
+              <a:rPr>
+                <a:hlinkClick r:id="rId5"/>
+              </a:rPr>
+              <a:t>ePrint</a:t>
             </a:r>
           </a:p>
         </p:txBody>

</xml_diff>